<commit_message>
glossary slide: Entry/Episode/History-Ledger bullets + deck-edit ports
Eight-bullet key-components glossary: Blackboard Entry (Key) rename
and workflow-stages Partition wording ported from deck edits; new
Episode and History/Ledger bullets; entry-key examples in speaker
notes; type tightened to fit.

Co-Authored-By: Claude Fable 5 <noreply@anthropic.com>
</commit_message>
<xml_diff>
--- a/docs/video_slides_draft.pptx
+++ b/docs/video_slides_draft.pptx
@@ -142,7 +142,7 @@
     </p:spTree>
     <p:extLst>
       <p:ext uri="{BB962C8B-B14F-4D97-AF65-F5344CB8AC3E}">
-        <p14:creationId xmlns:p14="http://schemas.microsoft.com/office/powerpoint/2010/main" val="2900677154"/>
+        <p14:creationId xmlns:p14="http://schemas.microsoft.com/office/powerpoint/2010/main" val="317768001"/>
       </p:ext>
     </p:extLst>
   </p:cSld>
@@ -735,6 +735,7 @@
             <a:r>
               <a:rPr lang="en-US" dirty="0"/>
               <a:t>The audience's glossary for the terminal scenes - point back at the slide-5 diagram while reading it.
+Entry keys in the real demos are the provisioned protocols: ready (the readiness gate), isolette_sysmlv2_rust_props (blessed model), _l1a (file hashes), _l2 (contract slices), _verus, _cheat, _sysproof, _gensrc, _report. Every row of the checklist the audience is about to watch is one of these keys.
 Predicate and restart-episode are deliberately OFF this slide (parked; placement TBD - possibly an 'evaluation primitives' strip). If asked: a predicate is the judge (one evaluation = one attestation episode), restart-episode is the freshness primitive (forget memoized verdicts, reset, re-evaluate).
 Also deliberately excluded (README-level detail): partition mechanics, component-wise entries and success handoff, dispatch latching, max_cycles.</a:t>
             </a:r>
@@ -4969,7 +4970,7 @@
           <a:bodyPr wrap="square" lIns="0" tIns="0" rIns="0" bIns="0" rtlCol="0" anchor="ctr"/>
           <a:lstStyle/>
           <a:p>
-            <a:pPr marL="0" indent="0" algn="ctr">
+            <a:pPr marL="0" indent="0" algn="l">
               <a:buNone/>
             </a:pPr>
             <a:r>
@@ -5016,9 +5017,10 @@
               </a:rPr>
               <a:t>of failure— every repair is </a:t>
             </a:r>
-          </a:p>
-          <a:p>
-            <a:pPr marL="0" indent="0" algn="ctr">
+            <a:endParaRPr lang="en-US" sz="1300" dirty="0"/>
+          </a:p>
+          <a:p>
+            <a:pPr marL="0" indent="0" algn="l">
               <a:buNone/>
             </a:pPr>
             <a:r>
@@ -5228,8 +5230,8 @@
         </p:nvSpPr>
         <p:spPr>
           <a:xfrm>
-            <a:off x="640080" y="1463040"/>
-            <a:ext cx="10972800" cy="4846320"/>
+            <a:off x="640080" y="1371600"/>
+            <a:ext cx="10972800" cy="5212080"/>
           </a:xfrm>
           <a:prstGeom prst="rect">
             <a:avLst/>
@@ -5246,7 +5248,7 @@
               <a:buChar char="•"/>
             </a:pPr>
             <a:r>
-              <a:rPr lang="en-US" sz="1700" b="1" dirty="0">
+              <a:rPr lang="en-US" sz="1600" b="1" dirty="0">
                 <a:solidFill>
                   <a:srgbClr val="1E2761"/>
                 </a:solidFill>
@@ -5257,7 +5259,7 @@
               <a:t>Blackboard</a:t>
             </a:r>
             <a:r>
-              <a:rPr lang="en-US" sz="1700" dirty="0">
+              <a:rPr lang="en-US" sz="1600" dirty="0">
                 <a:solidFill>
                   <a:srgbClr val="212121"/>
                 </a:solidFill>
@@ -5267,7 +5269,7 @@
               </a:rPr>
               <a:t> — the shared store: every measurement lands as an entry with its condition and standing; three segments (provision · certify · escalate) plus a full history of every change</a:t>
             </a:r>
-            <a:endParaRPr lang="en-US" sz="1700" dirty="0"/>
+            <a:endParaRPr lang="en-US" sz="1600" dirty="0"/>
           </a:p>
           <a:p>
             <a:pPr marL="342900" indent="-342900" algn="l">
@@ -5275,7 +5277,7 @@
               <a:buChar char="•"/>
             </a:pPr>
             <a:r>
-              <a:rPr lang="en-US" sz="1700" b="1" dirty="0">
+              <a:rPr lang="en-US" sz="1600" b="1" dirty="0">
                 <a:solidFill>
                   <a:srgbClr val="1E2761"/>
                 </a:solidFill>
@@ -5283,10 +5285,10 @@
                 <a:ea typeface="Calibri" pitchFamily="34" charset="-122"/>
                 <a:cs typeface="Calibri" pitchFamily="34" charset="-120"/>
               </a:rPr>
-              <a:t>Partition</a:t>
-            </a:r>
-            <a:r>
-              <a:rPr lang="en-US" sz="1700" dirty="0">
+              <a:t>Blackboard Entry (Key)</a:t>
+            </a:r>
+            <a:r>
+              <a:rPr lang="en-US" sz="1600" dirty="0">
                 <a:solidFill>
                   <a:srgbClr val="212121"/>
                 </a:solidFill>
@@ -5294,9 +5296,9 @@
                 <a:ea typeface="Calibri" pitchFamily="34" charset="-122"/>
                 <a:cs typeface="Calibri" pitchFamily="34" charset="-120"/>
               </a:rPr>
-              <a:t> — the division of blackboard entries among repairers: each knowledge source watches its own collection of keys, and an entry sits in the partition of whichever rung currently owns it</a:t>
-            </a:r>
-            <a:endParaRPr lang="en-US" sz="1700" dirty="0"/>
+              <a:t> — one measurement under judgment, identified by its key: the measurement, its condition, its standing, its repair history</a:t>
+            </a:r>
+            <a:endParaRPr lang="en-US" sz="1600" dirty="0"/>
           </a:p>
           <a:p>
             <a:pPr marL="342900" indent="-342900" algn="l">
@@ -5304,7 +5306,7 @@
               <a:buChar char="•"/>
             </a:pPr>
             <a:r>
-              <a:rPr lang="en-US" sz="1700" b="1" dirty="0">
+              <a:rPr lang="en-US" sz="1600" b="1" dirty="0">
                 <a:solidFill>
                   <a:srgbClr val="1E2761"/>
                 </a:solidFill>
@@ -5312,10 +5314,10 @@
                 <a:ea typeface="Calibri" pitchFamily="34" charset="-122"/>
                 <a:cs typeface="Calibri" pitchFamily="34" charset="-120"/>
               </a:rPr>
-              <a:t>Controller</a:t>
-            </a:r>
-            <a:r>
-              <a:rPr lang="en-US" sz="1700" dirty="0">
+              <a:t>Episode</a:t>
+            </a:r>
+            <a:r>
+              <a:rPr lang="en-US" sz="1600" dirty="0">
                 <a:solidFill>
                   <a:srgbClr val="212121"/>
                 </a:solidFill>
@@ -5323,9 +5325,9 @@
                 <a:ea typeface="Calibri" pitchFamily="34" charset="-122"/>
                 <a:cs typeface="Calibri" pitchFamily="34" charset="-120"/>
               </a:rPr>
-              <a:t> — the cycle: evaluates every entry (provision first), dispatches keys onto outcome-routed chains, advances or hands off, escalates; halts only when everything is in good standing</a:t>
-            </a:r>
-            <a:endParaRPr lang="en-US" sz="1700" dirty="0"/>
+              <a:t> — one full judgment of an entry: the attestation runs once and its verdicts are memoized until the episode ends — or is restarted for genuinely fresh measurement</a:t>
+            </a:r>
+            <a:endParaRPr lang="en-US" sz="1600" dirty="0"/>
           </a:p>
           <a:p>
             <a:pPr marL="342900" indent="-342900" algn="l">
@@ -5333,7 +5335,7 @@
               <a:buChar char="•"/>
             </a:pPr>
             <a:r>
-              <a:rPr lang="en-US" sz="1700" b="1" dirty="0">
+              <a:rPr lang="en-US" sz="1600" b="1" dirty="0">
                 <a:solidFill>
                   <a:srgbClr val="1E2761"/>
                 </a:solidFill>
@@ -5341,10 +5343,10 @@
                 <a:ea typeface="Calibri" pitchFamily="34" charset="-122"/>
                 <a:cs typeface="Calibri" pitchFamily="34" charset="-120"/>
               </a:rPr>
-              <a:t>Knowledge source (KS)</a:t>
-            </a:r>
-            <a:r>
-              <a:rPr lang="en-US" sz="1700" dirty="0">
+              <a:t>Partition</a:t>
+            </a:r>
+            <a:r>
+              <a:rPr lang="en-US" sz="1600" dirty="0">
                 <a:solidFill>
                   <a:srgbClr val="212121"/>
                 </a:solidFill>
@@ -5352,9 +5354,9 @@
                 <a:ea typeface="Calibri" pitchFamily="34" charset="-122"/>
                 <a:cs typeface="Calibri" pitchFamily="34" charset="-120"/>
               </a:rPr>
-              <a:t> — a repair rung: operates only on entries in its partition (optionally a single component), bounded by max_attempts; its work is always re-judged, never trusted</a:t>
-            </a:r>
-            <a:endParaRPr lang="en-US" sz="1700" dirty="0"/>
+              <a:t> — the division of blackboard entries among different workflow stages: each knowledge source watches its own collection of keys, and an entry sits in the partition of whichever rung currently owns it</a:t>
+            </a:r>
+            <a:endParaRPr lang="en-US" sz="1600" dirty="0"/>
           </a:p>
           <a:p>
             <a:pPr marL="342900" indent="-342900" algn="l">
@@ -5362,7 +5364,7 @@
               <a:buChar char="•"/>
             </a:pPr>
             <a:r>
-              <a:rPr lang="en-US" sz="1700" b="1" dirty="0">
+              <a:rPr lang="en-US" sz="1600" b="1" dirty="0">
                 <a:solidFill>
                   <a:srgbClr val="1E2761"/>
                 </a:solidFill>
@@ -5370,10 +5372,68 @@
                 <a:ea typeface="Calibri" pitchFamily="34" charset="-122"/>
                 <a:cs typeface="Calibri" pitchFamily="34" charset="-120"/>
               </a:rPr>
+              <a:t>Controller</a:t>
+            </a:r>
+            <a:r>
+              <a:rPr lang="en-US" sz="1600" dirty="0">
+                <a:solidFill>
+                  <a:srgbClr val="212121"/>
+                </a:solidFill>
+                <a:latin typeface="Calibri" pitchFamily="34" charset="0"/>
+                <a:ea typeface="Calibri" pitchFamily="34" charset="-122"/>
+                <a:cs typeface="Calibri" pitchFamily="34" charset="-120"/>
+              </a:rPr>
+              <a:t> — the cycle: evaluates every entry (provision first), dispatches keys onto outcome-routed chains, advances or hands off, escalates; halts only when everything is in good standing</a:t>
+            </a:r>
+            <a:endParaRPr lang="en-US" sz="1600" dirty="0"/>
+          </a:p>
+          <a:p>
+            <a:pPr marL="342900" indent="-342900" algn="l">
+              <a:buSzPct val="100000"/>
+              <a:buChar char="•"/>
+            </a:pPr>
+            <a:r>
+              <a:rPr lang="en-US" sz="1600" b="1" dirty="0">
+                <a:solidFill>
+                  <a:srgbClr val="1E2761"/>
+                </a:solidFill>
+                <a:latin typeface="Calibri" pitchFamily="34" charset="0"/>
+                <a:ea typeface="Calibri" pitchFamily="34" charset="-122"/>
+                <a:cs typeface="Calibri" pitchFamily="34" charset="-120"/>
+              </a:rPr>
+              <a:t>Knowledge source (KS)</a:t>
+            </a:r>
+            <a:r>
+              <a:rPr lang="en-US" sz="1600" dirty="0">
+                <a:solidFill>
+                  <a:srgbClr val="212121"/>
+                </a:solidFill>
+                <a:latin typeface="Calibri" pitchFamily="34" charset="0"/>
+                <a:ea typeface="Calibri" pitchFamily="34" charset="-122"/>
+                <a:cs typeface="Calibri" pitchFamily="34" charset="-120"/>
+              </a:rPr>
+              <a:t> — a repair rung: operates only on entries in its partition (optionally a single component), bounded by max_attempts; its work is always re-judged, never trusted</a:t>
+            </a:r>
+            <a:endParaRPr lang="en-US" sz="1600" dirty="0"/>
+          </a:p>
+          <a:p>
+            <a:pPr marL="342900" indent="-342900" algn="l">
+              <a:buSzPct val="100000"/>
+              <a:buChar char="•"/>
+            </a:pPr>
+            <a:r>
+              <a:rPr lang="en-US" sz="1600" b="1" dirty="0">
+                <a:solidFill>
+                  <a:srgbClr val="1E2761"/>
+                </a:solidFill>
+                <a:latin typeface="Calibri" pitchFamily="34" charset="0"/>
+                <a:ea typeface="Calibri" pitchFamily="34" charset="-122"/>
+                <a:cs typeface="Calibri" pitchFamily="34" charset="-120"/>
+              </a:rPr>
               <a:t>Route</a:t>
             </a:r>
             <a:r>
-              <a:rPr lang="en-US" sz="1700" dirty="0">
+              <a:rPr lang="en-US" sz="1600" dirty="0">
                 <a:solidFill>
                   <a:srgbClr val="212121"/>
                 </a:solidFill>
@@ -5383,7 +5443,36 @@
               </a:rPr>
               <a:t> — the per-key chains: on_fail = the repair ladder, on_pass = a confirmation chain before an entry may rest in good standing</a:t>
             </a:r>
-            <a:endParaRPr lang="en-US" sz="1700" dirty="0"/>
+            <a:endParaRPr lang="en-US" sz="1600" dirty="0"/>
+          </a:p>
+          <a:p>
+            <a:pPr marL="342900" indent="-342900" algn="l">
+              <a:buSzPct val="100000"/>
+              <a:buChar char="•"/>
+            </a:pPr>
+            <a:r>
+              <a:rPr lang="en-US" sz="1600" b="1" dirty="0">
+                <a:solidFill>
+                  <a:srgbClr val="1E2761"/>
+                </a:solidFill>
+                <a:latin typeface="Calibri" pitchFamily="34" charset="0"/>
+                <a:ea typeface="Calibri" pitchFamily="34" charset="-122"/>
+                <a:cs typeface="Calibri" pitchFamily="34" charset="-120"/>
+              </a:rPr>
+              <a:t>History / Ledger</a:t>
+            </a:r>
+            <a:r>
+              <a:rPr lang="en-US" sz="1600" dirty="0">
+                <a:solidFill>
+                  <a:srgbClr val="212121"/>
+                </a:solidFill>
+                <a:latin typeface="Calibri" pitchFamily="34" charset="0"/>
+                <a:ea typeface="Calibri" pitchFamily="34" charset="-122"/>
+                <a:cs typeface="Calibri" pitchFamily="34" charset="-120"/>
+              </a:rPr>
+              <a:t> — the blackboard's running record of every change across all segments — measurements, repairs, verdicts — the audit trail of the repair lifecycle</a:t>
+            </a:r>
+            <a:endParaRPr lang="en-US" sz="1600" dirty="0"/>
           </a:p>
         </p:txBody>
       </p:sp>

</xml_diff>

<commit_message>
artifact-classes slide: table from markdown draft + deck-edit ports
Deck position 7: the class -> measured-how -> judged-by -> repair
table (navy header, cross-cutting rows tagged). User deck edits
ported: short "Artifact classes" title, tests+verification judging
for implementation, pre-sanctioned toolchain restore.

Co-Authored-By: Claude Fable 5 <noreply@anthropic.com>
</commit_message>
<xml_diff>
--- a/docs/video_slides_draft.pptx
+++ b/docs/video_slides_draft.pptx
@@ -5,7 +5,7 @@
     <p:sldMasterId id="2147483648" r:id="rId1"/>
   </p:sldMasterIdLst>
   <p:notesMasterIdLst>
-    <p:notesMasterId r:id="rId8"/>
+    <p:notesMasterId r:id="rId9"/>
   </p:notesMasterIdLst>
   <p:sldIdLst>
     <p:sldId id="256" r:id="rId2"/>
@@ -14,6 +14,7 @@
     <p:sldId id="259" r:id="rId5"/>
     <p:sldId id="260" r:id="rId6"/>
     <p:sldId id="261" r:id="rId7"/>
+    <p:sldId id="262" r:id="rId8"/>
   </p:sldIdLst>
   <p:sldSz cx="12192000" cy="6858000"/>
   <p:notesSz cx="6858000" cy="12192000"/>
@@ -142,7 +143,7 @@
     </p:spTree>
     <p:extLst>
       <p:ext uri="{BB962C8B-B14F-4D97-AF65-F5344CB8AC3E}">
-        <p14:creationId xmlns:p14="http://schemas.microsoft.com/office/powerpoint/2010/main" val="317768001"/>
+        <p14:creationId xmlns:p14="http://schemas.microsoft.com/office/powerpoint/2010/main" val="1495642631"/>
       </p:ext>
     </p:extLst>
   </p:cSld>
@@ -760,6 +761,95 @@
             <a:fld id="{F7021451-1387-4CA6-816F-3879F97B5CBC}" type="slidenum">
               <a:rPr lang="en-US"/>
               <a:t>6</a:t>
+            </a:fld>
+            <a:endParaRPr lang="en-US"/>
+          </a:p>
+        </p:txBody>
+      </p:sp>
+    </p:spTree>
+    <p:extLst>
+      <p:ext uri="{BB962C8B-B14F-4D97-AF65-F5344CB8AC3E}">
+        <p14:creationId xmlns:p14="http://schemas.microsoft.com/office/powerpoint/2010/main" val="1024086991"/>
+      </p:ext>
+    </p:extLst>
+  </p:cSld>
+  <p:clrMapOvr>
+    <a:masterClrMapping/>
+  </p:clrMapOvr>
+</p:notes>
+</file>
+
+<file path=ppt/notesSlides/notesSlide7.xml><?xml version="1.0" encoding="utf-8"?>
+<p:notes xmlns:a="http://schemas.openxmlformats.org/drawingml/2006/main" xmlns:r="http://schemas.openxmlformats.org/officeDocument/2006/relationships" xmlns:p="http://schemas.openxmlformats.org/presentationml/2006/main">
+  <p:cSld>
+    <p:spTree>
+      <p:nvGrpSpPr>
+        <p:cNvPr id="1" name=""/>
+        <p:cNvGrpSpPr/>
+        <p:nvPr/>
+      </p:nvGrpSpPr>
+      <p:grpSpPr>
+        <a:xfrm>
+          <a:off x="0" y="0"/>
+          <a:ext cx="0" cy="0"/>
+          <a:chOff x="0" y="0"/>
+          <a:chExt cx="0" cy="0"/>
+        </a:xfrm>
+      </p:grpSpPr>
+      <p:sp>
+        <p:nvSpPr>
+          <p:cNvPr id="2" name="Slide Image Placeholder 1"/>
+          <p:cNvSpPr>
+            <a:spLocks noGrp="1" noRot="1" noChangeAspect="1"/>
+          </p:cNvSpPr>
+          <p:nvPr>
+            <p:ph type="sldImg"/>
+          </p:nvPr>
+        </p:nvSpPr>
+        <p:spPr/>
+      </p:sp>
+      <p:sp>
+        <p:nvSpPr>
+          <p:cNvPr id="3" name="Notes Placeholder 2"/>
+          <p:cNvSpPr>
+            <a:spLocks noGrp="1"/>
+          </p:cNvSpPr>
+          <p:nvPr>
+            <p:ph type="body" idx="1"/>
+          </p:nvPr>
+        </p:nvSpPr>
+        <p:spPr/>
+        <p:txBody>
+          <a:bodyPr/>
+          <a:lstStyle/>
+          <a:p>
+            <a:r>
+              <a:rPr lang="en-US" dirty="0"/>
+              <a:t>The last two rows are the surprising ones - scenes 6-7 exist for them.
+Spoken hook (never on-slide text): 'This table is deliberately incomplete - the demo will show why.' The cheat / sysproof / gensrc tiers are capstone slide C's punchline: attacks forced them into existence. Do not pre-introduce them here.
+Same column shape (class -&gt; measured how -&gt; judged by -&gt; repair) as capstone slide B, so the audience recognizes it when it returns.</a:t>
+            </a:r>
+          </a:p>
+        </p:txBody>
+      </p:sp>
+      <p:sp>
+        <p:nvSpPr>
+          <p:cNvPr id="4" name="Slide Number Placeholder 3"/>
+          <p:cNvSpPr>
+            <a:spLocks noGrp="1"/>
+          </p:cNvSpPr>
+          <p:nvPr>
+            <p:ph type="sldNum" sz="quarter" idx="10"/>
+          </p:nvPr>
+        </p:nvSpPr>
+        <p:spPr/>
+        <p:txBody>
+          <a:bodyPr/>
+          <a:lstStyle/>
+          <a:p>
+            <a:fld id="{F7021451-1387-4CA6-816F-3879F97B5CBC}" type="slidenum">
+              <a:rPr lang="en-US"/>
+              <a:t>7</a:t>
             </a:fld>
             <a:endParaRPr lang="en-US"/>
           </a:p>
@@ -5476,6 +5566,2153 @@
           </a:p>
         </p:txBody>
       </p:sp>
+    </p:spTree>
+  </p:cSld>
+  <p:clrMapOvr>
+    <a:masterClrMapping/>
+  </p:clrMapOvr>
+</p:sld>
+</file>
+
+<file path=ppt/slides/slide7.xml><?xml version="1.0" encoding="utf-8"?>
+<p:sld xmlns:a="http://schemas.openxmlformats.org/drawingml/2006/main" xmlns:r="http://schemas.openxmlformats.org/officeDocument/2006/relationships" xmlns:p="http://schemas.openxmlformats.org/presentationml/2006/main">
+  <p:cSld name="Slide 7">
+    <p:bg>
+      <p:bgPr>
+        <a:solidFill>
+          <a:srgbClr val="FFFFFF"/>
+        </a:solidFill>
+        <a:effectLst/>
+      </p:bgPr>
+    </p:bg>
+    <p:spTree>
+      <p:nvGrpSpPr>
+        <p:cNvPr id="1" name=""/>
+        <p:cNvGrpSpPr/>
+        <p:nvPr/>
+      </p:nvGrpSpPr>
+      <p:grpSpPr>
+        <a:xfrm>
+          <a:off x="0" y="0"/>
+          <a:ext cx="0" cy="0"/>
+          <a:chOff x="0" y="0"/>
+          <a:chExt cx="0" cy="0"/>
+        </a:xfrm>
+      </p:grpSpPr>
+      <p:sp>
+        <p:nvSpPr>
+          <p:cNvPr id="2" name="Text 0"/>
+          <p:cNvSpPr/>
+          <p:nvPr/>
+        </p:nvSpPr>
+        <p:spPr>
+          <a:xfrm>
+            <a:off x="640080" y="411480"/>
+            <a:ext cx="10972800" cy="731520"/>
+          </a:xfrm>
+          <a:prstGeom prst="rect">
+            <a:avLst/>
+          </a:prstGeom>
+          <a:noFill/>
+          <a:ln/>
+        </p:spPr>
+        <p:txBody>
+          <a:bodyPr wrap="square" lIns="0" tIns="0" rIns="0" bIns="0" rtlCol="0" anchor="ctr"/>
+          <a:lstStyle/>
+          <a:p>
+            <a:pPr marL="0" indent="0">
+              <a:buNone/>
+            </a:pPr>
+            <a:r>
+              <a:rPr lang="en-US" sz="3400" b="1" dirty="0">
+                <a:solidFill>
+                  <a:srgbClr val="1E2761"/>
+                </a:solidFill>
+                <a:latin typeface="Cambria" pitchFamily="34" charset="0"/>
+                <a:ea typeface="Cambria" pitchFamily="34" charset="-122"/>
+                <a:cs typeface="Cambria" pitchFamily="34" charset="-120"/>
+              </a:rPr>
+              <a:t>Artifact classes</a:t>
+            </a:r>
+            <a:endParaRPr lang="en-US" sz="3400" dirty="0"/>
+          </a:p>
+        </p:txBody>
+      </p:sp>
+      <p:graphicFrame>
+        <p:nvGraphicFramePr>
+          <p:cNvPr id="8" name="Table 0"/>
+          <p:cNvGraphicFramePr>
+            <a:graphicFrameLocks noGrp="1"/>
+          </p:cNvGraphicFramePr>
+          <p:nvPr>
+            <p:extLst>
+              <p:ext uri="{D42A27DB-BD31-4B8C-83A1-F6EECF244321}">
+                <p14:modId xmlns:p14="http://schemas.microsoft.com/office/powerpoint/2010/main" val="191026570"/>
+              </p:ext>
+            </p:extLst>
+          </p:nvPr>
+        </p:nvGraphicFramePr>
+        <p:xfrm>
+          <a:off x="640080" y="1417320"/>
+          <a:ext cx="10881360" cy="4608576"/>
+        </p:xfrm>
+        <a:graphic>
+          <a:graphicData uri="http://schemas.openxmlformats.org/drawingml/2006/table">
+            <a:tbl>
+              <a:tblPr/>
+              <a:tblGrid>
+                <a:gridCol w="2194560">
+                  <a:extLst>
+                    <a:ext uri="{9D8B030D-6E8A-4147-A177-3AD203B41FA5}">
+                      <a16:colId xmlns:a16="http://schemas.microsoft.com/office/drawing/2014/main" val="20000"/>
+                    </a:ext>
+                  </a:extLst>
+                </a:gridCol>
+                <a:gridCol w="2651760">
+                  <a:extLst>
+                    <a:ext uri="{9D8B030D-6E8A-4147-A177-3AD203B41FA5}">
+                      <a16:colId xmlns:a16="http://schemas.microsoft.com/office/drawing/2014/main" val="20001"/>
+                    </a:ext>
+                  </a:extLst>
+                </a:gridCol>
+                <a:gridCol w="3017520">
+                  <a:extLst>
+                    <a:ext uri="{9D8B030D-6E8A-4147-A177-3AD203B41FA5}">
+                      <a16:colId xmlns:a16="http://schemas.microsoft.com/office/drawing/2014/main" val="20002"/>
+                    </a:ext>
+                  </a:extLst>
+                </a:gridCol>
+                <a:gridCol w="3017520">
+                  <a:extLst>
+                    <a:ext uri="{9D8B030D-6E8A-4147-A177-3AD203B41FA5}">
+                      <a16:colId xmlns:a16="http://schemas.microsoft.com/office/drawing/2014/main" val="20003"/>
+                    </a:ext>
+                  </a:extLst>
+                </a:gridCol>
+              </a:tblGrid>
+              <a:tr h="658368">
+                <a:tc>
+                  <a:txBody>
+                    <a:bodyPr/>
+                    <a:lstStyle/>
+                    <a:p>
+                      <a:pPr marL="0" indent="0" algn="l">
+                        <a:buNone/>
+                      </a:pPr>
+                      <a:r>
+                        <a:rPr lang="en-US" sz="1400" b="1" dirty="0">
+                          <a:solidFill>
+                            <a:srgbClr val="FFFFFF"/>
+                          </a:solidFill>
+                          <a:latin typeface="Calibri" pitchFamily="34" charset="0"/>
+                          <a:ea typeface="Calibri" pitchFamily="34" charset="-122"/>
+                          <a:cs typeface="Calibri" pitchFamily="34" charset="-120"/>
+                        </a:rPr>
+                        <a:t>Artifact Class</a:t>
+                      </a:r>
+                      <a:endParaRPr lang="en-US" sz="1400" dirty="0">
+                        <a:latin typeface="Calibri" charset="0"/>
+                        <a:ea typeface="Calibri" charset="0"/>
+                        <a:cs typeface="Calibri" charset="0"/>
+                      </a:endParaRPr>
+                    </a:p>
+                  </a:txBody>
+                  <a:tcPr marL="73152" marR="73152" marT="73152" marB="73152" anchor="ctr">
+                    <a:lnL w="12700" cap="flat" cmpd="sng" algn="ctr">
+                      <a:solidFill>
+                        <a:srgbClr val="D8DEEA"/>
+                      </a:solidFill>
+                      <a:prstDash val="solid"/>
+                      <a:round/>
+                      <a:headEnd type="none" w="med" len="med"/>
+                      <a:tailEnd type="none" w="med" len="med"/>
+                    </a:lnL>
+                    <a:lnR w="12700" cap="flat" cmpd="sng" algn="ctr">
+                      <a:solidFill>
+                        <a:srgbClr val="D8DEEA"/>
+                      </a:solidFill>
+                      <a:prstDash val="solid"/>
+                      <a:round/>
+                      <a:headEnd type="none" w="med" len="med"/>
+                      <a:tailEnd type="none" w="med" len="med"/>
+                    </a:lnR>
+                    <a:lnT w="12700" cap="flat" cmpd="sng" algn="ctr">
+                      <a:solidFill>
+                        <a:srgbClr val="D8DEEA"/>
+                      </a:solidFill>
+                      <a:prstDash val="solid"/>
+                      <a:round/>
+                      <a:headEnd type="none" w="med" len="med"/>
+                      <a:tailEnd type="none" w="med" len="med"/>
+                    </a:lnT>
+                    <a:lnB w="12700" cap="flat" cmpd="sng" algn="ctr">
+                      <a:solidFill>
+                        <a:srgbClr val="D8DEEA"/>
+                      </a:solidFill>
+                      <a:prstDash val="solid"/>
+                      <a:round/>
+                      <a:headEnd type="none" w="med" len="med"/>
+                      <a:tailEnd type="none" w="med" len="med"/>
+                    </a:lnB>
+                    <a:solidFill>
+                      <a:srgbClr val="1E2761"/>
+                    </a:solidFill>
+                  </a:tcPr>
+                </a:tc>
+                <a:tc>
+                  <a:txBody>
+                    <a:bodyPr/>
+                    <a:lstStyle/>
+                    <a:p>
+                      <a:pPr marL="0" indent="0" algn="l">
+                        <a:buNone/>
+                      </a:pPr>
+                      <a:r>
+                        <a:rPr lang="en-US" sz="1400" b="1" dirty="0">
+                          <a:solidFill>
+                            <a:srgbClr val="FFFFFF"/>
+                          </a:solidFill>
+                          <a:latin typeface="Calibri" pitchFamily="34" charset="0"/>
+                          <a:ea typeface="Calibri" pitchFamily="34" charset="-122"/>
+                          <a:cs typeface="Calibri" pitchFamily="34" charset="-120"/>
+                        </a:rPr>
+                        <a:t>Measured how</a:t>
+                      </a:r>
+                      <a:endParaRPr lang="en-US" sz="1400" dirty="0">
+                        <a:latin typeface="Calibri" charset="0"/>
+                        <a:ea typeface="Calibri" charset="0"/>
+                        <a:cs typeface="Calibri" charset="0"/>
+                      </a:endParaRPr>
+                    </a:p>
+                  </a:txBody>
+                  <a:tcPr marL="73152" marR="73152" marT="73152" marB="73152" anchor="ctr">
+                    <a:lnL w="12700" cap="flat" cmpd="sng" algn="ctr">
+                      <a:solidFill>
+                        <a:srgbClr val="D8DEEA"/>
+                      </a:solidFill>
+                      <a:prstDash val="solid"/>
+                      <a:round/>
+                      <a:headEnd type="none" w="med" len="med"/>
+                      <a:tailEnd type="none" w="med" len="med"/>
+                    </a:lnL>
+                    <a:lnR w="12700" cap="flat" cmpd="sng" algn="ctr">
+                      <a:solidFill>
+                        <a:srgbClr val="D8DEEA"/>
+                      </a:solidFill>
+                      <a:prstDash val="solid"/>
+                      <a:round/>
+                      <a:headEnd type="none" w="med" len="med"/>
+                      <a:tailEnd type="none" w="med" len="med"/>
+                    </a:lnR>
+                    <a:lnT w="12700" cap="flat" cmpd="sng" algn="ctr">
+                      <a:solidFill>
+                        <a:srgbClr val="D8DEEA"/>
+                      </a:solidFill>
+                      <a:prstDash val="solid"/>
+                      <a:round/>
+                      <a:headEnd type="none" w="med" len="med"/>
+                      <a:tailEnd type="none" w="med" len="med"/>
+                    </a:lnT>
+                    <a:lnB w="12700" cap="flat" cmpd="sng" algn="ctr">
+                      <a:solidFill>
+                        <a:srgbClr val="D8DEEA"/>
+                      </a:solidFill>
+                      <a:prstDash val="solid"/>
+                      <a:round/>
+                      <a:headEnd type="none" w="med" len="med"/>
+                      <a:tailEnd type="none" w="med" len="med"/>
+                    </a:lnB>
+                    <a:solidFill>
+                      <a:srgbClr val="1E2761"/>
+                    </a:solidFill>
+                  </a:tcPr>
+                </a:tc>
+                <a:tc>
+                  <a:txBody>
+                    <a:bodyPr/>
+                    <a:lstStyle/>
+                    <a:p>
+                      <a:pPr marL="0" indent="0" algn="l">
+                        <a:buNone/>
+                      </a:pPr>
+                      <a:r>
+                        <a:rPr lang="en-US" sz="1400" b="1" dirty="0">
+                          <a:solidFill>
+                            <a:srgbClr val="FFFFFF"/>
+                          </a:solidFill>
+                          <a:latin typeface="Calibri" pitchFamily="34" charset="0"/>
+                          <a:ea typeface="Calibri" pitchFamily="34" charset="-122"/>
+                          <a:cs typeface="Calibri" pitchFamily="34" charset="-120"/>
+                        </a:rPr>
+                        <a:t>Judged by</a:t>
+                      </a:r>
+                      <a:endParaRPr lang="en-US" sz="1400" dirty="0">
+                        <a:latin typeface="Calibri" charset="0"/>
+                        <a:ea typeface="Calibri" charset="0"/>
+                        <a:cs typeface="Calibri" charset="0"/>
+                      </a:endParaRPr>
+                    </a:p>
+                  </a:txBody>
+                  <a:tcPr marL="73152" marR="73152" marT="73152" marB="73152" anchor="ctr">
+                    <a:lnL w="12700" cap="flat" cmpd="sng" algn="ctr">
+                      <a:solidFill>
+                        <a:srgbClr val="D8DEEA"/>
+                      </a:solidFill>
+                      <a:prstDash val="solid"/>
+                      <a:round/>
+                      <a:headEnd type="none" w="med" len="med"/>
+                      <a:tailEnd type="none" w="med" len="med"/>
+                    </a:lnL>
+                    <a:lnR w="12700" cap="flat" cmpd="sng" algn="ctr">
+                      <a:solidFill>
+                        <a:srgbClr val="D8DEEA"/>
+                      </a:solidFill>
+                      <a:prstDash val="solid"/>
+                      <a:round/>
+                      <a:headEnd type="none" w="med" len="med"/>
+                      <a:tailEnd type="none" w="med" len="med"/>
+                    </a:lnR>
+                    <a:lnT w="12700" cap="flat" cmpd="sng" algn="ctr">
+                      <a:solidFill>
+                        <a:srgbClr val="D8DEEA"/>
+                      </a:solidFill>
+                      <a:prstDash val="solid"/>
+                      <a:round/>
+                      <a:headEnd type="none" w="med" len="med"/>
+                      <a:tailEnd type="none" w="med" len="med"/>
+                    </a:lnT>
+                    <a:lnB w="12700" cap="flat" cmpd="sng" algn="ctr">
+                      <a:solidFill>
+                        <a:srgbClr val="D8DEEA"/>
+                      </a:solidFill>
+                      <a:prstDash val="solid"/>
+                      <a:round/>
+                      <a:headEnd type="none" w="med" len="med"/>
+                      <a:tailEnd type="none" w="med" len="med"/>
+                    </a:lnB>
+                    <a:solidFill>
+                      <a:srgbClr val="1E2761"/>
+                    </a:solidFill>
+                  </a:tcPr>
+                </a:tc>
+                <a:tc>
+                  <a:txBody>
+                    <a:bodyPr/>
+                    <a:lstStyle/>
+                    <a:p>
+                      <a:pPr marL="0" indent="0" algn="l">
+                        <a:buNone/>
+                      </a:pPr>
+                      <a:r>
+                        <a:rPr lang="en-US" sz="1400" b="1" dirty="0">
+                          <a:solidFill>
+                            <a:srgbClr val="FFFFFF"/>
+                          </a:solidFill>
+                          <a:latin typeface="Calibri" pitchFamily="34" charset="0"/>
+                          <a:ea typeface="Calibri" pitchFamily="34" charset="-122"/>
+                          <a:cs typeface="Calibri" pitchFamily="34" charset="-120"/>
+                        </a:rPr>
+                        <a:t>Repair type</a:t>
+                      </a:r>
+                      <a:endParaRPr lang="en-US" sz="1400" dirty="0">
+                        <a:latin typeface="Calibri" charset="0"/>
+                        <a:ea typeface="Calibri" charset="0"/>
+                        <a:cs typeface="Calibri" charset="0"/>
+                      </a:endParaRPr>
+                    </a:p>
+                  </a:txBody>
+                  <a:tcPr marL="73152" marR="73152" marT="73152" marB="73152" anchor="ctr">
+                    <a:lnL w="12700" cap="flat" cmpd="sng" algn="ctr">
+                      <a:solidFill>
+                        <a:srgbClr val="D8DEEA"/>
+                      </a:solidFill>
+                      <a:prstDash val="solid"/>
+                      <a:round/>
+                      <a:headEnd type="none" w="med" len="med"/>
+                      <a:tailEnd type="none" w="med" len="med"/>
+                    </a:lnL>
+                    <a:lnR w="12700" cap="flat" cmpd="sng" algn="ctr">
+                      <a:solidFill>
+                        <a:srgbClr val="D8DEEA"/>
+                      </a:solidFill>
+                      <a:prstDash val="solid"/>
+                      <a:round/>
+                      <a:headEnd type="none" w="med" len="med"/>
+                      <a:tailEnd type="none" w="med" len="med"/>
+                    </a:lnR>
+                    <a:lnT w="12700" cap="flat" cmpd="sng" algn="ctr">
+                      <a:solidFill>
+                        <a:srgbClr val="D8DEEA"/>
+                      </a:solidFill>
+                      <a:prstDash val="solid"/>
+                      <a:round/>
+                      <a:headEnd type="none" w="med" len="med"/>
+                      <a:tailEnd type="none" w="med" len="med"/>
+                    </a:lnT>
+                    <a:lnB w="12700" cap="flat" cmpd="sng" algn="ctr">
+                      <a:solidFill>
+                        <a:srgbClr val="D8DEEA"/>
+                      </a:solidFill>
+                      <a:prstDash val="solid"/>
+                      <a:round/>
+                      <a:headEnd type="none" w="med" len="med"/>
+                      <a:tailEnd type="none" w="med" len="med"/>
+                    </a:lnB>
+                    <a:solidFill>
+                      <a:srgbClr val="1E2761"/>
+                    </a:solidFill>
+                  </a:tcPr>
+                </a:tc>
+                <a:extLst>
+                  <a:ext uri="{0D108BD9-81ED-4DB2-BD59-A6C34878D82A}">
+                    <a16:rowId xmlns:a16="http://schemas.microsoft.com/office/drawing/2014/main" val="10000"/>
+                  </a:ext>
+                </a:extLst>
+              </a:tr>
+              <a:tr h="658368">
+                <a:tc>
+                  <a:txBody>
+                    <a:bodyPr/>
+                    <a:lstStyle/>
+                    <a:p>
+                      <a:pPr marL="0" indent="0" algn="l">
+                        <a:buNone/>
+                      </a:pPr>
+                      <a:r>
+                        <a:rPr lang="en-US" sz="1250" b="1" dirty="0">
+                          <a:solidFill>
+                            <a:srgbClr val="212121"/>
+                          </a:solidFill>
+                          <a:latin typeface="Calibri" pitchFamily="34" charset="0"/>
+                          <a:ea typeface="Calibri" pitchFamily="34" charset="-122"/>
+                          <a:cs typeface="Calibri" pitchFamily="34" charset="-120"/>
+                        </a:rPr>
+                        <a:t>Model</a:t>
+                      </a:r>
+                      <a:endParaRPr lang="en-US" sz="1250" dirty="0">
+                        <a:latin typeface="Calibri" charset="0"/>
+                        <a:ea typeface="Calibri" charset="0"/>
+                        <a:cs typeface="Calibri" charset="0"/>
+                      </a:endParaRPr>
+                    </a:p>
+                  </a:txBody>
+                  <a:tcPr marL="73152" marR="73152" marT="73152" marB="73152" anchor="ctr">
+                    <a:lnL w="12700" cap="flat" cmpd="sng" algn="ctr">
+                      <a:solidFill>
+                        <a:srgbClr val="D8DEEA"/>
+                      </a:solidFill>
+                      <a:prstDash val="solid"/>
+                      <a:round/>
+                      <a:headEnd type="none" w="med" len="med"/>
+                      <a:tailEnd type="none" w="med" len="med"/>
+                    </a:lnL>
+                    <a:lnR w="12700" cap="flat" cmpd="sng" algn="ctr">
+                      <a:solidFill>
+                        <a:srgbClr val="D8DEEA"/>
+                      </a:solidFill>
+                      <a:prstDash val="solid"/>
+                      <a:round/>
+                      <a:headEnd type="none" w="med" len="med"/>
+                      <a:tailEnd type="none" w="med" len="med"/>
+                    </a:lnR>
+                    <a:lnT w="12700" cap="flat" cmpd="sng" algn="ctr">
+                      <a:solidFill>
+                        <a:srgbClr val="D8DEEA"/>
+                      </a:solidFill>
+                      <a:prstDash val="solid"/>
+                      <a:round/>
+                      <a:headEnd type="none" w="med" len="med"/>
+                      <a:tailEnd type="none" w="med" len="med"/>
+                    </a:lnT>
+                    <a:lnB w="12700" cap="flat" cmpd="sng" algn="ctr">
+                      <a:solidFill>
+                        <a:srgbClr val="D8DEEA"/>
+                      </a:solidFill>
+                      <a:prstDash val="solid"/>
+                      <a:round/>
+                      <a:headEnd type="none" w="med" len="med"/>
+                      <a:tailEnd type="none" w="med" len="med"/>
+                    </a:lnB>
+                    <a:solidFill>
+                      <a:srgbClr val="FFFFFF"/>
+                    </a:solidFill>
+                  </a:tcPr>
+                </a:tc>
+                <a:tc>
+                  <a:txBody>
+                    <a:bodyPr/>
+                    <a:lstStyle/>
+                    <a:p>
+                      <a:pPr marL="0" indent="0" algn="l">
+                        <a:buNone/>
+                      </a:pPr>
+                      <a:r>
+                        <a:rPr lang="en-US" sz="1250" dirty="0">
+                          <a:solidFill>
+                            <a:srgbClr val="212121"/>
+                          </a:solidFill>
+                          <a:latin typeface="Calibri" pitchFamily="34" charset="0"/>
+                          <a:ea typeface="Calibri" pitchFamily="34" charset="-122"/>
+                          <a:cs typeface="Calibri" pitchFamily="34" charset="-120"/>
+                        </a:rPr>
+                        <a:t>whole-file hash of spec files</a:t>
+                      </a:r>
+                      <a:endParaRPr lang="en-US" sz="1250" dirty="0">
+                        <a:latin typeface="Calibri" charset="0"/>
+                        <a:ea typeface="Calibri" charset="0"/>
+                        <a:cs typeface="Calibri" charset="0"/>
+                      </a:endParaRPr>
+                    </a:p>
+                  </a:txBody>
+                  <a:tcPr marL="73152" marR="73152" marT="73152" marB="73152" anchor="ctr">
+                    <a:lnL w="12700" cap="flat" cmpd="sng" algn="ctr">
+                      <a:solidFill>
+                        <a:srgbClr val="D8DEEA"/>
+                      </a:solidFill>
+                      <a:prstDash val="solid"/>
+                      <a:round/>
+                      <a:headEnd type="none" w="med" len="med"/>
+                      <a:tailEnd type="none" w="med" len="med"/>
+                    </a:lnL>
+                    <a:lnR w="12700" cap="flat" cmpd="sng" algn="ctr">
+                      <a:solidFill>
+                        <a:srgbClr val="D8DEEA"/>
+                      </a:solidFill>
+                      <a:prstDash val="solid"/>
+                      <a:round/>
+                      <a:headEnd type="none" w="med" len="med"/>
+                      <a:tailEnd type="none" w="med" len="med"/>
+                    </a:lnR>
+                    <a:lnT w="12700" cap="flat" cmpd="sng" algn="ctr">
+                      <a:solidFill>
+                        <a:srgbClr val="D8DEEA"/>
+                      </a:solidFill>
+                      <a:prstDash val="solid"/>
+                      <a:round/>
+                      <a:headEnd type="none" w="med" len="med"/>
+                      <a:tailEnd type="none" w="med" len="med"/>
+                    </a:lnT>
+                    <a:lnB w="12700" cap="flat" cmpd="sng" algn="ctr">
+                      <a:solidFill>
+                        <a:srgbClr val="D8DEEA"/>
+                      </a:solidFill>
+                      <a:prstDash val="solid"/>
+                      <a:round/>
+                      <a:headEnd type="none" w="med" len="med"/>
+                      <a:tailEnd type="none" w="med" len="med"/>
+                    </a:lnB>
+                    <a:solidFill>
+                      <a:srgbClr val="FFFFFF"/>
+                    </a:solidFill>
+                  </a:tcPr>
+                </a:tc>
+                <a:tc>
+                  <a:txBody>
+                    <a:bodyPr/>
+                    <a:lstStyle/>
+                    <a:p>
+                      <a:pPr marL="0" indent="0" algn="l">
+                        <a:buNone/>
+                      </a:pPr>
+                      <a:r>
+                        <a:rPr lang="en-US" sz="1250" dirty="0">
+                          <a:solidFill>
+                            <a:srgbClr val="212121"/>
+                          </a:solidFill>
+                          <a:latin typeface="Calibri" pitchFamily="34" charset="0"/>
+                          <a:ea typeface="Calibri" pitchFamily="34" charset="-122"/>
+                          <a:cs typeface="Calibri" pitchFamily="34" charset="-120"/>
+                        </a:rPr>
+                        <a:t>appraisal vs the signed golden</a:t>
+                      </a:r>
+                      <a:endParaRPr lang="en-US" sz="1250" dirty="0">
+                        <a:latin typeface="Calibri" charset="0"/>
+                        <a:ea typeface="Calibri" charset="0"/>
+                        <a:cs typeface="Calibri" charset="0"/>
+                      </a:endParaRPr>
+                    </a:p>
+                  </a:txBody>
+                  <a:tcPr marL="73152" marR="73152" marT="73152" marB="73152" anchor="ctr">
+                    <a:lnL w="12700" cap="flat" cmpd="sng" algn="ctr">
+                      <a:solidFill>
+                        <a:srgbClr val="D8DEEA"/>
+                      </a:solidFill>
+                      <a:prstDash val="solid"/>
+                      <a:round/>
+                      <a:headEnd type="none" w="med" len="med"/>
+                      <a:tailEnd type="none" w="med" len="med"/>
+                    </a:lnL>
+                    <a:lnR w="12700" cap="flat" cmpd="sng" algn="ctr">
+                      <a:solidFill>
+                        <a:srgbClr val="D8DEEA"/>
+                      </a:solidFill>
+                      <a:prstDash val="solid"/>
+                      <a:round/>
+                      <a:headEnd type="none" w="med" len="med"/>
+                      <a:tailEnd type="none" w="med" len="med"/>
+                    </a:lnR>
+                    <a:lnT w="12700" cap="flat" cmpd="sng" algn="ctr">
+                      <a:solidFill>
+                        <a:srgbClr val="D8DEEA"/>
+                      </a:solidFill>
+                      <a:prstDash val="solid"/>
+                      <a:round/>
+                      <a:headEnd type="none" w="med" len="med"/>
+                      <a:tailEnd type="none" w="med" len="med"/>
+                    </a:lnT>
+                    <a:lnB w="12700" cap="flat" cmpd="sng" algn="ctr">
+                      <a:solidFill>
+                        <a:srgbClr val="D8DEEA"/>
+                      </a:solidFill>
+                      <a:prstDash val="solid"/>
+                      <a:round/>
+                      <a:headEnd type="none" w="med" len="med"/>
+                      <a:tailEnd type="none" w="med" len="med"/>
+                    </a:lnB>
+                    <a:solidFill>
+                      <a:srgbClr val="FFFFFF"/>
+                    </a:solidFill>
+                  </a:tcPr>
+                </a:tc>
+                <a:tc>
+                  <a:txBody>
+                    <a:bodyPr/>
+                    <a:lstStyle/>
+                    <a:p>
+                      <a:pPr marL="0" indent="0" algn="l">
+                        <a:buNone/>
+                      </a:pPr>
+                      <a:r>
+                        <a:rPr lang="en-US" sz="1250" dirty="0">
+                          <a:solidFill>
+                            <a:srgbClr val="212121"/>
+                          </a:solidFill>
+                          <a:latin typeface="Calibri" pitchFamily="34" charset="0"/>
+                          <a:ea typeface="Calibri" pitchFamily="34" charset="-122"/>
+                          <a:cs typeface="Calibri" pitchFamily="34" charset="-120"/>
+                        </a:rPr>
+                        <a:t>restore from golden — or </a:t>
+                      </a:r>
+                      <a:r>
+                        <a:rPr lang="en-US" sz="1250" i="1" dirty="0">
+                          <a:solidFill>
+                            <a:srgbClr val="212121"/>
+                          </a:solidFill>
+                          <a:latin typeface="Calibri" pitchFamily="34" charset="0"/>
+                          <a:ea typeface="Calibri" pitchFamily="34" charset="-122"/>
+                          <a:cs typeface="Calibri" pitchFamily="34" charset="-120"/>
+                        </a:rPr>
+                        <a:t>bless</a:t>
+                      </a:r>
+                      <a:r>
+                        <a:rPr lang="en-US" sz="1250" dirty="0">
+                          <a:solidFill>
+                            <a:srgbClr val="212121"/>
+                          </a:solidFill>
+                          <a:latin typeface="Calibri" pitchFamily="34" charset="0"/>
+                          <a:ea typeface="Calibri" pitchFamily="34" charset="-122"/>
+                          <a:cs typeface="Calibri" pitchFamily="34" charset="-120"/>
+                        </a:rPr>
+                        <a:t> (sanctioned change)</a:t>
+                      </a:r>
+                      <a:endParaRPr lang="en-US" sz="1250" dirty="0">
+                        <a:latin typeface="Calibri" charset="0"/>
+                        <a:ea typeface="Calibri" charset="0"/>
+                        <a:cs typeface="Calibri" charset="0"/>
+                      </a:endParaRPr>
+                    </a:p>
+                  </a:txBody>
+                  <a:tcPr marL="73152" marR="73152" marT="73152" marB="73152" anchor="ctr">
+                    <a:lnL w="12700" cap="flat" cmpd="sng" algn="ctr">
+                      <a:solidFill>
+                        <a:srgbClr val="D8DEEA"/>
+                      </a:solidFill>
+                      <a:prstDash val="solid"/>
+                      <a:round/>
+                      <a:headEnd type="none" w="med" len="med"/>
+                      <a:tailEnd type="none" w="med" len="med"/>
+                    </a:lnL>
+                    <a:lnR w="12700" cap="flat" cmpd="sng" algn="ctr">
+                      <a:solidFill>
+                        <a:srgbClr val="D8DEEA"/>
+                      </a:solidFill>
+                      <a:prstDash val="solid"/>
+                      <a:round/>
+                      <a:headEnd type="none" w="med" len="med"/>
+                      <a:tailEnd type="none" w="med" len="med"/>
+                    </a:lnR>
+                    <a:lnT w="12700" cap="flat" cmpd="sng" algn="ctr">
+                      <a:solidFill>
+                        <a:srgbClr val="D8DEEA"/>
+                      </a:solidFill>
+                      <a:prstDash val="solid"/>
+                      <a:round/>
+                      <a:headEnd type="none" w="med" len="med"/>
+                      <a:tailEnd type="none" w="med" len="med"/>
+                    </a:lnT>
+                    <a:lnB w="12700" cap="flat" cmpd="sng" algn="ctr">
+                      <a:solidFill>
+                        <a:srgbClr val="D8DEEA"/>
+                      </a:solidFill>
+                      <a:prstDash val="solid"/>
+                      <a:round/>
+                      <a:headEnd type="none" w="med" len="med"/>
+                      <a:tailEnd type="none" w="med" len="med"/>
+                    </a:lnB>
+                    <a:solidFill>
+                      <a:srgbClr val="FFFFFF"/>
+                    </a:solidFill>
+                  </a:tcPr>
+                </a:tc>
+                <a:extLst>
+                  <a:ext uri="{0D108BD9-81ED-4DB2-BD59-A6C34878D82A}">
+                    <a16:rowId xmlns:a16="http://schemas.microsoft.com/office/drawing/2014/main" val="10001"/>
+                  </a:ext>
+                </a:extLst>
+              </a:tr>
+              <a:tr h="658368">
+                <a:tc>
+                  <a:txBody>
+                    <a:bodyPr/>
+                    <a:lstStyle/>
+                    <a:p>
+                      <a:pPr marL="0" indent="0" algn="l">
+                        <a:buNone/>
+                      </a:pPr>
+                      <a:r>
+                        <a:rPr lang="en-US" sz="1250" b="1" dirty="0">
+                          <a:solidFill>
+                            <a:srgbClr val="212121"/>
+                          </a:solidFill>
+                          <a:latin typeface="Calibri" pitchFamily="34" charset="0"/>
+                          <a:ea typeface="Calibri" pitchFamily="34" charset="-122"/>
+                          <a:cs typeface="Calibri" pitchFamily="34" charset="-120"/>
+                        </a:rPr>
+                        <a:t>Contract</a:t>
+                      </a:r>
+                      <a:endParaRPr lang="en-US" sz="1250" dirty="0">
+                        <a:latin typeface="Calibri" charset="0"/>
+                        <a:ea typeface="Calibri" charset="0"/>
+                        <a:cs typeface="Calibri" charset="0"/>
+                      </a:endParaRPr>
+                    </a:p>
+                  </a:txBody>
+                  <a:tcPr marL="73152" marR="73152" marT="73152" marB="73152" anchor="ctr">
+                    <a:lnL w="12700" cap="flat" cmpd="sng" algn="ctr">
+                      <a:solidFill>
+                        <a:srgbClr val="D8DEEA"/>
+                      </a:solidFill>
+                      <a:prstDash val="solid"/>
+                      <a:round/>
+                      <a:headEnd type="none" w="med" len="med"/>
+                      <a:tailEnd type="none" w="med" len="med"/>
+                    </a:lnL>
+                    <a:lnR w="12700" cap="flat" cmpd="sng" algn="ctr">
+                      <a:solidFill>
+                        <a:srgbClr val="D8DEEA"/>
+                      </a:solidFill>
+                      <a:prstDash val="solid"/>
+                      <a:round/>
+                      <a:headEnd type="none" w="med" len="med"/>
+                      <a:tailEnd type="none" w="med" len="med"/>
+                    </a:lnR>
+                    <a:lnT w="12700" cap="flat" cmpd="sng" algn="ctr">
+                      <a:solidFill>
+                        <a:srgbClr val="D8DEEA"/>
+                      </a:solidFill>
+                      <a:prstDash val="solid"/>
+                      <a:round/>
+                      <a:headEnd type="none" w="med" len="med"/>
+                      <a:tailEnd type="none" w="med" len="med"/>
+                    </a:lnT>
+                    <a:lnB w="12700" cap="flat" cmpd="sng" algn="ctr">
+                      <a:solidFill>
+                        <a:srgbClr val="D8DEEA"/>
+                      </a:solidFill>
+                      <a:prstDash val="solid"/>
+                      <a:round/>
+                      <a:headEnd type="none" w="med" len="med"/>
+                      <a:tailEnd type="none" w="med" len="med"/>
+                    </a:lnB>
+                    <a:solidFill>
+                      <a:srgbClr val="FFFFFF"/>
+                    </a:solidFill>
+                  </a:tcPr>
+                </a:tc>
+                <a:tc>
+                  <a:txBody>
+                    <a:bodyPr/>
+                    <a:lstStyle/>
+                    <a:p>
+                      <a:pPr marL="0" indent="0" algn="l">
+                        <a:buNone/>
+                      </a:pPr>
+                      <a:r>
+                        <a:rPr lang="en-US" sz="1250" dirty="0">
+                          <a:solidFill>
+                            <a:srgbClr val="212121"/>
+                          </a:solidFill>
+                          <a:latin typeface="Calibri" pitchFamily="34" charset="0"/>
+                          <a:ea typeface="Calibri" pitchFamily="34" charset="-122"/>
+                          <a:cs typeface="Calibri" pitchFamily="34" charset="-120"/>
+                        </a:rPr>
+                        <a:t>syntax-guided file slices</a:t>
+                      </a:r>
+                      <a:endParaRPr lang="en-US" sz="1250" dirty="0">
+                        <a:latin typeface="Calibri" charset="0"/>
+                        <a:ea typeface="Calibri" charset="0"/>
+                        <a:cs typeface="Calibri" charset="0"/>
+                      </a:endParaRPr>
+                    </a:p>
+                  </a:txBody>
+                  <a:tcPr marL="73152" marR="73152" marT="73152" marB="73152" anchor="ctr">
+                    <a:lnL w="12700" cap="flat" cmpd="sng" algn="ctr">
+                      <a:solidFill>
+                        <a:srgbClr val="D8DEEA"/>
+                      </a:solidFill>
+                      <a:prstDash val="solid"/>
+                      <a:round/>
+                      <a:headEnd type="none" w="med" len="med"/>
+                      <a:tailEnd type="none" w="med" len="med"/>
+                    </a:lnL>
+                    <a:lnR w="12700" cap="flat" cmpd="sng" algn="ctr">
+                      <a:solidFill>
+                        <a:srgbClr val="D8DEEA"/>
+                      </a:solidFill>
+                      <a:prstDash val="solid"/>
+                      <a:round/>
+                      <a:headEnd type="none" w="med" len="med"/>
+                      <a:tailEnd type="none" w="med" len="med"/>
+                    </a:lnR>
+                    <a:lnT w="12700" cap="flat" cmpd="sng" algn="ctr">
+                      <a:solidFill>
+                        <a:srgbClr val="D8DEEA"/>
+                      </a:solidFill>
+                      <a:prstDash val="solid"/>
+                      <a:round/>
+                      <a:headEnd type="none" w="med" len="med"/>
+                      <a:tailEnd type="none" w="med" len="med"/>
+                    </a:lnT>
+                    <a:lnB w="12700" cap="flat" cmpd="sng" algn="ctr">
+                      <a:solidFill>
+                        <a:srgbClr val="D8DEEA"/>
+                      </a:solidFill>
+                      <a:prstDash val="solid"/>
+                      <a:round/>
+                      <a:headEnd type="none" w="med" len="med"/>
+                      <a:tailEnd type="none" w="med" len="med"/>
+                    </a:lnB>
+                    <a:solidFill>
+                      <a:srgbClr val="FFFFFF"/>
+                    </a:solidFill>
+                  </a:tcPr>
+                </a:tc>
+                <a:tc>
+                  <a:txBody>
+                    <a:bodyPr/>
+                    <a:lstStyle/>
+                    <a:p>
+                      <a:pPr marL="0" indent="0" algn="l">
+                        <a:buNone/>
+                      </a:pPr>
+                      <a:r>
+                        <a:rPr lang="en-US" sz="1250" dirty="0">
+                          <a:solidFill>
+                            <a:srgbClr val="212121"/>
+                          </a:solidFill>
+                          <a:latin typeface="Calibri" pitchFamily="34" charset="0"/>
+                          <a:ea typeface="Calibri" pitchFamily="34" charset="-122"/>
+                          <a:cs typeface="Calibri" pitchFamily="34" charset="-120"/>
+                        </a:rPr>
+                        <a:t>slice-level appraisal, attributed by name</a:t>
+                      </a:r>
+                      <a:endParaRPr lang="en-US" sz="1250" dirty="0">
+                        <a:latin typeface="Calibri" charset="0"/>
+                        <a:ea typeface="Calibri" charset="0"/>
+                        <a:cs typeface="Calibri" charset="0"/>
+                      </a:endParaRPr>
+                    </a:p>
+                  </a:txBody>
+                  <a:tcPr marL="73152" marR="73152" marT="73152" marB="73152" anchor="ctr">
+                    <a:lnL w="12700" cap="flat" cmpd="sng" algn="ctr">
+                      <a:solidFill>
+                        <a:srgbClr val="D8DEEA"/>
+                      </a:solidFill>
+                      <a:prstDash val="solid"/>
+                      <a:round/>
+                      <a:headEnd type="none" w="med" len="med"/>
+                      <a:tailEnd type="none" w="med" len="med"/>
+                    </a:lnL>
+                    <a:lnR w="12700" cap="flat" cmpd="sng" algn="ctr">
+                      <a:solidFill>
+                        <a:srgbClr val="D8DEEA"/>
+                      </a:solidFill>
+                      <a:prstDash val="solid"/>
+                      <a:round/>
+                      <a:headEnd type="none" w="med" len="med"/>
+                      <a:tailEnd type="none" w="med" len="med"/>
+                    </a:lnR>
+                    <a:lnT w="12700" cap="flat" cmpd="sng" algn="ctr">
+                      <a:solidFill>
+                        <a:srgbClr val="D8DEEA"/>
+                      </a:solidFill>
+                      <a:prstDash val="solid"/>
+                      <a:round/>
+                      <a:headEnd type="none" w="med" len="med"/>
+                      <a:tailEnd type="none" w="med" len="med"/>
+                    </a:lnT>
+                    <a:lnB w="12700" cap="flat" cmpd="sng" algn="ctr">
+                      <a:solidFill>
+                        <a:srgbClr val="D8DEEA"/>
+                      </a:solidFill>
+                      <a:prstDash val="solid"/>
+                      <a:round/>
+                      <a:headEnd type="none" w="med" len="med"/>
+                      <a:tailEnd type="none" w="med" len="med"/>
+                    </a:lnB>
+                    <a:solidFill>
+                      <a:srgbClr val="FFFFFF"/>
+                    </a:solidFill>
+                  </a:tcPr>
+                </a:tc>
+                <a:tc>
+                  <a:txBody>
+                    <a:bodyPr/>
+                    <a:lstStyle/>
+                    <a:p>
+                      <a:pPr marL="0" indent="0" algn="l">
+                        <a:buNone/>
+                      </a:pPr>
+                      <a:r>
+                        <a:rPr lang="en-US" sz="1250" dirty="0">
+                          <a:solidFill>
+                            <a:srgbClr val="212121"/>
+                          </a:solidFill>
+                          <a:latin typeface="Calibri" pitchFamily="34" charset="0"/>
+                          <a:ea typeface="Calibri" pitchFamily="34" charset="-122"/>
+                          <a:cs typeface="Calibri" pitchFamily="34" charset="-120"/>
+                        </a:rPr>
+                        <a:t>restore golden slice</a:t>
+                      </a:r>
+                      <a:endParaRPr lang="en-US" sz="1250" dirty="0">
+                        <a:latin typeface="Calibri" charset="0"/>
+                        <a:ea typeface="Calibri" charset="0"/>
+                        <a:cs typeface="Calibri" charset="0"/>
+                      </a:endParaRPr>
+                    </a:p>
+                  </a:txBody>
+                  <a:tcPr marL="73152" marR="73152" marT="73152" marB="73152" anchor="ctr">
+                    <a:lnL w="12700" cap="flat" cmpd="sng" algn="ctr">
+                      <a:solidFill>
+                        <a:srgbClr val="D8DEEA"/>
+                      </a:solidFill>
+                      <a:prstDash val="solid"/>
+                      <a:round/>
+                      <a:headEnd type="none" w="med" len="med"/>
+                      <a:tailEnd type="none" w="med" len="med"/>
+                    </a:lnL>
+                    <a:lnR w="12700" cap="flat" cmpd="sng" algn="ctr">
+                      <a:solidFill>
+                        <a:srgbClr val="D8DEEA"/>
+                      </a:solidFill>
+                      <a:prstDash val="solid"/>
+                      <a:round/>
+                      <a:headEnd type="none" w="med" len="med"/>
+                      <a:tailEnd type="none" w="med" len="med"/>
+                    </a:lnR>
+                    <a:lnT w="12700" cap="flat" cmpd="sng" algn="ctr">
+                      <a:solidFill>
+                        <a:srgbClr val="D8DEEA"/>
+                      </a:solidFill>
+                      <a:prstDash val="solid"/>
+                      <a:round/>
+                      <a:headEnd type="none" w="med" len="med"/>
+                      <a:tailEnd type="none" w="med" len="med"/>
+                    </a:lnT>
+                    <a:lnB w="12700" cap="flat" cmpd="sng" algn="ctr">
+                      <a:solidFill>
+                        <a:srgbClr val="D8DEEA"/>
+                      </a:solidFill>
+                      <a:prstDash val="solid"/>
+                      <a:round/>
+                      <a:headEnd type="none" w="med" len="med"/>
+                      <a:tailEnd type="none" w="med" len="med"/>
+                    </a:lnB>
+                    <a:solidFill>
+                      <a:srgbClr val="FFFFFF"/>
+                    </a:solidFill>
+                  </a:tcPr>
+                </a:tc>
+                <a:extLst>
+                  <a:ext uri="{0D108BD9-81ED-4DB2-BD59-A6C34878D82A}">
+                    <a16:rowId xmlns:a16="http://schemas.microsoft.com/office/drawing/2014/main" val="10002"/>
+                  </a:ext>
+                </a:extLst>
+              </a:tr>
+              <a:tr h="658368">
+                <a:tc>
+                  <a:txBody>
+                    <a:bodyPr/>
+                    <a:lstStyle/>
+                    <a:p>
+                      <a:pPr marL="0" indent="0" algn="l">
+                        <a:buNone/>
+                      </a:pPr>
+                      <a:r>
+                        <a:rPr lang="en-US" sz="1250" b="1" dirty="0">
+                          <a:solidFill>
+                            <a:srgbClr val="212121"/>
+                          </a:solidFill>
+                          <a:latin typeface="Calibri" pitchFamily="34" charset="0"/>
+                          <a:ea typeface="Calibri" pitchFamily="34" charset="-122"/>
+                          <a:cs typeface="Calibri" pitchFamily="34" charset="-120"/>
+                        </a:rPr>
+                        <a:t>Implementation</a:t>
+                      </a:r>
+                      <a:endParaRPr lang="en-US" sz="1250" dirty="0">
+                        <a:latin typeface="Calibri" charset="0"/>
+                        <a:ea typeface="Calibri" charset="0"/>
+                        <a:cs typeface="Calibri" charset="0"/>
+                      </a:endParaRPr>
+                    </a:p>
+                  </a:txBody>
+                  <a:tcPr marL="73152" marR="73152" marT="73152" marB="73152" anchor="ctr">
+                    <a:lnL w="12700" cap="flat" cmpd="sng" algn="ctr">
+                      <a:solidFill>
+                        <a:srgbClr val="D8DEEA"/>
+                      </a:solidFill>
+                      <a:prstDash val="solid"/>
+                      <a:round/>
+                      <a:headEnd type="none" w="med" len="med"/>
+                      <a:tailEnd type="none" w="med" len="med"/>
+                    </a:lnL>
+                    <a:lnR w="12700" cap="flat" cmpd="sng" algn="ctr">
+                      <a:solidFill>
+                        <a:srgbClr val="D8DEEA"/>
+                      </a:solidFill>
+                      <a:prstDash val="solid"/>
+                      <a:round/>
+                      <a:headEnd type="none" w="med" len="med"/>
+                      <a:tailEnd type="none" w="med" len="med"/>
+                    </a:lnR>
+                    <a:lnT w="12700" cap="flat" cmpd="sng" algn="ctr">
+                      <a:solidFill>
+                        <a:srgbClr val="D8DEEA"/>
+                      </a:solidFill>
+                      <a:prstDash val="solid"/>
+                      <a:round/>
+                      <a:headEnd type="none" w="med" len="med"/>
+                      <a:tailEnd type="none" w="med" len="med"/>
+                    </a:lnT>
+                    <a:lnB w="12700" cap="flat" cmpd="sng" algn="ctr">
+                      <a:solidFill>
+                        <a:srgbClr val="D8DEEA"/>
+                      </a:solidFill>
+                      <a:prstDash val="solid"/>
+                      <a:round/>
+                      <a:headEnd type="none" w="med" len="med"/>
+                      <a:tailEnd type="none" w="med" len="med"/>
+                    </a:lnB>
+                    <a:solidFill>
+                      <a:srgbClr val="FFFFFF"/>
+                    </a:solidFill>
+                  </a:tcPr>
+                </a:tc>
+                <a:tc>
+                  <a:txBody>
+                    <a:bodyPr/>
+                    <a:lstStyle/>
+                    <a:p>
+                      <a:pPr marL="0" indent="0" algn="l">
+                        <a:buNone/>
+                      </a:pPr>
+                      <a:r>
+                        <a:rPr lang="en-US" sz="1250" dirty="0">
+                          <a:solidFill>
+                            <a:srgbClr val="212121"/>
+                          </a:solidFill>
+                          <a:latin typeface="Calibri" pitchFamily="34" charset="0"/>
+                          <a:ea typeface="Calibri" pitchFamily="34" charset="-122"/>
+                          <a:cs typeface="Calibri" pitchFamily="34" charset="-120"/>
+                        </a:rPr>
+                        <a:t>developer-owned code</a:t>
+                      </a:r>
+                      <a:endParaRPr lang="en-US" sz="1250" dirty="0">
+                        <a:latin typeface="Calibri" charset="0"/>
+                        <a:ea typeface="Calibri" charset="0"/>
+                        <a:cs typeface="Calibri" charset="0"/>
+                      </a:endParaRPr>
+                    </a:p>
+                  </a:txBody>
+                  <a:tcPr marL="73152" marR="73152" marT="73152" marB="73152" anchor="ctr">
+                    <a:lnL w="12700" cap="flat" cmpd="sng" algn="ctr">
+                      <a:solidFill>
+                        <a:srgbClr val="D8DEEA"/>
+                      </a:solidFill>
+                      <a:prstDash val="solid"/>
+                      <a:round/>
+                      <a:headEnd type="none" w="med" len="med"/>
+                      <a:tailEnd type="none" w="med" len="med"/>
+                    </a:lnL>
+                    <a:lnR w="12700" cap="flat" cmpd="sng" algn="ctr">
+                      <a:solidFill>
+                        <a:srgbClr val="D8DEEA"/>
+                      </a:solidFill>
+                      <a:prstDash val="solid"/>
+                      <a:round/>
+                      <a:headEnd type="none" w="med" len="med"/>
+                      <a:tailEnd type="none" w="med" len="med"/>
+                    </a:lnR>
+                    <a:lnT w="12700" cap="flat" cmpd="sng" algn="ctr">
+                      <a:solidFill>
+                        <a:srgbClr val="D8DEEA"/>
+                      </a:solidFill>
+                      <a:prstDash val="solid"/>
+                      <a:round/>
+                      <a:headEnd type="none" w="med" len="med"/>
+                      <a:tailEnd type="none" w="med" len="med"/>
+                    </a:lnT>
+                    <a:lnB w="12700" cap="flat" cmpd="sng" algn="ctr">
+                      <a:solidFill>
+                        <a:srgbClr val="D8DEEA"/>
+                      </a:solidFill>
+                      <a:prstDash val="solid"/>
+                      <a:round/>
+                      <a:headEnd type="none" w="med" len="med"/>
+                      <a:tailEnd type="none" w="med" len="med"/>
+                    </a:lnB>
+                    <a:solidFill>
+                      <a:srgbClr val="FFFFFF"/>
+                    </a:solidFill>
+                  </a:tcPr>
+                </a:tc>
+                <a:tc>
+                  <a:txBody>
+                    <a:bodyPr/>
+                    <a:lstStyle/>
+                    <a:p>
+                      <a:pPr marL="0" indent="0" algn="l">
+                        <a:buNone/>
+                      </a:pPr>
+                      <a:r>
+                        <a:rPr lang="en-US" sz="1250" dirty="0">
+                          <a:solidFill>
+                            <a:srgbClr val="212121"/>
+                          </a:solidFill>
+                          <a:latin typeface="Calibri" pitchFamily="34" charset="0"/>
+                          <a:ea typeface="Calibri" charset="0"/>
+                          <a:cs typeface="Calibri" pitchFamily="34" charset="-120"/>
+                        </a:rPr>
+                        <a:t>tests + verification of contracts</a:t>
+                      </a:r>
+                      <a:endParaRPr lang="en-US" sz="1250" dirty="0">
+                        <a:latin typeface="Calibri" charset="0"/>
+                        <a:ea typeface="Calibri" charset="0"/>
+                        <a:cs typeface="Calibri" charset="0"/>
+                      </a:endParaRPr>
+                    </a:p>
+                  </a:txBody>
+                  <a:tcPr marL="73152" marR="73152" marT="73152" marB="73152" anchor="ctr">
+                    <a:lnL w="12700" cap="flat" cmpd="sng" algn="ctr">
+                      <a:solidFill>
+                        <a:srgbClr val="D8DEEA"/>
+                      </a:solidFill>
+                      <a:prstDash val="solid"/>
+                      <a:round/>
+                      <a:headEnd type="none" w="med" len="med"/>
+                      <a:tailEnd type="none" w="med" len="med"/>
+                    </a:lnL>
+                    <a:lnR w="12700" cap="flat" cmpd="sng" algn="ctr">
+                      <a:solidFill>
+                        <a:srgbClr val="D8DEEA"/>
+                      </a:solidFill>
+                      <a:prstDash val="solid"/>
+                      <a:round/>
+                      <a:headEnd type="none" w="med" len="med"/>
+                      <a:tailEnd type="none" w="med" len="med"/>
+                    </a:lnR>
+                    <a:lnT w="12700" cap="flat" cmpd="sng" algn="ctr">
+                      <a:solidFill>
+                        <a:srgbClr val="D8DEEA"/>
+                      </a:solidFill>
+                      <a:prstDash val="solid"/>
+                      <a:round/>
+                      <a:headEnd type="none" w="med" len="med"/>
+                      <a:tailEnd type="none" w="med" len="med"/>
+                    </a:lnT>
+                    <a:lnB w="12700" cap="flat" cmpd="sng" algn="ctr">
+                      <a:solidFill>
+                        <a:srgbClr val="D8DEEA"/>
+                      </a:solidFill>
+                      <a:prstDash val="solid"/>
+                      <a:round/>
+                      <a:headEnd type="none" w="med" len="med"/>
+                      <a:tailEnd type="none" w="med" len="med"/>
+                    </a:lnB>
+                    <a:solidFill>
+                      <a:srgbClr val="FFFFFF"/>
+                    </a:solidFill>
+                  </a:tcPr>
+                </a:tc>
+                <a:tc>
+                  <a:txBody>
+                    <a:bodyPr/>
+                    <a:lstStyle/>
+                    <a:p>
+                      <a:pPr marL="0" indent="0" algn="l">
+                        <a:buNone/>
+                      </a:pPr>
+                      <a:r>
+                        <a:rPr lang="en-US" sz="1250" dirty="0">
+                          <a:solidFill>
+                            <a:srgbClr val="212121"/>
+                          </a:solidFill>
+                          <a:latin typeface="Calibri" pitchFamily="34" charset="0"/>
+                          <a:ea typeface="Calibri" pitchFamily="34" charset="-122"/>
+                          <a:cs typeface="Calibri" pitchFamily="34" charset="-120"/>
+                        </a:rPr>
+                        <a:t>code synthesis/repair</a:t>
+                      </a:r>
+                      <a:endParaRPr lang="en-US" sz="1250" dirty="0">
+                        <a:latin typeface="Calibri" charset="0"/>
+                        <a:ea typeface="Calibri" charset="0"/>
+                        <a:cs typeface="Calibri" charset="0"/>
+                      </a:endParaRPr>
+                    </a:p>
+                  </a:txBody>
+                  <a:tcPr marL="73152" marR="73152" marT="73152" marB="73152" anchor="ctr">
+                    <a:lnL w="12700" cap="flat" cmpd="sng" algn="ctr">
+                      <a:solidFill>
+                        <a:srgbClr val="D8DEEA"/>
+                      </a:solidFill>
+                      <a:prstDash val="solid"/>
+                      <a:round/>
+                      <a:headEnd type="none" w="med" len="med"/>
+                      <a:tailEnd type="none" w="med" len="med"/>
+                    </a:lnL>
+                    <a:lnR w="12700" cap="flat" cmpd="sng" algn="ctr">
+                      <a:solidFill>
+                        <a:srgbClr val="D8DEEA"/>
+                      </a:solidFill>
+                      <a:prstDash val="solid"/>
+                      <a:round/>
+                      <a:headEnd type="none" w="med" len="med"/>
+                      <a:tailEnd type="none" w="med" len="med"/>
+                    </a:lnR>
+                    <a:lnT w="12700" cap="flat" cmpd="sng" algn="ctr">
+                      <a:solidFill>
+                        <a:srgbClr val="D8DEEA"/>
+                      </a:solidFill>
+                      <a:prstDash val="solid"/>
+                      <a:round/>
+                      <a:headEnd type="none" w="med" len="med"/>
+                      <a:tailEnd type="none" w="med" len="med"/>
+                    </a:lnT>
+                    <a:lnB w="12700" cap="flat" cmpd="sng" algn="ctr">
+                      <a:solidFill>
+                        <a:srgbClr val="D8DEEA"/>
+                      </a:solidFill>
+                      <a:prstDash val="solid"/>
+                      <a:round/>
+                      <a:headEnd type="none" w="med" len="med"/>
+                      <a:tailEnd type="none" w="med" len="med"/>
+                    </a:lnB>
+                    <a:solidFill>
+                      <a:srgbClr val="FFFFFF"/>
+                    </a:solidFill>
+                  </a:tcPr>
+                </a:tc>
+                <a:extLst>
+                  <a:ext uri="{0D108BD9-81ED-4DB2-BD59-A6C34878D82A}">
+                    <a16:rowId xmlns:a16="http://schemas.microsoft.com/office/drawing/2014/main" val="10003"/>
+                  </a:ext>
+                </a:extLst>
+              </a:tr>
+              <a:tr h="658368">
+                <a:tc>
+                  <a:txBody>
+                    <a:bodyPr/>
+                    <a:lstStyle/>
+                    <a:p>
+                      <a:pPr marL="0" indent="0" algn="l">
+                        <a:buNone/>
+                      </a:pPr>
+                      <a:r>
+                        <a:rPr lang="en-US" sz="1250" b="1" dirty="0">
+                          <a:solidFill>
+                            <a:srgbClr val="212121"/>
+                          </a:solidFill>
+                          <a:latin typeface="Calibri" pitchFamily="34" charset="0"/>
+                          <a:ea typeface="Calibri" pitchFamily="34" charset="-122"/>
+                          <a:cs typeface="Calibri" pitchFamily="34" charset="-120"/>
+                        </a:rPr>
+                        <a:t>Proof / Verification</a:t>
+                      </a:r>
+                      <a:endParaRPr lang="en-US" sz="1250" dirty="0">
+                        <a:latin typeface="Calibri" charset="0"/>
+                        <a:ea typeface="Calibri" charset="0"/>
+                        <a:cs typeface="Calibri" charset="0"/>
+                      </a:endParaRPr>
+                    </a:p>
+                  </a:txBody>
+                  <a:tcPr marL="73152" marR="73152" marT="73152" marB="73152" anchor="ctr">
+                    <a:lnL w="12700" cap="flat" cmpd="sng" algn="ctr">
+                      <a:solidFill>
+                        <a:srgbClr val="D8DEEA"/>
+                      </a:solidFill>
+                      <a:prstDash val="solid"/>
+                      <a:round/>
+                      <a:headEnd type="none" w="med" len="med"/>
+                      <a:tailEnd type="none" w="med" len="med"/>
+                    </a:lnL>
+                    <a:lnR w="12700" cap="flat" cmpd="sng" algn="ctr">
+                      <a:solidFill>
+                        <a:srgbClr val="D8DEEA"/>
+                      </a:solidFill>
+                      <a:prstDash val="solid"/>
+                      <a:round/>
+                      <a:headEnd type="none" w="med" len="med"/>
+                      <a:tailEnd type="none" w="med" len="med"/>
+                    </a:lnR>
+                    <a:lnT w="12700" cap="flat" cmpd="sng" algn="ctr">
+                      <a:solidFill>
+                        <a:srgbClr val="D8DEEA"/>
+                      </a:solidFill>
+                      <a:prstDash val="solid"/>
+                      <a:round/>
+                      <a:headEnd type="none" w="med" len="med"/>
+                      <a:tailEnd type="none" w="med" len="med"/>
+                    </a:lnT>
+                    <a:lnB w="12700" cap="flat" cmpd="sng" algn="ctr">
+                      <a:solidFill>
+                        <a:srgbClr val="D8DEEA"/>
+                      </a:solidFill>
+                      <a:prstDash val="solid"/>
+                      <a:round/>
+                      <a:headEnd type="none" w="med" len="med"/>
+                      <a:tailEnd type="none" w="med" len="med"/>
+                    </a:lnB>
+                    <a:solidFill>
+                      <a:srgbClr val="FFFFFF"/>
+                    </a:solidFill>
+                  </a:tcPr>
+                </a:tc>
+                <a:tc>
+                  <a:txBody>
+                    <a:bodyPr/>
+                    <a:lstStyle/>
+                    <a:p>
+                      <a:pPr marL="0" indent="0" algn="l">
+                        <a:buNone/>
+                      </a:pPr>
+                      <a:r>
+                        <a:rPr lang="en-US" sz="1250" dirty="0">
+                          <a:solidFill>
+                            <a:srgbClr val="212121"/>
+                          </a:solidFill>
+                          <a:latin typeface="Calibri" pitchFamily="34" charset="0"/>
+                          <a:ea typeface="Calibri" pitchFamily="34" charset="-122"/>
+                          <a:cs typeface="Calibri" pitchFamily="34" charset="-120"/>
+                        </a:rPr>
+                        <a:t>live verification run</a:t>
+                      </a:r>
+                      <a:endParaRPr lang="en-US" sz="1250" dirty="0">
+                        <a:latin typeface="Calibri" charset="0"/>
+                        <a:ea typeface="Calibri" charset="0"/>
+                        <a:cs typeface="Calibri" charset="0"/>
+                      </a:endParaRPr>
+                    </a:p>
+                  </a:txBody>
+                  <a:tcPr marL="73152" marR="73152" marT="73152" marB="73152" anchor="ctr">
+                    <a:lnL w="12700" cap="flat" cmpd="sng" algn="ctr">
+                      <a:solidFill>
+                        <a:srgbClr val="D8DEEA"/>
+                      </a:solidFill>
+                      <a:prstDash val="solid"/>
+                      <a:round/>
+                      <a:headEnd type="none" w="med" len="med"/>
+                      <a:tailEnd type="none" w="med" len="med"/>
+                    </a:lnL>
+                    <a:lnR w="12700" cap="flat" cmpd="sng" algn="ctr">
+                      <a:solidFill>
+                        <a:srgbClr val="D8DEEA"/>
+                      </a:solidFill>
+                      <a:prstDash val="solid"/>
+                      <a:round/>
+                      <a:headEnd type="none" w="med" len="med"/>
+                      <a:tailEnd type="none" w="med" len="med"/>
+                    </a:lnR>
+                    <a:lnT w="12700" cap="flat" cmpd="sng" algn="ctr">
+                      <a:solidFill>
+                        <a:srgbClr val="D8DEEA"/>
+                      </a:solidFill>
+                      <a:prstDash val="solid"/>
+                      <a:round/>
+                      <a:headEnd type="none" w="med" len="med"/>
+                      <a:tailEnd type="none" w="med" len="med"/>
+                    </a:lnT>
+                    <a:lnB w="12700" cap="flat" cmpd="sng" algn="ctr">
+                      <a:solidFill>
+                        <a:srgbClr val="D8DEEA"/>
+                      </a:solidFill>
+                      <a:prstDash val="solid"/>
+                      <a:round/>
+                      <a:headEnd type="none" w="med" len="med"/>
+                      <a:tailEnd type="none" w="med" len="med"/>
+                    </a:lnB>
+                    <a:solidFill>
+                      <a:srgbClr val="FFFFFF"/>
+                    </a:solidFill>
+                  </a:tcPr>
+                </a:tc>
+                <a:tc>
+                  <a:txBody>
+                    <a:bodyPr/>
+                    <a:lstStyle/>
+                    <a:p>
+                      <a:pPr marL="0" indent="0" algn="l">
+                        <a:buNone/>
+                      </a:pPr>
+                      <a:r>
+                        <a:rPr lang="en-US" sz="1250" dirty="0">
+                          <a:solidFill>
+                            <a:srgbClr val="212121"/>
+                          </a:solidFill>
+                          <a:latin typeface="Calibri" pitchFamily="34" charset="0"/>
+                          <a:ea typeface="Calibri" pitchFamily="34" charset="-122"/>
+                          <a:cs typeface="Calibri" pitchFamily="34" charset="-120"/>
+                        </a:rPr>
+                        <a:t>verification kernel — fresh, never cached</a:t>
+                      </a:r>
+                      <a:endParaRPr lang="en-US" sz="1250" dirty="0">
+                        <a:latin typeface="Calibri" charset="0"/>
+                        <a:ea typeface="Calibri" charset="0"/>
+                        <a:cs typeface="Calibri" charset="0"/>
+                      </a:endParaRPr>
+                    </a:p>
+                  </a:txBody>
+                  <a:tcPr marL="73152" marR="73152" marT="73152" marB="73152" anchor="ctr">
+                    <a:lnL w="12700" cap="flat" cmpd="sng" algn="ctr">
+                      <a:solidFill>
+                        <a:srgbClr val="D8DEEA"/>
+                      </a:solidFill>
+                      <a:prstDash val="solid"/>
+                      <a:round/>
+                      <a:headEnd type="none" w="med" len="med"/>
+                      <a:tailEnd type="none" w="med" len="med"/>
+                    </a:lnL>
+                    <a:lnR w="12700" cap="flat" cmpd="sng" algn="ctr">
+                      <a:solidFill>
+                        <a:srgbClr val="D8DEEA"/>
+                      </a:solidFill>
+                      <a:prstDash val="solid"/>
+                      <a:round/>
+                      <a:headEnd type="none" w="med" len="med"/>
+                      <a:tailEnd type="none" w="med" len="med"/>
+                    </a:lnR>
+                    <a:lnT w="12700" cap="flat" cmpd="sng" algn="ctr">
+                      <a:solidFill>
+                        <a:srgbClr val="D8DEEA"/>
+                      </a:solidFill>
+                      <a:prstDash val="solid"/>
+                      <a:round/>
+                      <a:headEnd type="none" w="med" len="med"/>
+                      <a:tailEnd type="none" w="med" len="med"/>
+                    </a:lnT>
+                    <a:lnB w="12700" cap="flat" cmpd="sng" algn="ctr">
+                      <a:solidFill>
+                        <a:srgbClr val="D8DEEA"/>
+                      </a:solidFill>
+                      <a:prstDash val="solid"/>
+                      <a:round/>
+                      <a:headEnd type="none" w="med" len="med"/>
+                      <a:tailEnd type="none" w="med" len="med"/>
+                    </a:lnB>
+                    <a:solidFill>
+                      <a:srgbClr val="FFFFFF"/>
+                    </a:solidFill>
+                  </a:tcPr>
+                </a:tc>
+                <a:tc>
+                  <a:txBody>
+                    <a:bodyPr/>
+                    <a:lstStyle/>
+                    <a:p>
+                      <a:pPr marL="0" indent="0" algn="l">
+                        <a:buNone/>
+                      </a:pPr>
+                      <a:r>
+                        <a:rPr lang="en-US" sz="1250" dirty="0">
+                          <a:solidFill>
+                            <a:srgbClr val="212121"/>
+                          </a:solidFill>
+                          <a:latin typeface="Calibri" pitchFamily="34" charset="0"/>
+                          <a:ea typeface="Calibri" pitchFamily="34" charset="-122"/>
+                          <a:cs typeface="Calibri" pitchFamily="34" charset="-120"/>
+                        </a:rPr>
+                        <a:t>proof synthesis/repair</a:t>
+                      </a:r>
+                      <a:endParaRPr lang="en-US" sz="1250" dirty="0">
+                        <a:latin typeface="Calibri" charset="0"/>
+                        <a:ea typeface="Calibri" charset="0"/>
+                        <a:cs typeface="Calibri" charset="0"/>
+                      </a:endParaRPr>
+                    </a:p>
+                  </a:txBody>
+                  <a:tcPr marL="73152" marR="73152" marT="73152" marB="73152" anchor="ctr">
+                    <a:lnL w="12700" cap="flat" cmpd="sng" algn="ctr">
+                      <a:solidFill>
+                        <a:srgbClr val="D8DEEA"/>
+                      </a:solidFill>
+                      <a:prstDash val="solid"/>
+                      <a:round/>
+                      <a:headEnd type="none" w="med" len="med"/>
+                      <a:tailEnd type="none" w="med" len="med"/>
+                    </a:lnL>
+                    <a:lnR w="12700" cap="flat" cmpd="sng" algn="ctr">
+                      <a:solidFill>
+                        <a:srgbClr val="D8DEEA"/>
+                      </a:solidFill>
+                      <a:prstDash val="solid"/>
+                      <a:round/>
+                      <a:headEnd type="none" w="med" len="med"/>
+                      <a:tailEnd type="none" w="med" len="med"/>
+                    </a:lnR>
+                    <a:lnT w="12700" cap="flat" cmpd="sng" algn="ctr">
+                      <a:solidFill>
+                        <a:srgbClr val="D8DEEA"/>
+                      </a:solidFill>
+                      <a:prstDash val="solid"/>
+                      <a:round/>
+                      <a:headEnd type="none" w="med" len="med"/>
+                      <a:tailEnd type="none" w="med" len="med"/>
+                    </a:lnT>
+                    <a:lnB w="12700" cap="flat" cmpd="sng" algn="ctr">
+                      <a:solidFill>
+                        <a:srgbClr val="D8DEEA"/>
+                      </a:solidFill>
+                      <a:prstDash val="solid"/>
+                      <a:round/>
+                      <a:headEnd type="none" w="med" len="med"/>
+                      <a:tailEnd type="none" w="med" len="med"/>
+                    </a:lnB>
+                    <a:solidFill>
+                      <a:srgbClr val="FFFFFF"/>
+                    </a:solidFill>
+                  </a:tcPr>
+                </a:tc>
+                <a:extLst>
+                  <a:ext uri="{0D108BD9-81ED-4DB2-BD59-A6C34878D82A}">
+                    <a16:rowId xmlns:a16="http://schemas.microsoft.com/office/drawing/2014/main" val="10004"/>
+                  </a:ext>
+                </a:extLst>
+              </a:tr>
+              <a:tr h="658368">
+                <a:tc>
+                  <a:txBody>
+                    <a:bodyPr/>
+                    <a:lstStyle/>
+                    <a:p>
+                      <a:pPr marL="0" indent="0" algn="l">
+                        <a:buNone/>
+                      </a:pPr>
+                      <a:r>
+                        <a:rPr lang="en-US" sz="1250" b="1" dirty="0">
+                          <a:solidFill>
+                            <a:srgbClr val="1E2761"/>
+                          </a:solidFill>
+                          <a:latin typeface="Calibri" pitchFamily="34" charset="0"/>
+                          <a:ea typeface="Calibri" pitchFamily="34" charset="-122"/>
+                          <a:cs typeface="Calibri" pitchFamily="34" charset="-120"/>
+                        </a:rPr>
+                        <a:t>Toolchain </a:t>
+                      </a:r>
+                      <a:r>
+                        <a:rPr lang="en-US" sz="1100" i="1" dirty="0">
+                          <a:solidFill>
+                            <a:srgbClr val="1E2761"/>
+                          </a:solidFill>
+                          <a:latin typeface="Calibri" pitchFamily="34" charset="0"/>
+                          <a:ea typeface="Calibri" pitchFamily="34" charset="-122"/>
+                          <a:cs typeface="Calibri" pitchFamily="34" charset="-120"/>
+                        </a:rPr>
+                        <a:t>(cross-cutting)</a:t>
+                      </a:r>
+                      <a:endParaRPr lang="en-US" sz="1250" dirty="0">
+                        <a:latin typeface="Calibri" charset="0"/>
+                        <a:ea typeface="Calibri" charset="0"/>
+                        <a:cs typeface="Calibri" charset="0"/>
+                      </a:endParaRPr>
+                    </a:p>
+                  </a:txBody>
+                  <a:tcPr marL="73152" marR="73152" marT="73152" marB="73152" anchor="ctr">
+                    <a:lnL w="12700" cap="flat" cmpd="sng" algn="ctr">
+                      <a:solidFill>
+                        <a:srgbClr val="D8DEEA"/>
+                      </a:solidFill>
+                      <a:prstDash val="solid"/>
+                      <a:round/>
+                      <a:headEnd type="none" w="med" len="med"/>
+                      <a:tailEnd type="none" w="med" len="med"/>
+                    </a:lnL>
+                    <a:lnR w="12700" cap="flat" cmpd="sng" algn="ctr">
+                      <a:solidFill>
+                        <a:srgbClr val="D8DEEA"/>
+                      </a:solidFill>
+                      <a:prstDash val="solid"/>
+                      <a:round/>
+                      <a:headEnd type="none" w="med" len="med"/>
+                      <a:tailEnd type="none" w="med" len="med"/>
+                    </a:lnR>
+                    <a:lnT w="12700" cap="flat" cmpd="sng" algn="ctr">
+                      <a:solidFill>
+                        <a:srgbClr val="D8DEEA"/>
+                      </a:solidFill>
+                      <a:prstDash val="solid"/>
+                      <a:round/>
+                      <a:headEnd type="none" w="med" len="med"/>
+                      <a:tailEnd type="none" w="med" len="med"/>
+                    </a:lnT>
+                    <a:lnB w="12700" cap="flat" cmpd="sng" algn="ctr">
+                      <a:solidFill>
+                        <a:srgbClr val="D8DEEA"/>
+                      </a:solidFill>
+                      <a:prstDash val="solid"/>
+                      <a:round/>
+                      <a:headEnd type="none" w="med" len="med"/>
+                      <a:tailEnd type="none" w="med" len="med"/>
+                    </a:lnB>
+                    <a:solidFill>
+                      <a:srgbClr val="FFFFFF"/>
+                    </a:solidFill>
+                  </a:tcPr>
+                </a:tc>
+                <a:tc>
+                  <a:txBody>
+                    <a:bodyPr/>
+                    <a:lstStyle/>
+                    <a:p>
+                      <a:pPr marL="0" indent="0" algn="l">
+                        <a:buNone/>
+                      </a:pPr>
+                      <a:r>
+                        <a:rPr lang="en-US" sz="1250" dirty="0">
+                          <a:solidFill>
+                            <a:srgbClr val="212121"/>
+                          </a:solidFill>
+                          <a:latin typeface="Calibri" pitchFamily="34" charset="0"/>
+                          <a:ea typeface="Calibri" pitchFamily="34" charset="-122"/>
+                          <a:cs typeface="Calibri" pitchFamily="34" charset="-120"/>
+                        </a:rPr>
+                        <a:t>hashed </a:t>
+                      </a:r>
+                      <a:r>
+                        <a:rPr lang="en-US" sz="1250" b="1" dirty="0">
+                          <a:solidFill>
+                            <a:srgbClr val="212121"/>
+                          </a:solidFill>
+                          <a:latin typeface="Calibri" pitchFamily="34" charset="0"/>
+                          <a:ea typeface="Calibri" pitchFamily="34" charset="-122"/>
+                          <a:cs typeface="Calibri" pitchFamily="34" charset="-120"/>
+                        </a:rPr>
+                        <a:t>measure-then-use</a:t>
+                      </a:r>
+                      <a:endParaRPr lang="en-US" sz="1250" dirty="0">
+                        <a:latin typeface="Calibri" charset="0"/>
+                        <a:ea typeface="Calibri" charset="0"/>
+                        <a:cs typeface="Calibri" charset="0"/>
+                      </a:endParaRPr>
+                    </a:p>
+                  </a:txBody>
+                  <a:tcPr marL="73152" marR="73152" marT="73152" marB="73152" anchor="ctr">
+                    <a:lnL w="12700" cap="flat" cmpd="sng" algn="ctr">
+                      <a:solidFill>
+                        <a:srgbClr val="D8DEEA"/>
+                      </a:solidFill>
+                      <a:prstDash val="solid"/>
+                      <a:round/>
+                      <a:headEnd type="none" w="med" len="med"/>
+                      <a:tailEnd type="none" w="med" len="med"/>
+                    </a:lnL>
+                    <a:lnR w="12700" cap="flat" cmpd="sng" algn="ctr">
+                      <a:solidFill>
+                        <a:srgbClr val="D8DEEA"/>
+                      </a:solidFill>
+                      <a:prstDash val="solid"/>
+                      <a:round/>
+                      <a:headEnd type="none" w="med" len="med"/>
+                      <a:tailEnd type="none" w="med" len="med"/>
+                    </a:lnR>
+                    <a:lnT w="12700" cap="flat" cmpd="sng" algn="ctr">
+                      <a:solidFill>
+                        <a:srgbClr val="D8DEEA"/>
+                      </a:solidFill>
+                      <a:prstDash val="solid"/>
+                      <a:round/>
+                      <a:headEnd type="none" w="med" len="med"/>
+                      <a:tailEnd type="none" w="med" len="med"/>
+                    </a:lnT>
+                    <a:lnB w="12700" cap="flat" cmpd="sng" algn="ctr">
+                      <a:solidFill>
+                        <a:srgbClr val="D8DEEA"/>
+                      </a:solidFill>
+                      <a:prstDash val="solid"/>
+                      <a:round/>
+                      <a:headEnd type="none" w="med" len="med"/>
+                      <a:tailEnd type="none" w="med" len="med"/>
+                    </a:lnB>
+                    <a:solidFill>
+                      <a:srgbClr val="FFFFFF"/>
+                    </a:solidFill>
+                  </a:tcPr>
+                </a:tc>
+                <a:tc>
+                  <a:txBody>
+                    <a:bodyPr/>
+                    <a:lstStyle/>
+                    <a:p>
+                      <a:pPr marL="0" indent="0" algn="l">
+                        <a:buNone/>
+                      </a:pPr>
+                      <a:r>
+                        <a:rPr lang="en-US" sz="1250" dirty="0">
+                          <a:solidFill>
+                            <a:srgbClr val="212121"/>
+                          </a:solidFill>
+                          <a:latin typeface="Calibri" pitchFamily="34" charset="0"/>
+                          <a:ea typeface="Calibri" pitchFamily="34" charset="-122"/>
+                          <a:cs typeface="Calibri" pitchFamily="34" charset="-120"/>
+                        </a:rPr>
+                        <a:t>the tool hash(es), taken in the same term</a:t>
+                      </a:r>
+                      <a:endParaRPr lang="en-US" sz="1250" dirty="0">
+                        <a:latin typeface="Calibri" charset="0"/>
+                        <a:ea typeface="Calibri" charset="0"/>
+                        <a:cs typeface="Calibri" charset="0"/>
+                      </a:endParaRPr>
+                    </a:p>
+                  </a:txBody>
+                  <a:tcPr marL="73152" marR="73152" marT="73152" marB="73152" anchor="ctr">
+                    <a:lnL w="12700" cap="flat" cmpd="sng" algn="ctr">
+                      <a:solidFill>
+                        <a:srgbClr val="D8DEEA"/>
+                      </a:solidFill>
+                      <a:prstDash val="solid"/>
+                      <a:round/>
+                      <a:headEnd type="none" w="med" len="med"/>
+                      <a:tailEnd type="none" w="med" len="med"/>
+                    </a:lnL>
+                    <a:lnR w="12700" cap="flat" cmpd="sng" algn="ctr">
+                      <a:solidFill>
+                        <a:srgbClr val="D8DEEA"/>
+                      </a:solidFill>
+                      <a:prstDash val="solid"/>
+                      <a:round/>
+                      <a:headEnd type="none" w="med" len="med"/>
+                      <a:tailEnd type="none" w="med" len="med"/>
+                    </a:lnR>
+                    <a:lnT w="12700" cap="flat" cmpd="sng" algn="ctr">
+                      <a:solidFill>
+                        <a:srgbClr val="D8DEEA"/>
+                      </a:solidFill>
+                      <a:prstDash val="solid"/>
+                      <a:round/>
+                      <a:headEnd type="none" w="med" len="med"/>
+                      <a:tailEnd type="none" w="med" len="med"/>
+                    </a:lnT>
+                    <a:lnB w="12700" cap="flat" cmpd="sng" algn="ctr">
+                      <a:solidFill>
+                        <a:srgbClr val="D8DEEA"/>
+                      </a:solidFill>
+                      <a:prstDash val="solid"/>
+                      <a:round/>
+                      <a:headEnd type="none" w="med" len="med"/>
+                      <a:tailEnd type="none" w="med" len="med"/>
+                    </a:lnB>
+                    <a:solidFill>
+                      <a:srgbClr val="FFFFFF"/>
+                    </a:solidFill>
+                  </a:tcPr>
+                </a:tc>
+                <a:tc>
+                  <a:txBody>
+                    <a:bodyPr/>
+                    <a:lstStyle/>
+                    <a:p>
+                      <a:pPr marL="0" indent="0" algn="l">
+                        <a:buNone/>
+                      </a:pPr>
+                      <a:r>
+                        <a:rPr lang="en-US" sz="1250" dirty="0">
+                          <a:solidFill>
+                            <a:srgbClr val="212121"/>
+                          </a:solidFill>
+                          <a:latin typeface="Calibri" pitchFamily="34" charset="0"/>
+                          <a:ea typeface="Calibri" pitchFamily="34" charset="-122"/>
+                          <a:cs typeface="Calibri" pitchFamily="34" charset="-120"/>
+                        </a:rPr>
+                        <a:t>out-of-band or pre-sanctioned restore</a:t>
+                      </a:r>
+                      <a:endParaRPr lang="en-US" sz="1250" dirty="0">
+                        <a:latin typeface="Calibri" charset="0"/>
+                        <a:ea typeface="Calibri" charset="0"/>
+                        <a:cs typeface="Calibri" charset="0"/>
+                      </a:endParaRPr>
+                    </a:p>
+                  </a:txBody>
+                  <a:tcPr marL="73152" marR="73152" marT="73152" marB="73152" anchor="ctr">
+                    <a:lnL w="12700" cap="flat" cmpd="sng" algn="ctr">
+                      <a:solidFill>
+                        <a:srgbClr val="D8DEEA"/>
+                      </a:solidFill>
+                      <a:prstDash val="solid"/>
+                      <a:round/>
+                      <a:headEnd type="none" w="med" len="med"/>
+                      <a:tailEnd type="none" w="med" len="med"/>
+                    </a:lnL>
+                    <a:lnR w="12700" cap="flat" cmpd="sng" algn="ctr">
+                      <a:solidFill>
+                        <a:srgbClr val="D8DEEA"/>
+                      </a:solidFill>
+                      <a:prstDash val="solid"/>
+                      <a:round/>
+                      <a:headEnd type="none" w="med" len="med"/>
+                      <a:tailEnd type="none" w="med" len="med"/>
+                    </a:lnR>
+                    <a:lnT w="12700" cap="flat" cmpd="sng" algn="ctr">
+                      <a:solidFill>
+                        <a:srgbClr val="D8DEEA"/>
+                      </a:solidFill>
+                      <a:prstDash val="solid"/>
+                      <a:round/>
+                      <a:headEnd type="none" w="med" len="med"/>
+                      <a:tailEnd type="none" w="med" len="med"/>
+                    </a:lnT>
+                    <a:lnB w="12700" cap="flat" cmpd="sng" algn="ctr">
+                      <a:solidFill>
+                        <a:srgbClr val="D8DEEA"/>
+                      </a:solidFill>
+                      <a:prstDash val="solid"/>
+                      <a:round/>
+                      <a:headEnd type="none" w="med" len="med"/>
+                      <a:tailEnd type="none" w="med" len="med"/>
+                    </a:lnB>
+                    <a:solidFill>
+                      <a:srgbClr val="FFFFFF"/>
+                    </a:solidFill>
+                  </a:tcPr>
+                </a:tc>
+                <a:extLst>
+                  <a:ext uri="{0D108BD9-81ED-4DB2-BD59-A6C34878D82A}">
+                    <a16:rowId xmlns:a16="http://schemas.microsoft.com/office/drawing/2014/main" val="10005"/>
+                  </a:ext>
+                </a:extLst>
+              </a:tr>
+              <a:tr h="658368">
+                <a:tc>
+                  <a:txBody>
+                    <a:bodyPr/>
+                    <a:lstStyle/>
+                    <a:p>
+                      <a:pPr marL="0" indent="0" algn="l">
+                        <a:buNone/>
+                      </a:pPr>
+                      <a:r>
+                        <a:rPr lang="en-US" sz="1250" b="1" dirty="0">
+                          <a:solidFill>
+                            <a:srgbClr val="1E2761"/>
+                          </a:solidFill>
+                          <a:latin typeface="Calibri" pitchFamily="34" charset="0"/>
+                          <a:ea typeface="Calibri" pitchFamily="34" charset="-122"/>
+                          <a:cs typeface="Calibri" pitchFamily="34" charset="-120"/>
+                        </a:rPr>
+                        <a:t>Trust state </a:t>
+                      </a:r>
+                      <a:r>
+                        <a:rPr lang="en-US" sz="1100" i="1" dirty="0">
+                          <a:solidFill>
+                            <a:srgbClr val="1E2761"/>
+                          </a:solidFill>
+                          <a:latin typeface="Calibri" pitchFamily="34" charset="0"/>
+                          <a:ea typeface="Calibri" pitchFamily="34" charset="-122"/>
+                          <a:cs typeface="Calibri" pitchFamily="34" charset="-120"/>
+                        </a:rPr>
+                        <a:t>(cross-cutting)</a:t>
+                      </a:r>
+                      <a:endParaRPr lang="en-US" sz="1250" dirty="0">
+                        <a:latin typeface="Calibri" charset="0"/>
+                        <a:ea typeface="Calibri" charset="0"/>
+                        <a:cs typeface="Calibri" charset="0"/>
+                      </a:endParaRPr>
+                    </a:p>
+                  </a:txBody>
+                  <a:tcPr marL="73152" marR="73152" marT="73152" marB="73152" anchor="ctr">
+                    <a:lnL w="12700" cap="flat" cmpd="sng" algn="ctr">
+                      <a:solidFill>
+                        <a:srgbClr val="D8DEEA"/>
+                      </a:solidFill>
+                      <a:prstDash val="solid"/>
+                      <a:round/>
+                      <a:headEnd type="none" w="med" len="med"/>
+                      <a:tailEnd type="none" w="med" len="med"/>
+                    </a:lnL>
+                    <a:lnR w="12700" cap="flat" cmpd="sng" algn="ctr">
+                      <a:solidFill>
+                        <a:srgbClr val="D8DEEA"/>
+                      </a:solidFill>
+                      <a:prstDash val="solid"/>
+                      <a:round/>
+                      <a:headEnd type="none" w="med" len="med"/>
+                      <a:tailEnd type="none" w="med" len="med"/>
+                    </a:lnR>
+                    <a:lnT w="12700" cap="flat" cmpd="sng" algn="ctr">
+                      <a:solidFill>
+                        <a:srgbClr val="D8DEEA"/>
+                      </a:solidFill>
+                      <a:prstDash val="solid"/>
+                      <a:round/>
+                      <a:headEnd type="none" w="med" len="med"/>
+                      <a:tailEnd type="none" w="med" len="med"/>
+                    </a:lnT>
+                    <a:lnB w="12700" cap="flat" cmpd="sng" algn="ctr">
+                      <a:solidFill>
+                        <a:srgbClr val="D8DEEA"/>
+                      </a:solidFill>
+                      <a:prstDash val="solid"/>
+                      <a:round/>
+                      <a:headEnd type="none" w="med" len="med"/>
+                      <a:tailEnd type="none" w="med" len="med"/>
+                    </a:lnB>
+                    <a:solidFill>
+                      <a:srgbClr val="FFFFFF"/>
+                    </a:solidFill>
+                  </a:tcPr>
+                </a:tc>
+                <a:tc>
+                  <a:txBody>
+                    <a:bodyPr/>
+                    <a:lstStyle/>
+                    <a:p>
+                      <a:pPr marL="0" indent="0" algn="l">
+                        <a:buNone/>
+                      </a:pPr>
+                      <a:r>
+                        <a:rPr lang="en-US" sz="1250" dirty="0">
+                          <a:solidFill>
+                            <a:srgbClr val="212121"/>
+                          </a:solidFill>
+                          <a:latin typeface="Calibri" pitchFamily="34" charset="0"/>
+                          <a:ea typeface="Calibri" pitchFamily="34" charset="-122"/>
+                          <a:cs typeface="Calibri" pitchFamily="34" charset="-120"/>
+                        </a:rPr>
+                        <a:t>bundles, goldens, signatures</a:t>
+                      </a:r>
+                      <a:endParaRPr lang="en-US" sz="1250" dirty="0">
+                        <a:latin typeface="Calibri" charset="0"/>
+                        <a:ea typeface="Calibri" charset="0"/>
+                        <a:cs typeface="Calibri" charset="0"/>
+                      </a:endParaRPr>
+                    </a:p>
+                  </a:txBody>
+                  <a:tcPr marL="73152" marR="73152" marT="73152" marB="73152" anchor="ctr">
+                    <a:lnL w="12700" cap="flat" cmpd="sng" algn="ctr">
+                      <a:solidFill>
+                        <a:srgbClr val="D8DEEA"/>
+                      </a:solidFill>
+                      <a:prstDash val="solid"/>
+                      <a:round/>
+                      <a:headEnd type="none" w="med" len="med"/>
+                      <a:tailEnd type="none" w="med" len="med"/>
+                    </a:lnL>
+                    <a:lnR w="12700" cap="flat" cmpd="sng" algn="ctr">
+                      <a:solidFill>
+                        <a:srgbClr val="D8DEEA"/>
+                      </a:solidFill>
+                      <a:prstDash val="solid"/>
+                      <a:round/>
+                      <a:headEnd type="none" w="med" len="med"/>
+                      <a:tailEnd type="none" w="med" len="med"/>
+                    </a:lnR>
+                    <a:lnT w="12700" cap="flat" cmpd="sng" algn="ctr">
+                      <a:solidFill>
+                        <a:srgbClr val="D8DEEA"/>
+                      </a:solidFill>
+                      <a:prstDash val="solid"/>
+                      <a:round/>
+                      <a:headEnd type="none" w="med" len="med"/>
+                      <a:tailEnd type="none" w="med" len="med"/>
+                    </a:lnT>
+                    <a:lnB w="12700" cap="flat" cmpd="sng" algn="ctr">
+                      <a:solidFill>
+                        <a:srgbClr val="D8DEEA"/>
+                      </a:solidFill>
+                      <a:prstDash val="solid"/>
+                      <a:round/>
+                      <a:headEnd type="none" w="med" len="med"/>
+                      <a:tailEnd type="none" w="med" len="med"/>
+                    </a:lnB>
+                    <a:solidFill>
+                      <a:srgbClr val="FFFFFF"/>
+                    </a:solidFill>
+                  </a:tcPr>
+                </a:tc>
+                <a:tc>
+                  <a:txBody>
+                    <a:bodyPr/>
+                    <a:lstStyle/>
+                    <a:p>
+                      <a:pPr marL="0" indent="0" algn="l">
+                        <a:buNone/>
+                      </a:pPr>
+                      <a:r>
+                        <a:rPr lang="en-US" sz="1250" dirty="0">
+                          <a:solidFill>
+                            <a:srgbClr val="212121"/>
+                          </a:solidFill>
+                          <a:latin typeface="Calibri" pitchFamily="34" charset="0"/>
+                          <a:ea typeface="Calibri" pitchFamily="34" charset="-122"/>
+                          <a:cs typeface="Calibri" pitchFamily="34" charset="-120"/>
+                        </a:rPr>
+                        <a:t>appraisal vs the signed golden or derived</a:t>
+                      </a:r>
+                      <a:endParaRPr lang="en-US" sz="1250" dirty="0">
+                        <a:latin typeface="Calibri" charset="0"/>
+                        <a:ea typeface="Calibri" charset="0"/>
+                        <a:cs typeface="Calibri" charset="0"/>
+                      </a:endParaRPr>
+                    </a:p>
+                  </a:txBody>
+                  <a:tcPr marL="73152" marR="73152" marT="73152" marB="73152" anchor="ctr">
+                    <a:lnL w="12700" cap="flat" cmpd="sng" algn="ctr">
+                      <a:solidFill>
+                        <a:srgbClr val="D8DEEA"/>
+                      </a:solidFill>
+                      <a:prstDash val="solid"/>
+                      <a:round/>
+                      <a:headEnd type="none" w="med" len="med"/>
+                      <a:tailEnd type="none" w="med" len="med"/>
+                    </a:lnL>
+                    <a:lnR w="12700" cap="flat" cmpd="sng" algn="ctr">
+                      <a:solidFill>
+                        <a:srgbClr val="D8DEEA"/>
+                      </a:solidFill>
+                      <a:prstDash val="solid"/>
+                      <a:round/>
+                      <a:headEnd type="none" w="med" len="med"/>
+                      <a:tailEnd type="none" w="med" len="med"/>
+                    </a:lnR>
+                    <a:lnT w="12700" cap="flat" cmpd="sng" algn="ctr">
+                      <a:solidFill>
+                        <a:srgbClr val="D8DEEA"/>
+                      </a:solidFill>
+                      <a:prstDash val="solid"/>
+                      <a:round/>
+                      <a:headEnd type="none" w="med" len="med"/>
+                      <a:tailEnd type="none" w="med" len="med"/>
+                    </a:lnT>
+                    <a:lnB w="12700" cap="flat" cmpd="sng" algn="ctr">
+                      <a:solidFill>
+                        <a:srgbClr val="D8DEEA"/>
+                      </a:solidFill>
+                      <a:prstDash val="solid"/>
+                      <a:round/>
+                      <a:headEnd type="none" w="med" len="med"/>
+                      <a:tailEnd type="none" w="med" len="med"/>
+                    </a:lnB>
+                    <a:solidFill>
+                      <a:srgbClr val="FFFFFF"/>
+                    </a:solidFill>
+                  </a:tcPr>
+                </a:tc>
+                <a:tc>
+                  <a:txBody>
+                    <a:bodyPr/>
+                    <a:lstStyle/>
+                    <a:p>
+                      <a:pPr marL="0" indent="0" algn="l">
+                        <a:buNone/>
+                      </a:pPr>
+                      <a:r>
+                        <a:rPr lang="en-US" sz="1250" b="1" dirty="0">
+                          <a:solidFill>
+                            <a:srgbClr val="212121"/>
+                          </a:solidFill>
+                          <a:latin typeface="Calibri" pitchFamily="34" charset="0"/>
+                          <a:ea typeface="Calibri" pitchFamily="34" charset="-122"/>
+                          <a:cs typeface="Calibri" pitchFamily="34" charset="-120"/>
+                        </a:rPr>
+                        <a:t>principled refusal</a:t>
+                      </a:r>
+                      <a:r>
+                        <a:rPr lang="en-US" sz="1250" dirty="0">
+                          <a:solidFill>
+                            <a:srgbClr val="212121"/>
+                          </a:solidFill>
+                          <a:latin typeface="Calibri" pitchFamily="34" charset="0"/>
+                          <a:ea typeface="Calibri" pitchFamily="34" charset="-122"/>
+                          <a:cs typeface="Calibri" pitchFamily="34" charset="-120"/>
+                        </a:rPr>
+                        <a:t> — out-of-band re-bless</a:t>
+                      </a:r>
+                      <a:endParaRPr lang="en-US" sz="1250" dirty="0">
+                        <a:latin typeface="Calibri" charset="0"/>
+                        <a:ea typeface="Calibri" charset="0"/>
+                        <a:cs typeface="Calibri" charset="0"/>
+                      </a:endParaRPr>
+                    </a:p>
+                  </a:txBody>
+                  <a:tcPr marL="73152" marR="73152" marT="73152" marB="73152" anchor="ctr">
+                    <a:lnL w="12700" cap="flat" cmpd="sng" algn="ctr">
+                      <a:solidFill>
+                        <a:srgbClr val="D8DEEA"/>
+                      </a:solidFill>
+                      <a:prstDash val="solid"/>
+                      <a:round/>
+                      <a:headEnd type="none" w="med" len="med"/>
+                      <a:tailEnd type="none" w="med" len="med"/>
+                    </a:lnL>
+                    <a:lnR w="12700" cap="flat" cmpd="sng" algn="ctr">
+                      <a:solidFill>
+                        <a:srgbClr val="D8DEEA"/>
+                      </a:solidFill>
+                      <a:prstDash val="solid"/>
+                      <a:round/>
+                      <a:headEnd type="none" w="med" len="med"/>
+                      <a:tailEnd type="none" w="med" len="med"/>
+                    </a:lnR>
+                    <a:lnT w="12700" cap="flat" cmpd="sng" algn="ctr">
+                      <a:solidFill>
+                        <a:srgbClr val="D8DEEA"/>
+                      </a:solidFill>
+                      <a:prstDash val="solid"/>
+                      <a:round/>
+                      <a:headEnd type="none" w="med" len="med"/>
+                      <a:tailEnd type="none" w="med" len="med"/>
+                    </a:lnT>
+                    <a:lnB w="12700" cap="flat" cmpd="sng" algn="ctr">
+                      <a:solidFill>
+                        <a:srgbClr val="D8DEEA"/>
+                      </a:solidFill>
+                      <a:prstDash val="solid"/>
+                      <a:round/>
+                      <a:headEnd type="none" w="med" len="med"/>
+                      <a:tailEnd type="none" w="med" len="med"/>
+                    </a:lnB>
+                    <a:solidFill>
+                      <a:srgbClr val="FFFFFF"/>
+                    </a:solidFill>
+                  </a:tcPr>
+                </a:tc>
+                <a:extLst>
+                  <a:ext uri="{0D108BD9-81ED-4DB2-BD59-A6C34878D82A}">
+                    <a16:rowId xmlns:a16="http://schemas.microsoft.com/office/drawing/2014/main" val="10006"/>
+                  </a:ext>
+                </a:extLst>
+              </a:tr>
+            </a:tbl>
+          </a:graphicData>
+        </a:graphic>
+      </p:graphicFrame>
     </p:spTree>
   </p:cSld>
   <p:clrMapOvr>

</xml_diff>

<commit_message>
isolette intro slide: high-level example intro + verified stat tiles
Deck position 8: compact roadmap strip (Demo active, the transition
template), system/provenance/pipeline/why beats with AR-08-32 cited
on-slide, five big-number callouts (13 files, 67 slices, 8 crates,
1,862 obligations - verified exact against live fixtures - and the 8
tier keys as the glossary bridge). Cheat-tier depth stats held back
for scene 9.

Co-Authored-By: Claude Fable 5 <noreply@anthropic.com>
</commit_message>
<xml_diff>
--- a/docs/video_slides_draft.pptx
+++ b/docs/video_slides_draft.pptx
@@ -5,7 +5,7 @@
     <p:sldMasterId id="2147483648" r:id="rId1"/>
   </p:sldMasterIdLst>
   <p:notesMasterIdLst>
-    <p:notesMasterId r:id="rId9"/>
+    <p:notesMasterId r:id="rId10"/>
   </p:notesMasterIdLst>
   <p:sldIdLst>
     <p:sldId id="256" r:id="rId2"/>
@@ -15,6 +15,7 @@
     <p:sldId id="260" r:id="rId6"/>
     <p:sldId id="261" r:id="rId7"/>
     <p:sldId id="262" r:id="rId8"/>
+    <p:sldId id="263" r:id="rId9"/>
   </p:sldIdLst>
   <p:sldSz cx="12192000" cy="6858000"/>
   <p:notesSz cx="6858000" cy="12192000"/>
@@ -143,7 +144,7 @@
     </p:spTree>
     <p:extLst>
       <p:ext uri="{BB962C8B-B14F-4D97-AF65-F5344CB8AC3E}">
-        <p14:creationId xmlns:p14="http://schemas.microsoft.com/office/powerpoint/2010/main" val="1495642631"/>
+        <p14:creationId xmlns:p14="http://schemas.microsoft.com/office/powerpoint/2010/main" val="1964892576"/>
       </p:ext>
     </p:extLst>
   </p:cSld>
@@ -850,6 +851,97 @@
             <a:fld id="{F7021451-1387-4CA6-816F-3879F97B5CBC}" type="slidenum">
               <a:rPr lang="en-US"/>
               <a:t>7</a:t>
+            </a:fld>
+            <a:endParaRPr lang="en-US"/>
+          </a:p>
+        </p:txBody>
+      </p:sp>
+    </p:spTree>
+    <p:extLst>
+      <p:ext uri="{BB962C8B-B14F-4D97-AF65-F5344CB8AC3E}">
+        <p14:creationId xmlns:p14="http://schemas.microsoft.com/office/powerpoint/2010/main" val="1024086991"/>
+      </p:ext>
+    </p:extLst>
+  </p:cSld>
+  <p:clrMapOvr>
+    <a:masterClrMapping/>
+  </p:clrMapOvr>
+</p:notes>
+</file>
+
+<file path=ppt/notesSlides/notesSlide8.xml><?xml version="1.0" encoding="utf-8"?>
+<p:notes xmlns:a="http://schemas.openxmlformats.org/drawingml/2006/main" xmlns:r="http://schemas.openxmlformats.org/officeDocument/2006/relationships" xmlns:p="http://schemas.openxmlformats.org/presentationml/2006/main">
+  <p:cSld>
+    <p:spTree>
+      <p:nvGrpSpPr>
+        <p:cNvPr id="1" name=""/>
+        <p:cNvGrpSpPr/>
+        <p:nvPr/>
+      </p:nvGrpSpPr>
+      <p:grpSpPr>
+        <a:xfrm>
+          <a:off x="0" y="0"/>
+          <a:ext cx="0" cy="0"/>
+          <a:chOff x="0" y="0"/>
+          <a:chExt cx="0" cy="0"/>
+        </a:xfrm>
+      </p:grpSpPr>
+      <p:sp>
+        <p:nvSpPr>
+          <p:cNvPr id="2" name="Slide Image Placeholder 1"/>
+          <p:cNvSpPr>
+            <a:spLocks noGrp="1" noRot="1" noChangeAspect="1"/>
+          </p:cNvSpPr>
+          <p:nvPr>
+            <p:ph type="sldImg"/>
+          </p:nvPr>
+        </p:nvSpPr>
+        <p:spPr/>
+      </p:sp>
+      <p:sp>
+        <p:nvSpPr>
+          <p:cNvPr id="3" name="Notes Placeholder 2"/>
+          <p:cNvSpPr>
+            <a:spLocks noGrp="1"/>
+          </p:cNvSpPr>
+          <p:nvPr>
+            <p:ph type="body" idx="1"/>
+          </p:nvPr>
+        </p:nvSpPr>
+        <p:spPr/>
+        <p:txBody>
+          <a:bodyPr/>
+          <a:lstStyle/>
+          <a:p>
+            <a:r>
+              <a:rPr lang="en-US" dirty="0"/>
+              <a:t>This slide IS the section transition into the demo (strip: Demo segment highlighted).
+The tiers callout is the bridge: these keys are the glossary's entry keys, and every checklist row in the scenes is one of them.
+Spoken line on the why-beat: 'the table you just saw, instantiated.'
+Held back on purpose (scene 9's reveal): cheat-tier depth stats - 86 blessed external_body sites, 10 scanned crates.
+Numbers verified exact 2026-08-25 (l1a targets, l2 slices, verus term, pub-proof-fn count); provision-dependent - re-verify before recording day.</a:t>
+            </a:r>
+          </a:p>
+        </p:txBody>
+      </p:sp>
+      <p:sp>
+        <p:nvSpPr>
+          <p:cNvPr id="4" name="Slide Number Placeholder 3"/>
+          <p:cNvSpPr>
+            <a:spLocks noGrp="1"/>
+          </p:cNvSpPr>
+          <p:nvPr>
+            <p:ph type="sldNum" sz="quarter" idx="10"/>
+          </p:nvPr>
+        </p:nvSpPr>
+        <p:spPr/>
+        <p:txBody>
+          <a:bodyPr/>
+          <a:lstStyle/>
+          <a:p>
+            <a:fld id="{F7021451-1387-4CA6-816F-3879F97B5CBC}" type="slidenum">
+              <a:rPr lang="en-US"/>
+              <a:t>8</a:t>
             </a:fld>
             <a:endParaRPr lang="en-US"/>
           </a:p>
@@ -5647,14 +5739,14 @@
           <p:nvPr>
             <p:extLst>
               <p:ext uri="{D42A27DB-BD31-4B8C-83A1-F6EECF244321}">
-                <p14:modId xmlns:p14="http://schemas.microsoft.com/office/powerpoint/2010/main" val="191026570"/>
+                <p14:modId xmlns:p14="http://schemas.microsoft.com/office/powerpoint/2010/main" val="1579011935"/>
               </p:ext>
             </p:extLst>
           </p:nvPr>
         </p:nvGraphicFramePr>
         <p:xfrm>
           <a:off x="640080" y="1417320"/>
-          <a:ext cx="10881360" cy="4608576"/>
+          <a:ext cx="10881360" cy="914400"/>
         </p:xfrm>
         <a:graphic>
           <a:graphicData uri="http://schemas.openxmlformats.org/drawingml/2006/table">
@@ -6700,7 +6792,7 @@
                             <a:srgbClr val="212121"/>
                           </a:solidFill>
                           <a:latin typeface="Calibri" pitchFamily="34" charset="0"/>
-                          <a:ea typeface="Calibri" charset="0"/>
+                          <a:ea typeface="Calibri" pitchFamily="34" charset="-122"/>
                           <a:cs typeface="Calibri" pitchFamily="34" charset="-120"/>
                         </a:rPr>
                         <a:t>tests + verification of contracts</a:t>
@@ -7713,6 +7805,1681 @@
           </a:graphicData>
         </a:graphic>
       </p:graphicFrame>
+    </p:spTree>
+  </p:cSld>
+  <p:clrMapOvr>
+    <a:masterClrMapping/>
+  </p:clrMapOvr>
+</p:sld>
+</file>
+
+<file path=ppt/slides/slide8.xml><?xml version="1.0" encoding="utf-8"?>
+<p:sld xmlns:a="http://schemas.openxmlformats.org/drawingml/2006/main" xmlns:r="http://schemas.openxmlformats.org/officeDocument/2006/relationships" xmlns:p="http://schemas.openxmlformats.org/presentationml/2006/main">
+  <p:cSld name="Slide 8">
+    <p:bg>
+      <p:bgPr>
+        <a:solidFill>
+          <a:srgbClr val="FFFFFF"/>
+        </a:solidFill>
+        <a:effectLst/>
+      </p:bgPr>
+    </p:bg>
+    <p:spTree>
+      <p:nvGrpSpPr>
+        <p:cNvPr id="1" name=""/>
+        <p:cNvGrpSpPr/>
+        <p:nvPr/>
+      </p:nvGrpSpPr>
+      <p:grpSpPr>
+        <a:xfrm>
+          <a:off x="0" y="0"/>
+          <a:ext cx="0" cy="0"/>
+          <a:chOff x="0" y="0"/>
+          <a:chExt cx="0" cy="0"/>
+        </a:xfrm>
+      </p:grpSpPr>
+      <p:sp>
+        <p:nvSpPr>
+          <p:cNvPr id="2" name="Shape 0"/>
+          <p:cNvSpPr/>
+          <p:nvPr/>
+        </p:nvSpPr>
+        <p:spPr>
+          <a:xfrm>
+            <a:off x="640080" y="201168"/>
+            <a:ext cx="2073859" cy="502920"/>
+          </a:xfrm>
+          <a:prstGeom prst="roundRect">
+            <a:avLst>
+              <a:gd name="adj" fmla="val 9091"/>
+            </a:avLst>
+          </a:prstGeom>
+          <a:solidFill>
+            <a:srgbClr val="E4EAF4"/>
+          </a:solidFill>
+          <a:ln/>
+        </p:spPr>
+        <p:txBody>
+          <a:bodyPr/>
+          <a:lstStyle/>
+          <a:p>
+            <a:endParaRPr lang="en-US"/>
+          </a:p>
+        </p:txBody>
+      </p:sp>
+      <p:sp>
+        <p:nvSpPr>
+          <p:cNvPr id="3" name="Text 1"/>
+          <p:cNvSpPr/>
+          <p:nvPr/>
+        </p:nvSpPr>
+        <p:spPr>
+          <a:xfrm>
+            <a:off x="640080" y="201168"/>
+            <a:ext cx="2073859" cy="502920"/>
+          </a:xfrm>
+          <a:prstGeom prst="rect">
+            <a:avLst/>
+          </a:prstGeom>
+          <a:noFill/>
+          <a:ln/>
+        </p:spPr>
+        <p:txBody>
+          <a:bodyPr wrap="square" lIns="254" tIns="254" rIns="254" bIns="254" rtlCol="0" anchor="ctr"/>
+          <a:lstStyle/>
+          <a:p>
+            <a:pPr marL="0" indent="0" algn="ctr">
+              <a:buNone/>
+            </a:pPr>
+            <a:r>
+              <a:rPr lang="en-US" sz="900" dirty="0">
+                <a:solidFill>
+                  <a:srgbClr val="5A6478"/>
+                </a:solidFill>
+                <a:latin typeface="Calibri" pitchFamily="34" charset="0"/>
+                <a:ea typeface="Calibri" pitchFamily="34" charset="-122"/>
+                <a:cs typeface="Calibri" pitchFamily="34" charset="-120"/>
+              </a:rPr>
+              <a:t>Preliminaries</a:t>
+            </a:r>
+            <a:endParaRPr lang="en-US" sz="900" dirty="0"/>
+          </a:p>
+        </p:txBody>
+      </p:sp>
+      <p:sp>
+        <p:nvSpPr>
+          <p:cNvPr id="4" name="Shape 2"/>
+          <p:cNvSpPr/>
+          <p:nvPr/>
+        </p:nvSpPr>
+        <p:spPr>
+          <a:xfrm>
+            <a:off x="2841955" y="201168"/>
+            <a:ext cx="2073859" cy="502920"/>
+          </a:xfrm>
+          <a:prstGeom prst="roundRect">
+            <a:avLst>
+              <a:gd name="adj" fmla="val 9091"/>
+            </a:avLst>
+          </a:prstGeom>
+          <a:solidFill>
+            <a:srgbClr val="1E2761"/>
+          </a:solidFill>
+          <a:ln/>
+        </p:spPr>
+        <p:txBody>
+          <a:bodyPr/>
+          <a:lstStyle/>
+          <a:p>
+            <a:endParaRPr lang="en-US"/>
+          </a:p>
+        </p:txBody>
+      </p:sp>
+      <p:sp>
+        <p:nvSpPr>
+          <p:cNvPr id="5" name="Text 3"/>
+          <p:cNvSpPr/>
+          <p:nvPr/>
+        </p:nvSpPr>
+        <p:spPr>
+          <a:xfrm>
+            <a:off x="2841955" y="201168"/>
+            <a:ext cx="2073859" cy="502920"/>
+          </a:xfrm>
+          <a:prstGeom prst="rect">
+            <a:avLst/>
+          </a:prstGeom>
+          <a:noFill/>
+          <a:ln/>
+        </p:spPr>
+        <p:txBody>
+          <a:bodyPr wrap="square" lIns="254" tIns="254" rIns="254" bIns="254" rtlCol="0" anchor="ctr"/>
+          <a:lstStyle/>
+          <a:p>
+            <a:pPr marL="0" indent="0" algn="ctr">
+              <a:buNone/>
+            </a:pPr>
+            <a:r>
+              <a:rPr lang="en-US" sz="900" b="1" dirty="0">
+                <a:solidFill>
+                  <a:srgbClr val="FFFFFF"/>
+                </a:solidFill>
+                <a:latin typeface="Calibri" pitchFamily="34" charset="0"/>
+                <a:ea typeface="Calibri" pitchFamily="34" charset="-122"/>
+                <a:cs typeface="Calibri" pitchFamily="34" charset="-120"/>
+              </a:rPr>
+              <a:t>Demo:</a:t>
+            </a:r>
+            <a:endParaRPr lang="en-US" sz="900" dirty="0"/>
+          </a:p>
+          <a:p>
+            <a:pPr marL="0" indent="0" algn="ctr">
+              <a:buNone/>
+            </a:pPr>
+            <a:r>
+              <a:rPr lang="en-US" sz="900" b="1" dirty="0">
+                <a:solidFill>
+                  <a:srgbClr val="FFFFFF"/>
+                </a:solidFill>
+                <a:latin typeface="Calibri" pitchFamily="34" charset="0"/>
+                <a:ea typeface="Calibri" pitchFamily="34" charset="-122"/>
+                <a:cs typeface="Calibri" pitchFamily="34" charset="-120"/>
+              </a:rPr>
+              <a:t>Isolette (SysMLv2 → Rust)</a:t>
+            </a:r>
+            <a:endParaRPr lang="en-US" sz="900" dirty="0"/>
+          </a:p>
+        </p:txBody>
+      </p:sp>
+      <p:sp>
+        <p:nvSpPr>
+          <p:cNvPr id="6" name="Shape 4"/>
+          <p:cNvSpPr/>
+          <p:nvPr/>
+        </p:nvSpPr>
+        <p:spPr>
+          <a:xfrm>
+            <a:off x="5043830" y="201168"/>
+            <a:ext cx="2073859" cy="502920"/>
+          </a:xfrm>
+          <a:prstGeom prst="roundRect">
+            <a:avLst>
+              <a:gd name="adj" fmla="val 9091"/>
+            </a:avLst>
+          </a:prstGeom>
+          <a:solidFill>
+            <a:srgbClr val="E4EAF4"/>
+          </a:solidFill>
+          <a:ln/>
+        </p:spPr>
+        <p:txBody>
+          <a:bodyPr/>
+          <a:lstStyle/>
+          <a:p>
+            <a:endParaRPr lang="en-US"/>
+          </a:p>
+        </p:txBody>
+      </p:sp>
+      <p:sp>
+        <p:nvSpPr>
+          <p:cNvPr id="7" name="Text 5"/>
+          <p:cNvSpPr/>
+          <p:nvPr/>
+        </p:nvSpPr>
+        <p:spPr>
+          <a:xfrm>
+            <a:off x="5043830" y="201168"/>
+            <a:ext cx="2073859" cy="502920"/>
+          </a:xfrm>
+          <a:prstGeom prst="rect">
+            <a:avLst/>
+          </a:prstGeom>
+          <a:noFill/>
+          <a:ln/>
+        </p:spPr>
+        <p:txBody>
+          <a:bodyPr wrap="square" lIns="254" tIns="254" rIns="254" bIns="254" rtlCol="0" anchor="ctr"/>
+          <a:lstStyle/>
+          <a:p>
+            <a:pPr marL="0" indent="0" algn="ctr">
+              <a:buNone/>
+            </a:pPr>
+            <a:r>
+              <a:rPr lang="en-US" sz="900" dirty="0">
+                <a:solidFill>
+                  <a:srgbClr val="5A6478"/>
+                </a:solidFill>
+                <a:latin typeface="Calibri" pitchFamily="34" charset="0"/>
+                <a:ea typeface="Calibri" pitchFamily="34" charset="-122"/>
+                <a:cs typeface="Calibri" pitchFamily="34" charset="-120"/>
+              </a:rPr>
+              <a:t>Other Ecosystems</a:t>
+            </a:r>
+            <a:endParaRPr lang="en-US" sz="900" dirty="0"/>
+          </a:p>
+        </p:txBody>
+      </p:sp>
+      <p:sp>
+        <p:nvSpPr>
+          <p:cNvPr id="8" name="Shape 6"/>
+          <p:cNvSpPr/>
+          <p:nvPr/>
+        </p:nvSpPr>
+        <p:spPr>
+          <a:xfrm>
+            <a:off x="7245706" y="201168"/>
+            <a:ext cx="2073859" cy="502920"/>
+          </a:xfrm>
+          <a:prstGeom prst="roundRect">
+            <a:avLst>
+              <a:gd name="adj" fmla="val 9091"/>
+            </a:avLst>
+          </a:prstGeom>
+          <a:solidFill>
+            <a:srgbClr val="E4EAF4"/>
+          </a:solidFill>
+          <a:ln/>
+        </p:spPr>
+        <p:txBody>
+          <a:bodyPr/>
+          <a:lstStyle/>
+          <a:p>
+            <a:endParaRPr lang="en-US"/>
+          </a:p>
+        </p:txBody>
+      </p:sp>
+      <p:sp>
+        <p:nvSpPr>
+          <p:cNvPr id="9" name="Text 7"/>
+          <p:cNvSpPr/>
+          <p:nvPr/>
+        </p:nvSpPr>
+        <p:spPr>
+          <a:xfrm>
+            <a:off x="7245706" y="201168"/>
+            <a:ext cx="2073859" cy="502920"/>
+          </a:xfrm>
+          <a:prstGeom prst="rect">
+            <a:avLst/>
+          </a:prstGeom>
+          <a:noFill/>
+          <a:ln/>
+        </p:spPr>
+        <p:txBody>
+          <a:bodyPr wrap="square" lIns="254" tIns="254" rIns="254" bIns="254" rtlCol="0" anchor="ctr"/>
+          <a:lstStyle/>
+          <a:p>
+            <a:pPr marL="0" indent="0" algn="ctr">
+              <a:buNone/>
+            </a:pPr>
+            <a:r>
+              <a:rPr lang="en-US" sz="900" dirty="0">
+                <a:solidFill>
+                  <a:srgbClr val="5A6478"/>
+                </a:solidFill>
+                <a:latin typeface="Calibri" pitchFamily="34" charset="0"/>
+                <a:ea typeface="Calibri" pitchFamily="34" charset="-122"/>
+                <a:cs typeface="Calibri" pitchFamily="34" charset="-120"/>
+              </a:rPr>
+              <a:t>AI in the Loop</a:t>
+            </a:r>
+            <a:endParaRPr lang="en-US" sz="900" dirty="0"/>
+          </a:p>
+        </p:txBody>
+      </p:sp>
+      <p:sp>
+        <p:nvSpPr>
+          <p:cNvPr id="10" name="Shape 8"/>
+          <p:cNvSpPr/>
+          <p:nvPr/>
+        </p:nvSpPr>
+        <p:spPr>
+          <a:xfrm>
+            <a:off x="9447581" y="201168"/>
+            <a:ext cx="2073859" cy="502920"/>
+          </a:xfrm>
+          <a:prstGeom prst="roundRect">
+            <a:avLst>
+              <a:gd name="adj" fmla="val 9091"/>
+            </a:avLst>
+          </a:prstGeom>
+          <a:solidFill>
+            <a:srgbClr val="E4EAF4"/>
+          </a:solidFill>
+          <a:ln/>
+        </p:spPr>
+        <p:txBody>
+          <a:bodyPr/>
+          <a:lstStyle/>
+          <a:p>
+            <a:endParaRPr lang="en-US"/>
+          </a:p>
+        </p:txBody>
+      </p:sp>
+      <p:sp>
+        <p:nvSpPr>
+          <p:cNvPr id="11" name="Text 9"/>
+          <p:cNvSpPr/>
+          <p:nvPr/>
+        </p:nvSpPr>
+        <p:spPr>
+          <a:xfrm>
+            <a:off x="9447581" y="201168"/>
+            <a:ext cx="2073859" cy="502920"/>
+          </a:xfrm>
+          <a:prstGeom prst="rect">
+            <a:avLst/>
+          </a:prstGeom>
+          <a:noFill/>
+          <a:ln/>
+        </p:spPr>
+        <p:txBody>
+          <a:bodyPr wrap="square" lIns="254" tIns="254" rIns="254" bIns="254" rtlCol="0" anchor="ctr"/>
+          <a:lstStyle/>
+          <a:p>
+            <a:pPr marL="0" indent="0" algn="ctr">
+              <a:buNone/>
+            </a:pPr>
+            <a:r>
+              <a:rPr lang="en-US" sz="900" dirty="0">
+                <a:solidFill>
+                  <a:srgbClr val="5A6478"/>
+                </a:solidFill>
+                <a:latin typeface="Calibri" pitchFamily="34" charset="0"/>
+                <a:ea typeface="Calibri" pitchFamily="34" charset="-122"/>
+                <a:cs typeface="Calibri" pitchFamily="34" charset="-120"/>
+              </a:rPr>
+              <a:t>Close</a:t>
+            </a:r>
+            <a:endParaRPr lang="en-US" sz="900" dirty="0"/>
+          </a:p>
+        </p:txBody>
+      </p:sp>
+      <p:sp>
+        <p:nvSpPr>
+          <p:cNvPr id="12" name="Text 10"/>
+          <p:cNvSpPr/>
+          <p:nvPr/>
+        </p:nvSpPr>
+        <p:spPr>
+          <a:xfrm>
+            <a:off x="640080" y="952760"/>
+            <a:ext cx="7315200" cy="640080"/>
+          </a:xfrm>
+          <a:prstGeom prst="rect">
+            <a:avLst/>
+          </a:prstGeom>
+          <a:noFill/>
+          <a:ln/>
+        </p:spPr>
+        <p:txBody>
+          <a:bodyPr wrap="square" lIns="0" tIns="0" rIns="0" bIns="0" rtlCol="0" anchor="ctr"/>
+          <a:lstStyle/>
+          <a:p>
+            <a:pPr marL="0" indent="0">
+              <a:buNone/>
+            </a:pPr>
+            <a:r>
+              <a:rPr lang="en-US" sz="3400" b="1" dirty="0">
+                <a:solidFill>
+                  <a:srgbClr val="1E2761"/>
+                </a:solidFill>
+                <a:latin typeface="Cambria" pitchFamily="34" charset="0"/>
+                <a:ea typeface="Cambria" pitchFamily="34" charset="-122"/>
+                <a:cs typeface="Cambria" pitchFamily="34" charset="-120"/>
+              </a:rPr>
+              <a:t>The isolette</a:t>
+            </a:r>
+            <a:endParaRPr lang="en-US" sz="3400" dirty="0"/>
+          </a:p>
+        </p:txBody>
+      </p:sp>
+      <p:sp>
+        <p:nvSpPr>
+          <p:cNvPr id="13" name="Text 11"/>
+          <p:cNvSpPr/>
+          <p:nvPr/>
+        </p:nvSpPr>
+        <p:spPr>
+          <a:xfrm>
+            <a:off x="640080" y="1730000"/>
+            <a:ext cx="6035040" cy="2286000"/>
+          </a:xfrm>
+          <a:prstGeom prst="rect">
+            <a:avLst/>
+          </a:prstGeom>
+          <a:noFill/>
+          <a:ln/>
+        </p:spPr>
+        <p:txBody>
+          <a:bodyPr wrap="square" lIns="0" tIns="0" rIns="0" bIns="0" rtlCol="0" anchor="t"/>
+          <a:lstStyle/>
+          <a:p>
+            <a:pPr marL="342900" indent="-342900" algn="l">
+              <a:buSzPct val="100000"/>
+              <a:buChar char="•"/>
+            </a:pPr>
+            <a:r>
+              <a:rPr lang="en-US" sz="1350" b="1" dirty="0">
+                <a:solidFill>
+                  <a:srgbClr val="212121"/>
+                </a:solidFill>
+                <a:latin typeface="Calibri" pitchFamily="34" charset="0"/>
+                <a:ea typeface="Calibri" pitchFamily="34" charset="-122"/>
+                <a:cs typeface="Calibri" pitchFamily="34" charset="-120"/>
+              </a:rPr>
+              <a:t>The system: </a:t>
+            </a:r>
+            <a:r>
+              <a:rPr lang="en-US" sz="1350" dirty="0">
+                <a:solidFill>
+                  <a:srgbClr val="212121"/>
+                </a:solidFill>
+                <a:latin typeface="Calibri" pitchFamily="34" charset="0"/>
+                <a:ea typeface="Calibri" pitchFamily="34" charset="-122"/>
+                <a:cs typeface="Calibri" pitchFamily="34" charset="-120"/>
+              </a:rPr>
+              <a:t>an infant-incubator thermostat — regulate and monitor functions keep a newborn's environment in a safe temperature range; heat control on/off</a:t>
+            </a:r>
+            <a:endParaRPr lang="en-US" sz="1350" dirty="0"/>
+          </a:p>
+          <a:p>
+            <a:pPr marL="0" indent="0" algn="l">
+              <a:spcAft>
+                <a:spcPts val="1000"/>
+              </a:spcAft>
+              <a:buNone/>
+            </a:pPr>
+            <a:r>
+              <a:rPr lang="en-US" sz="1100" i="1" dirty="0">
+                <a:solidFill>
+                  <a:srgbClr val="5A6478"/>
+                </a:solidFill>
+                <a:latin typeface="Calibri" pitchFamily="34" charset="0"/>
+                <a:ea typeface="Calibri" pitchFamily="34" charset="-122"/>
+                <a:cs typeface="Calibri" pitchFamily="34" charset="-120"/>
+              </a:rPr>
+              <a:t>requirements traceable to FAA AR-08-32 (the REQ-MHS-* family the scenes will tamper with)</a:t>
+            </a:r>
+            <a:endParaRPr lang="en-US" sz="1350" dirty="0"/>
+          </a:p>
+          <a:p>
+            <a:pPr marL="342900" indent="-342900" algn="l">
+              <a:buSzPct val="100000"/>
+              <a:buChar char="•"/>
+            </a:pPr>
+            <a:r>
+              <a:rPr lang="en-US" sz="1350" b="1" dirty="0">
+                <a:solidFill>
+                  <a:srgbClr val="212121"/>
+                </a:solidFill>
+                <a:latin typeface="Calibri" pitchFamily="34" charset="0"/>
+                <a:ea typeface="Calibri" pitchFamily="34" charset="-122"/>
+                <a:cs typeface="Calibri" pitchFamily="34" charset="-120"/>
+              </a:rPr>
+              <a:t>The relevance: </a:t>
+            </a:r>
+            <a:r>
+              <a:rPr lang="en-US" sz="1350" dirty="0">
+                <a:solidFill>
+                  <a:srgbClr val="212121"/>
+                </a:solidFill>
+                <a:latin typeface="Calibri" pitchFamily="34" charset="0"/>
+                <a:ea typeface="Calibri" pitchFamily="34" charset="-122"/>
+                <a:cs typeface="Calibri" pitchFamily="34" charset="-120"/>
+              </a:rPr>
+              <a:t>the INSPECTA program's seL4/</a:t>
+            </a:r>
+            <a:r>
+              <a:rPr lang="en-US" sz="1350" dirty="0" err="1">
+                <a:solidFill>
+                  <a:srgbClr val="212121"/>
+                </a:solidFill>
+                <a:latin typeface="Calibri" pitchFamily="34" charset="0"/>
+                <a:ea typeface="Calibri" pitchFamily="34" charset="-122"/>
+                <a:cs typeface="Calibri" pitchFamily="34" charset="-120"/>
+              </a:rPr>
+              <a:t>Microkit</a:t>
+            </a:r>
+            <a:r>
+              <a:rPr lang="en-US" sz="1350" dirty="0">
+                <a:solidFill>
+                  <a:srgbClr val="212121"/>
+                </a:solidFill>
+                <a:latin typeface="Calibri" pitchFamily="34" charset="0"/>
+                <a:ea typeface="Calibri" pitchFamily="34" charset="-122"/>
+                <a:cs typeface="Calibri" pitchFamily="34" charset="-120"/>
+              </a:rPr>
+              <a:t> target — a real, current, safety-critical development artifact, not a toy example</a:t>
+            </a:r>
+            <a:endParaRPr lang="en-US" sz="1350" dirty="0"/>
+          </a:p>
+        </p:txBody>
+      </p:sp>
+      <p:sp>
+        <p:nvSpPr>
+          <p:cNvPr id="14" name="Shape 12"/>
+          <p:cNvSpPr/>
+          <p:nvPr/>
+        </p:nvSpPr>
+        <p:spPr>
+          <a:xfrm>
+            <a:off x="640080" y="3977640"/>
+            <a:ext cx="1275588" cy="777240"/>
+          </a:xfrm>
+          <a:prstGeom prst="roundRect">
+            <a:avLst>
+              <a:gd name="adj" fmla="val 7059"/>
+            </a:avLst>
+          </a:prstGeom>
+          <a:solidFill>
+            <a:srgbClr val="3A4A8C"/>
+          </a:solidFill>
+          <a:ln/>
+        </p:spPr>
+        <p:txBody>
+          <a:bodyPr/>
+          <a:lstStyle/>
+          <a:p>
+            <a:endParaRPr lang="en-US"/>
+          </a:p>
+        </p:txBody>
+      </p:sp>
+      <p:sp>
+        <p:nvSpPr>
+          <p:cNvPr id="15" name="Text 13"/>
+          <p:cNvSpPr/>
+          <p:nvPr/>
+        </p:nvSpPr>
+        <p:spPr>
+          <a:xfrm>
+            <a:off x="640080" y="3977640"/>
+            <a:ext cx="1275588" cy="777240"/>
+          </a:xfrm>
+          <a:prstGeom prst="rect">
+            <a:avLst/>
+          </a:prstGeom>
+          <a:noFill/>
+          <a:ln/>
+        </p:spPr>
+        <p:txBody>
+          <a:bodyPr wrap="square" lIns="254" tIns="254" rIns="254" bIns="254" rtlCol="0" anchor="ctr"/>
+          <a:lstStyle/>
+          <a:p>
+            <a:pPr marL="0" indent="0" algn="ctr">
+              <a:buNone/>
+            </a:pPr>
+            <a:r>
+              <a:rPr lang="en-US" sz="1050" b="1" dirty="0">
+                <a:solidFill>
+                  <a:srgbClr val="FFFFFF"/>
+                </a:solidFill>
+                <a:latin typeface="Calibri" pitchFamily="34" charset="0"/>
+                <a:ea typeface="Calibri" pitchFamily="34" charset="-122"/>
+                <a:cs typeface="Calibri" pitchFamily="34" charset="-120"/>
+              </a:rPr>
+              <a:t>SysMLv2 model</a:t>
+            </a:r>
+            <a:endParaRPr lang="en-US" sz="1050" dirty="0"/>
+          </a:p>
+          <a:p>
+            <a:pPr marL="0" indent="0" algn="ctr">
+              <a:buNone/>
+            </a:pPr>
+            <a:r>
+              <a:rPr lang="en-US" sz="1050" b="1" dirty="0">
+                <a:solidFill>
+                  <a:srgbClr val="FFFFFF"/>
+                </a:solidFill>
+                <a:latin typeface="Calibri" pitchFamily="34" charset="0"/>
+                <a:ea typeface="Calibri" pitchFamily="34" charset="-122"/>
+                <a:cs typeface="Calibri" pitchFamily="34" charset="-120"/>
+              </a:rPr>
+              <a:t>+ GUMBO contracts</a:t>
+            </a:r>
+            <a:endParaRPr lang="en-US" sz="1050" dirty="0"/>
+          </a:p>
+        </p:txBody>
+      </p:sp>
+      <p:sp>
+        <p:nvSpPr>
+          <p:cNvPr id="16" name="Text 14"/>
+          <p:cNvSpPr/>
+          <p:nvPr/>
+        </p:nvSpPr>
+        <p:spPr>
+          <a:xfrm>
+            <a:off x="1879092" y="3977640"/>
+            <a:ext cx="384048" cy="777240"/>
+          </a:xfrm>
+          <a:prstGeom prst="rect">
+            <a:avLst/>
+          </a:prstGeom>
+          <a:noFill/>
+          <a:ln/>
+        </p:spPr>
+        <p:txBody>
+          <a:bodyPr wrap="square" lIns="0" tIns="0" rIns="0" bIns="0" rtlCol="0" anchor="ctr"/>
+          <a:lstStyle/>
+          <a:p>
+            <a:pPr marL="0" indent="0" algn="ctr">
+              <a:buNone/>
+            </a:pPr>
+            <a:r>
+              <a:rPr lang="en-US" sz="1300" dirty="0">
+                <a:solidFill>
+                  <a:srgbClr val="5A6478"/>
+                </a:solidFill>
+                <a:latin typeface="Calibri" pitchFamily="34" charset="0"/>
+                <a:ea typeface="Calibri" pitchFamily="34" charset="-122"/>
+                <a:cs typeface="Calibri" pitchFamily="34" charset="-120"/>
+              </a:rPr>
+              <a:t>→</a:t>
+            </a:r>
+            <a:endParaRPr lang="en-US" sz="1300" dirty="0"/>
+          </a:p>
+        </p:txBody>
+      </p:sp>
+      <p:sp>
+        <p:nvSpPr>
+          <p:cNvPr id="17" name="Shape 15"/>
+          <p:cNvSpPr/>
+          <p:nvPr/>
+        </p:nvSpPr>
+        <p:spPr>
+          <a:xfrm>
+            <a:off x="2226564" y="3977640"/>
+            <a:ext cx="1275588" cy="777240"/>
+          </a:xfrm>
+          <a:prstGeom prst="roundRect">
+            <a:avLst>
+              <a:gd name="adj" fmla="val 7059"/>
+            </a:avLst>
+          </a:prstGeom>
+          <a:solidFill>
+            <a:srgbClr val="3A4A8C"/>
+          </a:solidFill>
+          <a:ln/>
+        </p:spPr>
+        <p:txBody>
+          <a:bodyPr/>
+          <a:lstStyle/>
+          <a:p>
+            <a:endParaRPr lang="en-US"/>
+          </a:p>
+        </p:txBody>
+      </p:sp>
+      <p:sp>
+        <p:nvSpPr>
+          <p:cNvPr id="18" name="Text 16"/>
+          <p:cNvSpPr/>
+          <p:nvPr/>
+        </p:nvSpPr>
+        <p:spPr>
+          <a:xfrm>
+            <a:off x="2226564" y="3977640"/>
+            <a:ext cx="1275588" cy="777240"/>
+          </a:xfrm>
+          <a:prstGeom prst="rect">
+            <a:avLst/>
+          </a:prstGeom>
+          <a:noFill/>
+          <a:ln/>
+        </p:spPr>
+        <p:txBody>
+          <a:bodyPr wrap="square" lIns="254" tIns="254" rIns="254" bIns="254" rtlCol="0" anchor="ctr"/>
+          <a:lstStyle/>
+          <a:p>
+            <a:pPr marL="0" indent="0" algn="ctr">
+              <a:buNone/>
+            </a:pPr>
+            <a:r>
+              <a:rPr lang="en-US" sz="1050" b="1" dirty="0">
+                <a:solidFill>
+                  <a:srgbClr val="FFFFFF"/>
+                </a:solidFill>
+                <a:latin typeface="Calibri" pitchFamily="34" charset="0"/>
+                <a:ea typeface="Calibri" pitchFamily="34" charset="-122"/>
+                <a:cs typeface="Calibri" pitchFamily="34" charset="-120"/>
+              </a:rPr>
+              <a:t>HAMR</a:t>
+            </a:r>
+            <a:endParaRPr lang="en-US" sz="1050" dirty="0"/>
+          </a:p>
+          <a:p>
+            <a:pPr marL="0" indent="0" algn="ctr">
+              <a:buNone/>
+            </a:pPr>
+            <a:r>
+              <a:rPr lang="en-US" sz="1050" b="1" dirty="0">
+                <a:solidFill>
+                  <a:srgbClr val="FFFFFF"/>
+                </a:solidFill>
+                <a:latin typeface="Calibri" pitchFamily="34" charset="0"/>
+                <a:ea typeface="Calibri" pitchFamily="34" charset="-122"/>
+                <a:cs typeface="Calibri" pitchFamily="34" charset="-120"/>
+              </a:rPr>
+              <a:t>codegen</a:t>
+            </a:r>
+            <a:endParaRPr lang="en-US" sz="1050" dirty="0"/>
+          </a:p>
+        </p:txBody>
+      </p:sp>
+      <p:sp>
+        <p:nvSpPr>
+          <p:cNvPr id="19" name="Text 17"/>
+          <p:cNvSpPr/>
+          <p:nvPr/>
+        </p:nvSpPr>
+        <p:spPr>
+          <a:xfrm>
+            <a:off x="3465576" y="3977640"/>
+            <a:ext cx="384048" cy="777240"/>
+          </a:xfrm>
+          <a:prstGeom prst="rect">
+            <a:avLst/>
+          </a:prstGeom>
+          <a:noFill/>
+          <a:ln/>
+        </p:spPr>
+        <p:txBody>
+          <a:bodyPr wrap="square" lIns="0" tIns="0" rIns="0" bIns="0" rtlCol="0" anchor="ctr"/>
+          <a:lstStyle/>
+          <a:p>
+            <a:pPr marL="0" indent="0" algn="ctr">
+              <a:buNone/>
+            </a:pPr>
+            <a:r>
+              <a:rPr lang="en-US" sz="1300" dirty="0">
+                <a:solidFill>
+                  <a:srgbClr val="5A6478"/>
+                </a:solidFill>
+                <a:latin typeface="Calibri" pitchFamily="34" charset="0"/>
+                <a:ea typeface="Calibri" pitchFamily="34" charset="-122"/>
+                <a:cs typeface="Calibri" pitchFamily="34" charset="-120"/>
+              </a:rPr>
+              <a:t>→</a:t>
+            </a:r>
+            <a:endParaRPr lang="en-US" sz="1300" dirty="0"/>
+          </a:p>
+        </p:txBody>
+      </p:sp>
+      <p:sp>
+        <p:nvSpPr>
+          <p:cNvPr id="20" name="Shape 18"/>
+          <p:cNvSpPr/>
+          <p:nvPr/>
+        </p:nvSpPr>
+        <p:spPr>
+          <a:xfrm>
+            <a:off x="3813048" y="3977640"/>
+            <a:ext cx="1275588" cy="777240"/>
+          </a:xfrm>
+          <a:prstGeom prst="roundRect">
+            <a:avLst>
+              <a:gd name="adj" fmla="val 7059"/>
+            </a:avLst>
+          </a:prstGeom>
+          <a:solidFill>
+            <a:srgbClr val="3A4A8C"/>
+          </a:solidFill>
+          <a:ln/>
+        </p:spPr>
+        <p:txBody>
+          <a:bodyPr/>
+          <a:lstStyle/>
+          <a:p>
+            <a:endParaRPr lang="en-US"/>
+          </a:p>
+        </p:txBody>
+      </p:sp>
+      <p:sp>
+        <p:nvSpPr>
+          <p:cNvPr id="21" name="Text 19"/>
+          <p:cNvSpPr/>
+          <p:nvPr/>
+        </p:nvSpPr>
+        <p:spPr>
+          <a:xfrm>
+            <a:off x="3813048" y="3977640"/>
+            <a:ext cx="1275588" cy="777240"/>
+          </a:xfrm>
+          <a:prstGeom prst="rect">
+            <a:avLst/>
+          </a:prstGeom>
+          <a:noFill/>
+          <a:ln/>
+        </p:spPr>
+        <p:txBody>
+          <a:bodyPr wrap="square" lIns="254" tIns="254" rIns="254" bIns="254" rtlCol="0" anchor="ctr"/>
+          <a:lstStyle/>
+          <a:p>
+            <a:pPr marL="0" indent="0" algn="ctr">
+              <a:buNone/>
+            </a:pPr>
+            <a:r>
+              <a:rPr lang="en-US" sz="1050" b="1" dirty="0">
+                <a:solidFill>
+                  <a:srgbClr val="FFFFFF"/>
+                </a:solidFill>
+                <a:latin typeface="Calibri" pitchFamily="34" charset="0"/>
+                <a:ea typeface="Calibri" pitchFamily="34" charset="-122"/>
+                <a:cs typeface="Calibri" pitchFamily="34" charset="-120"/>
+              </a:rPr>
+              <a:t>Verus-verified</a:t>
+            </a:r>
+            <a:endParaRPr lang="en-US" sz="1050" dirty="0"/>
+          </a:p>
+          <a:p>
+            <a:pPr marL="0" indent="0" algn="ctr">
+              <a:buNone/>
+            </a:pPr>
+            <a:r>
+              <a:rPr lang="en-US" sz="1050" b="1" dirty="0">
+                <a:solidFill>
+                  <a:srgbClr val="FFFFFF"/>
+                </a:solidFill>
+                <a:latin typeface="Calibri" pitchFamily="34" charset="0"/>
+                <a:ea typeface="Calibri" pitchFamily="34" charset="-122"/>
+                <a:cs typeface="Calibri" pitchFamily="34" charset="-120"/>
+              </a:rPr>
+              <a:t>Rust</a:t>
+            </a:r>
+            <a:endParaRPr lang="en-US" sz="1050" dirty="0"/>
+          </a:p>
+        </p:txBody>
+      </p:sp>
+      <p:sp>
+        <p:nvSpPr>
+          <p:cNvPr id="22" name="Text 20"/>
+          <p:cNvSpPr/>
+          <p:nvPr/>
+        </p:nvSpPr>
+        <p:spPr>
+          <a:xfrm>
+            <a:off x="5052060" y="3977640"/>
+            <a:ext cx="384048" cy="777240"/>
+          </a:xfrm>
+          <a:prstGeom prst="rect">
+            <a:avLst/>
+          </a:prstGeom>
+          <a:noFill/>
+          <a:ln/>
+        </p:spPr>
+        <p:txBody>
+          <a:bodyPr wrap="square" lIns="0" tIns="0" rIns="0" bIns="0" rtlCol="0" anchor="ctr"/>
+          <a:lstStyle/>
+          <a:p>
+            <a:pPr marL="0" indent="0" algn="ctr">
+              <a:buNone/>
+            </a:pPr>
+            <a:r>
+              <a:rPr lang="en-US" sz="1300" dirty="0">
+                <a:solidFill>
+                  <a:srgbClr val="5A6478"/>
+                </a:solidFill>
+                <a:latin typeface="Calibri" pitchFamily="34" charset="0"/>
+                <a:ea typeface="Calibri" pitchFamily="34" charset="-122"/>
+                <a:cs typeface="Calibri" pitchFamily="34" charset="-120"/>
+              </a:rPr>
+              <a:t>→</a:t>
+            </a:r>
+            <a:endParaRPr lang="en-US" sz="1300" dirty="0"/>
+          </a:p>
+        </p:txBody>
+      </p:sp>
+      <p:sp>
+        <p:nvSpPr>
+          <p:cNvPr id="23" name="Shape 21"/>
+          <p:cNvSpPr/>
+          <p:nvPr/>
+        </p:nvSpPr>
+        <p:spPr>
+          <a:xfrm>
+            <a:off x="5399532" y="3977640"/>
+            <a:ext cx="1275588" cy="777240"/>
+          </a:xfrm>
+          <a:prstGeom prst="roundRect">
+            <a:avLst>
+              <a:gd name="adj" fmla="val 7059"/>
+            </a:avLst>
+          </a:prstGeom>
+          <a:solidFill>
+            <a:srgbClr val="3A4A8C"/>
+          </a:solidFill>
+          <a:ln/>
+        </p:spPr>
+        <p:txBody>
+          <a:bodyPr/>
+          <a:lstStyle/>
+          <a:p>
+            <a:endParaRPr lang="en-US"/>
+          </a:p>
+        </p:txBody>
+      </p:sp>
+      <p:sp>
+        <p:nvSpPr>
+          <p:cNvPr id="24" name="Text 22"/>
+          <p:cNvSpPr/>
+          <p:nvPr/>
+        </p:nvSpPr>
+        <p:spPr>
+          <a:xfrm>
+            <a:off x="5399532" y="3977640"/>
+            <a:ext cx="1275588" cy="777240"/>
+          </a:xfrm>
+          <a:prstGeom prst="rect">
+            <a:avLst/>
+          </a:prstGeom>
+          <a:noFill/>
+          <a:ln/>
+        </p:spPr>
+        <p:txBody>
+          <a:bodyPr wrap="square" lIns="254" tIns="254" rIns="254" bIns="254" rtlCol="0" anchor="ctr"/>
+          <a:lstStyle/>
+          <a:p>
+            <a:pPr marL="0" indent="0" algn="ctr">
+              <a:buNone/>
+            </a:pPr>
+            <a:r>
+              <a:rPr lang="en-US" sz="1050" b="1" dirty="0">
+                <a:solidFill>
+                  <a:srgbClr val="FFFFFF"/>
+                </a:solidFill>
+                <a:latin typeface="Calibri" pitchFamily="34" charset="0"/>
+                <a:ea typeface="Calibri" pitchFamily="34" charset="-122"/>
+                <a:cs typeface="Calibri" pitchFamily="34" charset="-120"/>
+              </a:rPr>
+              <a:t>seL4 / Microkit</a:t>
+            </a:r>
+            <a:endParaRPr lang="en-US" sz="1050" dirty="0"/>
+          </a:p>
+          <a:p>
+            <a:pPr marL="0" indent="0" algn="ctr">
+              <a:buNone/>
+            </a:pPr>
+            <a:r>
+              <a:rPr lang="en-US" sz="1050" b="1" dirty="0">
+                <a:solidFill>
+                  <a:srgbClr val="FFFFFF"/>
+                </a:solidFill>
+                <a:latin typeface="Calibri" pitchFamily="34" charset="0"/>
+                <a:ea typeface="Calibri" pitchFamily="34" charset="-122"/>
+                <a:cs typeface="Calibri" pitchFamily="34" charset="-120"/>
+              </a:rPr>
+              <a:t>target</a:t>
+            </a:r>
+            <a:endParaRPr lang="en-US" sz="1050" dirty="0"/>
+          </a:p>
+        </p:txBody>
+      </p:sp>
+      <p:sp>
+        <p:nvSpPr>
+          <p:cNvPr id="25" name="Text 23"/>
+          <p:cNvSpPr/>
+          <p:nvPr/>
+        </p:nvSpPr>
+        <p:spPr>
+          <a:xfrm>
+            <a:off x="640080" y="5029200"/>
+            <a:ext cx="6035040" cy="1371600"/>
+          </a:xfrm>
+          <a:prstGeom prst="rect">
+            <a:avLst/>
+          </a:prstGeom>
+          <a:noFill/>
+          <a:ln/>
+        </p:spPr>
+        <p:txBody>
+          <a:bodyPr wrap="square" lIns="0" tIns="0" rIns="0" bIns="0" rtlCol="0" anchor="t"/>
+          <a:lstStyle/>
+          <a:p>
+            <a:pPr marL="342900" indent="-342900" algn="l">
+              <a:buSzPct val="100000"/>
+              <a:buChar char="•"/>
+            </a:pPr>
+            <a:r>
+              <a:rPr lang="en-US" sz="1350" b="1" dirty="0">
+                <a:solidFill>
+                  <a:srgbClr val="212121"/>
+                </a:solidFill>
+                <a:latin typeface="Calibri" pitchFamily="34" charset="0"/>
+                <a:ea typeface="Calibri" pitchFamily="34" charset="-122"/>
+                <a:cs typeface="Calibri" pitchFamily="34" charset="-120"/>
+              </a:rPr>
+              <a:t>Why this example: </a:t>
+            </a:r>
+            <a:r>
+              <a:rPr lang="en-US" sz="1350" dirty="0">
+                <a:solidFill>
+                  <a:srgbClr val="212121"/>
+                </a:solidFill>
+                <a:latin typeface="Calibri" pitchFamily="34" charset="0"/>
+                <a:ea typeface="Calibri" pitchFamily="34" charset="-122"/>
+                <a:cs typeface="Calibri" pitchFamily="34" charset="-120"/>
+              </a:rPr>
+              <a:t>every artifact class from the previous slide is present and measured — blessed model, generated contracts, developer-owned implementation, machine-checked proofs, pinned toolchain</a:t>
+            </a:r>
+            <a:endParaRPr lang="en-US" sz="1350" dirty="0"/>
+          </a:p>
+        </p:txBody>
+      </p:sp>
+      <p:sp>
+        <p:nvSpPr>
+          <p:cNvPr id="26" name="Text 24"/>
+          <p:cNvSpPr/>
+          <p:nvPr/>
+        </p:nvSpPr>
+        <p:spPr>
+          <a:xfrm>
+            <a:off x="7040880" y="1325880"/>
+            <a:ext cx="4480560" cy="320040"/>
+          </a:xfrm>
+          <a:prstGeom prst="rect">
+            <a:avLst/>
+          </a:prstGeom>
+          <a:noFill/>
+          <a:ln/>
+        </p:spPr>
+        <p:txBody>
+          <a:bodyPr wrap="square" lIns="0" tIns="0" rIns="0" bIns="0" rtlCol="0" anchor="ctr"/>
+          <a:lstStyle/>
+          <a:p>
+            <a:pPr marL="0" indent="0" algn="l">
+              <a:buNone/>
+            </a:pPr>
+            <a:r>
+              <a:rPr lang="en-US" sz="1300" i="1" dirty="0">
+                <a:solidFill>
+                  <a:srgbClr val="5A6478"/>
+                </a:solidFill>
+                <a:latin typeface="Calibri" pitchFamily="34" charset="0"/>
+                <a:ea typeface="Calibri" pitchFamily="34" charset="-122"/>
+                <a:cs typeface="Calibri" pitchFamily="34" charset="-120"/>
+              </a:rPr>
+              <a:t>the measured surface</a:t>
+            </a:r>
+            <a:endParaRPr lang="en-US" sz="1300" dirty="0"/>
+          </a:p>
+        </p:txBody>
+      </p:sp>
+      <p:sp>
+        <p:nvSpPr>
+          <p:cNvPr id="27" name="Shape 25"/>
+          <p:cNvSpPr/>
+          <p:nvPr/>
+        </p:nvSpPr>
+        <p:spPr>
+          <a:xfrm>
+            <a:off x="7040880" y="1737360"/>
+            <a:ext cx="4480560" cy="822960"/>
+          </a:xfrm>
+          <a:prstGeom prst="roundRect">
+            <a:avLst>
+              <a:gd name="adj" fmla="val 6667"/>
+            </a:avLst>
+          </a:prstGeom>
+          <a:solidFill>
+            <a:srgbClr val="F2F4F8"/>
+          </a:solidFill>
+          <a:ln w="12700">
+            <a:solidFill>
+              <a:srgbClr val="CADCFC"/>
+            </a:solidFill>
+            <a:prstDash val="solid"/>
+          </a:ln>
+        </p:spPr>
+        <p:txBody>
+          <a:bodyPr/>
+          <a:lstStyle/>
+          <a:p>
+            <a:endParaRPr lang="en-US"/>
+          </a:p>
+        </p:txBody>
+      </p:sp>
+      <p:sp>
+        <p:nvSpPr>
+          <p:cNvPr id="28" name="Text 26"/>
+          <p:cNvSpPr/>
+          <p:nvPr/>
+        </p:nvSpPr>
+        <p:spPr>
+          <a:xfrm>
+            <a:off x="7178040" y="1737360"/>
+            <a:ext cx="1234440" cy="822960"/>
+          </a:xfrm>
+          <a:prstGeom prst="rect">
+            <a:avLst/>
+          </a:prstGeom>
+          <a:noFill/>
+          <a:ln/>
+        </p:spPr>
+        <p:txBody>
+          <a:bodyPr wrap="square" lIns="0" tIns="0" rIns="0" bIns="0" rtlCol="0" anchor="ctr"/>
+          <a:lstStyle/>
+          <a:p>
+            <a:pPr marL="0" indent="0" algn="l">
+              <a:buNone/>
+            </a:pPr>
+            <a:r>
+              <a:rPr lang="en-US" sz="3000" b="1" dirty="0">
+                <a:solidFill>
+                  <a:srgbClr val="1E2761"/>
+                </a:solidFill>
+                <a:latin typeface="Cambria" pitchFamily="34" charset="0"/>
+                <a:ea typeface="Cambria" pitchFamily="34" charset="-122"/>
+                <a:cs typeface="Cambria" pitchFamily="34" charset="-120"/>
+              </a:rPr>
+              <a:t>13</a:t>
+            </a:r>
+            <a:endParaRPr lang="en-US" sz="3000" dirty="0"/>
+          </a:p>
+        </p:txBody>
+      </p:sp>
+      <p:sp>
+        <p:nvSpPr>
+          <p:cNvPr id="29" name="Text 27"/>
+          <p:cNvSpPr/>
+          <p:nvPr/>
+        </p:nvSpPr>
+        <p:spPr>
+          <a:xfrm>
+            <a:off x="8458200" y="1737360"/>
+            <a:ext cx="2971800" cy="822960"/>
+          </a:xfrm>
+          <a:prstGeom prst="rect">
+            <a:avLst/>
+          </a:prstGeom>
+          <a:noFill/>
+          <a:ln/>
+        </p:spPr>
+        <p:txBody>
+          <a:bodyPr wrap="square" lIns="0" tIns="0" rIns="0" bIns="0" rtlCol="0" anchor="ctr"/>
+          <a:lstStyle/>
+          <a:p>
+            <a:pPr marL="0" indent="0" algn="l">
+              <a:buNone/>
+            </a:pPr>
+            <a:r>
+              <a:rPr lang="en-US" sz="1100" dirty="0">
+                <a:solidFill>
+                  <a:srgbClr val="212121"/>
+                </a:solidFill>
+                <a:latin typeface="Calibri" pitchFamily="34" charset="0"/>
+                <a:ea typeface="Calibri" pitchFamily="34" charset="-122"/>
+                <a:cs typeface="Calibri" pitchFamily="34" charset="-120"/>
+              </a:rPr>
+              <a:t>measured files (SysML packages + contract-bearing Rust)</a:t>
+            </a:r>
+            <a:endParaRPr lang="en-US" sz="1100" dirty="0"/>
+          </a:p>
+        </p:txBody>
+      </p:sp>
+      <p:sp>
+        <p:nvSpPr>
+          <p:cNvPr id="30" name="Shape 28"/>
+          <p:cNvSpPr/>
+          <p:nvPr/>
+        </p:nvSpPr>
+        <p:spPr>
+          <a:xfrm>
+            <a:off x="7040880" y="2651760"/>
+            <a:ext cx="4480560" cy="822960"/>
+          </a:xfrm>
+          <a:prstGeom prst="roundRect">
+            <a:avLst>
+              <a:gd name="adj" fmla="val 6667"/>
+            </a:avLst>
+          </a:prstGeom>
+          <a:solidFill>
+            <a:srgbClr val="F2F4F8"/>
+          </a:solidFill>
+          <a:ln w="12700">
+            <a:solidFill>
+              <a:srgbClr val="CADCFC"/>
+            </a:solidFill>
+            <a:prstDash val="solid"/>
+          </a:ln>
+        </p:spPr>
+        <p:txBody>
+          <a:bodyPr/>
+          <a:lstStyle/>
+          <a:p>
+            <a:endParaRPr lang="en-US"/>
+          </a:p>
+        </p:txBody>
+      </p:sp>
+      <p:sp>
+        <p:nvSpPr>
+          <p:cNvPr id="31" name="Text 29"/>
+          <p:cNvSpPr/>
+          <p:nvPr/>
+        </p:nvSpPr>
+        <p:spPr>
+          <a:xfrm>
+            <a:off x="7178040" y="2651760"/>
+            <a:ext cx="1234440" cy="822960"/>
+          </a:xfrm>
+          <a:prstGeom prst="rect">
+            <a:avLst/>
+          </a:prstGeom>
+          <a:noFill/>
+          <a:ln/>
+        </p:spPr>
+        <p:txBody>
+          <a:bodyPr wrap="square" lIns="0" tIns="0" rIns="0" bIns="0" rtlCol="0" anchor="ctr"/>
+          <a:lstStyle/>
+          <a:p>
+            <a:pPr marL="0" indent="0" algn="l">
+              <a:buNone/>
+            </a:pPr>
+            <a:r>
+              <a:rPr lang="en-US" sz="3000" b="1" dirty="0">
+                <a:solidFill>
+                  <a:srgbClr val="1E2761"/>
+                </a:solidFill>
+                <a:latin typeface="Cambria" pitchFamily="34" charset="0"/>
+                <a:ea typeface="Cambria" pitchFamily="34" charset="-122"/>
+                <a:cs typeface="Cambria" pitchFamily="34" charset="-120"/>
+              </a:rPr>
+              <a:t>67</a:t>
+            </a:r>
+            <a:endParaRPr lang="en-US" sz="3000" dirty="0"/>
+          </a:p>
+        </p:txBody>
+      </p:sp>
+      <p:sp>
+        <p:nvSpPr>
+          <p:cNvPr id="32" name="Text 30"/>
+          <p:cNvSpPr/>
+          <p:nvPr/>
+        </p:nvSpPr>
+        <p:spPr>
+          <a:xfrm>
+            <a:off x="8458200" y="2651760"/>
+            <a:ext cx="2971800" cy="822960"/>
+          </a:xfrm>
+          <a:prstGeom prst="rect">
+            <a:avLst/>
+          </a:prstGeom>
+          <a:noFill/>
+          <a:ln/>
+        </p:spPr>
+        <p:txBody>
+          <a:bodyPr wrap="square" lIns="0" tIns="0" rIns="0" bIns="0" rtlCol="0" anchor="ctr"/>
+          <a:lstStyle/>
+          <a:p>
+            <a:pPr marL="0" indent="0" algn="l">
+              <a:buNone/>
+            </a:pPr>
+            <a:r>
+              <a:rPr lang="en-US" sz="1100" dirty="0">
+                <a:solidFill>
+                  <a:srgbClr val="212121"/>
+                </a:solidFill>
+                <a:latin typeface="Calibri" pitchFamily="34" charset="0"/>
+                <a:ea typeface="Calibri" pitchFamily="34" charset="-122"/>
+                <a:cs typeface="Calibri" pitchFamily="34" charset="-120"/>
+              </a:rPr>
+              <a:t>contract slices</a:t>
+            </a:r>
+            <a:endParaRPr lang="en-US" sz="1100" dirty="0"/>
+          </a:p>
+        </p:txBody>
+      </p:sp>
+      <p:sp>
+        <p:nvSpPr>
+          <p:cNvPr id="33" name="Shape 31"/>
+          <p:cNvSpPr/>
+          <p:nvPr/>
+        </p:nvSpPr>
+        <p:spPr>
+          <a:xfrm>
+            <a:off x="7040880" y="3566160"/>
+            <a:ext cx="4480560" cy="822960"/>
+          </a:xfrm>
+          <a:prstGeom prst="roundRect">
+            <a:avLst>
+              <a:gd name="adj" fmla="val 6667"/>
+            </a:avLst>
+          </a:prstGeom>
+          <a:solidFill>
+            <a:srgbClr val="F2F4F8"/>
+          </a:solidFill>
+          <a:ln w="12700">
+            <a:solidFill>
+              <a:srgbClr val="CADCFC"/>
+            </a:solidFill>
+            <a:prstDash val="solid"/>
+          </a:ln>
+        </p:spPr>
+        <p:txBody>
+          <a:bodyPr/>
+          <a:lstStyle/>
+          <a:p>
+            <a:endParaRPr lang="en-US"/>
+          </a:p>
+        </p:txBody>
+      </p:sp>
+      <p:sp>
+        <p:nvSpPr>
+          <p:cNvPr id="34" name="Text 32"/>
+          <p:cNvSpPr/>
+          <p:nvPr/>
+        </p:nvSpPr>
+        <p:spPr>
+          <a:xfrm>
+            <a:off x="7178040" y="3566160"/>
+            <a:ext cx="1234440" cy="822960"/>
+          </a:xfrm>
+          <a:prstGeom prst="rect">
+            <a:avLst/>
+          </a:prstGeom>
+          <a:noFill/>
+          <a:ln/>
+        </p:spPr>
+        <p:txBody>
+          <a:bodyPr wrap="square" lIns="0" tIns="0" rIns="0" bIns="0" rtlCol="0" anchor="ctr"/>
+          <a:lstStyle/>
+          <a:p>
+            <a:pPr marL="0" indent="0" algn="l">
+              <a:buNone/>
+            </a:pPr>
+            <a:r>
+              <a:rPr lang="en-US" sz="3000" b="1" dirty="0">
+                <a:solidFill>
+                  <a:srgbClr val="1E2761"/>
+                </a:solidFill>
+                <a:latin typeface="Cambria" pitchFamily="34" charset="0"/>
+                <a:ea typeface="Cambria" pitchFamily="34" charset="-122"/>
+                <a:cs typeface="Cambria" pitchFamily="34" charset="-120"/>
+              </a:rPr>
+              <a:t>8</a:t>
+            </a:r>
+            <a:endParaRPr lang="en-US" sz="3000" dirty="0"/>
+          </a:p>
+        </p:txBody>
+      </p:sp>
+      <p:sp>
+        <p:nvSpPr>
+          <p:cNvPr id="35" name="Text 33"/>
+          <p:cNvSpPr/>
+          <p:nvPr/>
+        </p:nvSpPr>
+        <p:spPr>
+          <a:xfrm>
+            <a:off x="8458200" y="3566160"/>
+            <a:ext cx="2971800" cy="822960"/>
+          </a:xfrm>
+          <a:prstGeom prst="rect">
+            <a:avLst/>
+          </a:prstGeom>
+          <a:noFill/>
+          <a:ln/>
+        </p:spPr>
+        <p:txBody>
+          <a:bodyPr wrap="square" lIns="0" tIns="0" rIns="0" bIns="0" rtlCol="0" anchor="ctr"/>
+          <a:lstStyle/>
+          <a:p>
+            <a:pPr marL="0" indent="0" algn="l">
+              <a:buNone/>
+            </a:pPr>
+            <a:r>
+              <a:rPr lang="en-US" sz="1100" dirty="0">
+                <a:solidFill>
+                  <a:srgbClr val="212121"/>
+                </a:solidFill>
+                <a:latin typeface="Calibri" pitchFamily="34" charset="0"/>
+                <a:ea typeface="Calibri" pitchFamily="34" charset="-122"/>
+                <a:cs typeface="Calibri" pitchFamily="34" charset="-120"/>
+              </a:rPr>
+              <a:t>crates re-verified every episode (7 components + the system proof)</a:t>
+            </a:r>
+            <a:endParaRPr lang="en-US" sz="1100" dirty="0"/>
+          </a:p>
+        </p:txBody>
+      </p:sp>
+      <p:sp>
+        <p:nvSpPr>
+          <p:cNvPr id="36" name="Shape 34"/>
+          <p:cNvSpPr/>
+          <p:nvPr/>
+        </p:nvSpPr>
+        <p:spPr>
+          <a:xfrm>
+            <a:off x="7040880" y="4480560"/>
+            <a:ext cx="4480560" cy="822960"/>
+          </a:xfrm>
+          <a:prstGeom prst="roundRect">
+            <a:avLst>
+              <a:gd name="adj" fmla="val 6667"/>
+            </a:avLst>
+          </a:prstGeom>
+          <a:solidFill>
+            <a:srgbClr val="F2F4F8"/>
+          </a:solidFill>
+          <a:ln w="12700">
+            <a:solidFill>
+              <a:srgbClr val="CADCFC"/>
+            </a:solidFill>
+            <a:prstDash val="solid"/>
+          </a:ln>
+        </p:spPr>
+        <p:txBody>
+          <a:bodyPr/>
+          <a:lstStyle/>
+          <a:p>
+            <a:endParaRPr lang="en-US"/>
+          </a:p>
+        </p:txBody>
+      </p:sp>
+      <p:sp>
+        <p:nvSpPr>
+          <p:cNvPr id="37" name="Text 35"/>
+          <p:cNvSpPr/>
+          <p:nvPr/>
+        </p:nvSpPr>
+        <p:spPr>
+          <a:xfrm>
+            <a:off x="7178040" y="4480560"/>
+            <a:ext cx="1234440" cy="822960"/>
+          </a:xfrm>
+          <a:prstGeom prst="rect">
+            <a:avLst/>
+          </a:prstGeom>
+          <a:noFill/>
+          <a:ln/>
+        </p:spPr>
+        <p:txBody>
+          <a:bodyPr wrap="square" lIns="0" tIns="0" rIns="0" bIns="0" rtlCol="0" anchor="ctr"/>
+          <a:lstStyle/>
+          <a:p>
+            <a:pPr marL="0" indent="0" algn="l">
+              <a:buNone/>
+            </a:pPr>
+            <a:r>
+              <a:rPr lang="en-US" sz="3000" b="1" dirty="0">
+                <a:solidFill>
+                  <a:srgbClr val="1E2761"/>
+                </a:solidFill>
+                <a:latin typeface="Cambria" pitchFamily="34" charset="0"/>
+                <a:ea typeface="Cambria" pitchFamily="34" charset="-122"/>
+                <a:cs typeface="Cambria" pitchFamily="34" charset="-120"/>
+              </a:rPr>
+              <a:t>1,862</a:t>
+            </a:r>
+            <a:endParaRPr lang="en-US" sz="3000" dirty="0"/>
+          </a:p>
+        </p:txBody>
+      </p:sp>
+      <p:sp>
+        <p:nvSpPr>
+          <p:cNvPr id="38" name="Text 36"/>
+          <p:cNvSpPr/>
+          <p:nvPr/>
+        </p:nvSpPr>
+        <p:spPr>
+          <a:xfrm>
+            <a:off x="8458200" y="4480560"/>
+            <a:ext cx="2971800" cy="822960"/>
+          </a:xfrm>
+          <a:prstGeom prst="rect">
+            <a:avLst/>
+          </a:prstGeom>
+          <a:noFill/>
+          <a:ln/>
+        </p:spPr>
+        <p:txBody>
+          <a:bodyPr wrap="square" lIns="0" tIns="0" rIns="0" bIns="0" rtlCol="0" anchor="ctr"/>
+          <a:lstStyle/>
+          <a:p>
+            <a:pPr marL="0" indent="0" algn="l">
+              <a:buNone/>
+            </a:pPr>
+            <a:r>
+              <a:rPr lang="en-US" sz="1100" dirty="0">
+                <a:solidFill>
+                  <a:srgbClr val="212121"/>
+                </a:solidFill>
+                <a:latin typeface="Calibri" pitchFamily="34" charset="0"/>
+                <a:ea typeface="Calibri" pitchFamily="34" charset="-122"/>
+                <a:cs typeface="Calibri" pitchFamily="34" charset="-120"/>
+              </a:rPr>
+              <a:t>system-proof obligations</a:t>
+            </a:r>
+            <a:endParaRPr lang="en-US" sz="1100" dirty="0"/>
+          </a:p>
+        </p:txBody>
+      </p:sp>
+      <p:sp>
+        <p:nvSpPr>
+          <p:cNvPr id="39" name="Shape 37"/>
+          <p:cNvSpPr/>
+          <p:nvPr/>
+        </p:nvSpPr>
+        <p:spPr>
+          <a:xfrm>
+            <a:off x="7040880" y="5394960"/>
+            <a:ext cx="4480560" cy="822960"/>
+          </a:xfrm>
+          <a:prstGeom prst="roundRect">
+            <a:avLst>
+              <a:gd name="adj" fmla="val 6667"/>
+            </a:avLst>
+          </a:prstGeom>
+          <a:solidFill>
+            <a:srgbClr val="F2F4F8"/>
+          </a:solidFill>
+          <a:ln w="12700">
+            <a:solidFill>
+              <a:srgbClr val="CADCFC"/>
+            </a:solidFill>
+            <a:prstDash val="solid"/>
+          </a:ln>
+        </p:spPr>
+        <p:txBody>
+          <a:bodyPr/>
+          <a:lstStyle/>
+          <a:p>
+            <a:endParaRPr lang="en-US"/>
+          </a:p>
+        </p:txBody>
+      </p:sp>
+      <p:sp>
+        <p:nvSpPr>
+          <p:cNvPr id="40" name="Text 38"/>
+          <p:cNvSpPr/>
+          <p:nvPr/>
+        </p:nvSpPr>
+        <p:spPr>
+          <a:xfrm>
+            <a:off x="7178040" y="5394960"/>
+            <a:ext cx="1234440" cy="822960"/>
+          </a:xfrm>
+          <a:prstGeom prst="rect">
+            <a:avLst/>
+          </a:prstGeom>
+          <a:noFill/>
+          <a:ln/>
+        </p:spPr>
+        <p:txBody>
+          <a:bodyPr wrap="square" lIns="0" tIns="0" rIns="0" bIns="0" rtlCol="0" anchor="ctr"/>
+          <a:lstStyle/>
+          <a:p>
+            <a:pPr marL="0" indent="0" algn="l">
+              <a:buNone/>
+            </a:pPr>
+            <a:r>
+              <a:rPr lang="en-US" sz="3000" b="1" dirty="0">
+                <a:solidFill>
+                  <a:srgbClr val="1E2761"/>
+                </a:solidFill>
+                <a:latin typeface="Cambria" pitchFamily="34" charset="0"/>
+                <a:ea typeface="Cambria" pitchFamily="34" charset="-122"/>
+                <a:cs typeface="Cambria" pitchFamily="34" charset="-120"/>
+              </a:rPr>
+              <a:t>8</a:t>
+            </a:r>
+            <a:endParaRPr lang="en-US" sz="3000" dirty="0"/>
+          </a:p>
+        </p:txBody>
+      </p:sp>
+      <p:sp>
+        <p:nvSpPr>
+          <p:cNvPr id="41" name="Text 39"/>
+          <p:cNvSpPr/>
+          <p:nvPr/>
+        </p:nvSpPr>
+        <p:spPr>
+          <a:xfrm>
+            <a:off x="8458200" y="5394960"/>
+            <a:ext cx="2971800" cy="822960"/>
+          </a:xfrm>
+          <a:prstGeom prst="rect">
+            <a:avLst/>
+          </a:prstGeom>
+          <a:noFill/>
+          <a:ln/>
+        </p:spPr>
+        <p:txBody>
+          <a:bodyPr wrap="square" lIns="0" tIns="0" rIns="0" bIns="0" rtlCol="0" anchor="ctr"/>
+          <a:lstStyle/>
+          <a:p>
+            <a:pPr marL="0" indent="0" algn="l">
+              <a:buNone/>
+            </a:pPr>
+            <a:r>
+              <a:rPr lang="en-US" sz="1100" dirty="0">
+                <a:solidFill>
+                  <a:srgbClr val="212121"/>
+                </a:solidFill>
+                <a:latin typeface="Calibri" pitchFamily="34" charset="0"/>
+                <a:ea typeface="Calibri" pitchFamily="34" charset="-122"/>
+                <a:cs typeface="Calibri" pitchFamily="34" charset="-120"/>
+              </a:rPr>
+              <a:t>attestation tiers — the glossary's entry keys:</a:t>
+            </a:r>
+            <a:endParaRPr lang="en-US" sz="1100" dirty="0"/>
+          </a:p>
+          <a:p>
+            <a:pPr marL="0" indent="0" algn="l">
+              <a:buNone/>
+            </a:pPr>
+            <a:r>
+              <a:rPr lang="en-US" sz="1100" dirty="0">
+                <a:solidFill>
+                  <a:srgbClr val="212121"/>
+                </a:solidFill>
+                <a:latin typeface="Calibri" pitchFamily="34" charset="0"/>
+                <a:ea typeface="Calibri" pitchFamily="34" charset="-122"/>
+                <a:cs typeface="Calibri" pitchFamily="34" charset="-120"/>
+              </a:rPr>
+              <a:t>props · l1a · l2 · verus · cheat · sysproof · gensrc · report</a:t>
+            </a:r>
+            <a:endParaRPr lang="en-US" sz="1100" dirty="0"/>
+          </a:p>
+        </p:txBody>
+      </p:sp>
     </p:spTree>
   </p:cSld>
   <p:clrMapOvr>

</xml_diff>

<commit_message>
isolette references + deck-wide references slide
Isolette slide: three K-State citations (Isolette System 2025,
SysMLv2+HAMR 2025, HAMR ISoLA 2021) as a footer alongside AR-08-32;
relevance rename and position nudges ported from deck edits. New final
References slide grouped by topic (K-State/isolette, Copland POST
2019, Verus OOPSLA 2023, seL4 SOSP 2009) as the deck's collection
point; DOIs recorded in the drafts file.

Co-Authored-By: Claude Fable 5 <noreply@anthropic.com>
</commit_message>
<xml_diff>
--- a/docs/video_slides_draft.pptx
+++ b/docs/video_slides_draft.pptx
@@ -4,9 +4,6 @@
   <p:sldMasterIdLst>
     <p:sldMasterId id="2147483648" r:id="rId1"/>
   </p:sldMasterIdLst>
-  <p:notesMasterIdLst>
-    <p:notesMasterId r:id="rId10"/>
-  </p:notesMasterIdLst>
   <p:sldIdLst>
     <p:sldId id="256" r:id="rId2"/>
     <p:sldId id="257" r:id="rId3"/>
@@ -16,7 +13,11 @@
     <p:sldId id="261" r:id="rId7"/>
     <p:sldId id="262" r:id="rId8"/>
     <p:sldId id="263" r:id="rId9"/>
+    <p:sldId id="264" r:id="rId10"/>
   </p:sldIdLst>
+  <p:notesMasterIdLst>
+    <p:notesMasterId r:id="rId11"/>
+  </p:notesMasterIdLst>
   <p:sldSz cx="12192000" cy="6858000"/>
   <p:notesSz cx="6858000" cy="12192000"/>
   <p:defaultTextStyle>
@@ -111,11 +112,6 @@
       </a:defRPr>
     </a:lvl9pPr>
   </p:defaultTextStyle>
-  <p:extLst>
-    <p:ext uri="{EFAFB233-063F-42B5-8137-9DF3F51BA10A}">
-      <p15:sldGuideLst xmlns:p15="http://schemas.microsoft.com/office/powerpoint/2012/main"/>
-    </p:ext>
-  </p:extLst>
 </p:presentation>
 </file>
 
@@ -141,10 +137,234 @@
           <a:chExt cx="0" cy="0"/>
         </a:xfrm>
       </p:grpSpPr>
+      <p:sp>
+        <p:nvSpPr>
+          <p:cNvPr id="2" name="Header Placeholder 1"/>
+          <p:cNvSpPr>
+            <a:spLocks noGrp="1"/>
+          </p:cNvSpPr>
+          <p:nvPr>
+            <p:ph type="hdr" sz="quarter"/>
+          </p:nvPr>
+        </p:nvSpPr>
+        <p:spPr>
+          <a:xfrm>
+            <a:off x="0" y="0"/>
+            <a:ext cx="2971800" cy="458788"/>
+          </a:xfrm>
+          <a:prstGeom prst="rect">
+            <a:avLst/>
+          </a:prstGeom>
+        </p:spPr>
+        <p:txBody>
+          <a:bodyPr vert="horz" lIns="91440" tIns="45720" rIns="91440" bIns="45720" rtlCol="0"/>
+          <a:lstStyle>
+            <a:lvl1pPr algn="l">
+              <a:defRPr sz="1200"/>
+            </a:lvl1pPr>
+          </a:lstStyle>
+          <a:p>
+            <a:endParaRPr lang="en-US"/>
+          </a:p>
+        </p:txBody>
+      </p:sp>
+      <p:sp>
+        <p:nvSpPr>
+          <p:cNvPr id="3" name="Date Placeholder 2"/>
+          <p:cNvSpPr>
+            <a:spLocks noGrp="1"/>
+          </p:cNvSpPr>
+          <p:nvPr>
+            <p:ph type="dt" idx="1"/>
+          </p:nvPr>
+        </p:nvSpPr>
+        <p:spPr>
+          <a:xfrm>
+            <a:off x="3884613" y="0"/>
+            <a:ext cx="2971800" cy="458788"/>
+          </a:xfrm>
+          <a:prstGeom prst="rect">
+            <a:avLst/>
+          </a:prstGeom>
+        </p:spPr>
+        <p:txBody>
+          <a:bodyPr vert="horz" lIns="91440" tIns="45720" rIns="91440" bIns="45720" rtlCol="0"/>
+          <a:lstStyle>
+            <a:lvl1pPr algn="r">
+              <a:defRPr sz="1200"/>
+            </a:lvl1pPr>
+          </a:lstStyle>
+          <a:p>
+            <a:fld id="{5282F153-3F37-0F45-9E97-73ACFA13230C}" type="datetimeFigureOut">
+              <a:rPr lang="en-US"/>
+              <a:t>7/23/19</a:t>
+            </a:fld>
+            <a:endParaRPr lang="en-US"/>
+          </a:p>
+        </p:txBody>
+      </p:sp>
+      <p:sp>
+        <p:nvSpPr>
+          <p:cNvPr id="4" name="Slide Image Placeholder 3"/>
+          <p:cNvSpPr>
+            <a:spLocks noGrp="1" noRot="1" noChangeAspect="1"/>
+          </p:cNvSpPr>
+          <p:nvPr>
+            <p:ph type="sldImg" idx="2"/>
+          </p:nvPr>
+        </p:nvSpPr>
+        <p:spPr>
+          <a:xfrm>
+            <a:off x="685800" y="1143000"/>
+            <a:ext cx="5486400" cy="3086100"/>
+          </a:xfrm>
+          <a:prstGeom prst="rect">
+            <a:avLst/>
+          </a:prstGeom>
+          <a:noFill/>
+          <a:ln w="12700">
+            <a:solidFill>
+              <a:prstClr val="black"/>
+            </a:solidFill>
+          </a:ln>
+        </p:spPr>
+        <p:txBody>
+          <a:bodyPr vert="horz" lIns="91440" tIns="45720" rIns="91440" bIns="45720" rtlCol="0" anchor="ctr"/>
+          <a:lstStyle/>
+          <a:p>
+            <a:endParaRPr lang="en-US"/>
+          </a:p>
+        </p:txBody>
+      </p:sp>
+      <p:sp>
+        <p:nvSpPr>
+          <p:cNvPr id="5" name="Notes Placeholder 4"/>
+          <p:cNvSpPr>
+            <a:spLocks noGrp="1"/>
+          </p:cNvSpPr>
+          <p:nvPr>
+            <p:ph type="body" sz="quarter" idx="3"/>
+          </p:nvPr>
+        </p:nvSpPr>
+        <p:spPr>
+          <a:xfrm>
+            <a:off x="685800" y="4400550"/>
+            <a:ext cx="5486400" cy="3600450"/>
+          </a:xfrm>
+          <a:prstGeom prst="rect">
+            <a:avLst/>
+          </a:prstGeom>
+        </p:spPr>
+        <p:txBody>
+          <a:bodyPr vert="horz" lIns="91440" tIns="45720" rIns="91440" bIns="45720" rtlCol="0"/>
+          <a:lstStyle/>
+          <a:p>
+            <a:pPr lvl="0"/>
+            <a:r>
+              <a:rPr lang="en-US"/>
+              <a:t>Click to edit Master text styles</a:t>
+            </a:r>
+          </a:p>
+          <a:p>
+            <a:pPr lvl="1"/>
+            <a:r>
+              <a:rPr lang="en-US"/>
+              <a:t>Second level</a:t>
+            </a:r>
+          </a:p>
+          <a:p>
+            <a:pPr lvl="2"/>
+            <a:r>
+              <a:rPr lang="en-US"/>
+              <a:t>Third level</a:t>
+            </a:r>
+          </a:p>
+          <a:p>
+            <a:pPr lvl="3"/>
+            <a:r>
+              <a:rPr lang="en-US"/>
+              <a:t>Fourth level</a:t>
+            </a:r>
+          </a:p>
+          <a:p>
+            <a:pPr lvl="4"/>
+            <a:r>
+              <a:rPr lang="en-US"/>
+              <a:t>Fifth level</a:t>
+            </a:r>
+          </a:p>
+        </p:txBody>
+      </p:sp>
+      <p:sp>
+        <p:nvSpPr>
+          <p:cNvPr id="6" name="Footer Placeholder 5"/>
+          <p:cNvSpPr>
+            <a:spLocks noGrp="1"/>
+          </p:cNvSpPr>
+          <p:nvPr>
+            <p:ph type="ftr" sz="quarter" idx="4"/>
+          </p:nvPr>
+        </p:nvSpPr>
+        <p:spPr>
+          <a:xfrm>
+            <a:off x="0" y="8685213"/>
+            <a:ext cx="2971800" cy="458787"/>
+          </a:xfrm>
+          <a:prstGeom prst="rect">
+            <a:avLst/>
+          </a:prstGeom>
+        </p:spPr>
+        <p:txBody>
+          <a:bodyPr vert="horz" lIns="91440" tIns="45720" rIns="91440" bIns="45720" rtlCol="0" anchor="b"/>
+          <a:lstStyle>
+            <a:lvl1pPr algn="l">
+              <a:defRPr sz="1200"/>
+            </a:lvl1pPr>
+          </a:lstStyle>
+          <a:p>
+            <a:endParaRPr lang="en-US"/>
+          </a:p>
+        </p:txBody>
+      </p:sp>
+      <p:sp>
+        <p:nvSpPr>
+          <p:cNvPr id="7" name="Slide Number Placeholder 6"/>
+          <p:cNvSpPr>
+            <a:spLocks noGrp="1"/>
+          </p:cNvSpPr>
+          <p:nvPr>
+            <p:ph type="sldNum" sz="quarter" idx="5"/>
+          </p:nvPr>
+        </p:nvSpPr>
+        <p:spPr>
+          <a:xfrm>
+            <a:off x="3884613" y="8685213"/>
+            <a:ext cx="2971800" cy="458787"/>
+          </a:xfrm>
+          <a:prstGeom prst="rect">
+            <a:avLst/>
+          </a:prstGeom>
+        </p:spPr>
+        <p:txBody>
+          <a:bodyPr vert="horz" lIns="91440" tIns="45720" rIns="91440" bIns="45720" rtlCol="0" anchor="b"/>
+          <a:lstStyle>
+            <a:lvl1pPr algn="r">
+              <a:defRPr sz="1200"/>
+            </a:lvl1pPr>
+          </a:lstStyle>
+          <a:p>
+            <a:fld id="{CE5E9CC1-C706-0F49-92D6-E571CC5EEA8F}" type="slidenum">
+              <a:rPr lang="en-US"/>
+              <a:t>‹#›</a:t>
+            </a:fld>
+            <a:endParaRPr lang="en-US"/>
+          </a:p>
+        </p:txBody>
+      </p:sp>
     </p:spTree>
     <p:extLst>
       <p:ext uri="{BB962C8B-B14F-4D97-AF65-F5344CB8AC3E}">
-        <p14:creationId xmlns:p14="http://schemas.microsoft.com/office/powerpoint/2010/main" val="1964892576"/>
+        <p14:creationId xmlns:p14="http://schemas.microsoft.com/office/powerpoint/2010/main" val="1024086991"/>
       </p:ext>
     </p:extLst>
   </p:cSld>
@@ -292,6 +512,7 @@
               <a:rPr lang="en-US" dirty="0"/>
               <a:t>Title card. Subtitle deliberately names the four core artifact classes - the deck's first echo of the artifact-class table (slide 6). Optional footer: INSPECTA program context.</a:t>
             </a:r>
+            <a:endParaRPr lang="en-US" dirty="0"/>
           </a:p>
         </p:txBody>
       </p:sp>
@@ -382,6 +603,7 @@
 Subline payoffs: developer claims -&gt; scenes 5/7; untrusted tools -&gt; scene 7; LLM outputs -&gt; capstone slides A/B; cached verdicts -&gt; scene 11.
 Visual TODO: three-stage widening-scope progression (boot-time -&gt; layered runtime -&gt; lifecycle loop) to replace/join the bullets.</a:t>
             </a:r>
+            <a:endParaRPr lang="en-US" dirty="0"/>
           </a:p>
         </p:txBody>
       </p:sp>
@@ -470,6 +692,7 @@
               <a:t>~15 seconds on first appearance; afterwards it rides on transition slides for free.
 Design decision: one master/layout holds the strip text so a section rename is a single edit. Header titles are provisional.</a:t>
             </a:r>
+            <a:endParaRPr lang="en-US" dirty="0"/>
           </a:p>
         </p:txBody>
       </p:sp>
@@ -560,6 +783,7 @@
 Snippet source: tests/fixtures/isolette_sysmlv2_rust_props/term.json, rendered in concrete syntax (branches flattened, target IDs shortened to file names - cosmetic).
 The verus-tier measure-then-use phrase is deliberately held back for scene 7's reveal.</a:t>
             </a:r>
+            <a:endParaRPr lang="en-US" dirty="0"/>
           </a:p>
         </p:txBody>
       </p:sp>
@@ -651,6 +875,7 @@
 Speaker-note-only details (cut from the slide): on_pass/on_fail dispatch mechanics, success-driven handoff for component-wise entries, max_attempts per rung.
 The legend earns its space: every scene's checklist frames render through these glyphs.</a:t>
             </a:r>
+            <a:endParaRPr lang="en-US" dirty="0"/>
           </a:p>
         </p:txBody>
       </p:sp>
@@ -741,6 +966,7 @@
 Predicate and restart-episode are deliberately OFF this slide (parked; placement TBD - possibly an 'evaluation primitives' strip). If asked: a predicate is the judge (one evaluation = one attestation episode), restart-episode is the freshness primitive (forget memoized verdicts, reset, re-evaluate).
 Also deliberately excluded (README-level detail): partition mechanics, component-wise entries and success handoff, dispatch latching, max_cycles.</a:t>
             </a:r>
+            <a:endParaRPr lang="en-US" dirty="0"/>
           </a:p>
         </p:txBody>
       </p:sp>
@@ -830,6 +1056,7 @@
 Spoken hook (never on-slide text): 'This table is deliberately incomplete - the demo will show why.' The cheat / sysproof / gensrc tiers are capstone slide C's punchline: attacks forced them into existence. Do not pre-introduce them here.
 Same column shape (class -&gt; measured how -&gt; judged by -&gt; repair) as capstone slide B, so the audience recognizes it when it returns.</a:t>
             </a:r>
+            <a:endParaRPr lang="en-US" dirty="0"/>
           </a:p>
         </p:txBody>
       </p:sp>
@@ -921,6 +1148,7 @@
 Held back on purpose (scene 9's reveal): cheat-tier depth stats - 86 blessed external_body sites, 10 scanned crates.
 Numbers verified exact 2026-08-25 (l1a targets, l2 slices, verus term, pub-proof-fn count); provision-dependent - re-verify before recording day.</a:t>
             </a:r>
+            <a:endParaRPr lang="en-US" dirty="0"/>
           </a:p>
         </p:txBody>
       </p:sp>
@@ -942,6 +1170,95 @@
             <a:fld id="{F7021451-1387-4CA6-816F-3879F97B5CBC}" type="slidenum">
               <a:rPr lang="en-US"/>
               <a:t>8</a:t>
+            </a:fld>
+            <a:endParaRPr lang="en-US"/>
+          </a:p>
+        </p:txBody>
+      </p:sp>
+    </p:spTree>
+    <p:extLst>
+      <p:ext uri="{BB962C8B-B14F-4D97-AF65-F5344CB8AC3E}">
+        <p14:creationId xmlns:p14="http://schemas.microsoft.com/office/powerpoint/2010/main" val="1024086991"/>
+      </p:ext>
+    </p:extLst>
+  </p:cSld>
+  <p:clrMapOvr>
+    <a:masterClrMapping/>
+  </p:clrMapOvr>
+</p:notes>
+</file>
+
+<file path=ppt/notesSlides/notesSlide9.xml><?xml version="1.0" encoding="utf-8"?>
+<p:notes xmlns:a="http://schemas.openxmlformats.org/drawingml/2006/main" xmlns:r="http://schemas.openxmlformats.org/officeDocument/2006/relationships" xmlns:p="http://schemas.openxmlformats.org/presentationml/2006/main">
+  <p:cSld>
+    <p:spTree>
+      <p:nvGrpSpPr>
+        <p:cNvPr id="1" name=""/>
+        <p:cNvGrpSpPr/>
+        <p:nvPr/>
+      </p:nvGrpSpPr>
+      <p:grpSpPr>
+        <a:xfrm>
+          <a:off x="0" y="0"/>
+          <a:ext cx="0" cy="0"/>
+          <a:chOff x="0" y="0"/>
+          <a:chExt cx="0" cy="0"/>
+        </a:xfrm>
+      </p:grpSpPr>
+      <p:sp>
+        <p:nvSpPr>
+          <p:cNvPr id="2" name="Slide Image Placeholder 1"/>
+          <p:cNvSpPr>
+            <a:spLocks noGrp="1" noRot="1" noChangeAspect="1"/>
+          </p:cNvSpPr>
+          <p:nvPr>
+            <p:ph type="sldImg"/>
+          </p:nvPr>
+        </p:nvSpPr>
+        <p:spPr/>
+      </p:sp>
+      <p:sp>
+        <p:nvSpPr>
+          <p:cNvPr id="3" name="Notes Placeholder 2"/>
+          <p:cNvSpPr>
+            <a:spLocks noGrp="1"/>
+          </p:cNvSpPr>
+          <p:nvPr>
+            <p:ph type="body" idx="1"/>
+          </p:nvPr>
+        </p:nvSpPr>
+        <p:spPr/>
+        <p:txBody>
+          <a:bodyPr/>
+          <a:lstStyle/>
+          <a:p>
+            <a:r>
+              <a:rPr lang="en-US" dirty="0"/>
+              <a:t>Collection point for every reference in the deck - keep this slide current as sections are added (isolette slide carries the K-State + AR-08-32 citations inline; Copland/Verus/seL4 seeded here ahead of their sections).
+DOIs on record in docs/video_slide_drafts.md.</a:t>
+            </a:r>
+            <a:endParaRPr lang="en-US" dirty="0"/>
+          </a:p>
+        </p:txBody>
+      </p:sp>
+      <p:sp>
+        <p:nvSpPr>
+          <p:cNvPr id="4" name="Slide Number Placeholder 3"/>
+          <p:cNvSpPr>
+            <a:spLocks noGrp="1"/>
+          </p:cNvSpPr>
+          <p:nvPr>
+            <p:ph type="sldNum" sz="quarter" idx="10"/>
+          </p:nvPr>
+        </p:nvSpPr>
+        <p:spPr/>
+        <p:txBody>
+          <a:bodyPr/>
+          <a:lstStyle/>
+          <a:p>
+            <a:fld id="{F7021451-1387-4CA6-816F-3879F97B5CBC}" type="slidenum">
+              <a:rPr lang="en-US"/>
+              <a:t>9</a:t>
             </a:fld>
             <a:endParaRPr lang="en-US"/>
           </a:p>
@@ -993,11 +1310,6 @@
 <file path=ppt/slideMasters/slideMaster1.xml><?xml version="1.0" encoding="utf-8"?>
 <p:sldMaster xmlns:a="http://schemas.openxmlformats.org/drawingml/2006/main" xmlns:r="http://schemas.openxmlformats.org/officeDocument/2006/relationships" xmlns:p="http://schemas.openxmlformats.org/presentationml/2006/main">
   <p:cSld>
-    <p:bg>
-      <p:bgRef idx="1001">
-        <a:schemeClr val="bg1"/>
-      </p:bgRef>
-    </p:bg>
     <p:spTree>
       <p:nvGrpSpPr>
         <p:cNvPr id="1" name=""/>
@@ -1280,7 +1592,6 @@
         <a:solidFill>
           <a:srgbClr val="1E2761"/>
         </a:solidFill>
-        <a:effectLst/>
       </p:bgPr>
     </p:bg>
     <p:spTree>
@@ -1318,7 +1629,7 @@
           <a:bodyPr wrap="square" lIns="0" tIns="0" rIns="0" bIns="0" rtlCol="0" anchor="ctr"/>
           <a:lstStyle/>
           <a:p>
-            <a:pPr marL="0" indent="0" algn="l">
+            <a:pPr algn="l" indent="0" marL="0">
               <a:buNone/>
             </a:pPr>
             <a:r>
@@ -1357,7 +1668,7 @@
           <a:bodyPr wrap="square" lIns="0" tIns="0" rIns="0" bIns="0" rtlCol="0" anchor="ctr"/>
           <a:lstStyle/>
           <a:p>
-            <a:pPr marL="0" indent="0" algn="l">
+            <a:pPr algn="l" indent="0" marL="0">
               <a:buNone/>
             </a:pPr>
             <a:r>
@@ -1396,7 +1707,7 @@
           <a:bodyPr wrap="square" lIns="0" tIns="0" rIns="0" bIns="0" rtlCol="0" anchor="ctr"/>
           <a:lstStyle/>
           <a:p>
-            <a:pPr marL="0" indent="0" algn="l">
+            <a:pPr algn="l" indent="0" marL="0">
               <a:buNone/>
             </a:pPr>
             <a:r>
@@ -1430,7 +1741,6 @@
         <a:solidFill>
           <a:srgbClr val="FFFFFF"/>
         </a:solidFill>
-        <a:effectLst/>
       </p:bgPr>
     </p:bg>
     <p:spTree>
@@ -1468,7 +1778,7 @@
           <a:bodyPr wrap="square" lIns="0" tIns="0" rIns="0" bIns="0" rtlCol="0" anchor="ctr"/>
           <a:lstStyle/>
           <a:p>
-            <a:pPr marL="0" indent="0">
+            <a:pPr indent="0" marL="0">
               <a:buNone/>
             </a:pPr>
             <a:r>
@@ -1507,7 +1817,7 @@
           <a:bodyPr wrap="square" lIns="0" tIns="0" rIns="0" bIns="0" rtlCol="0" anchor="t"/>
           <a:lstStyle/>
           <a:p>
-            <a:pPr marL="342900" indent="-342900" algn="l">
+            <a:pPr algn="l" marL="342900" indent="-342900">
               <a:buSzPct val="100000"/>
               <a:buChar char="•"/>
             </a:pPr>
@@ -1520,8 +1830,28 @@
                 <a:ea typeface="Calibri" pitchFamily="34" charset="-122"/>
                 <a:cs typeface="Calibri" pitchFamily="34" charset="-120"/>
               </a:rPr>
-              <a:t>Traditional remote attestation: did system components boot into a predictable state?</a:t>
-            </a:r>
+              <a:t>Traditional remote attestation: </a:t>
+            </a:r>
+            <a:pPr algn="l" indent="0" marL="0">
+              <a:buNone/>
+            </a:pPr>
+            <a:r>
+              <a:rPr lang="en-US" sz="1700" b="1" dirty="0">
+                <a:solidFill>
+                  <a:srgbClr val="212121"/>
+                </a:solidFill>
+                <a:latin typeface="Calibri" pitchFamily="34" charset="0"/>
+                <a:ea typeface="Calibri" pitchFamily="34" charset="-122"/>
+                <a:cs typeface="Calibri" pitchFamily="34" charset="-120"/>
+              </a:rPr>
+              <a:t>did system components boot into a predictable state?</a:t>
+            </a:r>
+            <a:pPr algn="l" indent="0" marL="0">
+              <a:spcAft>
+                <a:spcPts val="1000"/>
+              </a:spcAft>
+              <a:buNone/>
+            </a:pPr>
             <a:r>
               <a:rPr lang="en-US" sz="1700" dirty="0">
                 <a:solidFill>
@@ -1536,7 +1866,7 @@
             <a:endParaRPr lang="en-US" sz="1700" dirty="0"/>
           </a:p>
           <a:p>
-            <a:pPr marL="342900" indent="-342900" algn="l">
+            <a:pPr algn="l" marL="342900" indent="-342900">
               <a:buSzPct val="100000"/>
               <a:buChar char="•"/>
             </a:pPr>
@@ -1551,6 +1881,9 @@
               </a:rPr>
               <a:t>Layered, runtime attestation: </a:t>
             </a:r>
+            <a:pPr algn="l" indent="0" marL="0">
+              <a:buNone/>
+            </a:pPr>
             <a:r>
               <a:rPr lang="en-US" sz="1700" dirty="0">
                 <a:solidFill>
@@ -1562,6 +1895,12 @@
               </a:rPr>
               <a:t>extend boot-time trust via dynamic measurement of system components </a:t>
             </a:r>
+            <a:pPr algn="l" indent="0" marL="0">
+              <a:spcAft>
+                <a:spcPts val="1000"/>
+              </a:spcAft>
+              <a:buNone/>
+            </a:pPr>
             <a:r>
               <a:rPr lang="en-US" sz="1700" b="1" dirty="0">
                 <a:solidFill>
@@ -1576,7 +1915,7 @@
             <a:endParaRPr lang="en-US" sz="1700" dirty="0"/>
           </a:p>
           <a:p>
-            <a:pPr marL="342900" indent="-342900" algn="l">
+            <a:pPr algn="l" marL="342900" indent="-342900">
               <a:buSzPct val="100000"/>
               <a:buChar char="•"/>
             </a:pPr>
@@ -1591,6 +1930,9 @@
               </a:rPr>
               <a:t>Lifecycle attestation: </a:t>
             </a:r>
+            <a:pPr algn="l" indent="0" marL="0">
+              <a:buNone/>
+            </a:pPr>
             <a:r>
               <a:rPr lang="en-US" sz="1700" dirty="0">
                 <a:solidFill>
@@ -1602,6 +1944,9 @@
               </a:rPr>
               <a:t>extends this notion to </a:t>
             </a:r>
+            <a:pPr algn="l" indent="0" marL="0">
+              <a:buNone/>
+            </a:pPr>
             <a:r>
               <a:rPr lang="en-US" sz="1700" b="1" dirty="0">
                 <a:solidFill>
@@ -1613,6 +1958,12 @@
               </a:rPr>
               <a:t>artifacts of the development lifecycle</a:t>
             </a:r>
+            <a:pPr algn="l" indent="0" marL="0">
+              <a:spcAft>
+                <a:spcPts val="1000"/>
+              </a:spcAft>
+              <a:buNone/>
+            </a:pPr>
             <a:r>
               <a:rPr lang="en-US" sz="1700" dirty="0">
                 <a:solidFill>
@@ -1627,7 +1978,7 @@
             <a:endParaRPr lang="en-US" sz="1700" dirty="0"/>
           </a:p>
           <a:p>
-            <a:pPr marL="685800" lvl="1" indent="-342900" algn="l">
+            <a:pPr algn="l" lvl="1" marL="685800" indent="-342900">
               <a:spcAft>
                 <a:spcPts val="1000"/>
               </a:spcAft>
@@ -1648,7 +1999,7 @@
             <a:endParaRPr lang="en-US" sz="1700" dirty="0"/>
           </a:p>
           <a:p>
-            <a:pPr marL="685800" lvl="1" indent="-342900" algn="l">
+            <a:pPr algn="l" lvl="1" marL="685800" indent="-342900">
               <a:buSzPct val="100000"/>
               <a:buChar char="–"/>
             </a:pPr>
@@ -1663,6 +2014,9 @@
               </a:rPr>
               <a:t>…and to lifecycle </a:t>
             </a:r>
+            <a:pPr algn="l" indent="0" marL="0">
+              <a:buNone/>
+            </a:pPr>
             <a:r>
               <a:rPr lang="en-US" sz="1700" b="1" dirty="0">
                 <a:solidFill>
@@ -1674,6 +2028,12 @@
               </a:rPr>
               <a:t>events</a:t>
             </a:r>
+            <a:pPr algn="l" indent="0" marL="0">
+              <a:spcAft>
+                <a:spcPts val="1000"/>
+              </a:spcAft>
+              <a:buNone/>
+            </a:pPr>
             <a:r>
               <a:rPr lang="en-US" sz="1700" dirty="0">
                 <a:solidFill>
@@ -1688,7 +2048,7 @@
             <a:endParaRPr lang="en-US" sz="1700" dirty="0"/>
           </a:p>
           <a:p>
-            <a:pPr marL="1028700" lvl="2" indent="-342900" algn="l">
+            <a:pPr algn="l" lvl="2" marL="1028700" indent="-342900">
               <a:spcAft>
                 <a:spcPts val="200"/>
               </a:spcAft>
@@ -1709,7 +2069,7 @@
             <a:endParaRPr lang="en-US" sz="1700" dirty="0"/>
           </a:p>
           <a:p>
-            <a:pPr marL="1028700" lvl="2" indent="-342900" algn="l">
+            <a:pPr algn="l" lvl="2" marL="1028700" indent="-342900">
               <a:spcAft>
                 <a:spcPts val="200"/>
               </a:spcAft>
@@ -1730,7 +2090,7 @@
             <a:endParaRPr lang="en-US" sz="1700" dirty="0"/>
           </a:p>
           <a:p>
-            <a:pPr marL="1028700" lvl="2" indent="-342900" algn="l">
+            <a:pPr algn="l" lvl="2" marL="1028700" indent="-342900">
               <a:spcAft>
                 <a:spcPts val="200"/>
               </a:spcAft>
@@ -1751,7 +2111,7 @@
             <a:endParaRPr lang="en-US" sz="1700" dirty="0"/>
           </a:p>
           <a:p>
-            <a:pPr marL="1028700" lvl="2" indent="-342900" algn="l">
+            <a:pPr algn="l" lvl="2" marL="1028700" indent="-342900">
               <a:spcAft>
                 <a:spcPts val="200"/>
               </a:spcAft>
@@ -1772,7 +2132,7 @@
             <a:endParaRPr lang="en-US" sz="1700" dirty="0"/>
           </a:p>
           <a:p>
-            <a:pPr marL="342900" indent="-342900" algn="l">
+            <a:pPr algn="l" marL="342900" indent="-342900">
               <a:buSzPct val="100000"/>
               <a:buChar char="•"/>
             </a:pPr>
@@ -1787,6 +2147,9 @@
               </a:rPr>
               <a:t>Motivation: </a:t>
             </a:r>
+            <a:pPr algn="l" indent="0" marL="0">
+              <a:buNone/>
+            </a:pPr>
             <a:r>
               <a:rPr lang="en-US" sz="1700" dirty="0">
                 <a:solidFill>
@@ -1798,6 +2161,9 @@
               </a:rPr>
               <a:t>the </a:t>
             </a:r>
+            <a:pPr algn="l" indent="0" marL="0">
+              <a:buNone/>
+            </a:pPr>
             <a:r>
               <a:rPr lang="en-US" sz="1700" b="1" dirty="0">
                 <a:solidFill>
@@ -1809,6 +2175,12 @@
               </a:rPr>
               <a:t>proliferation of AI-generated software artifacts</a:t>
             </a:r>
+            <a:pPr algn="l" indent="0" marL="0">
+              <a:spcAft>
+                <a:spcPts val="1000"/>
+              </a:spcAft>
+              <a:buNone/>
+            </a:pPr>
             <a:r>
               <a:rPr lang="en-US" sz="1700" dirty="0">
                 <a:solidFill>
@@ -1845,13 +2217,6 @@
           </a:solidFill>
           <a:ln/>
         </p:spPr>
-        <p:txBody>
-          <a:bodyPr/>
-          <a:lstStyle/>
-          <a:p>
-            <a:endParaRPr lang="en-US"/>
-          </a:p>
-        </p:txBody>
       </p:sp>
       <p:sp>
         <p:nvSpPr>
@@ -1874,7 +2239,7 @@
           <a:bodyPr wrap="square" lIns="0" tIns="0" rIns="0" bIns="0" rtlCol="0" anchor="ctr"/>
           <a:lstStyle/>
           <a:p>
-            <a:pPr marL="0" indent="0" algn="ctr">
+            <a:pPr algn="ctr" indent="0" marL="0">
               <a:spcAft>
                 <a:spcPts val="400"/>
               </a:spcAft>
@@ -1894,7 +2259,7 @@
             <a:endParaRPr lang="en-US" sz="2000" dirty="0"/>
           </a:p>
           <a:p>
-            <a:pPr marL="0" indent="0" algn="ctr">
+            <a:pPr algn="ctr" indent="0" marL="0">
               <a:buNone/>
             </a:pPr>
             <a:r>
@@ -1928,7 +2293,6 @@
         <a:solidFill>
           <a:srgbClr val="FFFFFF"/>
         </a:solidFill>
-        <a:effectLst/>
       </p:bgPr>
     </p:bg>
     <p:spTree>
@@ -1966,7 +2330,7 @@
           <a:bodyPr wrap="square" lIns="0" tIns="0" rIns="0" bIns="0" rtlCol="0" anchor="ctr"/>
           <a:lstStyle/>
           <a:p>
-            <a:pPr marL="0" indent="0">
+            <a:pPr indent="0" marL="0">
               <a:buNone/>
             </a:pPr>
             <a:r>
@@ -2005,13 +2369,6 @@
           </a:solidFill>
           <a:ln/>
         </p:spPr>
-        <p:txBody>
-          <a:bodyPr/>
-          <a:lstStyle/>
-          <a:p>
-            <a:endParaRPr lang="en-US"/>
-          </a:p>
-        </p:txBody>
       </p:sp>
       <p:sp>
         <p:nvSpPr>
@@ -2034,7 +2391,7 @@
           <a:bodyPr wrap="square" lIns="254" tIns="254" rIns="254" bIns="254" rtlCol="0" anchor="ctr"/>
           <a:lstStyle/>
           <a:p>
-            <a:pPr marL="0" indent="0" algn="ctr">
+            <a:pPr algn="ctr" indent="0" marL="0">
               <a:buNone/>
             </a:pPr>
             <a:r>
@@ -2073,7 +2430,7 @@
           <a:bodyPr wrap="square" lIns="0" tIns="0" rIns="0" bIns="0" rtlCol="0" anchor="ctr"/>
           <a:lstStyle/>
           <a:p>
-            <a:pPr marL="0" indent="0" algn="ctr">
+            <a:pPr algn="ctr" indent="0" marL="0">
               <a:buNone/>
             </a:pPr>
             <a:r>
@@ -2112,13 +2469,6 @@
           </a:solidFill>
           <a:ln/>
         </p:spPr>
-        <p:txBody>
-          <a:bodyPr/>
-          <a:lstStyle/>
-          <a:p>
-            <a:endParaRPr lang="en-US"/>
-          </a:p>
-        </p:txBody>
       </p:sp>
       <p:sp>
         <p:nvSpPr>
@@ -2141,7 +2491,7 @@
           <a:bodyPr wrap="square" lIns="254" tIns="254" rIns="254" bIns="254" rtlCol="0" anchor="ctr"/>
           <a:lstStyle/>
           <a:p>
-            <a:pPr marL="0" indent="0" algn="ctr">
+            <a:pPr algn="ctr" indent="0" marL="0">
               <a:buNone/>
             </a:pPr>
             <a:r>
@@ -2158,7 +2508,7 @@
             <a:endParaRPr lang="en-US" sz="1350" dirty="0"/>
           </a:p>
           <a:p>
-            <a:pPr marL="0" indent="0" algn="ctr">
+            <a:pPr algn="ctr" indent="0" marL="0">
               <a:buNone/>
             </a:pPr>
             <a:r>
@@ -2197,7 +2547,7 @@
           <a:bodyPr wrap="square" lIns="0" tIns="0" rIns="0" bIns="0" rtlCol="0" anchor="ctr"/>
           <a:lstStyle/>
           <a:p>
-            <a:pPr marL="0" indent="0" algn="ctr">
+            <a:pPr algn="ctr" indent="0" marL="0">
               <a:buNone/>
             </a:pPr>
             <a:r>
@@ -2236,13 +2586,6 @@
           </a:solidFill>
           <a:ln/>
         </p:spPr>
-        <p:txBody>
-          <a:bodyPr/>
-          <a:lstStyle/>
-          <a:p>
-            <a:endParaRPr lang="en-US"/>
-          </a:p>
-        </p:txBody>
       </p:sp>
       <p:sp>
         <p:nvSpPr>
@@ -2265,7 +2608,7 @@
           <a:bodyPr wrap="square" lIns="254" tIns="254" rIns="254" bIns="254" rtlCol="0" anchor="ctr"/>
           <a:lstStyle/>
           <a:p>
-            <a:pPr marL="0" indent="0" algn="ctr">
+            <a:pPr algn="ctr" indent="0" marL="0">
               <a:buNone/>
             </a:pPr>
             <a:r>
@@ -2304,7 +2647,7 @@
           <a:bodyPr wrap="square" lIns="0" tIns="0" rIns="0" bIns="0" rtlCol="0" anchor="ctr"/>
           <a:lstStyle/>
           <a:p>
-            <a:pPr marL="0" indent="0" algn="ctr">
+            <a:pPr algn="ctr" indent="0" marL="0">
               <a:buNone/>
             </a:pPr>
             <a:r>
@@ -2343,13 +2686,6 @@
           </a:solidFill>
           <a:ln/>
         </p:spPr>
-        <p:txBody>
-          <a:bodyPr/>
-          <a:lstStyle/>
-          <a:p>
-            <a:endParaRPr lang="en-US"/>
-          </a:p>
-        </p:txBody>
       </p:sp>
       <p:sp>
         <p:nvSpPr>
@@ -2372,7 +2708,7 @@
           <a:bodyPr wrap="square" lIns="254" tIns="254" rIns="254" bIns="254" rtlCol="0" anchor="ctr"/>
           <a:lstStyle/>
           <a:p>
-            <a:pPr marL="0" indent="0" algn="ctr">
+            <a:pPr algn="ctr" indent="0" marL="0">
               <a:buNone/>
             </a:pPr>
             <a:r>
@@ -2411,7 +2747,7 @@
           <a:bodyPr wrap="square" lIns="0" tIns="0" rIns="0" bIns="0" rtlCol="0" anchor="ctr"/>
           <a:lstStyle/>
           <a:p>
-            <a:pPr marL="0" indent="0" algn="ctr">
+            <a:pPr algn="ctr" indent="0" marL="0">
               <a:buNone/>
             </a:pPr>
             <a:r>
@@ -2450,13 +2786,6 @@
           </a:solidFill>
           <a:ln/>
         </p:spPr>
-        <p:txBody>
-          <a:bodyPr/>
-          <a:lstStyle/>
-          <a:p>
-            <a:endParaRPr lang="en-US"/>
-          </a:p>
-        </p:txBody>
       </p:sp>
       <p:sp>
         <p:nvSpPr>
@@ -2479,7 +2808,7 @@
           <a:bodyPr wrap="square" lIns="254" tIns="254" rIns="254" bIns="254" rtlCol="0" anchor="ctr"/>
           <a:lstStyle/>
           <a:p>
-            <a:pPr marL="0" indent="0" algn="ctr">
+            <a:pPr algn="ctr" indent="0" marL="0">
               <a:buNone/>
             </a:pPr>
             <a:r>
@@ -2518,7 +2847,7 @@
           <a:bodyPr wrap="square" lIns="0" tIns="0" rIns="0" bIns="0" rtlCol="0" anchor="ctr"/>
           <a:lstStyle/>
           <a:p>
-            <a:pPr marL="0" indent="0">
+            <a:pPr indent="0" marL="0">
               <a:buNone/>
             </a:pPr>
             <a:r>
@@ -2552,7 +2881,6 @@
         <a:solidFill>
           <a:srgbClr val="FFFFFF"/>
         </a:solidFill>
-        <a:effectLst/>
       </p:bgPr>
     </p:bg>
     <p:spTree>
@@ -2590,7 +2918,7 @@
           <a:bodyPr wrap="square" lIns="0" tIns="0" rIns="0" bIns="0" rtlCol="0" anchor="ctr"/>
           <a:lstStyle/>
           <a:p>
-            <a:pPr marL="0" indent="0">
+            <a:pPr indent="0" marL="0">
               <a:buNone/>
             </a:pPr>
             <a:r>
@@ -2629,13 +2957,6 @@
           </a:solidFill>
           <a:ln/>
         </p:spPr>
-        <p:txBody>
-          <a:bodyPr/>
-          <a:lstStyle/>
-          <a:p>
-            <a:endParaRPr lang="en-US"/>
-          </a:p>
-        </p:txBody>
       </p:sp>
       <p:sp>
         <p:nvSpPr>
@@ -2658,7 +2979,7 @@
           <a:bodyPr wrap="square" lIns="0" tIns="0" rIns="0" bIns="0" rtlCol="0" anchor="ctr"/>
           <a:lstStyle/>
           <a:p>
-            <a:pPr marL="0" indent="0" algn="l">
+            <a:pPr algn="l" indent="0" marL="0">
               <a:spcAft>
                 <a:spcPts val="200"/>
               </a:spcAft>
@@ -2678,7 +2999,7 @@
             <a:endParaRPr lang="en-US" sz="1700" dirty="0"/>
           </a:p>
           <a:p>
-            <a:pPr marL="0" indent="0" algn="l">
+            <a:pPr algn="l" indent="0" marL="0">
               <a:buNone/>
             </a:pPr>
             <a:r>
@@ -2717,7 +3038,7 @@
           <a:bodyPr wrap="square" lIns="0" tIns="0" rIns="0" bIns="0" rtlCol="0" anchor="ctr"/>
           <a:lstStyle/>
           <a:p>
-            <a:pPr marL="0" indent="0" algn="ctr">
+            <a:pPr algn="ctr" indent="0" marL="0">
               <a:buNone/>
             </a:pPr>
             <a:r>
@@ -2753,13 +3074,6 @@
           </a:solidFill>
           <a:ln/>
         </p:spPr>
-        <p:txBody>
-          <a:bodyPr/>
-          <a:lstStyle/>
-          <a:p>
-            <a:endParaRPr lang="en-US"/>
-          </a:p>
-        </p:txBody>
       </p:sp>
       <p:sp>
         <p:nvSpPr>
@@ -2782,7 +3096,7 @@
           <a:bodyPr wrap="square" lIns="0" tIns="0" rIns="0" bIns="0" rtlCol="0" anchor="ctr"/>
           <a:lstStyle/>
           <a:p>
-            <a:pPr marL="0" indent="0" algn="l">
+            <a:pPr algn="l" indent="0" marL="0">
               <a:spcAft>
                 <a:spcPts val="200"/>
               </a:spcAft>
@@ -2802,7 +3116,7 @@
             <a:endParaRPr lang="en-US" sz="1700" dirty="0"/>
           </a:p>
           <a:p>
-            <a:pPr marL="0" indent="0" algn="l">
+            <a:pPr algn="l" indent="0" marL="0">
               <a:buNone/>
             </a:pPr>
             <a:r>
@@ -2841,7 +3155,7 @@
           <a:bodyPr wrap="square" lIns="0" tIns="0" rIns="0" bIns="0" rtlCol="0" anchor="ctr"/>
           <a:lstStyle/>
           <a:p>
-            <a:pPr marL="0" indent="0" algn="ctr">
+            <a:pPr algn="ctr" indent="0" marL="0">
               <a:buNone/>
             </a:pPr>
             <a:r>
@@ -2877,13 +3191,6 @@
           </a:solidFill>
           <a:ln/>
         </p:spPr>
-        <p:txBody>
-          <a:bodyPr/>
-          <a:lstStyle/>
-          <a:p>
-            <a:endParaRPr lang="en-US"/>
-          </a:p>
-        </p:txBody>
       </p:sp>
       <p:sp>
         <p:nvSpPr>
@@ -2906,7 +3213,7 @@
           <a:bodyPr wrap="square" lIns="0" tIns="0" rIns="0" bIns="0" rtlCol="0" anchor="ctr"/>
           <a:lstStyle/>
           <a:p>
-            <a:pPr marL="0" indent="0" algn="l">
+            <a:pPr algn="l" indent="0" marL="0">
               <a:spcAft>
                 <a:spcPts val="200"/>
               </a:spcAft>
@@ -2926,7 +3233,7 @@
             <a:endParaRPr lang="en-US" sz="1700" dirty="0"/>
           </a:p>
           <a:p>
-            <a:pPr marL="0" indent="0" algn="l">
+            <a:pPr algn="l" indent="0" marL="0">
               <a:buNone/>
             </a:pPr>
             <a:r>
@@ -2965,7 +3272,7 @@
           <a:bodyPr wrap="square" lIns="0" tIns="0" rIns="0" bIns="0" rtlCol="0" anchor="ctr"/>
           <a:lstStyle/>
           <a:p>
-            <a:pPr marL="0" indent="0" algn="ctr">
+            <a:pPr algn="ctr" indent="0" marL="0">
               <a:buNone/>
             </a:pPr>
             <a:r>
@@ -3001,13 +3308,6 @@
           </a:solidFill>
           <a:ln/>
         </p:spPr>
-        <p:txBody>
-          <a:bodyPr/>
-          <a:lstStyle/>
-          <a:p>
-            <a:endParaRPr lang="en-US"/>
-          </a:p>
-        </p:txBody>
       </p:sp>
       <p:sp>
         <p:nvSpPr>
@@ -3030,7 +3330,7 @@
           <a:bodyPr wrap="square" lIns="0" tIns="0" rIns="0" bIns="0" rtlCol="0" anchor="ctr"/>
           <a:lstStyle/>
           <a:p>
-            <a:pPr marL="0" indent="0" algn="l">
+            <a:pPr algn="l" indent="0" marL="0">
               <a:buNone/>
             </a:pPr>
             <a:r>
@@ -3044,6 +3344,9 @@
               </a:rPr>
               <a:t>signed evidence bundles</a:t>
             </a:r>
+            <a:pPr algn="l" indent="0" marL="0">
+              <a:buNone/>
+            </a:pPr>
             <a:r>
               <a:rPr lang="en-US" sz="1500" dirty="0">
                 <a:solidFill>
@@ -3055,6 +3358,9 @@
               </a:rPr>
               <a:t>, appraised against </a:t>
             </a:r>
+            <a:pPr algn="l" indent="0" marL="0">
+              <a:buNone/>
+            </a:pPr>
             <a:r>
               <a:rPr lang="en-US" sz="1500" b="1" dirty="0">
                 <a:solidFill>
@@ -3091,7 +3397,7 @@
           <a:bodyPr wrap="square" lIns="0" tIns="0" rIns="0" bIns="0" rtlCol="0" anchor="ctr"/>
           <a:lstStyle/>
           <a:p>
-            <a:pPr marL="0" indent="0">
+            <a:pPr indent="0" marL="0">
               <a:buNone/>
             </a:pPr>
             <a:r>
@@ -3135,13 +3441,6 @@
             <a:prstDash val="solid"/>
           </a:ln>
         </p:spPr>
-        <p:txBody>
-          <a:bodyPr/>
-          <a:lstStyle/>
-          <a:p>
-            <a:endParaRPr lang="en-US"/>
-          </a:p>
-        </p:txBody>
       </p:sp>
       <p:sp>
         <p:nvSpPr>
@@ -3164,7 +3463,7 @@
           <a:bodyPr wrap="square" lIns="0" tIns="0" rIns="0" bIns="0" rtlCol="0" anchor="ctr"/>
           <a:lstStyle/>
           <a:p>
-            <a:pPr marL="0" indent="0" algn="l">
+            <a:pPr algn="l" indent="0" marL="0">
               <a:buNone/>
             </a:pPr>
             <a:r>
@@ -3181,7 +3480,7 @@
             <a:endParaRPr lang="en-US" sz="1300" dirty="0"/>
           </a:p>
           <a:p>
-            <a:pPr marL="0" indent="0" algn="l">
+            <a:pPr algn="l" indent="0" marL="0">
               <a:buNone/>
             </a:pPr>
             <a:r>
@@ -3198,7 +3497,7 @@
             <a:endParaRPr lang="en-US" sz="1300" dirty="0"/>
           </a:p>
           <a:p>
-            <a:pPr marL="0" indent="0" algn="l">
+            <a:pPr algn="l" indent="0" marL="0">
               <a:buNone/>
             </a:pPr>
             <a:r>
@@ -3215,7 +3514,7 @@
             <a:endParaRPr lang="en-US" sz="1300" dirty="0"/>
           </a:p>
           <a:p>
-            <a:pPr marL="0" indent="0" algn="l">
+            <a:pPr algn="l" indent="0" marL="0">
               <a:buNone/>
             </a:pPr>
             <a:r>
@@ -3232,7 +3531,7 @@
             <a:endParaRPr lang="en-US" sz="1300" dirty="0"/>
           </a:p>
           <a:p>
-            <a:pPr marL="0" indent="0" algn="l">
+            <a:pPr algn="l" indent="0" marL="0">
               <a:buNone/>
             </a:pPr>
             <a:r>
@@ -3249,7 +3548,7 @@
             <a:endParaRPr lang="en-US" sz="1300" dirty="0"/>
           </a:p>
           <a:p>
-            <a:pPr marL="0" indent="0" algn="l">
+            <a:pPr algn="l" indent="0" marL="0">
               <a:buNone/>
             </a:pPr>
             <a:r>
@@ -3288,7 +3587,7 @@
           <a:bodyPr wrap="square" lIns="0" tIns="0" rIns="0" bIns="0" rtlCol="0" anchor="ctr"/>
           <a:lstStyle/>
           <a:p>
-            <a:pPr marL="0" indent="0">
+            <a:pPr indent="0" marL="0">
               <a:buNone/>
             </a:pPr>
             <a:r>
@@ -3305,7 +3604,7 @@
             <a:endParaRPr lang="en-US" sz="2000" dirty="0"/>
           </a:p>
           <a:p>
-            <a:pPr marL="0" indent="0">
+            <a:pPr indent="0" marL="0">
               <a:buNone/>
             </a:pPr>
             <a:r>
@@ -3322,7 +3621,7 @@
             <a:endParaRPr lang="en-US" sz="2000" dirty="0"/>
           </a:p>
           <a:p>
-            <a:pPr marL="0" indent="0">
+            <a:pPr indent="0" marL="0">
               <a:buNone/>
             </a:pPr>
             <a:r>
@@ -3356,7 +3655,6 @@
         <a:solidFill>
           <a:srgbClr val="FFFFFF"/>
         </a:solidFill>
-        <a:effectLst/>
       </p:bgPr>
     </p:bg>
     <p:spTree>
@@ -3394,7 +3692,7 @@
           <a:bodyPr wrap="square" lIns="0" tIns="0" rIns="0" bIns="0" rtlCol="0" anchor="ctr"/>
           <a:lstStyle/>
           <a:p>
-            <a:pPr marL="0" indent="0">
+            <a:pPr indent="0" marL="0">
               <a:buNone/>
             </a:pPr>
             <a:r>
@@ -3438,13 +3736,6 @@
             <a:prstDash val="dash"/>
           </a:ln>
         </p:spPr>
-        <p:txBody>
-          <a:bodyPr/>
-          <a:lstStyle/>
-          <a:p>
-            <a:endParaRPr lang="en-US"/>
-          </a:p>
-        </p:txBody>
       </p:sp>
       <p:sp>
         <p:nvSpPr>
@@ -3467,7 +3758,7 @@
           <a:bodyPr wrap="square" lIns="254" tIns="254" rIns="254" bIns="254" rtlCol="0" anchor="ctr"/>
           <a:lstStyle/>
           <a:p>
-            <a:pPr marL="0" indent="0" algn="ctr">
+            <a:pPr algn="ctr" indent="0" marL="0">
               <a:buNone/>
             </a:pPr>
             <a:r>
@@ -3484,7 +3775,7 @@
             <a:endParaRPr lang="en-US" sz="1150" dirty="0"/>
           </a:p>
           <a:p>
-            <a:pPr marL="0" indent="0" algn="ctr">
+            <a:pPr algn="ctr" indent="0" marL="0">
               <a:buNone/>
             </a:pPr>
             <a:r>
@@ -3525,13 +3816,6 @@
             <a:tailEnd type="triangle"/>
           </a:ln>
         </p:spPr>
-        <p:txBody>
-          <a:bodyPr/>
-          <a:lstStyle/>
-          <a:p>
-            <a:endParaRPr lang="en-US"/>
-          </a:p>
-        </p:txBody>
       </p:sp>
       <p:sp>
         <p:nvSpPr>
@@ -3554,7 +3838,7 @@
           <a:bodyPr wrap="square" lIns="0" tIns="0" rIns="0" bIns="0" rtlCol="0" anchor="ctr"/>
           <a:lstStyle/>
           <a:p>
-            <a:pPr marL="0" indent="0" algn="l">
+            <a:pPr algn="l" indent="0" marL="0">
               <a:buNone/>
             </a:pPr>
             <a:r>
@@ -3593,13 +3877,6 @@
           </a:solidFill>
           <a:ln/>
         </p:spPr>
-        <p:txBody>
-          <a:bodyPr/>
-          <a:lstStyle/>
-          <a:p>
-            <a:endParaRPr lang="en-US"/>
-          </a:p>
-        </p:txBody>
       </p:sp>
       <p:sp>
         <p:nvSpPr>
@@ -3622,7 +3899,7 @@
           <a:bodyPr wrap="square" lIns="381" tIns="381" rIns="381" bIns="381" rtlCol="0" anchor="ctr"/>
           <a:lstStyle/>
           <a:p>
-            <a:pPr marL="0" indent="0" algn="ctr">
+            <a:pPr algn="ctr" indent="0" marL="0">
               <a:buNone/>
             </a:pPr>
             <a:r>
@@ -3663,13 +3940,6 @@
             <a:tailEnd type="triangle"/>
           </a:ln>
         </p:spPr>
-        <p:txBody>
-          <a:bodyPr/>
-          <a:lstStyle/>
-          <a:p>
-            <a:endParaRPr lang="en-US"/>
-          </a:p>
-        </p:txBody>
       </p:sp>
       <p:sp>
         <p:nvSpPr>
@@ -3692,7 +3962,7 @@
           <a:bodyPr wrap="square" lIns="0" tIns="0" rIns="0" bIns="0" rtlCol="0" anchor="ctr"/>
           <a:lstStyle/>
           <a:p>
-            <a:pPr marL="0" indent="0" algn="l">
+            <a:pPr algn="l" indent="0" marL="0">
               <a:buNone/>
             </a:pPr>
             <a:r>
@@ -3731,13 +4001,6 @@
           </a:solidFill>
           <a:ln/>
         </p:spPr>
-        <p:txBody>
-          <a:bodyPr/>
-          <a:lstStyle/>
-          <a:p>
-            <a:endParaRPr lang="en-US"/>
-          </a:p>
-        </p:txBody>
       </p:sp>
       <p:sp>
         <p:nvSpPr>
@@ -3760,7 +4023,7 @@
           <a:bodyPr wrap="square" lIns="381" tIns="381" rIns="381" bIns="381" rtlCol="0" anchor="ctr"/>
           <a:lstStyle/>
           <a:p>
-            <a:pPr marL="0" indent="0" algn="ctr">
+            <a:pPr algn="ctr" indent="0" marL="0">
               <a:buNone/>
             </a:pPr>
             <a:r>
@@ -3799,13 +4062,6 @@
           </a:solidFill>
           <a:ln/>
         </p:spPr>
-        <p:txBody>
-          <a:bodyPr/>
-          <a:lstStyle/>
-          <a:p>
-            <a:endParaRPr lang="en-US"/>
-          </a:p>
-        </p:txBody>
       </p:sp>
       <p:sp>
         <p:nvSpPr>
@@ -3828,7 +4084,7 @@
           <a:bodyPr wrap="square" lIns="381" tIns="381" rIns="381" bIns="381" rtlCol="0" anchor="ctr"/>
           <a:lstStyle/>
           <a:p>
-            <a:pPr marL="0" indent="0" algn="ctr">
+            <a:pPr algn="ctr" indent="0" marL="0">
               <a:buNone/>
             </a:pPr>
             <a:r>
@@ -3867,13 +4123,6 @@
           </a:solidFill>
           <a:ln/>
         </p:spPr>
-        <p:txBody>
-          <a:bodyPr/>
-          <a:lstStyle/>
-          <a:p>
-            <a:endParaRPr lang="en-US"/>
-          </a:p>
-        </p:txBody>
       </p:sp>
       <p:sp>
         <p:nvSpPr>
@@ -3896,7 +4145,7 @@
           <a:bodyPr wrap="square" lIns="381" tIns="381" rIns="381" bIns="381" rtlCol="0" anchor="ctr"/>
           <a:lstStyle/>
           <a:p>
-            <a:pPr marL="0" indent="0" algn="ctr">
+            <a:pPr algn="ctr" indent="0" marL="0">
               <a:buNone/>
             </a:pPr>
             <a:r>
@@ -3937,13 +4186,6 @@
             <a:tailEnd type="triangle"/>
           </a:ln>
         </p:spPr>
-        <p:txBody>
-          <a:bodyPr/>
-          <a:lstStyle/>
-          <a:p>
-            <a:endParaRPr lang="en-US"/>
-          </a:p>
-        </p:txBody>
       </p:sp>
       <p:sp>
         <p:nvSpPr>
@@ -3967,13 +4209,6 @@
             <a:prstDash val="solid"/>
           </a:ln>
         </p:spPr>
-        <p:txBody>
-          <a:bodyPr/>
-          <a:lstStyle/>
-          <a:p>
-            <a:endParaRPr lang="en-US"/>
-          </a:p>
-        </p:txBody>
       </p:sp>
       <p:sp>
         <p:nvSpPr>
@@ -3997,13 +4232,6 @@
             <a:prstDash val="solid"/>
           </a:ln>
         </p:spPr>
-        <p:txBody>
-          <a:bodyPr/>
-          <a:lstStyle/>
-          <a:p>
-            <a:endParaRPr lang="en-US"/>
-          </a:p>
-        </p:txBody>
       </p:sp>
       <p:sp>
         <p:nvSpPr>
@@ -4028,13 +4256,6 @@
             <a:tailEnd type="triangle"/>
           </a:ln>
         </p:spPr>
-        <p:txBody>
-          <a:bodyPr/>
-          <a:lstStyle/>
-          <a:p>
-            <a:endParaRPr lang="en-US"/>
-          </a:p>
-        </p:txBody>
       </p:sp>
       <p:sp>
         <p:nvSpPr>
@@ -4057,7 +4278,7 @@
           <a:bodyPr wrap="square" lIns="0" tIns="0" rIns="0" bIns="0" rtlCol="0" anchor="ctr"/>
           <a:lstStyle/>
           <a:p>
-            <a:pPr marL="0" indent="0" algn="r">
+            <a:pPr algn="r" indent="0" marL="0">
               <a:buNone/>
             </a:pPr>
             <a:r>
@@ -4074,7 +4295,7 @@
             <a:endParaRPr lang="en-US" sz="1000" dirty="0"/>
           </a:p>
           <a:p>
-            <a:pPr marL="0" indent="0" algn="r">
+            <a:pPr algn="r" indent="0" marL="0">
               <a:buNone/>
             </a:pPr>
             <a:r>
@@ -4114,13 +4335,6 @@
             <a:prstDash val="solid"/>
           </a:ln>
         </p:spPr>
-        <p:txBody>
-          <a:bodyPr/>
-          <a:lstStyle/>
-          <a:p>
-            <a:endParaRPr lang="en-US"/>
-          </a:p>
-        </p:txBody>
       </p:sp>
       <p:sp>
         <p:nvSpPr>
@@ -4145,13 +4359,6 @@
             <a:tailEnd type="triangle"/>
           </a:ln>
         </p:spPr>
-        <p:txBody>
-          <a:bodyPr/>
-          <a:lstStyle/>
-          <a:p>
-            <a:endParaRPr lang="en-US"/>
-          </a:p>
-        </p:txBody>
       </p:sp>
       <p:sp>
         <p:nvSpPr>
@@ -4174,7 +4381,7 @@
           <a:bodyPr wrap="square" lIns="0" tIns="0" rIns="0" bIns="0" rtlCol="0" anchor="ctr"/>
           <a:lstStyle/>
           <a:p>
-            <a:pPr marL="0" indent="0" algn="ctr">
+            <a:pPr algn="ctr" indent="0" marL="0">
               <a:buNone/>
             </a:pPr>
             <a:r>
@@ -4213,13 +4420,6 @@
           </a:solidFill>
           <a:ln/>
         </p:spPr>
-        <p:txBody>
-          <a:bodyPr/>
-          <a:lstStyle/>
-          <a:p>
-            <a:endParaRPr lang="en-US"/>
-          </a:p>
-        </p:txBody>
       </p:sp>
       <p:sp>
         <p:nvSpPr>
@@ -4242,7 +4442,7 @@
           <a:bodyPr wrap="square" lIns="381" tIns="381" rIns="381" bIns="381" rtlCol="0" anchor="ctr"/>
           <a:lstStyle/>
           <a:p>
-            <a:pPr marL="0" indent="0" algn="ctr">
+            <a:pPr algn="ctr" indent="0" marL="0">
               <a:buNone/>
             </a:pPr>
             <a:r>
@@ -4259,7 +4459,7 @@
             <a:endParaRPr lang="en-US" sz="1200" dirty="0"/>
           </a:p>
           <a:p>
-            <a:pPr marL="0" indent="0" algn="ctr">
+            <a:pPr algn="ctr" indent="0" marL="0">
               <a:buNone/>
             </a:pPr>
             <a:r>
@@ -4300,13 +4500,6 @@
             <a:tailEnd type="triangle"/>
           </a:ln>
         </p:spPr>
-        <p:txBody>
-          <a:bodyPr/>
-          <a:lstStyle/>
-          <a:p>
-            <a:endParaRPr lang="en-US"/>
-          </a:p>
-        </p:txBody>
       </p:sp>
       <p:sp>
         <p:nvSpPr>
@@ -4329,7 +4522,7 @@
           <a:bodyPr wrap="square" lIns="0" tIns="0" rIns="0" bIns="0" rtlCol="0" anchor="ctr"/>
           <a:lstStyle/>
           <a:p>
-            <a:pPr marL="0" indent="0" algn="ctr">
+            <a:pPr algn="ctr" indent="0" marL="0">
               <a:buNone/>
             </a:pPr>
             <a:r>
@@ -4368,13 +4561,6 @@
           </a:solidFill>
           <a:ln/>
         </p:spPr>
-        <p:txBody>
-          <a:bodyPr/>
-          <a:lstStyle/>
-          <a:p>
-            <a:endParaRPr lang="en-US"/>
-          </a:p>
-        </p:txBody>
       </p:sp>
       <p:sp>
         <p:nvSpPr>
@@ -4397,7 +4583,7 @@
           <a:bodyPr wrap="square" lIns="381" tIns="381" rIns="381" bIns="381" rtlCol="0" anchor="ctr"/>
           <a:lstStyle/>
           <a:p>
-            <a:pPr marL="0" indent="0" algn="ctr">
+            <a:pPr algn="ctr" indent="0" marL="0">
               <a:buNone/>
             </a:pPr>
             <a:r>
@@ -4438,13 +4624,6 @@
             <a:tailEnd type="triangle"/>
           </a:ln>
         </p:spPr>
-        <p:txBody>
-          <a:bodyPr/>
-          <a:lstStyle/>
-          <a:p>
-            <a:endParaRPr lang="en-US"/>
-          </a:p>
-        </p:txBody>
       </p:sp>
       <p:sp>
         <p:nvSpPr>
@@ -4467,13 +4646,6 @@
           </a:solidFill>
           <a:ln/>
         </p:spPr>
-        <p:txBody>
-          <a:bodyPr/>
-          <a:lstStyle/>
-          <a:p>
-            <a:endParaRPr lang="en-US"/>
-          </a:p>
-        </p:txBody>
       </p:sp>
       <p:sp>
         <p:nvSpPr>
@@ -4496,7 +4668,7 @@
           <a:bodyPr wrap="square" lIns="381" tIns="381" rIns="381" bIns="381" rtlCol="0" anchor="ctr"/>
           <a:lstStyle/>
           <a:p>
-            <a:pPr marL="0" indent="0" algn="ctr">
+            <a:pPr algn="ctr" indent="0" marL="0">
               <a:buNone/>
             </a:pPr>
             <a:r>
@@ -4537,13 +4709,6 @@
             <a:tailEnd type="triangle"/>
           </a:ln>
         </p:spPr>
-        <p:txBody>
-          <a:bodyPr/>
-          <a:lstStyle/>
-          <a:p>
-            <a:endParaRPr lang="en-US"/>
-          </a:p>
-        </p:txBody>
       </p:sp>
       <p:sp>
         <p:nvSpPr>
@@ -4566,13 +4731,6 @@
           </a:solidFill>
           <a:ln/>
         </p:spPr>
-        <p:txBody>
-          <a:bodyPr/>
-          <a:lstStyle/>
-          <a:p>
-            <a:endParaRPr lang="en-US"/>
-          </a:p>
-        </p:txBody>
       </p:sp>
       <p:sp>
         <p:nvSpPr>
@@ -4595,7 +4753,7 @@
           <a:bodyPr wrap="square" lIns="381" tIns="381" rIns="381" bIns="381" rtlCol="0" anchor="ctr"/>
           <a:lstStyle/>
           <a:p>
-            <a:pPr marL="0" indent="0" algn="ctr">
+            <a:pPr algn="ctr" indent="0" marL="0">
               <a:buNone/>
             </a:pPr>
             <a:r>
@@ -4634,7 +4792,7 @@
           <a:bodyPr wrap="square" lIns="0" tIns="0" rIns="0" bIns="0" rtlCol="0" anchor="ctr"/>
           <a:lstStyle/>
           <a:p>
-            <a:pPr marL="0" indent="0" algn="ctr">
+            <a:pPr algn="ctr" indent="0" marL="0">
               <a:buNone/>
             </a:pPr>
             <a:r>
@@ -4674,13 +4832,6 @@
             <a:prstDash val="solid"/>
           </a:ln>
         </p:spPr>
-        <p:txBody>
-          <a:bodyPr/>
-          <a:lstStyle/>
-          <a:p>
-            <a:endParaRPr lang="en-US"/>
-          </a:p>
-        </p:txBody>
       </p:sp>
       <p:sp>
         <p:nvSpPr>
@@ -4704,13 +4855,6 @@
             <a:prstDash val="solid"/>
           </a:ln>
         </p:spPr>
-        <p:txBody>
-          <a:bodyPr/>
-          <a:lstStyle/>
-          <a:p>
-            <a:endParaRPr lang="en-US"/>
-          </a:p>
-        </p:txBody>
       </p:sp>
       <p:sp>
         <p:nvSpPr>
@@ -4734,13 +4878,6 @@
             <a:prstDash val="solid"/>
           </a:ln>
         </p:spPr>
-        <p:txBody>
-          <a:bodyPr/>
-          <a:lstStyle/>
-          <a:p>
-            <a:endParaRPr lang="en-US"/>
-          </a:p>
-        </p:txBody>
       </p:sp>
       <p:sp>
         <p:nvSpPr>
@@ -4764,13 +4901,6 @@
             <a:prstDash val="solid"/>
           </a:ln>
         </p:spPr>
-        <p:txBody>
-          <a:bodyPr/>
-          <a:lstStyle/>
-          <a:p>
-            <a:endParaRPr lang="en-US"/>
-          </a:p>
-        </p:txBody>
       </p:sp>
       <p:sp>
         <p:nvSpPr>
@@ -4795,13 +4925,6 @@
             <a:tailEnd type="triangle"/>
           </a:ln>
         </p:spPr>
-        <p:txBody>
-          <a:bodyPr/>
-          <a:lstStyle/>
-          <a:p>
-            <a:endParaRPr lang="en-US"/>
-          </a:p>
-        </p:txBody>
       </p:sp>
       <p:sp>
         <p:nvSpPr>
@@ -4824,7 +4947,7 @@
           <a:bodyPr wrap="square" lIns="0" tIns="0" rIns="0" bIns="0" rtlCol="0" anchor="ctr"/>
           <a:lstStyle/>
           <a:p>
-            <a:pPr marL="0" indent="0" algn="ctr">
+            <a:pPr algn="ctr" indent="0" marL="0">
               <a:buNone/>
             </a:pPr>
             <a:r>
@@ -4864,13 +4987,6 @@
             <a:prstDash val="solid"/>
           </a:ln>
         </p:spPr>
-        <p:txBody>
-          <a:bodyPr/>
-          <a:lstStyle/>
-          <a:p>
-            <a:endParaRPr lang="en-US"/>
-          </a:p>
-        </p:txBody>
       </p:sp>
       <p:sp>
         <p:nvSpPr>
@@ -4894,13 +5010,6 @@
             <a:prstDash val="solid"/>
           </a:ln>
         </p:spPr>
-        <p:txBody>
-          <a:bodyPr/>
-          <a:lstStyle/>
-          <a:p>
-            <a:endParaRPr lang="en-US"/>
-          </a:p>
-        </p:txBody>
       </p:sp>
       <p:sp>
         <p:nvSpPr>
@@ -4925,13 +5034,6 @@
             <a:tailEnd type="triangle"/>
           </a:ln>
         </p:spPr>
-        <p:txBody>
-          <a:bodyPr/>
-          <a:lstStyle/>
-          <a:p>
-            <a:endParaRPr lang="en-US"/>
-          </a:p>
-        </p:txBody>
       </p:sp>
       <p:sp>
         <p:nvSpPr>
@@ -4954,7 +5056,7 @@
           <a:bodyPr wrap="square" lIns="0" tIns="0" rIns="0" bIns="0" rtlCol="0" anchor="ctr"/>
           <a:lstStyle/>
           <a:p>
-            <a:pPr marL="0" indent="0" algn="ctr">
+            <a:pPr algn="ctr" indent="0" marL="0">
               <a:buNone/>
             </a:pPr>
             <a:r>
@@ -4994,13 +5096,6 @@
             <a:prstDash val="solid"/>
           </a:ln>
         </p:spPr>
-        <p:txBody>
-          <a:bodyPr/>
-          <a:lstStyle/>
-          <a:p>
-            <a:endParaRPr lang="en-US"/>
-          </a:p>
-        </p:txBody>
       </p:sp>
       <p:sp>
         <p:nvSpPr>
@@ -5024,13 +5119,6 @@
             <a:prstDash val="solid"/>
           </a:ln>
         </p:spPr>
-        <p:txBody>
-          <a:bodyPr/>
-          <a:lstStyle/>
-          <a:p>
-            <a:endParaRPr lang="en-US"/>
-          </a:p>
-        </p:txBody>
       </p:sp>
       <p:sp>
         <p:nvSpPr>
@@ -5055,13 +5143,6 @@
             <a:tailEnd type="triangle"/>
           </a:ln>
         </p:spPr>
-        <p:txBody>
-          <a:bodyPr/>
-          <a:lstStyle/>
-          <a:p>
-            <a:endParaRPr lang="en-US"/>
-          </a:p>
-        </p:txBody>
       </p:sp>
       <p:sp>
         <p:nvSpPr>
@@ -5084,7 +5165,7 @@
           <a:bodyPr wrap="square" lIns="0" tIns="0" rIns="0" bIns="0" rtlCol="0" anchor="ctr"/>
           <a:lstStyle/>
           <a:p>
-            <a:pPr marL="0" indent="0" algn="ctr">
+            <a:pPr algn="ctr" indent="0" marL="0">
               <a:buNone/>
             </a:pPr>
             <a:r>
@@ -5123,13 +5204,6 @@
           </a:solidFill>
           <a:ln/>
         </p:spPr>
-        <p:txBody>
-          <a:bodyPr/>
-          <a:lstStyle/>
-          <a:p>
-            <a:endParaRPr lang="en-US"/>
-          </a:p>
-        </p:txBody>
       </p:sp>
       <p:sp>
         <p:nvSpPr>
@@ -5152,7 +5226,7 @@
           <a:bodyPr wrap="square" lIns="0" tIns="0" rIns="0" bIns="0" rtlCol="0" anchor="ctr"/>
           <a:lstStyle/>
           <a:p>
-            <a:pPr marL="0" indent="0" algn="l">
+            <a:pPr algn="l" indent="0" marL="0">
               <a:buNone/>
             </a:pPr>
             <a:r>
@@ -5166,6 +5240,9 @@
               </a:rPr>
               <a:t>The repair ladder: </a:t>
             </a:r>
+            <a:pPr algn="l" indent="0" marL="0">
+              <a:buNone/>
+            </a:pPr>
             <a:r>
               <a:rPr lang="en-US" sz="1300" dirty="0">
                 <a:solidFill>
@@ -5177,6 +5254,9 @@
               </a:rPr>
               <a:t>a rung's exhaustion is a </a:t>
             </a:r>
+            <a:pPr algn="l" indent="0" marL="0">
+              <a:buNone/>
+            </a:pPr>
             <a:r>
               <a:rPr lang="en-US" sz="1300" b="1" i="1" dirty="0">
                 <a:solidFill>
@@ -5188,6 +5268,9 @@
               </a:rPr>
               <a:t>local diagnosis </a:t>
             </a:r>
+            <a:pPr algn="l" indent="0" marL="0">
+              <a:buNone/>
+            </a:pPr>
             <a:r>
               <a:rPr lang="en-US" sz="1300" dirty="0">
                 <a:solidFill>
@@ -5202,7 +5285,7 @@
             <a:endParaRPr lang="en-US" sz="1300" dirty="0"/>
           </a:p>
           <a:p>
-            <a:pPr marL="0" indent="0" algn="l">
+            <a:pPr algn="l" indent="0" marL="0">
               <a:buNone/>
             </a:pPr>
             <a:r>
@@ -5216,6 +5299,9 @@
               </a:rPr>
               <a:t>judged only by </a:t>
             </a:r>
+            <a:pPr algn="l" indent="0" marL="0">
+              <a:buNone/>
+            </a:pPr>
             <a:r>
               <a:rPr lang="en-US" sz="1300" b="1" i="1" dirty="0">
                 <a:solidFill>
@@ -5227,6 +5313,9 @@
               </a:rPr>
               <a:t>fresh re-measurement</a:t>
             </a:r>
+            <a:pPr algn="l" indent="0" marL="0">
+              <a:buNone/>
+            </a:pPr>
             <a:r>
               <a:rPr lang="en-US" sz="1300" dirty="0">
                 <a:solidFill>
@@ -5268,13 +5357,6 @@
             <a:prstDash val="solid"/>
           </a:ln>
         </p:spPr>
-        <p:txBody>
-          <a:bodyPr/>
-          <a:lstStyle/>
-          <a:p>
-            <a:endParaRPr lang="en-US"/>
-          </a:p>
-        </p:txBody>
       </p:sp>
       <p:sp>
         <p:nvSpPr>
@@ -5297,7 +5379,7 @@
           <a:bodyPr wrap="square" lIns="0" tIns="0" rIns="0" bIns="0" rtlCol="0" anchor="ctr"/>
           <a:lstStyle/>
           <a:p>
-            <a:pPr marL="0" indent="0" algn="l">
+            <a:pPr algn="l" indent="0" marL="0">
               <a:buNone/>
             </a:pPr>
             <a:r>
@@ -5314,7 +5396,7 @@
             <a:endParaRPr lang="en-US" sz="1100" dirty="0"/>
           </a:p>
           <a:p>
-            <a:pPr marL="0" indent="0" algn="l">
+            <a:pPr algn="l" indent="0" marL="0">
               <a:buNone/>
             </a:pPr>
             <a:r>
@@ -5348,7 +5430,6 @@
         <a:solidFill>
           <a:srgbClr val="FFFFFF"/>
         </a:solidFill>
-        <a:effectLst/>
       </p:bgPr>
     </p:bg>
     <p:spTree>
@@ -5386,7 +5467,7 @@
           <a:bodyPr wrap="square" lIns="0" tIns="0" rIns="0" bIns="0" rtlCol="0" anchor="ctr"/>
           <a:lstStyle/>
           <a:p>
-            <a:pPr marL="0" indent="0">
+            <a:pPr indent="0" marL="0">
               <a:buNone/>
             </a:pPr>
             <a:r>
@@ -5425,7 +5506,7 @@
           <a:bodyPr wrap="square" lIns="0" tIns="0" rIns="0" bIns="0" rtlCol="0" anchor="t"/>
           <a:lstStyle/>
           <a:p>
-            <a:pPr marL="342900" indent="-342900" algn="l">
+            <a:pPr algn="l" marL="342900" indent="-342900">
               <a:buSzPct val="100000"/>
               <a:buChar char="•"/>
             </a:pPr>
@@ -5440,6 +5521,12 @@
               </a:rPr>
               <a:t>Blackboard</a:t>
             </a:r>
+            <a:pPr algn="l" indent="0" marL="0">
+              <a:spcAft>
+                <a:spcPts val="900"/>
+              </a:spcAft>
+              <a:buNone/>
+            </a:pPr>
             <a:r>
               <a:rPr lang="en-US" sz="1600" dirty="0">
                 <a:solidFill>
@@ -5454,7 +5541,7 @@
             <a:endParaRPr lang="en-US" sz="1600" dirty="0"/>
           </a:p>
           <a:p>
-            <a:pPr marL="342900" indent="-342900" algn="l">
+            <a:pPr algn="l" marL="342900" indent="-342900">
               <a:buSzPct val="100000"/>
               <a:buChar char="•"/>
             </a:pPr>
@@ -5469,6 +5556,12 @@
               </a:rPr>
               <a:t>Blackboard Entry (Key)</a:t>
             </a:r>
+            <a:pPr algn="l" indent="0" marL="0">
+              <a:spcAft>
+                <a:spcPts val="900"/>
+              </a:spcAft>
+              <a:buNone/>
+            </a:pPr>
             <a:r>
               <a:rPr lang="en-US" sz="1600" dirty="0">
                 <a:solidFill>
@@ -5483,7 +5576,7 @@
             <a:endParaRPr lang="en-US" sz="1600" dirty="0"/>
           </a:p>
           <a:p>
-            <a:pPr marL="342900" indent="-342900" algn="l">
+            <a:pPr algn="l" marL="342900" indent="-342900">
               <a:buSzPct val="100000"/>
               <a:buChar char="•"/>
             </a:pPr>
@@ -5498,6 +5591,12 @@
               </a:rPr>
               <a:t>Episode</a:t>
             </a:r>
+            <a:pPr algn="l" indent="0" marL="0">
+              <a:spcAft>
+                <a:spcPts val="900"/>
+              </a:spcAft>
+              <a:buNone/>
+            </a:pPr>
             <a:r>
               <a:rPr lang="en-US" sz="1600" dirty="0">
                 <a:solidFill>
@@ -5512,7 +5611,7 @@
             <a:endParaRPr lang="en-US" sz="1600" dirty="0"/>
           </a:p>
           <a:p>
-            <a:pPr marL="342900" indent="-342900" algn="l">
+            <a:pPr algn="l" marL="342900" indent="-342900">
               <a:buSzPct val="100000"/>
               <a:buChar char="•"/>
             </a:pPr>
@@ -5527,6 +5626,12 @@
               </a:rPr>
               <a:t>Partition</a:t>
             </a:r>
+            <a:pPr algn="l" indent="0" marL="0">
+              <a:spcAft>
+                <a:spcPts val="900"/>
+              </a:spcAft>
+              <a:buNone/>
+            </a:pPr>
             <a:r>
               <a:rPr lang="en-US" sz="1600" dirty="0">
                 <a:solidFill>
@@ -5541,7 +5646,7 @@
             <a:endParaRPr lang="en-US" sz="1600" dirty="0"/>
           </a:p>
           <a:p>
-            <a:pPr marL="342900" indent="-342900" algn="l">
+            <a:pPr algn="l" marL="342900" indent="-342900">
               <a:buSzPct val="100000"/>
               <a:buChar char="•"/>
             </a:pPr>
@@ -5556,6 +5661,12 @@
               </a:rPr>
               <a:t>Controller</a:t>
             </a:r>
+            <a:pPr algn="l" indent="0" marL="0">
+              <a:spcAft>
+                <a:spcPts val="900"/>
+              </a:spcAft>
+              <a:buNone/>
+            </a:pPr>
             <a:r>
               <a:rPr lang="en-US" sz="1600" dirty="0">
                 <a:solidFill>
@@ -5570,7 +5681,7 @@
             <a:endParaRPr lang="en-US" sz="1600" dirty="0"/>
           </a:p>
           <a:p>
-            <a:pPr marL="342900" indent="-342900" algn="l">
+            <a:pPr algn="l" marL="342900" indent="-342900">
               <a:buSzPct val="100000"/>
               <a:buChar char="•"/>
             </a:pPr>
@@ -5585,6 +5696,12 @@
               </a:rPr>
               <a:t>Knowledge source (KS)</a:t>
             </a:r>
+            <a:pPr algn="l" indent="0" marL="0">
+              <a:spcAft>
+                <a:spcPts val="900"/>
+              </a:spcAft>
+              <a:buNone/>
+            </a:pPr>
             <a:r>
               <a:rPr lang="en-US" sz="1600" dirty="0">
                 <a:solidFill>
@@ -5599,7 +5716,7 @@
             <a:endParaRPr lang="en-US" sz="1600" dirty="0"/>
           </a:p>
           <a:p>
-            <a:pPr marL="342900" indent="-342900" algn="l">
+            <a:pPr algn="l" marL="342900" indent="-342900">
               <a:buSzPct val="100000"/>
               <a:buChar char="•"/>
             </a:pPr>
@@ -5614,6 +5731,12 @@
               </a:rPr>
               <a:t>Route</a:t>
             </a:r>
+            <a:pPr algn="l" indent="0" marL="0">
+              <a:spcAft>
+                <a:spcPts val="900"/>
+              </a:spcAft>
+              <a:buNone/>
+            </a:pPr>
             <a:r>
               <a:rPr lang="en-US" sz="1600" dirty="0">
                 <a:solidFill>
@@ -5628,7 +5751,7 @@
             <a:endParaRPr lang="en-US" sz="1600" dirty="0"/>
           </a:p>
           <a:p>
-            <a:pPr marL="342900" indent="-342900" algn="l">
+            <a:pPr algn="l" marL="342900" indent="-342900">
               <a:buSzPct val="100000"/>
               <a:buChar char="•"/>
             </a:pPr>
@@ -5643,6 +5766,12 @@
               </a:rPr>
               <a:t>History / Ledger</a:t>
             </a:r>
+            <a:pPr algn="l" indent="0" marL="0">
+              <a:spcAft>
+                <a:spcPts val="900"/>
+              </a:spcAft>
+              <a:buNone/>
+            </a:pPr>
             <a:r>
               <a:rPr lang="en-US" sz="1600" dirty="0">
                 <a:solidFill>
@@ -5674,7 +5803,6 @@
         <a:solidFill>
           <a:srgbClr val="FFFFFF"/>
         </a:solidFill>
-        <a:effectLst/>
       </p:bgPr>
     </p:bg>
     <p:spTree>
@@ -5712,7 +5840,7 @@
           <a:bodyPr wrap="square" lIns="0" tIns="0" rIns="0" bIns="0" rtlCol="0" anchor="ctr"/>
           <a:lstStyle/>
           <a:p>
-            <a:pPr marL="0" indent="0">
+            <a:pPr indent="0" marL="0">
               <a:buNone/>
             </a:pPr>
             <a:r>
@@ -5753,34 +5881,10 @@
             <a:tbl>
               <a:tblPr/>
               <a:tblGrid>
-                <a:gridCol w="2194560">
-                  <a:extLst>
-                    <a:ext uri="{9D8B030D-6E8A-4147-A177-3AD203B41FA5}">
-                      <a16:colId xmlns:a16="http://schemas.microsoft.com/office/drawing/2014/main" val="20000"/>
-                    </a:ext>
-                  </a:extLst>
-                </a:gridCol>
-                <a:gridCol w="2651760">
-                  <a:extLst>
-                    <a:ext uri="{9D8B030D-6E8A-4147-A177-3AD203B41FA5}">
-                      <a16:colId xmlns:a16="http://schemas.microsoft.com/office/drawing/2014/main" val="20001"/>
-                    </a:ext>
-                  </a:extLst>
-                </a:gridCol>
-                <a:gridCol w="3017520">
-                  <a:extLst>
-                    <a:ext uri="{9D8B030D-6E8A-4147-A177-3AD203B41FA5}">
-                      <a16:colId xmlns:a16="http://schemas.microsoft.com/office/drawing/2014/main" val="20002"/>
-                    </a:ext>
-                  </a:extLst>
-                </a:gridCol>
-                <a:gridCol w="3017520">
-                  <a:extLst>
-                    <a:ext uri="{9D8B030D-6E8A-4147-A177-3AD203B41FA5}">
-                      <a16:colId xmlns:a16="http://schemas.microsoft.com/office/drawing/2014/main" val="20003"/>
-                    </a:ext>
-                  </a:extLst>
-                </a:gridCol>
+                <a:gridCol w="2194560"/>
+                <a:gridCol w="2651760"/>
+                <a:gridCol w="3017520"/>
+                <a:gridCol w="3017520"/>
               </a:tblGrid>
               <a:tr h="658368">
                 <a:tc>
@@ -5788,7 +5892,7 @@
                     <a:bodyPr/>
                     <a:lstStyle/>
                     <a:p>
-                      <a:pPr marL="0" indent="0" algn="l">
+                      <a:pPr algn="l" indent="0" marL="0">
                         <a:buNone/>
                       </a:pPr>
                       <a:r>
@@ -5856,7 +5960,7 @@
                     <a:bodyPr/>
                     <a:lstStyle/>
                     <a:p>
-                      <a:pPr marL="0" indent="0" algn="l">
+                      <a:pPr algn="l" indent="0" marL="0">
                         <a:buNone/>
                       </a:pPr>
                       <a:r>
@@ -5924,7 +6028,7 @@
                     <a:bodyPr/>
                     <a:lstStyle/>
                     <a:p>
-                      <a:pPr marL="0" indent="0" algn="l">
+                      <a:pPr algn="l" indent="0" marL="0">
                         <a:buNone/>
                       </a:pPr>
                       <a:r>
@@ -5992,7 +6096,7 @@
                     <a:bodyPr/>
                     <a:lstStyle/>
                     <a:p>
-                      <a:pPr marL="0" indent="0" algn="l">
+                      <a:pPr algn="l" indent="0" marL="0">
                         <a:buNone/>
                       </a:pPr>
                       <a:r>
@@ -6055,11 +6159,6 @@
                     </a:solidFill>
                   </a:tcPr>
                 </a:tc>
-                <a:extLst>
-                  <a:ext uri="{0D108BD9-81ED-4DB2-BD59-A6C34878D82A}">
-                    <a16:rowId xmlns:a16="http://schemas.microsoft.com/office/drawing/2014/main" val="10000"/>
-                  </a:ext>
-                </a:extLst>
               </a:tr>
               <a:tr h="658368">
                 <a:tc>
@@ -6067,7 +6166,7 @@
                     <a:bodyPr/>
                     <a:lstStyle/>
                     <a:p>
-                      <a:pPr marL="0" indent="0" algn="l">
+                      <a:pPr algn="l" indent="0" marL="0">
                         <a:buNone/>
                       </a:pPr>
                       <a:r>
@@ -6135,7 +6234,7 @@
                     <a:bodyPr/>
                     <a:lstStyle/>
                     <a:p>
-                      <a:pPr marL="0" indent="0" algn="l">
+                      <a:pPr algn="l" indent="0" marL="0">
                         <a:buNone/>
                       </a:pPr>
                       <a:r>
@@ -6203,7 +6302,7 @@
                     <a:bodyPr/>
                     <a:lstStyle/>
                     <a:p>
-                      <a:pPr marL="0" indent="0" algn="l">
+                      <a:pPr algn="l" indent="0" marL="0">
                         <a:buNone/>
                       </a:pPr>
                       <a:r>
@@ -6271,7 +6370,7 @@
                     <a:bodyPr/>
                     <a:lstStyle/>
                     <a:p>
-                      <a:pPr marL="0" indent="0" algn="l">
+                      <a:pPr algn="l" indent="0" marL="0">
                         <a:buNone/>
                       </a:pPr>
                       <a:r>
@@ -6285,6 +6384,9 @@
                         </a:rPr>
                         <a:t>restore from golden — or </a:t>
                       </a:r>
+                      <a:pPr algn="l" indent="0" marL="0">
+                        <a:buNone/>
+                      </a:pPr>
                       <a:r>
                         <a:rPr lang="en-US" sz="1250" i="1" dirty="0">
                           <a:solidFill>
@@ -6296,6 +6398,9 @@
                         </a:rPr>
                         <a:t>bless</a:t>
                       </a:r>
+                      <a:pPr algn="l" indent="0" marL="0">
+                        <a:buNone/>
+                      </a:pPr>
                       <a:r>
                         <a:rPr lang="en-US" sz="1250" dirty="0">
                           <a:solidFill>
@@ -6356,11 +6461,6 @@
                     </a:solidFill>
                   </a:tcPr>
                 </a:tc>
-                <a:extLst>
-                  <a:ext uri="{0D108BD9-81ED-4DB2-BD59-A6C34878D82A}">
-                    <a16:rowId xmlns:a16="http://schemas.microsoft.com/office/drawing/2014/main" val="10001"/>
-                  </a:ext>
-                </a:extLst>
               </a:tr>
               <a:tr h="658368">
                 <a:tc>
@@ -6368,7 +6468,7 @@
                     <a:bodyPr/>
                     <a:lstStyle/>
                     <a:p>
-                      <a:pPr marL="0" indent="0" algn="l">
+                      <a:pPr algn="l" indent="0" marL="0">
                         <a:buNone/>
                       </a:pPr>
                       <a:r>
@@ -6436,7 +6536,7 @@
                     <a:bodyPr/>
                     <a:lstStyle/>
                     <a:p>
-                      <a:pPr marL="0" indent="0" algn="l">
+                      <a:pPr algn="l" indent="0" marL="0">
                         <a:buNone/>
                       </a:pPr>
                       <a:r>
@@ -6504,7 +6604,7 @@
                     <a:bodyPr/>
                     <a:lstStyle/>
                     <a:p>
-                      <a:pPr marL="0" indent="0" algn="l">
+                      <a:pPr algn="l" indent="0" marL="0">
                         <a:buNone/>
                       </a:pPr>
                       <a:r>
@@ -6572,7 +6672,7 @@
                     <a:bodyPr/>
                     <a:lstStyle/>
                     <a:p>
-                      <a:pPr marL="0" indent="0" algn="l">
+                      <a:pPr algn="l" indent="0" marL="0">
                         <a:buNone/>
                       </a:pPr>
                       <a:r>
@@ -6635,11 +6735,6 @@
                     </a:solidFill>
                   </a:tcPr>
                 </a:tc>
-                <a:extLst>
-                  <a:ext uri="{0D108BD9-81ED-4DB2-BD59-A6C34878D82A}">
-                    <a16:rowId xmlns:a16="http://schemas.microsoft.com/office/drawing/2014/main" val="10002"/>
-                  </a:ext>
-                </a:extLst>
               </a:tr>
               <a:tr h="658368">
                 <a:tc>
@@ -6647,7 +6742,7 @@
                     <a:bodyPr/>
                     <a:lstStyle/>
                     <a:p>
-                      <a:pPr marL="0" indent="0" algn="l">
+                      <a:pPr algn="l" indent="0" marL="0">
                         <a:buNone/>
                       </a:pPr>
                       <a:r>
@@ -6715,7 +6810,7 @@
                     <a:bodyPr/>
                     <a:lstStyle/>
                     <a:p>
-                      <a:pPr marL="0" indent="0" algn="l">
+                      <a:pPr algn="l" indent="0" marL="0">
                         <a:buNone/>
                       </a:pPr>
                       <a:r>
@@ -6783,7 +6878,7 @@
                     <a:bodyPr/>
                     <a:lstStyle/>
                     <a:p>
-                      <a:pPr marL="0" indent="0" algn="l">
+                      <a:pPr algn="l" indent="0" marL="0">
                         <a:buNone/>
                       </a:pPr>
                       <a:r>
@@ -6851,7 +6946,7 @@
                     <a:bodyPr/>
                     <a:lstStyle/>
                     <a:p>
-                      <a:pPr marL="0" indent="0" algn="l">
+                      <a:pPr algn="l" indent="0" marL="0">
                         <a:buNone/>
                       </a:pPr>
                       <a:r>
@@ -6914,11 +7009,6 @@
                     </a:solidFill>
                   </a:tcPr>
                 </a:tc>
-                <a:extLst>
-                  <a:ext uri="{0D108BD9-81ED-4DB2-BD59-A6C34878D82A}">
-                    <a16:rowId xmlns:a16="http://schemas.microsoft.com/office/drawing/2014/main" val="10003"/>
-                  </a:ext>
-                </a:extLst>
               </a:tr>
               <a:tr h="658368">
                 <a:tc>
@@ -6926,7 +7016,7 @@
                     <a:bodyPr/>
                     <a:lstStyle/>
                     <a:p>
-                      <a:pPr marL="0" indent="0" algn="l">
+                      <a:pPr algn="l" indent="0" marL="0">
                         <a:buNone/>
                       </a:pPr>
                       <a:r>
@@ -6994,7 +7084,7 @@
                     <a:bodyPr/>
                     <a:lstStyle/>
                     <a:p>
-                      <a:pPr marL="0" indent="0" algn="l">
+                      <a:pPr algn="l" indent="0" marL="0">
                         <a:buNone/>
                       </a:pPr>
                       <a:r>
@@ -7062,7 +7152,7 @@
                     <a:bodyPr/>
                     <a:lstStyle/>
                     <a:p>
-                      <a:pPr marL="0" indent="0" algn="l">
+                      <a:pPr algn="l" indent="0" marL="0">
                         <a:buNone/>
                       </a:pPr>
                       <a:r>
@@ -7130,7 +7220,7 @@
                     <a:bodyPr/>
                     <a:lstStyle/>
                     <a:p>
-                      <a:pPr marL="0" indent="0" algn="l">
+                      <a:pPr algn="l" indent="0" marL="0">
                         <a:buNone/>
                       </a:pPr>
                       <a:r>
@@ -7193,11 +7283,6 @@
                     </a:solidFill>
                   </a:tcPr>
                 </a:tc>
-                <a:extLst>
-                  <a:ext uri="{0D108BD9-81ED-4DB2-BD59-A6C34878D82A}">
-                    <a16:rowId xmlns:a16="http://schemas.microsoft.com/office/drawing/2014/main" val="10004"/>
-                  </a:ext>
-                </a:extLst>
               </a:tr>
               <a:tr h="658368">
                 <a:tc>
@@ -7205,7 +7290,7 @@
                     <a:bodyPr/>
                     <a:lstStyle/>
                     <a:p>
-                      <a:pPr marL="0" indent="0" algn="l">
+                      <a:pPr algn="l" indent="0" marL="0">
                         <a:buNone/>
                       </a:pPr>
                       <a:r>
@@ -7219,6 +7304,9 @@
                         </a:rPr>
                         <a:t>Toolchain </a:t>
                       </a:r>
+                      <a:pPr algn="l" indent="0" marL="0">
+                        <a:buNone/>
+                      </a:pPr>
                       <a:r>
                         <a:rPr lang="en-US" sz="1100" i="1" dirty="0">
                           <a:solidFill>
@@ -7284,7 +7372,7 @@
                     <a:bodyPr/>
                     <a:lstStyle/>
                     <a:p>
-                      <a:pPr marL="0" indent="0" algn="l">
+                      <a:pPr algn="l" indent="0" marL="0">
                         <a:buNone/>
                       </a:pPr>
                       <a:r>
@@ -7298,6 +7386,9 @@
                         </a:rPr>
                         <a:t>hashed </a:t>
                       </a:r>
+                      <a:pPr algn="l" indent="0" marL="0">
+                        <a:buNone/>
+                      </a:pPr>
                       <a:r>
                         <a:rPr lang="en-US" sz="1250" b="1" dirty="0">
                           <a:solidFill>
@@ -7363,7 +7454,7 @@
                     <a:bodyPr/>
                     <a:lstStyle/>
                     <a:p>
-                      <a:pPr marL="0" indent="0" algn="l">
+                      <a:pPr algn="l" indent="0" marL="0">
                         <a:buNone/>
                       </a:pPr>
                       <a:r>
@@ -7431,7 +7522,7 @@
                     <a:bodyPr/>
                     <a:lstStyle/>
                     <a:p>
-                      <a:pPr marL="0" indent="0" algn="l">
+                      <a:pPr algn="l" indent="0" marL="0">
                         <a:buNone/>
                       </a:pPr>
                       <a:r>
@@ -7494,11 +7585,6 @@
                     </a:solidFill>
                   </a:tcPr>
                 </a:tc>
-                <a:extLst>
-                  <a:ext uri="{0D108BD9-81ED-4DB2-BD59-A6C34878D82A}">
-                    <a16:rowId xmlns:a16="http://schemas.microsoft.com/office/drawing/2014/main" val="10005"/>
-                  </a:ext>
-                </a:extLst>
               </a:tr>
               <a:tr h="658368">
                 <a:tc>
@@ -7506,7 +7592,7 @@
                     <a:bodyPr/>
                     <a:lstStyle/>
                     <a:p>
-                      <a:pPr marL="0" indent="0" algn="l">
+                      <a:pPr algn="l" indent="0" marL="0">
                         <a:buNone/>
                       </a:pPr>
                       <a:r>
@@ -7520,6 +7606,9 @@
                         </a:rPr>
                         <a:t>Trust state </a:t>
                       </a:r>
+                      <a:pPr algn="l" indent="0" marL="0">
+                        <a:buNone/>
+                      </a:pPr>
                       <a:r>
                         <a:rPr lang="en-US" sz="1100" i="1" dirty="0">
                           <a:solidFill>
@@ -7585,7 +7674,7 @@
                     <a:bodyPr/>
                     <a:lstStyle/>
                     <a:p>
-                      <a:pPr marL="0" indent="0" algn="l">
+                      <a:pPr algn="l" indent="0" marL="0">
                         <a:buNone/>
                       </a:pPr>
                       <a:r>
@@ -7653,7 +7742,7 @@
                     <a:bodyPr/>
                     <a:lstStyle/>
                     <a:p>
-                      <a:pPr marL="0" indent="0" algn="l">
+                      <a:pPr algn="l" indent="0" marL="0">
                         <a:buNone/>
                       </a:pPr>
                       <a:r>
@@ -7721,7 +7810,7 @@
                     <a:bodyPr/>
                     <a:lstStyle/>
                     <a:p>
-                      <a:pPr marL="0" indent="0" algn="l">
+                      <a:pPr algn="l" indent="0" marL="0">
                         <a:buNone/>
                       </a:pPr>
                       <a:r>
@@ -7735,6 +7824,9 @@
                         </a:rPr>
                         <a:t>principled refusal</a:t>
                       </a:r>
+                      <a:pPr algn="l" indent="0" marL="0">
+                        <a:buNone/>
+                      </a:pPr>
                       <a:r>
                         <a:rPr lang="en-US" sz="1250" dirty="0">
                           <a:solidFill>
@@ -7795,11 +7887,6 @@
                     </a:solidFill>
                   </a:tcPr>
                 </a:tc>
-                <a:extLst>
-                  <a:ext uri="{0D108BD9-81ED-4DB2-BD59-A6C34878D82A}">
-                    <a16:rowId xmlns:a16="http://schemas.microsoft.com/office/drawing/2014/main" val="10006"/>
-                  </a:ext>
-                </a:extLst>
               </a:tr>
             </a:tbl>
           </a:graphicData>
@@ -7821,7 +7908,6 @@
         <a:solidFill>
           <a:srgbClr val="FFFFFF"/>
         </a:solidFill>
-        <a:effectLst/>
       </p:bgPr>
     </p:bg>
     <p:spTree>
@@ -7859,13 +7945,6 @@
           </a:solidFill>
           <a:ln/>
         </p:spPr>
-        <p:txBody>
-          <a:bodyPr/>
-          <a:lstStyle/>
-          <a:p>
-            <a:endParaRPr lang="en-US"/>
-          </a:p>
-        </p:txBody>
       </p:sp>
       <p:sp>
         <p:nvSpPr>
@@ -7888,7 +7967,7 @@
           <a:bodyPr wrap="square" lIns="254" tIns="254" rIns="254" bIns="254" rtlCol="0" anchor="ctr"/>
           <a:lstStyle/>
           <a:p>
-            <a:pPr marL="0" indent="0" algn="ctr">
+            <a:pPr algn="ctr" indent="0" marL="0">
               <a:buNone/>
             </a:pPr>
             <a:r>
@@ -7927,13 +8006,6 @@
           </a:solidFill>
           <a:ln/>
         </p:spPr>
-        <p:txBody>
-          <a:bodyPr/>
-          <a:lstStyle/>
-          <a:p>
-            <a:endParaRPr lang="en-US"/>
-          </a:p>
-        </p:txBody>
       </p:sp>
       <p:sp>
         <p:nvSpPr>
@@ -7956,7 +8028,7 @@
           <a:bodyPr wrap="square" lIns="254" tIns="254" rIns="254" bIns="254" rtlCol="0" anchor="ctr"/>
           <a:lstStyle/>
           <a:p>
-            <a:pPr marL="0" indent="0" algn="ctr">
+            <a:pPr algn="ctr" indent="0" marL="0">
               <a:buNone/>
             </a:pPr>
             <a:r>
@@ -7973,7 +8045,7 @@
             <a:endParaRPr lang="en-US" sz="900" dirty="0"/>
           </a:p>
           <a:p>
-            <a:pPr marL="0" indent="0" algn="ctr">
+            <a:pPr algn="ctr" indent="0" marL="0">
               <a:buNone/>
             </a:pPr>
             <a:r>
@@ -8012,13 +8084,6 @@
           </a:solidFill>
           <a:ln/>
         </p:spPr>
-        <p:txBody>
-          <a:bodyPr/>
-          <a:lstStyle/>
-          <a:p>
-            <a:endParaRPr lang="en-US"/>
-          </a:p>
-        </p:txBody>
       </p:sp>
       <p:sp>
         <p:nvSpPr>
@@ -8041,7 +8106,7 @@
           <a:bodyPr wrap="square" lIns="254" tIns="254" rIns="254" bIns="254" rtlCol="0" anchor="ctr"/>
           <a:lstStyle/>
           <a:p>
-            <a:pPr marL="0" indent="0" algn="ctr">
+            <a:pPr algn="ctr" indent="0" marL="0">
               <a:buNone/>
             </a:pPr>
             <a:r>
@@ -8080,13 +8145,6 @@
           </a:solidFill>
           <a:ln/>
         </p:spPr>
-        <p:txBody>
-          <a:bodyPr/>
-          <a:lstStyle/>
-          <a:p>
-            <a:endParaRPr lang="en-US"/>
-          </a:p>
-        </p:txBody>
       </p:sp>
       <p:sp>
         <p:nvSpPr>
@@ -8109,7 +8167,7 @@
           <a:bodyPr wrap="square" lIns="254" tIns="254" rIns="254" bIns="254" rtlCol="0" anchor="ctr"/>
           <a:lstStyle/>
           <a:p>
-            <a:pPr marL="0" indent="0" algn="ctr">
+            <a:pPr algn="ctr" indent="0" marL="0">
               <a:buNone/>
             </a:pPr>
             <a:r>
@@ -8148,13 +8206,6 @@
           </a:solidFill>
           <a:ln/>
         </p:spPr>
-        <p:txBody>
-          <a:bodyPr/>
-          <a:lstStyle/>
-          <a:p>
-            <a:endParaRPr lang="en-US"/>
-          </a:p>
-        </p:txBody>
       </p:sp>
       <p:sp>
         <p:nvSpPr>
@@ -8177,7 +8228,7 @@
           <a:bodyPr wrap="square" lIns="254" tIns="254" rIns="254" bIns="254" rtlCol="0" anchor="ctr"/>
           <a:lstStyle/>
           <a:p>
-            <a:pPr marL="0" indent="0" algn="ctr">
+            <a:pPr algn="ctr" indent="0" marL="0">
               <a:buNone/>
             </a:pPr>
             <a:r>
@@ -8203,7 +8254,7 @@
         </p:nvSpPr>
         <p:spPr>
           <a:xfrm>
-            <a:off x="640080" y="952760"/>
+            <a:off x="640080" y="950976"/>
             <a:ext cx="7315200" cy="640080"/>
           </a:xfrm>
           <a:prstGeom prst="rect">
@@ -8216,7 +8267,7 @@
           <a:bodyPr wrap="square" lIns="0" tIns="0" rIns="0" bIns="0" rtlCol="0" anchor="ctr"/>
           <a:lstStyle/>
           <a:p>
-            <a:pPr marL="0" indent="0">
+            <a:pPr indent="0" marL="0">
               <a:buNone/>
             </a:pPr>
             <a:r>
@@ -8242,7 +8293,7 @@
         </p:nvSpPr>
         <p:spPr>
           <a:xfrm>
-            <a:off x="640080" y="1730000"/>
+            <a:off x="640080" y="1728216"/>
             <a:ext cx="6035040" cy="2286000"/>
           </a:xfrm>
           <a:prstGeom prst="rect">
@@ -8255,7 +8306,7 @@
           <a:bodyPr wrap="square" lIns="0" tIns="0" rIns="0" bIns="0" rtlCol="0" anchor="t"/>
           <a:lstStyle/>
           <a:p>
-            <a:pPr marL="342900" indent="-342900" algn="l">
+            <a:pPr algn="l" marL="342900" indent="-342900">
               <a:buSzPct val="100000"/>
               <a:buChar char="•"/>
             </a:pPr>
@@ -8270,6 +8321,12 @@
               </a:rPr>
               <a:t>The system: </a:t>
             </a:r>
+            <a:pPr algn="l" indent="0" marL="0">
+              <a:spcAft>
+                <a:spcPts val="200"/>
+              </a:spcAft>
+              <a:buNone/>
+            </a:pPr>
             <a:r>
               <a:rPr lang="en-US" sz="1350" dirty="0">
                 <a:solidFill>
@@ -8284,7 +8341,7 @@
             <a:endParaRPr lang="en-US" sz="1350" dirty="0"/>
           </a:p>
           <a:p>
-            <a:pPr marL="0" indent="0" algn="l">
+            <a:pPr algn="l" indent="0" marL="0">
               <a:spcAft>
                 <a:spcPts val="1000"/>
               </a:spcAft>
@@ -8304,7 +8361,7 @@
             <a:endParaRPr lang="en-US" sz="1350" dirty="0"/>
           </a:p>
           <a:p>
-            <a:pPr marL="342900" indent="-342900" algn="l">
+            <a:pPr algn="l" marL="342900" indent="-342900">
               <a:buSzPct val="100000"/>
               <a:buChar char="•"/>
             </a:pPr>
@@ -8319,6 +8376,9 @@
               </a:rPr>
               <a:t>The relevance: </a:t>
             </a:r>
+            <a:pPr algn="l" indent="0" marL="0">
+              <a:buNone/>
+            </a:pPr>
             <a:r>
               <a:rPr lang="en-US" sz="1350" dirty="0">
                 <a:solidFill>
@@ -8328,29 +8388,7 @@
                 <a:ea typeface="Calibri" pitchFamily="34" charset="-122"/>
                 <a:cs typeface="Calibri" pitchFamily="34" charset="-120"/>
               </a:rPr>
-              <a:t>the INSPECTA program's seL4/</a:t>
-            </a:r>
-            <a:r>
-              <a:rPr lang="en-US" sz="1350" dirty="0" err="1">
-                <a:solidFill>
-                  <a:srgbClr val="212121"/>
-                </a:solidFill>
-                <a:latin typeface="Calibri" pitchFamily="34" charset="0"/>
-                <a:ea typeface="Calibri" pitchFamily="34" charset="-122"/>
-                <a:cs typeface="Calibri" pitchFamily="34" charset="-120"/>
-              </a:rPr>
-              <a:t>Microkit</a:t>
-            </a:r>
-            <a:r>
-              <a:rPr lang="en-US" sz="1350" dirty="0">
-                <a:solidFill>
-                  <a:srgbClr val="212121"/>
-                </a:solidFill>
-                <a:latin typeface="Calibri" pitchFamily="34" charset="0"/>
-                <a:ea typeface="Calibri" pitchFamily="34" charset="-122"/>
-                <a:cs typeface="Calibri" pitchFamily="34" charset="-120"/>
-              </a:rPr>
-              <a:t> target — a real, current, safety-critical development artifact, not a toy example</a:t>
+              <a:t>the INSPECTA program's seL4/Microkit exemplar — a real, current, safety-critical development artifact, not a toy built for this talk</a:t>
             </a:r>
             <a:endParaRPr lang="en-US" sz="1350" dirty="0"/>
           </a:p>
@@ -8377,13 +8415,6 @@
           </a:solidFill>
           <a:ln/>
         </p:spPr>
-        <p:txBody>
-          <a:bodyPr/>
-          <a:lstStyle/>
-          <a:p>
-            <a:endParaRPr lang="en-US"/>
-          </a:p>
-        </p:txBody>
       </p:sp>
       <p:sp>
         <p:nvSpPr>
@@ -8406,7 +8437,7 @@
           <a:bodyPr wrap="square" lIns="254" tIns="254" rIns="254" bIns="254" rtlCol="0" anchor="ctr"/>
           <a:lstStyle/>
           <a:p>
-            <a:pPr marL="0" indent="0" algn="ctr">
+            <a:pPr algn="ctr" indent="0" marL="0">
               <a:buNone/>
             </a:pPr>
             <a:r>
@@ -8423,7 +8454,7 @@
             <a:endParaRPr lang="en-US" sz="1050" dirty="0"/>
           </a:p>
           <a:p>
-            <a:pPr marL="0" indent="0" algn="ctr">
+            <a:pPr algn="ctr" indent="0" marL="0">
               <a:buNone/>
             </a:pPr>
             <a:r>
@@ -8462,7 +8493,7 @@
           <a:bodyPr wrap="square" lIns="0" tIns="0" rIns="0" bIns="0" rtlCol="0" anchor="ctr"/>
           <a:lstStyle/>
           <a:p>
-            <a:pPr marL="0" indent="0" algn="ctr">
+            <a:pPr algn="ctr" indent="0" marL="0">
               <a:buNone/>
             </a:pPr>
             <a:r>
@@ -8501,13 +8532,6 @@
           </a:solidFill>
           <a:ln/>
         </p:spPr>
-        <p:txBody>
-          <a:bodyPr/>
-          <a:lstStyle/>
-          <a:p>
-            <a:endParaRPr lang="en-US"/>
-          </a:p>
-        </p:txBody>
       </p:sp>
       <p:sp>
         <p:nvSpPr>
@@ -8530,7 +8554,7 @@
           <a:bodyPr wrap="square" lIns="254" tIns="254" rIns="254" bIns="254" rtlCol="0" anchor="ctr"/>
           <a:lstStyle/>
           <a:p>
-            <a:pPr marL="0" indent="0" algn="ctr">
+            <a:pPr algn="ctr" indent="0" marL="0">
               <a:buNone/>
             </a:pPr>
             <a:r>
@@ -8547,7 +8571,7 @@
             <a:endParaRPr lang="en-US" sz="1050" dirty="0"/>
           </a:p>
           <a:p>
-            <a:pPr marL="0" indent="0" algn="ctr">
+            <a:pPr algn="ctr" indent="0" marL="0">
               <a:buNone/>
             </a:pPr>
             <a:r>
@@ -8586,7 +8610,7 @@
           <a:bodyPr wrap="square" lIns="0" tIns="0" rIns="0" bIns="0" rtlCol="0" anchor="ctr"/>
           <a:lstStyle/>
           <a:p>
-            <a:pPr marL="0" indent="0" algn="ctr">
+            <a:pPr algn="ctr" indent="0" marL="0">
               <a:buNone/>
             </a:pPr>
             <a:r>
@@ -8625,13 +8649,6 @@
           </a:solidFill>
           <a:ln/>
         </p:spPr>
-        <p:txBody>
-          <a:bodyPr/>
-          <a:lstStyle/>
-          <a:p>
-            <a:endParaRPr lang="en-US"/>
-          </a:p>
-        </p:txBody>
       </p:sp>
       <p:sp>
         <p:nvSpPr>
@@ -8654,7 +8671,7 @@
           <a:bodyPr wrap="square" lIns="254" tIns="254" rIns="254" bIns="254" rtlCol="0" anchor="ctr"/>
           <a:lstStyle/>
           <a:p>
-            <a:pPr marL="0" indent="0" algn="ctr">
+            <a:pPr algn="ctr" indent="0" marL="0">
               <a:buNone/>
             </a:pPr>
             <a:r>
@@ -8671,7 +8688,7 @@
             <a:endParaRPr lang="en-US" sz="1050" dirty="0"/>
           </a:p>
           <a:p>
-            <a:pPr marL="0" indent="0" algn="ctr">
+            <a:pPr algn="ctr" indent="0" marL="0">
               <a:buNone/>
             </a:pPr>
             <a:r>
@@ -8710,7 +8727,7 @@
           <a:bodyPr wrap="square" lIns="0" tIns="0" rIns="0" bIns="0" rtlCol="0" anchor="ctr"/>
           <a:lstStyle/>
           <a:p>
-            <a:pPr marL="0" indent="0" algn="ctr">
+            <a:pPr algn="ctr" indent="0" marL="0">
               <a:buNone/>
             </a:pPr>
             <a:r>
@@ -8749,13 +8766,6 @@
           </a:solidFill>
           <a:ln/>
         </p:spPr>
-        <p:txBody>
-          <a:bodyPr/>
-          <a:lstStyle/>
-          <a:p>
-            <a:endParaRPr lang="en-US"/>
-          </a:p>
-        </p:txBody>
       </p:sp>
       <p:sp>
         <p:nvSpPr>
@@ -8778,7 +8788,7 @@
           <a:bodyPr wrap="square" lIns="254" tIns="254" rIns="254" bIns="254" rtlCol="0" anchor="ctr"/>
           <a:lstStyle/>
           <a:p>
-            <a:pPr marL="0" indent="0" algn="ctr">
+            <a:pPr algn="ctr" indent="0" marL="0">
               <a:buNone/>
             </a:pPr>
             <a:r>
@@ -8795,7 +8805,7 @@
             <a:endParaRPr lang="en-US" sz="1050" dirty="0"/>
           </a:p>
           <a:p>
-            <a:pPr marL="0" indent="0" algn="ctr">
+            <a:pPr algn="ctr" indent="0" marL="0">
               <a:buNone/>
             </a:pPr>
             <a:r>
@@ -8822,7 +8832,7 @@
         <p:spPr>
           <a:xfrm>
             <a:off x="640080" y="5029200"/>
-            <a:ext cx="6035040" cy="1371600"/>
+            <a:ext cx="6035040" cy="1097280"/>
           </a:xfrm>
           <a:prstGeom prst="rect">
             <a:avLst/>
@@ -8834,7 +8844,7 @@
           <a:bodyPr wrap="square" lIns="0" tIns="0" rIns="0" bIns="0" rtlCol="0" anchor="t"/>
           <a:lstStyle/>
           <a:p>
-            <a:pPr marL="342900" indent="-342900" algn="l">
+            <a:pPr algn="l" marL="342900" indent="-342900">
               <a:buSzPct val="100000"/>
               <a:buChar char="•"/>
             </a:pPr>
@@ -8849,6 +8859,9 @@
               </a:rPr>
               <a:t>Why this example: </a:t>
             </a:r>
+            <a:pPr algn="l" indent="0" marL="0">
+              <a:buNone/>
+            </a:pPr>
             <a:r>
               <a:rPr lang="en-US" sz="1350" dirty="0">
                 <a:solidFill>
@@ -8867,6 +8880,163 @@
       <p:sp>
         <p:nvSpPr>
           <p:cNvPr id="26" name="Text 24"/>
+          <p:cNvSpPr/>
+          <p:nvPr/>
+        </p:nvSpPr>
+        <p:spPr>
+          <a:xfrm>
+            <a:off x="640080" y="6236208"/>
+            <a:ext cx="10881360" cy="566928"/>
+          </a:xfrm>
+          <a:prstGeom prst="rect">
+            <a:avLst/>
+          </a:prstGeom>
+          <a:noFill/>
+          <a:ln/>
+        </p:spPr>
+        <p:txBody>
+          <a:bodyPr wrap="square" lIns="0" tIns="0" rIns="0" bIns="0" rtlCol="0" anchor="t"/>
+          <a:lstStyle/>
+          <a:p>
+            <a:pPr algn="l" indent="0" marL="0">
+              <a:buNone/>
+            </a:pPr>
+            <a:r>
+              <a:rPr lang="en-US" sz="850" dirty="0">
+                <a:solidFill>
+                  <a:srgbClr val="5A6478"/>
+                </a:solidFill>
+                <a:latin typeface="Calibri" pitchFamily="34" charset="0"/>
+                <a:ea typeface="Calibri" pitchFamily="34" charset="-122"/>
+                <a:cs typeface="Calibri" pitchFamily="34" charset="-120"/>
+              </a:rPr>
+              <a:t>Hatcliff &amp; Belt, </a:t>
+            </a:r>
+            <a:pPr algn="l" indent="0" marL="0">
+              <a:buNone/>
+            </a:pPr>
+            <a:r>
+              <a:rPr lang="en-US" sz="850" i="1" dirty="0">
+                <a:solidFill>
+                  <a:srgbClr val="5A6478"/>
+                </a:solidFill>
+                <a:latin typeface="Calibri" pitchFamily="34" charset="0"/>
+                <a:ea typeface="Calibri" pitchFamily="34" charset="-122"/>
+                <a:cs typeface="Calibri" pitchFamily="34" charset="-120"/>
+              </a:rPr>
+              <a:t>The Isolette System: Illustrating End-to-End Artifacts for Rigorous Model-Based Engineering</a:t>
+            </a:r>
+            <a:pPr algn="l" indent="0" marL="0">
+              <a:buNone/>
+            </a:pPr>
+            <a:r>
+              <a:rPr lang="en-US" sz="850" dirty="0">
+                <a:solidFill>
+                  <a:srgbClr val="5A6478"/>
+                </a:solidFill>
+                <a:latin typeface="Calibri" pitchFamily="34" charset="0"/>
+                <a:ea typeface="Calibri" pitchFamily="34" charset="-122"/>
+                <a:cs typeface="Calibri" pitchFamily="34" charset="-120"/>
+              </a:rPr>
+              <a:t>, Springer LNCS 15240, 2025</a:t>
+            </a:r>
+            <a:endParaRPr lang="en-US" sz="850" dirty="0"/>
+          </a:p>
+          <a:p>
+            <a:pPr algn="l" indent="0" marL="0">
+              <a:buNone/>
+            </a:pPr>
+            <a:r>
+              <a:rPr lang="en-US" sz="850" dirty="0">
+                <a:solidFill>
+                  <a:srgbClr val="5A6478"/>
+                </a:solidFill>
+                <a:latin typeface="Calibri" pitchFamily="34" charset="0"/>
+                <a:ea typeface="Calibri" pitchFamily="34" charset="-122"/>
+                <a:cs typeface="Calibri" pitchFamily="34" charset="-120"/>
+              </a:rPr>
+              <a:t>Hatcliff, Belt, Robby, McKenzie, Liang, </a:t>
+            </a:r>
+            <a:pPr algn="l" indent="0" marL="0">
+              <a:buNone/>
+            </a:pPr>
+            <a:r>
+              <a:rPr lang="en-US" sz="850" i="1" dirty="0">
+                <a:solidFill>
+                  <a:srgbClr val="5A6478"/>
+                </a:solidFill>
+                <a:latin typeface="Calibri" pitchFamily="34" charset="0"/>
+                <a:ea typeface="Calibri" pitchFamily="34" charset="-122"/>
+                <a:cs typeface="Calibri" pitchFamily="34" charset="-120"/>
+              </a:rPr>
+              <a:t>End-to-End Formal Methods Integrated Development with SysMLv2 Using HAMR</a:t>
+            </a:r>
+            <a:pPr algn="l" indent="0" marL="0">
+              <a:buNone/>
+            </a:pPr>
+            <a:r>
+              <a:rPr lang="en-US" sz="850" dirty="0">
+                <a:solidFill>
+                  <a:srgbClr val="5A6478"/>
+                </a:solidFill>
+                <a:latin typeface="Calibri" pitchFamily="34" charset="0"/>
+                <a:ea typeface="Calibri" pitchFamily="34" charset="-122"/>
+                <a:cs typeface="Calibri" pitchFamily="34" charset="-120"/>
+              </a:rPr>
+              <a:t>, Springer, 2025</a:t>
+            </a:r>
+            <a:endParaRPr lang="en-US" sz="850" dirty="0"/>
+          </a:p>
+          <a:p>
+            <a:pPr algn="l" indent="0" marL="0">
+              <a:buNone/>
+            </a:pPr>
+            <a:r>
+              <a:rPr lang="en-US" sz="850" dirty="0">
+                <a:solidFill>
+                  <a:srgbClr val="5A6478"/>
+                </a:solidFill>
+                <a:latin typeface="Calibri" pitchFamily="34" charset="0"/>
+                <a:ea typeface="Calibri" pitchFamily="34" charset="-122"/>
+                <a:cs typeface="Calibri" pitchFamily="34" charset="-120"/>
+              </a:rPr>
+              <a:t>Hatcliff, Belt, Robby, Carpenter, </a:t>
+            </a:r>
+            <a:pPr algn="l" indent="0" marL="0">
+              <a:buNone/>
+            </a:pPr>
+            <a:r>
+              <a:rPr lang="en-US" sz="850" i="1" dirty="0">
+                <a:solidFill>
+                  <a:srgbClr val="5A6478"/>
+                </a:solidFill>
+                <a:latin typeface="Calibri" pitchFamily="34" charset="0"/>
+                <a:ea typeface="Calibri" pitchFamily="34" charset="-122"/>
+                <a:cs typeface="Calibri" pitchFamily="34" charset="-120"/>
+              </a:rPr>
+              <a:t>HAMR: An AADL Multi-platform Code Generation Toolset</a:t>
+            </a:r>
+            <a:pPr algn="l" indent="0" marL="0">
+              <a:buNone/>
+            </a:pPr>
+            <a:r>
+              <a:rPr lang="en-US" sz="850" dirty="0">
+                <a:solidFill>
+                  <a:srgbClr val="5A6478"/>
+                </a:solidFill>
+                <a:latin typeface="Calibri" pitchFamily="34" charset="0"/>
+                <a:ea typeface="Calibri" pitchFamily="34" charset="-122"/>
+                <a:cs typeface="Calibri" pitchFamily="34" charset="-120"/>
+              </a:rPr>
+              <a:t>, ISoLA 2021, LNCS 13036</a:t>
+            </a:r>
+            <a:endParaRPr lang="en-US" sz="850" dirty="0"/>
+          </a:p>
+        </p:txBody>
+      </p:sp>
+      <p:sp>
+        <p:nvSpPr>
+          <p:cNvPr id="27" name="Text 25"/>
           <p:cNvSpPr/>
           <p:nvPr/>
         </p:nvSpPr>
@@ -8885,7 +9055,7 @@
           <a:bodyPr wrap="square" lIns="0" tIns="0" rIns="0" bIns="0" rtlCol="0" anchor="ctr"/>
           <a:lstStyle/>
           <a:p>
-            <a:pPr marL="0" indent="0" algn="l">
+            <a:pPr algn="l" indent="0" marL="0">
               <a:buNone/>
             </a:pPr>
             <a:r>
@@ -8905,7 +9075,7 @@
       </p:sp>
       <p:sp>
         <p:nvSpPr>
-          <p:cNvPr id="27" name="Shape 25"/>
+          <p:cNvPr id="28" name="Shape 26"/>
           <p:cNvSpPr/>
           <p:nvPr/>
         </p:nvSpPr>
@@ -8929,17 +9099,10 @@
             <a:prstDash val="solid"/>
           </a:ln>
         </p:spPr>
-        <p:txBody>
-          <a:bodyPr/>
-          <a:lstStyle/>
-          <a:p>
-            <a:endParaRPr lang="en-US"/>
-          </a:p>
-        </p:txBody>
-      </p:sp>
-      <p:sp>
-        <p:nvSpPr>
-          <p:cNvPr id="28" name="Text 26"/>
+      </p:sp>
+      <p:sp>
+        <p:nvSpPr>
+          <p:cNvPr id="29" name="Text 27"/>
           <p:cNvSpPr/>
           <p:nvPr/>
         </p:nvSpPr>
@@ -8958,7 +9121,7 @@
           <a:bodyPr wrap="square" lIns="0" tIns="0" rIns="0" bIns="0" rtlCol="0" anchor="ctr"/>
           <a:lstStyle/>
           <a:p>
-            <a:pPr marL="0" indent="0" algn="l">
+            <a:pPr algn="l" indent="0" marL="0">
               <a:buNone/>
             </a:pPr>
             <a:r>
@@ -8978,7 +9141,7 @@
       </p:sp>
       <p:sp>
         <p:nvSpPr>
-          <p:cNvPr id="29" name="Text 27"/>
+          <p:cNvPr id="30" name="Text 28"/>
           <p:cNvSpPr/>
           <p:nvPr/>
         </p:nvSpPr>
@@ -8997,7 +9160,7 @@
           <a:bodyPr wrap="square" lIns="0" tIns="0" rIns="0" bIns="0" rtlCol="0" anchor="ctr"/>
           <a:lstStyle/>
           <a:p>
-            <a:pPr marL="0" indent="0" algn="l">
+            <a:pPr algn="l" indent="0" marL="0">
               <a:buNone/>
             </a:pPr>
             <a:r>
@@ -9017,7 +9180,7 @@
       </p:sp>
       <p:sp>
         <p:nvSpPr>
-          <p:cNvPr id="30" name="Shape 28"/>
+          <p:cNvPr id="31" name="Shape 29"/>
           <p:cNvSpPr/>
           <p:nvPr/>
         </p:nvSpPr>
@@ -9041,17 +9204,10 @@
             <a:prstDash val="solid"/>
           </a:ln>
         </p:spPr>
-        <p:txBody>
-          <a:bodyPr/>
-          <a:lstStyle/>
-          <a:p>
-            <a:endParaRPr lang="en-US"/>
-          </a:p>
-        </p:txBody>
-      </p:sp>
-      <p:sp>
-        <p:nvSpPr>
-          <p:cNvPr id="31" name="Text 29"/>
+      </p:sp>
+      <p:sp>
+        <p:nvSpPr>
+          <p:cNvPr id="32" name="Text 30"/>
           <p:cNvSpPr/>
           <p:nvPr/>
         </p:nvSpPr>
@@ -9070,7 +9226,7 @@
           <a:bodyPr wrap="square" lIns="0" tIns="0" rIns="0" bIns="0" rtlCol="0" anchor="ctr"/>
           <a:lstStyle/>
           <a:p>
-            <a:pPr marL="0" indent="0" algn="l">
+            <a:pPr algn="l" indent="0" marL="0">
               <a:buNone/>
             </a:pPr>
             <a:r>
@@ -9090,7 +9246,7 @@
       </p:sp>
       <p:sp>
         <p:nvSpPr>
-          <p:cNvPr id="32" name="Text 30"/>
+          <p:cNvPr id="33" name="Text 31"/>
           <p:cNvSpPr/>
           <p:nvPr/>
         </p:nvSpPr>
@@ -9109,7 +9265,7 @@
           <a:bodyPr wrap="square" lIns="0" tIns="0" rIns="0" bIns="0" rtlCol="0" anchor="ctr"/>
           <a:lstStyle/>
           <a:p>
-            <a:pPr marL="0" indent="0" algn="l">
+            <a:pPr algn="l" indent="0" marL="0">
               <a:buNone/>
             </a:pPr>
             <a:r>
@@ -9129,7 +9285,7 @@
       </p:sp>
       <p:sp>
         <p:nvSpPr>
-          <p:cNvPr id="33" name="Shape 31"/>
+          <p:cNvPr id="34" name="Shape 32"/>
           <p:cNvSpPr/>
           <p:nvPr/>
         </p:nvSpPr>
@@ -9153,17 +9309,10 @@
             <a:prstDash val="solid"/>
           </a:ln>
         </p:spPr>
-        <p:txBody>
-          <a:bodyPr/>
-          <a:lstStyle/>
-          <a:p>
-            <a:endParaRPr lang="en-US"/>
-          </a:p>
-        </p:txBody>
-      </p:sp>
-      <p:sp>
-        <p:nvSpPr>
-          <p:cNvPr id="34" name="Text 32"/>
+      </p:sp>
+      <p:sp>
+        <p:nvSpPr>
+          <p:cNvPr id="35" name="Text 33"/>
           <p:cNvSpPr/>
           <p:nvPr/>
         </p:nvSpPr>
@@ -9182,7 +9331,7 @@
           <a:bodyPr wrap="square" lIns="0" tIns="0" rIns="0" bIns="0" rtlCol="0" anchor="ctr"/>
           <a:lstStyle/>
           <a:p>
-            <a:pPr marL="0" indent="0" algn="l">
+            <a:pPr algn="l" indent="0" marL="0">
               <a:buNone/>
             </a:pPr>
             <a:r>
@@ -9202,7 +9351,7 @@
       </p:sp>
       <p:sp>
         <p:nvSpPr>
-          <p:cNvPr id="35" name="Text 33"/>
+          <p:cNvPr id="36" name="Text 34"/>
           <p:cNvSpPr/>
           <p:nvPr/>
         </p:nvSpPr>
@@ -9221,7 +9370,7 @@
           <a:bodyPr wrap="square" lIns="0" tIns="0" rIns="0" bIns="0" rtlCol="0" anchor="ctr"/>
           <a:lstStyle/>
           <a:p>
-            <a:pPr marL="0" indent="0" algn="l">
+            <a:pPr algn="l" indent="0" marL="0">
               <a:buNone/>
             </a:pPr>
             <a:r>
@@ -9241,7 +9390,7 @@
       </p:sp>
       <p:sp>
         <p:nvSpPr>
-          <p:cNvPr id="36" name="Shape 34"/>
+          <p:cNvPr id="37" name="Shape 35"/>
           <p:cNvSpPr/>
           <p:nvPr/>
         </p:nvSpPr>
@@ -9265,17 +9414,10 @@
             <a:prstDash val="solid"/>
           </a:ln>
         </p:spPr>
-        <p:txBody>
-          <a:bodyPr/>
-          <a:lstStyle/>
-          <a:p>
-            <a:endParaRPr lang="en-US"/>
-          </a:p>
-        </p:txBody>
-      </p:sp>
-      <p:sp>
-        <p:nvSpPr>
-          <p:cNvPr id="37" name="Text 35"/>
+      </p:sp>
+      <p:sp>
+        <p:nvSpPr>
+          <p:cNvPr id="38" name="Text 36"/>
           <p:cNvSpPr/>
           <p:nvPr/>
         </p:nvSpPr>
@@ -9294,7 +9436,7 @@
           <a:bodyPr wrap="square" lIns="0" tIns="0" rIns="0" bIns="0" rtlCol="0" anchor="ctr"/>
           <a:lstStyle/>
           <a:p>
-            <a:pPr marL="0" indent="0" algn="l">
+            <a:pPr algn="l" indent="0" marL="0">
               <a:buNone/>
             </a:pPr>
             <a:r>
@@ -9314,7 +9456,7 @@
       </p:sp>
       <p:sp>
         <p:nvSpPr>
-          <p:cNvPr id="38" name="Text 36"/>
+          <p:cNvPr id="39" name="Text 37"/>
           <p:cNvSpPr/>
           <p:nvPr/>
         </p:nvSpPr>
@@ -9333,7 +9475,7 @@
           <a:bodyPr wrap="square" lIns="0" tIns="0" rIns="0" bIns="0" rtlCol="0" anchor="ctr"/>
           <a:lstStyle/>
           <a:p>
-            <a:pPr marL="0" indent="0" algn="l">
+            <a:pPr algn="l" indent="0" marL="0">
               <a:buNone/>
             </a:pPr>
             <a:r>
@@ -9353,7 +9495,7 @@
       </p:sp>
       <p:sp>
         <p:nvSpPr>
-          <p:cNvPr id="39" name="Shape 37"/>
+          <p:cNvPr id="40" name="Shape 38"/>
           <p:cNvSpPr/>
           <p:nvPr/>
         </p:nvSpPr>
@@ -9377,17 +9519,10 @@
             <a:prstDash val="solid"/>
           </a:ln>
         </p:spPr>
-        <p:txBody>
-          <a:bodyPr/>
-          <a:lstStyle/>
-          <a:p>
-            <a:endParaRPr lang="en-US"/>
-          </a:p>
-        </p:txBody>
-      </p:sp>
-      <p:sp>
-        <p:nvSpPr>
-          <p:cNvPr id="40" name="Text 38"/>
+      </p:sp>
+      <p:sp>
+        <p:nvSpPr>
+          <p:cNvPr id="41" name="Text 39"/>
           <p:cNvSpPr/>
           <p:nvPr/>
         </p:nvSpPr>
@@ -9406,7 +9541,7 @@
           <a:bodyPr wrap="square" lIns="0" tIns="0" rIns="0" bIns="0" rtlCol="0" anchor="ctr"/>
           <a:lstStyle/>
           <a:p>
-            <a:pPr marL="0" indent="0" algn="l">
+            <a:pPr algn="l" indent="0" marL="0">
               <a:buNone/>
             </a:pPr>
             <a:r>
@@ -9426,7 +9561,7 @@
       </p:sp>
       <p:sp>
         <p:nvSpPr>
-          <p:cNvPr id="41" name="Text 39"/>
+          <p:cNvPr id="42" name="Text 40"/>
           <p:cNvSpPr/>
           <p:nvPr/>
         </p:nvSpPr>
@@ -9445,7 +9580,7 @@
           <a:bodyPr wrap="square" lIns="0" tIns="0" rIns="0" bIns="0" rtlCol="0" anchor="ctr"/>
           <a:lstStyle/>
           <a:p>
-            <a:pPr marL="0" indent="0" algn="l">
+            <a:pPr algn="l" indent="0" marL="0">
               <a:buNone/>
             </a:pPr>
             <a:r>
@@ -9462,7 +9597,7 @@
             <a:endParaRPr lang="en-US" sz="1100" dirty="0"/>
           </a:p>
           <a:p>
-            <a:pPr marL="0" indent="0" algn="l">
+            <a:pPr algn="l" indent="0" marL="0">
               <a:buNone/>
             </a:pPr>
             <a:r>
@@ -9477,6 +9612,571 @@
               <a:t>props · l1a · l2 · verus · cheat · sysproof · gensrc · report</a:t>
             </a:r>
             <a:endParaRPr lang="en-US" sz="1100" dirty="0"/>
+          </a:p>
+        </p:txBody>
+      </p:sp>
+    </p:spTree>
+  </p:cSld>
+  <p:clrMapOvr>
+    <a:masterClrMapping/>
+  </p:clrMapOvr>
+</p:sld>
+</file>
+
+<file path=ppt/slides/slide9.xml><?xml version="1.0" encoding="utf-8"?>
+<p:sld xmlns:a="http://schemas.openxmlformats.org/drawingml/2006/main" xmlns:r="http://schemas.openxmlformats.org/officeDocument/2006/relationships" xmlns:p="http://schemas.openxmlformats.org/presentationml/2006/main">
+  <p:cSld name="Slide 9">
+    <p:bg>
+      <p:bgPr>
+        <a:solidFill>
+          <a:srgbClr val="FFFFFF"/>
+        </a:solidFill>
+      </p:bgPr>
+    </p:bg>
+    <p:spTree>
+      <p:nvGrpSpPr>
+        <p:cNvPr id="1" name=""/>
+        <p:cNvGrpSpPr/>
+        <p:nvPr/>
+      </p:nvGrpSpPr>
+      <p:grpSpPr>
+        <a:xfrm>
+          <a:off x="0" y="0"/>
+          <a:ext cx="0" cy="0"/>
+          <a:chOff x="0" y="0"/>
+          <a:chExt cx="0" cy="0"/>
+        </a:xfrm>
+      </p:grpSpPr>
+      <p:sp>
+        <p:nvSpPr>
+          <p:cNvPr id="2" name="Text 0"/>
+          <p:cNvSpPr/>
+          <p:nvPr/>
+        </p:nvSpPr>
+        <p:spPr>
+          <a:xfrm>
+            <a:off x="640080" y="411480"/>
+            <a:ext cx="10972800" cy="731520"/>
+          </a:xfrm>
+          <a:prstGeom prst="rect">
+            <a:avLst/>
+          </a:prstGeom>
+          <a:noFill/>
+          <a:ln/>
+        </p:spPr>
+        <p:txBody>
+          <a:bodyPr wrap="square" lIns="0" tIns="0" rIns="0" bIns="0" rtlCol="0" anchor="ctr"/>
+          <a:lstStyle/>
+          <a:p>
+            <a:pPr indent="0" marL="0">
+              <a:buNone/>
+            </a:pPr>
+            <a:r>
+              <a:rPr lang="en-US" sz="3600" b="1" dirty="0">
+                <a:solidFill>
+                  <a:srgbClr val="1E2761"/>
+                </a:solidFill>
+                <a:latin typeface="Cambria" pitchFamily="34" charset="0"/>
+                <a:ea typeface="Cambria" pitchFamily="34" charset="-122"/>
+                <a:cs typeface="Cambria" pitchFamily="34" charset="-120"/>
+              </a:rPr>
+              <a:t>References</a:t>
+            </a:r>
+            <a:endParaRPr lang="en-US" sz="3600" dirty="0"/>
+          </a:p>
+        </p:txBody>
+      </p:sp>
+      <p:sp>
+        <p:nvSpPr>
+          <p:cNvPr id="3" name="Text 1"/>
+          <p:cNvSpPr/>
+          <p:nvPr/>
+        </p:nvSpPr>
+        <p:spPr>
+          <a:xfrm>
+            <a:off x="640080" y="1371600"/>
+            <a:ext cx="10972800" cy="5120640"/>
+          </a:xfrm>
+          <a:prstGeom prst="rect">
+            <a:avLst/>
+          </a:prstGeom>
+          <a:noFill/>
+          <a:ln/>
+        </p:spPr>
+        <p:txBody>
+          <a:bodyPr wrap="square" lIns="0" tIns="0" rIns="0" bIns="0" rtlCol="0" anchor="t"/>
+          <a:lstStyle/>
+          <a:p>
+            <a:pPr algn="l" indent="0" marL="0">
+              <a:spcAft>
+                <a:spcPts val="400"/>
+              </a:spcAft>
+              <a:buNone/>
+            </a:pPr>
+            <a:r>
+              <a:rPr lang="en-US" sz="1400" b="1" dirty="0">
+                <a:solidFill>
+                  <a:srgbClr val="1E2761"/>
+                </a:solidFill>
+                <a:latin typeface="Calibri" pitchFamily="34" charset="0"/>
+                <a:ea typeface="Calibri" pitchFamily="34" charset="-122"/>
+                <a:cs typeface="Calibri" pitchFamily="34" charset="-120"/>
+              </a:rPr>
+              <a:t>The isolette &amp; HAMR (Kansas State)</a:t>
+            </a:r>
+            <a:endParaRPr lang="en-US" sz="1400" dirty="0"/>
+          </a:p>
+          <a:p>
+            <a:pPr algn="l" marL="342900" indent="-342900">
+              <a:spcAft>
+                <a:spcPts val="300"/>
+              </a:spcAft>
+              <a:buSzPct val="100000"/>
+              <a:buChar char="•"/>
+            </a:pPr>
+            <a:r>
+              <a:rPr lang="en-US" sz="1150" dirty="0">
+                <a:solidFill>
+                  <a:srgbClr val="212121"/>
+                </a:solidFill>
+                <a:latin typeface="Calibri" pitchFamily="34" charset="0"/>
+                <a:ea typeface="Calibri" pitchFamily="34" charset="-122"/>
+                <a:cs typeface="Calibri" pitchFamily="34" charset="-120"/>
+              </a:rPr>
+              <a:t>Hatcliff &amp; Belt, </a:t>
+            </a:r>
+            <a:pPr algn="l" indent="0" marL="0">
+              <a:spcAft>
+                <a:spcPts val="300"/>
+              </a:spcAft>
+              <a:buNone/>
+            </a:pPr>
+            <a:r>
+              <a:rPr lang="en-US" sz="1150" i="1" dirty="0">
+                <a:solidFill>
+                  <a:srgbClr val="212121"/>
+                </a:solidFill>
+                <a:latin typeface="Calibri" pitchFamily="34" charset="0"/>
+                <a:ea typeface="Calibri" pitchFamily="34" charset="-122"/>
+                <a:cs typeface="Calibri" pitchFamily="34" charset="-120"/>
+              </a:rPr>
+              <a:t>The Isolette System: Illustrating End-to-End Artifacts for Rigorous Model-Based Engineering</a:t>
+            </a:r>
+            <a:pPr algn="l" indent="0" marL="0">
+              <a:spcAft>
+                <a:spcPts val="300"/>
+              </a:spcAft>
+              <a:buNone/>
+            </a:pPr>
+            <a:r>
+              <a:rPr lang="en-US" sz="1150" dirty="0">
+                <a:solidFill>
+                  <a:srgbClr val="212121"/>
+                </a:solidFill>
+                <a:latin typeface="Calibri" pitchFamily="34" charset="0"/>
+                <a:ea typeface="Calibri" pitchFamily="34" charset="-122"/>
+                <a:cs typeface="Calibri" pitchFamily="34" charset="-120"/>
+              </a:rPr>
+              <a:t>, Springer LNCS 15240, 2025</a:t>
+            </a:r>
+            <a:endParaRPr lang="en-US" sz="1400" dirty="0"/>
+          </a:p>
+          <a:p>
+            <a:pPr algn="l" marL="342900" indent="-342900">
+              <a:spcAft>
+                <a:spcPts val="300"/>
+              </a:spcAft>
+              <a:buSzPct val="100000"/>
+              <a:buChar char="•"/>
+            </a:pPr>
+            <a:r>
+              <a:rPr lang="en-US" sz="1150" dirty="0">
+                <a:solidFill>
+                  <a:srgbClr val="212121"/>
+                </a:solidFill>
+                <a:latin typeface="Calibri" pitchFamily="34" charset="0"/>
+                <a:ea typeface="Calibri" pitchFamily="34" charset="-122"/>
+                <a:cs typeface="Calibri" pitchFamily="34" charset="-120"/>
+              </a:rPr>
+              <a:t>Hatcliff, Belt, Robby, McKenzie, Liang, </a:t>
+            </a:r>
+            <a:pPr algn="l" indent="0" marL="0">
+              <a:spcAft>
+                <a:spcPts val="300"/>
+              </a:spcAft>
+              <a:buNone/>
+            </a:pPr>
+            <a:r>
+              <a:rPr lang="en-US" sz="1150" i="1" dirty="0">
+                <a:solidFill>
+                  <a:srgbClr val="212121"/>
+                </a:solidFill>
+                <a:latin typeface="Calibri" pitchFamily="34" charset="0"/>
+                <a:ea typeface="Calibri" pitchFamily="34" charset="-122"/>
+                <a:cs typeface="Calibri" pitchFamily="34" charset="-120"/>
+              </a:rPr>
+              <a:t>End-to-End Formal Methods Integrated Development with SysMLv2 Using HAMR</a:t>
+            </a:r>
+            <a:pPr algn="l" indent="0" marL="0">
+              <a:spcAft>
+                <a:spcPts val="300"/>
+              </a:spcAft>
+              <a:buNone/>
+            </a:pPr>
+            <a:r>
+              <a:rPr lang="en-US" sz="1150" dirty="0">
+                <a:solidFill>
+                  <a:srgbClr val="212121"/>
+                </a:solidFill>
+                <a:latin typeface="Calibri" pitchFamily="34" charset="0"/>
+                <a:ea typeface="Calibri" pitchFamily="34" charset="-122"/>
+                <a:cs typeface="Calibri" pitchFamily="34" charset="-120"/>
+              </a:rPr>
+              <a:t>, Springer, 2025</a:t>
+            </a:r>
+            <a:endParaRPr lang="en-US" sz="1400" dirty="0"/>
+          </a:p>
+          <a:p>
+            <a:pPr algn="l" marL="342900" indent="-342900">
+              <a:spcAft>
+                <a:spcPts val="300"/>
+              </a:spcAft>
+              <a:buSzPct val="100000"/>
+              <a:buChar char="•"/>
+            </a:pPr>
+            <a:r>
+              <a:rPr lang="en-US" sz="1150" dirty="0">
+                <a:solidFill>
+                  <a:srgbClr val="212121"/>
+                </a:solidFill>
+                <a:latin typeface="Calibri" pitchFamily="34" charset="0"/>
+                <a:ea typeface="Calibri" pitchFamily="34" charset="-122"/>
+                <a:cs typeface="Calibri" pitchFamily="34" charset="-120"/>
+              </a:rPr>
+              <a:t>Hatcliff, Belt, Robby, Carpenter, </a:t>
+            </a:r>
+            <a:pPr algn="l" indent="0" marL="0">
+              <a:spcAft>
+                <a:spcPts val="300"/>
+              </a:spcAft>
+              <a:buNone/>
+            </a:pPr>
+            <a:r>
+              <a:rPr lang="en-US" sz="1150" i="1" dirty="0">
+                <a:solidFill>
+                  <a:srgbClr val="212121"/>
+                </a:solidFill>
+                <a:latin typeface="Calibri" pitchFamily="34" charset="0"/>
+                <a:ea typeface="Calibri" pitchFamily="34" charset="-122"/>
+                <a:cs typeface="Calibri" pitchFamily="34" charset="-120"/>
+              </a:rPr>
+              <a:t>HAMR: An AADL Multi-platform Code Generation Toolset</a:t>
+            </a:r>
+            <a:pPr algn="l" indent="0" marL="0">
+              <a:spcAft>
+                <a:spcPts val="300"/>
+              </a:spcAft>
+              <a:buNone/>
+            </a:pPr>
+            <a:r>
+              <a:rPr lang="en-US" sz="1150" dirty="0">
+                <a:solidFill>
+                  <a:srgbClr val="212121"/>
+                </a:solidFill>
+                <a:latin typeface="Calibri" pitchFamily="34" charset="0"/>
+                <a:ea typeface="Calibri" pitchFamily="34" charset="-122"/>
+                <a:cs typeface="Calibri" pitchFamily="34" charset="-120"/>
+              </a:rPr>
+              <a:t>, ISoLA 2021, LNCS 13036, pp. 274–295</a:t>
+            </a:r>
+            <a:endParaRPr lang="en-US" sz="1400" dirty="0"/>
+          </a:p>
+          <a:p>
+            <a:pPr algn="l" marL="342900" indent="-342900">
+              <a:spcAft>
+                <a:spcPts val="300"/>
+              </a:spcAft>
+              <a:buSzPct val="100000"/>
+              <a:buChar char="•"/>
+            </a:pPr>
+            <a:r>
+              <a:rPr lang="en-US" sz="1150" dirty="0">
+                <a:solidFill>
+                  <a:srgbClr val="212121"/>
+                </a:solidFill>
+                <a:latin typeface="Calibri" pitchFamily="34" charset="0"/>
+                <a:ea typeface="Calibri" pitchFamily="34" charset="-122"/>
+                <a:cs typeface="Calibri" pitchFamily="34" charset="-120"/>
+              </a:rPr>
+              <a:t>Lempia &amp; Miller, </a:t>
+            </a:r>
+            <a:pPr algn="l" indent="0" marL="0">
+              <a:spcAft>
+                <a:spcPts val="300"/>
+              </a:spcAft>
+              <a:buNone/>
+            </a:pPr>
+            <a:r>
+              <a:rPr lang="en-US" sz="1150" i="1" dirty="0">
+                <a:solidFill>
+                  <a:srgbClr val="212121"/>
+                </a:solidFill>
+                <a:latin typeface="Calibri" pitchFamily="34" charset="0"/>
+                <a:ea typeface="Calibri" pitchFamily="34" charset="-122"/>
+                <a:cs typeface="Calibri" pitchFamily="34" charset="-120"/>
+              </a:rPr>
+              <a:t>Requirements Engineering Management Handbook</a:t>
+            </a:r>
+            <a:pPr algn="l" indent="0" marL="0">
+              <a:spcAft>
+                <a:spcPts val="300"/>
+              </a:spcAft>
+              <a:buNone/>
+            </a:pPr>
+            <a:r>
+              <a:rPr lang="en-US" sz="1150" dirty="0">
+                <a:solidFill>
+                  <a:srgbClr val="212121"/>
+                </a:solidFill>
+                <a:latin typeface="Calibri" pitchFamily="34" charset="0"/>
+                <a:ea typeface="Calibri" pitchFamily="34" charset="-122"/>
+                <a:cs typeface="Calibri" pitchFamily="34" charset="-120"/>
+              </a:rPr>
+              <a:t>, DOT/FAA/AR-08/32, 2009</a:t>
+            </a:r>
+            <a:endParaRPr lang="en-US" sz="1400" dirty="0"/>
+          </a:p>
+          <a:p>
+            <a:pPr algn="l" marL="342900" indent="-342900">
+              <a:spcAft>
+                <a:spcPts val="300"/>
+              </a:spcAft>
+              <a:buSzPct val="100000"/>
+              <a:buChar char="•"/>
+            </a:pPr>
+            <a:r>
+              <a:rPr lang="en-US" sz="1150" dirty="0">
+                <a:solidFill>
+                  <a:srgbClr val="212121"/>
+                </a:solidFill>
+                <a:latin typeface="Calibri" pitchFamily="34" charset="0"/>
+                <a:ea typeface="Calibri" pitchFamily="34" charset="-122"/>
+                <a:cs typeface="Calibri" pitchFamily="34" charset="-120"/>
+              </a:rPr>
+              <a:t>INSPECTA models: github.com/loonwerks/INSPECTA-models</a:t>
+            </a:r>
+            <a:endParaRPr lang="en-US" sz="1400" dirty="0"/>
+          </a:p>
+          <a:p>
+            <a:pPr algn="l" indent="0" marL="0">
+              <a:spcBef>
+                <a:spcPts val="1200"/>
+              </a:spcBef>
+              <a:spcAft>
+                <a:spcPts val="400"/>
+              </a:spcAft>
+              <a:buNone/>
+            </a:pPr>
+            <a:r>
+              <a:rPr lang="en-US" sz="1400" b="1" dirty="0">
+                <a:solidFill>
+                  <a:srgbClr val="1E2761"/>
+                </a:solidFill>
+                <a:latin typeface="Calibri" pitchFamily="34" charset="0"/>
+                <a:ea typeface="Calibri" pitchFamily="34" charset="-122"/>
+                <a:cs typeface="Calibri" pitchFamily="34" charset="-120"/>
+              </a:rPr>
+              <a:t>Attestation foundations</a:t>
+            </a:r>
+            <a:endParaRPr lang="en-US" sz="1400" dirty="0"/>
+          </a:p>
+          <a:p>
+            <a:pPr algn="l" marL="342900" indent="-342900">
+              <a:spcAft>
+                <a:spcPts val="300"/>
+              </a:spcAft>
+              <a:buSzPct val="100000"/>
+              <a:buChar char="•"/>
+            </a:pPr>
+            <a:r>
+              <a:rPr lang="en-US" sz="1150" dirty="0">
+                <a:solidFill>
+                  <a:srgbClr val="212121"/>
+                </a:solidFill>
+                <a:latin typeface="Calibri" pitchFamily="34" charset="0"/>
+                <a:ea typeface="Calibri" pitchFamily="34" charset="-122"/>
+                <a:cs typeface="Calibri" pitchFamily="34" charset="-120"/>
+              </a:rPr>
+              <a:t>Ramsdell, Rowe, Alexander, Helble, Loscocco, Pendergrass, Petz, </a:t>
+            </a:r>
+            <a:pPr algn="l" indent="0" marL="0">
+              <a:spcAft>
+                <a:spcPts val="300"/>
+              </a:spcAft>
+              <a:buNone/>
+            </a:pPr>
+            <a:r>
+              <a:rPr lang="en-US" sz="1150" i="1" dirty="0">
+                <a:solidFill>
+                  <a:srgbClr val="212121"/>
+                </a:solidFill>
+                <a:latin typeface="Calibri" pitchFamily="34" charset="0"/>
+                <a:ea typeface="Calibri" pitchFamily="34" charset="-122"/>
+                <a:cs typeface="Calibri" pitchFamily="34" charset="-120"/>
+              </a:rPr>
+              <a:t>Orchestrating Layered Attestations</a:t>
+            </a:r>
+            <a:pPr algn="l" indent="0" marL="0">
+              <a:spcAft>
+                <a:spcPts val="300"/>
+              </a:spcAft>
+              <a:buNone/>
+            </a:pPr>
+            <a:r>
+              <a:rPr lang="en-US" sz="1150" dirty="0">
+                <a:solidFill>
+                  <a:srgbClr val="212121"/>
+                </a:solidFill>
+                <a:latin typeface="Calibri" pitchFamily="34" charset="0"/>
+                <a:ea typeface="Calibri" pitchFamily="34" charset="-122"/>
+                <a:cs typeface="Calibri" pitchFamily="34" charset="-120"/>
+              </a:rPr>
+              <a:t>, POST 2019, LNCS 11426</a:t>
+            </a:r>
+            <a:endParaRPr lang="en-US" sz="1400" dirty="0"/>
+          </a:p>
+          <a:p>
+            <a:pPr algn="l" indent="0" marL="0">
+              <a:spcBef>
+                <a:spcPts val="1200"/>
+              </a:spcBef>
+              <a:spcAft>
+                <a:spcPts val="400"/>
+              </a:spcAft>
+              <a:buNone/>
+            </a:pPr>
+            <a:r>
+              <a:rPr lang="en-US" sz="1400" b="1" dirty="0">
+                <a:solidFill>
+                  <a:srgbClr val="1E2761"/>
+                </a:solidFill>
+                <a:latin typeface="Calibri" pitchFamily="34" charset="0"/>
+                <a:ea typeface="Calibri" pitchFamily="34" charset="-122"/>
+                <a:cs typeface="Calibri" pitchFamily="34" charset="-120"/>
+              </a:rPr>
+              <a:t>Verification &amp; platform</a:t>
+            </a:r>
+            <a:endParaRPr lang="en-US" sz="1400" dirty="0"/>
+          </a:p>
+          <a:p>
+            <a:pPr algn="l" marL="342900" indent="-342900">
+              <a:spcAft>
+                <a:spcPts val="300"/>
+              </a:spcAft>
+              <a:buSzPct val="100000"/>
+              <a:buChar char="•"/>
+            </a:pPr>
+            <a:r>
+              <a:rPr lang="en-US" sz="1150" dirty="0">
+                <a:solidFill>
+                  <a:srgbClr val="212121"/>
+                </a:solidFill>
+                <a:latin typeface="Calibri" pitchFamily="34" charset="0"/>
+                <a:ea typeface="Calibri" pitchFamily="34" charset="-122"/>
+                <a:cs typeface="Calibri" pitchFamily="34" charset="-120"/>
+              </a:rPr>
+              <a:t>Lattuada, Hance, Cho, Brun, Subasinghe, Zhou, Howell, Parno, Hawblitzel, </a:t>
+            </a:r>
+            <a:pPr algn="l" indent="0" marL="0">
+              <a:spcAft>
+                <a:spcPts val="300"/>
+              </a:spcAft>
+              <a:buNone/>
+            </a:pPr>
+            <a:r>
+              <a:rPr lang="en-US" sz="1150" i="1" dirty="0">
+                <a:solidFill>
+                  <a:srgbClr val="212121"/>
+                </a:solidFill>
+                <a:latin typeface="Calibri" pitchFamily="34" charset="0"/>
+                <a:ea typeface="Calibri" pitchFamily="34" charset="-122"/>
+                <a:cs typeface="Calibri" pitchFamily="34" charset="-120"/>
+              </a:rPr>
+              <a:t>Verus: Verifying Rust Programs using Linear Ghost Types</a:t>
+            </a:r>
+            <a:pPr algn="l" indent="0" marL="0">
+              <a:spcAft>
+                <a:spcPts val="300"/>
+              </a:spcAft>
+              <a:buNone/>
+            </a:pPr>
+            <a:r>
+              <a:rPr lang="en-US" sz="1150" dirty="0">
+                <a:solidFill>
+                  <a:srgbClr val="212121"/>
+                </a:solidFill>
+                <a:latin typeface="Calibri" pitchFamily="34" charset="0"/>
+                <a:ea typeface="Calibri" pitchFamily="34" charset="-122"/>
+                <a:cs typeface="Calibri" pitchFamily="34" charset="-120"/>
+              </a:rPr>
+              <a:t>, PACMPL 7 (OOPSLA1), 2023</a:t>
+            </a:r>
+            <a:endParaRPr lang="en-US" sz="1400" dirty="0"/>
+          </a:p>
+          <a:p>
+            <a:pPr algn="l" marL="342900" indent="-342900">
+              <a:spcAft>
+                <a:spcPts val="300"/>
+              </a:spcAft>
+              <a:buSzPct val="100000"/>
+              <a:buChar char="•"/>
+            </a:pPr>
+            <a:r>
+              <a:rPr lang="en-US" sz="1150" dirty="0">
+                <a:solidFill>
+                  <a:srgbClr val="212121"/>
+                </a:solidFill>
+                <a:latin typeface="Calibri" pitchFamily="34" charset="0"/>
+                <a:ea typeface="Calibri" pitchFamily="34" charset="-122"/>
+                <a:cs typeface="Calibri" pitchFamily="34" charset="-120"/>
+              </a:rPr>
+              <a:t>Klein et al., </a:t>
+            </a:r>
+            <a:pPr algn="l" indent="0" marL="0">
+              <a:spcAft>
+                <a:spcPts val="300"/>
+              </a:spcAft>
+              <a:buNone/>
+            </a:pPr>
+            <a:r>
+              <a:rPr lang="en-US" sz="1150" i="1" dirty="0">
+                <a:solidFill>
+                  <a:srgbClr val="212121"/>
+                </a:solidFill>
+                <a:latin typeface="Calibri" pitchFamily="34" charset="0"/>
+                <a:ea typeface="Calibri" pitchFamily="34" charset="-122"/>
+                <a:cs typeface="Calibri" pitchFamily="34" charset="-120"/>
+              </a:rPr>
+              <a:t>seL4: Formal Verification of an OS Kernel</a:t>
+            </a:r>
+            <a:pPr algn="l" indent="0" marL="0">
+              <a:spcAft>
+                <a:spcPts val="300"/>
+              </a:spcAft>
+              <a:buNone/>
+            </a:pPr>
+            <a:r>
+              <a:rPr lang="en-US" sz="1150" dirty="0">
+                <a:solidFill>
+                  <a:srgbClr val="212121"/>
+                </a:solidFill>
+                <a:latin typeface="Calibri" pitchFamily="34" charset="0"/>
+                <a:ea typeface="Calibri" pitchFamily="34" charset="-122"/>
+                <a:cs typeface="Calibri" pitchFamily="34" charset="-120"/>
+              </a:rPr>
+              <a:t>, SOSP 2009</a:t>
+            </a:r>
+            <a:endParaRPr lang="en-US" sz="1400" dirty="0"/>
           </a:p>
         </p:txBody>
       </p:sp>
@@ -9781,319 +10481,4 @@
     </a:ext>
   </a:extLst>
 </a:theme>
-</file>
-
-<file path=ppt/theme/theme2.xml><?xml version="1.0" encoding="utf-8"?>
-<a:theme xmlns:a="http://schemas.openxmlformats.org/drawingml/2006/main" name="Office Theme">
-  <a:themeElements>
-    <a:clrScheme name="Office">
-      <a:dk1>
-        <a:sysClr val="windowText" lastClr="000000"/>
-      </a:dk1>
-      <a:lt1>
-        <a:sysClr val="window" lastClr="FFFFFF"/>
-      </a:lt1>
-      <a:dk2>
-        <a:srgbClr val="0E2841"/>
-      </a:dk2>
-      <a:lt2>
-        <a:srgbClr val="E8E8E8"/>
-      </a:lt2>
-      <a:accent1>
-        <a:srgbClr val="156082"/>
-      </a:accent1>
-      <a:accent2>
-        <a:srgbClr val="E97132"/>
-      </a:accent2>
-      <a:accent3>
-        <a:srgbClr val="196B24"/>
-      </a:accent3>
-      <a:accent4>
-        <a:srgbClr val="0F9ED5"/>
-      </a:accent4>
-      <a:accent5>
-        <a:srgbClr val="A02B93"/>
-      </a:accent5>
-      <a:accent6>
-        <a:srgbClr val="4EA72E"/>
-      </a:accent6>
-      <a:hlink>
-        <a:srgbClr val="467886"/>
-      </a:hlink>
-      <a:folHlink>
-        <a:srgbClr val="96607D"/>
-      </a:folHlink>
-    </a:clrScheme>
-    <a:fontScheme name="Office">
-      <a:majorFont>
-        <a:latin typeface="Aptos Display" panose="02110004020202020204"/>
-        <a:ea typeface=""/>
-        <a:cs typeface=""/>
-        <a:font script="Jpan" typeface="游ゴシック Light"/>
-        <a:font script="Hang" typeface="맑은 고딕"/>
-        <a:font script="Hans" typeface="等线 Light"/>
-        <a:font script="Hant" typeface="新細明體"/>
-        <a:font script="Arab" typeface="Times New Roman"/>
-        <a:font script="Hebr" typeface="Times New Roman"/>
-        <a:font script="Thai" typeface="Angsana New"/>
-        <a:font script="Ethi" typeface="Nyala"/>
-        <a:font script="Beng" typeface="Vrinda"/>
-        <a:font script="Gujr" typeface="Shruti"/>
-        <a:font script="Khmr" typeface="MoolBoran"/>
-        <a:font script="Knda" typeface="Tunga"/>
-        <a:font script="Guru" typeface="Raavi"/>
-        <a:font script="Cans" typeface="Euphemia"/>
-        <a:font script="Cher" typeface="Plantagenet Cherokee"/>
-        <a:font script="Yiii" typeface="Microsoft Yi Baiti"/>
-        <a:font script="Tibt" typeface="Microsoft Himalaya"/>
-        <a:font script="Thaa" typeface="MV Boli"/>
-        <a:font script="Deva" typeface="Mangal"/>
-        <a:font script="Telu" typeface="Gautami"/>
-        <a:font script="Taml" typeface="Latha"/>
-        <a:font script="Syrc" typeface="Estrangelo Edessa"/>
-        <a:font script="Orya" typeface="Kalinga"/>
-        <a:font script="Mlym" typeface="Kartika"/>
-        <a:font script="Laoo" typeface="DokChampa"/>
-        <a:font script="Sinh" typeface="Iskoola Pota"/>
-        <a:font script="Mong" typeface="Mongolian Baiti"/>
-        <a:font script="Viet" typeface="Times New Roman"/>
-        <a:font script="Uigh" typeface="Microsoft Uighur"/>
-        <a:font script="Geor" typeface="Sylfaen"/>
-        <a:font script="Armn" typeface="Arial"/>
-        <a:font script="Bugi" typeface="Leelawadee UI"/>
-        <a:font script="Bopo" typeface="Microsoft JhengHei"/>
-        <a:font script="Java" typeface="Javanese Text"/>
-        <a:font script="Lisu" typeface="Segoe UI"/>
-        <a:font script="Mymr" typeface="Myanmar Text"/>
-        <a:font script="Nkoo" typeface="Ebrima"/>
-        <a:font script="Olck" typeface="Nirmala UI"/>
-        <a:font script="Osma" typeface="Ebrima"/>
-        <a:font script="Phag" typeface="Phagspa"/>
-        <a:font script="Syrn" typeface="Estrangelo Edessa"/>
-        <a:font script="Syrj" typeface="Estrangelo Edessa"/>
-        <a:font script="Syre" typeface="Estrangelo Edessa"/>
-        <a:font script="Sora" typeface="Nirmala UI"/>
-        <a:font script="Tale" typeface="Microsoft Tai Le"/>
-        <a:font script="Talu" typeface="Microsoft New Tai Lue"/>
-        <a:font script="Tfng" typeface="Ebrima"/>
-      </a:majorFont>
-      <a:minorFont>
-        <a:latin typeface="Aptos" panose="02110004020202020204"/>
-        <a:ea typeface=""/>
-        <a:cs typeface=""/>
-        <a:font script="Jpan" typeface="游ゴシック"/>
-        <a:font script="Hang" typeface="맑은 고딕"/>
-        <a:font script="Hans" typeface="等线"/>
-        <a:font script="Hant" typeface="新細明體"/>
-        <a:font script="Arab" typeface="Arial"/>
-        <a:font script="Hebr" typeface="Arial"/>
-        <a:font script="Thai" typeface="Cordia New"/>
-        <a:font script="Ethi" typeface="Nyala"/>
-        <a:font script="Beng" typeface="Vrinda"/>
-        <a:font script="Gujr" typeface="Shruti"/>
-        <a:font script="Khmr" typeface="DaunPenh"/>
-        <a:font script="Knda" typeface="Tunga"/>
-        <a:font script="Guru" typeface="Raavi"/>
-        <a:font script="Cans" typeface="Euphemia"/>
-        <a:font script="Cher" typeface="Plantagenet Cherokee"/>
-        <a:font script="Yiii" typeface="Microsoft Yi Baiti"/>
-        <a:font script="Tibt" typeface="Microsoft Himalaya"/>
-        <a:font script="Thaa" typeface="MV Boli"/>
-        <a:font script="Deva" typeface="Mangal"/>
-        <a:font script="Telu" typeface="Gautami"/>
-        <a:font script="Taml" typeface="Latha"/>
-        <a:font script="Syrc" typeface="Estrangelo Edessa"/>
-        <a:font script="Orya" typeface="Kalinga"/>
-        <a:font script="Mlym" typeface="Kartika"/>
-        <a:font script="Laoo" typeface="DokChampa"/>
-        <a:font script="Sinh" typeface="Iskoola Pota"/>
-        <a:font script="Mong" typeface="Mongolian Baiti"/>
-        <a:font script="Viet" typeface="Arial"/>
-        <a:font script="Uigh" typeface="Microsoft Uighur"/>
-        <a:font script="Geor" typeface="Sylfaen"/>
-        <a:font script="Armn" typeface="Arial"/>
-        <a:font script="Bugi" typeface="Leelawadee UI"/>
-        <a:font script="Bopo" typeface="Microsoft JhengHei"/>
-        <a:font script="Java" typeface="Javanese Text"/>
-        <a:font script="Lisu" typeface="Segoe UI"/>
-        <a:font script="Mymr" typeface="Myanmar Text"/>
-        <a:font script="Nkoo" typeface="Ebrima"/>
-        <a:font script="Olck" typeface="Nirmala UI"/>
-        <a:font script="Osma" typeface="Ebrima"/>
-        <a:font script="Phag" typeface="Phagspa"/>
-        <a:font script="Syrn" typeface="Estrangelo Edessa"/>
-        <a:font script="Syrj" typeface="Estrangelo Edessa"/>
-        <a:font script="Syre" typeface="Estrangelo Edessa"/>
-        <a:font script="Sora" typeface="Nirmala UI"/>
-        <a:font script="Tale" typeface="Microsoft Tai Le"/>
-        <a:font script="Talu" typeface="Microsoft New Tai Lue"/>
-        <a:font script="Tfng" typeface="Ebrima"/>
-      </a:minorFont>
-    </a:fontScheme>
-    <a:fmtScheme name="Office">
-      <a:fillStyleLst>
-        <a:solidFill>
-          <a:schemeClr val="phClr"/>
-        </a:solidFill>
-        <a:gradFill rotWithShape="1">
-          <a:gsLst>
-            <a:gs pos="0">
-              <a:schemeClr val="phClr">
-                <a:lumMod val="110000"/>
-                <a:satMod val="105000"/>
-                <a:tint val="67000"/>
-              </a:schemeClr>
-            </a:gs>
-            <a:gs pos="50000">
-              <a:schemeClr val="phClr">
-                <a:lumMod val="105000"/>
-                <a:satMod val="103000"/>
-                <a:tint val="73000"/>
-              </a:schemeClr>
-            </a:gs>
-            <a:gs pos="100000">
-              <a:schemeClr val="phClr">
-                <a:lumMod val="105000"/>
-                <a:satMod val="109000"/>
-                <a:tint val="81000"/>
-              </a:schemeClr>
-            </a:gs>
-          </a:gsLst>
-          <a:lin ang="5400000" scaled="0"/>
-        </a:gradFill>
-        <a:gradFill rotWithShape="1">
-          <a:gsLst>
-            <a:gs pos="0">
-              <a:schemeClr val="phClr">
-                <a:satMod val="103000"/>
-                <a:lumMod val="102000"/>
-                <a:tint val="94000"/>
-              </a:schemeClr>
-            </a:gs>
-            <a:gs pos="50000">
-              <a:schemeClr val="phClr">
-                <a:satMod val="110000"/>
-                <a:lumMod val="100000"/>
-                <a:shade val="100000"/>
-              </a:schemeClr>
-            </a:gs>
-            <a:gs pos="100000">
-              <a:schemeClr val="phClr">
-                <a:lumMod val="99000"/>
-                <a:satMod val="120000"/>
-                <a:shade val="78000"/>
-              </a:schemeClr>
-            </a:gs>
-          </a:gsLst>
-          <a:lin ang="5400000" scaled="0"/>
-        </a:gradFill>
-      </a:fillStyleLst>
-      <a:lnStyleLst>
-        <a:ln w="12700" cap="flat" cmpd="sng" algn="ctr">
-          <a:solidFill>
-            <a:schemeClr val="phClr"/>
-          </a:solidFill>
-          <a:prstDash val="solid"/>
-          <a:miter lim="800000"/>
-        </a:ln>
-        <a:ln w="19050" cap="flat" cmpd="sng" algn="ctr">
-          <a:solidFill>
-            <a:schemeClr val="phClr"/>
-          </a:solidFill>
-          <a:prstDash val="solid"/>
-          <a:miter lim="800000"/>
-        </a:ln>
-        <a:ln w="25400" cap="flat" cmpd="sng" algn="ctr">
-          <a:solidFill>
-            <a:schemeClr val="phClr"/>
-          </a:solidFill>
-          <a:prstDash val="solid"/>
-          <a:miter lim="800000"/>
-        </a:ln>
-      </a:lnStyleLst>
-      <a:effectStyleLst>
-        <a:effectStyle>
-          <a:effectLst/>
-        </a:effectStyle>
-        <a:effectStyle>
-          <a:effectLst/>
-        </a:effectStyle>
-        <a:effectStyle>
-          <a:effectLst>
-            <a:outerShdw blurRad="57150" dist="19050" dir="5400000" algn="ctr" rotWithShape="0">
-              <a:srgbClr val="000000">
-                <a:alpha val="63000"/>
-              </a:srgbClr>
-            </a:outerShdw>
-          </a:effectLst>
-        </a:effectStyle>
-      </a:effectStyleLst>
-      <a:bgFillStyleLst>
-        <a:solidFill>
-          <a:schemeClr val="phClr"/>
-        </a:solidFill>
-        <a:solidFill>
-          <a:schemeClr val="phClr">
-            <a:tint val="95000"/>
-            <a:satMod val="170000"/>
-          </a:schemeClr>
-        </a:solidFill>
-        <a:gradFill rotWithShape="1">
-          <a:gsLst>
-            <a:gs pos="0">
-              <a:schemeClr val="phClr">
-                <a:tint val="93000"/>
-                <a:satMod val="150000"/>
-                <a:shade val="98000"/>
-                <a:lumMod val="102000"/>
-              </a:schemeClr>
-            </a:gs>
-            <a:gs pos="50000">
-              <a:schemeClr val="phClr">
-                <a:tint val="98000"/>
-                <a:satMod val="130000"/>
-                <a:shade val="90000"/>
-                <a:lumMod val="103000"/>
-              </a:schemeClr>
-            </a:gs>
-            <a:gs pos="100000">
-              <a:schemeClr val="phClr">
-                <a:shade val="63000"/>
-                <a:satMod val="120000"/>
-              </a:schemeClr>
-            </a:gs>
-          </a:gsLst>
-          <a:lin ang="5400000" scaled="0"/>
-        </a:gradFill>
-      </a:bgFillStyleLst>
-    </a:fmtScheme>
-  </a:themeElements>
-  <a:objectDefaults>
-    <a:lnDef>
-      <a:spPr/>
-      <a:bodyPr/>
-      <a:lstStyle/>
-      <a:style>
-        <a:lnRef idx="2">
-          <a:schemeClr val="accent1"/>
-        </a:lnRef>
-        <a:fillRef idx="0">
-          <a:schemeClr val="accent1"/>
-        </a:fillRef>
-        <a:effectRef idx="1">
-          <a:schemeClr val="accent1"/>
-        </a:effectRef>
-        <a:fontRef idx="minor">
-          <a:schemeClr val="tx1"/>
-        </a:fontRef>
-      </a:style>
-    </a:lnDef>
-  </a:objectDefaults>
-  <a:extraClrSchemeLst/>
-  <a:extLst>
-    <a:ext uri="{05A4C25C-085E-4340-85A3-A5531E510DB2}">
-      <thm15:themeFamily xmlns:thm15="http://schemas.microsoft.com/office/thememl/2012/main" name="Office Theme" id="{2E142A2C-CD16-42D6-873A-C26D2A0506FA}" vid="{1BDDFF52-6CD6-40A5-AB3C-68EB2F1E4D0A}"/>
-    </a:ext>
-  </a:extLst>
-</a:theme>
 </file>
</xml_diff>

<commit_message>
isolette stats: 30 measured toolchain/dependency files tile
Sixth measured-surface tile, verified from fixtures: 4 verus-term tool
hashes + 9 hamr_tools jars + 17 sysml_libs files; column compacted to
fit.

Co-Authored-By: Claude Fable 5 <noreply@anthropic.com>
</commit_message>
<xml_diff>
--- a/docs/video_slides_draft.pptx
+++ b/docs/video_slides_draft.pptx
@@ -4,6 +4,9 @@
   <p:sldMasterIdLst>
     <p:sldMasterId id="2147483648" r:id="rId1"/>
   </p:sldMasterIdLst>
+  <p:notesMasterIdLst>
+    <p:notesMasterId r:id="rId11"/>
+  </p:notesMasterIdLst>
   <p:sldIdLst>
     <p:sldId id="256" r:id="rId2"/>
     <p:sldId id="257" r:id="rId3"/>
@@ -15,9 +18,6 @@
     <p:sldId id="263" r:id="rId9"/>
     <p:sldId id="264" r:id="rId10"/>
   </p:sldIdLst>
-  <p:notesMasterIdLst>
-    <p:notesMasterId r:id="rId11"/>
-  </p:notesMasterIdLst>
   <p:sldSz cx="12192000" cy="6858000"/>
   <p:notesSz cx="6858000" cy="12192000"/>
   <p:defaultTextStyle>
@@ -112,6 +112,11 @@
       </a:defRPr>
     </a:lvl9pPr>
   </p:defaultTextStyle>
+  <p:extLst>
+    <p:ext uri="{EFAFB233-063F-42B5-8137-9DF3F51BA10A}">
+      <p15:sldGuideLst xmlns:p15="http://schemas.microsoft.com/office/powerpoint/2012/main"/>
+    </p:ext>
+  </p:extLst>
 </p:presentation>
 </file>
 
@@ -137,234 +142,10 @@
           <a:chExt cx="0" cy="0"/>
         </a:xfrm>
       </p:grpSpPr>
-      <p:sp>
-        <p:nvSpPr>
-          <p:cNvPr id="2" name="Header Placeholder 1"/>
-          <p:cNvSpPr>
-            <a:spLocks noGrp="1"/>
-          </p:cNvSpPr>
-          <p:nvPr>
-            <p:ph type="hdr" sz="quarter"/>
-          </p:nvPr>
-        </p:nvSpPr>
-        <p:spPr>
-          <a:xfrm>
-            <a:off x="0" y="0"/>
-            <a:ext cx="2971800" cy="458788"/>
-          </a:xfrm>
-          <a:prstGeom prst="rect">
-            <a:avLst/>
-          </a:prstGeom>
-        </p:spPr>
-        <p:txBody>
-          <a:bodyPr vert="horz" lIns="91440" tIns="45720" rIns="91440" bIns="45720" rtlCol="0"/>
-          <a:lstStyle>
-            <a:lvl1pPr algn="l">
-              <a:defRPr sz="1200"/>
-            </a:lvl1pPr>
-          </a:lstStyle>
-          <a:p>
-            <a:endParaRPr lang="en-US"/>
-          </a:p>
-        </p:txBody>
-      </p:sp>
-      <p:sp>
-        <p:nvSpPr>
-          <p:cNvPr id="3" name="Date Placeholder 2"/>
-          <p:cNvSpPr>
-            <a:spLocks noGrp="1"/>
-          </p:cNvSpPr>
-          <p:nvPr>
-            <p:ph type="dt" idx="1"/>
-          </p:nvPr>
-        </p:nvSpPr>
-        <p:spPr>
-          <a:xfrm>
-            <a:off x="3884613" y="0"/>
-            <a:ext cx="2971800" cy="458788"/>
-          </a:xfrm>
-          <a:prstGeom prst="rect">
-            <a:avLst/>
-          </a:prstGeom>
-        </p:spPr>
-        <p:txBody>
-          <a:bodyPr vert="horz" lIns="91440" tIns="45720" rIns="91440" bIns="45720" rtlCol="0"/>
-          <a:lstStyle>
-            <a:lvl1pPr algn="r">
-              <a:defRPr sz="1200"/>
-            </a:lvl1pPr>
-          </a:lstStyle>
-          <a:p>
-            <a:fld id="{5282F153-3F37-0F45-9E97-73ACFA13230C}" type="datetimeFigureOut">
-              <a:rPr lang="en-US"/>
-              <a:t>7/23/19</a:t>
-            </a:fld>
-            <a:endParaRPr lang="en-US"/>
-          </a:p>
-        </p:txBody>
-      </p:sp>
-      <p:sp>
-        <p:nvSpPr>
-          <p:cNvPr id="4" name="Slide Image Placeholder 3"/>
-          <p:cNvSpPr>
-            <a:spLocks noGrp="1" noRot="1" noChangeAspect="1"/>
-          </p:cNvSpPr>
-          <p:nvPr>
-            <p:ph type="sldImg" idx="2"/>
-          </p:nvPr>
-        </p:nvSpPr>
-        <p:spPr>
-          <a:xfrm>
-            <a:off x="685800" y="1143000"/>
-            <a:ext cx="5486400" cy="3086100"/>
-          </a:xfrm>
-          <a:prstGeom prst="rect">
-            <a:avLst/>
-          </a:prstGeom>
-          <a:noFill/>
-          <a:ln w="12700">
-            <a:solidFill>
-              <a:prstClr val="black"/>
-            </a:solidFill>
-          </a:ln>
-        </p:spPr>
-        <p:txBody>
-          <a:bodyPr vert="horz" lIns="91440" tIns="45720" rIns="91440" bIns="45720" rtlCol="0" anchor="ctr"/>
-          <a:lstStyle/>
-          <a:p>
-            <a:endParaRPr lang="en-US"/>
-          </a:p>
-        </p:txBody>
-      </p:sp>
-      <p:sp>
-        <p:nvSpPr>
-          <p:cNvPr id="5" name="Notes Placeholder 4"/>
-          <p:cNvSpPr>
-            <a:spLocks noGrp="1"/>
-          </p:cNvSpPr>
-          <p:nvPr>
-            <p:ph type="body" sz="quarter" idx="3"/>
-          </p:nvPr>
-        </p:nvSpPr>
-        <p:spPr>
-          <a:xfrm>
-            <a:off x="685800" y="4400550"/>
-            <a:ext cx="5486400" cy="3600450"/>
-          </a:xfrm>
-          <a:prstGeom prst="rect">
-            <a:avLst/>
-          </a:prstGeom>
-        </p:spPr>
-        <p:txBody>
-          <a:bodyPr vert="horz" lIns="91440" tIns="45720" rIns="91440" bIns="45720" rtlCol="0"/>
-          <a:lstStyle/>
-          <a:p>
-            <a:pPr lvl="0"/>
-            <a:r>
-              <a:rPr lang="en-US"/>
-              <a:t>Click to edit Master text styles</a:t>
-            </a:r>
-          </a:p>
-          <a:p>
-            <a:pPr lvl="1"/>
-            <a:r>
-              <a:rPr lang="en-US"/>
-              <a:t>Second level</a:t>
-            </a:r>
-          </a:p>
-          <a:p>
-            <a:pPr lvl="2"/>
-            <a:r>
-              <a:rPr lang="en-US"/>
-              <a:t>Third level</a:t>
-            </a:r>
-          </a:p>
-          <a:p>
-            <a:pPr lvl="3"/>
-            <a:r>
-              <a:rPr lang="en-US"/>
-              <a:t>Fourth level</a:t>
-            </a:r>
-          </a:p>
-          <a:p>
-            <a:pPr lvl="4"/>
-            <a:r>
-              <a:rPr lang="en-US"/>
-              <a:t>Fifth level</a:t>
-            </a:r>
-          </a:p>
-        </p:txBody>
-      </p:sp>
-      <p:sp>
-        <p:nvSpPr>
-          <p:cNvPr id="6" name="Footer Placeholder 5"/>
-          <p:cNvSpPr>
-            <a:spLocks noGrp="1"/>
-          </p:cNvSpPr>
-          <p:nvPr>
-            <p:ph type="ftr" sz="quarter" idx="4"/>
-          </p:nvPr>
-        </p:nvSpPr>
-        <p:spPr>
-          <a:xfrm>
-            <a:off x="0" y="8685213"/>
-            <a:ext cx="2971800" cy="458787"/>
-          </a:xfrm>
-          <a:prstGeom prst="rect">
-            <a:avLst/>
-          </a:prstGeom>
-        </p:spPr>
-        <p:txBody>
-          <a:bodyPr vert="horz" lIns="91440" tIns="45720" rIns="91440" bIns="45720" rtlCol="0" anchor="b"/>
-          <a:lstStyle>
-            <a:lvl1pPr algn="l">
-              <a:defRPr sz="1200"/>
-            </a:lvl1pPr>
-          </a:lstStyle>
-          <a:p>
-            <a:endParaRPr lang="en-US"/>
-          </a:p>
-        </p:txBody>
-      </p:sp>
-      <p:sp>
-        <p:nvSpPr>
-          <p:cNvPr id="7" name="Slide Number Placeholder 6"/>
-          <p:cNvSpPr>
-            <a:spLocks noGrp="1"/>
-          </p:cNvSpPr>
-          <p:nvPr>
-            <p:ph type="sldNum" sz="quarter" idx="5"/>
-          </p:nvPr>
-        </p:nvSpPr>
-        <p:spPr>
-          <a:xfrm>
-            <a:off x="3884613" y="8685213"/>
-            <a:ext cx="2971800" cy="458787"/>
-          </a:xfrm>
-          <a:prstGeom prst="rect">
-            <a:avLst/>
-          </a:prstGeom>
-        </p:spPr>
-        <p:txBody>
-          <a:bodyPr vert="horz" lIns="91440" tIns="45720" rIns="91440" bIns="45720" rtlCol="0" anchor="b"/>
-          <a:lstStyle>
-            <a:lvl1pPr algn="r">
-              <a:defRPr sz="1200"/>
-            </a:lvl1pPr>
-          </a:lstStyle>
-          <a:p>
-            <a:fld id="{CE5E9CC1-C706-0F49-92D6-E571CC5EEA8F}" type="slidenum">
-              <a:rPr lang="en-US"/>
-              <a:t>‹#›</a:t>
-            </a:fld>
-            <a:endParaRPr lang="en-US"/>
-          </a:p>
-        </p:txBody>
-      </p:sp>
     </p:spTree>
     <p:extLst>
       <p:ext uri="{BB962C8B-B14F-4D97-AF65-F5344CB8AC3E}">
-        <p14:creationId xmlns:p14="http://schemas.microsoft.com/office/powerpoint/2010/main" val="1024086991"/>
+        <p14:creationId xmlns:p14="http://schemas.microsoft.com/office/powerpoint/2010/main" val="2913311002"/>
       </p:ext>
     </p:extLst>
   </p:cSld>
@@ -512,7 +293,6 @@
               <a:rPr lang="en-US" dirty="0"/>
               <a:t>Title card. Subtitle deliberately names the four core artifact classes - the deck's first echo of the artifact-class table (slide 6). Optional footer: INSPECTA program context.</a:t>
             </a:r>
-            <a:endParaRPr lang="en-US" dirty="0"/>
           </a:p>
         </p:txBody>
       </p:sp>
@@ -603,7 +383,6 @@
 Subline payoffs: developer claims -&gt; scenes 5/7; untrusted tools -&gt; scene 7; LLM outputs -&gt; capstone slides A/B; cached verdicts -&gt; scene 11.
 Visual TODO: three-stage widening-scope progression (boot-time -&gt; layered runtime -&gt; lifecycle loop) to replace/join the bullets.</a:t>
             </a:r>
-            <a:endParaRPr lang="en-US" dirty="0"/>
           </a:p>
         </p:txBody>
       </p:sp>
@@ -692,7 +471,6 @@
               <a:t>~15 seconds on first appearance; afterwards it rides on transition slides for free.
 Design decision: one master/layout holds the strip text so a section rename is a single edit. Header titles are provisional.</a:t>
             </a:r>
-            <a:endParaRPr lang="en-US" dirty="0"/>
           </a:p>
         </p:txBody>
       </p:sp>
@@ -783,7 +561,6 @@
 Snippet source: tests/fixtures/isolette_sysmlv2_rust_props/term.json, rendered in concrete syntax (branches flattened, target IDs shortened to file names - cosmetic).
 The verus-tier measure-then-use phrase is deliberately held back for scene 7's reveal.</a:t>
             </a:r>
-            <a:endParaRPr lang="en-US" dirty="0"/>
           </a:p>
         </p:txBody>
       </p:sp>
@@ -875,7 +652,6 @@
 Speaker-note-only details (cut from the slide): on_pass/on_fail dispatch mechanics, success-driven handoff for component-wise entries, max_attempts per rung.
 The legend earns its space: every scene's checklist frames render through these glyphs.</a:t>
             </a:r>
-            <a:endParaRPr lang="en-US" dirty="0"/>
           </a:p>
         </p:txBody>
       </p:sp>
@@ -966,7 +742,6 @@
 Predicate and restart-episode are deliberately OFF this slide (parked; placement TBD - possibly an 'evaluation primitives' strip). If asked: a predicate is the judge (one evaluation = one attestation episode), restart-episode is the freshness primitive (forget memoized verdicts, reset, re-evaluate).
 Also deliberately excluded (README-level detail): partition mechanics, component-wise entries and success handoff, dispatch latching, max_cycles.</a:t>
             </a:r>
-            <a:endParaRPr lang="en-US" dirty="0"/>
           </a:p>
         </p:txBody>
       </p:sp>
@@ -1056,7 +831,6 @@
 Spoken hook (never on-slide text): 'This table is deliberately incomplete - the demo will show why.' The cheat / sysproof / gensrc tiers are capstone slide C's punchline: attacks forced them into existence. Do not pre-introduce them here.
 Same column shape (class -&gt; measured how -&gt; judged by -&gt; repair) as capstone slide B, so the audience recognizes it when it returns.</a:t>
             </a:r>
-            <a:endParaRPr lang="en-US" dirty="0"/>
           </a:p>
         </p:txBody>
       </p:sp>
@@ -1148,7 +922,6 @@
 Held back on purpose (scene 9's reveal): cheat-tier depth stats - 86 blessed external_body sites, 10 scanned crates.
 Numbers verified exact 2026-08-25 (l1a targets, l2 slices, verus term, pub-proof-fn count); provision-dependent - re-verify before recording day.</a:t>
             </a:r>
-            <a:endParaRPr lang="en-US" dirty="0"/>
           </a:p>
         </p:txBody>
       </p:sp>
@@ -1237,7 +1010,6 @@
               <a:t>Collection point for every reference in the deck - keep this slide current as sections are added (isolette slide carries the K-State + AR-08-32 citations inline; Copland/Verus/seL4 seeded here ahead of their sections).
 DOIs on record in docs/video_slide_drafts.md.</a:t>
             </a:r>
-            <a:endParaRPr lang="en-US" dirty="0"/>
           </a:p>
         </p:txBody>
       </p:sp>
@@ -1310,6 +1082,11 @@
 <file path=ppt/slideMasters/slideMaster1.xml><?xml version="1.0" encoding="utf-8"?>
 <p:sldMaster xmlns:a="http://schemas.openxmlformats.org/drawingml/2006/main" xmlns:r="http://schemas.openxmlformats.org/officeDocument/2006/relationships" xmlns:p="http://schemas.openxmlformats.org/presentationml/2006/main">
   <p:cSld>
+    <p:bg>
+      <p:bgRef idx="1001">
+        <a:schemeClr val="bg1"/>
+      </p:bgRef>
+    </p:bg>
     <p:spTree>
       <p:nvGrpSpPr>
         <p:cNvPr id="1" name=""/>
@@ -1592,6 +1369,7 @@
         <a:solidFill>
           <a:srgbClr val="1E2761"/>
         </a:solidFill>
+        <a:effectLst/>
       </p:bgPr>
     </p:bg>
     <p:spTree>
@@ -1629,7 +1407,7 @@
           <a:bodyPr wrap="square" lIns="0" tIns="0" rIns="0" bIns="0" rtlCol="0" anchor="ctr"/>
           <a:lstStyle/>
           <a:p>
-            <a:pPr algn="l" indent="0" marL="0">
+            <a:pPr marL="0" indent="0" algn="l">
               <a:buNone/>
             </a:pPr>
             <a:r>
@@ -1668,7 +1446,7 @@
           <a:bodyPr wrap="square" lIns="0" tIns="0" rIns="0" bIns="0" rtlCol="0" anchor="ctr"/>
           <a:lstStyle/>
           <a:p>
-            <a:pPr algn="l" indent="0" marL="0">
+            <a:pPr marL="0" indent="0" algn="l">
               <a:buNone/>
             </a:pPr>
             <a:r>
@@ -1707,7 +1485,7 @@
           <a:bodyPr wrap="square" lIns="0" tIns="0" rIns="0" bIns="0" rtlCol="0" anchor="ctr"/>
           <a:lstStyle/>
           <a:p>
-            <a:pPr algn="l" indent="0" marL="0">
+            <a:pPr marL="0" indent="0" algn="l">
               <a:buNone/>
             </a:pPr>
             <a:r>
@@ -1741,6 +1519,7 @@
         <a:solidFill>
           <a:srgbClr val="FFFFFF"/>
         </a:solidFill>
+        <a:effectLst/>
       </p:bgPr>
     </p:bg>
     <p:spTree>
@@ -1778,7 +1557,7 @@
           <a:bodyPr wrap="square" lIns="0" tIns="0" rIns="0" bIns="0" rtlCol="0" anchor="ctr"/>
           <a:lstStyle/>
           <a:p>
-            <a:pPr indent="0" marL="0">
+            <a:pPr marL="0" indent="0">
               <a:buNone/>
             </a:pPr>
             <a:r>
@@ -1817,7 +1596,7 @@
           <a:bodyPr wrap="square" lIns="0" tIns="0" rIns="0" bIns="0" rtlCol="0" anchor="t"/>
           <a:lstStyle/>
           <a:p>
-            <a:pPr algn="l" marL="342900" indent="-342900">
+            <a:pPr marL="342900" indent="-342900" algn="l">
               <a:buSzPct val="100000"/>
               <a:buChar char="•"/>
             </a:pPr>
@@ -1830,13 +1609,10 @@
                 <a:ea typeface="Calibri" pitchFamily="34" charset="-122"/>
                 <a:cs typeface="Calibri" pitchFamily="34" charset="-120"/>
               </a:rPr>
-              <a:t>Traditional remote attestation: </a:t>
-            </a:r>
-            <a:pPr algn="l" indent="0" marL="0">
-              <a:buNone/>
-            </a:pPr>
-            <a:r>
-              <a:rPr lang="en-US" sz="1700" b="1" dirty="0">
+              <a:t>Traditional remote attestation: did system components boot into a predictable state?</a:t>
+            </a:r>
+            <a:r>
+              <a:rPr lang="en-US" sz="1700" dirty="0">
                 <a:solidFill>
                   <a:srgbClr val="212121"/>
                 </a:solidFill>
@@ -1844,29 +1620,12 @@
                 <a:ea typeface="Calibri" pitchFamily="34" charset="-122"/>
                 <a:cs typeface="Calibri" pitchFamily="34" charset="-120"/>
               </a:rPr>
-              <a:t>did system components boot into a predictable state?</a:t>
-            </a:r>
-            <a:pPr algn="l" indent="0" marL="0">
-              <a:spcAft>
-                <a:spcPts val="1000"/>
-              </a:spcAft>
-              <a:buNone/>
-            </a:pPr>
-            <a:r>
-              <a:rPr lang="en-US" sz="1700" dirty="0">
-                <a:solidFill>
-                  <a:srgbClr val="212121"/>
-                </a:solidFill>
-                <a:latin typeface="Calibri" pitchFamily="34" charset="0"/>
-                <a:ea typeface="Calibri" pitchFamily="34" charset="-122"/>
-                <a:cs typeface="Calibri" pitchFamily="34" charset="-120"/>
-              </a:rPr>
               <a:t> (boot-time, static runtime)</a:t>
             </a:r>
             <a:endParaRPr lang="en-US" sz="1700" dirty="0"/>
           </a:p>
           <a:p>
-            <a:pPr algn="l" marL="342900" indent="-342900">
+            <a:pPr marL="342900" indent="-342900" algn="l">
               <a:buSzPct val="100000"/>
               <a:buChar char="•"/>
             </a:pPr>
@@ -1881,9 +1640,6 @@
               </a:rPr>
               <a:t>Layered, runtime attestation: </a:t>
             </a:r>
-            <a:pPr algn="l" indent="0" marL="0">
-              <a:buNone/>
-            </a:pPr>
             <a:r>
               <a:rPr lang="en-US" sz="1700" dirty="0">
                 <a:solidFill>
@@ -1895,12 +1651,6 @@
               </a:rPr>
               <a:t>extend boot-time trust via dynamic measurement of system components </a:t>
             </a:r>
-            <a:pPr algn="l" indent="0" marL="0">
-              <a:spcAft>
-                <a:spcPts val="1000"/>
-              </a:spcAft>
-              <a:buNone/>
-            </a:pPr>
             <a:r>
               <a:rPr lang="en-US" sz="1700" b="1" dirty="0">
                 <a:solidFill>
@@ -1915,7 +1665,7 @@
             <a:endParaRPr lang="en-US" sz="1700" dirty="0"/>
           </a:p>
           <a:p>
-            <a:pPr algn="l" marL="342900" indent="-342900">
+            <a:pPr marL="342900" indent="-342900" algn="l">
               <a:buSzPct val="100000"/>
               <a:buChar char="•"/>
             </a:pPr>
@@ -1930,9 +1680,6 @@
               </a:rPr>
               <a:t>Lifecycle attestation: </a:t>
             </a:r>
-            <a:pPr algn="l" indent="0" marL="0">
-              <a:buNone/>
-            </a:pPr>
             <a:r>
               <a:rPr lang="en-US" sz="1700" dirty="0">
                 <a:solidFill>
@@ -1944,9 +1691,6 @@
               </a:rPr>
               <a:t>extends this notion to </a:t>
             </a:r>
-            <a:pPr algn="l" indent="0" marL="0">
-              <a:buNone/>
-            </a:pPr>
             <a:r>
               <a:rPr lang="en-US" sz="1700" b="1" dirty="0">
                 <a:solidFill>
@@ -1958,12 +1702,6 @@
               </a:rPr>
               <a:t>artifacts of the development lifecycle</a:t>
             </a:r>
-            <a:pPr algn="l" indent="0" marL="0">
-              <a:spcAft>
-                <a:spcPts val="1000"/>
-              </a:spcAft>
-              <a:buNone/>
-            </a:pPr>
             <a:r>
               <a:rPr lang="en-US" sz="1700" dirty="0">
                 <a:solidFill>
@@ -1978,7 +1716,7 @@
             <a:endParaRPr lang="en-US" sz="1700" dirty="0"/>
           </a:p>
           <a:p>
-            <a:pPr algn="l" lvl="1" marL="685800" indent="-342900">
+            <a:pPr marL="685800" lvl="1" indent="-342900" algn="l">
               <a:spcAft>
                 <a:spcPts val="1000"/>
               </a:spcAft>
@@ -1999,7 +1737,7 @@
             <a:endParaRPr lang="en-US" sz="1700" dirty="0"/>
           </a:p>
           <a:p>
-            <a:pPr algn="l" lvl="1" marL="685800" indent="-342900">
+            <a:pPr marL="685800" lvl="1" indent="-342900" algn="l">
               <a:buSzPct val="100000"/>
               <a:buChar char="–"/>
             </a:pPr>
@@ -2014,9 +1752,6 @@
               </a:rPr>
               <a:t>…and to lifecycle </a:t>
             </a:r>
-            <a:pPr algn="l" indent="0" marL="0">
-              <a:buNone/>
-            </a:pPr>
             <a:r>
               <a:rPr lang="en-US" sz="1700" b="1" dirty="0">
                 <a:solidFill>
@@ -2028,12 +1763,6 @@
               </a:rPr>
               <a:t>events</a:t>
             </a:r>
-            <a:pPr algn="l" indent="0" marL="0">
-              <a:spcAft>
-                <a:spcPts val="1000"/>
-              </a:spcAft>
-              <a:buNone/>
-            </a:pPr>
             <a:r>
               <a:rPr lang="en-US" sz="1700" dirty="0">
                 <a:solidFill>
@@ -2048,7 +1777,7 @@
             <a:endParaRPr lang="en-US" sz="1700" dirty="0"/>
           </a:p>
           <a:p>
-            <a:pPr algn="l" lvl="2" marL="1028700" indent="-342900">
+            <a:pPr marL="1028700" lvl="2" indent="-342900" algn="l">
               <a:spcAft>
                 <a:spcPts val="200"/>
               </a:spcAft>
@@ -2069,7 +1798,7 @@
             <a:endParaRPr lang="en-US" sz="1700" dirty="0"/>
           </a:p>
           <a:p>
-            <a:pPr algn="l" lvl="2" marL="1028700" indent="-342900">
+            <a:pPr marL="1028700" lvl="2" indent="-342900" algn="l">
               <a:spcAft>
                 <a:spcPts val="200"/>
               </a:spcAft>
@@ -2090,7 +1819,7 @@
             <a:endParaRPr lang="en-US" sz="1700" dirty="0"/>
           </a:p>
           <a:p>
-            <a:pPr algn="l" lvl="2" marL="1028700" indent="-342900">
+            <a:pPr marL="1028700" lvl="2" indent="-342900" algn="l">
               <a:spcAft>
                 <a:spcPts val="200"/>
               </a:spcAft>
@@ -2111,7 +1840,7 @@
             <a:endParaRPr lang="en-US" sz="1700" dirty="0"/>
           </a:p>
           <a:p>
-            <a:pPr algn="l" lvl="2" marL="1028700" indent="-342900">
+            <a:pPr marL="1028700" lvl="2" indent="-342900" algn="l">
               <a:spcAft>
                 <a:spcPts val="200"/>
               </a:spcAft>
@@ -2132,7 +1861,7 @@
             <a:endParaRPr lang="en-US" sz="1700" dirty="0"/>
           </a:p>
           <a:p>
-            <a:pPr algn="l" marL="342900" indent="-342900">
+            <a:pPr marL="342900" indent="-342900" algn="l">
               <a:buSzPct val="100000"/>
               <a:buChar char="•"/>
             </a:pPr>
@@ -2147,9 +1876,6 @@
               </a:rPr>
               <a:t>Motivation: </a:t>
             </a:r>
-            <a:pPr algn="l" indent="0" marL="0">
-              <a:buNone/>
-            </a:pPr>
             <a:r>
               <a:rPr lang="en-US" sz="1700" dirty="0">
                 <a:solidFill>
@@ -2161,9 +1887,6 @@
               </a:rPr>
               <a:t>the </a:t>
             </a:r>
-            <a:pPr algn="l" indent="0" marL="0">
-              <a:buNone/>
-            </a:pPr>
             <a:r>
               <a:rPr lang="en-US" sz="1700" b="1" dirty="0">
                 <a:solidFill>
@@ -2175,12 +1898,6 @@
               </a:rPr>
               <a:t>proliferation of AI-generated software artifacts</a:t>
             </a:r>
-            <a:pPr algn="l" indent="0" marL="0">
-              <a:spcAft>
-                <a:spcPts val="1000"/>
-              </a:spcAft>
-              <a:buNone/>
-            </a:pPr>
             <a:r>
               <a:rPr lang="en-US" sz="1700" dirty="0">
                 <a:solidFill>
@@ -2217,6 +1934,13 @@
           </a:solidFill>
           <a:ln/>
         </p:spPr>
+        <p:txBody>
+          <a:bodyPr/>
+          <a:lstStyle/>
+          <a:p>
+            <a:endParaRPr lang="en-US"/>
+          </a:p>
+        </p:txBody>
       </p:sp>
       <p:sp>
         <p:nvSpPr>
@@ -2239,7 +1963,7 @@
           <a:bodyPr wrap="square" lIns="0" tIns="0" rIns="0" bIns="0" rtlCol="0" anchor="ctr"/>
           <a:lstStyle/>
           <a:p>
-            <a:pPr algn="ctr" indent="0" marL="0">
+            <a:pPr marL="0" indent="0" algn="ctr">
               <a:spcAft>
                 <a:spcPts val="400"/>
               </a:spcAft>
@@ -2259,7 +1983,7 @@
             <a:endParaRPr lang="en-US" sz="2000" dirty="0"/>
           </a:p>
           <a:p>
-            <a:pPr algn="ctr" indent="0" marL="0">
+            <a:pPr marL="0" indent="0" algn="ctr">
               <a:buNone/>
             </a:pPr>
             <a:r>
@@ -2293,6 +2017,7 @@
         <a:solidFill>
           <a:srgbClr val="FFFFFF"/>
         </a:solidFill>
+        <a:effectLst/>
       </p:bgPr>
     </p:bg>
     <p:spTree>
@@ -2330,7 +2055,7 @@
           <a:bodyPr wrap="square" lIns="0" tIns="0" rIns="0" bIns="0" rtlCol="0" anchor="ctr"/>
           <a:lstStyle/>
           <a:p>
-            <a:pPr indent="0" marL="0">
+            <a:pPr marL="0" indent="0">
               <a:buNone/>
             </a:pPr>
             <a:r>
@@ -2369,6 +2094,13 @@
           </a:solidFill>
           <a:ln/>
         </p:spPr>
+        <p:txBody>
+          <a:bodyPr/>
+          <a:lstStyle/>
+          <a:p>
+            <a:endParaRPr lang="en-US"/>
+          </a:p>
+        </p:txBody>
       </p:sp>
       <p:sp>
         <p:nvSpPr>
@@ -2391,7 +2123,7 @@
           <a:bodyPr wrap="square" lIns="254" tIns="254" rIns="254" bIns="254" rtlCol="0" anchor="ctr"/>
           <a:lstStyle/>
           <a:p>
-            <a:pPr algn="ctr" indent="0" marL="0">
+            <a:pPr marL="0" indent="0" algn="ctr">
               <a:buNone/>
             </a:pPr>
             <a:r>
@@ -2430,7 +2162,7 @@
           <a:bodyPr wrap="square" lIns="0" tIns="0" rIns="0" bIns="0" rtlCol="0" anchor="ctr"/>
           <a:lstStyle/>
           <a:p>
-            <a:pPr algn="ctr" indent="0" marL="0">
+            <a:pPr marL="0" indent="0" algn="ctr">
               <a:buNone/>
             </a:pPr>
             <a:r>
@@ -2469,6 +2201,13 @@
           </a:solidFill>
           <a:ln/>
         </p:spPr>
+        <p:txBody>
+          <a:bodyPr/>
+          <a:lstStyle/>
+          <a:p>
+            <a:endParaRPr lang="en-US"/>
+          </a:p>
+        </p:txBody>
       </p:sp>
       <p:sp>
         <p:nvSpPr>
@@ -2491,7 +2230,7 @@
           <a:bodyPr wrap="square" lIns="254" tIns="254" rIns="254" bIns="254" rtlCol="0" anchor="ctr"/>
           <a:lstStyle/>
           <a:p>
-            <a:pPr algn="ctr" indent="0" marL="0">
+            <a:pPr marL="0" indent="0" algn="ctr">
               <a:buNone/>
             </a:pPr>
             <a:r>
@@ -2508,7 +2247,7 @@
             <a:endParaRPr lang="en-US" sz="1350" dirty="0"/>
           </a:p>
           <a:p>
-            <a:pPr algn="ctr" indent="0" marL="0">
+            <a:pPr marL="0" indent="0" algn="ctr">
               <a:buNone/>
             </a:pPr>
             <a:r>
@@ -2547,7 +2286,7 @@
           <a:bodyPr wrap="square" lIns="0" tIns="0" rIns="0" bIns="0" rtlCol="0" anchor="ctr"/>
           <a:lstStyle/>
           <a:p>
-            <a:pPr algn="ctr" indent="0" marL="0">
+            <a:pPr marL="0" indent="0" algn="ctr">
               <a:buNone/>
             </a:pPr>
             <a:r>
@@ -2586,6 +2325,13 @@
           </a:solidFill>
           <a:ln/>
         </p:spPr>
+        <p:txBody>
+          <a:bodyPr/>
+          <a:lstStyle/>
+          <a:p>
+            <a:endParaRPr lang="en-US"/>
+          </a:p>
+        </p:txBody>
       </p:sp>
       <p:sp>
         <p:nvSpPr>
@@ -2608,7 +2354,7 @@
           <a:bodyPr wrap="square" lIns="254" tIns="254" rIns="254" bIns="254" rtlCol="0" anchor="ctr"/>
           <a:lstStyle/>
           <a:p>
-            <a:pPr algn="ctr" indent="0" marL="0">
+            <a:pPr marL="0" indent="0" algn="ctr">
               <a:buNone/>
             </a:pPr>
             <a:r>
@@ -2647,7 +2393,7 @@
           <a:bodyPr wrap="square" lIns="0" tIns="0" rIns="0" bIns="0" rtlCol="0" anchor="ctr"/>
           <a:lstStyle/>
           <a:p>
-            <a:pPr algn="ctr" indent="0" marL="0">
+            <a:pPr marL="0" indent="0" algn="ctr">
               <a:buNone/>
             </a:pPr>
             <a:r>
@@ -2686,6 +2432,13 @@
           </a:solidFill>
           <a:ln/>
         </p:spPr>
+        <p:txBody>
+          <a:bodyPr/>
+          <a:lstStyle/>
+          <a:p>
+            <a:endParaRPr lang="en-US"/>
+          </a:p>
+        </p:txBody>
       </p:sp>
       <p:sp>
         <p:nvSpPr>
@@ -2708,7 +2461,7 @@
           <a:bodyPr wrap="square" lIns="254" tIns="254" rIns="254" bIns="254" rtlCol="0" anchor="ctr"/>
           <a:lstStyle/>
           <a:p>
-            <a:pPr algn="ctr" indent="0" marL="0">
+            <a:pPr marL="0" indent="0" algn="ctr">
               <a:buNone/>
             </a:pPr>
             <a:r>
@@ -2747,7 +2500,7 @@
           <a:bodyPr wrap="square" lIns="0" tIns="0" rIns="0" bIns="0" rtlCol="0" anchor="ctr"/>
           <a:lstStyle/>
           <a:p>
-            <a:pPr algn="ctr" indent="0" marL="0">
+            <a:pPr marL="0" indent="0" algn="ctr">
               <a:buNone/>
             </a:pPr>
             <a:r>
@@ -2786,6 +2539,13 @@
           </a:solidFill>
           <a:ln/>
         </p:spPr>
+        <p:txBody>
+          <a:bodyPr/>
+          <a:lstStyle/>
+          <a:p>
+            <a:endParaRPr lang="en-US"/>
+          </a:p>
+        </p:txBody>
       </p:sp>
       <p:sp>
         <p:nvSpPr>
@@ -2808,7 +2568,7 @@
           <a:bodyPr wrap="square" lIns="254" tIns="254" rIns="254" bIns="254" rtlCol="0" anchor="ctr"/>
           <a:lstStyle/>
           <a:p>
-            <a:pPr algn="ctr" indent="0" marL="0">
+            <a:pPr marL="0" indent="0" algn="ctr">
               <a:buNone/>
             </a:pPr>
             <a:r>
@@ -2847,7 +2607,7 @@
           <a:bodyPr wrap="square" lIns="0" tIns="0" rIns="0" bIns="0" rtlCol="0" anchor="ctr"/>
           <a:lstStyle/>
           <a:p>
-            <a:pPr indent="0" marL="0">
+            <a:pPr marL="0" indent="0">
               <a:buNone/>
             </a:pPr>
             <a:r>
@@ -2881,6 +2641,7 @@
         <a:solidFill>
           <a:srgbClr val="FFFFFF"/>
         </a:solidFill>
+        <a:effectLst/>
       </p:bgPr>
     </p:bg>
     <p:spTree>
@@ -2918,7 +2679,7 @@
           <a:bodyPr wrap="square" lIns="0" tIns="0" rIns="0" bIns="0" rtlCol="0" anchor="ctr"/>
           <a:lstStyle/>
           <a:p>
-            <a:pPr indent="0" marL="0">
+            <a:pPr marL="0" indent="0">
               <a:buNone/>
             </a:pPr>
             <a:r>
@@ -2957,6 +2718,13 @@
           </a:solidFill>
           <a:ln/>
         </p:spPr>
+        <p:txBody>
+          <a:bodyPr/>
+          <a:lstStyle/>
+          <a:p>
+            <a:endParaRPr lang="en-US"/>
+          </a:p>
+        </p:txBody>
       </p:sp>
       <p:sp>
         <p:nvSpPr>
@@ -2979,7 +2747,7 @@
           <a:bodyPr wrap="square" lIns="0" tIns="0" rIns="0" bIns="0" rtlCol="0" anchor="ctr"/>
           <a:lstStyle/>
           <a:p>
-            <a:pPr algn="l" indent="0" marL="0">
+            <a:pPr marL="0" indent="0" algn="l">
               <a:spcAft>
                 <a:spcPts val="200"/>
               </a:spcAft>
@@ -2999,7 +2767,7 @@
             <a:endParaRPr lang="en-US" sz="1700" dirty="0"/>
           </a:p>
           <a:p>
-            <a:pPr algn="l" indent="0" marL="0">
+            <a:pPr marL="0" indent="0" algn="l">
               <a:buNone/>
             </a:pPr>
             <a:r>
@@ -3038,7 +2806,7 @@
           <a:bodyPr wrap="square" lIns="0" tIns="0" rIns="0" bIns="0" rtlCol="0" anchor="ctr"/>
           <a:lstStyle/>
           <a:p>
-            <a:pPr algn="ctr" indent="0" marL="0">
+            <a:pPr marL="0" indent="0" algn="ctr">
               <a:buNone/>
             </a:pPr>
             <a:r>
@@ -3074,6 +2842,13 @@
           </a:solidFill>
           <a:ln/>
         </p:spPr>
+        <p:txBody>
+          <a:bodyPr/>
+          <a:lstStyle/>
+          <a:p>
+            <a:endParaRPr lang="en-US"/>
+          </a:p>
+        </p:txBody>
       </p:sp>
       <p:sp>
         <p:nvSpPr>
@@ -3096,7 +2871,7 @@
           <a:bodyPr wrap="square" lIns="0" tIns="0" rIns="0" bIns="0" rtlCol="0" anchor="ctr"/>
           <a:lstStyle/>
           <a:p>
-            <a:pPr algn="l" indent="0" marL="0">
+            <a:pPr marL="0" indent="0" algn="l">
               <a:spcAft>
                 <a:spcPts val="200"/>
               </a:spcAft>
@@ -3116,7 +2891,7 @@
             <a:endParaRPr lang="en-US" sz="1700" dirty="0"/>
           </a:p>
           <a:p>
-            <a:pPr algn="l" indent="0" marL="0">
+            <a:pPr marL="0" indent="0" algn="l">
               <a:buNone/>
             </a:pPr>
             <a:r>
@@ -3155,7 +2930,7 @@
           <a:bodyPr wrap="square" lIns="0" tIns="0" rIns="0" bIns="0" rtlCol="0" anchor="ctr"/>
           <a:lstStyle/>
           <a:p>
-            <a:pPr algn="ctr" indent="0" marL="0">
+            <a:pPr marL="0" indent="0" algn="ctr">
               <a:buNone/>
             </a:pPr>
             <a:r>
@@ -3191,6 +2966,13 @@
           </a:solidFill>
           <a:ln/>
         </p:spPr>
+        <p:txBody>
+          <a:bodyPr/>
+          <a:lstStyle/>
+          <a:p>
+            <a:endParaRPr lang="en-US"/>
+          </a:p>
+        </p:txBody>
       </p:sp>
       <p:sp>
         <p:nvSpPr>
@@ -3213,7 +2995,7 @@
           <a:bodyPr wrap="square" lIns="0" tIns="0" rIns="0" bIns="0" rtlCol="0" anchor="ctr"/>
           <a:lstStyle/>
           <a:p>
-            <a:pPr algn="l" indent="0" marL="0">
+            <a:pPr marL="0" indent="0" algn="l">
               <a:spcAft>
                 <a:spcPts val="200"/>
               </a:spcAft>
@@ -3233,7 +3015,7 @@
             <a:endParaRPr lang="en-US" sz="1700" dirty="0"/>
           </a:p>
           <a:p>
-            <a:pPr algn="l" indent="0" marL="0">
+            <a:pPr marL="0" indent="0" algn="l">
               <a:buNone/>
             </a:pPr>
             <a:r>
@@ -3272,7 +3054,7 @@
           <a:bodyPr wrap="square" lIns="0" tIns="0" rIns="0" bIns="0" rtlCol="0" anchor="ctr"/>
           <a:lstStyle/>
           <a:p>
-            <a:pPr algn="ctr" indent="0" marL="0">
+            <a:pPr marL="0" indent="0" algn="ctr">
               <a:buNone/>
             </a:pPr>
             <a:r>
@@ -3308,6 +3090,13 @@
           </a:solidFill>
           <a:ln/>
         </p:spPr>
+        <p:txBody>
+          <a:bodyPr/>
+          <a:lstStyle/>
+          <a:p>
+            <a:endParaRPr lang="en-US"/>
+          </a:p>
+        </p:txBody>
       </p:sp>
       <p:sp>
         <p:nvSpPr>
@@ -3330,7 +3119,7 @@
           <a:bodyPr wrap="square" lIns="0" tIns="0" rIns="0" bIns="0" rtlCol="0" anchor="ctr"/>
           <a:lstStyle/>
           <a:p>
-            <a:pPr algn="l" indent="0" marL="0">
+            <a:pPr marL="0" indent="0" algn="l">
               <a:buNone/>
             </a:pPr>
             <a:r>
@@ -3344,9 +3133,6 @@
               </a:rPr>
               <a:t>signed evidence bundles</a:t>
             </a:r>
-            <a:pPr algn="l" indent="0" marL="0">
-              <a:buNone/>
-            </a:pPr>
             <a:r>
               <a:rPr lang="en-US" sz="1500" dirty="0">
                 <a:solidFill>
@@ -3358,9 +3144,6 @@
               </a:rPr>
               <a:t>, appraised against </a:t>
             </a:r>
-            <a:pPr algn="l" indent="0" marL="0">
-              <a:buNone/>
-            </a:pPr>
             <a:r>
               <a:rPr lang="en-US" sz="1500" b="1" dirty="0">
                 <a:solidFill>
@@ -3397,7 +3180,7 @@
           <a:bodyPr wrap="square" lIns="0" tIns="0" rIns="0" bIns="0" rtlCol="0" anchor="ctr"/>
           <a:lstStyle/>
           <a:p>
-            <a:pPr indent="0" marL="0">
+            <a:pPr marL="0" indent="0">
               <a:buNone/>
             </a:pPr>
             <a:r>
@@ -3441,6 +3224,13 @@
             <a:prstDash val="solid"/>
           </a:ln>
         </p:spPr>
+        <p:txBody>
+          <a:bodyPr/>
+          <a:lstStyle/>
+          <a:p>
+            <a:endParaRPr lang="en-US"/>
+          </a:p>
+        </p:txBody>
       </p:sp>
       <p:sp>
         <p:nvSpPr>
@@ -3463,7 +3253,7 @@
           <a:bodyPr wrap="square" lIns="0" tIns="0" rIns="0" bIns="0" rtlCol="0" anchor="ctr"/>
           <a:lstStyle/>
           <a:p>
-            <a:pPr algn="l" indent="0" marL="0">
+            <a:pPr marL="0" indent="0" algn="l">
               <a:buNone/>
             </a:pPr>
             <a:r>
@@ -3480,7 +3270,7 @@
             <a:endParaRPr lang="en-US" sz="1300" dirty="0"/>
           </a:p>
           <a:p>
-            <a:pPr algn="l" indent="0" marL="0">
+            <a:pPr marL="0" indent="0" algn="l">
               <a:buNone/>
             </a:pPr>
             <a:r>
@@ -3497,7 +3287,7 @@
             <a:endParaRPr lang="en-US" sz="1300" dirty="0"/>
           </a:p>
           <a:p>
-            <a:pPr algn="l" indent="0" marL="0">
+            <a:pPr marL="0" indent="0" algn="l">
               <a:buNone/>
             </a:pPr>
             <a:r>
@@ -3514,7 +3304,7 @@
             <a:endParaRPr lang="en-US" sz="1300" dirty="0"/>
           </a:p>
           <a:p>
-            <a:pPr algn="l" indent="0" marL="0">
+            <a:pPr marL="0" indent="0" algn="l">
               <a:buNone/>
             </a:pPr>
             <a:r>
@@ -3531,7 +3321,7 @@
             <a:endParaRPr lang="en-US" sz="1300" dirty="0"/>
           </a:p>
           <a:p>
-            <a:pPr algn="l" indent="0" marL="0">
+            <a:pPr marL="0" indent="0" algn="l">
               <a:buNone/>
             </a:pPr>
             <a:r>
@@ -3548,7 +3338,7 @@
             <a:endParaRPr lang="en-US" sz="1300" dirty="0"/>
           </a:p>
           <a:p>
-            <a:pPr algn="l" indent="0" marL="0">
+            <a:pPr marL="0" indent="0" algn="l">
               <a:buNone/>
             </a:pPr>
             <a:r>
@@ -3587,7 +3377,7 @@
           <a:bodyPr wrap="square" lIns="0" tIns="0" rIns="0" bIns="0" rtlCol="0" anchor="ctr"/>
           <a:lstStyle/>
           <a:p>
-            <a:pPr indent="0" marL="0">
+            <a:pPr marL="0" indent="0">
               <a:buNone/>
             </a:pPr>
             <a:r>
@@ -3604,7 +3394,7 @@
             <a:endParaRPr lang="en-US" sz="2000" dirty="0"/>
           </a:p>
           <a:p>
-            <a:pPr indent="0" marL="0">
+            <a:pPr marL="0" indent="0">
               <a:buNone/>
             </a:pPr>
             <a:r>
@@ -3621,7 +3411,7 @@
             <a:endParaRPr lang="en-US" sz="2000" dirty="0"/>
           </a:p>
           <a:p>
-            <a:pPr indent="0" marL="0">
+            <a:pPr marL="0" indent="0">
               <a:buNone/>
             </a:pPr>
             <a:r>
@@ -3655,6 +3445,7 @@
         <a:solidFill>
           <a:srgbClr val="FFFFFF"/>
         </a:solidFill>
+        <a:effectLst/>
       </p:bgPr>
     </p:bg>
     <p:spTree>
@@ -3692,7 +3483,7 @@
           <a:bodyPr wrap="square" lIns="0" tIns="0" rIns="0" bIns="0" rtlCol="0" anchor="ctr"/>
           <a:lstStyle/>
           <a:p>
-            <a:pPr indent="0" marL="0">
+            <a:pPr marL="0" indent="0">
               <a:buNone/>
             </a:pPr>
             <a:r>
@@ -3736,6 +3527,13 @@
             <a:prstDash val="dash"/>
           </a:ln>
         </p:spPr>
+        <p:txBody>
+          <a:bodyPr/>
+          <a:lstStyle/>
+          <a:p>
+            <a:endParaRPr lang="en-US"/>
+          </a:p>
+        </p:txBody>
       </p:sp>
       <p:sp>
         <p:nvSpPr>
@@ -3758,7 +3556,7 @@
           <a:bodyPr wrap="square" lIns="254" tIns="254" rIns="254" bIns="254" rtlCol="0" anchor="ctr"/>
           <a:lstStyle/>
           <a:p>
-            <a:pPr algn="ctr" indent="0" marL="0">
+            <a:pPr marL="0" indent="0" algn="ctr">
               <a:buNone/>
             </a:pPr>
             <a:r>
@@ -3775,7 +3573,7 @@
             <a:endParaRPr lang="en-US" sz="1150" dirty="0"/>
           </a:p>
           <a:p>
-            <a:pPr algn="ctr" indent="0" marL="0">
+            <a:pPr marL="0" indent="0" algn="ctr">
               <a:buNone/>
             </a:pPr>
             <a:r>
@@ -3816,6 +3614,13 @@
             <a:tailEnd type="triangle"/>
           </a:ln>
         </p:spPr>
+        <p:txBody>
+          <a:bodyPr/>
+          <a:lstStyle/>
+          <a:p>
+            <a:endParaRPr lang="en-US"/>
+          </a:p>
+        </p:txBody>
       </p:sp>
       <p:sp>
         <p:nvSpPr>
@@ -3838,7 +3643,7 @@
           <a:bodyPr wrap="square" lIns="0" tIns="0" rIns="0" bIns="0" rtlCol="0" anchor="ctr"/>
           <a:lstStyle/>
           <a:p>
-            <a:pPr algn="l" indent="0" marL="0">
+            <a:pPr marL="0" indent="0" algn="l">
               <a:buNone/>
             </a:pPr>
             <a:r>
@@ -3877,6 +3682,13 @@
           </a:solidFill>
           <a:ln/>
         </p:spPr>
+        <p:txBody>
+          <a:bodyPr/>
+          <a:lstStyle/>
+          <a:p>
+            <a:endParaRPr lang="en-US"/>
+          </a:p>
+        </p:txBody>
       </p:sp>
       <p:sp>
         <p:nvSpPr>
@@ -3899,7 +3711,7 @@
           <a:bodyPr wrap="square" lIns="381" tIns="381" rIns="381" bIns="381" rtlCol="0" anchor="ctr"/>
           <a:lstStyle/>
           <a:p>
-            <a:pPr algn="ctr" indent="0" marL="0">
+            <a:pPr marL="0" indent="0" algn="ctr">
               <a:buNone/>
             </a:pPr>
             <a:r>
@@ -3940,6 +3752,13 @@
             <a:tailEnd type="triangle"/>
           </a:ln>
         </p:spPr>
+        <p:txBody>
+          <a:bodyPr/>
+          <a:lstStyle/>
+          <a:p>
+            <a:endParaRPr lang="en-US"/>
+          </a:p>
+        </p:txBody>
       </p:sp>
       <p:sp>
         <p:nvSpPr>
@@ -3962,7 +3781,7 @@
           <a:bodyPr wrap="square" lIns="0" tIns="0" rIns="0" bIns="0" rtlCol="0" anchor="ctr"/>
           <a:lstStyle/>
           <a:p>
-            <a:pPr algn="l" indent="0" marL="0">
+            <a:pPr marL="0" indent="0" algn="l">
               <a:buNone/>
             </a:pPr>
             <a:r>
@@ -4001,6 +3820,13 @@
           </a:solidFill>
           <a:ln/>
         </p:spPr>
+        <p:txBody>
+          <a:bodyPr/>
+          <a:lstStyle/>
+          <a:p>
+            <a:endParaRPr lang="en-US"/>
+          </a:p>
+        </p:txBody>
       </p:sp>
       <p:sp>
         <p:nvSpPr>
@@ -4023,7 +3849,7 @@
           <a:bodyPr wrap="square" lIns="381" tIns="381" rIns="381" bIns="381" rtlCol="0" anchor="ctr"/>
           <a:lstStyle/>
           <a:p>
-            <a:pPr algn="ctr" indent="0" marL="0">
+            <a:pPr marL="0" indent="0" algn="ctr">
               <a:buNone/>
             </a:pPr>
             <a:r>
@@ -4062,6 +3888,13 @@
           </a:solidFill>
           <a:ln/>
         </p:spPr>
+        <p:txBody>
+          <a:bodyPr/>
+          <a:lstStyle/>
+          <a:p>
+            <a:endParaRPr lang="en-US"/>
+          </a:p>
+        </p:txBody>
       </p:sp>
       <p:sp>
         <p:nvSpPr>
@@ -4084,7 +3917,7 @@
           <a:bodyPr wrap="square" lIns="381" tIns="381" rIns="381" bIns="381" rtlCol="0" anchor="ctr"/>
           <a:lstStyle/>
           <a:p>
-            <a:pPr algn="ctr" indent="0" marL="0">
+            <a:pPr marL="0" indent="0" algn="ctr">
               <a:buNone/>
             </a:pPr>
             <a:r>
@@ -4123,6 +3956,13 @@
           </a:solidFill>
           <a:ln/>
         </p:spPr>
+        <p:txBody>
+          <a:bodyPr/>
+          <a:lstStyle/>
+          <a:p>
+            <a:endParaRPr lang="en-US"/>
+          </a:p>
+        </p:txBody>
       </p:sp>
       <p:sp>
         <p:nvSpPr>
@@ -4145,7 +3985,7 @@
           <a:bodyPr wrap="square" lIns="381" tIns="381" rIns="381" bIns="381" rtlCol="0" anchor="ctr"/>
           <a:lstStyle/>
           <a:p>
-            <a:pPr algn="ctr" indent="0" marL="0">
+            <a:pPr marL="0" indent="0" algn="ctr">
               <a:buNone/>
             </a:pPr>
             <a:r>
@@ -4186,6 +4026,13 @@
             <a:tailEnd type="triangle"/>
           </a:ln>
         </p:spPr>
+        <p:txBody>
+          <a:bodyPr/>
+          <a:lstStyle/>
+          <a:p>
+            <a:endParaRPr lang="en-US"/>
+          </a:p>
+        </p:txBody>
       </p:sp>
       <p:sp>
         <p:nvSpPr>
@@ -4209,6 +4056,13 @@
             <a:prstDash val="solid"/>
           </a:ln>
         </p:spPr>
+        <p:txBody>
+          <a:bodyPr/>
+          <a:lstStyle/>
+          <a:p>
+            <a:endParaRPr lang="en-US"/>
+          </a:p>
+        </p:txBody>
       </p:sp>
       <p:sp>
         <p:nvSpPr>
@@ -4232,6 +4086,13 @@
             <a:prstDash val="solid"/>
           </a:ln>
         </p:spPr>
+        <p:txBody>
+          <a:bodyPr/>
+          <a:lstStyle/>
+          <a:p>
+            <a:endParaRPr lang="en-US"/>
+          </a:p>
+        </p:txBody>
       </p:sp>
       <p:sp>
         <p:nvSpPr>
@@ -4256,6 +4117,13 @@
             <a:tailEnd type="triangle"/>
           </a:ln>
         </p:spPr>
+        <p:txBody>
+          <a:bodyPr/>
+          <a:lstStyle/>
+          <a:p>
+            <a:endParaRPr lang="en-US"/>
+          </a:p>
+        </p:txBody>
       </p:sp>
       <p:sp>
         <p:nvSpPr>
@@ -4278,7 +4146,7 @@
           <a:bodyPr wrap="square" lIns="0" tIns="0" rIns="0" bIns="0" rtlCol="0" anchor="ctr"/>
           <a:lstStyle/>
           <a:p>
-            <a:pPr algn="r" indent="0" marL="0">
+            <a:pPr marL="0" indent="0" algn="r">
               <a:buNone/>
             </a:pPr>
             <a:r>
@@ -4295,7 +4163,7 @@
             <a:endParaRPr lang="en-US" sz="1000" dirty="0"/>
           </a:p>
           <a:p>
-            <a:pPr algn="r" indent="0" marL="0">
+            <a:pPr marL="0" indent="0" algn="r">
               <a:buNone/>
             </a:pPr>
             <a:r>
@@ -4335,6 +4203,13 @@
             <a:prstDash val="solid"/>
           </a:ln>
         </p:spPr>
+        <p:txBody>
+          <a:bodyPr/>
+          <a:lstStyle/>
+          <a:p>
+            <a:endParaRPr lang="en-US"/>
+          </a:p>
+        </p:txBody>
       </p:sp>
       <p:sp>
         <p:nvSpPr>
@@ -4359,6 +4234,13 @@
             <a:tailEnd type="triangle"/>
           </a:ln>
         </p:spPr>
+        <p:txBody>
+          <a:bodyPr/>
+          <a:lstStyle/>
+          <a:p>
+            <a:endParaRPr lang="en-US"/>
+          </a:p>
+        </p:txBody>
       </p:sp>
       <p:sp>
         <p:nvSpPr>
@@ -4381,7 +4263,7 @@
           <a:bodyPr wrap="square" lIns="0" tIns="0" rIns="0" bIns="0" rtlCol="0" anchor="ctr"/>
           <a:lstStyle/>
           <a:p>
-            <a:pPr algn="ctr" indent="0" marL="0">
+            <a:pPr marL="0" indent="0" algn="ctr">
               <a:buNone/>
             </a:pPr>
             <a:r>
@@ -4420,6 +4302,13 @@
           </a:solidFill>
           <a:ln/>
         </p:spPr>
+        <p:txBody>
+          <a:bodyPr/>
+          <a:lstStyle/>
+          <a:p>
+            <a:endParaRPr lang="en-US"/>
+          </a:p>
+        </p:txBody>
       </p:sp>
       <p:sp>
         <p:nvSpPr>
@@ -4442,7 +4331,7 @@
           <a:bodyPr wrap="square" lIns="381" tIns="381" rIns="381" bIns="381" rtlCol="0" anchor="ctr"/>
           <a:lstStyle/>
           <a:p>
-            <a:pPr algn="ctr" indent="0" marL="0">
+            <a:pPr marL="0" indent="0" algn="ctr">
               <a:buNone/>
             </a:pPr>
             <a:r>
@@ -4459,7 +4348,7 @@
             <a:endParaRPr lang="en-US" sz="1200" dirty="0"/>
           </a:p>
           <a:p>
-            <a:pPr algn="ctr" indent="0" marL="0">
+            <a:pPr marL="0" indent="0" algn="ctr">
               <a:buNone/>
             </a:pPr>
             <a:r>
@@ -4500,6 +4389,13 @@
             <a:tailEnd type="triangle"/>
           </a:ln>
         </p:spPr>
+        <p:txBody>
+          <a:bodyPr/>
+          <a:lstStyle/>
+          <a:p>
+            <a:endParaRPr lang="en-US"/>
+          </a:p>
+        </p:txBody>
       </p:sp>
       <p:sp>
         <p:nvSpPr>
@@ -4522,7 +4418,7 @@
           <a:bodyPr wrap="square" lIns="0" tIns="0" rIns="0" bIns="0" rtlCol="0" anchor="ctr"/>
           <a:lstStyle/>
           <a:p>
-            <a:pPr algn="ctr" indent="0" marL="0">
+            <a:pPr marL="0" indent="0" algn="ctr">
               <a:buNone/>
             </a:pPr>
             <a:r>
@@ -4561,6 +4457,13 @@
           </a:solidFill>
           <a:ln/>
         </p:spPr>
+        <p:txBody>
+          <a:bodyPr/>
+          <a:lstStyle/>
+          <a:p>
+            <a:endParaRPr lang="en-US"/>
+          </a:p>
+        </p:txBody>
       </p:sp>
       <p:sp>
         <p:nvSpPr>
@@ -4583,7 +4486,7 @@
           <a:bodyPr wrap="square" lIns="381" tIns="381" rIns="381" bIns="381" rtlCol="0" anchor="ctr"/>
           <a:lstStyle/>
           <a:p>
-            <a:pPr algn="ctr" indent="0" marL="0">
+            <a:pPr marL="0" indent="0" algn="ctr">
               <a:buNone/>
             </a:pPr>
             <a:r>
@@ -4624,6 +4527,13 @@
             <a:tailEnd type="triangle"/>
           </a:ln>
         </p:spPr>
+        <p:txBody>
+          <a:bodyPr/>
+          <a:lstStyle/>
+          <a:p>
+            <a:endParaRPr lang="en-US"/>
+          </a:p>
+        </p:txBody>
       </p:sp>
       <p:sp>
         <p:nvSpPr>
@@ -4646,6 +4556,13 @@
           </a:solidFill>
           <a:ln/>
         </p:spPr>
+        <p:txBody>
+          <a:bodyPr/>
+          <a:lstStyle/>
+          <a:p>
+            <a:endParaRPr lang="en-US"/>
+          </a:p>
+        </p:txBody>
       </p:sp>
       <p:sp>
         <p:nvSpPr>
@@ -4668,7 +4585,7 @@
           <a:bodyPr wrap="square" lIns="381" tIns="381" rIns="381" bIns="381" rtlCol="0" anchor="ctr"/>
           <a:lstStyle/>
           <a:p>
-            <a:pPr algn="ctr" indent="0" marL="0">
+            <a:pPr marL="0" indent="0" algn="ctr">
               <a:buNone/>
             </a:pPr>
             <a:r>
@@ -4709,6 +4626,13 @@
             <a:tailEnd type="triangle"/>
           </a:ln>
         </p:spPr>
+        <p:txBody>
+          <a:bodyPr/>
+          <a:lstStyle/>
+          <a:p>
+            <a:endParaRPr lang="en-US"/>
+          </a:p>
+        </p:txBody>
       </p:sp>
       <p:sp>
         <p:nvSpPr>
@@ -4731,6 +4655,13 @@
           </a:solidFill>
           <a:ln/>
         </p:spPr>
+        <p:txBody>
+          <a:bodyPr/>
+          <a:lstStyle/>
+          <a:p>
+            <a:endParaRPr lang="en-US"/>
+          </a:p>
+        </p:txBody>
       </p:sp>
       <p:sp>
         <p:nvSpPr>
@@ -4753,7 +4684,7 @@
           <a:bodyPr wrap="square" lIns="381" tIns="381" rIns="381" bIns="381" rtlCol="0" anchor="ctr"/>
           <a:lstStyle/>
           <a:p>
-            <a:pPr algn="ctr" indent="0" marL="0">
+            <a:pPr marL="0" indent="0" algn="ctr">
               <a:buNone/>
             </a:pPr>
             <a:r>
@@ -4792,7 +4723,7 @@
           <a:bodyPr wrap="square" lIns="0" tIns="0" rIns="0" bIns="0" rtlCol="0" anchor="ctr"/>
           <a:lstStyle/>
           <a:p>
-            <a:pPr algn="ctr" indent="0" marL="0">
+            <a:pPr marL="0" indent="0" algn="ctr">
               <a:buNone/>
             </a:pPr>
             <a:r>
@@ -4832,6 +4763,13 @@
             <a:prstDash val="solid"/>
           </a:ln>
         </p:spPr>
+        <p:txBody>
+          <a:bodyPr/>
+          <a:lstStyle/>
+          <a:p>
+            <a:endParaRPr lang="en-US"/>
+          </a:p>
+        </p:txBody>
       </p:sp>
       <p:sp>
         <p:nvSpPr>
@@ -4855,6 +4793,13 @@
             <a:prstDash val="solid"/>
           </a:ln>
         </p:spPr>
+        <p:txBody>
+          <a:bodyPr/>
+          <a:lstStyle/>
+          <a:p>
+            <a:endParaRPr lang="en-US"/>
+          </a:p>
+        </p:txBody>
       </p:sp>
       <p:sp>
         <p:nvSpPr>
@@ -4878,6 +4823,13 @@
             <a:prstDash val="solid"/>
           </a:ln>
         </p:spPr>
+        <p:txBody>
+          <a:bodyPr/>
+          <a:lstStyle/>
+          <a:p>
+            <a:endParaRPr lang="en-US"/>
+          </a:p>
+        </p:txBody>
       </p:sp>
       <p:sp>
         <p:nvSpPr>
@@ -4901,6 +4853,13 @@
             <a:prstDash val="solid"/>
           </a:ln>
         </p:spPr>
+        <p:txBody>
+          <a:bodyPr/>
+          <a:lstStyle/>
+          <a:p>
+            <a:endParaRPr lang="en-US"/>
+          </a:p>
+        </p:txBody>
       </p:sp>
       <p:sp>
         <p:nvSpPr>
@@ -4925,6 +4884,13 @@
             <a:tailEnd type="triangle"/>
           </a:ln>
         </p:spPr>
+        <p:txBody>
+          <a:bodyPr/>
+          <a:lstStyle/>
+          <a:p>
+            <a:endParaRPr lang="en-US"/>
+          </a:p>
+        </p:txBody>
       </p:sp>
       <p:sp>
         <p:nvSpPr>
@@ -4947,7 +4913,7 @@
           <a:bodyPr wrap="square" lIns="0" tIns="0" rIns="0" bIns="0" rtlCol="0" anchor="ctr"/>
           <a:lstStyle/>
           <a:p>
-            <a:pPr algn="ctr" indent="0" marL="0">
+            <a:pPr marL="0" indent="0" algn="ctr">
               <a:buNone/>
             </a:pPr>
             <a:r>
@@ -4987,6 +4953,13 @@
             <a:prstDash val="solid"/>
           </a:ln>
         </p:spPr>
+        <p:txBody>
+          <a:bodyPr/>
+          <a:lstStyle/>
+          <a:p>
+            <a:endParaRPr lang="en-US"/>
+          </a:p>
+        </p:txBody>
       </p:sp>
       <p:sp>
         <p:nvSpPr>
@@ -5010,6 +4983,13 @@
             <a:prstDash val="solid"/>
           </a:ln>
         </p:spPr>
+        <p:txBody>
+          <a:bodyPr/>
+          <a:lstStyle/>
+          <a:p>
+            <a:endParaRPr lang="en-US"/>
+          </a:p>
+        </p:txBody>
       </p:sp>
       <p:sp>
         <p:nvSpPr>
@@ -5034,6 +5014,13 @@
             <a:tailEnd type="triangle"/>
           </a:ln>
         </p:spPr>
+        <p:txBody>
+          <a:bodyPr/>
+          <a:lstStyle/>
+          <a:p>
+            <a:endParaRPr lang="en-US"/>
+          </a:p>
+        </p:txBody>
       </p:sp>
       <p:sp>
         <p:nvSpPr>
@@ -5056,7 +5043,7 @@
           <a:bodyPr wrap="square" lIns="0" tIns="0" rIns="0" bIns="0" rtlCol="0" anchor="ctr"/>
           <a:lstStyle/>
           <a:p>
-            <a:pPr algn="ctr" indent="0" marL="0">
+            <a:pPr marL="0" indent="0" algn="ctr">
               <a:buNone/>
             </a:pPr>
             <a:r>
@@ -5096,6 +5083,13 @@
             <a:prstDash val="solid"/>
           </a:ln>
         </p:spPr>
+        <p:txBody>
+          <a:bodyPr/>
+          <a:lstStyle/>
+          <a:p>
+            <a:endParaRPr lang="en-US"/>
+          </a:p>
+        </p:txBody>
       </p:sp>
       <p:sp>
         <p:nvSpPr>
@@ -5119,6 +5113,13 @@
             <a:prstDash val="solid"/>
           </a:ln>
         </p:spPr>
+        <p:txBody>
+          <a:bodyPr/>
+          <a:lstStyle/>
+          <a:p>
+            <a:endParaRPr lang="en-US"/>
+          </a:p>
+        </p:txBody>
       </p:sp>
       <p:sp>
         <p:nvSpPr>
@@ -5143,6 +5144,13 @@
             <a:tailEnd type="triangle"/>
           </a:ln>
         </p:spPr>
+        <p:txBody>
+          <a:bodyPr/>
+          <a:lstStyle/>
+          <a:p>
+            <a:endParaRPr lang="en-US"/>
+          </a:p>
+        </p:txBody>
       </p:sp>
       <p:sp>
         <p:nvSpPr>
@@ -5165,7 +5173,7 @@
           <a:bodyPr wrap="square" lIns="0" tIns="0" rIns="0" bIns="0" rtlCol="0" anchor="ctr"/>
           <a:lstStyle/>
           <a:p>
-            <a:pPr algn="ctr" indent="0" marL="0">
+            <a:pPr marL="0" indent="0" algn="ctr">
               <a:buNone/>
             </a:pPr>
             <a:r>
@@ -5204,6 +5212,13 @@
           </a:solidFill>
           <a:ln/>
         </p:spPr>
+        <p:txBody>
+          <a:bodyPr/>
+          <a:lstStyle/>
+          <a:p>
+            <a:endParaRPr lang="en-US"/>
+          </a:p>
+        </p:txBody>
       </p:sp>
       <p:sp>
         <p:nvSpPr>
@@ -5226,7 +5241,7 @@
           <a:bodyPr wrap="square" lIns="0" tIns="0" rIns="0" bIns="0" rtlCol="0" anchor="ctr"/>
           <a:lstStyle/>
           <a:p>
-            <a:pPr algn="l" indent="0" marL="0">
+            <a:pPr marL="0" indent="0" algn="l">
               <a:buNone/>
             </a:pPr>
             <a:r>
@@ -5240,7 +5255,43 @@
               </a:rPr>
               <a:t>The repair ladder: </a:t>
             </a:r>
-            <a:pPr algn="l" indent="0" marL="0">
+            <a:r>
+              <a:rPr lang="en-US" sz="1300" dirty="0">
+                <a:solidFill>
+                  <a:srgbClr val="CADCFC"/>
+                </a:solidFill>
+                <a:latin typeface="Calibri" pitchFamily="34" charset="0"/>
+                <a:ea typeface="Calibri" pitchFamily="34" charset="-122"/>
+                <a:cs typeface="Calibri" pitchFamily="34" charset="-120"/>
+              </a:rPr>
+              <a:t>a rung's exhaustion is a </a:t>
+            </a:r>
+            <a:r>
+              <a:rPr lang="en-US" sz="1300" b="1" i="1" dirty="0">
+                <a:solidFill>
+                  <a:srgbClr val="CADCFC"/>
+                </a:solidFill>
+                <a:latin typeface="Calibri" pitchFamily="34" charset="0"/>
+                <a:ea typeface="Calibri" pitchFamily="34" charset="-122"/>
+                <a:cs typeface="Calibri" pitchFamily="34" charset="-120"/>
+              </a:rPr>
+              <a:t>local diagnosis </a:t>
+            </a:r>
+            <a:r>
+              <a:rPr lang="en-US" sz="1300" dirty="0">
+                <a:solidFill>
+                  <a:srgbClr val="CADCFC"/>
+                </a:solidFill>
+                <a:latin typeface="Calibri" pitchFamily="34" charset="0"/>
+                <a:ea typeface="Calibri" pitchFamily="34" charset="-122"/>
+                <a:cs typeface="Calibri" pitchFamily="34" charset="-120"/>
+              </a:rPr>
+              <a:t>of failure— every repair is </a:t>
+            </a:r>
+            <a:endParaRPr lang="en-US" sz="1300" dirty="0"/>
+          </a:p>
+          <a:p>
+            <a:pPr marL="0" indent="0" algn="l">
               <a:buNone/>
             </a:pPr>
             <a:r>
@@ -5252,11 +5303,8 @@
                 <a:ea typeface="Calibri" pitchFamily="34" charset="-122"/>
                 <a:cs typeface="Calibri" pitchFamily="34" charset="-120"/>
               </a:rPr>
-              <a:t>a rung's exhaustion is a </a:t>
-            </a:r>
-            <a:pPr algn="l" indent="0" marL="0">
-              <a:buNone/>
-            </a:pPr>
+              <a:t>judged only by </a:t>
+            </a:r>
             <a:r>
               <a:rPr lang="en-US" sz="1300" b="1" i="1" dirty="0">
                 <a:solidFill>
@@ -5266,56 +5314,8 @@
                 <a:ea typeface="Calibri" pitchFamily="34" charset="-122"/>
                 <a:cs typeface="Calibri" pitchFamily="34" charset="-120"/>
               </a:rPr>
-              <a:t>local diagnosis </a:t>
-            </a:r>
-            <a:pPr algn="l" indent="0" marL="0">
-              <a:buNone/>
-            </a:pPr>
-            <a:r>
-              <a:rPr lang="en-US" sz="1300" dirty="0">
-                <a:solidFill>
-                  <a:srgbClr val="CADCFC"/>
-                </a:solidFill>
-                <a:latin typeface="Calibri" pitchFamily="34" charset="0"/>
-                <a:ea typeface="Calibri" pitchFamily="34" charset="-122"/>
-                <a:cs typeface="Calibri" pitchFamily="34" charset="-120"/>
-              </a:rPr>
-              <a:t>of failure— every repair is </a:t>
-            </a:r>
-            <a:endParaRPr lang="en-US" sz="1300" dirty="0"/>
-          </a:p>
-          <a:p>
-            <a:pPr algn="l" indent="0" marL="0">
-              <a:buNone/>
-            </a:pPr>
-            <a:r>
-              <a:rPr lang="en-US" sz="1300" dirty="0">
-                <a:solidFill>
-                  <a:srgbClr val="CADCFC"/>
-                </a:solidFill>
-                <a:latin typeface="Calibri" pitchFamily="34" charset="0"/>
-                <a:ea typeface="Calibri" pitchFamily="34" charset="-122"/>
-                <a:cs typeface="Calibri" pitchFamily="34" charset="-120"/>
-              </a:rPr>
-              <a:t>judged only by </a:t>
-            </a:r>
-            <a:pPr algn="l" indent="0" marL="0">
-              <a:buNone/>
-            </a:pPr>
-            <a:r>
-              <a:rPr lang="en-US" sz="1300" b="1" i="1" dirty="0">
-                <a:solidFill>
-                  <a:srgbClr val="CADCFC"/>
-                </a:solidFill>
-                <a:latin typeface="Calibri" pitchFamily="34" charset="0"/>
-                <a:ea typeface="Calibri" pitchFamily="34" charset="-122"/>
-                <a:cs typeface="Calibri" pitchFamily="34" charset="-120"/>
-              </a:rPr>
               <a:t>fresh re-measurement</a:t>
             </a:r>
-            <a:pPr algn="l" indent="0" marL="0">
-              <a:buNone/>
-            </a:pPr>
             <a:r>
               <a:rPr lang="en-US" sz="1300" dirty="0">
                 <a:solidFill>
@@ -5357,6 +5357,13 @@
             <a:prstDash val="solid"/>
           </a:ln>
         </p:spPr>
+        <p:txBody>
+          <a:bodyPr/>
+          <a:lstStyle/>
+          <a:p>
+            <a:endParaRPr lang="en-US"/>
+          </a:p>
+        </p:txBody>
       </p:sp>
       <p:sp>
         <p:nvSpPr>
@@ -5379,7 +5386,7 @@
           <a:bodyPr wrap="square" lIns="0" tIns="0" rIns="0" bIns="0" rtlCol="0" anchor="ctr"/>
           <a:lstStyle/>
           <a:p>
-            <a:pPr algn="l" indent="0" marL="0">
+            <a:pPr marL="0" indent="0" algn="l">
               <a:buNone/>
             </a:pPr>
             <a:r>
@@ -5396,7 +5403,7 @@
             <a:endParaRPr lang="en-US" sz="1100" dirty="0"/>
           </a:p>
           <a:p>
-            <a:pPr algn="l" indent="0" marL="0">
+            <a:pPr marL="0" indent="0" algn="l">
               <a:buNone/>
             </a:pPr>
             <a:r>
@@ -5430,6 +5437,7 @@
         <a:solidFill>
           <a:srgbClr val="FFFFFF"/>
         </a:solidFill>
+        <a:effectLst/>
       </p:bgPr>
     </p:bg>
     <p:spTree>
@@ -5467,7 +5475,7 @@
           <a:bodyPr wrap="square" lIns="0" tIns="0" rIns="0" bIns="0" rtlCol="0" anchor="ctr"/>
           <a:lstStyle/>
           <a:p>
-            <a:pPr indent="0" marL="0">
+            <a:pPr marL="0" indent="0">
               <a:buNone/>
             </a:pPr>
             <a:r>
@@ -5506,7 +5514,7 @@
           <a:bodyPr wrap="square" lIns="0" tIns="0" rIns="0" bIns="0" rtlCol="0" anchor="t"/>
           <a:lstStyle/>
           <a:p>
-            <a:pPr algn="l" marL="342900" indent="-342900">
+            <a:pPr marL="342900" indent="-342900" algn="l">
               <a:buSzPct val="100000"/>
               <a:buChar char="•"/>
             </a:pPr>
@@ -5521,12 +5529,6 @@
               </a:rPr>
               <a:t>Blackboard</a:t>
             </a:r>
-            <a:pPr algn="l" indent="0" marL="0">
-              <a:spcAft>
-                <a:spcPts val="900"/>
-              </a:spcAft>
-              <a:buNone/>
-            </a:pPr>
             <a:r>
               <a:rPr lang="en-US" sz="1600" dirty="0">
                 <a:solidFill>
@@ -5541,7 +5543,7 @@
             <a:endParaRPr lang="en-US" sz="1600" dirty="0"/>
           </a:p>
           <a:p>
-            <a:pPr algn="l" marL="342900" indent="-342900">
+            <a:pPr marL="342900" indent="-342900" algn="l">
               <a:buSzPct val="100000"/>
               <a:buChar char="•"/>
             </a:pPr>
@@ -5556,12 +5558,6 @@
               </a:rPr>
               <a:t>Blackboard Entry (Key)</a:t>
             </a:r>
-            <a:pPr algn="l" indent="0" marL="0">
-              <a:spcAft>
-                <a:spcPts val="900"/>
-              </a:spcAft>
-              <a:buNone/>
-            </a:pPr>
             <a:r>
               <a:rPr lang="en-US" sz="1600" dirty="0">
                 <a:solidFill>
@@ -5576,7 +5572,7 @@
             <a:endParaRPr lang="en-US" sz="1600" dirty="0"/>
           </a:p>
           <a:p>
-            <a:pPr algn="l" marL="342900" indent="-342900">
+            <a:pPr marL="342900" indent="-342900" algn="l">
               <a:buSzPct val="100000"/>
               <a:buChar char="•"/>
             </a:pPr>
@@ -5591,12 +5587,6 @@
               </a:rPr>
               <a:t>Episode</a:t>
             </a:r>
-            <a:pPr algn="l" indent="0" marL="0">
-              <a:spcAft>
-                <a:spcPts val="900"/>
-              </a:spcAft>
-              <a:buNone/>
-            </a:pPr>
             <a:r>
               <a:rPr lang="en-US" sz="1600" dirty="0">
                 <a:solidFill>
@@ -5611,7 +5601,7 @@
             <a:endParaRPr lang="en-US" sz="1600" dirty="0"/>
           </a:p>
           <a:p>
-            <a:pPr algn="l" marL="342900" indent="-342900">
+            <a:pPr marL="342900" indent="-342900" algn="l">
               <a:buSzPct val="100000"/>
               <a:buChar char="•"/>
             </a:pPr>
@@ -5626,12 +5616,6 @@
               </a:rPr>
               <a:t>Partition</a:t>
             </a:r>
-            <a:pPr algn="l" indent="0" marL="0">
-              <a:spcAft>
-                <a:spcPts val="900"/>
-              </a:spcAft>
-              <a:buNone/>
-            </a:pPr>
             <a:r>
               <a:rPr lang="en-US" sz="1600" dirty="0">
                 <a:solidFill>
@@ -5646,7 +5630,7 @@
             <a:endParaRPr lang="en-US" sz="1600" dirty="0"/>
           </a:p>
           <a:p>
-            <a:pPr algn="l" marL="342900" indent="-342900">
+            <a:pPr marL="342900" indent="-342900" algn="l">
               <a:buSzPct val="100000"/>
               <a:buChar char="•"/>
             </a:pPr>
@@ -5661,12 +5645,6 @@
               </a:rPr>
               <a:t>Controller</a:t>
             </a:r>
-            <a:pPr algn="l" indent="0" marL="0">
-              <a:spcAft>
-                <a:spcPts val="900"/>
-              </a:spcAft>
-              <a:buNone/>
-            </a:pPr>
             <a:r>
               <a:rPr lang="en-US" sz="1600" dirty="0">
                 <a:solidFill>
@@ -5681,7 +5659,7 @@
             <a:endParaRPr lang="en-US" sz="1600" dirty="0"/>
           </a:p>
           <a:p>
-            <a:pPr algn="l" marL="342900" indent="-342900">
+            <a:pPr marL="342900" indent="-342900" algn="l">
               <a:buSzPct val="100000"/>
               <a:buChar char="•"/>
             </a:pPr>
@@ -5696,12 +5674,6 @@
               </a:rPr>
               <a:t>Knowledge source (KS)</a:t>
             </a:r>
-            <a:pPr algn="l" indent="0" marL="0">
-              <a:spcAft>
-                <a:spcPts val="900"/>
-              </a:spcAft>
-              <a:buNone/>
-            </a:pPr>
             <a:r>
               <a:rPr lang="en-US" sz="1600" dirty="0">
                 <a:solidFill>
@@ -5716,7 +5688,7 @@
             <a:endParaRPr lang="en-US" sz="1600" dirty="0"/>
           </a:p>
           <a:p>
-            <a:pPr algn="l" marL="342900" indent="-342900">
+            <a:pPr marL="342900" indent="-342900" algn="l">
               <a:buSzPct val="100000"/>
               <a:buChar char="•"/>
             </a:pPr>
@@ -5731,12 +5703,6 @@
               </a:rPr>
               <a:t>Route</a:t>
             </a:r>
-            <a:pPr algn="l" indent="0" marL="0">
-              <a:spcAft>
-                <a:spcPts val="900"/>
-              </a:spcAft>
-              <a:buNone/>
-            </a:pPr>
             <a:r>
               <a:rPr lang="en-US" sz="1600" dirty="0">
                 <a:solidFill>
@@ -5751,7 +5717,7 @@
             <a:endParaRPr lang="en-US" sz="1600" dirty="0"/>
           </a:p>
           <a:p>
-            <a:pPr algn="l" marL="342900" indent="-342900">
+            <a:pPr marL="342900" indent="-342900" algn="l">
               <a:buSzPct val="100000"/>
               <a:buChar char="•"/>
             </a:pPr>
@@ -5766,12 +5732,6 @@
               </a:rPr>
               <a:t>History / Ledger</a:t>
             </a:r>
-            <a:pPr algn="l" indent="0" marL="0">
-              <a:spcAft>
-                <a:spcPts val="900"/>
-              </a:spcAft>
-              <a:buNone/>
-            </a:pPr>
             <a:r>
               <a:rPr lang="en-US" sz="1600" dirty="0">
                 <a:solidFill>
@@ -5803,6 +5763,7 @@
         <a:solidFill>
           <a:srgbClr val="FFFFFF"/>
         </a:solidFill>
+        <a:effectLst/>
       </p:bgPr>
     </p:bg>
     <p:spTree>
@@ -5840,7 +5801,7 @@
           <a:bodyPr wrap="square" lIns="0" tIns="0" rIns="0" bIns="0" rtlCol="0" anchor="ctr"/>
           <a:lstStyle/>
           <a:p>
-            <a:pPr indent="0" marL="0">
+            <a:pPr marL="0" indent="0">
               <a:buNone/>
             </a:pPr>
             <a:r>
@@ -5881,10 +5842,34 @@
             <a:tbl>
               <a:tblPr/>
               <a:tblGrid>
-                <a:gridCol w="2194560"/>
-                <a:gridCol w="2651760"/>
-                <a:gridCol w="3017520"/>
-                <a:gridCol w="3017520"/>
+                <a:gridCol w="2194560">
+                  <a:extLst>
+                    <a:ext uri="{9D8B030D-6E8A-4147-A177-3AD203B41FA5}">
+                      <a16:colId xmlns:a16="http://schemas.microsoft.com/office/drawing/2014/main" val="20000"/>
+                    </a:ext>
+                  </a:extLst>
+                </a:gridCol>
+                <a:gridCol w="2651760">
+                  <a:extLst>
+                    <a:ext uri="{9D8B030D-6E8A-4147-A177-3AD203B41FA5}">
+                      <a16:colId xmlns:a16="http://schemas.microsoft.com/office/drawing/2014/main" val="20001"/>
+                    </a:ext>
+                  </a:extLst>
+                </a:gridCol>
+                <a:gridCol w="3017520">
+                  <a:extLst>
+                    <a:ext uri="{9D8B030D-6E8A-4147-A177-3AD203B41FA5}">
+                      <a16:colId xmlns:a16="http://schemas.microsoft.com/office/drawing/2014/main" val="20002"/>
+                    </a:ext>
+                  </a:extLst>
+                </a:gridCol>
+                <a:gridCol w="3017520">
+                  <a:extLst>
+                    <a:ext uri="{9D8B030D-6E8A-4147-A177-3AD203B41FA5}">
+                      <a16:colId xmlns:a16="http://schemas.microsoft.com/office/drawing/2014/main" val="20003"/>
+                    </a:ext>
+                  </a:extLst>
+                </a:gridCol>
               </a:tblGrid>
               <a:tr h="658368">
                 <a:tc>
@@ -5892,7 +5877,7 @@
                     <a:bodyPr/>
                     <a:lstStyle/>
                     <a:p>
-                      <a:pPr algn="l" indent="0" marL="0">
+                      <a:pPr marL="0" indent="0" algn="l">
                         <a:buNone/>
                       </a:pPr>
                       <a:r>
@@ -5960,7 +5945,7 @@
                     <a:bodyPr/>
                     <a:lstStyle/>
                     <a:p>
-                      <a:pPr algn="l" indent="0" marL="0">
+                      <a:pPr marL="0" indent="0" algn="l">
                         <a:buNone/>
                       </a:pPr>
                       <a:r>
@@ -6028,7 +6013,7 @@
                     <a:bodyPr/>
                     <a:lstStyle/>
                     <a:p>
-                      <a:pPr algn="l" indent="0" marL="0">
+                      <a:pPr marL="0" indent="0" algn="l">
                         <a:buNone/>
                       </a:pPr>
                       <a:r>
@@ -6096,7 +6081,7 @@
                     <a:bodyPr/>
                     <a:lstStyle/>
                     <a:p>
-                      <a:pPr algn="l" indent="0" marL="0">
+                      <a:pPr marL="0" indent="0" algn="l">
                         <a:buNone/>
                       </a:pPr>
                       <a:r>
@@ -6159,6 +6144,11 @@
                     </a:solidFill>
                   </a:tcPr>
                 </a:tc>
+                <a:extLst>
+                  <a:ext uri="{0D108BD9-81ED-4DB2-BD59-A6C34878D82A}">
+                    <a16:rowId xmlns:a16="http://schemas.microsoft.com/office/drawing/2014/main" val="10000"/>
+                  </a:ext>
+                </a:extLst>
               </a:tr>
               <a:tr h="658368">
                 <a:tc>
@@ -6166,7 +6156,7 @@
                     <a:bodyPr/>
                     <a:lstStyle/>
                     <a:p>
-                      <a:pPr algn="l" indent="0" marL="0">
+                      <a:pPr marL="0" indent="0" algn="l">
                         <a:buNone/>
                       </a:pPr>
                       <a:r>
@@ -6234,7 +6224,7 @@
                     <a:bodyPr/>
                     <a:lstStyle/>
                     <a:p>
-                      <a:pPr algn="l" indent="0" marL="0">
+                      <a:pPr marL="0" indent="0" algn="l">
                         <a:buNone/>
                       </a:pPr>
                       <a:r>
@@ -6302,7 +6292,7 @@
                     <a:bodyPr/>
                     <a:lstStyle/>
                     <a:p>
-                      <a:pPr algn="l" indent="0" marL="0">
+                      <a:pPr marL="0" indent="0" algn="l">
                         <a:buNone/>
                       </a:pPr>
                       <a:r>
@@ -6370,7 +6360,7 @@
                     <a:bodyPr/>
                     <a:lstStyle/>
                     <a:p>
-                      <a:pPr algn="l" indent="0" marL="0">
+                      <a:pPr marL="0" indent="0" algn="l">
                         <a:buNone/>
                       </a:pPr>
                       <a:r>
@@ -6384,9 +6374,6 @@
                         </a:rPr>
                         <a:t>restore from golden — or </a:t>
                       </a:r>
-                      <a:pPr algn="l" indent="0" marL="0">
-                        <a:buNone/>
-                      </a:pPr>
                       <a:r>
                         <a:rPr lang="en-US" sz="1250" i="1" dirty="0">
                           <a:solidFill>
@@ -6398,9 +6385,6 @@
                         </a:rPr>
                         <a:t>bless</a:t>
                       </a:r>
-                      <a:pPr algn="l" indent="0" marL="0">
-                        <a:buNone/>
-                      </a:pPr>
                       <a:r>
                         <a:rPr lang="en-US" sz="1250" dirty="0">
                           <a:solidFill>
@@ -6461,6 +6445,11 @@
                     </a:solidFill>
                   </a:tcPr>
                 </a:tc>
+                <a:extLst>
+                  <a:ext uri="{0D108BD9-81ED-4DB2-BD59-A6C34878D82A}">
+                    <a16:rowId xmlns:a16="http://schemas.microsoft.com/office/drawing/2014/main" val="10001"/>
+                  </a:ext>
+                </a:extLst>
               </a:tr>
               <a:tr h="658368">
                 <a:tc>
@@ -6468,7 +6457,7 @@
                     <a:bodyPr/>
                     <a:lstStyle/>
                     <a:p>
-                      <a:pPr algn="l" indent="0" marL="0">
+                      <a:pPr marL="0" indent="0" algn="l">
                         <a:buNone/>
                       </a:pPr>
                       <a:r>
@@ -6536,7 +6525,7 @@
                     <a:bodyPr/>
                     <a:lstStyle/>
                     <a:p>
-                      <a:pPr algn="l" indent="0" marL="0">
+                      <a:pPr marL="0" indent="0" algn="l">
                         <a:buNone/>
                       </a:pPr>
                       <a:r>
@@ -6604,7 +6593,7 @@
                     <a:bodyPr/>
                     <a:lstStyle/>
                     <a:p>
-                      <a:pPr algn="l" indent="0" marL="0">
+                      <a:pPr marL="0" indent="0" algn="l">
                         <a:buNone/>
                       </a:pPr>
                       <a:r>
@@ -6672,7 +6661,7 @@
                     <a:bodyPr/>
                     <a:lstStyle/>
                     <a:p>
-                      <a:pPr algn="l" indent="0" marL="0">
+                      <a:pPr marL="0" indent="0" algn="l">
                         <a:buNone/>
                       </a:pPr>
                       <a:r>
@@ -6735,6 +6724,11 @@
                     </a:solidFill>
                   </a:tcPr>
                 </a:tc>
+                <a:extLst>
+                  <a:ext uri="{0D108BD9-81ED-4DB2-BD59-A6C34878D82A}">
+                    <a16:rowId xmlns:a16="http://schemas.microsoft.com/office/drawing/2014/main" val="10002"/>
+                  </a:ext>
+                </a:extLst>
               </a:tr>
               <a:tr h="658368">
                 <a:tc>
@@ -6742,7 +6736,7 @@
                     <a:bodyPr/>
                     <a:lstStyle/>
                     <a:p>
-                      <a:pPr algn="l" indent="0" marL="0">
+                      <a:pPr marL="0" indent="0" algn="l">
                         <a:buNone/>
                       </a:pPr>
                       <a:r>
@@ -6810,7 +6804,7 @@
                     <a:bodyPr/>
                     <a:lstStyle/>
                     <a:p>
-                      <a:pPr algn="l" indent="0" marL="0">
+                      <a:pPr marL="0" indent="0" algn="l">
                         <a:buNone/>
                       </a:pPr>
                       <a:r>
@@ -6878,7 +6872,7 @@
                     <a:bodyPr/>
                     <a:lstStyle/>
                     <a:p>
-                      <a:pPr algn="l" indent="0" marL="0">
+                      <a:pPr marL="0" indent="0" algn="l">
                         <a:buNone/>
                       </a:pPr>
                       <a:r>
@@ -6946,7 +6940,7 @@
                     <a:bodyPr/>
                     <a:lstStyle/>
                     <a:p>
-                      <a:pPr algn="l" indent="0" marL="0">
+                      <a:pPr marL="0" indent="0" algn="l">
                         <a:buNone/>
                       </a:pPr>
                       <a:r>
@@ -7009,6 +7003,11 @@
                     </a:solidFill>
                   </a:tcPr>
                 </a:tc>
+                <a:extLst>
+                  <a:ext uri="{0D108BD9-81ED-4DB2-BD59-A6C34878D82A}">
+                    <a16:rowId xmlns:a16="http://schemas.microsoft.com/office/drawing/2014/main" val="10003"/>
+                  </a:ext>
+                </a:extLst>
               </a:tr>
               <a:tr h="658368">
                 <a:tc>
@@ -7016,7 +7015,7 @@
                     <a:bodyPr/>
                     <a:lstStyle/>
                     <a:p>
-                      <a:pPr algn="l" indent="0" marL="0">
+                      <a:pPr marL="0" indent="0" algn="l">
                         <a:buNone/>
                       </a:pPr>
                       <a:r>
@@ -7084,7 +7083,7 @@
                     <a:bodyPr/>
                     <a:lstStyle/>
                     <a:p>
-                      <a:pPr algn="l" indent="0" marL="0">
+                      <a:pPr marL="0" indent="0" algn="l">
                         <a:buNone/>
                       </a:pPr>
                       <a:r>
@@ -7152,7 +7151,7 @@
                     <a:bodyPr/>
                     <a:lstStyle/>
                     <a:p>
-                      <a:pPr algn="l" indent="0" marL="0">
+                      <a:pPr marL="0" indent="0" algn="l">
                         <a:buNone/>
                       </a:pPr>
                       <a:r>
@@ -7220,7 +7219,7 @@
                     <a:bodyPr/>
                     <a:lstStyle/>
                     <a:p>
-                      <a:pPr algn="l" indent="0" marL="0">
+                      <a:pPr marL="0" indent="0" algn="l">
                         <a:buNone/>
                       </a:pPr>
                       <a:r>
@@ -7283,6 +7282,11 @@
                     </a:solidFill>
                   </a:tcPr>
                 </a:tc>
+                <a:extLst>
+                  <a:ext uri="{0D108BD9-81ED-4DB2-BD59-A6C34878D82A}">
+                    <a16:rowId xmlns:a16="http://schemas.microsoft.com/office/drawing/2014/main" val="10004"/>
+                  </a:ext>
+                </a:extLst>
               </a:tr>
               <a:tr h="658368">
                 <a:tc>
@@ -7290,7 +7294,7 @@
                     <a:bodyPr/>
                     <a:lstStyle/>
                     <a:p>
-                      <a:pPr algn="l" indent="0" marL="0">
+                      <a:pPr marL="0" indent="0" algn="l">
                         <a:buNone/>
                       </a:pPr>
                       <a:r>
@@ -7304,9 +7308,6 @@
                         </a:rPr>
                         <a:t>Toolchain </a:t>
                       </a:r>
-                      <a:pPr algn="l" indent="0" marL="0">
-                        <a:buNone/>
-                      </a:pPr>
                       <a:r>
                         <a:rPr lang="en-US" sz="1100" i="1" dirty="0">
                           <a:solidFill>
@@ -7372,7 +7373,7 @@
                     <a:bodyPr/>
                     <a:lstStyle/>
                     <a:p>
-                      <a:pPr algn="l" indent="0" marL="0">
+                      <a:pPr marL="0" indent="0" algn="l">
                         <a:buNone/>
                       </a:pPr>
                       <a:r>
@@ -7386,9 +7387,6 @@
                         </a:rPr>
                         <a:t>hashed </a:t>
                       </a:r>
-                      <a:pPr algn="l" indent="0" marL="0">
-                        <a:buNone/>
-                      </a:pPr>
                       <a:r>
                         <a:rPr lang="en-US" sz="1250" b="1" dirty="0">
                           <a:solidFill>
@@ -7454,7 +7452,7 @@
                     <a:bodyPr/>
                     <a:lstStyle/>
                     <a:p>
-                      <a:pPr algn="l" indent="0" marL="0">
+                      <a:pPr marL="0" indent="0" algn="l">
                         <a:buNone/>
                       </a:pPr>
                       <a:r>
@@ -7522,7 +7520,7 @@
                     <a:bodyPr/>
                     <a:lstStyle/>
                     <a:p>
-                      <a:pPr algn="l" indent="0" marL="0">
+                      <a:pPr marL="0" indent="0" algn="l">
                         <a:buNone/>
                       </a:pPr>
                       <a:r>
@@ -7585,6 +7583,11 @@
                     </a:solidFill>
                   </a:tcPr>
                 </a:tc>
+                <a:extLst>
+                  <a:ext uri="{0D108BD9-81ED-4DB2-BD59-A6C34878D82A}">
+                    <a16:rowId xmlns:a16="http://schemas.microsoft.com/office/drawing/2014/main" val="10005"/>
+                  </a:ext>
+                </a:extLst>
               </a:tr>
               <a:tr h="658368">
                 <a:tc>
@@ -7592,7 +7595,7 @@
                     <a:bodyPr/>
                     <a:lstStyle/>
                     <a:p>
-                      <a:pPr algn="l" indent="0" marL="0">
+                      <a:pPr marL="0" indent="0" algn="l">
                         <a:buNone/>
                       </a:pPr>
                       <a:r>
@@ -7606,9 +7609,6 @@
                         </a:rPr>
                         <a:t>Trust state </a:t>
                       </a:r>
-                      <a:pPr algn="l" indent="0" marL="0">
-                        <a:buNone/>
-                      </a:pPr>
                       <a:r>
                         <a:rPr lang="en-US" sz="1100" i="1" dirty="0">
                           <a:solidFill>
@@ -7674,7 +7674,7 @@
                     <a:bodyPr/>
                     <a:lstStyle/>
                     <a:p>
-                      <a:pPr algn="l" indent="0" marL="0">
+                      <a:pPr marL="0" indent="0" algn="l">
                         <a:buNone/>
                       </a:pPr>
                       <a:r>
@@ -7742,7 +7742,7 @@
                     <a:bodyPr/>
                     <a:lstStyle/>
                     <a:p>
-                      <a:pPr algn="l" indent="0" marL="0">
+                      <a:pPr marL="0" indent="0" algn="l">
                         <a:buNone/>
                       </a:pPr>
                       <a:r>
@@ -7810,7 +7810,7 @@
                     <a:bodyPr/>
                     <a:lstStyle/>
                     <a:p>
-                      <a:pPr algn="l" indent="0" marL="0">
+                      <a:pPr marL="0" indent="0" algn="l">
                         <a:buNone/>
                       </a:pPr>
                       <a:r>
@@ -7824,9 +7824,6 @@
                         </a:rPr>
                         <a:t>principled refusal</a:t>
                       </a:r>
-                      <a:pPr algn="l" indent="0" marL="0">
-                        <a:buNone/>
-                      </a:pPr>
                       <a:r>
                         <a:rPr lang="en-US" sz="1250" dirty="0">
                           <a:solidFill>
@@ -7887,6 +7884,11 @@
                     </a:solidFill>
                   </a:tcPr>
                 </a:tc>
+                <a:extLst>
+                  <a:ext uri="{0D108BD9-81ED-4DB2-BD59-A6C34878D82A}">
+                    <a16:rowId xmlns:a16="http://schemas.microsoft.com/office/drawing/2014/main" val="10006"/>
+                  </a:ext>
+                </a:extLst>
               </a:tr>
             </a:tbl>
           </a:graphicData>
@@ -7908,6 +7910,7 @@
         <a:solidFill>
           <a:srgbClr val="FFFFFF"/>
         </a:solidFill>
+        <a:effectLst/>
       </p:bgPr>
     </p:bg>
     <p:spTree>
@@ -7945,6 +7948,13 @@
           </a:solidFill>
           <a:ln/>
         </p:spPr>
+        <p:txBody>
+          <a:bodyPr/>
+          <a:lstStyle/>
+          <a:p>
+            <a:endParaRPr lang="en-US"/>
+          </a:p>
+        </p:txBody>
       </p:sp>
       <p:sp>
         <p:nvSpPr>
@@ -7967,7 +7977,7 @@
           <a:bodyPr wrap="square" lIns="254" tIns="254" rIns="254" bIns="254" rtlCol="0" anchor="ctr"/>
           <a:lstStyle/>
           <a:p>
-            <a:pPr algn="ctr" indent="0" marL="0">
+            <a:pPr marL="0" indent="0" algn="ctr">
               <a:buNone/>
             </a:pPr>
             <a:r>
@@ -8006,6 +8016,13 @@
           </a:solidFill>
           <a:ln/>
         </p:spPr>
+        <p:txBody>
+          <a:bodyPr/>
+          <a:lstStyle/>
+          <a:p>
+            <a:endParaRPr lang="en-US"/>
+          </a:p>
+        </p:txBody>
       </p:sp>
       <p:sp>
         <p:nvSpPr>
@@ -8028,7 +8045,7 @@
           <a:bodyPr wrap="square" lIns="254" tIns="254" rIns="254" bIns="254" rtlCol="0" anchor="ctr"/>
           <a:lstStyle/>
           <a:p>
-            <a:pPr algn="ctr" indent="0" marL="0">
+            <a:pPr marL="0" indent="0" algn="ctr">
               <a:buNone/>
             </a:pPr>
             <a:r>
@@ -8045,7 +8062,7 @@
             <a:endParaRPr lang="en-US" sz="900" dirty="0"/>
           </a:p>
           <a:p>
-            <a:pPr algn="ctr" indent="0" marL="0">
+            <a:pPr marL="0" indent="0" algn="ctr">
               <a:buNone/>
             </a:pPr>
             <a:r>
@@ -8084,6 +8101,13 @@
           </a:solidFill>
           <a:ln/>
         </p:spPr>
+        <p:txBody>
+          <a:bodyPr/>
+          <a:lstStyle/>
+          <a:p>
+            <a:endParaRPr lang="en-US"/>
+          </a:p>
+        </p:txBody>
       </p:sp>
       <p:sp>
         <p:nvSpPr>
@@ -8106,7 +8130,7 @@
           <a:bodyPr wrap="square" lIns="254" tIns="254" rIns="254" bIns="254" rtlCol="0" anchor="ctr"/>
           <a:lstStyle/>
           <a:p>
-            <a:pPr algn="ctr" indent="0" marL="0">
+            <a:pPr marL="0" indent="0" algn="ctr">
               <a:buNone/>
             </a:pPr>
             <a:r>
@@ -8145,6 +8169,13 @@
           </a:solidFill>
           <a:ln/>
         </p:spPr>
+        <p:txBody>
+          <a:bodyPr/>
+          <a:lstStyle/>
+          <a:p>
+            <a:endParaRPr lang="en-US"/>
+          </a:p>
+        </p:txBody>
       </p:sp>
       <p:sp>
         <p:nvSpPr>
@@ -8167,7 +8198,7 @@
           <a:bodyPr wrap="square" lIns="254" tIns="254" rIns="254" bIns="254" rtlCol="0" anchor="ctr"/>
           <a:lstStyle/>
           <a:p>
-            <a:pPr algn="ctr" indent="0" marL="0">
+            <a:pPr marL="0" indent="0" algn="ctr">
               <a:buNone/>
             </a:pPr>
             <a:r>
@@ -8206,6 +8237,13 @@
           </a:solidFill>
           <a:ln/>
         </p:spPr>
+        <p:txBody>
+          <a:bodyPr/>
+          <a:lstStyle/>
+          <a:p>
+            <a:endParaRPr lang="en-US"/>
+          </a:p>
+        </p:txBody>
       </p:sp>
       <p:sp>
         <p:nvSpPr>
@@ -8228,7 +8266,7 @@
           <a:bodyPr wrap="square" lIns="254" tIns="254" rIns="254" bIns="254" rtlCol="0" anchor="ctr"/>
           <a:lstStyle/>
           <a:p>
-            <a:pPr algn="ctr" indent="0" marL="0">
+            <a:pPr marL="0" indent="0" algn="ctr">
               <a:buNone/>
             </a:pPr>
             <a:r>
@@ -8267,7 +8305,7 @@
           <a:bodyPr wrap="square" lIns="0" tIns="0" rIns="0" bIns="0" rtlCol="0" anchor="ctr"/>
           <a:lstStyle/>
           <a:p>
-            <a:pPr indent="0" marL="0">
+            <a:pPr marL="0" indent="0">
               <a:buNone/>
             </a:pPr>
             <a:r>
@@ -8293,8 +8331,8 @@
         </p:nvSpPr>
         <p:spPr>
           <a:xfrm>
-            <a:off x="640080" y="1728216"/>
-            <a:ext cx="6035040" cy="2286000"/>
+            <a:off x="567557" y="1812296"/>
+            <a:ext cx="6149603" cy="2286000"/>
           </a:xfrm>
           <a:prstGeom prst="rect">
             <a:avLst/>
@@ -8306,12 +8344,12 @@
           <a:bodyPr wrap="square" lIns="0" tIns="0" rIns="0" bIns="0" rtlCol="0" anchor="t"/>
           <a:lstStyle/>
           <a:p>
-            <a:pPr algn="l" marL="342900" indent="-342900">
+            <a:pPr marL="342900" indent="-342900" algn="l">
               <a:buSzPct val="100000"/>
               <a:buChar char="•"/>
             </a:pPr>
             <a:r>
-              <a:rPr lang="en-US" sz="1350" b="1" dirty="0">
+              <a:rPr lang="en-US" sz="1400" b="1" dirty="0">
                 <a:solidFill>
                   <a:srgbClr val="212121"/>
                 </a:solidFill>
@@ -8321,14 +8359,8 @@
               </a:rPr>
               <a:t>The system: </a:t>
             </a:r>
-            <a:pPr algn="l" indent="0" marL="0">
-              <a:spcAft>
-                <a:spcPts val="200"/>
-              </a:spcAft>
-              <a:buNone/>
-            </a:pPr>
-            <a:r>
-              <a:rPr lang="en-US" sz="1350" dirty="0">
+            <a:r>
+              <a:rPr lang="en-US" sz="1400" dirty="0">
                 <a:solidFill>
                   <a:srgbClr val="212121"/>
                 </a:solidFill>
@@ -8338,17 +8370,17 @@
               </a:rPr>
               <a:t>an infant-incubator thermostat — regulate and monitor functions keep a newborn's environment in a safe temperature range; heat control on/off</a:t>
             </a:r>
-            <a:endParaRPr lang="en-US" sz="1350" dirty="0"/>
-          </a:p>
-          <a:p>
-            <a:pPr algn="l" indent="0" marL="0">
+            <a:endParaRPr lang="en-US" sz="1400" dirty="0"/>
+          </a:p>
+          <a:p>
+            <a:pPr marL="0" indent="0" algn="l">
               <a:spcAft>
                 <a:spcPts val="1000"/>
               </a:spcAft>
               <a:buNone/>
             </a:pPr>
             <a:r>
-              <a:rPr lang="en-US" sz="1100" i="1" dirty="0">
+              <a:rPr lang="en-US" sz="1400" i="1" dirty="0">
                 <a:solidFill>
                   <a:srgbClr val="5A6478"/>
                 </a:solidFill>
@@ -8356,17 +8388,17 @@
                 <a:ea typeface="Calibri" pitchFamily="34" charset="-122"/>
                 <a:cs typeface="Calibri" pitchFamily="34" charset="-120"/>
               </a:rPr>
-              <a:t>requirements traceable to FAA AR-08-32 (the REQ-MHS-* family the scenes will tamper with)</a:t>
-            </a:r>
-            <a:endParaRPr lang="en-US" sz="1350" dirty="0"/>
-          </a:p>
-          <a:p>
-            <a:pPr algn="l" marL="342900" indent="-342900">
+              <a:t>	requirements traceable to FAA AR-08-32 (the REQ-MHS-* family the 	scenes will tamper with)</a:t>
+            </a:r>
+            <a:endParaRPr lang="en-US" sz="1400" dirty="0"/>
+          </a:p>
+          <a:p>
+            <a:pPr marL="342900" indent="-342900" algn="l">
               <a:buSzPct val="100000"/>
               <a:buChar char="•"/>
             </a:pPr>
             <a:r>
-              <a:rPr lang="en-US" sz="1350" b="1" dirty="0">
+              <a:rPr lang="en-US" sz="1400" b="1" dirty="0">
                 <a:solidFill>
                   <a:srgbClr val="212121"/>
                 </a:solidFill>
@@ -8376,11 +8408,8 @@
               </a:rPr>
               <a:t>The relevance: </a:t>
             </a:r>
-            <a:pPr algn="l" indent="0" marL="0">
-              <a:buNone/>
-            </a:pPr>
-            <a:r>
-              <a:rPr lang="en-US" sz="1350" dirty="0">
+            <a:r>
+              <a:rPr lang="en-US" sz="1400" dirty="0">
                 <a:solidFill>
                   <a:srgbClr val="212121"/>
                 </a:solidFill>
@@ -8390,7 +8419,7 @@
               </a:rPr>
               <a:t>the INSPECTA program's seL4/Microkit exemplar — a real, current, safety-critical development artifact, not a toy built for this talk</a:t>
             </a:r>
-            <a:endParaRPr lang="en-US" sz="1350" dirty="0"/>
+            <a:endParaRPr lang="en-US" sz="1400" dirty="0"/>
           </a:p>
         </p:txBody>
       </p:sp>
@@ -8415,6 +8444,13 @@
           </a:solidFill>
           <a:ln/>
         </p:spPr>
+        <p:txBody>
+          <a:bodyPr/>
+          <a:lstStyle/>
+          <a:p>
+            <a:endParaRPr lang="en-US"/>
+          </a:p>
+        </p:txBody>
       </p:sp>
       <p:sp>
         <p:nvSpPr>
@@ -8437,7 +8473,7 @@
           <a:bodyPr wrap="square" lIns="254" tIns="254" rIns="254" bIns="254" rtlCol="0" anchor="ctr"/>
           <a:lstStyle/>
           <a:p>
-            <a:pPr algn="ctr" indent="0" marL="0">
+            <a:pPr marL="0" indent="0" algn="ctr">
               <a:buNone/>
             </a:pPr>
             <a:r>
@@ -8454,7 +8490,7 @@
             <a:endParaRPr lang="en-US" sz="1050" dirty="0"/>
           </a:p>
           <a:p>
-            <a:pPr algn="ctr" indent="0" marL="0">
+            <a:pPr marL="0" indent="0" algn="ctr">
               <a:buNone/>
             </a:pPr>
             <a:r>
@@ -8493,7 +8529,7 @@
           <a:bodyPr wrap="square" lIns="0" tIns="0" rIns="0" bIns="0" rtlCol="0" anchor="ctr"/>
           <a:lstStyle/>
           <a:p>
-            <a:pPr algn="ctr" indent="0" marL="0">
+            <a:pPr marL="0" indent="0" algn="ctr">
               <a:buNone/>
             </a:pPr>
             <a:r>
@@ -8532,6 +8568,13 @@
           </a:solidFill>
           <a:ln/>
         </p:spPr>
+        <p:txBody>
+          <a:bodyPr/>
+          <a:lstStyle/>
+          <a:p>
+            <a:endParaRPr lang="en-US"/>
+          </a:p>
+        </p:txBody>
       </p:sp>
       <p:sp>
         <p:nvSpPr>
@@ -8554,7 +8597,7 @@
           <a:bodyPr wrap="square" lIns="254" tIns="254" rIns="254" bIns="254" rtlCol="0" anchor="ctr"/>
           <a:lstStyle/>
           <a:p>
-            <a:pPr algn="ctr" indent="0" marL="0">
+            <a:pPr marL="0" indent="0" algn="ctr">
               <a:buNone/>
             </a:pPr>
             <a:r>
@@ -8571,7 +8614,7 @@
             <a:endParaRPr lang="en-US" sz="1050" dirty="0"/>
           </a:p>
           <a:p>
-            <a:pPr algn="ctr" indent="0" marL="0">
+            <a:pPr marL="0" indent="0" algn="ctr">
               <a:buNone/>
             </a:pPr>
             <a:r>
@@ -8610,7 +8653,7 @@
           <a:bodyPr wrap="square" lIns="0" tIns="0" rIns="0" bIns="0" rtlCol="0" anchor="ctr"/>
           <a:lstStyle/>
           <a:p>
-            <a:pPr algn="ctr" indent="0" marL="0">
+            <a:pPr marL="0" indent="0" algn="ctr">
               <a:buNone/>
             </a:pPr>
             <a:r>
@@ -8649,6 +8692,13 @@
           </a:solidFill>
           <a:ln/>
         </p:spPr>
+        <p:txBody>
+          <a:bodyPr/>
+          <a:lstStyle/>
+          <a:p>
+            <a:endParaRPr lang="en-US"/>
+          </a:p>
+        </p:txBody>
       </p:sp>
       <p:sp>
         <p:nvSpPr>
@@ -8671,7 +8721,7 @@
           <a:bodyPr wrap="square" lIns="254" tIns="254" rIns="254" bIns="254" rtlCol="0" anchor="ctr"/>
           <a:lstStyle/>
           <a:p>
-            <a:pPr algn="ctr" indent="0" marL="0">
+            <a:pPr marL="0" indent="0" algn="ctr">
               <a:buNone/>
             </a:pPr>
             <a:r>
@@ -8688,7 +8738,7 @@
             <a:endParaRPr lang="en-US" sz="1050" dirty="0"/>
           </a:p>
           <a:p>
-            <a:pPr algn="ctr" indent="0" marL="0">
+            <a:pPr marL="0" indent="0" algn="ctr">
               <a:buNone/>
             </a:pPr>
             <a:r>
@@ -8727,7 +8777,7 @@
           <a:bodyPr wrap="square" lIns="0" tIns="0" rIns="0" bIns="0" rtlCol="0" anchor="ctr"/>
           <a:lstStyle/>
           <a:p>
-            <a:pPr algn="ctr" indent="0" marL="0">
+            <a:pPr marL="0" indent="0" algn="ctr">
               <a:buNone/>
             </a:pPr>
             <a:r>
@@ -8766,6 +8816,13 @@
           </a:solidFill>
           <a:ln/>
         </p:spPr>
+        <p:txBody>
+          <a:bodyPr/>
+          <a:lstStyle/>
+          <a:p>
+            <a:endParaRPr lang="en-US"/>
+          </a:p>
+        </p:txBody>
       </p:sp>
       <p:sp>
         <p:nvSpPr>
@@ -8788,7 +8845,7 @@
           <a:bodyPr wrap="square" lIns="254" tIns="254" rIns="254" bIns="254" rtlCol="0" anchor="ctr"/>
           <a:lstStyle/>
           <a:p>
-            <a:pPr algn="ctr" indent="0" marL="0">
+            <a:pPr marL="0" indent="0" algn="ctr">
               <a:buNone/>
             </a:pPr>
             <a:r>
@@ -8805,7 +8862,7 @@
             <a:endParaRPr lang="en-US" sz="1050" dirty="0"/>
           </a:p>
           <a:p>
-            <a:pPr algn="ctr" indent="0" marL="0">
+            <a:pPr marL="0" indent="0" algn="ctr">
               <a:buNone/>
             </a:pPr>
             <a:r>
@@ -8844,7 +8901,7 @@
           <a:bodyPr wrap="square" lIns="0" tIns="0" rIns="0" bIns="0" rtlCol="0" anchor="t"/>
           <a:lstStyle/>
           <a:p>
-            <a:pPr algn="l" marL="342900" indent="-342900">
+            <a:pPr marL="342900" indent="-342900" algn="l">
               <a:buSzPct val="100000"/>
               <a:buChar char="•"/>
             </a:pPr>
@@ -8859,9 +8916,6 @@
               </a:rPr>
               <a:t>Why this example: </a:t>
             </a:r>
-            <a:pPr algn="l" indent="0" marL="0">
-              <a:buNone/>
-            </a:pPr>
             <a:r>
               <a:rPr lang="en-US" sz="1350" dirty="0">
                 <a:solidFill>
@@ -8898,7 +8952,7 @@
           <a:bodyPr wrap="square" lIns="0" tIns="0" rIns="0" bIns="0" rtlCol="0" anchor="t"/>
           <a:lstStyle/>
           <a:p>
-            <a:pPr algn="l" indent="0" marL="0">
+            <a:pPr marL="0" indent="0" algn="l">
               <a:buNone/>
             </a:pPr>
             <a:r>
@@ -8912,10 +8966,46 @@
               </a:rPr>
               <a:t>Hatcliff &amp; Belt, </a:t>
             </a:r>
-            <a:pPr algn="l" indent="0" marL="0">
+            <a:r>
+              <a:rPr lang="en-US" sz="850" i="1" dirty="0">
+                <a:solidFill>
+                  <a:srgbClr val="5A6478"/>
+                </a:solidFill>
+                <a:latin typeface="Calibri" pitchFamily="34" charset="0"/>
+                <a:ea typeface="Calibri" pitchFamily="34" charset="-122"/>
+                <a:cs typeface="Calibri" pitchFamily="34" charset="-120"/>
+              </a:rPr>
+              <a:t>The Isolette System: Illustrating End-to-End Artifacts for Rigorous Model-Based Engineering</a:t>
+            </a:r>
+            <a:r>
+              <a:rPr lang="en-US" sz="850" dirty="0">
+                <a:solidFill>
+                  <a:srgbClr val="5A6478"/>
+                </a:solidFill>
+                <a:latin typeface="Calibri" pitchFamily="34" charset="0"/>
+                <a:ea typeface="Calibri" pitchFamily="34" charset="-122"/>
+                <a:cs typeface="Calibri" pitchFamily="34" charset="-120"/>
+              </a:rPr>
+              <a:t>, Springer LNCS 15240, 2025</a:t>
+            </a:r>
+            <a:endParaRPr lang="en-US" sz="850" dirty="0"/>
+          </a:p>
+          <a:p>
+            <a:pPr marL="0" indent="0" algn="l">
               <a:buNone/>
             </a:pPr>
             <a:r>
+              <a:rPr lang="en-US" sz="850" dirty="0">
+                <a:solidFill>
+                  <a:srgbClr val="5A6478"/>
+                </a:solidFill>
+                <a:latin typeface="Calibri" pitchFamily="34" charset="0"/>
+                <a:ea typeface="Calibri" pitchFamily="34" charset="-122"/>
+                <a:cs typeface="Calibri" pitchFamily="34" charset="-120"/>
+              </a:rPr>
+              <a:t>Hatcliff, Belt, Robby, McKenzie, Liang, </a:t>
+            </a:r>
+            <a:r>
               <a:rPr lang="en-US" sz="850" i="1" dirty="0">
                 <a:solidFill>
                   <a:srgbClr val="5A6478"/>
@@ -8924,9 +9014,23 @@
                 <a:ea typeface="Calibri" pitchFamily="34" charset="-122"/>
                 <a:cs typeface="Calibri" pitchFamily="34" charset="-120"/>
               </a:rPr>
-              <a:t>The Isolette System: Illustrating End-to-End Artifacts for Rigorous Model-Based Engineering</a:t>
-            </a:r>
-            <a:pPr algn="l" indent="0" marL="0">
+              <a:t>End-to-End Formal Methods Integrated Development with SysMLv2 Using HAMR</a:t>
+            </a:r>
+            <a:r>
+              <a:rPr lang="en-US" sz="850" dirty="0">
+                <a:solidFill>
+                  <a:srgbClr val="5A6478"/>
+                </a:solidFill>
+                <a:latin typeface="Calibri" pitchFamily="34" charset="0"/>
+                <a:ea typeface="Calibri" pitchFamily="34" charset="-122"/>
+                <a:cs typeface="Calibri" pitchFamily="34" charset="-120"/>
+              </a:rPr>
+              <a:t>, Springer, 2025</a:t>
+            </a:r>
+            <a:endParaRPr lang="en-US" sz="850" dirty="0"/>
+          </a:p>
+          <a:p>
+            <a:pPr marL="0" indent="0" algn="l">
               <a:buNone/>
             </a:pPr>
             <a:r>
@@ -8938,16 +9042,10 @@
                 <a:ea typeface="Calibri" pitchFamily="34" charset="-122"/>
                 <a:cs typeface="Calibri" pitchFamily="34" charset="-120"/>
               </a:rPr>
-              <a:t>, Springer LNCS 15240, 2025</a:t>
-            </a:r>
-            <a:endParaRPr lang="en-US" sz="850" dirty="0"/>
-          </a:p>
-          <a:p>
-            <a:pPr algn="l" indent="0" marL="0">
-              <a:buNone/>
-            </a:pPr>
-            <a:r>
-              <a:rPr lang="en-US" sz="850" dirty="0">
+              <a:t>Hatcliff, Belt, Robby, Carpenter, </a:t>
+            </a:r>
+            <a:r>
+              <a:rPr lang="en-US" sz="850" i="1" dirty="0">
                 <a:solidFill>
                   <a:srgbClr val="5A6478"/>
                 </a:solidFill>
@@ -8955,70 +9053,8 @@
                 <a:ea typeface="Calibri" pitchFamily="34" charset="-122"/>
                 <a:cs typeface="Calibri" pitchFamily="34" charset="-120"/>
               </a:rPr>
-              <a:t>Hatcliff, Belt, Robby, McKenzie, Liang, </a:t>
-            </a:r>
-            <a:pPr algn="l" indent="0" marL="0">
-              <a:buNone/>
-            </a:pPr>
-            <a:r>
-              <a:rPr lang="en-US" sz="850" i="1" dirty="0">
-                <a:solidFill>
-                  <a:srgbClr val="5A6478"/>
-                </a:solidFill>
-                <a:latin typeface="Calibri" pitchFamily="34" charset="0"/>
-                <a:ea typeface="Calibri" pitchFamily="34" charset="-122"/>
-                <a:cs typeface="Calibri" pitchFamily="34" charset="-120"/>
-              </a:rPr>
-              <a:t>End-to-End Formal Methods Integrated Development with SysMLv2 Using HAMR</a:t>
-            </a:r>
-            <a:pPr algn="l" indent="0" marL="0">
-              <a:buNone/>
-            </a:pPr>
-            <a:r>
-              <a:rPr lang="en-US" sz="850" dirty="0">
-                <a:solidFill>
-                  <a:srgbClr val="5A6478"/>
-                </a:solidFill>
-                <a:latin typeface="Calibri" pitchFamily="34" charset="0"/>
-                <a:ea typeface="Calibri" pitchFamily="34" charset="-122"/>
-                <a:cs typeface="Calibri" pitchFamily="34" charset="-120"/>
-              </a:rPr>
-              <a:t>, Springer, 2025</a:t>
-            </a:r>
-            <a:endParaRPr lang="en-US" sz="850" dirty="0"/>
-          </a:p>
-          <a:p>
-            <a:pPr algn="l" indent="0" marL="0">
-              <a:buNone/>
-            </a:pPr>
-            <a:r>
-              <a:rPr lang="en-US" sz="850" dirty="0">
-                <a:solidFill>
-                  <a:srgbClr val="5A6478"/>
-                </a:solidFill>
-                <a:latin typeface="Calibri" pitchFamily="34" charset="0"/>
-                <a:ea typeface="Calibri" pitchFamily="34" charset="-122"/>
-                <a:cs typeface="Calibri" pitchFamily="34" charset="-120"/>
-              </a:rPr>
-              <a:t>Hatcliff, Belt, Robby, Carpenter, </a:t>
-            </a:r>
-            <a:pPr algn="l" indent="0" marL="0">
-              <a:buNone/>
-            </a:pPr>
-            <a:r>
-              <a:rPr lang="en-US" sz="850" i="1" dirty="0">
-                <a:solidFill>
-                  <a:srgbClr val="5A6478"/>
-                </a:solidFill>
-                <a:latin typeface="Calibri" pitchFamily="34" charset="0"/>
-                <a:ea typeface="Calibri" pitchFamily="34" charset="-122"/>
-                <a:cs typeface="Calibri" pitchFamily="34" charset="-120"/>
-              </a:rPr>
               <a:t>HAMR: An AADL Multi-platform Code Generation Toolset</a:t>
             </a:r>
-            <a:pPr algn="l" indent="0" marL="0">
-              <a:buNone/>
-            </a:pPr>
             <a:r>
               <a:rPr lang="en-US" sz="850" dirty="0">
                 <a:solidFill>
@@ -9055,7 +9091,7 @@
           <a:bodyPr wrap="square" lIns="0" tIns="0" rIns="0" bIns="0" rtlCol="0" anchor="ctr"/>
           <a:lstStyle/>
           <a:p>
-            <a:pPr algn="l" indent="0" marL="0">
+            <a:pPr marL="0" indent="0" algn="l">
               <a:buNone/>
             </a:pPr>
             <a:r>
@@ -9081,12 +9117,12 @@
         </p:nvSpPr>
         <p:spPr>
           <a:xfrm>
-            <a:off x="7040880" y="1737360"/>
-            <a:ext cx="4480560" cy="822960"/>
+            <a:off x="7040880" y="1627632"/>
+            <a:ext cx="4480560" cy="676656"/>
           </a:xfrm>
           <a:prstGeom prst="roundRect">
             <a:avLst>
-              <a:gd name="adj" fmla="val 6667"/>
+              <a:gd name="adj" fmla="val 8108"/>
             </a:avLst>
           </a:prstGeom>
           <a:solidFill>
@@ -9099,6 +9135,13 @@
             <a:prstDash val="solid"/>
           </a:ln>
         </p:spPr>
+        <p:txBody>
+          <a:bodyPr/>
+          <a:lstStyle/>
+          <a:p>
+            <a:endParaRPr lang="en-US"/>
+          </a:p>
+        </p:txBody>
       </p:sp>
       <p:sp>
         <p:nvSpPr>
@@ -9108,8 +9151,8 @@
         </p:nvSpPr>
         <p:spPr>
           <a:xfrm>
-            <a:off x="7178040" y="1737360"/>
-            <a:ext cx="1234440" cy="822960"/>
+            <a:off x="7178040" y="1627632"/>
+            <a:ext cx="1234440" cy="676656"/>
           </a:xfrm>
           <a:prstGeom prst="rect">
             <a:avLst/>
@@ -9121,11 +9164,11 @@
           <a:bodyPr wrap="square" lIns="0" tIns="0" rIns="0" bIns="0" rtlCol="0" anchor="ctr"/>
           <a:lstStyle/>
           <a:p>
-            <a:pPr algn="l" indent="0" marL="0">
+            <a:pPr marL="0" indent="0" algn="l">
               <a:buNone/>
             </a:pPr>
             <a:r>
-              <a:rPr lang="en-US" sz="3000" b="1" dirty="0">
+              <a:rPr lang="en-US" sz="2600" b="1" dirty="0">
                 <a:solidFill>
                   <a:srgbClr val="1E2761"/>
                 </a:solidFill>
@@ -9135,7 +9178,7 @@
               </a:rPr>
               <a:t>13</a:t>
             </a:r>
-            <a:endParaRPr lang="en-US" sz="3000" dirty="0"/>
+            <a:endParaRPr lang="en-US" sz="2600" dirty="0"/>
           </a:p>
         </p:txBody>
       </p:sp>
@@ -9147,8 +9190,8 @@
         </p:nvSpPr>
         <p:spPr>
           <a:xfrm>
-            <a:off x="8458200" y="1737360"/>
-            <a:ext cx="2971800" cy="822960"/>
+            <a:off x="8198069" y="1627632"/>
+            <a:ext cx="3277651" cy="676656"/>
           </a:xfrm>
           <a:prstGeom prst="rect">
             <a:avLst/>
@@ -9160,11 +9203,11 @@
           <a:bodyPr wrap="square" lIns="0" tIns="0" rIns="0" bIns="0" rtlCol="0" anchor="ctr"/>
           <a:lstStyle/>
           <a:p>
-            <a:pPr algn="l" indent="0" marL="0">
+            <a:pPr marL="0" indent="0" algn="l">
               <a:buNone/>
             </a:pPr>
             <a:r>
-              <a:rPr lang="en-US" sz="1100" dirty="0">
+              <a:rPr lang="en-US" sz="1000" dirty="0">
                 <a:solidFill>
                   <a:srgbClr val="212121"/>
                 </a:solidFill>
@@ -9172,9 +9215,9 @@
                 <a:ea typeface="Calibri" pitchFamily="34" charset="-122"/>
                 <a:cs typeface="Calibri" pitchFamily="34" charset="-120"/>
               </a:rPr>
-              <a:t>measured files (SysML packages + contract-bearing Rust)</a:t>
-            </a:r>
-            <a:endParaRPr lang="en-US" sz="1100" dirty="0"/>
+              <a:t>measured spec files (SysML packages + contract-bearing Rust)</a:t>
+            </a:r>
+            <a:endParaRPr lang="en-US" sz="1000" dirty="0"/>
           </a:p>
         </p:txBody>
       </p:sp>
@@ -9186,12 +9229,12 @@
         </p:nvSpPr>
         <p:spPr>
           <a:xfrm>
-            <a:off x="7040880" y="2651760"/>
-            <a:ext cx="4480560" cy="822960"/>
+            <a:off x="7040880" y="2377440"/>
+            <a:ext cx="4480560" cy="676656"/>
           </a:xfrm>
           <a:prstGeom prst="roundRect">
             <a:avLst>
-              <a:gd name="adj" fmla="val 6667"/>
+              <a:gd name="adj" fmla="val 8108"/>
             </a:avLst>
           </a:prstGeom>
           <a:solidFill>
@@ -9204,6 +9247,13 @@
             <a:prstDash val="solid"/>
           </a:ln>
         </p:spPr>
+        <p:txBody>
+          <a:bodyPr/>
+          <a:lstStyle/>
+          <a:p>
+            <a:endParaRPr lang="en-US"/>
+          </a:p>
+        </p:txBody>
       </p:sp>
       <p:sp>
         <p:nvSpPr>
@@ -9213,8 +9263,8 @@
         </p:nvSpPr>
         <p:spPr>
           <a:xfrm>
-            <a:off x="7178040" y="2651760"/>
-            <a:ext cx="1234440" cy="822960"/>
+            <a:off x="7178040" y="2377440"/>
+            <a:ext cx="1234440" cy="676656"/>
           </a:xfrm>
           <a:prstGeom prst="rect">
             <a:avLst/>
@@ -9226,11 +9276,11 @@
           <a:bodyPr wrap="square" lIns="0" tIns="0" rIns="0" bIns="0" rtlCol="0" anchor="ctr"/>
           <a:lstStyle/>
           <a:p>
-            <a:pPr algn="l" indent="0" marL="0">
+            <a:pPr marL="0" indent="0" algn="l">
               <a:buNone/>
             </a:pPr>
             <a:r>
-              <a:rPr lang="en-US" sz="3000" b="1" dirty="0">
+              <a:rPr lang="en-US" sz="2600" b="1" dirty="0">
                 <a:solidFill>
                   <a:srgbClr val="1E2761"/>
                 </a:solidFill>
@@ -9240,7 +9290,7 @@
               </a:rPr>
               <a:t>67</a:t>
             </a:r>
-            <a:endParaRPr lang="en-US" sz="3000" dirty="0"/>
+            <a:endParaRPr lang="en-US" sz="2600" dirty="0"/>
           </a:p>
         </p:txBody>
       </p:sp>
@@ -9252,8 +9302,8 @@
         </p:nvSpPr>
         <p:spPr>
           <a:xfrm>
-            <a:off x="8458200" y="2651760"/>
-            <a:ext cx="2971800" cy="822960"/>
+            <a:off x="8458200" y="2377440"/>
+            <a:ext cx="3017520" cy="676656"/>
           </a:xfrm>
           <a:prstGeom prst="rect">
             <a:avLst/>
@@ -9265,11 +9315,11 @@
           <a:bodyPr wrap="square" lIns="0" tIns="0" rIns="0" bIns="0" rtlCol="0" anchor="ctr"/>
           <a:lstStyle/>
           <a:p>
-            <a:pPr algn="l" indent="0" marL="0">
+            <a:pPr marL="0" indent="0" algn="l">
               <a:buNone/>
             </a:pPr>
             <a:r>
-              <a:rPr lang="en-US" sz="1100" dirty="0">
+              <a:rPr lang="en-US" sz="1000" dirty="0">
                 <a:solidFill>
                   <a:srgbClr val="212121"/>
                 </a:solidFill>
@@ -9279,7 +9329,7 @@
               </a:rPr>
               <a:t>contract slices</a:t>
             </a:r>
-            <a:endParaRPr lang="en-US" sz="1100" dirty="0"/>
+            <a:endParaRPr lang="en-US" sz="1000" dirty="0"/>
           </a:p>
         </p:txBody>
       </p:sp>
@@ -9291,12 +9341,12 @@
         </p:nvSpPr>
         <p:spPr>
           <a:xfrm>
-            <a:off x="7040880" y="3566160"/>
-            <a:ext cx="4480560" cy="822960"/>
+            <a:off x="7040880" y="3127248"/>
+            <a:ext cx="4480560" cy="676656"/>
           </a:xfrm>
           <a:prstGeom prst="roundRect">
             <a:avLst>
-              <a:gd name="adj" fmla="val 6667"/>
+              <a:gd name="adj" fmla="val 8108"/>
             </a:avLst>
           </a:prstGeom>
           <a:solidFill>
@@ -9309,6 +9359,13 @@
             <a:prstDash val="solid"/>
           </a:ln>
         </p:spPr>
+        <p:txBody>
+          <a:bodyPr/>
+          <a:lstStyle/>
+          <a:p>
+            <a:endParaRPr lang="en-US"/>
+          </a:p>
+        </p:txBody>
       </p:sp>
       <p:sp>
         <p:nvSpPr>
@@ -9318,8 +9375,8 @@
         </p:nvSpPr>
         <p:spPr>
           <a:xfrm>
-            <a:off x="7178040" y="3566160"/>
-            <a:ext cx="1234440" cy="822960"/>
+            <a:off x="7178040" y="3127248"/>
+            <a:ext cx="1234440" cy="676656"/>
           </a:xfrm>
           <a:prstGeom prst="rect">
             <a:avLst/>
@@ -9331,11 +9388,11 @@
           <a:bodyPr wrap="square" lIns="0" tIns="0" rIns="0" bIns="0" rtlCol="0" anchor="ctr"/>
           <a:lstStyle/>
           <a:p>
-            <a:pPr algn="l" indent="0" marL="0">
+            <a:pPr marL="0" indent="0" algn="l">
               <a:buNone/>
             </a:pPr>
             <a:r>
-              <a:rPr lang="en-US" sz="3000" b="1" dirty="0">
+              <a:rPr lang="en-US" sz="2600" b="1" dirty="0">
                 <a:solidFill>
                   <a:srgbClr val="1E2761"/>
                 </a:solidFill>
@@ -9345,7 +9402,7 @@
               </a:rPr>
               <a:t>8</a:t>
             </a:r>
-            <a:endParaRPr lang="en-US" sz="3000" dirty="0"/>
+            <a:endParaRPr lang="en-US" sz="2600" dirty="0"/>
           </a:p>
         </p:txBody>
       </p:sp>
@@ -9357,8 +9414,8 @@
         </p:nvSpPr>
         <p:spPr>
           <a:xfrm>
-            <a:off x="8458200" y="3566160"/>
-            <a:ext cx="2971800" cy="822960"/>
+            <a:off x="8458200" y="3127248"/>
+            <a:ext cx="3017520" cy="676656"/>
           </a:xfrm>
           <a:prstGeom prst="rect">
             <a:avLst/>
@@ -9370,11 +9427,11 @@
           <a:bodyPr wrap="square" lIns="0" tIns="0" rIns="0" bIns="0" rtlCol="0" anchor="ctr"/>
           <a:lstStyle/>
           <a:p>
-            <a:pPr algn="l" indent="0" marL="0">
+            <a:pPr marL="0" indent="0" algn="l">
               <a:buNone/>
             </a:pPr>
             <a:r>
-              <a:rPr lang="en-US" sz="1100" dirty="0">
+              <a:rPr lang="en-US" sz="1000" dirty="0">
                 <a:solidFill>
                   <a:srgbClr val="212121"/>
                 </a:solidFill>
@@ -9382,9 +9439,9 @@
                 <a:ea typeface="Calibri" pitchFamily="34" charset="-122"/>
                 <a:cs typeface="Calibri" pitchFamily="34" charset="-120"/>
               </a:rPr>
-              <a:t>crates re-verified every episode (7 components + the system proof)</a:t>
-            </a:r>
-            <a:endParaRPr lang="en-US" sz="1100" dirty="0"/>
+              <a:t>Rust crates re-verified every episode (7 components + the system proof)</a:t>
+            </a:r>
+            <a:endParaRPr lang="en-US" sz="1000" dirty="0"/>
           </a:p>
         </p:txBody>
       </p:sp>
@@ -9396,12 +9453,12 @@
         </p:nvSpPr>
         <p:spPr>
           <a:xfrm>
-            <a:off x="7040880" y="4480560"/>
-            <a:ext cx="4480560" cy="822960"/>
+            <a:off x="7040880" y="3877056"/>
+            <a:ext cx="4480560" cy="676656"/>
           </a:xfrm>
           <a:prstGeom prst="roundRect">
             <a:avLst>
-              <a:gd name="adj" fmla="val 6667"/>
+              <a:gd name="adj" fmla="val 8108"/>
             </a:avLst>
           </a:prstGeom>
           <a:solidFill>
@@ -9414,6 +9471,13 @@
             <a:prstDash val="solid"/>
           </a:ln>
         </p:spPr>
+        <p:txBody>
+          <a:bodyPr/>
+          <a:lstStyle/>
+          <a:p>
+            <a:endParaRPr lang="en-US"/>
+          </a:p>
+        </p:txBody>
       </p:sp>
       <p:sp>
         <p:nvSpPr>
@@ -9423,8 +9487,8 @@
         </p:nvSpPr>
         <p:spPr>
           <a:xfrm>
-            <a:off x="7178040" y="4480560"/>
-            <a:ext cx="1234440" cy="822960"/>
+            <a:off x="7178040" y="3877056"/>
+            <a:ext cx="1234440" cy="676656"/>
           </a:xfrm>
           <a:prstGeom prst="rect">
             <a:avLst/>
@@ -9436,11 +9500,11 @@
           <a:bodyPr wrap="square" lIns="0" tIns="0" rIns="0" bIns="0" rtlCol="0" anchor="ctr"/>
           <a:lstStyle/>
           <a:p>
-            <a:pPr algn="l" indent="0" marL="0">
+            <a:pPr marL="0" indent="0" algn="l">
               <a:buNone/>
             </a:pPr>
             <a:r>
-              <a:rPr lang="en-US" sz="3000" b="1" dirty="0">
+              <a:rPr lang="en-US" sz="2600" b="1" dirty="0">
                 <a:solidFill>
                   <a:srgbClr val="1E2761"/>
                 </a:solidFill>
@@ -9450,7 +9514,7 @@
               </a:rPr>
               <a:t>1,862</a:t>
             </a:r>
-            <a:endParaRPr lang="en-US" sz="3000" dirty="0"/>
+            <a:endParaRPr lang="en-US" sz="2600" dirty="0"/>
           </a:p>
         </p:txBody>
       </p:sp>
@@ -9462,8 +9526,8 @@
         </p:nvSpPr>
         <p:spPr>
           <a:xfrm>
-            <a:off x="8458200" y="4480560"/>
-            <a:ext cx="2971800" cy="822960"/>
+            <a:off x="8458200" y="3877056"/>
+            <a:ext cx="3017520" cy="676656"/>
           </a:xfrm>
           <a:prstGeom prst="rect">
             <a:avLst/>
@@ -9475,11 +9539,11 @@
           <a:bodyPr wrap="square" lIns="0" tIns="0" rIns="0" bIns="0" rtlCol="0" anchor="ctr"/>
           <a:lstStyle/>
           <a:p>
-            <a:pPr algn="l" indent="0" marL="0">
+            <a:pPr marL="0" indent="0" algn="l">
               <a:buNone/>
             </a:pPr>
             <a:r>
-              <a:rPr lang="en-US" sz="1100" dirty="0">
+              <a:rPr lang="en-US" sz="1000" dirty="0">
                 <a:solidFill>
                   <a:srgbClr val="212121"/>
                 </a:solidFill>
@@ -9489,7 +9553,7 @@
               </a:rPr>
               <a:t>system-proof obligations</a:t>
             </a:r>
-            <a:endParaRPr lang="en-US" sz="1100" dirty="0"/>
+            <a:endParaRPr lang="en-US" sz="1000" dirty="0"/>
           </a:p>
         </p:txBody>
       </p:sp>
@@ -9501,12 +9565,12 @@
         </p:nvSpPr>
         <p:spPr>
           <a:xfrm>
-            <a:off x="7040880" y="5394960"/>
-            <a:ext cx="4480560" cy="822960"/>
+            <a:off x="7040880" y="4626864"/>
+            <a:ext cx="4480560" cy="676656"/>
           </a:xfrm>
           <a:prstGeom prst="roundRect">
             <a:avLst>
-              <a:gd name="adj" fmla="val 6667"/>
+              <a:gd name="adj" fmla="val 8108"/>
             </a:avLst>
           </a:prstGeom>
           <a:solidFill>
@@ -9519,6 +9583,13 @@
             <a:prstDash val="solid"/>
           </a:ln>
         </p:spPr>
+        <p:txBody>
+          <a:bodyPr/>
+          <a:lstStyle/>
+          <a:p>
+            <a:endParaRPr lang="en-US"/>
+          </a:p>
+        </p:txBody>
       </p:sp>
       <p:sp>
         <p:nvSpPr>
@@ -9528,8 +9599,8 @@
         </p:nvSpPr>
         <p:spPr>
           <a:xfrm>
-            <a:off x="7178040" y="5394960"/>
-            <a:ext cx="1234440" cy="822960"/>
+            <a:off x="7178040" y="4626864"/>
+            <a:ext cx="1234440" cy="676656"/>
           </a:xfrm>
           <a:prstGeom prst="rect">
             <a:avLst/>
@@ -9541,11 +9612,11 @@
           <a:bodyPr wrap="square" lIns="0" tIns="0" rIns="0" bIns="0" rtlCol="0" anchor="ctr"/>
           <a:lstStyle/>
           <a:p>
-            <a:pPr algn="l" indent="0" marL="0">
+            <a:pPr marL="0" indent="0" algn="l">
               <a:buNone/>
             </a:pPr>
             <a:r>
-              <a:rPr lang="en-US" sz="3000" b="1" dirty="0">
+              <a:rPr lang="en-US" sz="2600" b="1" dirty="0">
                 <a:solidFill>
                   <a:srgbClr val="1E2761"/>
                 </a:solidFill>
@@ -9553,9 +9624,9 @@
                 <a:ea typeface="Cambria" pitchFamily="34" charset="-122"/>
                 <a:cs typeface="Cambria" pitchFamily="34" charset="-120"/>
               </a:rPr>
-              <a:t>8</a:t>
-            </a:r>
-            <a:endParaRPr lang="en-US" sz="3000" dirty="0"/>
+              <a:t>30</a:t>
+            </a:r>
+            <a:endParaRPr lang="en-US" sz="2600" dirty="0"/>
           </a:p>
         </p:txBody>
       </p:sp>
@@ -9567,8 +9638,8 @@
         </p:nvSpPr>
         <p:spPr>
           <a:xfrm>
-            <a:off x="8458200" y="5394960"/>
-            <a:ext cx="2971800" cy="822960"/>
+            <a:off x="8458200" y="4626864"/>
+            <a:ext cx="3017520" cy="676656"/>
           </a:xfrm>
           <a:prstGeom prst="rect">
             <a:avLst/>
@@ -9580,11 +9651,11 @@
           <a:bodyPr wrap="square" lIns="0" tIns="0" rIns="0" bIns="0" rtlCol="0" anchor="ctr"/>
           <a:lstStyle/>
           <a:p>
-            <a:pPr algn="l" indent="0" marL="0">
+            <a:pPr marL="0" indent="0" algn="l">
               <a:buNone/>
             </a:pPr>
             <a:r>
-              <a:rPr lang="en-US" sz="1100" dirty="0">
+              <a:rPr lang="en-US" sz="1000" dirty="0">
                 <a:solidFill>
                   <a:srgbClr val="212121"/>
                 </a:solidFill>
@@ -9592,16 +9663,111 @@
                 <a:ea typeface="Calibri" pitchFamily="34" charset="-122"/>
                 <a:cs typeface="Calibri" pitchFamily="34" charset="-120"/>
               </a:rPr>
-              <a:t>attestation tiers — the glossary's entry keys:</a:t>
-            </a:r>
-            <a:endParaRPr lang="en-US" sz="1100" dirty="0"/>
-          </a:p>
-          <a:p>
-            <a:pPr algn="l" indent="0" marL="0">
+              <a:t>toolchain + dependency files hashed measure-then-use (4 Verus · 9 HAMR · 17 SysML libs)</a:t>
+            </a:r>
+            <a:endParaRPr lang="en-US" sz="1000" dirty="0"/>
+          </a:p>
+        </p:txBody>
+      </p:sp>
+      <p:sp>
+        <p:nvSpPr>
+          <p:cNvPr id="43" name="Shape 41"/>
+          <p:cNvSpPr/>
+          <p:nvPr/>
+        </p:nvSpPr>
+        <p:spPr>
+          <a:xfrm>
+            <a:off x="7040880" y="5376672"/>
+            <a:ext cx="4480560" cy="676656"/>
+          </a:xfrm>
+          <a:prstGeom prst="roundRect">
+            <a:avLst>
+              <a:gd name="adj" fmla="val 8108"/>
+            </a:avLst>
+          </a:prstGeom>
+          <a:solidFill>
+            <a:srgbClr val="F2F4F8"/>
+          </a:solidFill>
+          <a:ln w="12700">
+            <a:solidFill>
+              <a:srgbClr val="CADCFC"/>
+            </a:solidFill>
+            <a:prstDash val="solid"/>
+          </a:ln>
+        </p:spPr>
+        <p:txBody>
+          <a:bodyPr/>
+          <a:lstStyle/>
+          <a:p>
+            <a:endParaRPr lang="en-US"/>
+          </a:p>
+        </p:txBody>
+      </p:sp>
+      <p:sp>
+        <p:nvSpPr>
+          <p:cNvPr id="44" name="Text 42"/>
+          <p:cNvSpPr/>
+          <p:nvPr/>
+        </p:nvSpPr>
+        <p:spPr>
+          <a:xfrm>
+            <a:off x="7178040" y="5376672"/>
+            <a:ext cx="1234440" cy="676656"/>
+          </a:xfrm>
+          <a:prstGeom prst="rect">
+            <a:avLst/>
+          </a:prstGeom>
+          <a:noFill/>
+          <a:ln/>
+        </p:spPr>
+        <p:txBody>
+          <a:bodyPr wrap="square" lIns="0" tIns="0" rIns="0" bIns="0" rtlCol="0" anchor="ctr"/>
+          <a:lstStyle/>
+          <a:p>
+            <a:pPr marL="0" indent="0" algn="l">
               <a:buNone/>
             </a:pPr>
             <a:r>
-              <a:rPr lang="en-US" sz="1100" dirty="0">
+              <a:rPr lang="en-US" sz="2600" b="1" dirty="0">
+                <a:solidFill>
+                  <a:srgbClr val="1E2761"/>
+                </a:solidFill>
+                <a:latin typeface="Cambria" pitchFamily="34" charset="0"/>
+                <a:ea typeface="Cambria" pitchFamily="34" charset="-122"/>
+                <a:cs typeface="Cambria" pitchFamily="34" charset="-120"/>
+              </a:rPr>
+              <a:t>8</a:t>
+            </a:r>
+            <a:endParaRPr lang="en-US" sz="2600" dirty="0"/>
+          </a:p>
+        </p:txBody>
+      </p:sp>
+      <p:sp>
+        <p:nvSpPr>
+          <p:cNvPr id="45" name="Text 43"/>
+          <p:cNvSpPr/>
+          <p:nvPr/>
+        </p:nvSpPr>
+        <p:spPr>
+          <a:xfrm>
+            <a:off x="8458200" y="5376672"/>
+            <a:ext cx="3017520" cy="676656"/>
+          </a:xfrm>
+          <a:prstGeom prst="rect">
+            <a:avLst/>
+          </a:prstGeom>
+          <a:noFill/>
+          <a:ln/>
+        </p:spPr>
+        <p:txBody>
+          <a:bodyPr wrap="square" lIns="0" tIns="0" rIns="0" bIns="0" rtlCol="0" anchor="ctr"/>
+          <a:lstStyle/>
+          <a:p>
+            <a:pPr marL="0" indent="0" algn="l">
+              <a:buNone/>
+            </a:pPr>
+            <a:r>
+              <a:rPr lang="en-US" sz="1000" dirty="0">
                 <a:solidFill>
                   <a:srgbClr val="212121"/>
                 </a:solidFill>
@@ -9609,9 +9775,26 @@
                 <a:ea typeface="Calibri" pitchFamily="34" charset="-122"/>
                 <a:cs typeface="Calibri" pitchFamily="34" charset="-120"/>
               </a:rPr>
+              <a:t>attestation tiers — the blackboard’s entry keys:</a:t>
+            </a:r>
+            <a:endParaRPr lang="en-US" sz="1000" dirty="0"/>
+          </a:p>
+          <a:p>
+            <a:pPr marL="0" indent="0" algn="l">
+              <a:buNone/>
+            </a:pPr>
+            <a:r>
+              <a:rPr lang="en-US" sz="1000" dirty="0">
+                <a:solidFill>
+                  <a:srgbClr val="212121"/>
+                </a:solidFill>
+                <a:latin typeface="Calibri" pitchFamily="34" charset="0"/>
+                <a:ea typeface="Calibri" pitchFamily="34" charset="-122"/>
+                <a:cs typeface="Calibri" pitchFamily="34" charset="-120"/>
+              </a:rPr>
               <a:t>props · l1a · l2 · verus · cheat · sysproof · gensrc · report</a:t>
             </a:r>
-            <a:endParaRPr lang="en-US" sz="1100" dirty="0"/>
+            <a:endParaRPr lang="en-US" sz="1000" dirty="0"/>
           </a:p>
         </p:txBody>
       </p:sp>
@@ -9631,6 +9814,7 @@
         <a:solidFill>
           <a:srgbClr val="FFFFFF"/>
         </a:solidFill>
+        <a:effectLst/>
       </p:bgPr>
     </p:bg>
     <p:spTree>
@@ -9668,7 +9852,7 @@
           <a:bodyPr wrap="square" lIns="0" tIns="0" rIns="0" bIns="0" rtlCol="0" anchor="ctr"/>
           <a:lstStyle/>
           <a:p>
-            <a:pPr indent="0" marL="0">
+            <a:pPr marL="0" indent="0">
               <a:buNone/>
             </a:pPr>
             <a:r>
@@ -9707,7 +9891,7 @@
           <a:bodyPr wrap="square" lIns="0" tIns="0" rIns="0" bIns="0" rtlCol="0" anchor="t"/>
           <a:lstStyle/>
           <a:p>
-            <a:pPr algn="l" indent="0" marL="0">
+            <a:pPr marL="0" indent="0" algn="l">
               <a:spcAft>
                 <a:spcPts val="400"/>
               </a:spcAft>
@@ -9727,7 +9911,7 @@
             <a:endParaRPr lang="en-US" sz="1400" dirty="0"/>
           </a:p>
           <a:p>
-            <a:pPr algn="l" marL="342900" indent="-342900">
+            <a:pPr marL="342900" indent="-342900" algn="l">
               <a:spcAft>
                 <a:spcPts val="300"/>
               </a:spcAft>
@@ -9745,12 +9929,6 @@
               </a:rPr>
               <a:t>Hatcliff &amp; Belt, </a:t>
             </a:r>
-            <a:pPr algn="l" indent="0" marL="0">
-              <a:spcAft>
-                <a:spcPts val="300"/>
-              </a:spcAft>
-              <a:buNone/>
-            </a:pPr>
             <a:r>
               <a:rPr lang="en-US" sz="1150" i="1" dirty="0">
                 <a:solidFill>
@@ -9762,12 +9940,6 @@
               </a:rPr>
               <a:t>The Isolette System: Illustrating End-to-End Artifacts for Rigorous Model-Based Engineering</a:t>
             </a:r>
-            <a:pPr algn="l" indent="0" marL="0">
-              <a:spcAft>
-                <a:spcPts val="300"/>
-              </a:spcAft>
-              <a:buNone/>
-            </a:pPr>
             <a:r>
               <a:rPr lang="en-US" sz="1150" dirty="0">
                 <a:solidFill>
@@ -9782,7 +9954,7 @@
             <a:endParaRPr lang="en-US" sz="1400" dirty="0"/>
           </a:p>
           <a:p>
-            <a:pPr algn="l" marL="342900" indent="-342900">
+            <a:pPr marL="342900" indent="-342900" algn="l">
               <a:spcAft>
                 <a:spcPts val="300"/>
               </a:spcAft>
@@ -9800,12 +9972,6 @@
               </a:rPr>
               <a:t>Hatcliff, Belt, Robby, McKenzie, Liang, </a:t>
             </a:r>
-            <a:pPr algn="l" indent="0" marL="0">
-              <a:spcAft>
-                <a:spcPts val="300"/>
-              </a:spcAft>
-              <a:buNone/>
-            </a:pPr>
             <a:r>
               <a:rPr lang="en-US" sz="1150" i="1" dirty="0">
                 <a:solidFill>
@@ -9817,12 +9983,6 @@
               </a:rPr>
               <a:t>End-to-End Formal Methods Integrated Development with SysMLv2 Using HAMR</a:t>
             </a:r>
-            <a:pPr algn="l" indent="0" marL="0">
-              <a:spcAft>
-                <a:spcPts val="300"/>
-              </a:spcAft>
-              <a:buNone/>
-            </a:pPr>
             <a:r>
               <a:rPr lang="en-US" sz="1150" dirty="0">
                 <a:solidFill>
@@ -9837,7 +9997,7 @@
             <a:endParaRPr lang="en-US" sz="1400" dirty="0"/>
           </a:p>
           <a:p>
-            <a:pPr algn="l" marL="342900" indent="-342900">
+            <a:pPr marL="342900" indent="-342900" algn="l">
               <a:spcAft>
                 <a:spcPts val="300"/>
               </a:spcAft>
@@ -9855,12 +10015,6 @@
               </a:rPr>
               <a:t>Hatcliff, Belt, Robby, Carpenter, </a:t>
             </a:r>
-            <a:pPr algn="l" indent="0" marL="0">
-              <a:spcAft>
-                <a:spcPts val="300"/>
-              </a:spcAft>
-              <a:buNone/>
-            </a:pPr>
             <a:r>
               <a:rPr lang="en-US" sz="1150" i="1" dirty="0">
                 <a:solidFill>
@@ -9872,12 +10026,6 @@
               </a:rPr>
               <a:t>HAMR: An AADL Multi-platform Code Generation Toolset</a:t>
             </a:r>
-            <a:pPr algn="l" indent="0" marL="0">
-              <a:spcAft>
-                <a:spcPts val="300"/>
-              </a:spcAft>
-              <a:buNone/>
-            </a:pPr>
             <a:r>
               <a:rPr lang="en-US" sz="1150" dirty="0">
                 <a:solidFill>
@@ -9892,7 +10040,7 @@
             <a:endParaRPr lang="en-US" sz="1400" dirty="0"/>
           </a:p>
           <a:p>
-            <a:pPr algn="l" marL="342900" indent="-342900">
+            <a:pPr marL="342900" indent="-342900" algn="l">
               <a:spcAft>
                 <a:spcPts val="300"/>
               </a:spcAft>
@@ -9910,12 +10058,6 @@
               </a:rPr>
               <a:t>Lempia &amp; Miller, </a:t>
             </a:r>
-            <a:pPr algn="l" indent="0" marL="0">
-              <a:spcAft>
-                <a:spcPts val="300"/>
-              </a:spcAft>
-              <a:buNone/>
-            </a:pPr>
             <a:r>
               <a:rPr lang="en-US" sz="1150" i="1" dirty="0">
                 <a:solidFill>
@@ -9927,12 +10069,6 @@
               </a:rPr>
               <a:t>Requirements Engineering Management Handbook</a:t>
             </a:r>
-            <a:pPr algn="l" indent="0" marL="0">
-              <a:spcAft>
-                <a:spcPts val="300"/>
-              </a:spcAft>
-              <a:buNone/>
-            </a:pPr>
             <a:r>
               <a:rPr lang="en-US" sz="1150" dirty="0">
                 <a:solidFill>
@@ -9947,7 +10083,7 @@
             <a:endParaRPr lang="en-US" sz="1400" dirty="0"/>
           </a:p>
           <a:p>
-            <a:pPr algn="l" marL="342900" indent="-342900">
+            <a:pPr marL="342900" indent="-342900" algn="l">
               <a:spcAft>
                 <a:spcPts val="300"/>
               </a:spcAft>
@@ -9968,7 +10104,7 @@
             <a:endParaRPr lang="en-US" sz="1400" dirty="0"/>
           </a:p>
           <a:p>
-            <a:pPr algn="l" indent="0" marL="0">
+            <a:pPr marL="0" indent="0" algn="l">
               <a:spcBef>
                 <a:spcPts val="1200"/>
               </a:spcBef>
@@ -9991,7 +10127,7 @@
             <a:endParaRPr lang="en-US" sz="1400" dirty="0"/>
           </a:p>
           <a:p>
-            <a:pPr algn="l" marL="342900" indent="-342900">
+            <a:pPr marL="342900" indent="-342900" algn="l">
               <a:spcAft>
                 <a:spcPts val="300"/>
               </a:spcAft>
@@ -10009,12 +10145,6 @@
               </a:rPr>
               <a:t>Ramsdell, Rowe, Alexander, Helble, Loscocco, Pendergrass, Petz, </a:t>
             </a:r>
-            <a:pPr algn="l" indent="0" marL="0">
-              <a:spcAft>
-                <a:spcPts val="300"/>
-              </a:spcAft>
-              <a:buNone/>
-            </a:pPr>
             <a:r>
               <a:rPr lang="en-US" sz="1150" i="1" dirty="0">
                 <a:solidFill>
@@ -10026,12 +10156,6 @@
               </a:rPr>
               <a:t>Orchestrating Layered Attestations</a:t>
             </a:r>
-            <a:pPr algn="l" indent="0" marL="0">
-              <a:spcAft>
-                <a:spcPts val="300"/>
-              </a:spcAft>
-              <a:buNone/>
-            </a:pPr>
             <a:r>
               <a:rPr lang="en-US" sz="1150" dirty="0">
                 <a:solidFill>
@@ -10046,7 +10170,7 @@
             <a:endParaRPr lang="en-US" sz="1400" dirty="0"/>
           </a:p>
           <a:p>
-            <a:pPr algn="l" indent="0" marL="0">
+            <a:pPr marL="0" indent="0" algn="l">
               <a:spcBef>
                 <a:spcPts val="1200"/>
               </a:spcBef>
@@ -10069,7 +10193,7 @@
             <a:endParaRPr lang="en-US" sz="1400" dirty="0"/>
           </a:p>
           <a:p>
-            <a:pPr algn="l" marL="342900" indent="-342900">
+            <a:pPr marL="342900" indent="-342900" algn="l">
               <a:spcAft>
                 <a:spcPts val="300"/>
               </a:spcAft>
@@ -10087,12 +10211,6 @@
               </a:rPr>
               <a:t>Lattuada, Hance, Cho, Brun, Subasinghe, Zhou, Howell, Parno, Hawblitzel, </a:t>
             </a:r>
-            <a:pPr algn="l" indent="0" marL="0">
-              <a:spcAft>
-                <a:spcPts val="300"/>
-              </a:spcAft>
-              <a:buNone/>
-            </a:pPr>
             <a:r>
               <a:rPr lang="en-US" sz="1150" i="1" dirty="0">
                 <a:solidFill>
@@ -10104,12 +10222,6 @@
               </a:rPr>
               <a:t>Verus: Verifying Rust Programs using Linear Ghost Types</a:t>
             </a:r>
-            <a:pPr algn="l" indent="0" marL="0">
-              <a:spcAft>
-                <a:spcPts val="300"/>
-              </a:spcAft>
-              <a:buNone/>
-            </a:pPr>
             <a:r>
               <a:rPr lang="en-US" sz="1150" dirty="0">
                 <a:solidFill>
@@ -10124,7 +10236,7 @@
             <a:endParaRPr lang="en-US" sz="1400" dirty="0"/>
           </a:p>
           <a:p>
-            <a:pPr algn="l" marL="342900" indent="-342900">
+            <a:pPr marL="342900" indent="-342900" algn="l">
               <a:spcAft>
                 <a:spcPts val="300"/>
               </a:spcAft>
@@ -10142,12 +10254,6 @@
               </a:rPr>
               <a:t>Klein et al., </a:t>
             </a:r>
-            <a:pPr algn="l" indent="0" marL="0">
-              <a:spcAft>
-                <a:spcPts val="300"/>
-              </a:spcAft>
-              <a:buNone/>
-            </a:pPr>
             <a:r>
               <a:rPr lang="en-US" sz="1150" i="1" dirty="0">
                 <a:solidFill>
@@ -10159,12 +10265,6 @@
               </a:rPr>
               <a:t>seL4: Formal Verification of an OS Kernel</a:t>
             </a:r>
-            <a:pPr algn="l" indent="0" marL="0">
-              <a:spcAft>
-                <a:spcPts val="300"/>
-              </a:spcAft>
-              <a:buNone/>
-            </a:pPr>
             <a:r>
               <a:rPr lang="en-US" sz="1150" dirty="0">
                 <a:solidFill>
@@ -10481,4 +10581,319 @@
     </a:ext>
   </a:extLst>
 </a:theme>
+</file>
+
+<file path=ppt/theme/theme2.xml><?xml version="1.0" encoding="utf-8"?>
+<a:theme xmlns:a="http://schemas.openxmlformats.org/drawingml/2006/main" name="Office Theme">
+  <a:themeElements>
+    <a:clrScheme name="Office">
+      <a:dk1>
+        <a:sysClr val="windowText" lastClr="000000"/>
+      </a:dk1>
+      <a:lt1>
+        <a:sysClr val="window" lastClr="FFFFFF"/>
+      </a:lt1>
+      <a:dk2>
+        <a:srgbClr val="0E2841"/>
+      </a:dk2>
+      <a:lt2>
+        <a:srgbClr val="E8E8E8"/>
+      </a:lt2>
+      <a:accent1>
+        <a:srgbClr val="156082"/>
+      </a:accent1>
+      <a:accent2>
+        <a:srgbClr val="E97132"/>
+      </a:accent2>
+      <a:accent3>
+        <a:srgbClr val="196B24"/>
+      </a:accent3>
+      <a:accent4>
+        <a:srgbClr val="0F9ED5"/>
+      </a:accent4>
+      <a:accent5>
+        <a:srgbClr val="A02B93"/>
+      </a:accent5>
+      <a:accent6>
+        <a:srgbClr val="4EA72E"/>
+      </a:accent6>
+      <a:hlink>
+        <a:srgbClr val="467886"/>
+      </a:hlink>
+      <a:folHlink>
+        <a:srgbClr val="96607D"/>
+      </a:folHlink>
+    </a:clrScheme>
+    <a:fontScheme name="Office">
+      <a:majorFont>
+        <a:latin typeface="Aptos Display" panose="02110004020202020204"/>
+        <a:ea typeface=""/>
+        <a:cs typeface=""/>
+        <a:font script="Jpan" typeface="游ゴシック Light"/>
+        <a:font script="Hang" typeface="맑은 고딕"/>
+        <a:font script="Hans" typeface="等线 Light"/>
+        <a:font script="Hant" typeface="新細明體"/>
+        <a:font script="Arab" typeface="Times New Roman"/>
+        <a:font script="Hebr" typeface="Times New Roman"/>
+        <a:font script="Thai" typeface="Angsana New"/>
+        <a:font script="Ethi" typeface="Nyala"/>
+        <a:font script="Beng" typeface="Vrinda"/>
+        <a:font script="Gujr" typeface="Shruti"/>
+        <a:font script="Khmr" typeface="MoolBoran"/>
+        <a:font script="Knda" typeface="Tunga"/>
+        <a:font script="Guru" typeface="Raavi"/>
+        <a:font script="Cans" typeface="Euphemia"/>
+        <a:font script="Cher" typeface="Plantagenet Cherokee"/>
+        <a:font script="Yiii" typeface="Microsoft Yi Baiti"/>
+        <a:font script="Tibt" typeface="Microsoft Himalaya"/>
+        <a:font script="Thaa" typeface="MV Boli"/>
+        <a:font script="Deva" typeface="Mangal"/>
+        <a:font script="Telu" typeface="Gautami"/>
+        <a:font script="Taml" typeface="Latha"/>
+        <a:font script="Syrc" typeface="Estrangelo Edessa"/>
+        <a:font script="Orya" typeface="Kalinga"/>
+        <a:font script="Mlym" typeface="Kartika"/>
+        <a:font script="Laoo" typeface="DokChampa"/>
+        <a:font script="Sinh" typeface="Iskoola Pota"/>
+        <a:font script="Mong" typeface="Mongolian Baiti"/>
+        <a:font script="Viet" typeface="Times New Roman"/>
+        <a:font script="Uigh" typeface="Microsoft Uighur"/>
+        <a:font script="Geor" typeface="Sylfaen"/>
+        <a:font script="Armn" typeface="Arial"/>
+        <a:font script="Bugi" typeface="Leelawadee UI"/>
+        <a:font script="Bopo" typeface="Microsoft JhengHei"/>
+        <a:font script="Java" typeface="Javanese Text"/>
+        <a:font script="Lisu" typeface="Segoe UI"/>
+        <a:font script="Mymr" typeface="Myanmar Text"/>
+        <a:font script="Nkoo" typeface="Ebrima"/>
+        <a:font script="Olck" typeface="Nirmala UI"/>
+        <a:font script="Osma" typeface="Ebrima"/>
+        <a:font script="Phag" typeface="Phagspa"/>
+        <a:font script="Syrn" typeface="Estrangelo Edessa"/>
+        <a:font script="Syrj" typeface="Estrangelo Edessa"/>
+        <a:font script="Syre" typeface="Estrangelo Edessa"/>
+        <a:font script="Sora" typeface="Nirmala UI"/>
+        <a:font script="Tale" typeface="Microsoft Tai Le"/>
+        <a:font script="Talu" typeface="Microsoft New Tai Lue"/>
+        <a:font script="Tfng" typeface="Ebrima"/>
+      </a:majorFont>
+      <a:minorFont>
+        <a:latin typeface="Aptos" panose="02110004020202020204"/>
+        <a:ea typeface=""/>
+        <a:cs typeface=""/>
+        <a:font script="Jpan" typeface="游ゴシック"/>
+        <a:font script="Hang" typeface="맑은 고딕"/>
+        <a:font script="Hans" typeface="等线"/>
+        <a:font script="Hant" typeface="新細明體"/>
+        <a:font script="Arab" typeface="Arial"/>
+        <a:font script="Hebr" typeface="Arial"/>
+        <a:font script="Thai" typeface="Cordia New"/>
+        <a:font script="Ethi" typeface="Nyala"/>
+        <a:font script="Beng" typeface="Vrinda"/>
+        <a:font script="Gujr" typeface="Shruti"/>
+        <a:font script="Khmr" typeface="DaunPenh"/>
+        <a:font script="Knda" typeface="Tunga"/>
+        <a:font script="Guru" typeface="Raavi"/>
+        <a:font script="Cans" typeface="Euphemia"/>
+        <a:font script="Cher" typeface="Plantagenet Cherokee"/>
+        <a:font script="Yiii" typeface="Microsoft Yi Baiti"/>
+        <a:font script="Tibt" typeface="Microsoft Himalaya"/>
+        <a:font script="Thaa" typeface="MV Boli"/>
+        <a:font script="Deva" typeface="Mangal"/>
+        <a:font script="Telu" typeface="Gautami"/>
+        <a:font script="Taml" typeface="Latha"/>
+        <a:font script="Syrc" typeface="Estrangelo Edessa"/>
+        <a:font script="Orya" typeface="Kalinga"/>
+        <a:font script="Mlym" typeface="Kartika"/>
+        <a:font script="Laoo" typeface="DokChampa"/>
+        <a:font script="Sinh" typeface="Iskoola Pota"/>
+        <a:font script="Mong" typeface="Mongolian Baiti"/>
+        <a:font script="Viet" typeface="Arial"/>
+        <a:font script="Uigh" typeface="Microsoft Uighur"/>
+        <a:font script="Geor" typeface="Sylfaen"/>
+        <a:font script="Armn" typeface="Arial"/>
+        <a:font script="Bugi" typeface="Leelawadee UI"/>
+        <a:font script="Bopo" typeface="Microsoft JhengHei"/>
+        <a:font script="Java" typeface="Javanese Text"/>
+        <a:font script="Lisu" typeface="Segoe UI"/>
+        <a:font script="Mymr" typeface="Myanmar Text"/>
+        <a:font script="Nkoo" typeface="Ebrima"/>
+        <a:font script="Olck" typeface="Nirmala UI"/>
+        <a:font script="Osma" typeface="Ebrima"/>
+        <a:font script="Phag" typeface="Phagspa"/>
+        <a:font script="Syrn" typeface="Estrangelo Edessa"/>
+        <a:font script="Syrj" typeface="Estrangelo Edessa"/>
+        <a:font script="Syre" typeface="Estrangelo Edessa"/>
+        <a:font script="Sora" typeface="Nirmala UI"/>
+        <a:font script="Tale" typeface="Microsoft Tai Le"/>
+        <a:font script="Talu" typeface="Microsoft New Tai Lue"/>
+        <a:font script="Tfng" typeface="Ebrima"/>
+      </a:minorFont>
+    </a:fontScheme>
+    <a:fmtScheme name="Office">
+      <a:fillStyleLst>
+        <a:solidFill>
+          <a:schemeClr val="phClr"/>
+        </a:solidFill>
+        <a:gradFill rotWithShape="1">
+          <a:gsLst>
+            <a:gs pos="0">
+              <a:schemeClr val="phClr">
+                <a:lumMod val="110000"/>
+                <a:satMod val="105000"/>
+                <a:tint val="67000"/>
+              </a:schemeClr>
+            </a:gs>
+            <a:gs pos="50000">
+              <a:schemeClr val="phClr">
+                <a:lumMod val="105000"/>
+                <a:satMod val="103000"/>
+                <a:tint val="73000"/>
+              </a:schemeClr>
+            </a:gs>
+            <a:gs pos="100000">
+              <a:schemeClr val="phClr">
+                <a:lumMod val="105000"/>
+                <a:satMod val="109000"/>
+                <a:tint val="81000"/>
+              </a:schemeClr>
+            </a:gs>
+          </a:gsLst>
+          <a:lin ang="5400000" scaled="0"/>
+        </a:gradFill>
+        <a:gradFill rotWithShape="1">
+          <a:gsLst>
+            <a:gs pos="0">
+              <a:schemeClr val="phClr">
+                <a:satMod val="103000"/>
+                <a:lumMod val="102000"/>
+                <a:tint val="94000"/>
+              </a:schemeClr>
+            </a:gs>
+            <a:gs pos="50000">
+              <a:schemeClr val="phClr">
+                <a:satMod val="110000"/>
+                <a:lumMod val="100000"/>
+                <a:shade val="100000"/>
+              </a:schemeClr>
+            </a:gs>
+            <a:gs pos="100000">
+              <a:schemeClr val="phClr">
+                <a:lumMod val="99000"/>
+                <a:satMod val="120000"/>
+                <a:shade val="78000"/>
+              </a:schemeClr>
+            </a:gs>
+          </a:gsLst>
+          <a:lin ang="5400000" scaled="0"/>
+        </a:gradFill>
+      </a:fillStyleLst>
+      <a:lnStyleLst>
+        <a:ln w="12700" cap="flat" cmpd="sng" algn="ctr">
+          <a:solidFill>
+            <a:schemeClr val="phClr"/>
+          </a:solidFill>
+          <a:prstDash val="solid"/>
+          <a:miter lim="800000"/>
+        </a:ln>
+        <a:ln w="19050" cap="flat" cmpd="sng" algn="ctr">
+          <a:solidFill>
+            <a:schemeClr val="phClr"/>
+          </a:solidFill>
+          <a:prstDash val="solid"/>
+          <a:miter lim="800000"/>
+        </a:ln>
+        <a:ln w="25400" cap="flat" cmpd="sng" algn="ctr">
+          <a:solidFill>
+            <a:schemeClr val="phClr"/>
+          </a:solidFill>
+          <a:prstDash val="solid"/>
+          <a:miter lim="800000"/>
+        </a:ln>
+      </a:lnStyleLst>
+      <a:effectStyleLst>
+        <a:effectStyle>
+          <a:effectLst/>
+        </a:effectStyle>
+        <a:effectStyle>
+          <a:effectLst/>
+        </a:effectStyle>
+        <a:effectStyle>
+          <a:effectLst>
+            <a:outerShdw blurRad="57150" dist="19050" dir="5400000" algn="ctr" rotWithShape="0">
+              <a:srgbClr val="000000">
+                <a:alpha val="63000"/>
+              </a:srgbClr>
+            </a:outerShdw>
+          </a:effectLst>
+        </a:effectStyle>
+      </a:effectStyleLst>
+      <a:bgFillStyleLst>
+        <a:solidFill>
+          <a:schemeClr val="phClr"/>
+        </a:solidFill>
+        <a:solidFill>
+          <a:schemeClr val="phClr">
+            <a:tint val="95000"/>
+            <a:satMod val="170000"/>
+          </a:schemeClr>
+        </a:solidFill>
+        <a:gradFill rotWithShape="1">
+          <a:gsLst>
+            <a:gs pos="0">
+              <a:schemeClr val="phClr">
+                <a:tint val="93000"/>
+                <a:satMod val="150000"/>
+                <a:shade val="98000"/>
+                <a:lumMod val="102000"/>
+              </a:schemeClr>
+            </a:gs>
+            <a:gs pos="50000">
+              <a:schemeClr val="phClr">
+                <a:tint val="98000"/>
+                <a:satMod val="130000"/>
+                <a:shade val="90000"/>
+                <a:lumMod val="103000"/>
+              </a:schemeClr>
+            </a:gs>
+            <a:gs pos="100000">
+              <a:schemeClr val="phClr">
+                <a:shade val="63000"/>
+                <a:satMod val="120000"/>
+              </a:schemeClr>
+            </a:gs>
+          </a:gsLst>
+          <a:lin ang="5400000" scaled="0"/>
+        </a:gradFill>
+      </a:bgFillStyleLst>
+    </a:fmtScheme>
+  </a:themeElements>
+  <a:objectDefaults>
+    <a:lnDef>
+      <a:spPr/>
+      <a:bodyPr/>
+      <a:lstStyle/>
+      <a:style>
+        <a:lnRef idx="2">
+          <a:schemeClr val="accent1"/>
+        </a:lnRef>
+        <a:fillRef idx="0">
+          <a:schemeClr val="accent1"/>
+        </a:fillRef>
+        <a:effectRef idx="1">
+          <a:schemeClr val="accent1"/>
+        </a:effectRef>
+        <a:fontRef idx="minor">
+          <a:schemeClr val="tx1"/>
+        </a:fontRef>
+      </a:style>
+    </a:lnDef>
+  </a:objectDefaults>
+  <a:extraClrSchemeLst/>
+  <a:extLst>
+    <a:ext uri="{05A4C25C-085E-4340-85A3-A5531E510DB2}">
+      <thm15:themeFamily xmlns:thm15="http://schemas.microsoft.com/office/thememl/2012/main" name="Office Theme" id="{2E142A2C-CD16-42D6-873A-C26D2A0506FA}" vid="{1BDDFF52-6CD6-40A5-AB3C-68EB2F1E4D0A}"/>
+    </a:ext>
+  </a:extLst>
+</a:theme>
 </file>
</xml_diff>

<commit_message>
video plan: two-beat Act II (range + breaking) + deck sync
Act II shows the full benign-range bless arc (fail with attribution ->
bless -> promote -> re-proves green) then the breaking variant; Act I
renamed "The consistent baseline" per deck edits (ported); slide 10
footer fixed to real invocations; timings rebudgeted (~21 min).

Co-Authored-By: Claude Fable 5 <noreply@anthropic.com>
</commit_message>
<xml_diff>
--- a/docs/video_slides_draft.pptx
+++ b/docs/video_slides_draft.pptx
@@ -4,6 +4,9 @@
   <p:sldMasterIdLst>
     <p:sldMasterId id="2147483648" r:id="rId1"/>
   </p:sldMasterIdLst>
+  <p:notesMasterIdLst>
+    <p:notesMasterId r:id="rId16"/>
+  </p:notesMasterIdLst>
   <p:sldIdLst>
     <p:sldId id="256" r:id="rId2"/>
     <p:sldId id="257" r:id="rId3"/>
@@ -20,9 +23,6 @@
     <p:sldId id="268" r:id="rId14"/>
     <p:sldId id="269" r:id="rId15"/>
   </p:sldIdLst>
-  <p:notesMasterIdLst>
-    <p:notesMasterId r:id="rId16"/>
-  </p:notesMasterIdLst>
   <p:sldSz cx="12192000" cy="6858000"/>
   <p:notesSz cx="6858000" cy="12192000"/>
   <p:defaultTextStyle>
@@ -117,6 +117,11 @@
       </a:defRPr>
     </a:lvl9pPr>
   </p:defaultTextStyle>
+  <p:extLst>
+    <p:ext uri="{EFAFB233-063F-42B5-8137-9DF3F51BA10A}">
+      <p15:sldGuideLst xmlns:p15="http://schemas.microsoft.com/office/powerpoint/2012/main"/>
+    </p:ext>
+  </p:extLst>
 </p:presentation>
 </file>
 
@@ -142,234 +147,10 @@
           <a:chExt cx="0" cy="0"/>
         </a:xfrm>
       </p:grpSpPr>
-      <p:sp>
-        <p:nvSpPr>
-          <p:cNvPr id="2" name="Header Placeholder 1"/>
-          <p:cNvSpPr>
-            <a:spLocks noGrp="1"/>
-          </p:cNvSpPr>
-          <p:nvPr>
-            <p:ph type="hdr" sz="quarter"/>
-          </p:nvPr>
-        </p:nvSpPr>
-        <p:spPr>
-          <a:xfrm>
-            <a:off x="0" y="0"/>
-            <a:ext cx="2971800" cy="458788"/>
-          </a:xfrm>
-          <a:prstGeom prst="rect">
-            <a:avLst/>
-          </a:prstGeom>
-        </p:spPr>
-        <p:txBody>
-          <a:bodyPr vert="horz" lIns="91440" tIns="45720" rIns="91440" bIns="45720" rtlCol="0"/>
-          <a:lstStyle>
-            <a:lvl1pPr algn="l">
-              <a:defRPr sz="1200"/>
-            </a:lvl1pPr>
-          </a:lstStyle>
-          <a:p>
-            <a:endParaRPr lang="en-US"/>
-          </a:p>
-        </p:txBody>
-      </p:sp>
-      <p:sp>
-        <p:nvSpPr>
-          <p:cNvPr id="3" name="Date Placeholder 2"/>
-          <p:cNvSpPr>
-            <a:spLocks noGrp="1"/>
-          </p:cNvSpPr>
-          <p:nvPr>
-            <p:ph type="dt" idx="1"/>
-          </p:nvPr>
-        </p:nvSpPr>
-        <p:spPr>
-          <a:xfrm>
-            <a:off x="3884613" y="0"/>
-            <a:ext cx="2971800" cy="458788"/>
-          </a:xfrm>
-          <a:prstGeom prst="rect">
-            <a:avLst/>
-          </a:prstGeom>
-        </p:spPr>
-        <p:txBody>
-          <a:bodyPr vert="horz" lIns="91440" tIns="45720" rIns="91440" bIns="45720" rtlCol="0"/>
-          <a:lstStyle>
-            <a:lvl1pPr algn="r">
-              <a:defRPr sz="1200"/>
-            </a:lvl1pPr>
-          </a:lstStyle>
-          <a:p>
-            <a:fld id="{5282F153-3F37-0F45-9E97-73ACFA13230C}" type="datetimeFigureOut">
-              <a:rPr lang="en-US"/>
-              <a:t>7/23/19</a:t>
-            </a:fld>
-            <a:endParaRPr lang="en-US"/>
-          </a:p>
-        </p:txBody>
-      </p:sp>
-      <p:sp>
-        <p:nvSpPr>
-          <p:cNvPr id="4" name="Slide Image Placeholder 3"/>
-          <p:cNvSpPr>
-            <a:spLocks noGrp="1" noRot="1" noChangeAspect="1"/>
-          </p:cNvSpPr>
-          <p:nvPr>
-            <p:ph type="sldImg" idx="2"/>
-          </p:nvPr>
-        </p:nvSpPr>
-        <p:spPr>
-          <a:xfrm>
-            <a:off x="685800" y="1143000"/>
-            <a:ext cx="5486400" cy="3086100"/>
-          </a:xfrm>
-          <a:prstGeom prst="rect">
-            <a:avLst/>
-          </a:prstGeom>
-          <a:noFill/>
-          <a:ln w="12700">
-            <a:solidFill>
-              <a:prstClr val="black"/>
-            </a:solidFill>
-          </a:ln>
-        </p:spPr>
-        <p:txBody>
-          <a:bodyPr vert="horz" lIns="91440" tIns="45720" rIns="91440" bIns="45720" rtlCol="0" anchor="ctr"/>
-          <a:lstStyle/>
-          <a:p>
-            <a:endParaRPr lang="en-US"/>
-          </a:p>
-        </p:txBody>
-      </p:sp>
-      <p:sp>
-        <p:nvSpPr>
-          <p:cNvPr id="5" name="Notes Placeholder 4"/>
-          <p:cNvSpPr>
-            <a:spLocks noGrp="1"/>
-          </p:cNvSpPr>
-          <p:nvPr>
-            <p:ph type="body" sz="quarter" idx="3"/>
-          </p:nvPr>
-        </p:nvSpPr>
-        <p:spPr>
-          <a:xfrm>
-            <a:off x="685800" y="4400550"/>
-            <a:ext cx="5486400" cy="3600450"/>
-          </a:xfrm>
-          <a:prstGeom prst="rect">
-            <a:avLst/>
-          </a:prstGeom>
-        </p:spPr>
-        <p:txBody>
-          <a:bodyPr vert="horz" lIns="91440" tIns="45720" rIns="91440" bIns="45720" rtlCol="0"/>
-          <a:lstStyle/>
-          <a:p>
-            <a:pPr lvl="0"/>
-            <a:r>
-              <a:rPr lang="en-US"/>
-              <a:t>Click to edit Master text styles</a:t>
-            </a:r>
-          </a:p>
-          <a:p>
-            <a:pPr lvl="1"/>
-            <a:r>
-              <a:rPr lang="en-US"/>
-              <a:t>Second level</a:t>
-            </a:r>
-          </a:p>
-          <a:p>
-            <a:pPr lvl="2"/>
-            <a:r>
-              <a:rPr lang="en-US"/>
-              <a:t>Third level</a:t>
-            </a:r>
-          </a:p>
-          <a:p>
-            <a:pPr lvl="3"/>
-            <a:r>
-              <a:rPr lang="en-US"/>
-              <a:t>Fourth level</a:t>
-            </a:r>
-          </a:p>
-          <a:p>
-            <a:pPr lvl="4"/>
-            <a:r>
-              <a:rPr lang="en-US"/>
-              <a:t>Fifth level</a:t>
-            </a:r>
-          </a:p>
-        </p:txBody>
-      </p:sp>
-      <p:sp>
-        <p:nvSpPr>
-          <p:cNvPr id="6" name="Footer Placeholder 5"/>
-          <p:cNvSpPr>
-            <a:spLocks noGrp="1"/>
-          </p:cNvSpPr>
-          <p:nvPr>
-            <p:ph type="ftr" sz="quarter" idx="4"/>
-          </p:nvPr>
-        </p:nvSpPr>
-        <p:spPr>
-          <a:xfrm>
-            <a:off x="0" y="8685213"/>
-            <a:ext cx="2971800" cy="458787"/>
-          </a:xfrm>
-          <a:prstGeom prst="rect">
-            <a:avLst/>
-          </a:prstGeom>
-        </p:spPr>
-        <p:txBody>
-          <a:bodyPr vert="horz" lIns="91440" tIns="45720" rIns="91440" bIns="45720" rtlCol="0" anchor="b"/>
-          <a:lstStyle>
-            <a:lvl1pPr algn="l">
-              <a:defRPr sz="1200"/>
-            </a:lvl1pPr>
-          </a:lstStyle>
-          <a:p>
-            <a:endParaRPr lang="en-US"/>
-          </a:p>
-        </p:txBody>
-      </p:sp>
-      <p:sp>
-        <p:nvSpPr>
-          <p:cNvPr id="7" name="Slide Number Placeholder 6"/>
-          <p:cNvSpPr>
-            <a:spLocks noGrp="1"/>
-          </p:cNvSpPr>
-          <p:nvPr>
-            <p:ph type="sldNum" sz="quarter" idx="5"/>
-          </p:nvPr>
-        </p:nvSpPr>
-        <p:spPr>
-          <a:xfrm>
-            <a:off x="3884613" y="8685213"/>
-            <a:ext cx="2971800" cy="458787"/>
-          </a:xfrm>
-          <a:prstGeom prst="rect">
-            <a:avLst/>
-          </a:prstGeom>
-        </p:spPr>
-        <p:txBody>
-          <a:bodyPr vert="horz" lIns="91440" tIns="45720" rIns="91440" bIns="45720" rtlCol="0" anchor="b"/>
-          <a:lstStyle>
-            <a:lvl1pPr algn="r">
-              <a:defRPr sz="1200"/>
-            </a:lvl1pPr>
-          </a:lstStyle>
-          <a:p>
-            <a:fld id="{CE5E9CC1-C706-0F49-92D6-E571CC5EEA8F}" type="slidenum">
-              <a:rPr lang="en-US"/>
-              <a:t>‹#›</a:t>
-            </a:fld>
-            <a:endParaRPr lang="en-US"/>
-          </a:p>
-        </p:txBody>
-      </p:sp>
     </p:spTree>
     <p:extLst>
       <p:ext uri="{BB962C8B-B14F-4D97-AF65-F5344CB8AC3E}">
-        <p14:creationId xmlns:p14="http://schemas.microsoft.com/office/powerpoint/2010/main" val="1024086991"/>
+        <p14:creationId xmlns:p14="http://schemas.microsoft.com/office/powerpoint/2010/main" val="2793169109"/>
       </p:ext>
     </p:extLst>
   </p:cSld>
@@ -517,7 +298,6 @@
               <a:rPr lang="en-US" dirty="0"/>
               <a:t>Title card. Subtitle deliberately names the four core artifact classes - the deck's first echo of the artifact-class table (slide 6). Optional footer: INSPECTA program context.</a:t>
             </a:r>
-            <a:endParaRPr lang="en-US" dirty="0"/>
           </a:p>
         </p:txBody>
       </p:sp>
@@ -603,10 +383,9 @@
           <a:p>
             <a:r>
               <a:rPr lang="en-US" dirty="0"/>
-              <a:t>Beats: drifted episode escalates with slice attribution -&gt; ruling diff (always shown; linger) -&gt; bless -&gt; promote (real codegen; speed-ramp stretch, keep rolling) -&gt; gold moves -&gt; Verus tier RED against the new baseline. End on the honest-RED checklist.
+              <a:t>Take A (benign range, --drift range): Table A-12 ceiling 102 -&gt; 103 in the shared library -&gt; appraisal fails, gumbo_library attributed, all else green (dwell: 'sanction, not semantics') -&gt; ruling diff -&gt; bless -&gt; spec-first green -&gt; promote (codegen; speed-ramp) -&gt; re-proves ALL GREEN; offered diff = regenerated shared-library constant. Take B (breaking): escalation with attribution -&gt; ruling diff (linger) -&gt; bless -&gt; promote (speed-ramp) -&gt; gold moves -&gt; Verus tier RED; end on the honest-RED checklist. VO bridge: 'same lifecycle, opposite verdicts - authority chooses the baseline; measurement alone decides whether it holds.'
 Watch-for line doubles as the VO opener over the terminal cut. Full runbook: docs/video_recording_plan.md.</a:t>
             </a:r>
-            <a:endParaRPr lang="en-US" dirty="0"/>
           </a:p>
         </p:txBody>
       </p:sp>
@@ -695,7 +474,6 @@
               <a:t>Beats: dummy-bad-impl diff (take the [v]iew - VSCode diff D1 on camera) -&gt; contracts-intact rung exhausts -&gt; impl rung restores crate-scoped -&gt; restart -&gt; re-attested clean.
 Watch-for line doubles as the VO opener over the terminal cut. Full runbook: docs/video_recording_plan.md.</a:t>
             </a:r>
-            <a:endParaRPr lang="en-US" dirty="0"/>
           </a:p>
         </p:txBody>
       </p:sp>
@@ -784,7 +562,6 @@
               <a:t>Scene 6 beats: three tampers, three attributed refusals (signature -&gt; anchor -&gt; derivability); optionally the flipped-evidence-byte diff on camera. Scene 7 beats: wrapper edit (take the [v]iew, diff D10) -&gt; readiness still passes -&gt; tool hash refutes, every proof cell poisons to ? - dwell, this is the act's money shot. --restore-tools recovery in VO only.
 Watch-for line doubles as the VO opener over the terminal cut. Full runbook: docs/video_recording_plan.md.</a:t>
             </a:r>
-            <a:endParaRPr lang="en-US" dirty="0"/>
           </a:p>
         </p:txBody>
       </p:sp>
@@ -873,7 +650,6 @@
               <a:t>Beats: inverted-FFI diff (take the [v]iew, diff D18 - 'see how innocent it looks') -&gt; proofs pass, cheat scan silent -&gt; gensrc byte anchor refuses, naming the file -&gt; diagnosis rung classifies -&gt; repair by regeneration (second speed-ramp stretch) -&gt; re-attested clean. Final checklist doubles as the coverage beat's background; close with one sentence naming scenes 9-11 (capstone slide C carries that taxonomy).
 Watch-for line doubles as the VO opener over the terminal cut. Full runbook: docs/video_recording_plan.md.</a:t>
             </a:r>
-            <a:endParaRPr lang="en-US" dirty="0"/>
           </a:p>
         </p:txBody>
       </p:sp>
@@ -962,7 +738,6 @@
               <a:t>Collection point for every reference in the deck - keep this slide current as sections are added (isolette slide carries the K-State + AR-08-32 citations inline; Copland/Verus/seL4 seeded here ahead of their sections).
 DOIs on record in docs/video_slide_drafts.md.</a:t>
             </a:r>
-            <a:endParaRPr lang="en-US" dirty="0"/>
           </a:p>
         </p:txBody>
       </p:sp>
@@ -1053,7 +828,6 @@
 Subline payoffs: developer claims -&gt; scenes 5/7; untrusted tools -&gt; scene 7; LLM outputs -&gt; capstone slides A/B; cached verdicts -&gt; scene 11.
 Visual TODO: three-stage widening-scope progression (boot-time -&gt; layered runtime -&gt; lifecycle loop) to replace/join the bullets.</a:t>
             </a:r>
-            <a:endParaRPr lang="en-US" dirty="0"/>
           </a:p>
         </p:txBody>
       </p:sp>
@@ -1142,7 +916,6 @@
               <a:t>~15 seconds on first appearance; afterwards it rides on transition slides for free.
 Design decision: one master/layout holds the strip text so a section rename is a single edit. Header titles are provisional.</a:t>
             </a:r>
-            <a:endParaRPr lang="en-US" dirty="0"/>
           </a:p>
         </p:txBody>
       </p:sp>
@@ -1233,7 +1006,6 @@
 Snippet source: tests/fixtures/isolette_sysmlv2_rust_props/term.json, rendered in concrete syntax (branches flattened, target IDs shortened to file names - cosmetic).
 The verus-tier measure-then-use phrase is deliberately held back for scene 7's reveal.</a:t>
             </a:r>
-            <a:endParaRPr lang="en-US" dirty="0"/>
           </a:p>
         </p:txBody>
       </p:sp>
@@ -1325,7 +1097,6 @@
 Speaker-note-only details (cut from the slide): on_pass/on_fail dispatch mechanics, success-driven handoff for component-wise entries, max_attempts per rung.
 The legend earns its space: every scene's checklist frames render through these glyphs.</a:t>
             </a:r>
-            <a:endParaRPr lang="en-US" dirty="0"/>
           </a:p>
         </p:txBody>
       </p:sp>
@@ -1416,7 +1187,6 @@
 Predicate and restart-episode are deliberately OFF this slide (parked; placement TBD - possibly an 'evaluation primitives' strip). If asked: a predicate is the judge (one evaluation = one attestation episode), restart-episode is the freshness primitive (forget memoized verdicts, reset, re-evaluate).
 Also deliberately excluded (README-level detail): partition mechanics, component-wise entries and success handoff, dispatch latching, max_cycles.</a:t>
             </a:r>
-            <a:endParaRPr lang="en-US" dirty="0"/>
           </a:p>
         </p:txBody>
       </p:sp>
@@ -1506,7 +1276,6 @@
 Spoken hook (never on-slide text): 'This table is deliberately incomplete - the demo will show why.' The cheat / sysproof / gensrc tiers are capstone slide C's punchline: attacks forced them into existence. Do not pre-introduce them here.
 Same column shape (class -&gt; measured how -&gt; judged by -&gt; repair) as capstone slide B, so the audience recognizes it when it returns.</a:t>
             </a:r>
-            <a:endParaRPr lang="en-US" dirty="0"/>
           </a:p>
         </p:txBody>
       </p:sp>
@@ -1598,7 +1367,6 @@
 Held back on purpose (scene 9's reveal): cheat-tier depth stats - 86 blessed external_body sites, 10 scanned crates.
 Numbers verified exact 2026-08-25 (l1a targets, l2 slices, verus term, pub-proof-fn count); provision-dependent - re-verify before recording day.</a:t>
             </a:r>
-            <a:endParaRPr lang="en-US" dirty="0"/>
           </a:p>
         </p:txBody>
       </p:sp>
@@ -1687,7 +1455,6 @@
               <a:t>Beats: readiness gate green -&gt; one full episode -&gt; per-crate checklist all green. Dwell on the final checklist - it is the frame every later refusal is compared against.
 Watch-for line doubles as the VO opener over the terminal cut. Full runbook: docs/video_recording_plan.md.</a:t>
             </a:r>
-            <a:endParaRPr lang="en-US" dirty="0"/>
           </a:p>
         </p:txBody>
       </p:sp>
@@ -1760,6 +1527,11 @@
 <file path=ppt/slideMasters/slideMaster1.xml><?xml version="1.0" encoding="utf-8"?>
 <p:sldMaster xmlns:a="http://schemas.openxmlformats.org/drawingml/2006/main" xmlns:r="http://schemas.openxmlformats.org/officeDocument/2006/relationships" xmlns:p="http://schemas.openxmlformats.org/presentationml/2006/main">
   <p:cSld>
+    <p:bg>
+      <p:bgRef idx="1001">
+        <a:schemeClr val="bg1"/>
+      </p:bgRef>
+    </p:bg>
     <p:spTree>
       <p:nvGrpSpPr>
         <p:cNvPr id="1" name=""/>
@@ -2042,6 +1814,7 @@
         <a:solidFill>
           <a:srgbClr val="1E2761"/>
         </a:solidFill>
+        <a:effectLst/>
       </p:bgPr>
     </p:bg>
     <p:spTree>
@@ -2079,7 +1852,7 @@
           <a:bodyPr wrap="square" lIns="0" tIns="0" rIns="0" bIns="0" rtlCol="0" anchor="ctr"/>
           <a:lstStyle/>
           <a:p>
-            <a:pPr algn="l" indent="0" marL="0">
+            <a:pPr marL="0" indent="0" algn="l">
               <a:buNone/>
             </a:pPr>
             <a:r>
@@ -2118,7 +1891,7 @@
           <a:bodyPr wrap="square" lIns="0" tIns="0" rIns="0" bIns="0" rtlCol="0" anchor="ctr"/>
           <a:lstStyle/>
           <a:p>
-            <a:pPr algn="l" indent="0" marL="0">
+            <a:pPr marL="0" indent="0" algn="l">
               <a:buNone/>
             </a:pPr>
             <a:r>
@@ -2157,7 +1930,7 @@
           <a:bodyPr wrap="square" lIns="0" tIns="0" rIns="0" bIns="0" rtlCol="0" anchor="ctr"/>
           <a:lstStyle/>
           <a:p>
-            <a:pPr algn="l" indent="0" marL="0">
+            <a:pPr marL="0" indent="0" algn="l">
               <a:buNone/>
             </a:pPr>
             <a:r>
@@ -2191,6 +1964,7 @@
         <a:solidFill>
           <a:srgbClr val="FFFFFF"/>
         </a:solidFill>
+        <a:effectLst/>
       </p:bgPr>
     </p:bg>
     <p:spTree>
@@ -2228,6 +2002,13 @@
           </a:solidFill>
           <a:ln/>
         </p:spPr>
+        <p:txBody>
+          <a:bodyPr/>
+          <a:lstStyle/>
+          <a:p>
+            <a:endParaRPr lang="en-US"/>
+          </a:p>
+        </p:txBody>
       </p:sp>
       <p:sp>
         <p:nvSpPr>
@@ -2250,7 +2031,7 @@
           <a:bodyPr wrap="square" lIns="254" tIns="254" rIns="254" bIns="254" rtlCol="0" anchor="ctr"/>
           <a:lstStyle/>
           <a:p>
-            <a:pPr algn="ctr" indent="0" marL="0">
+            <a:pPr marL="0" indent="0" algn="ctr">
               <a:buNone/>
             </a:pPr>
             <a:r>
@@ -2289,6 +2070,13 @@
           </a:solidFill>
           <a:ln/>
         </p:spPr>
+        <p:txBody>
+          <a:bodyPr/>
+          <a:lstStyle/>
+          <a:p>
+            <a:endParaRPr lang="en-US"/>
+          </a:p>
+        </p:txBody>
       </p:sp>
       <p:sp>
         <p:nvSpPr>
@@ -2311,7 +2099,7 @@
           <a:bodyPr wrap="square" lIns="254" tIns="254" rIns="254" bIns="254" rtlCol="0" anchor="ctr"/>
           <a:lstStyle/>
           <a:p>
-            <a:pPr algn="ctr" indent="0" marL="0">
+            <a:pPr marL="0" indent="0" algn="ctr">
               <a:buNone/>
             </a:pPr>
             <a:r>
@@ -2328,7 +2116,7 @@
             <a:endParaRPr lang="en-US" sz="900" dirty="0"/>
           </a:p>
           <a:p>
-            <a:pPr algn="ctr" indent="0" marL="0">
+            <a:pPr marL="0" indent="0" algn="ctr">
               <a:buNone/>
             </a:pPr>
             <a:r>
@@ -2367,6 +2155,13 @@
           </a:solidFill>
           <a:ln/>
         </p:spPr>
+        <p:txBody>
+          <a:bodyPr/>
+          <a:lstStyle/>
+          <a:p>
+            <a:endParaRPr lang="en-US"/>
+          </a:p>
+        </p:txBody>
       </p:sp>
       <p:sp>
         <p:nvSpPr>
@@ -2389,7 +2184,7 @@
           <a:bodyPr wrap="square" lIns="254" tIns="254" rIns="254" bIns="254" rtlCol="0" anchor="ctr"/>
           <a:lstStyle/>
           <a:p>
-            <a:pPr algn="ctr" indent="0" marL="0">
+            <a:pPr marL="0" indent="0" algn="ctr">
               <a:buNone/>
             </a:pPr>
             <a:r>
@@ -2428,6 +2223,13 @@
           </a:solidFill>
           <a:ln/>
         </p:spPr>
+        <p:txBody>
+          <a:bodyPr/>
+          <a:lstStyle/>
+          <a:p>
+            <a:endParaRPr lang="en-US"/>
+          </a:p>
+        </p:txBody>
       </p:sp>
       <p:sp>
         <p:nvSpPr>
@@ -2450,7 +2252,7 @@
           <a:bodyPr wrap="square" lIns="254" tIns="254" rIns="254" bIns="254" rtlCol="0" anchor="ctr"/>
           <a:lstStyle/>
           <a:p>
-            <a:pPr algn="ctr" indent="0" marL="0">
+            <a:pPr marL="0" indent="0" algn="ctr">
               <a:buNone/>
             </a:pPr>
             <a:r>
@@ -2489,6 +2291,13 @@
           </a:solidFill>
           <a:ln/>
         </p:spPr>
+        <p:txBody>
+          <a:bodyPr/>
+          <a:lstStyle/>
+          <a:p>
+            <a:endParaRPr lang="en-US"/>
+          </a:p>
+        </p:txBody>
       </p:sp>
       <p:sp>
         <p:nvSpPr>
@@ -2511,7 +2320,7 @@
           <a:bodyPr wrap="square" lIns="254" tIns="254" rIns="254" bIns="254" rtlCol="0" anchor="ctr"/>
           <a:lstStyle/>
           <a:p>
-            <a:pPr algn="ctr" indent="0" marL="0">
+            <a:pPr marL="0" indent="0" algn="ctr">
               <a:buNone/>
             </a:pPr>
             <a:r>
@@ -2550,11 +2359,11 @@
           <a:bodyPr wrap="square" lIns="0" tIns="0" rIns="0" bIns="0" rtlCol="0" anchor="ctr"/>
           <a:lstStyle/>
           <a:p>
-            <a:pPr indent="0" marL="0">
-              <a:buNone/>
-            </a:pPr>
-            <a:r>
-              <a:rPr lang="en-US" sz="1800" b="1" spc="300" kern="0" dirty="0">
+            <a:pPr marL="0" indent="0">
+              <a:buNone/>
+            </a:pPr>
+            <a:r>
+              <a:rPr lang="en-US" sz="1800" b="1" kern="0" spc="300" dirty="0">
                 <a:solidFill>
                   <a:srgbClr val="5A6478"/>
                 </a:solidFill>
@@ -2589,11 +2398,11 @@
           <a:bodyPr wrap="square" lIns="0" tIns="0" rIns="0" bIns="0" rtlCol="0" anchor="ctr"/>
           <a:lstStyle/>
           <a:p>
-            <a:pPr indent="0" marL="0">
-              <a:buNone/>
-            </a:pPr>
-            <a:r>
-              <a:rPr lang="en-US" sz="4000" b="1" dirty="0">
+            <a:pPr marL="0" indent="0">
+              <a:buNone/>
+            </a:pPr>
+            <a:r>
+              <a:rPr lang="en-US" sz="4000" b="1">
                 <a:solidFill>
                   <a:srgbClr val="1E2761"/>
                 </a:solidFill>
@@ -2601,7 +2410,18 @@
                 <a:ea typeface="Cambria" pitchFamily="34" charset="-122"/>
                 <a:cs typeface="Cambria" pitchFamily="34" charset="-120"/>
               </a:rPr>
-              <a:t>Sanctioned change</a:t>
+              <a:t>Model </a:t>
+            </a:r>
+            <a:r>
+              <a:rPr lang="en-US" sz="4000" b="1" dirty="0">
+                <a:solidFill>
+                  <a:srgbClr val="1E2761"/>
+                </a:solidFill>
+                <a:latin typeface="Cambria" pitchFamily="34" charset="0"/>
+                <a:ea typeface="Cambria" pitchFamily="34" charset="-122"/>
+                <a:cs typeface="Cambria" pitchFamily="34" charset="-120"/>
+              </a:rPr>
+              <a:t>drift: benign, re-blessed</a:t>
             </a:r>
             <a:endParaRPr lang="en-US" sz="4000" dirty="0"/>
           </a:p>
@@ -2628,7 +2448,7 @@
           <a:bodyPr wrap="square" lIns="0" tIns="0" rIns="0" bIns="0" rtlCol="0" anchor="ctr"/>
           <a:lstStyle/>
           <a:p>
-            <a:pPr indent="0" marL="0">
+            <a:pPr marL="0" indent="0">
               <a:buNone/>
             </a:pPr>
             <a:r>
@@ -2640,7 +2460,7 @@
                 <a:ea typeface="Calibri" pitchFamily="34" charset="-122"/>
                 <a:cs typeface="Calibri" pitchFamily="34" charset="-120"/>
               </a:rPr>
-              <a:t>scene 3 (breaking)</a:t>
+              <a:t>Demo scene: 3 (expand allowed temperature range)</a:t>
             </a:r>
             <a:endParaRPr lang="en-US" sz="1500" dirty="0"/>
           </a:p>
@@ -2667,7 +2487,7 @@
           <a:bodyPr wrap="square" lIns="0" tIns="0" rIns="0" bIns="0" rtlCol="0" anchor="ctr"/>
           <a:lstStyle/>
           <a:p>
-            <a:pPr indent="0" marL="0">
+            <a:pPr marL="0" indent="0">
               <a:buNone/>
             </a:pPr>
             <a:r>
@@ -2679,7 +2499,7 @@
                 <a:ea typeface="Calibri" pitchFamily="34" charset="-122"/>
                 <a:cs typeface="Calibri" pitchFamily="34" charset="-120"/>
               </a:rPr>
-              <a:t>A spec edit gets caught, examined, and blessed — and the system honestly reports a spec the implementation doesn't yet meet.</a:t>
+              <a:t>A benign change in requirements — the temperature alarm range widened — model appraisal fails quickly.  Administrator re-blesses and promotes new spec, all contract appraisals again pass.</a:t>
             </a:r>
             <a:endParaRPr lang="en-US" sz="2000" dirty="0"/>
           </a:p>
@@ -2693,8 +2513,8 @@
         </p:nvSpPr>
         <p:spPr>
           <a:xfrm>
-            <a:off x="822960" y="6172200"/>
-            <a:ext cx="10515600" cy="365760"/>
+            <a:off x="822960" y="6053328"/>
+            <a:ext cx="10515600" cy="603504"/>
           </a:xfrm>
           <a:prstGeom prst="rect">
             <a:avLst/>
@@ -2706,9 +2526,6 @@
           <a:bodyPr wrap="square" lIns="0" tIns="0" rIns="0" bIns="0" rtlCol="0" anchor="ctr"/>
           <a:lstStyle/>
           <a:p>
-            <a:pPr indent="0" marL="0">
-              <a:buNone/>
-            </a:pPr>
             <a:r>
               <a:rPr lang="en-US" sz="1100" dirty="0">
                 <a:solidFill>
@@ -2718,7 +2535,7 @@
                 <a:ea typeface="Courier New" pitchFamily="34" charset="-122"/>
                 <a:cs typeface="Courier New" pitchFamily="34" charset="-120"/>
               </a:rPr>
-              <a:t>./examples/demo_isolette.sh --scenes 3 --drift breaking</a:t>
+              <a:t>./examples/demo_isolette.sh --scenes 3 --drift range         (ruling at the prompt: bless)</a:t>
             </a:r>
             <a:endParaRPr lang="en-US" sz="1100" dirty="0"/>
           </a:p>
@@ -2740,6 +2557,7 @@
         <a:solidFill>
           <a:srgbClr val="FFFFFF"/>
         </a:solidFill>
+        <a:effectLst/>
       </p:bgPr>
     </p:bg>
     <p:spTree>
@@ -2777,6 +2595,13 @@
           </a:solidFill>
           <a:ln/>
         </p:spPr>
+        <p:txBody>
+          <a:bodyPr/>
+          <a:lstStyle/>
+          <a:p>
+            <a:endParaRPr lang="en-US"/>
+          </a:p>
+        </p:txBody>
       </p:sp>
       <p:sp>
         <p:nvSpPr>
@@ -2799,7 +2624,7 @@
           <a:bodyPr wrap="square" lIns="254" tIns="254" rIns="254" bIns="254" rtlCol="0" anchor="ctr"/>
           <a:lstStyle/>
           <a:p>
-            <a:pPr algn="ctr" indent="0" marL="0">
+            <a:pPr marL="0" indent="0" algn="ctr">
               <a:buNone/>
             </a:pPr>
             <a:r>
@@ -2838,6 +2663,13 @@
           </a:solidFill>
           <a:ln/>
         </p:spPr>
+        <p:txBody>
+          <a:bodyPr/>
+          <a:lstStyle/>
+          <a:p>
+            <a:endParaRPr lang="en-US"/>
+          </a:p>
+        </p:txBody>
       </p:sp>
       <p:sp>
         <p:nvSpPr>
@@ -2860,7 +2692,7 @@
           <a:bodyPr wrap="square" lIns="254" tIns="254" rIns="254" bIns="254" rtlCol="0" anchor="ctr"/>
           <a:lstStyle/>
           <a:p>
-            <a:pPr algn="ctr" indent="0" marL="0">
+            <a:pPr marL="0" indent="0" algn="ctr">
               <a:buNone/>
             </a:pPr>
             <a:r>
@@ -2877,7 +2709,7 @@
             <a:endParaRPr lang="en-US" sz="900" dirty="0"/>
           </a:p>
           <a:p>
-            <a:pPr algn="ctr" indent="0" marL="0">
+            <a:pPr marL="0" indent="0" algn="ctr">
               <a:buNone/>
             </a:pPr>
             <a:r>
@@ -2916,6 +2748,13 @@
           </a:solidFill>
           <a:ln/>
         </p:spPr>
+        <p:txBody>
+          <a:bodyPr/>
+          <a:lstStyle/>
+          <a:p>
+            <a:endParaRPr lang="en-US"/>
+          </a:p>
+        </p:txBody>
       </p:sp>
       <p:sp>
         <p:nvSpPr>
@@ -2938,7 +2777,7 @@
           <a:bodyPr wrap="square" lIns="254" tIns="254" rIns="254" bIns="254" rtlCol="0" anchor="ctr"/>
           <a:lstStyle/>
           <a:p>
-            <a:pPr algn="ctr" indent="0" marL="0">
+            <a:pPr marL="0" indent="0" algn="ctr">
               <a:buNone/>
             </a:pPr>
             <a:r>
@@ -2977,6 +2816,13 @@
           </a:solidFill>
           <a:ln/>
         </p:spPr>
+        <p:txBody>
+          <a:bodyPr/>
+          <a:lstStyle/>
+          <a:p>
+            <a:endParaRPr lang="en-US"/>
+          </a:p>
+        </p:txBody>
       </p:sp>
       <p:sp>
         <p:nvSpPr>
@@ -2999,7 +2845,7 @@
           <a:bodyPr wrap="square" lIns="254" tIns="254" rIns="254" bIns="254" rtlCol="0" anchor="ctr"/>
           <a:lstStyle/>
           <a:p>
-            <a:pPr algn="ctr" indent="0" marL="0">
+            <a:pPr marL="0" indent="0" algn="ctr">
               <a:buNone/>
             </a:pPr>
             <a:r>
@@ -3038,6 +2884,13 @@
           </a:solidFill>
           <a:ln/>
         </p:spPr>
+        <p:txBody>
+          <a:bodyPr/>
+          <a:lstStyle/>
+          <a:p>
+            <a:endParaRPr lang="en-US"/>
+          </a:p>
+        </p:txBody>
       </p:sp>
       <p:sp>
         <p:nvSpPr>
@@ -3060,7 +2913,7 @@
           <a:bodyPr wrap="square" lIns="254" tIns="254" rIns="254" bIns="254" rtlCol="0" anchor="ctr"/>
           <a:lstStyle/>
           <a:p>
-            <a:pPr algn="ctr" indent="0" marL="0">
+            <a:pPr marL="0" indent="0" algn="ctr">
               <a:buNone/>
             </a:pPr>
             <a:r>
@@ -3099,11 +2952,11 @@
           <a:bodyPr wrap="square" lIns="0" tIns="0" rIns="0" bIns="0" rtlCol="0" anchor="ctr"/>
           <a:lstStyle/>
           <a:p>
-            <a:pPr indent="0" marL="0">
-              <a:buNone/>
-            </a:pPr>
-            <a:r>
-              <a:rPr lang="en-US" sz="1800" b="1" spc="300" kern="0" dirty="0">
+            <a:pPr marL="0" indent="0">
+              <a:buNone/>
+            </a:pPr>
+            <a:r>
+              <a:rPr lang="en-US" sz="1800" b="1" kern="0" spc="300" dirty="0">
                 <a:solidFill>
                   <a:srgbClr val="5A6478"/>
                 </a:solidFill>
@@ -3138,7 +2991,7 @@
           <a:bodyPr wrap="square" lIns="0" tIns="0" rIns="0" bIns="0" rtlCol="0" anchor="ctr"/>
           <a:lstStyle/>
           <a:p>
-            <a:pPr indent="0" marL="0">
+            <a:pPr marL="0" indent="0">
               <a:buNone/>
             </a:pPr>
             <a:r>
@@ -3177,7 +3030,7 @@
           <a:bodyPr wrap="square" lIns="0" tIns="0" rIns="0" bIns="0" rtlCol="0" anchor="ctr"/>
           <a:lstStyle/>
           <a:p>
-            <a:pPr indent="0" marL="0">
+            <a:pPr marL="0" indent="0">
               <a:buNone/>
             </a:pPr>
             <a:r>
@@ -3216,7 +3069,7 @@
           <a:bodyPr wrap="square" lIns="0" tIns="0" rIns="0" bIns="0" rtlCol="0" anchor="ctr"/>
           <a:lstStyle/>
           <a:p>
-            <a:pPr indent="0" marL="0">
+            <a:pPr marL="0" indent="0">
               <a:buNone/>
             </a:pPr>
             <a:r>
@@ -3242,8 +3095,8 @@
         </p:nvSpPr>
         <p:spPr>
           <a:xfrm>
-            <a:off x="822960" y="6172200"/>
-            <a:ext cx="10515600" cy="365760"/>
+            <a:off x="822960" y="6053328"/>
+            <a:ext cx="10515600" cy="603504"/>
           </a:xfrm>
           <a:prstGeom prst="rect">
             <a:avLst/>
@@ -3255,7 +3108,7 @@
           <a:bodyPr wrap="square" lIns="0" tIns="0" rIns="0" bIns="0" rtlCol="0" anchor="ctr"/>
           <a:lstStyle/>
           <a:p>
-            <a:pPr indent="0" marL="0">
+            <a:pPr marL="0" indent="0">
               <a:buNone/>
             </a:pPr>
             <a:r>
@@ -3289,6 +3142,7 @@
         <a:solidFill>
           <a:srgbClr val="FFFFFF"/>
         </a:solidFill>
+        <a:effectLst/>
       </p:bgPr>
     </p:bg>
     <p:spTree>
@@ -3326,6 +3180,13 @@
           </a:solidFill>
           <a:ln/>
         </p:spPr>
+        <p:txBody>
+          <a:bodyPr/>
+          <a:lstStyle/>
+          <a:p>
+            <a:endParaRPr lang="en-US"/>
+          </a:p>
+        </p:txBody>
       </p:sp>
       <p:sp>
         <p:nvSpPr>
@@ -3348,7 +3209,7 @@
           <a:bodyPr wrap="square" lIns="254" tIns="254" rIns="254" bIns="254" rtlCol="0" anchor="ctr"/>
           <a:lstStyle/>
           <a:p>
-            <a:pPr algn="ctr" indent="0" marL="0">
+            <a:pPr marL="0" indent="0" algn="ctr">
               <a:buNone/>
             </a:pPr>
             <a:r>
@@ -3387,6 +3248,13 @@
           </a:solidFill>
           <a:ln/>
         </p:spPr>
+        <p:txBody>
+          <a:bodyPr/>
+          <a:lstStyle/>
+          <a:p>
+            <a:endParaRPr lang="en-US"/>
+          </a:p>
+        </p:txBody>
       </p:sp>
       <p:sp>
         <p:nvSpPr>
@@ -3409,7 +3277,7 @@
           <a:bodyPr wrap="square" lIns="254" tIns="254" rIns="254" bIns="254" rtlCol="0" anchor="ctr"/>
           <a:lstStyle/>
           <a:p>
-            <a:pPr algn="ctr" indent="0" marL="0">
+            <a:pPr marL="0" indent="0" algn="ctr">
               <a:buNone/>
             </a:pPr>
             <a:r>
@@ -3426,7 +3294,7 @@
             <a:endParaRPr lang="en-US" sz="900" dirty="0"/>
           </a:p>
           <a:p>
-            <a:pPr algn="ctr" indent="0" marL="0">
+            <a:pPr marL="0" indent="0" algn="ctr">
               <a:buNone/>
             </a:pPr>
             <a:r>
@@ -3465,6 +3333,13 @@
           </a:solidFill>
           <a:ln/>
         </p:spPr>
+        <p:txBody>
+          <a:bodyPr/>
+          <a:lstStyle/>
+          <a:p>
+            <a:endParaRPr lang="en-US"/>
+          </a:p>
+        </p:txBody>
       </p:sp>
       <p:sp>
         <p:nvSpPr>
@@ -3487,7 +3362,7 @@
           <a:bodyPr wrap="square" lIns="254" tIns="254" rIns="254" bIns="254" rtlCol="0" anchor="ctr"/>
           <a:lstStyle/>
           <a:p>
-            <a:pPr algn="ctr" indent="0" marL="0">
+            <a:pPr marL="0" indent="0" algn="ctr">
               <a:buNone/>
             </a:pPr>
             <a:r>
@@ -3526,6 +3401,13 @@
           </a:solidFill>
           <a:ln/>
         </p:spPr>
+        <p:txBody>
+          <a:bodyPr/>
+          <a:lstStyle/>
+          <a:p>
+            <a:endParaRPr lang="en-US"/>
+          </a:p>
+        </p:txBody>
       </p:sp>
       <p:sp>
         <p:nvSpPr>
@@ -3548,7 +3430,7 @@
           <a:bodyPr wrap="square" lIns="254" tIns="254" rIns="254" bIns="254" rtlCol="0" anchor="ctr"/>
           <a:lstStyle/>
           <a:p>
-            <a:pPr algn="ctr" indent="0" marL="0">
+            <a:pPr marL="0" indent="0" algn="ctr">
               <a:buNone/>
             </a:pPr>
             <a:r>
@@ -3587,6 +3469,13 @@
           </a:solidFill>
           <a:ln/>
         </p:spPr>
+        <p:txBody>
+          <a:bodyPr/>
+          <a:lstStyle/>
+          <a:p>
+            <a:endParaRPr lang="en-US"/>
+          </a:p>
+        </p:txBody>
       </p:sp>
       <p:sp>
         <p:nvSpPr>
@@ -3609,7 +3498,7 @@
           <a:bodyPr wrap="square" lIns="254" tIns="254" rIns="254" bIns="254" rtlCol="0" anchor="ctr"/>
           <a:lstStyle/>
           <a:p>
-            <a:pPr algn="ctr" indent="0" marL="0">
+            <a:pPr marL="0" indent="0" algn="ctr">
               <a:buNone/>
             </a:pPr>
             <a:r>
@@ -3648,11 +3537,11 @@
           <a:bodyPr wrap="square" lIns="0" tIns="0" rIns="0" bIns="0" rtlCol="0" anchor="ctr"/>
           <a:lstStyle/>
           <a:p>
-            <a:pPr indent="0" marL="0">
-              <a:buNone/>
-            </a:pPr>
-            <a:r>
-              <a:rPr lang="en-US" sz="1800" b="1" spc="300" kern="0" dirty="0">
+            <a:pPr marL="0" indent="0">
+              <a:buNone/>
+            </a:pPr>
+            <a:r>
+              <a:rPr lang="en-US" sz="1800" b="1" kern="0" spc="300" dirty="0">
                 <a:solidFill>
                   <a:srgbClr val="5A6478"/>
                 </a:solidFill>
@@ -3687,7 +3576,7 @@
           <a:bodyPr wrap="square" lIns="0" tIns="0" rIns="0" bIns="0" rtlCol="0" anchor="ctr"/>
           <a:lstStyle/>
           <a:p>
-            <a:pPr indent="0" marL="0">
+            <a:pPr marL="0" indent="0">
               <a:buNone/>
             </a:pPr>
             <a:r>
@@ -3726,7 +3615,7 @@
           <a:bodyPr wrap="square" lIns="0" tIns="0" rIns="0" bIns="0" rtlCol="0" anchor="ctr"/>
           <a:lstStyle/>
           <a:p>
-            <a:pPr indent="0" marL="0">
+            <a:pPr marL="0" indent="0">
               <a:buNone/>
             </a:pPr>
             <a:r>
@@ -3765,7 +3654,7 @@
           <a:bodyPr wrap="square" lIns="0" tIns="0" rIns="0" bIns="0" rtlCol="0" anchor="ctr"/>
           <a:lstStyle/>
           <a:p>
-            <a:pPr indent="0" marL="0">
+            <a:pPr marL="0" indent="0">
               <a:buNone/>
             </a:pPr>
             <a:r>
@@ -3791,8 +3680,8 @@
         </p:nvSpPr>
         <p:spPr>
           <a:xfrm>
-            <a:off x="822960" y="6172200"/>
-            <a:ext cx="10515600" cy="365760"/>
+            <a:off x="822960" y="6053328"/>
+            <a:ext cx="10515600" cy="603504"/>
           </a:xfrm>
           <a:prstGeom prst="rect">
             <a:avLst/>
@@ -3804,7 +3693,7 @@
           <a:bodyPr wrap="square" lIns="0" tIns="0" rIns="0" bIns="0" rtlCol="0" anchor="ctr"/>
           <a:lstStyle/>
           <a:p>
-            <a:pPr indent="0" marL="0">
+            <a:pPr marL="0" indent="0">
               <a:buNone/>
             </a:pPr>
             <a:r>
@@ -3838,6 +3727,7 @@
         <a:solidFill>
           <a:srgbClr val="FFFFFF"/>
         </a:solidFill>
+        <a:effectLst/>
       </p:bgPr>
     </p:bg>
     <p:spTree>
@@ -3875,6 +3765,13 @@
           </a:solidFill>
           <a:ln/>
         </p:spPr>
+        <p:txBody>
+          <a:bodyPr/>
+          <a:lstStyle/>
+          <a:p>
+            <a:endParaRPr lang="en-US"/>
+          </a:p>
+        </p:txBody>
       </p:sp>
       <p:sp>
         <p:nvSpPr>
@@ -3897,7 +3794,7 @@
           <a:bodyPr wrap="square" lIns="254" tIns="254" rIns="254" bIns="254" rtlCol="0" anchor="ctr"/>
           <a:lstStyle/>
           <a:p>
-            <a:pPr algn="ctr" indent="0" marL="0">
+            <a:pPr marL="0" indent="0" algn="ctr">
               <a:buNone/>
             </a:pPr>
             <a:r>
@@ -3936,6 +3833,13 @@
           </a:solidFill>
           <a:ln/>
         </p:spPr>
+        <p:txBody>
+          <a:bodyPr/>
+          <a:lstStyle/>
+          <a:p>
+            <a:endParaRPr lang="en-US"/>
+          </a:p>
+        </p:txBody>
       </p:sp>
       <p:sp>
         <p:nvSpPr>
@@ -3958,7 +3862,7 @@
           <a:bodyPr wrap="square" lIns="254" tIns="254" rIns="254" bIns="254" rtlCol="0" anchor="ctr"/>
           <a:lstStyle/>
           <a:p>
-            <a:pPr algn="ctr" indent="0" marL="0">
+            <a:pPr marL="0" indent="0" algn="ctr">
               <a:buNone/>
             </a:pPr>
             <a:r>
@@ -3975,7 +3879,7 @@
             <a:endParaRPr lang="en-US" sz="900" dirty="0"/>
           </a:p>
           <a:p>
-            <a:pPr algn="ctr" indent="0" marL="0">
+            <a:pPr marL="0" indent="0" algn="ctr">
               <a:buNone/>
             </a:pPr>
             <a:r>
@@ -4014,6 +3918,13 @@
           </a:solidFill>
           <a:ln/>
         </p:spPr>
+        <p:txBody>
+          <a:bodyPr/>
+          <a:lstStyle/>
+          <a:p>
+            <a:endParaRPr lang="en-US"/>
+          </a:p>
+        </p:txBody>
       </p:sp>
       <p:sp>
         <p:nvSpPr>
@@ -4036,7 +3947,7 @@
           <a:bodyPr wrap="square" lIns="254" tIns="254" rIns="254" bIns="254" rtlCol="0" anchor="ctr"/>
           <a:lstStyle/>
           <a:p>
-            <a:pPr algn="ctr" indent="0" marL="0">
+            <a:pPr marL="0" indent="0" algn="ctr">
               <a:buNone/>
             </a:pPr>
             <a:r>
@@ -4075,6 +3986,13 @@
           </a:solidFill>
           <a:ln/>
         </p:spPr>
+        <p:txBody>
+          <a:bodyPr/>
+          <a:lstStyle/>
+          <a:p>
+            <a:endParaRPr lang="en-US"/>
+          </a:p>
+        </p:txBody>
       </p:sp>
       <p:sp>
         <p:nvSpPr>
@@ -4097,7 +4015,7 @@
           <a:bodyPr wrap="square" lIns="254" tIns="254" rIns="254" bIns="254" rtlCol="0" anchor="ctr"/>
           <a:lstStyle/>
           <a:p>
-            <a:pPr algn="ctr" indent="0" marL="0">
+            <a:pPr marL="0" indent="0" algn="ctr">
               <a:buNone/>
             </a:pPr>
             <a:r>
@@ -4136,6 +4054,13 @@
           </a:solidFill>
           <a:ln/>
         </p:spPr>
+        <p:txBody>
+          <a:bodyPr/>
+          <a:lstStyle/>
+          <a:p>
+            <a:endParaRPr lang="en-US"/>
+          </a:p>
+        </p:txBody>
       </p:sp>
       <p:sp>
         <p:nvSpPr>
@@ -4158,7 +4083,7 @@
           <a:bodyPr wrap="square" lIns="254" tIns="254" rIns="254" bIns="254" rtlCol="0" anchor="ctr"/>
           <a:lstStyle/>
           <a:p>
-            <a:pPr algn="ctr" indent="0" marL="0">
+            <a:pPr marL="0" indent="0" algn="ctr">
               <a:buNone/>
             </a:pPr>
             <a:r>
@@ -4197,11 +4122,11 @@
           <a:bodyPr wrap="square" lIns="0" tIns="0" rIns="0" bIns="0" rtlCol="0" anchor="ctr"/>
           <a:lstStyle/>
           <a:p>
-            <a:pPr indent="0" marL="0">
-              <a:buNone/>
-            </a:pPr>
-            <a:r>
-              <a:rPr lang="en-US" sz="1800" b="1" spc="300" kern="0" dirty="0">
+            <a:pPr marL="0" indent="0">
+              <a:buNone/>
+            </a:pPr>
+            <a:r>
+              <a:rPr lang="en-US" sz="1800" b="1" kern="0" spc="300" dirty="0">
                 <a:solidFill>
                   <a:srgbClr val="5A6478"/>
                 </a:solidFill>
@@ -4236,7 +4161,7 @@
           <a:bodyPr wrap="square" lIns="0" tIns="0" rIns="0" bIns="0" rtlCol="0" anchor="ctr"/>
           <a:lstStyle/>
           <a:p>
-            <a:pPr indent="0" marL="0">
+            <a:pPr marL="0" indent="0">
               <a:buNone/>
             </a:pPr>
             <a:r>
@@ -4275,7 +4200,7 @@
           <a:bodyPr wrap="square" lIns="0" tIns="0" rIns="0" bIns="0" rtlCol="0" anchor="ctr"/>
           <a:lstStyle/>
           <a:p>
-            <a:pPr indent="0" marL="0">
+            <a:pPr marL="0" indent="0">
               <a:buNone/>
             </a:pPr>
             <a:r>
@@ -4314,7 +4239,7 @@
           <a:bodyPr wrap="square" lIns="0" tIns="0" rIns="0" bIns="0" rtlCol="0" anchor="ctr"/>
           <a:lstStyle/>
           <a:p>
-            <a:pPr indent="0" marL="0">
+            <a:pPr marL="0" indent="0">
               <a:buNone/>
             </a:pPr>
             <a:r>
@@ -4340,8 +4265,8 @@
         </p:nvSpPr>
         <p:spPr>
           <a:xfrm>
-            <a:off x="822960" y="6172200"/>
-            <a:ext cx="10515600" cy="365760"/>
+            <a:off x="822960" y="6053328"/>
+            <a:ext cx="10515600" cy="603504"/>
           </a:xfrm>
           <a:prstGeom prst="rect">
             <a:avLst/>
@@ -4353,7 +4278,7 @@
           <a:bodyPr wrap="square" lIns="0" tIns="0" rIns="0" bIns="0" rtlCol="0" anchor="ctr"/>
           <a:lstStyle/>
           <a:p>
-            <a:pPr indent="0" marL="0">
+            <a:pPr marL="0" indent="0">
               <a:buNone/>
             </a:pPr>
             <a:r>
@@ -4387,6 +4312,7 @@
         <a:solidFill>
           <a:srgbClr val="FFFFFF"/>
         </a:solidFill>
+        <a:effectLst/>
       </p:bgPr>
     </p:bg>
     <p:spTree>
@@ -4424,7 +4350,7 @@
           <a:bodyPr wrap="square" lIns="0" tIns="0" rIns="0" bIns="0" rtlCol="0" anchor="ctr"/>
           <a:lstStyle/>
           <a:p>
-            <a:pPr indent="0" marL="0">
+            <a:pPr marL="0" indent="0">
               <a:buNone/>
             </a:pPr>
             <a:r>
@@ -4463,7 +4389,7 @@
           <a:bodyPr wrap="square" lIns="0" tIns="0" rIns="0" bIns="0" rtlCol="0" anchor="t"/>
           <a:lstStyle/>
           <a:p>
-            <a:pPr algn="l" indent="0" marL="0">
+            <a:pPr marL="0" indent="0" algn="l">
               <a:spcAft>
                 <a:spcPts val="400"/>
               </a:spcAft>
@@ -4483,7 +4409,7 @@
             <a:endParaRPr lang="en-US" sz="1400" dirty="0"/>
           </a:p>
           <a:p>
-            <a:pPr algn="l" marL="342900" indent="-342900">
+            <a:pPr marL="342900" indent="-342900" algn="l">
               <a:spcAft>
                 <a:spcPts val="300"/>
               </a:spcAft>
@@ -4501,12 +4427,6 @@
               </a:rPr>
               <a:t>Hatcliff &amp; Belt, </a:t>
             </a:r>
-            <a:pPr algn="l" indent="0" marL="0">
-              <a:spcAft>
-                <a:spcPts val="300"/>
-              </a:spcAft>
-              <a:buNone/>
-            </a:pPr>
             <a:r>
               <a:rPr lang="en-US" sz="1150" i="1" dirty="0">
                 <a:solidFill>
@@ -4518,12 +4438,6 @@
               </a:rPr>
               <a:t>The Isolette System: Illustrating End-to-End Artifacts for Rigorous Model-Based Engineering</a:t>
             </a:r>
-            <a:pPr algn="l" indent="0" marL="0">
-              <a:spcAft>
-                <a:spcPts val="300"/>
-              </a:spcAft>
-              <a:buNone/>
-            </a:pPr>
             <a:r>
               <a:rPr lang="en-US" sz="1150" dirty="0">
                 <a:solidFill>
@@ -4538,7 +4452,7 @@
             <a:endParaRPr lang="en-US" sz="1400" dirty="0"/>
           </a:p>
           <a:p>
-            <a:pPr algn="l" marL="342900" indent="-342900">
+            <a:pPr marL="342900" indent="-342900" algn="l">
               <a:spcAft>
                 <a:spcPts val="300"/>
               </a:spcAft>
@@ -4556,12 +4470,6 @@
               </a:rPr>
               <a:t>Hatcliff, Belt, Robby, McKenzie, Liang, </a:t>
             </a:r>
-            <a:pPr algn="l" indent="0" marL="0">
-              <a:spcAft>
-                <a:spcPts val="300"/>
-              </a:spcAft>
-              <a:buNone/>
-            </a:pPr>
             <a:r>
               <a:rPr lang="en-US" sz="1150" i="1" dirty="0">
                 <a:solidFill>
@@ -4573,12 +4481,6 @@
               </a:rPr>
               <a:t>End-to-End Formal Methods Integrated Development with SysMLv2 Using HAMR</a:t>
             </a:r>
-            <a:pPr algn="l" indent="0" marL="0">
-              <a:spcAft>
-                <a:spcPts val="300"/>
-              </a:spcAft>
-              <a:buNone/>
-            </a:pPr>
             <a:r>
               <a:rPr lang="en-US" sz="1150" dirty="0">
                 <a:solidFill>
@@ -4593,7 +4495,7 @@
             <a:endParaRPr lang="en-US" sz="1400" dirty="0"/>
           </a:p>
           <a:p>
-            <a:pPr algn="l" marL="342900" indent="-342900">
+            <a:pPr marL="342900" indent="-342900" algn="l">
               <a:spcAft>
                 <a:spcPts val="300"/>
               </a:spcAft>
@@ -4611,12 +4513,6 @@
               </a:rPr>
               <a:t>Hatcliff, Belt, Robby, Carpenter, </a:t>
             </a:r>
-            <a:pPr algn="l" indent="0" marL="0">
-              <a:spcAft>
-                <a:spcPts val="300"/>
-              </a:spcAft>
-              <a:buNone/>
-            </a:pPr>
             <a:r>
               <a:rPr lang="en-US" sz="1150" i="1" dirty="0">
                 <a:solidFill>
@@ -4628,12 +4524,6 @@
               </a:rPr>
               <a:t>HAMR: An AADL Multi-platform Code Generation Toolset</a:t>
             </a:r>
-            <a:pPr algn="l" indent="0" marL="0">
-              <a:spcAft>
-                <a:spcPts val="300"/>
-              </a:spcAft>
-              <a:buNone/>
-            </a:pPr>
             <a:r>
               <a:rPr lang="en-US" sz="1150" dirty="0">
                 <a:solidFill>
@@ -4648,7 +4538,7 @@
             <a:endParaRPr lang="en-US" sz="1400" dirty="0"/>
           </a:p>
           <a:p>
-            <a:pPr algn="l" marL="342900" indent="-342900">
+            <a:pPr marL="342900" indent="-342900" algn="l">
               <a:spcAft>
                 <a:spcPts val="300"/>
               </a:spcAft>
@@ -4666,12 +4556,6 @@
               </a:rPr>
               <a:t>Lempia &amp; Miller, </a:t>
             </a:r>
-            <a:pPr algn="l" indent="0" marL="0">
-              <a:spcAft>
-                <a:spcPts val="300"/>
-              </a:spcAft>
-              <a:buNone/>
-            </a:pPr>
             <a:r>
               <a:rPr lang="en-US" sz="1150" i="1" dirty="0">
                 <a:solidFill>
@@ -4683,12 +4567,6 @@
               </a:rPr>
               <a:t>Requirements Engineering Management Handbook</a:t>
             </a:r>
-            <a:pPr algn="l" indent="0" marL="0">
-              <a:spcAft>
-                <a:spcPts val="300"/>
-              </a:spcAft>
-              <a:buNone/>
-            </a:pPr>
             <a:r>
               <a:rPr lang="en-US" sz="1150" dirty="0">
                 <a:solidFill>
@@ -4703,7 +4581,7 @@
             <a:endParaRPr lang="en-US" sz="1400" dirty="0"/>
           </a:p>
           <a:p>
-            <a:pPr algn="l" marL="342900" indent="-342900">
+            <a:pPr marL="342900" indent="-342900" algn="l">
               <a:spcAft>
                 <a:spcPts val="300"/>
               </a:spcAft>
@@ -4724,7 +4602,7 @@
             <a:endParaRPr lang="en-US" sz="1400" dirty="0"/>
           </a:p>
           <a:p>
-            <a:pPr algn="l" indent="0" marL="0">
+            <a:pPr marL="0" indent="0" algn="l">
               <a:spcBef>
                 <a:spcPts val="1200"/>
               </a:spcBef>
@@ -4747,7 +4625,7 @@
             <a:endParaRPr lang="en-US" sz="1400" dirty="0"/>
           </a:p>
           <a:p>
-            <a:pPr algn="l" marL="342900" indent="-342900">
+            <a:pPr marL="342900" indent="-342900" algn="l">
               <a:spcAft>
                 <a:spcPts val="300"/>
               </a:spcAft>
@@ -4765,12 +4643,6 @@
               </a:rPr>
               <a:t>Ramsdell, Rowe, Alexander, Helble, Loscocco, Pendergrass, Petz, </a:t>
             </a:r>
-            <a:pPr algn="l" indent="0" marL="0">
-              <a:spcAft>
-                <a:spcPts val="300"/>
-              </a:spcAft>
-              <a:buNone/>
-            </a:pPr>
             <a:r>
               <a:rPr lang="en-US" sz="1150" i="1" dirty="0">
                 <a:solidFill>
@@ -4782,12 +4654,6 @@
               </a:rPr>
               <a:t>Orchestrating Layered Attestations</a:t>
             </a:r>
-            <a:pPr algn="l" indent="0" marL="0">
-              <a:spcAft>
-                <a:spcPts val="300"/>
-              </a:spcAft>
-              <a:buNone/>
-            </a:pPr>
             <a:r>
               <a:rPr lang="en-US" sz="1150" dirty="0">
                 <a:solidFill>
@@ -4802,7 +4668,7 @@
             <a:endParaRPr lang="en-US" sz="1400" dirty="0"/>
           </a:p>
           <a:p>
-            <a:pPr algn="l" indent="0" marL="0">
+            <a:pPr marL="0" indent="0" algn="l">
               <a:spcBef>
                 <a:spcPts val="1200"/>
               </a:spcBef>
@@ -4825,7 +4691,7 @@
             <a:endParaRPr lang="en-US" sz="1400" dirty="0"/>
           </a:p>
           <a:p>
-            <a:pPr algn="l" marL="342900" indent="-342900">
+            <a:pPr marL="342900" indent="-342900" algn="l">
               <a:spcAft>
                 <a:spcPts val="300"/>
               </a:spcAft>
@@ -4843,12 +4709,6 @@
               </a:rPr>
               <a:t>Lattuada, Hance, Cho, Brun, Subasinghe, Zhou, Howell, Parno, Hawblitzel, </a:t>
             </a:r>
-            <a:pPr algn="l" indent="0" marL="0">
-              <a:spcAft>
-                <a:spcPts val="300"/>
-              </a:spcAft>
-              <a:buNone/>
-            </a:pPr>
             <a:r>
               <a:rPr lang="en-US" sz="1150" i="1" dirty="0">
                 <a:solidFill>
@@ -4860,12 +4720,6 @@
               </a:rPr>
               <a:t>Verus: Verifying Rust Programs using Linear Ghost Types</a:t>
             </a:r>
-            <a:pPr algn="l" indent="0" marL="0">
-              <a:spcAft>
-                <a:spcPts val="300"/>
-              </a:spcAft>
-              <a:buNone/>
-            </a:pPr>
             <a:r>
               <a:rPr lang="en-US" sz="1150" dirty="0">
                 <a:solidFill>
@@ -4880,7 +4734,7 @@
             <a:endParaRPr lang="en-US" sz="1400" dirty="0"/>
           </a:p>
           <a:p>
-            <a:pPr algn="l" marL="342900" indent="-342900">
+            <a:pPr marL="342900" indent="-342900" algn="l">
               <a:spcAft>
                 <a:spcPts val="300"/>
               </a:spcAft>
@@ -4898,12 +4752,6 @@
               </a:rPr>
               <a:t>Klein et al., </a:t>
             </a:r>
-            <a:pPr algn="l" indent="0" marL="0">
-              <a:spcAft>
-                <a:spcPts val="300"/>
-              </a:spcAft>
-              <a:buNone/>
-            </a:pPr>
             <a:r>
               <a:rPr lang="en-US" sz="1150" i="1" dirty="0">
                 <a:solidFill>
@@ -4915,12 +4763,6 @@
               </a:rPr>
               <a:t>seL4: Formal Verification of an OS Kernel</a:t>
             </a:r>
-            <a:pPr algn="l" indent="0" marL="0">
-              <a:spcAft>
-                <a:spcPts val="300"/>
-              </a:spcAft>
-              <a:buNone/>
-            </a:pPr>
             <a:r>
               <a:rPr lang="en-US" sz="1150" dirty="0">
                 <a:solidFill>
@@ -4952,6 +4794,7 @@
         <a:solidFill>
           <a:srgbClr val="FFFFFF"/>
         </a:solidFill>
+        <a:effectLst/>
       </p:bgPr>
     </p:bg>
     <p:spTree>
@@ -4989,7 +4832,7 @@
           <a:bodyPr wrap="square" lIns="0" tIns="0" rIns="0" bIns="0" rtlCol="0" anchor="ctr"/>
           <a:lstStyle/>
           <a:p>
-            <a:pPr indent="0" marL="0">
+            <a:pPr marL="0" indent="0">
               <a:buNone/>
             </a:pPr>
             <a:r>
@@ -5028,7 +4871,7 @@
           <a:bodyPr wrap="square" lIns="0" tIns="0" rIns="0" bIns="0" rtlCol="0" anchor="t"/>
           <a:lstStyle/>
           <a:p>
-            <a:pPr algn="l" marL="342900" indent="-342900">
+            <a:pPr marL="342900" indent="-342900" algn="l">
               <a:buSzPct val="100000"/>
               <a:buChar char="•"/>
             </a:pPr>
@@ -5041,13 +4884,10 @@
                 <a:ea typeface="Calibri" pitchFamily="34" charset="-122"/>
                 <a:cs typeface="Calibri" pitchFamily="34" charset="-120"/>
               </a:rPr>
-              <a:t>Traditional remote attestation: </a:t>
-            </a:r>
-            <a:pPr algn="l" indent="0" marL="0">
-              <a:buNone/>
-            </a:pPr>
-            <a:r>
-              <a:rPr lang="en-US" sz="1700" b="1" dirty="0">
+              <a:t>Traditional remote attestation: did system components boot into a predictable state?</a:t>
+            </a:r>
+            <a:r>
+              <a:rPr lang="en-US" sz="1700" dirty="0">
                 <a:solidFill>
                   <a:srgbClr val="212121"/>
                 </a:solidFill>
@@ -5055,29 +4895,12 @@
                 <a:ea typeface="Calibri" pitchFamily="34" charset="-122"/>
                 <a:cs typeface="Calibri" pitchFamily="34" charset="-120"/>
               </a:rPr>
-              <a:t>did system components boot into a predictable state?</a:t>
-            </a:r>
-            <a:pPr algn="l" indent="0" marL="0">
-              <a:spcAft>
-                <a:spcPts val="1000"/>
-              </a:spcAft>
-              <a:buNone/>
-            </a:pPr>
-            <a:r>
-              <a:rPr lang="en-US" sz="1700" dirty="0">
-                <a:solidFill>
-                  <a:srgbClr val="212121"/>
-                </a:solidFill>
-                <a:latin typeface="Calibri" pitchFamily="34" charset="0"/>
-                <a:ea typeface="Calibri" pitchFamily="34" charset="-122"/>
-                <a:cs typeface="Calibri" pitchFamily="34" charset="-120"/>
-              </a:rPr>
               <a:t> (boot-time, static runtime)</a:t>
             </a:r>
             <a:endParaRPr lang="en-US" sz="1700" dirty="0"/>
           </a:p>
           <a:p>
-            <a:pPr algn="l" marL="342900" indent="-342900">
+            <a:pPr marL="342900" indent="-342900" algn="l">
               <a:buSzPct val="100000"/>
               <a:buChar char="•"/>
             </a:pPr>
@@ -5092,9 +4915,6 @@
               </a:rPr>
               <a:t>Layered, runtime attestation: </a:t>
             </a:r>
-            <a:pPr algn="l" indent="0" marL="0">
-              <a:buNone/>
-            </a:pPr>
             <a:r>
               <a:rPr lang="en-US" sz="1700" dirty="0">
                 <a:solidFill>
@@ -5106,12 +4926,6 @@
               </a:rPr>
               <a:t>extend boot-time trust via dynamic measurement of system components </a:t>
             </a:r>
-            <a:pPr algn="l" indent="0" marL="0">
-              <a:spcAft>
-                <a:spcPts val="1000"/>
-              </a:spcAft>
-              <a:buNone/>
-            </a:pPr>
             <a:r>
               <a:rPr lang="en-US" sz="1700" b="1" dirty="0">
                 <a:solidFill>
@@ -5126,7 +4940,7 @@
             <a:endParaRPr lang="en-US" sz="1700" dirty="0"/>
           </a:p>
           <a:p>
-            <a:pPr algn="l" marL="342900" indent="-342900">
+            <a:pPr marL="342900" indent="-342900" algn="l">
               <a:buSzPct val="100000"/>
               <a:buChar char="•"/>
             </a:pPr>
@@ -5141,9 +4955,6 @@
               </a:rPr>
               <a:t>Lifecycle attestation: </a:t>
             </a:r>
-            <a:pPr algn="l" indent="0" marL="0">
-              <a:buNone/>
-            </a:pPr>
             <a:r>
               <a:rPr lang="en-US" sz="1700" dirty="0">
                 <a:solidFill>
@@ -5155,9 +4966,6 @@
               </a:rPr>
               <a:t>extends this notion to </a:t>
             </a:r>
-            <a:pPr algn="l" indent="0" marL="0">
-              <a:buNone/>
-            </a:pPr>
             <a:r>
               <a:rPr lang="en-US" sz="1700" b="1" dirty="0">
                 <a:solidFill>
@@ -5169,12 +4977,6 @@
               </a:rPr>
               <a:t>artifacts of the development lifecycle</a:t>
             </a:r>
-            <a:pPr algn="l" indent="0" marL="0">
-              <a:spcAft>
-                <a:spcPts val="1000"/>
-              </a:spcAft>
-              <a:buNone/>
-            </a:pPr>
             <a:r>
               <a:rPr lang="en-US" sz="1700" dirty="0">
                 <a:solidFill>
@@ -5189,7 +4991,7 @@
             <a:endParaRPr lang="en-US" sz="1700" dirty="0"/>
           </a:p>
           <a:p>
-            <a:pPr algn="l" lvl="1" marL="685800" indent="-342900">
+            <a:pPr marL="685800" lvl="1" indent="-342900" algn="l">
               <a:spcAft>
                 <a:spcPts val="1000"/>
               </a:spcAft>
@@ -5210,7 +5012,7 @@
             <a:endParaRPr lang="en-US" sz="1700" dirty="0"/>
           </a:p>
           <a:p>
-            <a:pPr algn="l" lvl="1" marL="685800" indent="-342900">
+            <a:pPr marL="685800" lvl="1" indent="-342900" algn="l">
               <a:buSzPct val="100000"/>
               <a:buChar char="–"/>
             </a:pPr>
@@ -5225,9 +5027,6 @@
               </a:rPr>
               <a:t>…and to lifecycle </a:t>
             </a:r>
-            <a:pPr algn="l" indent="0" marL="0">
-              <a:buNone/>
-            </a:pPr>
             <a:r>
               <a:rPr lang="en-US" sz="1700" b="1" dirty="0">
                 <a:solidFill>
@@ -5239,12 +5038,6 @@
               </a:rPr>
               <a:t>events</a:t>
             </a:r>
-            <a:pPr algn="l" indent="0" marL="0">
-              <a:spcAft>
-                <a:spcPts val="1000"/>
-              </a:spcAft>
-              <a:buNone/>
-            </a:pPr>
             <a:r>
               <a:rPr lang="en-US" sz="1700" dirty="0">
                 <a:solidFill>
@@ -5259,7 +5052,7 @@
             <a:endParaRPr lang="en-US" sz="1700" dirty="0"/>
           </a:p>
           <a:p>
-            <a:pPr algn="l" lvl="2" marL="1028700" indent="-342900">
+            <a:pPr marL="1028700" lvl="2" indent="-342900" algn="l">
               <a:spcAft>
                 <a:spcPts val="200"/>
               </a:spcAft>
@@ -5280,7 +5073,7 @@
             <a:endParaRPr lang="en-US" sz="1700" dirty="0"/>
           </a:p>
           <a:p>
-            <a:pPr algn="l" lvl="2" marL="1028700" indent="-342900">
+            <a:pPr marL="1028700" lvl="2" indent="-342900" algn="l">
               <a:spcAft>
                 <a:spcPts val="200"/>
               </a:spcAft>
@@ -5301,7 +5094,7 @@
             <a:endParaRPr lang="en-US" sz="1700" dirty="0"/>
           </a:p>
           <a:p>
-            <a:pPr algn="l" lvl="2" marL="1028700" indent="-342900">
+            <a:pPr marL="1028700" lvl="2" indent="-342900" algn="l">
               <a:spcAft>
                 <a:spcPts val="200"/>
               </a:spcAft>
@@ -5322,7 +5115,7 @@
             <a:endParaRPr lang="en-US" sz="1700" dirty="0"/>
           </a:p>
           <a:p>
-            <a:pPr algn="l" lvl="2" marL="1028700" indent="-342900">
+            <a:pPr marL="1028700" lvl="2" indent="-342900" algn="l">
               <a:spcAft>
                 <a:spcPts val="200"/>
               </a:spcAft>
@@ -5343,7 +5136,7 @@
             <a:endParaRPr lang="en-US" sz="1700" dirty="0"/>
           </a:p>
           <a:p>
-            <a:pPr algn="l" marL="342900" indent="-342900">
+            <a:pPr marL="342900" indent="-342900" algn="l">
               <a:buSzPct val="100000"/>
               <a:buChar char="•"/>
             </a:pPr>
@@ -5358,9 +5151,6 @@
               </a:rPr>
               <a:t>Motivation: </a:t>
             </a:r>
-            <a:pPr algn="l" indent="0" marL="0">
-              <a:buNone/>
-            </a:pPr>
             <a:r>
               <a:rPr lang="en-US" sz="1700" dirty="0">
                 <a:solidFill>
@@ -5372,9 +5162,6 @@
               </a:rPr>
               <a:t>the </a:t>
             </a:r>
-            <a:pPr algn="l" indent="0" marL="0">
-              <a:buNone/>
-            </a:pPr>
             <a:r>
               <a:rPr lang="en-US" sz="1700" b="1" dirty="0">
                 <a:solidFill>
@@ -5386,12 +5173,6 @@
               </a:rPr>
               <a:t>proliferation of AI-generated software artifacts</a:t>
             </a:r>
-            <a:pPr algn="l" indent="0" marL="0">
-              <a:spcAft>
-                <a:spcPts val="1000"/>
-              </a:spcAft>
-              <a:buNone/>
-            </a:pPr>
             <a:r>
               <a:rPr lang="en-US" sz="1700" dirty="0">
                 <a:solidFill>
@@ -5428,6 +5209,13 @@
           </a:solidFill>
           <a:ln/>
         </p:spPr>
+        <p:txBody>
+          <a:bodyPr/>
+          <a:lstStyle/>
+          <a:p>
+            <a:endParaRPr lang="en-US"/>
+          </a:p>
+        </p:txBody>
       </p:sp>
       <p:sp>
         <p:nvSpPr>
@@ -5450,7 +5238,7 @@
           <a:bodyPr wrap="square" lIns="0" tIns="0" rIns="0" bIns="0" rtlCol="0" anchor="ctr"/>
           <a:lstStyle/>
           <a:p>
-            <a:pPr algn="ctr" indent="0" marL="0">
+            <a:pPr marL="0" indent="0" algn="ctr">
               <a:spcAft>
                 <a:spcPts val="400"/>
               </a:spcAft>
@@ -5470,7 +5258,7 @@
             <a:endParaRPr lang="en-US" sz="2000" dirty="0"/>
           </a:p>
           <a:p>
-            <a:pPr algn="ctr" indent="0" marL="0">
+            <a:pPr marL="0" indent="0" algn="ctr">
               <a:buNone/>
             </a:pPr>
             <a:r>
@@ -5504,6 +5292,7 @@
         <a:solidFill>
           <a:srgbClr val="FFFFFF"/>
         </a:solidFill>
+        <a:effectLst/>
       </p:bgPr>
     </p:bg>
     <p:spTree>
@@ -5541,7 +5330,7 @@
           <a:bodyPr wrap="square" lIns="0" tIns="0" rIns="0" bIns="0" rtlCol="0" anchor="ctr"/>
           <a:lstStyle/>
           <a:p>
-            <a:pPr indent="0" marL="0">
+            <a:pPr marL="0" indent="0">
               <a:buNone/>
             </a:pPr>
             <a:r>
@@ -5580,6 +5369,13 @@
           </a:solidFill>
           <a:ln/>
         </p:spPr>
+        <p:txBody>
+          <a:bodyPr/>
+          <a:lstStyle/>
+          <a:p>
+            <a:endParaRPr lang="en-US"/>
+          </a:p>
+        </p:txBody>
       </p:sp>
       <p:sp>
         <p:nvSpPr>
@@ -5602,7 +5398,7 @@
           <a:bodyPr wrap="square" lIns="254" tIns="254" rIns="254" bIns="254" rtlCol="0" anchor="ctr"/>
           <a:lstStyle/>
           <a:p>
-            <a:pPr algn="ctr" indent="0" marL="0">
+            <a:pPr marL="0" indent="0" algn="ctr">
               <a:buNone/>
             </a:pPr>
             <a:r>
@@ -5641,7 +5437,7 @@
           <a:bodyPr wrap="square" lIns="0" tIns="0" rIns="0" bIns="0" rtlCol="0" anchor="ctr"/>
           <a:lstStyle/>
           <a:p>
-            <a:pPr algn="ctr" indent="0" marL="0">
+            <a:pPr marL="0" indent="0" algn="ctr">
               <a:buNone/>
             </a:pPr>
             <a:r>
@@ -5680,6 +5476,13 @@
           </a:solidFill>
           <a:ln/>
         </p:spPr>
+        <p:txBody>
+          <a:bodyPr/>
+          <a:lstStyle/>
+          <a:p>
+            <a:endParaRPr lang="en-US"/>
+          </a:p>
+        </p:txBody>
       </p:sp>
       <p:sp>
         <p:nvSpPr>
@@ -5702,7 +5505,7 @@
           <a:bodyPr wrap="square" lIns="254" tIns="254" rIns="254" bIns="254" rtlCol="0" anchor="ctr"/>
           <a:lstStyle/>
           <a:p>
-            <a:pPr algn="ctr" indent="0" marL="0">
+            <a:pPr marL="0" indent="0" algn="ctr">
               <a:buNone/>
             </a:pPr>
             <a:r>
@@ -5719,7 +5522,7 @@
             <a:endParaRPr lang="en-US" sz="1350" dirty="0"/>
           </a:p>
           <a:p>
-            <a:pPr algn="ctr" indent="0" marL="0">
+            <a:pPr marL="0" indent="0" algn="ctr">
               <a:buNone/>
             </a:pPr>
             <a:r>
@@ -5758,7 +5561,7 @@
           <a:bodyPr wrap="square" lIns="0" tIns="0" rIns="0" bIns="0" rtlCol="0" anchor="ctr"/>
           <a:lstStyle/>
           <a:p>
-            <a:pPr algn="ctr" indent="0" marL="0">
+            <a:pPr marL="0" indent="0" algn="ctr">
               <a:buNone/>
             </a:pPr>
             <a:r>
@@ -5797,6 +5600,13 @@
           </a:solidFill>
           <a:ln/>
         </p:spPr>
+        <p:txBody>
+          <a:bodyPr/>
+          <a:lstStyle/>
+          <a:p>
+            <a:endParaRPr lang="en-US"/>
+          </a:p>
+        </p:txBody>
       </p:sp>
       <p:sp>
         <p:nvSpPr>
@@ -5819,7 +5629,7 @@
           <a:bodyPr wrap="square" lIns="254" tIns="254" rIns="254" bIns="254" rtlCol="0" anchor="ctr"/>
           <a:lstStyle/>
           <a:p>
-            <a:pPr algn="ctr" indent="0" marL="0">
+            <a:pPr marL="0" indent="0" algn="ctr">
               <a:buNone/>
             </a:pPr>
             <a:r>
@@ -5858,7 +5668,7 @@
           <a:bodyPr wrap="square" lIns="0" tIns="0" rIns="0" bIns="0" rtlCol="0" anchor="ctr"/>
           <a:lstStyle/>
           <a:p>
-            <a:pPr algn="ctr" indent="0" marL="0">
+            <a:pPr marL="0" indent="0" algn="ctr">
               <a:buNone/>
             </a:pPr>
             <a:r>
@@ -5897,6 +5707,13 @@
           </a:solidFill>
           <a:ln/>
         </p:spPr>
+        <p:txBody>
+          <a:bodyPr/>
+          <a:lstStyle/>
+          <a:p>
+            <a:endParaRPr lang="en-US"/>
+          </a:p>
+        </p:txBody>
       </p:sp>
       <p:sp>
         <p:nvSpPr>
@@ -5919,7 +5736,7 @@
           <a:bodyPr wrap="square" lIns="254" tIns="254" rIns="254" bIns="254" rtlCol="0" anchor="ctr"/>
           <a:lstStyle/>
           <a:p>
-            <a:pPr algn="ctr" indent="0" marL="0">
+            <a:pPr marL="0" indent="0" algn="ctr">
               <a:buNone/>
             </a:pPr>
             <a:r>
@@ -5958,7 +5775,7 @@
           <a:bodyPr wrap="square" lIns="0" tIns="0" rIns="0" bIns="0" rtlCol="0" anchor="ctr"/>
           <a:lstStyle/>
           <a:p>
-            <a:pPr algn="ctr" indent="0" marL="0">
+            <a:pPr marL="0" indent="0" algn="ctr">
               <a:buNone/>
             </a:pPr>
             <a:r>
@@ -5997,6 +5814,13 @@
           </a:solidFill>
           <a:ln/>
         </p:spPr>
+        <p:txBody>
+          <a:bodyPr/>
+          <a:lstStyle/>
+          <a:p>
+            <a:endParaRPr lang="en-US"/>
+          </a:p>
+        </p:txBody>
       </p:sp>
       <p:sp>
         <p:nvSpPr>
@@ -6019,7 +5843,7 @@
           <a:bodyPr wrap="square" lIns="254" tIns="254" rIns="254" bIns="254" rtlCol="0" anchor="ctr"/>
           <a:lstStyle/>
           <a:p>
-            <a:pPr algn="ctr" indent="0" marL="0">
+            <a:pPr marL="0" indent="0" algn="ctr">
               <a:buNone/>
             </a:pPr>
             <a:r>
@@ -6058,7 +5882,7 @@
           <a:bodyPr wrap="square" lIns="0" tIns="0" rIns="0" bIns="0" rtlCol="0" anchor="ctr"/>
           <a:lstStyle/>
           <a:p>
-            <a:pPr indent="0" marL="0">
+            <a:pPr marL="0" indent="0">
               <a:buNone/>
             </a:pPr>
             <a:r>
@@ -6092,6 +5916,7 @@
         <a:solidFill>
           <a:srgbClr val="FFFFFF"/>
         </a:solidFill>
+        <a:effectLst/>
       </p:bgPr>
     </p:bg>
     <p:spTree>
@@ -6129,7 +5954,7 @@
           <a:bodyPr wrap="square" lIns="0" tIns="0" rIns="0" bIns="0" rtlCol="0" anchor="ctr"/>
           <a:lstStyle/>
           <a:p>
-            <a:pPr indent="0" marL="0">
+            <a:pPr marL="0" indent="0">
               <a:buNone/>
             </a:pPr>
             <a:r>
@@ -6168,6 +5993,13 @@
           </a:solidFill>
           <a:ln/>
         </p:spPr>
+        <p:txBody>
+          <a:bodyPr/>
+          <a:lstStyle/>
+          <a:p>
+            <a:endParaRPr lang="en-US"/>
+          </a:p>
+        </p:txBody>
       </p:sp>
       <p:sp>
         <p:nvSpPr>
@@ -6190,7 +6022,7 @@
           <a:bodyPr wrap="square" lIns="0" tIns="0" rIns="0" bIns="0" rtlCol="0" anchor="ctr"/>
           <a:lstStyle/>
           <a:p>
-            <a:pPr algn="l" indent="0" marL="0">
+            <a:pPr marL="0" indent="0" algn="l">
               <a:spcAft>
                 <a:spcPts val="200"/>
               </a:spcAft>
@@ -6210,7 +6042,7 @@
             <a:endParaRPr lang="en-US" sz="1700" dirty="0"/>
           </a:p>
           <a:p>
-            <a:pPr algn="l" indent="0" marL="0">
+            <a:pPr marL="0" indent="0" algn="l">
               <a:buNone/>
             </a:pPr>
             <a:r>
@@ -6249,7 +6081,7 @@
           <a:bodyPr wrap="square" lIns="0" tIns="0" rIns="0" bIns="0" rtlCol="0" anchor="ctr"/>
           <a:lstStyle/>
           <a:p>
-            <a:pPr algn="ctr" indent="0" marL="0">
+            <a:pPr marL="0" indent="0" algn="ctr">
               <a:buNone/>
             </a:pPr>
             <a:r>
@@ -6285,6 +6117,13 @@
           </a:solidFill>
           <a:ln/>
         </p:spPr>
+        <p:txBody>
+          <a:bodyPr/>
+          <a:lstStyle/>
+          <a:p>
+            <a:endParaRPr lang="en-US"/>
+          </a:p>
+        </p:txBody>
       </p:sp>
       <p:sp>
         <p:nvSpPr>
@@ -6307,7 +6146,7 @@
           <a:bodyPr wrap="square" lIns="0" tIns="0" rIns="0" bIns="0" rtlCol="0" anchor="ctr"/>
           <a:lstStyle/>
           <a:p>
-            <a:pPr algn="l" indent="0" marL="0">
+            <a:pPr marL="0" indent="0" algn="l">
               <a:spcAft>
                 <a:spcPts val="200"/>
               </a:spcAft>
@@ -6327,7 +6166,7 @@
             <a:endParaRPr lang="en-US" sz="1700" dirty="0"/>
           </a:p>
           <a:p>
-            <a:pPr algn="l" indent="0" marL="0">
+            <a:pPr marL="0" indent="0" algn="l">
               <a:buNone/>
             </a:pPr>
             <a:r>
@@ -6366,7 +6205,7 @@
           <a:bodyPr wrap="square" lIns="0" tIns="0" rIns="0" bIns="0" rtlCol="0" anchor="ctr"/>
           <a:lstStyle/>
           <a:p>
-            <a:pPr algn="ctr" indent="0" marL="0">
+            <a:pPr marL="0" indent="0" algn="ctr">
               <a:buNone/>
             </a:pPr>
             <a:r>
@@ -6402,6 +6241,13 @@
           </a:solidFill>
           <a:ln/>
         </p:spPr>
+        <p:txBody>
+          <a:bodyPr/>
+          <a:lstStyle/>
+          <a:p>
+            <a:endParaRPr lang="en-US"/>
+          </a:p>
+        </p:txBody>
       </p:sp>
       <p:sp>
         <p:nvSpPr>
@@ -6424,7 +6270,7 @@
           <a:bodyPr wrap="square" lIns="0" tIns="0" rIns="0" bIns="0" rtlCol="0" anchor="ctr"/>
           <a:lstStyle/>
           <a:p>
-            <a:pPr algn="l" indent="0" marL="0">
+            <a:pPr marL="0" indent="0" algn="l">
               <a:spcAft>
                 <a:spcPts val="200"/>
               </a:spcAft>
@@ -6444,7 +6290,7 @@
             <a:endParaRPr lang="en-US" sz="1700" dirty="0"/>
           </a:p>
           <a:p>
-            <a:pPr algn="l" indent="0" marL="0">
+            <a:pPr marL="0" indent="0" algn="l">
               <a:buNone/>
             </a:pPr>
             <a:r>
@@ -6483,7 +6329,7 @@
           <a:bodyPr wrap="square" lIns="0" tIns="0" rIns="0" bIns="0" rtlCol="0" anchor="ctr"/>
           <a:lstStyle/>
           <a:p>
-            <a:pPr algn="ctr" indent="0" marL="0">
+            <a:pPr marL="0" indent="0" algn="ctr">
               <a:buNone/>
             </a:pPr>
             <a:r>
@@ -6519,6 +6365,13 @@
           </a:solidFill>
           <a:ln/>
         </p:spPr>
+        <p:txBody>
+          <a:bodyPr/>
+          <a:lstStyle/>
+          <a:p>
+            <a:endParaRPr lang="en-US"/>
+          </a:p>
+        </p:txBody>
       </p:sp>
       <p:sp>
         <p:nvSpPr>
@@ -6541,7 +6394,7 @@
           <a:bodyPr wrap="square" lIns="0" tIns="0" rIns="0" bIns="0" rtlCol="0" anchor="ctr"/>
           <a:lstStyle/>
           <a:p>
-            <a:pPr algn="l" indent="0" marL="0">
+            <a:pPr marL="0" indent="0" algn="l">
               <a:buNone/>
             </a:pPr>
             <a:r>
@@ -6555,9 +6408,6 @@
               </a:rPr>
               <a:t>signed evidence bundles</a:t>
             </a:r>
-            <a:pPr algn="l" indent="0" marL="0">
-              <a:buNone/>
-            </a:pPr>
             <a:r>
               <a:rPr lang="en-US" sz="1500" dirty="0">
                 <a:solidFill>
@@ -6569,9 +6419,6 @@
               </a:rPr>
               <a:t>, appraised against </a:t>
             </a:r>
-            <a:pPr algn="l" indent="0" marL="0">
-              <a:buNone/>
-            </a:pPr>
             <a:r>
               <a:rPr lang="en-US" sz="1500" b="1" dirty="0">
                 <a:solidFill>
@@ -6608,7 +6455,7 @@
           <a:bodyPr wrap="square" lIns="0" tIns="0" rIns="0" bIns="0" rtlCol="0" anchor="ctr"/>
           <a:lstStyle/>
           <a:p>
-            <a:pPr indent="0" marL="0">
+            <a:pPr marL="0" indent="0">
               <a:buNone/>
             </a:pPr>
             <a:r>
@@ -6652,6 +6499,13 @@
             <a:prstDash val="solid"/>
           </a:ln>
         </p:spPr>
+        <p:txBody>
+          <a:bodyPr/>
+          <a:lstStyle/>
+          <a:p>
+            <a:endParaRPr lang="en-US"/>
+          </a:p>
+        </p:txBody>
       </p:sp>
       <p:sp>
         <p:nvSpPr>
@@ -6674,7 +6528,7 @@
           <a:bodyPr wrap="square" lIns="0" tIns="0" rIns="0" bIns="0" rtlCol="0" anchor="ctr"/>
           <a:lstStyle/>
           <a:p>
-            <a:pPr algn="l" indent="0" marL="0">
+            <a:pPr marL="0" indent="0" algn="l">
               <a:buNone/>
             </a:pPr>
             <a:r>
@@ -6691,7 +6545,7 @@
             <a:endParaRPr lang="en-US" sz="1300" dirty="0"/>
           </a:p>
           <a:p>
-            <a:pPr algn="l" indent="0" marL="0">
+            <a:pPr marL="0" indent="0" algn="l">
               <a:buNone/>
             </a:pPr>
             <a:r>
@@ -6708,7 +6562,7 @@
             <a:endParaRPr lang="en-US" sz="1300" dirty="0"/>
           </a:p>
           <a:p>
-            <a:pPr algn="l" indent="0" marL="0">
+            <a:pPr marL="0" indent="0" algn="l">
               <a:buNone/>
             </a:pPr>
             <a:r>
@@ -6725,7 +6579,7 @@
             <a:endParaRPr lang="en-US" sz="1300" dirty="0"/>
           </a:p>
           <a:p>
-            <a:pPr algn="l" indent="0" marL="0">
+            <a:pPr marL="0" indent="0" algn="l">
               <a:buNone/>
             </a:pPr>
             <a:r>
@@ -6742,7 +6596,7 @@
             <a:endParaRPr lang="en-US" sz="1300" dirty="0"/>
           </a:p>
           <a:p>
-            <a:pPr algn="l" indent="0" marL="0">
+            <a:pPr marL="0" indent="0" algn="l">
               <a:buNone/>
             </a:pPr>
             <a:r>
@@ -6759,7 +6613,7 @@
             <a:endParaRPr lang="en-US" sz="1300" dirty="0"/>
           </a:p>
           <a:p>
-            <a:pPr algn="l" indent="0" marL="0">
+            <a:pPr marL="0" indent="0" algn="l">
               <a:buNone/>
             </a:pPr>
             <a:r>
@@ -6798,7 +6652,7 @@
           <a:bodyPr wrap="square" lIns="0" tIns="0" rIns="0" bIns="0" rtlCol="0" anchor="ctr"/>
           <a:lstStyle/>
           <a:p>
-            <a:pPr indent="0" marL="0">
+            <a:pPr marL="0" indent="0">
               <a:buNone/>
             </a:pPr>
             <a:r>
@@ -6815,7 +6669,7 @@
             <a:endParaRPr lang="en-US" sz="2000" dirty="0"/>
           </a:p>
           <a:p>
-            <a:pPr indent="0" marL="0">
+            <a:pPr marL="0" indent="0">
               <a:buNone/>
             </a:pPr>
             <a:r>
@@ -6832,7 +6686,7 @@
             <a:endParaRPr lang="en-US" sz="2000" dirty="0"/>
           </a:p>
           <a:p>
-            <a:pPr indent="0" marL="0">
+            <a:pPr marL="0" indent="0">
               <a:buNone/>
             </a:pPr>
             <a:r>
@@ -6866,6 +6720,7 @@
         <a:solidFill>
           <a:srgbClr val="FFFFFF"/>
         </a:solidFill>
+        <a:effectLst/>
       </p:bgPr>
     </p:bg>
     <p:spTree>
@@ -6903,7 +6758,7 @@
           <a:bodyPr wrap="square" lIns="0" tIns="0" rIns="0" bIns="0" rtlCol="0" anchor="ctr"/>
           <a:lstStyle/>
           <a:p>
-            <a:pPr indent="0" marL="0">
+            <a:pPr marL="0" indent="0">
               <a:buNone/>
             </a:pPr>
             <a:r>
@@ -6947,6 +6802,13 @@
             <a:prstDash val="dash"/>
           </a:ln>
         </p:spPr>
+        <p:txBody>
+          <a:bodyPr/>
+          <a:lstStyle/>
+          <a:p>
+            <a:endParaRPr lang="en-US"/>
+          </a:p>
+        </p:txBody>
       </p:sp>
       <p:sp>
         <p:nvSpPr>
@@ -6969,7 +6831,7 @@
           <a:bodyPr wrap="square" lIns="254" tIns="254" rIns="254" bIns="254" rtlCol="0" anchor="ctr"/>
           <a:lstStyle/>
           <a:p>
-            <a:pPr algn="ctr" indent="0" marL="0">
+            <a:pPr marL="0" indent="0" algn="ctr">
               <a:buNone/>
             </a:pPr>
             <a:r>
@@ -6986,7 +6848,7 @@
             <a:endParaRPr lang="en-US" sz="1150" dirty="0"/>
           </a:p>
           <a:p>
-            <a:pPr algn="ctr" indent="0" marL="0">
+            <a:pPr marL="0" indent="0" algn="ctr">
               <a:buNone/>
             </a:pPr>
             <a:r>
@@ -7027,6 +6889,13 @@
             <a:tailEnd type="triangle"/>
           </a:ln>
         </p:spPr>
+        <p:txBody>
+          <a:bodyPr/>
+          <a:lstStyle/>
+          <a:p>
+            <a:endParaRPr lang="en-US"/>
+          </a:p>
+        </p:txBody>
       </p:sp>
       <p:sp>
         <p:nvSpPr>
@@ -7049,7 +6918,7 @@
           <a:bodyPr wrap="square" lIns="0" tIns="0" rIns="0" bIns="0" rtlCol="0" anchor="ctr"/>
           <a:lstStyle/>
           <a:p>
-            <a:pPr algn="l" indent="0" marL="0">
+            <a:pPr marL="0" indent="0" algn="l">
               <a:buNone/>
             </a:pPr>
             <a:r>
@@ -7088,6 +6957,13 @@
           </a:solidFill>
           <a:ln/>
         </p:spPr>
+        <p:txBody>
+          <a:bodyPr/>
+          <a:lstStyle/>
+          <a:p>
+            <a:endParaRPr lang="en-US"/>
+          </a:p>
+        </p:txBody>
       </p:sp>
       <p:sp>
         <p:nvSpPr>
@@ -7110,7 +6986,7 @@
           <a:bodyPr wrap="square" lIns="381" tIns="381" rIns="381" bIns="381" rtlCol="0" anchor="ctr"/>
           <a:lstStyle/>
           <a:p>
-            <a:pPr algn="ctr" indent="0" marL="0">
+            <a:pPr marL="0" indent="0" algn="ctr">
               <a:buNone/>
             </a:pPr>
             <a:r>
@@ -7151,6 +7027,13 @@
             <a:tailEnd type="triangle"/>
           </a:ln>
         </p:spPr>
+        <p:txBody>
+          <a:bodyPr/>
+          <a:lstStyle/>
+          <a:p>
+            <a:endParaRPr lang="en-US"/>
+          </a:p>
+        </p:txBody>
       </p:sp>
       <p:sp>
         <p:nvSpPr>
@@ -7173,7 +7056,7 @@
           <a:bodyPr wrap="square" lIns="0" tIns="0" rIns="0" bIns="0" rtlCol="0" anchor="ctr"/>
           <a:lstStyle/>
           <a:p>
-            <a:pPr algn="l" indent="0" marL="0">
+            <a:pPr marL="0" indent="0" algn="l">
               <a:buNone/>
             </a:pPr>
             <a:r>
@@ -7212,6 +7095,13 @@
           </a:solidFill>
           <a:ln/>
         </p:spPr>
+        <p:txBody>
+          <a:bodyPr/>
+          <a:lstStyle/>
+          <a:p>
+            <a:endParaRPr lang="en-US"/>
+          </a:p>
+        </p:txBody>
       </p:sp>
       <p:sp>
         <p:nvSpPr>
@@ -7234,7 +7124,7 @@
           <a:bodyPr wrap="square" lIns="381" tIns="381" rIns="381" bIns="381" rtlCol="0" anchor="ctr"/>
           <a:lstStyle/>
           <a:p>
-            <a:pPr algn="ctr" indent="0" marL="0">
+            <a:pPr marL="0" indent="0" algn="ctr">
               <a:buNone/>
             </a:pPr>
             <a:r>
@@ -7273,6 +7163,13 @@
           </a:solidFill>
           <a:ln/>
         </p:spPr>
+        <p:txBody>
+          <a:bodyPr/>
+          <a:lstStyle/>
+          <a:p>
+            <a:endParaRPr lang="en-US"/>
+          </a:p>
+        </p:txBody>
       </p:sp>
       <p:sp>
         <p:nvSpPr>
@@ -7295,7 +7192,7 @@
           <a:bodyPr wrap="square" lIns="381" tIns="381" rIns="381" bIns="381" rtlCol="0" anchor="ctr"/>
           <a:lstStyle/>
           <a:p>
-            <a:pPr algn="ctr" indent="0" marL="0">
+            <a:pPr marL="0" indent="0" algn="ctr">
               <a:buNone/>
             </a:pPr>
             <a:r>
@@ -7334,6 +7231,13 @@
           </a:solidFill>
           <a:ln/>
         </p:spPr>
+        <p:txBody>
+          <a:bodyPr/>
+          <a:lstStyle/>
+          <a:p>
+            <a:endParaRPr lang="en-US"/>
+          </a:p>
+        </p:txBody>
       </p:sp>
       <p:sp>
         <p:nvSpPr>
@@ -7356,7 +7260,7 @@
           <a:bodyPr wrap="square" lIns="381" tIns="381" rIns="381" bIns="381" rtlCol="0" anchor="ctr"/>
           <a:lstStyle/>
           <a:p>
-            <a:pPr algn="ctr" indent="0" marL="0">
+            <a:pPr marL="0" indent="0" algn="ctr">
               <a:buNone/>
             </a:pPr>
             <a:r>
@@ -7397,6 +7301,13 @@
             <a:tailEnd type="triangle"/>
           </a:ln>
         </p:spPr>
+        <p:txBody>
+          <a:bodyPr/>
+          <a:lstStyle/>
+          <a:p>
+            <a:endParaRPr lang="en-US"/>
+          </a:p>
+        </p:txBody>
       </p:sp>
       <p:sp>
         <p:nvSpPr>
@@ -7420,6 +7331,13 @@
             <a:prstDash val="solid"/>
           </a:ln>
         </p:spPr>
+        <p:txBody>
+          <a:bodyPr/>
+          <a:lstStyle/>
+          <a:p>
+            <a:endParaRPr lang="en-US"/>
+          </a:p>
+        </p:txBody>
       </p:sp>
       <p:sp>
         <p:nvSpPr>
@@ -7443,6 +7361,13 @@
             <a:prstDash val="solid"/>
           </a:ln>
         </p:spPr>
+        <p:txBody>
+          <a:bodyPr/>
+          <a:lstStyle/>
+          <a:p>
+            <a:endParaRPr lang="en-US"/>
+          </a:p>
+        </p:txBody>
       </p:sp>
       <p:sp>
         <p:nvSpPr>
@@ -7467,6 +7392,13 @@
             <a:tailEnd type="triangle"/>
           </a:ln>
         </p:spPr>
+        <p:txBody>
+          <a:bodyPr/>
+          <a:lstStyle/>
+          <a:p>
+            <a:endParaRPr lang="en-US"/>
+          </a:p>
+        </p:txBody>
       </p:sp>
       <p:sp>
         <p:nvSpPr>
@@ -7489,7 +7421,7 @@
           <a:bodyPr wrap="square" lIns="0" tIns="0" rIns="0" bIns="0" rtlCol="0" anchor="ctr"/>
           <a:lstStyle/>
           <a:p>
-            <a:pPr algn="r" indent="0" marL="0">
+            <a:pPr marL="0" indent="0" algn="r">
               <a:buNone/>
             </a:pPr>
             <a:r>
@@ -7506,7 +7438,7 @@
             <a:endParaRPr lang="en-US" sz="1000" dirty="0"/>
           </a:p>
           <a:p>
-            <a:pPr algn="r" indent="0" marL="0">
+            <a:pPr marL="0" indent="0" algn="r">
               <a:buNone/>
             </a:pPr>
             <a:r>
@@ -7546,6 +7478,13 @@
             <a:prstDash val="solid"/>
           </a:ln>
         </p:spPr>
+        <p:txBody>
+          <a:bodyPr/>
+          <a:lstStyle/>
+          <a:p>
+            <a:endParaRPr lang="en-US"/>
+          </a:p>
+        </p:txBody>
       </p:sp>
       <p:sp>
         <p:nvSpPr>
@@ -7570,6 +7509,13 @@
             <a:tailEnd type="triangle"/>
           </a:ln>
         </p:spPr>
+        <p:txBody>
+          <a:bodyPr/>
+          <a:lstStyle/>
+          <a:p>
+            <a:endParaRPr lang="en-US"/>
+          </a:p>
+        </p:txBody>
       </p:sp>
       <p:sp>
         <p:nvSpPr>
@@ -7592,7 +7538,7 @@
           <a:bodyPr wrap="square" lIns="0" tIns="0" rIns="0" bIns="0" rtlCol="0" anchor="ctr"/>
           <a:lstStyle/>
           <a:p>
-            <a:pPr algn="ctr" indent="0" marL="0">
+            <a:pPr marL="0" indent="0" algn="ctr">
               <a:buNone/>
             </a:pPr>
             <a:r>
@@ -7631,6 +7577,13 @@
           </a:solidFill>
           <a:ln/>
         </p:spPr>
+        <p:txBody>
+          <a:bodyPr/>
+          <a:lstStyle/>
+          <a:p>
+            <a:endParaRPr lang="en-US"/>
+          </a:p>
+        </p:txBody>
       </p:sp>
       <p:sp>
         <p:nvSpPr>
@@ -7653,7 +7606,7 @@
           <a:bodyPr wrap="square" lIns="381" tIns="381" rIns="381" bIns="381" rtlCol="0" anchor="ctr"/>
           <a:lstStyle/>
           <a:p>
-            <a:pPr algn="ctr" indent="0" marL="0">
+            <a:pPr marL="0" indent="0" algn="ctr">
               <a:buNone/>
             </a:pPr>
             <a:r>
@@ -7670,7 +7623,7 @@
             <a:endParaRPr lang="en-US" sz="1200" dirty="0"/>
           </a:p>
           <a:p>
-            <a:pPr algn="ctr" indent="0" marL="0">
+            <a:pPr marL="0" indent="0" algn="ctr">
               <a:buNone/>
             </a:pPr>
             <a:r>
@@ -7711,6 +7664,13 @@
             <a:tailEnd type="triangle"/>
           </a:ln>
         </p:spPr>
+        <p:txBody>
+          <a:bodyPr/>
+          <a:lstStyle/>
+          <a:p>
+            <a:endParaRPr lang="en-US"/>
+          </a:p>
+        </p:txBody>
       </p:sp>
       <p:sp>
         <p:nvSpPr>
@@ -7733,7 +7693,7 @@
           <a:bodyPr wrap="square" lIns="0" tIns="0" rIns="0" bIns="0" rtlCol="0" anchor="ctr"/>
           <a:lstStyle/>
           <a:p>
-            <a:pPr algn="ctr" indent="0" marL="0">
+            <a:pPr marL="0" indent="0" algn="ctr">
               <a:buNone/>
             </a:pPr>
             <a:r>
@@ -7772,6 +7732,13 @@
           </a:solidFill>
           <a:ln/>
         </p:spPr>
+        <p:txBody>
+          <a:bodyPr/>
+          <a:lstStyle/>
+          <a:p>
+            <a:endParaRPr lang="en-US"/>
+          </a:p>
+        </p:txBody>
       </p:sp>
       <p:sp>
         <p:nvSpPr>
@@ -7794,7 +7761,7 @@
           <a:bodyPr wrap="square" lIns="381" tIns="381" rIns="381" bIns="381" rtlCol="0" anchor="ctr"/>
           <a:lstStyle/>
           <a:p>
-            <a:pPr algn="ctr" indent="0" marL="0">
+            <a:pPr marL="0" indent="0" algn="ctr">
               <a:buNone/>
             </a:pPr>
             <a:r>
@@ -7835,6 +7802,13 @@
             <a:tailEnd type="triangle"/>
           </a:ln>
         </p:spPr>
+        <p:txBody>
+          <a:bodyPr/>
+          <a:lstStyle/>
+          <a:p>
+            <a:endParaRPr lang="en-US"/>
+          </a:p>
+        </p:txBody>
       </p:sp>
       <p:sp>
         <p:nvSpPr>
@@ -7857,6 +7831,13 @@
           </a:solidFill>
           <a:ln/>
         </p:spPr>
+        <p:txBody>
+          <a:bodyPr/>
+          <a:lstStyle/>
+          <a:p>
+            <a:endParaRPr lang="en-US"/>
+          </a:p>
+        </p:txBody>
       </p:sp>
       <p:sp>
         <p:nvSpPr>
@@ -7879,7 +7860,7 @@
           <a:bodyPr wrap="square" lIns="381" tIns="381" rIns="381" bIns="381" rtlCol="0" anchor="ctr"/>
           <a:lstStyle/>
           <a:p>
-            <a:pPr algn="ctr" indent="0" marL="0">
+            <a:pPr marL="0" indent="0" algn="ctr">
               <a:buNone/>
             </a:pPr>
             <a:r>
@@ -7920,6 +7901,13 @@
             <a:tailEnd type="triangle"/>
           </a:ln>
         </p:spPr>
+        <p:txBody>
+          <a:bodyPr/>
+          <a:lstStyle/>
+          <a:p>
+            <a:endParaRPr lang="en-US"/>
+          </a:p>
+        </p:txBody>
       </p:sp>
       <p:sp>
         <p:nvSpPr>
@@ -7942,6 +7930,13 @@
           </a:solidFill>
           <a:ln/>
         </p:spPr>
+        <p:txBody>
+          <a:bodyPr/>
+          <a:lstStyle/>
+          <a:p>
+            <a:endParaRPr lang="en-US"/>
+          </a:p>
+        </p:txBody>
       </p:sp>
       <p:sp>
         <p:nvSpPr>
@@ -7964,7 +7959,7 @@
           <a:bodyPr wrap="square" lIns="381" tIns="381" rIns="381" bIns="381" rtlCol="0" anchor="ctr"/>
           <a:lstStyle/>
           <a:p>
-            <a:pPr algn="ctr" indent="0" marL="0">
+            <a:pPr marL="0" indent="0" algn="ctr">
               <a:buNone/>
             </a:pPr>
             <a:r>
@@ -8003,7 +7998,7 @@
           <a:bodyPr wrap="square" lIns="0" tIns="0" rIns="0" bIns="0" rtlCol="0" anchor="ctr"/>
           <a:lstStyle/>
           <a:p>
-            <a:pPr algn="ctr" indent="0" marL="0">
+            <a:pPr marL="0" indent="0" algn="ctr">
               <a:buNone/>
             </a:pPr>
             <a:r>
@@ -8043,6 +8038,13 @@
             <a:prstDash val="solid"/>
           </a:ln>
         </p:spPr>
+        <p:txBody>
+          <a:bodyPr/>
+          <a:lstStyle/>
+          <a:p>
+            <a:endParaRPr lang="en-US"/>
+          </a:p>
+        </p:txBody>
       </p:sp>
       <p:sp>
         <p:nvSpPr>
@@ -8066,6 +8068,13 @@
             <a:prstDash val="solid"/>
           </a:ln>
         </p:spPr>
+        <p:txBody>
+          <a:bodyPr/>
+          <a:lstStyle/>
+          <a:p>
+            <a:endParaRPr lang="en-US"/>
+          </a:p>
+        </p:txBody>
       </p:sp>
       <p:sp>
         <p:nvSpPr>
@@ -8089,6 +8098,13 @@
             <a:prstDash val="solid"/>
           </a:ln>
         </p:spPr>
+        <p:txBody>
+          <a:bodyPr/>
+          <a:lstStyle/>
+          <a:p>
+            <a:endParaRPr lang="en-US"/>
+          </a:p>
+        </p:txBody>
       </p:sp>
       <p:sp>
         <p:nvSpPr>
@@ -8112,6 +8128,13 @@
             <a:prstDash val="solid"/>
           </a:ln>
         </p:spPr>
+        <p:txBody>
+          <a:bodyPr/>
+          <a:lstStyle/>
+          <a:p>
+            <a:endParaRPr lang="en-US"/>
+          </a:p>
+        </p:txBody>
       </p:sp>
       <p:sp>
         <p:nvSpPr>
@@ -8136,6 +8159,13 @@
             <a:tailEnd type="triangle"/>
           </a:ln>
         </p:spPr>
+        <p:txBody>
+          <a:bodyPr/>
+          <a:lstStyle/>
+          <a:p>
+            <a:endParaRPr lang="en-US"/>
+          </a:p>
+        </p:txBody>
       </p:sp>
       <p:sp>
         <p:nvSpPr>
@@ -8158,7 +8188,7 @@
           <a:bodyPr wrap="square" lIns="0" tIns="0" rIns="0" bIns="0" rtlCol="0" anchor="ctr"/>
           <a:lstStyle/>
           <a:p>
-            <a:pPr algn="ctr" indent="0" marL="0">
+            <a:pPr marL="0" indent="0" algn="ctr">
               <a:buNone/>
             </a:pPr>
             <a:r>
@@ -8198,6 +8228,13 @@
             <a:prstDash val="solid"/>
           </a:ln>
         </p:spPr>
+        <p:txBody>
+          <a:bodyPr/>
+          <a:lstStyle/>
+          <a:p>
+            <a:endParaRPr lang="en-US"/>
+          </a:p>
+        </p:txBody>
       </p:sp>
       <p:sp>
         <p:nvSpPr>
@@ -8221,6 +8258,13 @@
             <a:prstDash val="solid"/>
           </a:ln>
         </p:spPr>
+        <p:txBody>
+          <a:bodyPr/>
+          <a:lstStyle/>
+          <a:p>
+            <a:endParaRPr lang="en-US"/>
+          </a:p>
+        </p:txBody>
       </p:sp>
       <p:sp>
         <p:nvSpPr>
@@ -8245,6 +8289,13 @@
             <a:tailEnd type="triangle"/>
           </a:ln>
         </p:spPr>
+        <p:txBody>
+          <a:bodyPr/>
+          <a:lstStyle/>
+          <a:p>
+            <a:endParaRPr lang="en-US"/>
+          </a:p>
+        </p:txBody>
       </p:sp>
       <p:sp>
         <p:nvSpPr>
@@ -8267,7 +8318,7 @@
           <a:bodyPr wrap="square" lIns="0" tIns="0" rIns="0" bIns="0" rtlCol="0" anchor="ctr"/>
           <a:lstStyle/>
           <a:p>
-            <a:pPr algn="ctr" indent="0" marL="0">
+            <a:pPr marL="0" indent="0" algn="ctr">
               <a:buNone/>
             </a:pPr>
             <a:r>
@@ -8307,6 +8358,13 @@
             <a:prstDash val="solid"/>
           </a:ln>
         </p:spPr>
+        <p:txBody>
+          <a:bodyPr/>
+          <a:lstStyle/>
+          <a:p>
+            <a:endParaRPr lang="en-US"/>
+          </a:p>
+        </p:txBody>
       </p:sp>
       <p:sp>
         <p:nvSpPr>
@@ -8330,6 +8388,13 @@
             <a:prstDash val="solid"/>
           </a:ln>
         </p:spPr>
+        <p:txBody>
+          <a:bodyPr/>
+          <a:lstStyle/>
+          <a:p>
+            <a:endParaRPr lang="en-US"/>
+          </a:p>
+        </p:txBody>
       </p:sp>
       <p:sp>
         <p:nvSpPr>
@@ -8354,6 +8419,13 @@
             <a:tailEnd type="triangle"/>
           </a:ln>
         </p:spPr>
+        <p:txBody>
+          <a:bodyPr/>
+          <a:lstStyle/>
+          <a:p>
+            <a:endParaRPr lang="en-US"/>
+          </a:p>
+        </p:txBody>
       </p:sp>
       <p:sp>
         <p:nvSpPr>
@@ -8376,7 +8448,7 @@
           <a:bodyPr wrap="square" lIns="0" tIns="0" rIns="0" bIns="0" rtlCol="0" anchor="ctr"/>
           <a:lstStyle/>
           <a:p>
-            <a:pPr algn="ctr" indent="0" marL="0">
+            <a:pPr marL="0" indent="0" algn="ctr">
               <a:buNone/>
             </a:pPr>
             <a:r>
@@ -8415,6 +8487,13 @@
           </a:solidFill>
           <a:ln/>
         </p:spPr>
+        <p:txBody>
+          <a:bodyPr/>
+          <a:lstStyle/>
+          <a:p>
+            <a:endParaRPr lang="en-US"/>
+          </a:p>
+        </p:txBody>
       </p:sp>
       <p:sp>
         <p:nvSpPr>
@@ -8437,7 +8516,7 @@
           <a:bodyPr wrap="square" lIns="0" tIns="0" rIns="0" bIns="0" rtlCol="0" anchor="ctr"/>
           <a:lstStyle/>
           <a:p>
-            <a:pPr algn="l" indent="0" marL="0">
+            <a:pPr marL="0" indent="0" algn="l">
               <a:buNone/>
             </a:pPr>
             <a:r>
@@ -8451,9 +8530,6 @@
               </a:rPr>
               <a:t>The repair ladder: </a:t>
             </a:r>
-            <a:pPr algn="l" indent="0" marL="0">
-              <a:buNone/>
-            </a:pPr>
             <a:r>
               <a:rPr lang="en-US" sz="1300" dirty="0">
                 <a:solidFill>
@@ -8465,9 +8541,6 @@
               </a:rPr>
               <a:t>a rung's exhaustion is a </a:t>
             </a:r>
-            <a:pPr algn="l" indent="0" marL="0">
-              <a:buNone/>
-            </a:pPr>
             <a:r>
               <a:rPr lang="en-US" sz="1300" b="1" i="1" dirty="0">
                 <a:solidFill>
@@ -8479,9 +8552,6 @@
               </a:rPr>
               <a:t>local diagnosis </a:t>
             </a:r>
-            <a:pPr algn="l" indent="0" marL="0">
-              <a:buNone/>
-            </a:pPr>
             <a:r>
               <a:rPr lang="en-US" sz="1300" dirty="0">
                 <a:solidFill>
@@ -8496,7 +8566,7 @@
             <a:endParaRPr lang="en-US" sz="1300" dirty="0"/>
           </a:p>
           <a:p>
-            <a:pPr algn="l" indent="0" marL="0">
+            <a:pPr marL="0" indent="0" algn="l">
               <a:buNone/>
             </a:pPr>
             <a:r>
@@ -8510,9 +8580,6 @@
               </a:rPr>
               <a:t>judged only by </a:t>
             </a:r>
-            <a:pPr algn="l" indent="0" marL="0">
-              <a:buNone/>
-            </a:pPr>
             <a:r>
               <a:rPr lang="en-US" sz="1300" b="1" i="1" dirty="0">
                 <a:solidFill>
@@ -8524,9 +8591,6 @@
               </a:rPr>
               <a:t>fresh re-measurement</a:t>
             </a:r>
-            <a:pPr algn="l" indent="0" marL="0">
-              <a:buNone/>
-            </a:pPr>
             <a:r>
               <a:rPr lang="en-US" sz="1300" dirty="0">
                 <a:solidFill>
@@ -8568,6 +8632,13 @@
             <a:prstDash val="solid"/>
           </a:ln>
         </p:spPr>
+        <p:txBody>
+          <a:bodyPr/>
+          <a:lstStyle/>
+          <a:p>
+            <a:endParaRPr lang="en-US"/>
+          </a:p>
+        </p:txBody>
       </p:sp>
       <p:sp>
         <p:nvSpPr>
@@ -8590,7 +8661,7 @@
           <a:bodyPr wrap="square" lIns="0" tIns="0" rIns="0" bIns="0" rtlCol="0" anchor="ctr"/>
           <a:lstStyle/>
           <a:p>
-            <a:pPr algn="l" indent="0" marL="0">
+            <a:pPr marL="0" indent="0" algn="l">
               <a:buNone/>
             </a:pPr>
             <a:r>
@@ -8607,7 +8678,7 @@
             <a:endParaRPr lang="en-US" sz="1100" dirty="0"/>
           </a:p>
           <a:p>
-            <a:pPr algn="l" indent="0" marL="0">
+            <a:pPr marL="0" indent="0" algn="l">
               <a:buNone/>
             </a:pPr>
             <a:r>
@@ -8641,6 +8712,7 @@
         <a:solidFill>
           <a:srgbClr val="FFFFFF"/>
         </a:solidFill>
+        <a:effectLst/>
       </p:bgPr>
     </p:bg>
     <p:spTree>
@@ -8678,7 +8750,7 @@
           <a:bodyPr wrap="square" lIns="0" tIns="0" rIns="0" bIns="0" rtlCol="0" anchor="ctr"/>
           <a:lstStyle/>
           <a:p>
-            <a:pPr indent="0" marL="0">
+            <a:pPr marL="0" indent="0">
               <a:buNone/>
             </a:pPr>
             <a:r>
@@ -8717,7 +8789,7 @@
           <a:bodyPr wrap="square" lIns="0" tIns="0" rIns="0" bIns="0" rtlCol="0" anchor="t"/>
           <a:lstStyle/>
           <a:p>
-            <a:pPr algn="l" marL="342900" indent="-342900">
+            <a:pPr marL="342900" indent="-342900" algn="l">
               <a:buSzPct val="100000"/>
               <a:buChar char="•"/>
             </a:pPr>
@@ -8732,12 +8804,6 @@
               </a:rPr>
               <a:t>Blackboard</a:t>
             </a:r>
-            <a:pPr algn="l" indent="0" marL="0">
-              <a:spcAft>
-                <a:spcPts val="900"/>
-              </a:spcAft>
-              <a:buNone/>
-            </a:pPr>
             <a:r>
               <a:rPr lang="en-US" sz="1600" dirty="0">
                 <a:solidFill>
@@ -8752,7 +8818,7 @@
             <a:endParaRPr lang="en-US" sz="1600" dirty="0"/>
           </a:p>
           <a:p>
-            <a:pPr algn="l" marL="342900" indent="-342900">
+            <a:pPr marL="342900" indent="-342900" algn="l">
               <a:buSzPct val="100000"/>
               <a:buChar char="•"/>
             </a:pPr>
@@ -8767,12 +8833,6 @@
               </a:rPr>
               <a:t>Blackboard Entry (Key)</a:t>
             </a:r>
-            <a:pPr algn="l" indent="0" marL="0">
-              <a:spcAft>
-                <a:spcPts val="900"/>
-              </a:spcAft>
-              <a:buNone/>
-            </a:pPr>
             <a:r>
               <a:rPr lang="en-US" sz="1600" dirty="0">
                 <a:solidFill>
@@ -8787,7 +8847,7 @@
             <a:endParaRPr lang="en-US" sz="1600" dirty="0"/>
           </a:p>
           <a:p>
-            <a:pPr algn="l" marL="342900" indent="-342900">
+            <a:pPr marL="342900" indent="-342900" algn="l">
               <a:buSzPct val="100000"/>
               <a:buChar char="•"/>
             </a:pPr>
@@ -8802,12 +8862,6 @@
               </a:rPr>
               <a:t>Episode</a:t>
             </a:r>
-            <a:pPr algn="l" indent="0" marL="0">
-              <a:spcAft>
-                <a:spcPts val="900"/>
-              </a:spcAft>
-              <a:buNone/>
-            </a:pPr>
             <a:r>
               <a:rPr lang="en-US" sz="1600" dirty="0">
                 <a:solidFill>
@@ -8822,7 +8876,7 @@
             <a:endParaRPr lang="en-US" sz="1600" dirty="0"/>
           </a:p>
           <a:p>
-            <a:pPr algn="l" marL="342900" indent="-342900">
+            <a:pPr marL="342900" indent="-342900" algn="l">
               <a:buSzPct val="100000"/>
               <a:buChar char="•"/>
             </a:pPr>
@@ -8837,12 +8891,6 @@
               </a:rPr>
               <a:t>Partition</a:t>
             </a:r>
-            <a:pPr algn="l" indent="0" marL="0">
-              <a:spcAft>
-                <a:spcPts val="900"/>
-              </a:spcAft>
-              <a:buNone/>
-            </a:pPr>
             <a:r>
               <a:rPr lang="en-US" sz="1600" dirty="0">
                 <a:solidFill>
@@ -8857,7 +8905,7 @@
             <a:endParaRPr lang="en-US" sz="1600" dirty="0"/>
           </a:p>
           <a:p>
-            <a:pPr algn="l" marL="342900" indent="-342900">
+            <a:pPr marL="342900" indent="-342900" algn="l">
               <a:buSzPct val="100000"/>
               <a:buChar char="•"/>
             </a:pPr>
@@ -8872,12 +8920,6 @@
               </a:rPr>
               <a:t>Controller</a:t>
             </a:r>
-            <a:pPr algn="l" indent="0" marL="0">
-              <a:spcAft>
-                <a:spcPts val="900"/>
-              </a:spcAft>
-              <a:buNone/>
-            </a:pPr>
             <a:r>
               <a:rPr lang="en-US" sz="1600" dirty="0">
                 <a:solidFill>
@@ -8892,7 +8934,7 @@
             <a:endParaRPr lang="en-US" sz="1600" dirty="0"/>
           </a:p>
           <a:p>
-            <a:pPr algn="l" marL="342900" indent="-342900">
+            <a:pPr marL="342900" indent="-342900" algn="l">
               <a:buSzPct val="100000"/>
               <a:buChar char="•"/>
             </a:pPr>
@@ -8907,12 +8949,6 @@
               </a:rPr>
               <a:t>Knowledge source (KS)</a:t>
             </a:r>
-            <a:pPr algn="l" indent="0" marL="0">
-              <a:spcAft>
-                <a:spcPts val="900"/>
-              </a:spcAft>
-              <a:buNone/>
-            </a:pPr>
             <a:r>
               <a:rPr lang="en-US" sz="1600" dirty="0">
                 <a:solidFill>
@@ -8927,7 +8963,7 @@
             <a:endParaRPr lang="en-US" sz="1600" dirty="0"/>
           </a:p>
           <a:p>
-            <a:pPr algn="l" marL="342900" indent="-342900">
+            <a:pPr marL="342900" indent="-342900" algn="l">
               <a:buSzPct val="100000"/>
               <a:buChar char="•"/>
             </a:pPr>
@@ -8942,12 +8978,6 @@
               </a:rPr>
               <a:t>Route</a:t>
             </a:r>
-            <a:pPr algn="l" indent="0" marL="0">
-              <a:spcAft>
-                <a:spcPts val="900"/>
-              </a:spcAft>
-              <a:buNone/>
-            </a:pPr>
             <a:r>
               <a:rPr lang="en-US" sz="1600" dirty="0">
                 <a:solidFill>
@@ -8962,7 +8992,7 @@
             <a:endParaRPr lang="en-US" sz="1600" dirty="0"/>
           </a:p>
           <a:p>
-            <a:pPr algn="l" marL="342900" indent="-342900">
+            <a:pPr marL="342900" indent="-342900" algn="l">
               <a:buSzPct val="100000"/>
               <a:buChar char="•"/>
             </a:pPr>
@@ -8977,12 +9007,6 @@
               </a:rPr>
               <a:t>History / Ledger</a:t>
             </a:r>
-            <a:pPr algn="l" indent="0" marL="0">
-              <a:spcAft>
-                <a:spcPts val="900"/>
-              </a:spcAft>
-              <a:buNone/>
-            </a:pPr>
             <a:r>
               <a:rPr lang="en-US" sz="1600" dirty="0">
                 <a:solidFill>
@@ -9014,6 +9038,7 @@
         <a:solidFill>
           <a:srgbClr val="FFFFFF"/>
         </a:solidFill>
+        <a:effectLst/>
       </p:bgPr>
     </p:bg>
     <p:spTree>
@@ -9051,7 +9076,7 @@
           <a:bodyPr wrap="square" lIns="0" tIns="0" rIns="0" bIns="0" rtlCol="0" anchor="ctr"/>
           <a:lstStyle/>
           <a:p>
-            <a:pPr indent="0" marL="0">
+            <a:pPr marL="0" indent="0">
               <a:buNone/>
             </a:pPr>
             <a:r>
@@ -9092,10 +9117,34 @@
             <a:tbl>
               <a:tblPr/>
               <a:tblGrid>
-                <a:gridCol w="2194560"/>
-                <a:gridCol w="2651760"/>
-                <a:gridCol w="3017520"/>
-                <a:gridCol w="3017520"/>
+                <a:gridCol w="2194560">
+                  <a:extLst>
+                    <a:ext uri="{9D8B030D-6E8A-4147-A177-3AD203B41FA5}">
+                      <a16:colId xmlns:a16="http://schemas.microsoft.com/office/drawing/2014/main" val="20000"/>
+                    </a:ext>
+                  </a:extLst>
+                </a:gridCol>
+                <a:gridCol w="2651760">
+                  <a:extLst>
+                    <a:ext uri="{9D8B030D-6E8A-4147-A177-3AD203B41FA5}">
+                      <a16:colId xmlns:a16="http://schemas.microsoft.com/office/drawing/2014/main" val="20001"/>
+                    </a:ext>
+                  </a:extLst>
+                </a:gridCol>
+                <a:gridCol w="3017520">
+                  <a:extLst>
+                    <a:ext uri="{9D8B030D-6E8A-4147-A177-3AD203B41FA5}">
+                      <a16:colId xmlns:a16="http://schemas.microsoft.com/office/drawing/2014/main" val="20002"/>
+                    </a:ext>
+                  </a:extLst>
+                </a:gridCol>
+                <a:gridCol w="3017520">
+                  <a:extLst>
+                    <a:ext uri="{9D8B030D-6E8A-4147-A177-3AD203B41FA5}">
+                      <a16:colId xmlns:a16="http://schemas.microsoft.com/office/drawing/2014/main" val="20003"/>
+                    </a:ext>
+                  </a:extLst>
+                </a:gridCol>
               </a:tblGrid>
               <a:tr h="658368">
                 <a:tc>
@@ -9103,7 +9152,7 @@
                     <a:bodyPr/>
                     <a:lstStyle/>
                     <a:p>
-                      <a:pPr algn="l" indent="0" marL="0">
+                      <a:pPr marL="0" indent="0" algn="l">
                         <a:buNone/>
                       </a:pPr>
                       <a:r>
@@ -9171,7 +9220,7 @@
                     <a:bodyPr/>
                     <a:lstStyle/>
                     <a:p>
-                      <a:pPr algn="l" indent="0" marL="0">
+                      <a:pPr marL="0" indent="0" algn="l">
                         <a:buNone/>
                       </a:pPr>
                       <a:r>
@@ -9239,7 +9288,7 @@
                     <a:bodyPr/>
                     <a:lstStyle/>
                     <a:p>
-                      <a:pPr algn="l" indent="0" marL="0">
+                      <a:pPr marL="0" indent="0" algn="l">
                         <a:buNone/>
                       </a:pPr>
                       <a:r>
@@ -9307,7 +9356,7 @@
                     <a:bodyPr/>
                     <a:lstStyle/>
                     <a:p>
-                      <a:pPr algn="l" indent="0" marL="0">
+                      <a:pPr marL="0" indent="0" algn="l">
                         <a:buNone/>
                       </a:pPr>
                       <a:r>
@@ -9370,6 +9419,11 @@
                     </a:solidFill>
                   </a:tcPr>
                 </a:tc>
+                <a:extLst>
+                  <a:ext uri="{0D108BD9-81ED-4DB2-BD59-A6C34878D82A}">
+                    <a16:rowId xmlns:a16="http://schemas.microsoft.com/office/drawing/2014/main" val="10000"/>
+                  </a:ext>
+                </a:extLst>
               </a:tr>
               <a:tr h="658368">
                 <a:tc>
@@ -9377,7 +9431,7 @@
                     <a:bodyPr/>
                     <a:lstStyle/>
                     <a:p>
-                      <a:pPr algn="l" indent="0" marL="0">
+                      <a:pPr marL="0" indent="0" algn="l">
                         <a:buNone/>
                       </a:pPr>
                       <a:r>
@@ -9445,7 +9499,7 @@
                     <a:bodyPr/>
                     <a:lstStyle/>
                     <a:p>
-                      <a:pPr algn="l" indent="0" marL="0">
+                      <a:pPr marL="0" indent="0" algn="l">
                         <a:buNone/>
                       </a:pPr>
                       <a:r>
@@ -9513,7 +9567,7 @@
                     <a:bodyPr/>
                     <a:lstStyle/>
                     <a:p>
-                      <a:pPr algn="l" indent="0" marL="0">
+                      <a:pPr marL="0" indent="0" algn="l">
                         <a:buNone/>
                       </a:pPr>
                       <a:r>
@@ -9581,7 +9635,7 @@
                     <a:bodyPr/>
                     <a:lstStyle/>
                     <a:p>
-                      <a:pPr algn="l" indent="0" marL="0">
+                      <a:pPr marL="0" indent="0" algn="l">
                         <a:buNone/>
                       </a:pPr>
                       <a:r>
@@ -9595,9 +9649,6 @@
                         </a:rPr>
                         <a:t>restore from golden — or </a:t>
                       </a:r>
-                      <a:pPr algn="l" indent="0" marL="0">
-                        <a:buNone/>
-                      </a:pPr>
                       <a:r>
                         <a:rPr lang="en-US" sz="1250" i="1" dirty="0">
                           <a:solidFill>
@@ -9609,9 +9660,6 @@
                         </a:rPr>
                         <a:t>bless</a:t>
                       </a:r>
-                      <a:pPr algn="l" indent="0" marL="0">
-                        <a:buNone/>
-                      </a:pPr>
                       <a:r>
                         <a:rPr lang="en-US" sz="1250" dirty="0">
                           <a:solidFill>
@@ -9672,6 +9720,11 @@
                     </a:solidFill>
                   </a:tcPr>
                 </a:tc>
+                <a:extLst>
+                  <a:ext uri="{0D108BD9-81ED-4DB2-BD59-A6C34878D82A}">
+                    <a16:rowId xmlns:a16="http://schemas.microsoft.com/office/drawing/2014/main" val="10001"/>
+                  </a:ext>
+                </a:extLst>
               </a:tr>
               <a:tr h="658368">
                 <a:tc>
@@ -9679,7 +9732,7 @@
                     <a:bodyPr/>
                     <a:lstStyle/>
                     <a:p>
-                      <a:pPr algn="l" indent="0" marL="0">
+                      <a:pPr marL="0" indent="0" algn="l">
                         <a:buNone/>
                       </a:pPr>
                       <a:r>
@@ -9747,7 +9800,7 @@
                     <a:bodyPr/>
                     <a:lstStyle/>
                     <a:p>
-                      <a:pPr algn="l" indent="0" marL="0">
+                      <a:pPr marL="0" indent="0" algn="l">
                         <a:buNone/>
                       </a:pPr>
                       <a:r>
@@ -9815,7 +9868,7 @@
                     <a:bodyPr/>
                     <a:lstStyle/>
                     <a:p>
-                      <a:pPr algn="l" indent="0" marL="0">
+                      <a:pPr marL="0" indent="0" algn="l">
                         <a:buNone/>
                       </a:pPr>
                       <a:r>
@@ -9883,7 +9936,7 @@
                     <a:bodyPr/>
                     <a:lstStyle/>
                     <a:p>
-                      <a:pPr algn="l" indent="0" marL="0">
+                      <a:pPr marL="0" indent="0" algn="l">
                         <a:buNone/>
                       </a:pPr>
                       <a:r>
@@ -9946,6 +9999,11 @@
                     </a:solidFill>
                   </a:tcPr>
                 </a:tc>
+                <a:extLst>
+                  <a:ext uri="{0D108BD9-81ED-4DB2-BD59-A6C34878D82A}">
+                    <a16:rowId xmlns:a16="http://schemas.microsoft.com/office/drawing/2014/main" val="10002"/>
+                  </a:ext>
+                </a:extLst>
               </a:tr>
               <a:tr h="658368">
                 <a:tc>
@@ -9953,7 +10011,7 @@
                     <a:bodyPr/>
                     <a:lstStyle/>
                     <a:p>
-                      <a:pPr algn="l" indent="0" marL="0">
+                      <a:pPr marL="0" indent="0" algn="l">
                         <a:buNone/>
                       </a:pPr>
                       <a:r>
@@ -10021,7 +10079,7 @@
                     <a:bodyPr/>
                     <a:lstStyle/>
                     <a:p>
-                      <a:pPr algn="l" indent="0" marL="0">
+                      <a:pPr marL="0" indent="0" algn="l">
                         <a:buNone/>
                       </a:pPr>
                       <a:r>
@@ -10089,7 +10147,7 @@
                     <a:bodyPr/>
                     <a:lstStyle/>
                     <a:p>
-                      <a:pPr algn="l" indent="0" marL="0">
+                      <a:pPr marL="0" indent="0" algn="l">
                         <a:buNone/>
                       </a:pPr>
                       <a:r>
@@ -10157,7 +10215,7 @@
                     <a:bodyPr/>
                     <a:lstStyle/>
                     <a:p>
-                      <a:pPr algn="l" indent="0" marL="0">
+                      <a:pPr marL="0" indent="0" algn="l">
                         <a:buNone/>
                       </a:pPr>
                       <a:r>
@@ -10220,6 +10278,11 @@
                     </a:solidFill>
                   </a:tcPr>
                 </a:tc>
+                <a:extLst>
+                  <a:ext uri="{0D108BD9-81ED-4DB2-BD59-A6C34878D82A}">
+                    <a16:rowId xmlns:a16="http://schemas.microsoft.com/office/drawing/2014/main" val="10003"/>
+                  </a:ext>
+                </a:extLst>
               </a:tr>
               <a:tr h="658368">
                 <a:tc>
@@ -10227,7 +10290,7 @@
                     <a:bodyPr/>
                     <a:lstStyle/>
                     <a:p>
-                      <a:pPr algn="l" indent="0" marL="0">
+                      <a:pPr marL="0" indent="0" algn="l">
                         <a:buNone/>
                       </a:pPr>
                       <a:r>
@@ -10295,7 +10358,7 @@
                     <a:bodyPr/>
                     <a:lstStyle/>
                     <a:p>
-                      <a:pPr algn="l" indent="0" marL="0">
+                      <a:pPr marL="0" indent="0" algn="l">
                         <a:buNone/>
                       </a:pPr>
                       <a:r>
@@ -10363,7 +10426,7 @@
                     <a:bodyPr/>
                     <a:lstStyle/>
                     <a:p>
-                      <a:pPr algn="l" indent="0" marL="0">
+                      <a:pPr marL="0" indent="0" algn="l">
                         <a:buNone/>
                       </a:pPr>
                       <a:r>
@@ -10431,7 +10494,7 @@
                     <a:bodyPr/>
                     <a:lstStyle/>
                     <a:p>
-                      <a:pPr algn="l" indent="0" marL="0">
+                      <a:pPr marL="0" indent="0" algn="l">
                         <a:buNone/>
                       </a:pPr>
                       <a:r>
@@ -10494,6 +10557,11 @@
                     </a:solidFill>
                   </a:tcPr>
                 </a:tc>
+                <a:extLst>
+                  <a:ext uri="{0D108BD9-81ED-4DB2-BD59-A6C34878D82A}">
+                    <a16:rowId xmlns:a16="http://schemas.microsoft.com/office/drawing/2014/main" val="10004"/>
+                  </a:ext>
+                </a:extLst>
               </a:tr>
               <a:tr h="658368">
                 <a:tc>
@@ -10501,7 +10569,7 @@
                     <a:bodyPr/>
                     <a:lstStyle/>
                     <a:p>
-                      <a:pPr algn="l" indent="0" marL="0">
+                      <a:pPr marL="0" indent="0" algn="l">
                         <a:buNone/>
                       </a:pPr>
                       <a:r>
@@ -10515,9 +10583,6 @@
                         </a:rPr>
                         <a:t>Toolchain </a:t>
                       </a:r>
-                      <a:pPr algn="l" indent="0" marL="0">
-                        <a:buNone/>
-                      </a:pPr>
                       <a:r>
                         <a:rPr lang="en-US" sz="1100" i="1" dirty="0">
                           <a:solidFill>
@@ -10583,7 +10648,7 @@
                     <a:bodyPr/>
                     <a:lstStyle/>
                     <a:p>
-                      <a:pPr algn="l" indent="0" marL="0">
+                      <a:pPr marL="0" indent="0" algn="l">
                         <a:buNone/>
                       </a:pPr>
                       <a:r>
@@ -10597,9 +10662,6 @@
                         </a:rPr>
                         <a:t>hashed </a:t>
                       </a:r>
-                      <a:pPr algn="l" indent="0" marL="0">
-                        <a:buNone/>
-                      </a:pPr>
                       <a:r>
                         <a:rPr lang="en-US" sz="1250" b="1" dirty="0">
                           <a:solidFill>
@@ -10665,7 +10727,7 @@
                     <a:bodyPr/>
                     <a:lstStyle/>
                     <a:p>
-                      <a:pPr algn="l" indent="0" marL="0">
+                      <a:pPr marL="0" indent="0" algn="l">
                         <a:buNone/>
                       </a:pPr>
                       <a:r>
@@ -10733,7 +10795,7 @@
                     <a:bodyPr/>
                     <a:lstStyle/>
                     <a:p>
-                      <a:pPr algn="l" indent="0" marL="0">
+                      <a:pPr marL="0" indent="0" algn="l">
                         <a:buNone/>
                       </a:pPr>
                       <a:r>
@@ -10796,6 +10858,11 @@
                     </a:solidFill>
                   </a:tcPr>
                 </a:tc>
+                <a:extLst>
+                  <a:ext uri="{0D108BD9-81ED-4DB2-BD59-A6C34878D82A}">
+                    <a16:rowId xmlns:a16="http://schemas.microsoft.com/office/drawing/2014/main" val="10005"/>
+                  </a:ext>
+                </a:extLst>
               </a:tr>
               <a:tr h="658368">
                 <a:tc>
@@ -10803,7 +10870,7 @@
                     <a:bodyPr/>
                     <a:lstStyle/>
                     <a:p>
-                      <a:pPr algn="l" indent="0" marL="0">
+                      <a:pPr marL="0" indent="0" algn="l">
                         <a:buNone/>
                       </a:pPr>
                       <a:r>
@@ -10817,9 +10884,6 @@
                         </a:rPr>
                         <a:t>Trust state </a:t>
                       </a:r>
-                      <a:pPr algn="l" indent="0" marL="0">
-                        <a:buNone/>
-                      </a:pPr>
                       <a:r>
                         <a:rPr lang="en-US" sz="1100" i="1" dirty="0">
                           <a:solidFill>
@@ -10885,7 +10949,7 @@
                     <a:bodyPr/>
                     <a:lstStyle/>
                     <a:p>
-                      <a:pPr algn="l" indent="0" marL="0">
+                      <a:pPr marL="0" indent="0" algn="l">
                         <a:buNone/>
                       </a:pPr>
                       <a:r>
@@ -10953,7 +11017,7 @@
                     <a:bodyPr/>
                     <a:lstStyle/>
                     <a:p>
-                      <a:pPr algn="l" indent="0" marL="0">
+                      <a:pPr marL="0" indent="0" algn="l">
                         <a:buNone/>
                       </a:pPr>
                       <a:r>
@@ -11021,7 +11085,7 @@
                     <a:bodyPr/>
                     <a:lstStyle/>
                     <a:p>
-                      <a:pPr algn="l" indent="0" marL="0">
+                      <a:pPr marL="0" indent="0" algn="l">
                         <a:buNone/>
                       </a:pPr>
                       <a:r>
@@ -11035,9 +11099,6 @@
                         </a:rPr>
                         <a:t>principled refusal</a:t>
                       </a:r>
-                      <a:pPr algn="l" indent="0" marL="0">
-                        <a:buNone/>
-                      </a:pPr>
                       <a:r>
                         <a:rPr lang="en-US" sz="1250" dirty="0">
                           <a:solidFill>
@@ -11098,6 +11159,11 @@
                     </a:solidFill>
                   </a:tcPr>
                 </a:tc>
+                <a:extLst>
+                  <a:ext uri="{0D108BD9-81ED-4DB2-BD59-A6C34878D82A}">
+                    <a16:rowId xmlns:a16="http://schemas.microsoft.com/office/drawing/2014/main" val="10006"/>
+                  </a:ext>
+                </a:extLst>
               </a:tr>
             </a:tbl>
           </a:graphicData>
@@ -11119,6 +11185,7 @@
         <a:solidFill>
           <a:srgbClr val="FFFFFF"/>
         </a:solidFill>
+        <a:effectLst/>
       </p:bgPr>
     </p:bg>
     <p:spTree>
@@ -11156,6 +11223,13 @@
           </a:solidFill>
           <a:ln/>
         </p:spPr>
+        <p:txBody>
+          <a:bodyPr/>
+          <a:lstStyle/>
+          <a:p>
+            <a:endParaRPr lang="en-US"/>
+          </a:p>
+        </p:txBody>
       </p:sp>
       <p:sp>
         <p:nvSpPr>
@@ -11178,7 +11252,7 @@
           <a:bodyPr wrap="square" lIns="254" tIns="254" rIns="254" bIns="254" rtlCol="0" anchor="ctr"/>
           <a:lstStyle/>
           <a:p>
-            <a:pPr algn="ctr" indent="0" marL="0">
+            <a:pPr marL="0" indent="0" algn="ctr">
               <a:buNone/>
             </a:pPr>
             <a:r>
@@ -11217,6 +11291,13 @@
           </a:solidFill>
           <a:ln/>
         </p:spPr>
+        <p:txBody>
+          <a:bodyPr/>
+          <a:lstStyle/>
+          <a:p>
+            <a:endParaRPr lang="en-US"/>
+          </a:p>
+        </p:txBody>
       </p:sp>
       <p:sp>
         <p:nvSpPr>
@@ -11239,7 +11320,7 @@
           <a:bodyPr wrap="square" lIns="254" tIns="254" rIns="254" bIns="254" rtlCol="0" anchor="ctr"/>
           <a:lstStyle/>
           <a:p>
-            <a:pPr algn="ctr" indent="0" marL="0">
+            <a:pPr marL="0" indent="0" algn="ctr">
               <a:buNone/>
             </a:pPr>
             <a:r>
@@ -11256,7 +11337,7 @@
             <a:endParaRPr lang="en-US" sz="900" dirty="0"/>
           </a:p>
           <a:p>
-            <a:pPr algn="ctr" indent="0" marL="0">
+            <a:pPr marL="0" indent="0" algn="ctr">
               <a:buNone/>
             </a:pPr>
             <a:r>
@@ -11295,6 +11376,13 @@
           </a:solidFill>
           <a:ln/>
         </p:spPr>
+        <p:txBody>
+          <a:bodyPr/>
+          <a:lstStyle/>
+          <a:p>
+            <a:endParaRPr lang="en-US"/>
+          </a:p>
+        </p:txBody>
       </p:sp>
       <p:sp>
         <p:nvSpPr>
@@ -11317,7 +11405,7 @@
           <a:bodyPr wrap="square" lIns="254" tIns="254" rIns="254" bIns="254" rtlCol="0" anchor="ctr"/>
           <a:lstStyle/>
           <a:p>
-            <a:pPr algn="ctr" indent="0" marL="0">
+            <a:pPr marL="0" indent="0" algn="ctr">
               <a:buNone/>
             </a:pPr>
             <a:r>
@@ -11356,6 +11444,13 @@
           </a:solidFill>
           <a:ln/>
         </p:spPr>
+        <p:txBody>
+          <a:bodyPr/>
+          <a:lstStyle/>
+          <a:p>
+            <a:endParaRPr lang="en-US"/>
+          </a:p>
+        </p:txBody>
       </p:sp>
       <p:sp>
         <p:nvSpPr>
@@ -11378,7 +11473,7 @@
           <a:bodyPr wrap="square" lIns="254" tIns="254" rIns="254" bIns="254" rtlCol="0" anchor="ctr"/>
           <a:lstStyle/>
           <a:p>
-            <a:pPr algn="ctr" indent="0" marL="0">
+            <a:pPr marL="0" indent="0" algn="ctr">
               <a:buNone/>
             </a:pPr>
             <a:r>
@@ -11417,6 +11512,13 @@
           </a:solidFill>
           <a:ln/>
         </p:spPr>
+        <p:txBody>
+          <a:bodyPr/>
+          <a:lstStyle/>
+          <a:p>
+            <a:endParaRPr lang="en-US"/>
+          </a:p>
+        </p:txBody>
       </p:sp>
       <p:sp>
         <p:nvSpPr>
@@ -11439,7 +11541,7 @@
           <a:bodyPr wrap="square" lIns="254" tIns="254" rIns="254" bIns="254" rtlCol="0" anchor="ctr"/>
           <a:lstStyle/>
           <a:p>
-            <a:pPr algn="ctr" indent="0" marL="0">
+            <a:pPr marL="0" indent="0" algn="ctr">
               <a:buNone/>
             </a:pPr>
             <a:r>
@@ -11478,7 +11580,7 @@
           <a:bodyPr wrap="square" lIns="0" tIns="0" rIns="0" bIns="0" rtlCol="0" anchor="ctr"/>
           <a:lstStyle/>
           <a:p>
-            <a:pPr indent="0" marL="0">
+            <a:pPr marL="0" indent="0">
               <a:buNone/>
             </a:pPr>
             <a:r>
@@ -11517,7 +11619,7 @@
           <a:bodyPr wrap="square" lIns="0" tIns="0" rIns="0" bIns="0" rtlCol="0" anchor="t"/>
           <a:lstStyle/>
           <a:p>
-            <a:pPr algn="l" marL="342900" indent="-342900">
+            <a:pPr marL="342900" indent="-342900" algn="l">
               <a:buSzPct val="100000"/>
               <a:buChar char="•"/>
             </a:pPr>
@@ -11532,12 +11634,6 @@
               </a:rPr>
               <a:t>The system: </a:t>
             </a:r>
-            <a:pPr algn="l" indent="0" marL="0">
-              <a:spcAft>
-                <a:spcPts val="200"/>
-              </a:spcAft>
-              <a:buNone/>
-            </a:pPr>
             <a:r>
               <a:rPr lang="en-US" sz="1350" dirty="0">
                 <a:solidFill>
@@ -11552,7 +11648,7 @@
             <a:endParaRPr lang="en-US" sz="1350" dirty="0"/>
           </a:p>
           <a:p>
-            <a:pPr algn="l" indent="0" marL="0">
+            <a:pPr marL="0" indent="0" algn="l">
               <a:spcAft>
                 <a:spcPts val="1000"/>
               </a:spcAft>
@@ -11572,7 +11668,7 @@
             <a:endParaRPr lang="en-US" sz="1350" dirty="0"/>
           </a:p>
           <a:p>
-            <a:pPr algn="l" marL="342900" indent="-342900">
+            <a:pPr marL="342900" indent="-342900" algn="l">
               <a:buSzPct val="100000"/>
               <a:buChar char="•"/>
             </a:pPr>
@@ -11587,9 +11683,6 @@
               </a:rPr>
               <a:t>The relevance: </a:t>
             </a:r>
-            <a:pPr algn="l" indent="0" marL="0">
-              <a:buNone/>
-            </a:pPr>
             <a:r>
               <a:rPr lang="en-US" sz="1350" dirty="0">
                 <a:solidFill>
@@ -11626,6 +11719,13 @@
           </a:solidFill>
           <a:ln/>
         </p:spPr>
+        <p:txBody>
+          <a:bodyPr/>
+          <a:lstStyle/>
+          <a:p>
+            <a:endParaRPr lang="en-US"/>
+          </a:p>
+        </p:txBody>
       </p:sp>
       <p:sp>
         <p:nvSpPr>
@@ -11648,7 +11748,7 @@
           <a:bodyPr wrap="square" lIns="254" tIns="254" rIns="254" bIns="254" rtlCol="0" anchor="ctr"/>
           <a:lstStyle/>
           <a:p>
-            <a:pPr algn="ctr" indent="0" marL="0">
+            <a:pPr marL="0" indent="0" algn="ctr">
               <a:buNone/>
             </a:pPr>
             <a:r>
@@ -11665,7 +11765,7 @@
             <a:endParaRPr lang="en-US" sz="1050" dirty="0"/>
           </a:p>
           <a:p>
-            <a:pPr algn="ctr" indent="0" marL="0">
+            <a:pPr marL="0" indent="0" algn="ctr">
               <a:buNone/>
             </a:pPr>
             <a:r>
@@ -11704,7 +11804,7 @@
           <a:bodyPr wrap="square" lIns="0" tIns="0" rIns="0" bIns="0" rtlCol="0" anchor="ctr"/>
           <a:lstStyle/>
           <a:p>
-            <a:pPr algn="ctr" indent="0" marL="0">
+            <a:pPr marL="0" indent="0" algn="ctr">
               <a:buNone/>
             </a:pPr>
             <a:r>
@@ -11743,6 +11843,13 @@
           </a:solidFill>
           <a:ln/>
         </p:spPr>
+        <p:txBody>
+          <a:bodyPr/>
+          <a:lstStyle/>
+          <a:p>
+            <a:endParaRPr lang="en-US"/>
+          </a:p>
+        </p:txBody>
       </p:sp>
       <p:sp>
         <p:nvSpPr>
@@ -11765,7 +11872,7 @@
           <a:bodyPr wrap="square" lIns="254" tIns="254" rIns="254" bIns="254" rtlCol="0" anchor="ctr"/>
           <a:lstStyle/>
           <a:p>
-            <a:pPr algn="ctr" indent="0" marL="0">
+            <a:pPr marL="0" indent="0" algn="ctr">
               <a:buNone/>
             </a:pPr>
             <a:r>
@@ -11782,7 +11889,7 @@
             <a:endParaRPr lang="en-US" sz="1050" dirty="0"/>
           </a:p>
           <a:p>
-            <a:pPr algn="ctr" indent="0" marL="0">
+            <a:pPr marL="0" indent="0" algn="ctr">
               <a:buNone/>
             </a:pPr>
             <a:r>
@@ -11821,7 +11928,7 @@
           <a:bodyPr wrap="square" lIns="0" tIns="0" rIns="0" bIns="0" rtlCol="0" anchor="ctr"/>
           <a:lstStyle/>
           <a:p>
-            <a:pPr algn="ctr" indent="0" marL="0">
+            <a:pPr marL="0" indent="0" algn="ctr">
               <a:buNone/>
             </a:pPr>
             <a:r>
@@ -11860,6 +11967,13 @@
           </a:solidFill>
           <a:ln/>
         </p:spPr>
+        <p:txBody>
+          <a:bodyPr/>
+          <a:lstStyle/>
+          <a:p>
+            <a:endParaRPr lang="en-US"/>
+          </a:p>
+        </p:txBody>
       </p:sp>
       <p:sp>
         <p:nvSpPr>
@@ -11882,7 +11996,7 @@
           <a:bodyPr wrap="square" lIns="254" tIns="254" rIns="254" bIns="254" rtlCol="0" anchor="ctr"/>
           <a:lstStyle/>
           <a:p>
-            <a:pPr algn="ctr" indent="0" marL="0">
+            <a:pPr marL="0" indent="0" algn="ctr">
               <a:buNone/>
             </a:pPr>
             <a:r>
@@ -11899,7 +12013,7 @@
             <a:endParaRPr lang="en-US" sz="1050" dirty="0"/>
           </a:p>
           <a:p>
-            <a:pPr algn="ctr" indent="0" marL="0">
+            <a:pPr marL="0" indent="0" algn="ctr">
               <a:buNone/>
             </a:pPr>
             <a:r>
@@ -11938,7 +12052,7 @@
           <a:bodyPr wrap="square" lIns="0" tIns="0" rIns="0" bIns="0" rtlCol="0" anchor="ctr"/>
           <a:lstStyle/>
           <a:p>
-            <a:pPr algn="ctr" indent="0" marL="0">
+            <a:pPr marL="0" indent="0" algn="ctr">
               <a:buNone/>
             </a:pPr>
             <a:r>
@@ -11977,6 +12091,13 @@
           </a:solidFill>
           <a:ln/>
         </p:spPr>
+        <p:txBody>
+          <a:bodyPr/>
+          <a:lstStyle/>
+          <a:p>
+            <a:endParaRPr lang="en-US"/>
+          </a:p>
+        </p:txBody>
       </p:sp>
       <p:sp>
         <p:nvSpPr>
@@ -11999,7 +12120,7 @@
           <a:bodyPr wrap="square" lIns="254" tIns="254" rIns="254" bIns="254" rtlCol="0" anchor="ctr"/>
           <a:lstStyle/>
           <a:p>
-            <a:pPr algn="ctr" indent="0" marL="0">
+            <a:pPr marL="0" indent="0" algn="ctr">
               <a:buNone/>
             </a:pPr>
             <a:r>
@@ -12016,7 +12137,7 @@
             <a:endParaRPr lang="en-US" sz="1050" dirty="0"/>
           </a:p>
           <a:p>
-            <a:pPr algn="ctr" indent="0" marL="0">
+            <a:pPr marL="0" indent="0" algn="ctr">
               <a:buNone/>
             </a:pPr>
             <a:r>
@@ -12055,7 +12176,7 @@
           <a:bodyPr wrap="square" lIns="0" tIns="0" rIns="0" bIns="0" rtlCol="0" anchor="t"/>
           <a:lstStyle/>
           <a:p>
-            <a:pPr algn="l" marL="342900" indent="-342900">
+            <a:pPr marL="342900" indent="-342900" algn="l">
               <a:buSzPct val="100000"/>
               <a:buChar char="•"/>
             </a:pPr>
@@ -12070,9 +12191,6 @@
               </a:rPr>
               <a:t>Why this example: </a:t>
             </a:r>
-            <a:pPr algn="l" indent="0" marL="0">
-              <a:buNone/>
-            </a:pPr>
             <a:r>
               <a:rPr lang="en-US" sz="1350" dirty="0">
                 <a:solidFill>
@@ -12109,7 +12227,7 @@
           <a:bodyPr wrap="square" lIns="0" tIns="0" rIns="0" bIns="0" rtlCol="0" anchor="t"/>
           <a:lstStyle/>
           <a:p>
-            <a:pPr algn="l" indent="0" marL="0">
+            <a:pPr marL="0" indent="0" algn="l">
               <a:buNone/>
             </a:pPr>
             <a:r>
@@ -12123,9 +12241,6 @@
               </a:rPr>
               <a:t>Hatcliff &amp; Belt, </a:t>
             </a:r>
-            <a:pPr algn="l" indent="0" marL="0">
-              <a:buNone/>
-            </a:pPr>
             <a:r>
               <a:rPr lang="en-US" sz="850" i="1" dirty="0">
                 <a:solidFill>
@@ -12137,9 +12252,6 @@
               </a:rPr>
               <a:t>The Isolette System: Illustrating End-to-End Artifacts for Rigorous Model-Based Engineering</a:t>
             </a:r>
-            <a:pPr algn="l" indent="0" marL="0">
-              <a:buNone/>
-            </a:pPr>
             <a:r>
               <a:rPr lang="en-US" sz="850" dirty="0">
                 <a:solidFill>
@@ -12154,7 +12266,7 @@
             <a:endParaRPr lang="en-US" sz="850" dirty="0"/>
           </a:p>
           <a:p>
-            <a:pPr algn="l" indent="0" marL="0">
+            <a:pPr marL="0" indent="0" algn="l">
               <a:buNone/>
             </a:pPr>
             <a:r>
@@ -12168,9 +12280,6 @@
               </a:rPr>
               <a:t>Hatcliff, Belt, Robby, McKenzie, Liang, </a:t>
             </a:r>
-            <a:pPr algn="l" indent="0" marL="0">
-              <a:buNone/>
-            </a:pPr>
             <a:r>
               <a:rPr lang="en-US" sz="850" i="1" dirty="0">
                 <a:solidFill>
@@ -12182,9 +12291,6 @@
               </a:rPr>
               <a:t>End-to-End Formal Methods Integrated Development with SysMLv2 Using HAMR</a:t>
             </a:r>
-            <a:pPr algn="l" indent="0" marL="0">
-              <a:buNone/>
-            </a:pPr>
             <a:r>
               <a:rPr lang="en-US" sz="850" dirty="0">
                 <a:solidFill>
@@ -12199,7 +12305,7 @@
             <a:endParaRPr lang="en-US" sz="850" dirty="0"/>
           </a:p>
           <a:p>
-            <a:pPr algn="l" indent="0" marL="0">
+            <a:pPr marL="0" indent="0" algn="l">
               <a:buNone/>
             </a:pPr>
             <a:r>
@@ -12213,9 +12319,6 @@
               </a:rPr>
               <a:t>Hatcliff, Belt, Robby, Carpenter, </a:t>
             </a:r>
-            <a:pPr algn="l" indent="0" marL="0">
-              <a:buNone/>
-            </a:pPr>
             <a:r>
               <a:rPr lang="en-US" sz="850" i="1" dirty="0">
                 <a:solidFill>
@@ -12227,9 +12330,6 @@
               </a:rPr>
               <a:t>HAMR: An AADL Multi-platform Code Generation Toolset</a:t>
             </a:r>
-            <a:pPr algn="l" indent="0" marL="0">
-              <a:buNone/>
-            </a:pPr>
             <a:r>
               <a:rPr lang="en-US" sz="850" dirty="0">
                 <a:solidFill>
@@ -12266,7 +12366,7 @@
           <a:bodyPr wrap="square" lIns="0" tIns="0" rIns="0" bIns="0" rtlCol="0" anchor="ctr"/>
           <a:lstStyle/>
           <a:p>
-            <a:pPr algn="l" indent="0" marL="0">
+            <a:pPr marL="0" indent="0" algn="l">
               <a:buNone/>
             </a:pPr>
             <a:r>
@@ -12310,6 +12410,13 @@
             <a:prstDash val="solid"/>
           </a:ln>
         </p:spPr>
+        <p:txBody>
+          <a:bodyPr/>
+          <a:lstStyle/>
+          <a:p>
+            <a:endParaRPr lang="en-US"/>
+          </a:p>
+        </p:txBody>
       </p:sp>
       <p:sp>
         <p:nvSpPr>
@@ -12332,7 +12439,7 @@
           <a:bodyPr wrap="square" lIns="0" tIns="0" rIns="0" bIns="0" rtlCol="0" anchor="ctr"/>
           <a:lstStyle/>
           <a:p>
-            <a:pPr algn="l" indent="0" marL="0">
+            <a:pPr marL="0" indent="0" algn="l">
               <a:buNone/>
             </a:pPr>
             <a:r>
@@ -12371,7 +12478,7 @@
           <a:bodyPr wrap="square" lIns="0" tIns="0" rIns="0" bIns="0" rtlCol="0" anchor="ctr"/>
           <a:lstStyle/>
           <a:p>
-            <a:pPr algn="l" indent="0" marL="0">
+            <a:pPr marL="0" indent="0" algn="l">
               <a:buNone/>
             </a:pPr>
             <a:r>
@@ -12415,6 +12522,13 @@
             <a:prstDash val="solid"/>
           </a:ln>
         </p:spPr>
+        <p:txBody>
+          <a:bodyPr/>
+          <a:lstStyle/>
+          <a:p>
+            <a:endParaRPr lang="en-US"/>
+          </a:p>
+        </p:txBody>
       </p:sp>
       <p:sp>
         <p:nvSpPr>
@@ -12437,7 +12551,7 @@
           <a:bodyPr wrap="square" lIns="0" tIns="0" rIns="0" bIns="0" rtlCol="0" anchor="ctr"/>
           <a:lstStyle/>
           <a:p>
-            <a:pPr algn="l" indent="0" marL="0">
+            <a:pPr marL="0" indent="0" algn="l">
               <a:buNone/>
             </a:pPr>
             <a:r>
@@ -12476,7 +12590,7 @@
           <a:bodyPr wrap="square" lIns="0" tIns="0" rIns="0" bIns="0" rtlCol="0" anchor="ctr"/>
           <a:lstStyle/>
           <a:p>
-            <a:pPr algn="l" indent="0" marL="0">
+            <a:pPr marL="0" indent="0" algn="l">
               <a:buNone/>
             </a:pPr>
             <a:r>
@@ -12520,6 +12634,13 @@
             <a:prstDash val="solid"/>
           </a:ln>
         </p:spPr>
+        <p:txBody>
+          <a:bodyPr/>
+          <a:lstStyle/>
+          <a:p>
+            <a:endParaRPr lang="en-US"/>
+          </a:p>
+        </p:txBody>
       </p:sp>
       <p:sp>
         <p:nvSpPr>
@@ -12542,7 +12663,7 @@
           <a:bodyPr wrap="square" lIns="0" tIns="0" rIns="0" bIns="0" rtlCol="0" anchor="ctr"/>
           <a:lstStyle/>
           <a:p>
-            <a:pPr algn="l" indent="0" marL="0">
+            <a:pPr marL="0" indent="0" algn="l">
               <a:buNone/>
             </a:pPr>
             <a:r>
@@ -12581,7 +12702,7 @@
           <a:bodyPr wrap="square" lIns="0" tIns="0" rIns="0" bIns="0" rtlCol="0" anchor="ctr"/>
           <a:lstStyle/>
           <a:p>
-            <a:pPr algn="l" indent="0" marL="0">
+            <a:pPr marL="0" indent="0" algn="l">
               <a:buNone/>
             </a:pPr>
             <a:r>
@@ -12625,6 +12746,13 @@
             <a:prstDash val="solid"/>
           </a:ln>
         </p:spPr>
+        <p:txBody>
+          <a:bodyPr/>
+          <a:lstStyle/>
+          <a:p>
+            <a:endParaRPr lang="en-US"/>
+          </a:p>
+        </p:txBody>
       </p:sp>
       <p:sp>
         <p:nvSpPr>
@@ -12647,7 +12775,7 @@
           <a:bodyPr wrap="square" lIns="0" tIns="0" rIns="0" bIns="0" rtlCol="0" anchor="ctr"/>
           <a:lstStyle/>
           <a:p>
-            <a:pPr algn="l" indent="0" marL="0">
+            <a:pPr marL="0" indent="0" algn="l">
               <a:buNone/>
             </a:pPr>
             <a:r>
@@ -12686,7 +12814,7 @@
           <a:bodyPr wrap="square" lIns="0" tIns="0" rIns="0" bIns="0" rtlCol="0" anchor="ctr"/>
           <a:lstStyle/>
           <a:p>
-            <a:pPr algn="l" indent="0" marL="0">
+            <a:pPr marL="0" indent="0" algn="l">
               <a:buNone/>
             </a:pPr>
             <a:r>
@@ -12730,6 +12858,13 @@
             <a:prstDash val="solid"/>
           </a:ln>
         </p:spPr>
+        <p:txBody>
+          <a:bodyPr/>
+          <a:lstStyle/>
+          <a:p>
+            <a:endParaRPr lang="en-US"/>
+          </a:p>
+        </p:txBody>
       </p:sp>
       <p:sp>
         <p:nvSpPr>
@@ -12752,7 +12887,7 @@
           <a:bodyPr wrap="square" lIns="0" tIns="0" rIns="0" bIns="0" rtlCol="0" anchor="ctr"/>
           <a:lstStyle/>
           <a:p>
-            <a:pPr algn="l" indent="0" marL="0">
+            <a:pPr marL="0" indent="0" algn="l">
               <a:buNone/>
             </a:pPr>
             <a:r>
@@ -12791,7 +12926,7 @@
           <a:bodyPr wrap="square" lIns="0" tIns="0" rIns="0" bIns="0" rtlCol="0" anchor="ctr"/>
           <a:lstStyle/>
           <a:p>
-            <a:pPr algn="l" indent="0" marL="0">
+            <a:pPr marL="0" indent="0" algn="l">
               <a:buNone/>
             </a:pPr>
             <a:r>
@@ -12835,6 +12970,13 @@
             <a:prstDash val="solid"/>
           </a:ln>
         </p:spPr>
+        <p:txBody>
+          <a:bodyPr/>
+          <a:lstStyle/>
+          <a:p>
+            <a:endParaRPr lang="en-US"/>
+          </a:p>
+        </p:txBody>
       </p:sp>
       <p:sp>
         <p:nvSpPr>
@@ -12857,7 +12999,7 @@
           <a:bodyPr wrap="square" lIns="0" tIns="0" rIns="0" bIns="0" rtlCol="0" anchor="ctr"/>
           <a:lstStyle/>
           <a:p>
-            <a:pPr algn="l" indent="0" marL="0">
+            <a:pPr marL="0" indent="0" algn="l">
               <a:buNone/>
             </a:pPr>
             <a:r>
@@ -12896,7 +13038,7 @@
           <a:bodyPr wrap="square" lIns="0" tIns="0" rIns="0" bIns="0" rtlCol="0" anchor="ctr"/>
           <a:lstStyle/>
           <a:p>
-            <a:pPr algn="l" indent="0" marL="0">
+            <a:pPr marL="0" indent="0" algn="l">
               <a:buNone/>
             </a:pPr>
             <a:r>
@@ -12913,7 +13055,7 @@
             <a:endParaRPr lang="en-US" sz="1000" dirty="0"/>
           </a:p>
           <a:p>
-            <a:pPr algn="l" indent="0" marL="0">
+            <a:pPr marL="0" indent="0" algn="l">
               <a:buNone/>
             </a:pPr>
             <a:r>
@@ -12947,6 +13089,7 @@
         <a:solidFill>
           <a:srgbClr val="FFFFFF"/>
         </a:solidFill>
+        <a:effectLst/>
       </p:bgPr>
     </p:bg>
     <p:spTree>
@@ -12984,6 +13127,13 @@
           </a:solidFill>
           <a:ln/>
         </p:spPr>
+        <p:txBody>
+          <a:bodyPr/>
+          <a:lstStyle/>
+          <a:p>
+            <a:endParaRPr lang="en-US"/>
+          </a:p>
+        </p:txBody>
       </p:sp>
       <p:sp>
         <p:nvSpPr>
@@ -13006,7 +13156,7 @@
           <a:bodyPr wrap="square" lIns="254" tIns="254" rIns="254" bIns="254" rtlCol="0" anchor="ctr"/>
           <a:lstStyle/>
           <a:p>
-            <a:pPr algn="ctr" indent="0" marL="0">
+            <a:pPr marL="0" indent="0" algn="ctr">
               <a:buNone/>
             </a:pPr>
             <a:r>
@@ -13045,6 +13195,13 @@
           </a:solidFill>
           <a:ln/>
         </p:spPr>
+        <p:txBody>
+          <a:bodyPr/>
+          <a:lstStyle/>
+          <a:p>
+            <a:endParaRPr lang="en-US"/>
+          </a:p>
+        </p:txBody>
       </p:sp>
       <p:sp>
         <p:nvSpPr>
@@ -13067,7 +13224,7 @@
           <a:bodyPr wrap="square" lIns="254" tIns="254" rIns="254" bIns="254" rtlCol="0" anchor="ctr"/>
           <a:lstStyle/>
           <a:p>
-            <a:pPr algn="ctr" indent="0" marL="0">
+            <a:pPr marL="0" indent="0" algn="ctr">
               <a:buNone/>
             </a:pPr>
             <a:r>
@@ -13084,7 +13241,7 @@
             <a:endParaRPr lang="en-US" sz="900" dirty="0"/>
           </a:p>
           <a:p>
-            <a:pPr algn="ctr" indent="0" marL="0">
+            <a:pPr marL="0" indent="0" algn="ctr">
               <a:buNone/>
             </a:pPr>
             <a:r>
@@ -13123,6 +13280,13 @@
           </a:solidFill>
           <a:ln/>
         </p:spPr>
+        <p:txBody>
+          <a:bodyPr/>
+          <a:lstStyle/>
+          <a:p>
+            <a:endParaRPr lang="en-US"/>
+          </a:p>
+        </p:txBody>
       </p:sp>
       <p:sp>
         <p:nvSpPr>
@@ -13145,7 +13309,7 @@
           <a:bodyPr wrap="square" lIns="254" tIns="254" rIns="254" bIns="254" rtlCol="0" anchor="ctr"/>
           <a:lstStyle/>
           <a:p>
-            <a:pPr algn="ctr" indent="0" marL="0">
+            <a:pPr marL="0" indent="0" algn="ctr">
               <a:buNone/>
             </a:pPr>
             <a:r>
@@ -13184,6 +13348,13 @@
           </a:solidFill>
           <a:ln/>
         </p:spPr>
+        <p:txBody>
+          <a:bodyPr/>
+          <a:lstStyle/>
+          <a:p>
+            <a:endParaRPr lang="en-US"/>
+          </a:p>
+        </p:txBody>
       </p:sp>
       <p:sp>
         <p:nvSpPr>
@@ -13206,7 +13377,7 @@
           <a:bodyPr wrap="square" lIns="254" tIns="254" rIns="254" bIns="254" rtlCol="0" anchor="ctr"/>
           <a:lstStyle/>
           <a:p>
-            <a:pPr algn="ctr" indent="0" marL="0">
+            <a:pPr marL="0" indent="0" algn="ctr">
               <a:buNone/>
             </a:pPr>
             <a:r>
@@ -13245,6 +13416,13 @@
           </a:solidFill>
           <a:ln/>
         </p:spPr>
+        <p:txBody>
+          <a:bodyPr/>
+          <a:lstStyle/>
+          <a:p>
+            <a:endParaRPr lang="en-US"/>
+          </a:p>
+        </p:txBody>
       </p:sp>
       <p:sp>
         <p:nvSpPr>
@@ -13267,7 +13445,7 @@
           <a:bodyPr wrap="square" lIns="254" tIns="254" rIns="254" bIns="254" rtlCol="0" anchor="ctr"/>
           <a:lstStyle/>
           <a:p>
-            <a:pPr algn="ctr" indent="0" marL="0">
+            <a:pPr marL="0" indent="0" algn="ctr">
               <a:buNone/>
             </a:pPr>
             <a:r>
@@ -13306,11 +13484,11 @@
           <a:bodyPr wrap="square" lIns="0" tIns="0" rIns="0" bIns="0" rtlCol="0" anchor="ctr"/>
           <a:lstStyle/>
           <a:p>
-            <a:pPr indent="0" marL="0">
-              <a:buNone/>
-            </a:pPr>
-            <a:r>
-              <a:rPr lang="en-US" sz="1800" b="1" spc="300" kern="0" dirty="0">
+            <a:pPr marL="0" indent="0">
+              <a:buNone/>
+            </a:pPr>
+            <a:r>
+              <a:rPr lang="en-US" sz="1800" b="1" kern="0" spc="300" dirty="0">
                 <a:solidFill>
                   <a:srgbClr val="5A6478"/>
                 </a:solidFill>
@@ -13345,7 +13523,7 @@
           <a:bodyPr wrap="square" lIns="0" tIns="0" rIns="0" bIns="0" rtlCol="0" anchor="ctr"/>
           <a:lstStyle/>
           <a:p>
-            <a:pPr indent="0" marL="0">
+            <a:pPr marL="0" indent="0">
               <a:buNone/>
             </a:pPr>
             <a:r>
@@ -13357,7 +13535,7 @@
                 <a:ea typeface="Cambria" pitchFamily="34" charset="-122"/>
                 <a:cs typeface="Cambria" pitchFamily="34" charset="-120"/>
               </a:rPr>
-              <a:t>The honest baseline</a:t>
+              <a:t>The consistent baseline</a:t>
             </a:r>
             <a:endParaRPr lang="en-US" sz="4000" dirty="0"/>
           </a:p>
@@ -13384,7 +13562,7 @@
           <a:bodyPr wrap="square" lIns="0" tIns="0" rIns="0" bIns="0" rtlCol="0" anchor="ctr"/>
           <a:lstStyle/>
           <a:p>
-            <a:pPr indent="0" marL="0">
+            <a:pPr marL="0" indent="0">
               <a:buNone/>
             </a:pPr>
             <a:r>
@@ -13396,7 +13574,7 @@
                 <a:ea typeface="Calibri" pitchFamily="34" charset="-122"/>
                 <a:cs typeface="Calibri" pitchFamily="34" charset="-120"/>
               </a:rPr>
-              <a:t>scene 1</a:t>
+              <a:t>Demo scene:  1 (clean appraisal)</a:t>
             </a:r>
             <a:endParaRPr lang="en-US" sz="1500" dirty="0"/>
           </a:p>
@@ -13423,7 +13601,7 @@
           <a:bodyPr wrap="square" lIns="0" tIns="0" rIns="0" bIns="0" rtlCol="0" anchor="ctr"/>
           <a:lstStyle/>
           <a:p>
-            <a:pPr indent="0" marL="0">
+            <a:pPr marL="0" indent="0">
               <a:buNone/>
             </a:pPr>
             <a:r>
@@ -13435,7 +13613,7 @@
                 <a:ea typeface="Calibri" pitchFamily="34" charset="-122"/>
                 <a:cs typeface="Calibri" pitchFamily="34" charset="-120"/>
               </a:rPr>
-              <a:t>One episode measures every artifact class — watch the checklist go green, and remember what green looks like.</a:t>
+              <a:t>All artifacts start in a “pass” state:  all artifacts have integrity against golden values and implementations meet their contracts.</a:t>
             </a:r>
             <a:endParaRPr lang="en-US" sz="2000" dirty="0"/>
           </a:p>
@@ -13449,8 +13627,8 @@
         </p:nvSpPr>
         <p:spPr>
           <a:xfrm>
-            <a:off x="822960" y="6172200"/>
-            <a:ext cx="10515600" cy="365760"/>
+            <a:off x="822960" y="6053328"/>
+            <a:ext cx="10515600" cy="603504"/>
           </a:xfrm>
           <a:prstGeom prst="rect">
             <a:avLst/>
@@ -13462,7 +13640,7 @@
           <a:bodyPr wrap="square" lIns="0" tIns="0" rIns="0" bIns="0" rtlCol="0" anchor="ctr"/>
           <a:lstStyle/>
           <a:p>
-            <a:pPr indent="0" marL="0">
+            <a:pPr marL="0" indent="0">
               <a:buNone/>
             </a:pPr>
             <a:r>
@@ -13781,4 +13959,319 @@
     </a:ext>
   </a:extLst>
 </a:theme>
+</file>
+
+<file path=ppt/theme/theme2.xml><?xml version="1.0" encoding="utf-8"?>
+<a:theme xmlns:a="http://schemas.openxmlformats.org/drawingml/2006/main" name="Office Theme">
+  <a:themeElements>
+    <a:clrScheme name="Office">
+      <a:dk1>
+        <a:sysClr val="windowText" lastClr="000000"/>
+      </a:dk1>
+      <a:lt1>
+        <a:sysClr val="window" lastClr="FFFFFF"/>
+      </a:lt1>
+      <a:dk2>
+        <a:srgbClr val="0E2841"/>
+      </a:dk2>
+      <a:lt2>
+        <a:srgbClr val="E8E8E8"/>
+      </a:lt2>
+      <a:accent1>
+        <a:srgbClr val="156082"/>
+      </a:accent1>
+      <a:accent2>
+        <a:srgbClr val="E97132"/>
+      </a:accent2>
+      <a:accent3>
+        <a:srgbClr val="196B24"/>
+      </a:accent3>
+      <a:accent4>
+        <a:srgbClr val="0F9ED5"/>
+      </a:accent4>
+      <a:accent5>
+        <a:srgbClr val="A02B93"/>
+      </a:accent5>
+      <a:accent6>
+        <a:srgbClr val="4EA72E"/>
+      </a:accent6>
+      <a:hlink>
+        <a:srgbClr val="467886"/>
+      </a:hlink>
+      <a:folHlink>
+        <a:srgbClr val="96607D"/>
+      </a:folHlink>
+    </a:clrScheme>
+    <a:fontScheme name="Office">
+      <a:majorFont>
+        <a:latin typeface="Aptos Display" panose="02110004020202020204"/>
+        <a:ea typeface=""/>
+        <a:cs typeface=""/>
+        <a:font script="Jpan" typeface="游ゴシック Light"/>
+        <a:font script="Hang" typeface="맑은 고딕"/>
+        <a:font script="Hans" typeface="等线 Light"/>
+        <a:font script="Hant" typeface="新細明體"/>
+        <a:font script="Arab" typeface="Times New Roman"/>
+        <a:font script="Hebr" typeface="Times New Roman"/>
+        <a:font script="Thai" typeface="Angsana New"/>
+        <a:font script="Ethi" typeface="Nyala"/>
+        <a:font script="Beng" typeface="Vrinda"/>
+        <a:font script="Gujr" typeface="Shruti"/>
+        <a:font script="Khmr" typeface="MoolBoran"/>
+        <a:font script="Knda" typeface="Tunga"/>
+        <a:font script="Guru" typeface="Raavi"/>
+        <a:font script="Cans" typeface="Euphemia"/>
+        <a:font script="Cher" typeface="Plantagenet Cherokee"/>
+        <a:font script="Yiii" typeface="Microsoft Yi Baiti"/>
+        <a:font script="Tibt" typeface="Microsoft Himalaya"/>
+        <a:font script="Thaa" typeface="MV Boli"/>
+        <a:font script="Deva" typeface="Mangal"/>
+        <a:font script="Telu" typeface="Gautami"/>
+        <a:font script="Taml" typeface="Latha"/>
+        <a:font script="Syrc" typeface="Estrangelo Edessa"/>
+        <a:font script="Orya" typeface="Kalinga"/>
+        <a:font script="Mlym" typeface="Kartika"/>
+        <a:font script="Laoo" typeface="DokChampa"/>
+        <a:font script="Sinh" typeface="Iskoola Pota"/>
+        <a:font script="Mong" typeface="Mongolian Baiti"/>
+        <a:font script="Viet" typeface="Times New Roman"/>
+        <a:font script="Uigh" typeface="Microsoft Uighur"/>
+        <a:font script="Geor" typeface="Sylfaen"/>
+        <a:font script="Armn" typeface="Arial"/>
+        <a:font script="Bugi" typeface="Leelawadee UI"/>
+        <a:font script="Bopo" typeface="Microsoft JhengHei"/>
+        <a:font script="Java" typeface="Javanese Text"/>
+        <a:font script="Lisu" typeface="Segoe UI"/>
+        <a:font script="Mymr" typeface="Myanmar Text"/>
+        <a:font script="Nkoo" typeface="Ebrima"/>
+        <a:font script="Olck" typeface="Nirmala UI"/>
+        <a:font script="Osma" typeface="Ebrima"/>
+        <a:font script="Phag" typeface="Phagspa"/>
+        <a:font script="Syrn" typeface="Estrangelo Edessa"/>
+        <a:font script="Syrj" typeface="Estrangelo Edessa"/>
+        <a:font script="Syre" typeface="Estrangelo Edessa"/>
+        <a:font script="Sora" typeface="Nirmala UI"/>
+        <a:font script="Tale" typeface="Microsoft Tai Le"/>
+        <a:font script="Talu" typeface="Microsoft New Tai Lue"/>
+        <a:font script="Tfng" typeface="Ebrima"/>
+      </a:majorFont>
+      <a:minorFont>
+        <a:latin typeface="Aptos" panose="02110004020202020204"/>
+        <a:ea typeface=""/>
+        <a:cs typeface=""/>
+        <a:font script="Jpan" typeface="游ゴシック"/>
+        <a:font script="Hang" typeface="맑은 고딕"/>
+        <a:font script="Hans" typeface="等线"/>
+        <a:font script="Hant" typeface="新細明體"/>
+        <a:font script="Arab" typeface="Arial"/>
+        <a:font script="Hebr" typeface="Arial"/>
+        <a:font script="Thai" typeface="Cordia New"/>
+        <a:font script="Ethi" typeface="Nyala"/>
+        <a:font script="Beng" typeface="Vrinda"/>
+        <a:font script="Gujr" typeface="Shruti"/>
+        <a:font script="Khmr" typeface="DaunPenh"/>
+        <a:font script="Knda" typeface="Tunga"/>
+        <a:font script="Guru" typeface="Raavi"/>
+        <a:font script="Cans" typeface="Euphemia"/>
+        <a:font script="Cher" typeface="Plantagenet Cherokee"/>
+        <a:font script="Yiii" typeface="Microsoft Yi Baiti"/>
+        <a:font script="Tibt" typeface="Microsoft Himalaya"/>
+        <a:font script="Thaa" typeface="MV Boli"/>
+        <a:font script="Deva" typeface="Mangal"/>
+        <a:font script="Telu" typeface="Gautami"/>
+        <a:font script="Taml" typeface="Latha"/>
+        <a:font script="Syrc" typeface="Estrangelo Edessa"/>
+        <a:font script="Orya" typeface="Kalinga"/>
+        <a:font script="Mlym" typeface="Kartika"/>
+        <a:font script="Laoo" typeface="DokChampa"/>
+        <a:font script="Sinh" typeface="Iskoola Pota"/>
+        <a:font script="Mong" typeface="Mongolian Baiti"/>
+        <a:font script="Viet" typeface="Arial"/>
+        <a:font script="Uigh" typeface="Microsoft Uighur"/>
+        <a:font script="Geor" typeface="Sylfaen"/>
+        <a:font script="Armn" typeface="Arial"/>
+        <a:font script="Bugi" typeface="Leelawadee UI"/>
+        <a:font script="Bopo" typeface="Microsoft JhengHei"/>
+        <a:font script="Java" typeface="Javanese Text"/>
+        <a:font script="Lisu" typeface="Segoe UI"/>
+        <a:font script="Mymr" typeface="Myanmar Text"/>
+        <a:font script="Nkoo" typeface="Ebrima"/>
+        <a:font script="Olck" typeface="Nirmala UI"/>
+        <a:font script="Osma" typeface="Ebrima"/>
+        <a:font script="Phag" typeface="Phagspa"/>
+        <a:font script="Syrn" typeface="Estrangelo Edessa"/>
+        <a:font script="Syrj" typeface="Estrangelo Edessa"/>
+        <a:font script="Syre" typeface="Estrangelo Edessa"/>
+        <a:font script="Sora" typeface="Nirmala UI"/>
+        <a:font script="Tale" typeface="Microsoft Tai Le"/>
+        <a:font script="Talu" typeface="Microsoft New Tai Lue"/>
+        <a:font script="Tfng" typeface="Ebrima"/>
+      </a:minorFont>
+    </a:fontScheme>
+    <a:fmtScheme name="Office">
+      <a:fillStyleLst>
+        <a:solidFill>
+          <a:schemeClr val="phClr"/>
+        </a:solidFill>
+        <a:gradFill rotWithShape="1">
+          <a:gsLst>
+            <a:gs pos="0">
+              <a:schemeClr val="phClr">
+                <a:lumMod val="110000"/>
+                <a:satMod val="105000"/>
+                <a:tint val="67000"/>
+              </a:schemeClr>
+            </a:gs>
+            <a:gs pos="50000">
+              <a:schemeClr val="phClr">
+                <a:lumMod val="105000"/>
+                <a:satMod val="103000"/>
+                <a:tint val="73000"/>
+              </a:schemeClr>
+            </a:gs>
+            <a:gs pos="100000">
+              <a:schemeClr val="phClr">
+                <a:lumMod val="105000"/>
+                <a:satMod val="109000"/>
+                <a:tint val="81000"/>
+              </a:schemeClr>
+            </a:gs>
+          </a:gsLst>
+          <a:lin ang="5400000" scaled="0"/>
+        </a:gradFill>
+        <a:gradFill rotWithShape="1">
+          <a:gsLst>
+            <a:gs pos="0">
+              <a:schemeClr val="phClr">
+                <a:satMod val="103000"/>
+                <a:lumMod val="102000"/>
+                <a:tint val="94000"/>
+              </a:schemeClr>
+            </a:gs>
+            <a:gs pos="50000">
+              <a:schemeClr val="phClr">
+                <a:satMod val="110000"/>
+                <a:lumMod val="100000"/>
+                <a:shade val="100000"/>
+              </a:schemeClr>
+            </a:gs>
+            <a:gs pos="100000">
+              <a:schemeClr val="phClr">
+                <a:lumMod val="99000"/>
+                <a:satMod val="120000"/>
+                <a:shade val="78000"/>
+              </a:schemeClr>
+            </a:gs>
+          </a:gsLst>
+          <a:lin ang="5400000" scaled="0"/>
+        </a:gradFill>
+      </a:fillStyleLst>
+      <a:lnStyleLst>
+        <a:ln w="12700" cap="flat" cmpd="sng" algn="ctr">
+          <a:solidFill>
+            <a:schemeClr val="phClr"/>
+          </a:solidFill>
+          <a:prstDash val="solid"/>
+          <a:miter lim="800000"/>
+        </a:ln>
+        <a:ln w="19050" cap="flat" cmpd="sng" algn="ctr">
+          <a:solidFill>
+            <a:schemeClr val="phClr"/>
+          </a:solidFill>
+          <a:prstDash val="solid"/>
+          <a:miter lim="800000"/>
+        </a:ln>
+        <a:ln w="25400" cap="flat" cmpd="sng" algn="ctr">
+          <a:solidFill>
+            <a:schemeClr val="phClr"/>
+          </a:solidFill>
+          <a:prstDash val="solid"/>
+          <a:miter lim="800000"/>
+        </a:ln>
+      </a:lnStyleLst>
+      <a:effectStyleLst>
+        <a:effectStyle>
+          <a:effectLst/>
+        </a:effectStyle>
+        <a:effectStyle>
+          <a:effectLst/>
+        </a:effectStyle>
+        <a:effectStyle>
+          <a:effectLst>
+            <a:outerShdw blurRad="57150" dist="19050" dir="5400000" algn="ctr" rotWithShape="0">
+              <a:srgbClr val="000000">
+                <a:alpha val="63000"/>
+              </a:srgbClr>
+            </a:outerShdw>
+          </a:effectLst>
+        </a:effectStyle>
+      </a:effectStyleLst>
+      <a:bgFillStyleLst>
+        <a:solidFill>
+          <a:schemeClr val="phClr"/>
+        </a:solidFill>
+        <a:solidFill>
+          <a:schemeClr val="phClr">
+            <a:tint val="95000"/>
+            <a:satMod val="170000"/>
+          </a:schemeClr>
+        </a:solidFill>
+        <a:gradFill rotWithShape="1">
+          <a:gsLst>
+            <a:gs pos="0">
+              <a:schemeClr val="phClr">
+                <a:tint val="93000"/>
+                <a:satMod val="150000"/>
+                <a:shade val="98000"/>
+                <a:lumMod val="102000"/>
+              </a:schemeClr>
+            </a:gs>
+            <a:gs pos="50000">
+              <a:schemeClr val="phClr">
+                <a:tint val="98000"/>
+                <a:satMod val="130000"/>
+                <a:shade val="90000"/>
+                <a:lumMod val="103000"/>
+              </a:schemeClr>
+            </a:gs>
+            <a:gs pos="100000">
+              <a:schemeClr val="phClr">
+                <a:shade val="63000"/>
+                <a:satMod val="120000"/>
+              </a:schemeClr>
+            </a:gs>
+          </a:gsLst>
+          <a:lin ang="5400000" scaled="0"/>
+        </a:gradFill>
+      </a:bgFillStyleLst>
+    </a:fmtScheme>
+  </a:themeElements>
+  <a:objectDefaults>
+    <a:lnDef>
+      <a:spPr/>
+      <a:bodyPr/>
+      <a:lstStyle/>
+      <a:style>
+        <a:lnRef idx="2">
+          <a:schemeClr val="accent1"/>
+        </a:lnRef>
+        <a:fillRef idx="0">
+          <a:schemeClr val="accent1"/>
+        </a:fillRef>
+        <a:effectRef idx="1">
+          <a:schemeClr val="accent1"/>
+        </a:effectRef>
+        <a:fontRef idx="minor">
+          <a:schemeClr val="tx1"/>
+        </a:fontRef>
+      </a:style>
+    </a:lnDef>
+  </a:objectDefaults>
+  <a:extraClrSchemeLst/>
+  <a:extLst>
+    <a:ext uri="{05A4C25C-085E-4340-85A3-A5531E510DB2}">
+      <thm15:themeFamily xmlns:thm15="http://schemas.microsoft.com/office/thememl/2012/main" name="Office Theme" id="{2E142A2C-CD16-42D6-873A-C26D2A0506FA}" vid="{1BDDFF52-6CD6-40A5-AB3C-68EB2F1E4D0A}"/>
+    </a:ext>
+  </a:extLst>
+</a:theme>
 </file>
</xml_diff>

<commit_message>
Act VII absorbs scene 9: axioms (cheat scan) then FFI (byte anchor)
Act VII grows from scene 12 to scenes 9 + 12 — a three-detector
escalation closing the demo: beat 1 (scene 9 axioms) shows the verus
grid all green beside the proof-escape grid naming the drifted
construct (ADMIT assume 0->1; SMUGGLE broadcast 0->1), the cheat scan
catching what the outcome cannot; beat 2 (scene 12 FFI) adds no
construct, so only the gensrc byte anchor refuses. Deck Act VII slide
(scenes tag, watch-for, invocation --scenes "9 12", notes) + outline,
drafts table, and recording plan synced; 8->9 captured scenes, timings
rebudgeted (Act VII 2.75, section ~14, total ~24).

Co-Authored-By: Claude Fable 5 <noreply@anthropic.com>
</commit_message>
<xml_diff>
--- a/docs/video_slides_draft.pptx
+++ b/docs/video_slides_draft.pptx
@@ -1050,7 +1050,7 @@
           <a:p>
             <a:r>
               <a:rPr lang="en-US" dirty="0"/>
-              <a:t>Beats: inverted-FFI diff (take the [v]iew, diff D18 - 'see how innocent it looks') -&gt; proofs pass, cheat scan silent -&gt; gensrc byte anchor refuses, naming the file -&gt; diagnosis rung classifies -&gt; repair by regeneration (second speed-ramp stretch) -&gt; re-attested clean. Final checklist doubles as the coverage beat's background; close with one sentence naming scenes 9-11 (capstone slide C carries that taxonomy).
+              <a:t>The detector escalation that closes the demo. BEAT 1 (scene 9, axioms): two-grid view - the verus grid all green (cargo-verus succeeds) beside the proof-escape grid refusing the exact crate and naming the construct (ADMIT: assume 0-&gt;1; SMUGGLE: broadcast 0-&gt;1, external_body 0-&gt;1). The CHEAT SCAN catches what the outcome cannot - a construct appeared. BEAT 2 (scene 12, FFI): the heat command inverted behind external_body (diff D18) -&gt; every proof passes AND the cheat scan is SILENT (no construct) -&gt; only the GENSRC byte anchor refuses, naming the file -&gt; diagnosis rung classifies -&gt; repair by regeneration (speed-ramp). Three detectors, three blind spots: outcome (blind to both), construct scan (catches beat 1), byte anchor (catches beat 2). Close naming scenes 10-11 (slide C carries the rest).
 Watch-for line doubles as the VO opener over the terminal cut. Full runbook: docs/video_recording_plan.md.</a:t>
             </a:r>
             <a:endParaRPr lang="en-US" dirty="0"/>
@@ -5649,7 +5649,7 @@
                 <a:ea typeface="Calibri" pitchFamily="34" charset="-122"/>
                 <a:cs typeface="Calibri" pitchFamily="34" charset="-120"/>
               </a:rPr>
-              <a:t>scene 12</a:t>
+              <a:t>scenes 9 + 12</a:t>
             </a:r>
             <a:endParaRPr lang="en-US" sz="1500" dirty="0"/>
           </a:p>
@@ -5688,7 +5688,7 @@
                 <a:ea typeface="Calibri" pitchFamily="34" charset="-122"/>
                 <a:cs typeface="Calibri" pitchFamily="34" charset="-120"/>
               </a:rPr>
-              <a:t>Every proof passes, every scan is silent — the heat command is inverted anyway. Only the bytes tell.</a:t>
+              <a:t>Two proofs that pass. First an axiom the cheat scan catches by its construct; then an FFI inversion that adds no construct at all — only the byte anchor sees it. Verification succeeded both times.</a:t>
             </a:r>
             <a:endParaRPr lang="en-US" sz="2000" dirty="0"/>
           </a:p>
@@ -5727,7 +5727,7 @@
                 <a:ea typeface="Courier New" pitchFamily="34" charset="-122"/>
                 <a:cs typeface="Courier New" pitchFamily="34" charset="-120"/>
               </a:rPr>
-              <a:t>./examples/demo_isolette.sh --scenes 12</a:t>
+              <a:t>./examples/demo_isolette.sh --scenes "9 12"</a:t>
             </a:r>
             <a:endParaRPr lang="en-US" sz="1100" dirty="0"/>
           </a:p>

</xml_diff>

<commit_message>
act slides: retitle VI (trust) and VII (verification soundness)
VI: "Trust-anchor tamper: attribute then refuse" (two-verb active,
covering baselines + tool). VII: "Verification soundness" with caption
"Proofs verify, but measurement detects unsound axioms." Deck, drafts
table, and outline headers synced; fixed a stale capture count
(eight -> nine, scene 9 was absorbed into Act VII).

Co-Authored-By: Claude Fable 5 <noreply@anthropic.com>
</commit_message>
<xml_diff>
--- a/docs/video_slides_draft.pptx
+++ b/docs/video_slides_draft.pptx
@@ -5061,7 +5061,7 @@
                 <a:ea typeface="Cambria" pitchFamily="34" charset="-122"/>
                 <a:cs typeface="Cambria" pitchFamily="34" charset="-120"/>
               </a:rPr>
-              <a:t>Trust-state tamper: refuse</a:t>
+              <a:t>Trust-anchor tamper: attribute then refuse</a:t>
             </a:r>
             <a:endParaRPr lang="en-US" sz="4000" dirty="0"/>
           </a:p>
@@ -5139,7 +5139,7 @@
                 <a:ea typeface="Calibri" pitchFamily="34" charset="-122"/>
                 <a:cs typeface="Calibri" pitchFamily="34" charset="-120"/>
               </a:rPr>
-              <a:t>Three tampers with the trust state, three attributed refusals — then a tampered tool, and every proof cell poisons fail-closed. Nothing repairs a baseline.</a:t>
+              <a:t>The signed evidence, an installed golden, then the verifier itself — each tamper attributed, each refused. No knowledge source repairs a trust anchor.</a:t>
             </a:r>
             <a:endParaRPr lang="en-US" sz="2000" dirty="0"/>
           </a:p>
@@ -5610,7 +5610,7 @@
                 <a:ea typeface="Cambria" pitchFamily="34" charset="-122"/>
                 <a:cs typeface="Cambria" pitchFamily="34" charset="-120"/>
               </a:rPr>
-              <a:t>“Verification succeeded” is not enough</a:t>
+              <a:t>Verification soundness</a:t>
             </a:r>
             <a:endParaRPr lang="en-US" sz="4000" dirty="0"/>
           </a:p>
@@ -5688,7 +5688,7 @@
                 <a:ea typeface="Calibri" pitchFamily="34" charset="-122"/>
                 <a:cs typeface="Calibri" pitchFamily="34" charset="-120"/>
               </a:rPr>
-              <a:t>Two proofs that pass. First an axiom the cheat scan catches by its construct; then an FFI inversion that adds no construct at all — only the byte anchor sees it. Verification succeeded both times.</a:t>
+              <a:t>Proofs verify, but measurement detects unsound axioms.</a:t>
             </a:r>
             <a:endParaRPr lang="en-US" sz="2000" dirty="0"/>
           </a:p>

</xml_diff>

<commit_message>
act slides: port manual deck edits (drift-scheme titles + captions)
User reworked the act titles into a consistent "<subject> drift:"
scheme and refined captions: VI -> "Baseline drift: tampered evidence
bundle, protocol, tooling", VII -> "Axiom drift: semantic measurement
detects axioms and unsound proof techniques"; caption edits on II
(drop "promotes"), III/V/VII (bold emphasis), IV (rewritten tail:
"Contract repair ... exposes the verification failure"). Ported
verbatim into the generator (run-level bold/italic preserved); drafts
table and outline headers synced.

Co-Authored-By: Claude Fable 5 <noreply@anthropic.com>
</commit_message>
<xml_diff>
--- a/docs/video_slides_draft.pptx
+++ b/docs/video_slides_draft.pptx
@@ -2859,7 +2859,7 @@
                 <a:ea typeface="Calibri" pitchFamily="34" charset="-122"/>
                 <a:cs typeface="Calibri" pitchFamily="34" charset="-120"/>
               </a:rPr>
-              <a:t>A benign change in requirements — the temperature alarm range widened — model appraisal fails quickly.  Administrator re-blesses and promotes new spec, all contract appraisals again pass.</a:t>
+              <a:t>A benign change in requirements — the temperature alarm range widened — model appraisal fails quickly.  Administrator re-blesses new spec, all contract appraisals again pass.</a:t>
             </a:r>
             <a:endParaRPr lang="en-US" sz="2000" dirty="0"/>
           </a:p>
@@ -3408,7 +3408,35 @@
                 <a:ea typeface="Calibri" pitchFamily="34" charset="-122"/>
                 <a:cs typeface="Calibri" pitchFamily="34" charset="-120"/>
               </a:rPr>
-              <a:t>A developer rewrites implementation logic — semantically equivalent. The hash moves, but every contract slice maintains integrity, and the proofs re-verify: the benign change survives.</a:t>
+              <a:t>A developer rewrites implementation logic — semantically equivalent. The hash moves, but </a:t>
+            </a:r>
+            <a:pPr indent="0" marL="0">
+              <a:buNone/>
+            </a:pPr>
+            <a:r>
+              <a:rPr lang="en-US" sz="2000" b="1" i="1" dirty="0">
+                <a:solidFill>
+                  <a:srgbClr val="212121"/>
+                </a:solidFill>
+                <a:latin typeface="Calibri" pitchFamily="34" charset="0"/>
+                <a:ea typeface="Calibri" pitchFamily="34" charset="-122"/>
+                <a:cs typeface="Calibri" pitchFamily="34" charset="-120"/>
+              </a:rPr>
+              <a:t>every contract slice maintains integrity</a:t>
+            </a:r>
+            <a:pPr indent="0" marL="0">
+              <a:buNone/>
+            </a:pPr>
+            <a:r>
+              <a:rPr lang="en-US" sz="2000" i="1" dirty="0">
+                <a:solidFill>
+                  <a:srgbClr val="212121"/>
+                </a:solidFill>
+                <a:latin typeface="Calibri" pitchFamily="34" charset="0"/>
+                <a:ea typeface="Calibri" pitchFamily="34" charset="-122"/>
+                <a:cs typeface="Calibri" pitchFamily="34" charset="-120"/>
+              </a:rPr>
+              <a:t>, and the proofs re-verify: the benign change survives.</a:t>
             </a:r>
             <a:endParaRPr lang="en-US" sz="2000" dirty="0"/>
           </a:p>
@@ -3971,13 +3999,13 @@
                 <a:ea typeface="Calibri" pitchFamily="34" charset="-122"/>
                 <a:cs typeface="Calibri" pitchFamily="34" charset="-120"/>
               </a:rPr>
-              <a:t>after </a:t>
+              <a:t>after codegen, but before verification</a:t>
             </a:r>
             <a:pPr indent="0" marL="0">
               <a:buNone/>
             </a:pPr>
             <a:r>
-              <a:rPr lang="en-US" sz="2000" b="1" i="1" dirty="0">
+              <a:rPr lang="en-US" sz="2000" i="1" dirty="0">
                 <a:solidFill>
                   <a:srgbClr val="212121"/>
                 </a:solidFill>
@@ -3985,63 +4013,7 @@
                 <a:ea typeface="Calibri" pitchFamily="34" charset="-122"/>
                 <a:cs typeface="Calibri" pitchFamily="34" charset="-120"/>
               </a:rPr>
-              <a:t>codegen</a:t>
-            </a:r>
-            <a:pPr indent="0" marL="0">
-              <a:buNone/>
-            </a:pPr>
-            <a:r>
-              <a:rPr lang="en-US" sz="2000" b="1" i="1" dirty="0">
-                <a:solidFill>
-                  <a:srgbClr val="212121"/>
-                </a:solidFill>
-                <a:latin typeface="Calibri" pitchFamily="34" charset="0"/>
-                <a:ea typeface="Calibri" pitchFamily="34" charset="-122"/>
-                <a:cs typeface="Calibri" pitchFamily="34" charset="-120"/>
-              </a:rPr>
-              <a:t>, but before verification</a:t>
-            </a:r>
-            <a:pPr indent="0" marL="0">
-              <a:buNone/>
-            </a:pPr>
-            <a:r>
-              <a:rPr lang="en-US" sz="2000" i="1" dirty="0">
-                <a:solidFill>
-                  <a:srgbClr val="212121"/>
-                </a:solidFill>
-                <a:latin typeface="Calibri" pitchFamily="34" charset="0"/>
-                <a:ea typeface="Calibri" pitchFamily="34" charset="-122"/>
-                <a:cs typeface="Calibri" pitchFamily="34" charset="-120"/>
-              </a:rPr>
-              <a:t>) and the code is inverted to match — </a:t>
-            </a:r>
-            <a:pPr indent="0" marL="0">
-              <a:buNone/>
-            </a:pPr>
-            <a:r>
-              <a:rPr lang="en-US" sz="2000" i="1" dirty="0">
-                <a:solidFill>
-                  <a:srgbClr val="212121"/>
-                </a:solidFill>
-                <a:latin typeface="Calibri" pitchFamily="34" charset="0"/>
-                <a:ea typeface="Calibri" pitchFamily="34" charset="-122"/>
-                <a:cs typeface="Calibri" pitchFamily="34" charset="-120"/>
-              </a:rPr>
-              <a:t>verus</a:t>
-            </a:r>
-            <a:pPr indent="0" marL="0">
-              <a:buNone/>
-            </a:pPr>
-            <a:r>
-              <a:rPr lang="en-US" sz="2000" i="1" dirty="0">
-                <a:solidFill>
-                  <a:srgbClr val="212121"/>
-                </a:solidFill>
-                <a:latin typeface="Calibri" pitchFamily="34" charset="0"/>
-                <a:ea typeface="Calibri" pitchFamily="34" charset="-122"/>
-                <a:cs typeface="Calibri" pitchFamily="34" charset="-120"/>
-              </a:rPr>
-              <a:t> checks pass.  Only the contract tier sees the drift; restoring the true contract exposes the Verus refusal the laundering hid.</a:t>
+              <a:t>) and the code is inverted to match — verus checks pass.  Contract repair (restoring the true Verus contract) exposes the verification failure.</a:t>
             </a:r>
             <a:endParaRPr lang="en-US" sz="2000" dirty="0"/>
           </a:p>
@@ -4590,7 +4562,35 @@
                 <a:ea typeface="Calibri" pitchFamily="34" charset="-122"/>
                 <a:cs typeface="Calibri" pitchFamily="34" charset="-120"/>
               </a:rPr>
-              <a:t>The ladder diagnoses by exhaustion — watch it repair the right artifact, and watch standing return only by re-measurement.</a:t>
+              <a:t>Implementation code (developer-owned) changes, breaking a Verus contract.  Blackboard loop diagnoses, repairs (simulated for demo), then </a:t>
+            </a:r>
+            <a:pPr indent="0" marL="0">
+              <a:buNone/>
+            </a:pPr>
+            <a:r>
+              <a:rPr lang="en-US" sz="2000" b="1" i="1" dirty="0">
+                <a:solidFill>
+                  <a:srgbClr val="212121"/>
+                </a:solidFill>
+                <a:latin typeface="Calibri" pitchFamily="34" charset="0"/>
+                <a:ea typeface="Calibri" pitchFamily="34" charset="-122"/>
+                <a:cs typeface="Calibri" pitchFamily="34" charset="-120"/>
+              </a:rPr>
+              <a:t>returns the artifact to good standing only by re-measurement</a:t>
+            </a:r>
+            <a:pPr indent="0" marL="0">
+              <a:buNone/>
+            </a:pPr>
+            <a:r>
+              <a:rPr lang="en-US" sz="2000" i="1" dirty="0">
+                <a:solidFill>
+                  <a:srgbClr val="212121"/>
+                </a:solidFill>
+                <a:latin typeface="Calibri" pitchFamily="34" charset="0"/>
+                <a:ea typeface="Calibri" pitchFamily="34" charset="-122"/>
+                <a:cs typeface="Calibri" pitchFamily="34" charset="-120"/>
+              </a:rPr>
+              <a:t>.</a:t>
             </a:r>
             <a:endParaRPr lang="en-US" sz="2000" dirty="0"/>
           </a:p>
@@ -5061,7 +5061,7 @@
                 <a:ea typeface="Cambria" pitchFamily="34" charset="-122"/>
                 <a:cs typeface="Cambria" pitchFamily="34" charset="-120"/>
               </a:rPr>
-              <a:t>Trust-anchor tamper: attribute then refuse</a:t>
+              <a:t>Baseline drift:  tampered evidence bundle, protocol, tooling</a:t>
             </a:r>
             <a:endParaRPr lang="en-US" sz="4000" dirty="0"/>
           </a:p>
@@ -5139,7 +5139,7 @@
                 <a:ea typeface="Calibri" pitchFamily="34" charset="-122"/>
                 <a:cs typeface="Calibri" pitchFamily="34" charset="-120"/>
               </a:rPr>
-              <a:t>The signed evidence, an installed golden, then the verifier itself — each tamper attributed, each refused. No knowledge source repairs a trust anchor.</a:t>
+              <a:t>The signed golden evidence bundle, an installed golden value in the protocol ASP ARGS, then the verifier itself — each tamper attributed, each refused by cryptographic checks.</a:t>
             </a:r>
             <a:endParaRPr lang="en-US" sz="2000" dirty="0"/>
           </a:p>
@@ -5610,7 +5610,7 @@
                 <a:ea typeface="Cambria" pitchFamily="34" charset="-122"/>
                 <a:cs typeface="Cambria" pitchFamily="34" charset="-120"/>
               </a:rPr>
-              <a:t>Verification soundness</a:t>
+              <a:t>Axiom drift:  semantic measurement detects axioms and unsound proof techniques</a:t>
             </a:r>
             <a:endParaRPr lang="en-US" sz="4000" dirty="0"/>
           </a:p>
@@ -5688,7 +5688,35 @@
                 <a:ea typeface="Calibri" pitchFamily="34" charset="-122"/>
                 <a:cs typeface="Calibri" pitchFamily="34" charset="-120"/>
               </a:rPr>
-              <a:t>Proofs verify, but measurement detects unsound axioms.</a:t>
+              <a:t>Proofs verify, but measurement detects </a:t>
+            </a:r>
+            <a:pPr indent="0" marL="0">
+              <a:buNone/>
+            </a:pPr>
+            <a:r>
+              <a:rPr lang="en-US" sz="2000" b="1" i="1" dirty="0">
+                <a:solidFill>
+                  <a:srgbClr val="212121"/>
+                </a:solidFill>
+                <a:latin typeface="Calibri" pitchFamily="34" charset="0"/>
+                <a:ea typeface="Calibri" pitchFamily="34" charset="-122"/>
+                <a:cs typeface="Calibri" pitchFamily="34" charset="-120"/>
+              </a:rPr>
+              <a:t>subtle ways that proof attempts cheat </a:t>
+            </a:r>
+            <a:pPr indent="0" marL="0">
+              <a:buNone/>
+            </a:pPr>
+            <a:r>
+              <a:rPr lang="en-US" sz="2000" i="1" dirty="0">
+                <a:solidFill>
+                  <a:srgbClr val="212121"/>
+                </a:solidFill>
+                <a:latin typeface="Calibri" pitchFamily="34" charset="0"/>
+                <a:ea typeface="Calibri" pitchFamily="34" charset="-122"/>
+                <a:cs typeface="Calibri" pitchFamily="34" charset="-120"/>
+              </a:rPr>
+              <a:t>to undermine verification soundness.</a:t>
             </a:r>
             <a:endParaRPr lang="en-US" sz="2000" dirty="0"/>
           </a:p>

</xml_diff>

<commit_message>
ecosystems slide: one blackboard, many artifact pipelines
High-level breadth slide (deck 16, before References): a one-line
invariant-core thesis + four pipeline chip-rows - the isolette
reference (SysML->HAMR->Verus/Rust->seL4, highlighted) beside AADL->
Slang/JVM, Lean (blessed statements), and Rocq (proof synthesis), each
with its example systems named. Repair-strategy footer deliberately
cut (lands in the capstone). Two frontends, four prover/target stacks,
all real in the repo.

Co-Authored-By: Claude Fable 5 <noreply@anthropic.com>
</commit_message>
<xml_diff>
--- a/docs/video_slides_draft.pptx
+++ b/docs/video_slides_draft.pptx
@@ -21,9 +21,10 @@
     <p:sldId id="269" r:id="rId15"/>
     <p:sldId id="270" r:id="rId16"/>
     <p:sldId id="271" r:id="rId17"/>
+    <p:sldId id="272" r:id="rId18"/>
   </p:sldIdLst>
   <p:notesMasterIdLst>
-    <p:notesMasterId r:id="rId18"/>
+    <p:notesMasterId r:id="rId19"/>
   </p:notesMasterIdLst>
   <p:sldSz cx="12192000" cy="6858000"/>
   <p:notesSz cx="6858000" cy="12192000"/>
@@ -1139,8 +1140,9 @@
           <a:p>
             <a:r>
               <a:rPr lang="en-US" dirty="0"/>
-              <a:t>Collection point for every reference in the deck - keep this slide current as sections are added (isolette slide carries the K-State + AR-08-32 citations inline; Copland/Verus/seL4 seeded here ahead of their sections).
-DOIs on record in docs/video_slide_drafts.md.</a:t>
+              <a:t>High-level breadth slide (section 3 opener). The point: the blackboard workflow is invariant; the pipeline swaps - two frontends (SysML, AADL), four prover/target stacks (Verus/Rust, Slang/JVM, Lean, Rocq), example systems beyond the isolette (landing-gear, temp-control), all real in the repo.
+Repair-strategy diversity deliberately CUT from this slide - it lands in the capstone section instead.
+Each row is a pipeline; varying chip counts are intentional (Lean/Rocq are prover-centric, no separate HAMR codegen chain).</a:t>
             </a:r>
             <a:endParaRPr lang="en-US" dirty="0"/>
           </a:p>
@@ -1164,6 +1166,95 @@
             <a:fld id="{F7021451-1387-4CA6-816F-3879F97B5CBC}" type="slidenum">
               <a:rPr lang="en-US"/>
               <a:t>16</a:t>
+            </a:fld>
+            <a:endParaRPr lang="en-US"/>
+          </a:p>
+        </p:txBody>
+      </p:sp>
+    </p:spTree>
+    <p:extLst>
+      <p:ext uri="{BB962C8B-B14F-4D97-AF65-F5344CB8AC3E}">
+        <p14:creationId xmlns:p14="http://schemas.microsoft.com/office/powerpoint/2010/main" val="1024086991"/>
+      </p:ext>
+    </p:extLst>
+  </p:cSld>
+  <p:clrMapOvr>
+    <a:masterClrMapping/>
+  </p:clrMapOvr>
+</p:notes>
+</file>
+
+<file path=ppt/notesSlides/notesSlide17.xml><?xml version="1.0" encoding="utf-8"?>
+<p:notes xmlns:a="http://schemas.openxmlformats.org/drawingml/2006/main" xmlns:r="http://schemas.openxmlformats.org/officeDocument/2006/relationships" xmlns:p="http://schemas.openxmlformats.org/presentationml/2006/main">
+  <p:cSld>
+    <p:spTree>
+      <p:nvGrpSpPr>
+        <p:cNvPr id="1" name=""/>
+        <p:cNvGrpSpPr/>
+        <p:nvPr/>
+      </p:nvGrpSpPr>
+      <p:grpSpPr>
+        <a:xfrm>
+          <a:off x="0" y="0"/>
+          <a:ext cx="0" cy="0"/>
+          <a:chOff x="0" y="0"/>
+          <a:chExt cx="0" cy="0"/>
+        </a:xfrm>
+      </p:grpSpPr>
+      <p:sp>
+        <p:nvSpPr>
+          <p:cNvPr id="2" name="Slide Image Placeholder 1"/>
+          <p:cNvSpPr>
+            <a:spLocks noGrp="1" noRot="1" noChangeAspect="1"/>
+          </p:cNvSpPr>
+          <p:nvPr>
+            <p:ph type="sldImg"/>
+          </p:nvPr>
+        </p:nvSpPr>
+        <p:spPr/>
+      </p:sp>
+      <p:sp>
+        <p:nvSpPr>
+          <p:cNvPr id="3" name="Notes Placeholder 2"/>
+          <p:cNvSpPr>
+            <a:spLocks noGrp="1"/>
+          </p:cNvSpPr>
+          <p:nvPr>
+            <p:ph type="body" idx="1"/>
+          </p:nvPr>
+        </p:nvSpPr>
+        <p:spPr/>
+        <p:txBody>
+          <a:bodyPr/>
+          <a:lstStyle/>
+          <a:p>
+            <a:r>
+              <a:rPr lang="en-US" dirty="0"/>
+              <a:t>Collection point for every reference in the deck - keep this slide current as sections are added (isolette slide carries the K-State + AR-08-32 citations inline; Copland/Verus/seL4 seeded here ahead of their sections).
+DOIs on record in docs/video_slide_drafts.md.</a:t>
+            </a:r>
+            <a:endParaRPr lang="en-US" dirty="0"/>
+          </a:p>
+        </p:txBody>
+      </p:sp>
+      <p:sp>
+        <p:nvSpPr>
+          <p:cNvPr id="4" name="Slide Number Placeholder 3"/>
+          <p:cNvSpPr>
+            <a:spLocks noGrp="1"/>
+          </p:cNvSpPr>
+          <p:nvPr>
+            <p:ph type="sldNum" sz="quarter" idx="10"/>
+          </p:nvPr>
+        </p:nvSpPr>
+        <p:spPr/>
+        <p:txBody>
+          <a:bodyPr/>
+          <a:lstStyle/>
+          <a:p>
+            <a:fld id="{F7021451-1387-4CA6-816F-3879F97B5CBC}" type="slidenum">
+              <a:rPr lang="en-US"/>
+              <a:t>17</a:t>
             </a:fld>
             <a:endParaRPr lang="en-US"/>
           </a:p>
@@ -5772,6 +5863,1283 @@
 <file path=ppt/slides/slide16.xml><?xml version="1.0" encoding="utf-8"?>
 <p:sld xmlns:a="http://schemas.openxmlformats.org/drawingml/2006/main" xmlns:r="http://schemas.openxmlformats.org/officeDocument/2006/relationships" xmlns:p="http://schemas.openxmlformats.org/presentationml/2006/main">
   <p:cSld name="Slide 16">
+    <p:bg>
+      <p:bgPr>
+        <a:solidFill>
+          <a:srgbClr val="FFFFFF"/>
+        </a:solidFill>
+      </p:bgPr>
+    </p:bg>
+    <p:spTree>
+      <p:nvGrpSpPr>
+        <p:cNvPr id="1" name=""/>
+        <p:cNvGrpSpPr/>
+        <p:nvPr/>
+      </p:nvGrpSpPr>
+      <p:grpSpPr>
+        <a:xfrm>
+          <a:off x="0" y="0"/>
+          <a:ext cx="0" cy="0"/>
+          <a:chOff x="0" y="0"/>
+          <a:chExt cx="0" cy="0"/>
+        </a:xfrm>
+      </p:grpSpPr>
+      <p:sp>
+        <p:nvSpPr>
+          <p:cNvPr id="2" name="Text 0"/>
+          <p:cNvSpPr/>
+          <p:nvPr/>
+        </p:nvSpPr>
+        <p:spPr>
+          <a:xfrm>
+            <a:off x="640080" y="365760"/>
+            <a:ext cx="10972800" cy="640080"/>
+          </a:xfrm>
+          <a:prstGeom prst="rect">
+            <a:avLst/>
+          </a:prstGeom>
+          <a:noFill/>
+          <a:ln/>
+        </p:spPr>
+        <p:txBody>
+          <a:bodyPr wrap="square" lIns="0" tIns="0" rIns="0" bIns="0" rtlCol="0" anchor="ctr"/>
+          <a:lstStyle/>
+          <a:p>
+            <a:pPr indent="0" marL="0">
+              <a:buNone/>
+            </a:pPr>
+            <a:r>
+              <a:rPr lang="en-US" sz="3400" b="1" dirty="0">
+                <a:solidFill>
+                  <a:srgbClr val="1E2761"/>
+                </a:solidFill>
+                <a:latin typeface="Cambria" pitchFamily="34" charset="0"/>
+                <a:ea typeface="Cambria" pitchFamily="34" charset="-122"/>
+                <a:cs typeface="Cambria" pitchFamily="34" charset="-120"/>
+              </a:rPr>
+              <a:t>One blackboard, many artifact pipelines</a:t>
+            </a:r>
+            <a:endParaRPr lang="en-US" sz="3400" dirty="0"/>
+          </a:p>
+        </p:txBody>
+      </p:sp>
+      <p:sp>
+        <p:nvSpPr>
+          <p:cNvPr id="3" name="Text 1"/>
+          <p:cNvSpPr/>
+          <p:nvPr/>
+        </p:nvSpPr>
+        <p:spPr>
+          <a:xfrm>
+            <a:off x="640080" y="1051560"/>
+            <a:ext cx="10972800" cy="457200"/>
+          </a:xfrm>
+          <a:prstGeom prst="rect">
+            <a:avLst/>
+          </a:prstGeom>
+          <a:noFill/>
+          <a:ln/>
+        </p:spPr>
+        <p:txBody>
+          <a:bodyPr wrap="square" lIns="0" tIns="0" rIns="0" bIns="0" rtlCol="0" anchor="ctr"/>
+          <a:lstStyle/>
+          <a:p>
+            <a:pPr indent="0" marL="0">
+              <a:buNone/>
+            </a:pPr>
+            <a:r>
+              <a:rPr lang="en-US" sz="1500" i="1" dirty="0">
+                <a:solidFill>
+                  <a:srgbClr val="212121"/>
+                </a:solidFill>
+                <a:latin typeface="Calibri" pitchFamily="34" charset="0"/>
+                <a:ea typeface="Calibri" pitchFamily="34" charset="-122"/>
+                <a:cs typeface="Calibri" pitchFamily="34" charset="-120"/>
+              </a:rPr>
+              <a:t>The blackboard, controller, repair ladder, and artifact classes don’t change — only the </a:t>
+            </a:r>
+            <a:pPr indent="0" marL="0">
+              <a:buNone/>
+            </a:pPr>
+            <a:r>
+              <a:rPr lang="en-US" sz="1500" b="1" i="1" dirty="0">
+                <a:solidFill>
+                  <a:srgbClr val="212121"/>
+                </a:solidFill>
+                <a:latin typeface="Calibri" pitchFamily="34" charset="0"/>
+                <a:ea typeface="Calibri" pitchFamily="34" charset="-122"/>
+                <a:cs typeface="Calibri" pitchFamily="34" charset="-120"/>
+              </a:rPr>
+              <a:t>pipeline around them does</a:t>
+            </a:r>
+            <a:pPr indent="0" marL="0">
+              <a:buNone/>
+            </a:pPr>
+            <a:r>
+              <a:rPr lang="en-US" sz="1500" i="1" dirty="0">
+                <a:solidFill>
+                  <a:srgbClr val="212121"/>
+                </a:solidFill>
+                <a:latin typeface="Calibri" pitchFamily="34" charset="0"/>
+                <a:ea typeface="Calibri" pitchFamily="34" charset="-122"/>
+                <a:cs typeface="Calibri" pitchFamily="34" charset="-120"/>
+              </a:rPr>
+              <a:t>: the modeling language, the prover, and the target runtime.</a:t>
+            </a:r>
+            <a:endParaRPr lang="en-US" sz="1500" dirty="0"/>
+          </a:p>
+        </p:txBody>
+      </p:sp>
+      <p:sp>
+        <p:nvSpPr>
+          <p:cNvPr id="4" name="Shape 2"/>
+          <p:cNvSpPr/>
+          <p:nvPr/>
+        </p:nvSpPr>
+        <p:spPr>
+          <a:xfrm>
+            <a:off x="640080" y="1920240"/>
+            <a:ext cx="1298448" cy="566928"/>
+          </a:xfrm>
+          <a:prstGeom prst="roundRect">
+            <a:avLst>
+              <a:gd name="adj" fmla="val 9677"/>
+            </a:avLst>
+          </a:prstGeom>
+          <a:solidFill>
+            <a:srgbClr val="1E2761"/>
+          </a:solidFill>
+          <a:ln/>
+        </p:spPr>
+      </p:sp>
+      <p:sp>
+        <p:nvSpPr>
+          <p:cNvPr id="5" name="Text 3"/>
+          <p:cNvSpPr/>
+          <p:nvPr/>
+        </p:nvSpPr>
+        <p:spPr>
+          <a:xfrm>
+            <a:off x="640080" y="1920240"/>
+            <a:ext cx="1298448" cy="566928"/>
+          </a:xfrm>
+          <a:prstGeom prst="rect">
+            <a:avLst/>
+          </a:prstGeom>
+          <a:noFill/>
+          <a:ln/>
+        </p:spPr>
+        <p:txBody>
+          <a:bodyPr wrap="square" lIns="254" tIns="254" rIns="254" bIns="254" rtlCol="0" anchor="ctr"/>
+          <a:lstStyle/>
+          <a:p>
+            <a:pPr algn="ctr" indent="0" marL="0">
+              <a:buNone/>
+            </a:pPr>
+            <a:r>
+              <a:rPr lang="en-US" sz="1300" b="1" dirty="0">
+                <a:solidFill>
+                  <a:srgbClr val="FFFFFF"/>
+                </a:solidFill>
+                <a:latin typeface="Calibri" pitchFamily="34" charset="0"/>
+                <a:ea typeface="Calibri" pitchFamily="34" charset="-122"/>
+                <a:cs typeface="Calibri" pitchFamily="34" charset="-120"/>
+              </a:rPr>
+              <a:t>SysML v2</a:t>
+            </a:r>
+            <a:endParaRPr lang="en-US" sz="1300" dirty="0"/>
+          </a:p>
+        </p:txBody>
+      </p:sp>
+      <p:sp>
+        <p:nvSpPr>
+          <p:cNvPr id="6" name="Text 4"/>
+          <p:cNvSpPr/>
+          <p:nvPr/>
+        </p:nvSpPr>
+        <p:spPr>
+          <a:xfrm>
+            <a:off x="1920240" y="1920240"/>
+            <a:ext cx="365760" cy="566928"/>
+          </a:xfrm>
+          <a:prstGeom prst="rect">
+            <a:avLst/>
+          </a:prstGeom>
+          <a:noFill/>
+          <a:ln/>
+        </p:spPr>
+        <p:txBody>
+          <a:bodyPr wrap="square" lIns="0" tIns="0" rIns="0" bIns="0" rtlCol="0" anchor="ctr"/>
+          <a:lstStyle/>
+          <a:p>
+            <a:pPr algn="ctr" indent="0" marL="0">
+              <a:buNone/>
+            </a:pPr>
+            <a:r>
+              <a:rPr lang="en-US" sz="1500" dirty="0">
+                <a:solidFill>
+                  <a:srgbClr val="5A6478"/>
+                </a:solidFill>
+                <a:latin typeface="Calibri" pitchFamily="34" charset="0"/>
+                <a:ea typeface="Calibri" pitchFamily="34" charset="-122"/>
+                <a:cs typeface="Calibri" pitchFamily="34" charset="-120"/>
+              </a:rPr>
+              <a:t>→</a:t>
+            </a:r>
+            <a:endParaRPr lang="en-US" sz="1500" dirty="0"/>
+          </a:p>
+        </p:txBody>
+      </p:sp>
+      <p:sp>
+        <p:nvSpPr>
+          <p:cNvPr id="7" name="Shape 5"/>
+          <p:cNvSpPr/>
+          <p:nvPr/>
+        </p:nvSpPr>
+        <p:spPr>
+          <a:xfrm>
+            <a:off x="2286000" y="1920240"/>
+            <a:ext cx="1234440" cy="566928"/>
+          </a:xfrm>
+          <a:prstGeom prst="roundRect">
+            <a:avLst>
+              <a:gd name="adj" fmla="val 9677"/>
+            </a:avLst>
+          </a:prstGeom>
+          <a:solidFill>
+            <a:srgbClr val="1E2761"/>
+          </a:solidFill>
+          <a:ln/>
+        </p:spPr>
+      </p:sp>
+      <p:sp>
+        <p:nvSpPr>
+          <p:cNvPr id="8" name="Text 6"/>
+          <p:cNvSpPr/>
+          <p:nvPr/>
+        </p:nvSpPr>
+        <p:spPr>
+          <a:xfrm>
+            <a:off x="2286000" y="1920240"/>
+            <a:ext cx="1234440" cy="566928"/>
+          </a:xfrm>
+          <a:prstGeom prst="rect">
+            <a:avLst/>
+          </a:prstGeom>
+          <a:noFill/>
+          <a:ln/>
+        </p:spPr>
+        <p:txBody>
+          <a:bodyPr wrap="square" lIns="254" tIns="254" rIns="254" bIns="254" rtlCol="0" anchor="ctr"/>
+          <a:lstStyle/>
+          <a:p>
+            <a:pPr algn="ctr" indent="0" marL="0">
+              <a:buNone/>
+            </a:pPr>
+            <a:r>
+              <a:rPr lang="en-US" sz="1300" b="1" dirty="0">
+                <a:solidFill>
+                  <a:srgbClr val="FFFFFF"/>
+                </a:solidFill>
+                <a:latin typeface="Calibri" pitchFamily="34" charset="0"/>
+                <a:ea typeface="Calibri" pitchFamily="34" charset="-122"/>
+                <a:cs typeface="Calibri" pitchFamily="34" charset="-120"/>
+              </a:rPr>
+              <a:t>HAMR</a:t>
+            </a:r>
+            <a:endParaRPr lang="en-US" sz="1300" dirty="0"/>
+          </a:p>
+        </p:txBody>
+      </p:sp>
+      <p:sp>
+        <p:nvSpPr>
+          <p:cNvPr id="9" name="Text 7"/>
+          <p:cNvSpPr/>
+          <p:nvPr/>
+        </p:nvSpPr>
+        <p:spPr>
+          <a:xfrm>
+            <a:off x="3502152" y="1920240"/>
+            <a:ext cx="365760" cy="566928"/>
+          </a:xfrm>
+          <a:prstGeom prst="rect">
+            <a:avLst/>
+          </a:prstGeom>
+          <a:noFill/>
+          <a:ln/>
+        </p:spPr>
+        <p:txBody>
+          <a:bodyPr wrap="square" lIns="0" tIns="0" rIns="0" bIns="0" rtlCol="0" anchor="ctr"/>
+          <a:lstStyle/>
+          <a:p>
+            <a:pPr algn="ctr" indent="0" marL="0">
+              <a:buNone/>
+            </a:pPr>
+            <a:r>
+              <a:rPr lang="en-US" sz="1500" dirty="0">
+                <a:solidFill>
+                  <a:srgbClr val="5A6478"/>
+                </a:solidFill>
+                <a:latin typeface="Calibri" pitchFamily="34" charset="0"/>
+                <a:ea typeface="Calibri" pitchFamily="34" charset="-122"/>
+                <a:cs typeface="Calibri" pitchFamily="34" charset="-120"/>
+              </a:rPr>
+              <a:t>→</a:t>
+            </a:r>
+            <a:endParaRPr lang="en-US" sz="1500" dirty="0"/>
+          </a:p>
+        </p:txBody>
+      </p:sp>
+      <p:sp>
+        <p:nvSpPr>
+          <p:cNvPr id="10" name="Shape 8"/>
+          <p:cNvSpPr/>
+          <p:nvPr/>
+        </p:nvSpPr>
+        <p:spPr>
+          <a:xfrm>
+            <a:off x="3867912" y="1920240"/>
+            <a:ext cx="1719072" cy="566928"/>
+          </a:xfrm>
+          <a:prstGeom prst="roundRect">
+            <a:avLst>
+              <a:gd name="adj" fmla="val 9677"/>
+            </a:avLst>
+          </a:prstGeom>
+          <a:solidFill>
+            <a:srgbClr val="1E2761"/>
+          </a:solidFill>
+          <a:ln/>
+        </p:spPr>
+      </p:sp>
+      <p:sp>
+        <p:nvSpPr>
+          <p:cNvPr id="11" name="Text 9"/>
+          <p:cNvSpPr/>
+          <p:nvPr/>
+        </p:nvSpPr>
+        <p:spPr>
+          <a:xfrm>
+            <a:off x="3867912" y="1920240"/>
+            <a:ext cx="1719072" cy="566928"/>
+          </a:xfrm>
+          <a:prstGeom prst="rect">
+            <a:avLst/>
+          </a:prstGeom>
+          <a:noFill/>
+          <a:ln/>
+        </p:spPr>
+        <p:txBody>
+          <a:bodyPr wrap="square" lIns="254" tIns="254" rIns="254" bIns="254" rtlCol="0" anchor="ctr"/>
+          <a:lstStyle/>
+          <a:p>
+            <a:pPr algn="ctr" indent="0" marL="0">
+              <a:buNone/>
+            </a:pPr>
+            <a:r>
+              <a:rPr lang="en-US" sz="1300" b="1" dirty="0">
+                <a:solidFill>
+                  <a:srgbClr val="FFFFFF"/>
+                </a:solidFill>
+                <a:latin typeface="Calibri" pitchFamily="34" charset="0"/>
+                <a:ea typeface="Calibri" pitchFamily="34" charset="-122"/>
+                <a:cs typeface="Calibri" pitchFamily="34" charset="-120"/>
+              </a:rPr>
+              <a:t>Verus · Rust</a:t>
+            </a:r>
+            <a:endParaRPr lang="en-US" sz="1300" dirty="0"/>
+          </a:p>
+        </p:txBody>
+      </p:sp>
+      <p:sp>
+        <p:nvSpPr>
+          <p:cNvPr id="12" name="Text 10"/>
+          <p:cNvSpPr/>
+          <p:nvPr/>
+        </p:nvSpPr>
+        <p:spPr>
+          <a:xfrm>
+            <a:off x="5568696" y="1920240"/>
+            <a:ext cx="365760" cy="566928"/>
+          </a:xfrm>
+          <a:prstGeom prst="rect">
+            <a:avLst/>
+          </a:prstGeom>
+          <a:noFill/>
+          <a:ln/>
+        </p:spPr>
+        <p:txBody>
+          <a:bodyPr wrap="square" lIns="0" tIns="0" rIns="0" bIns="0" rtlCol="0" anchor="ctr"/>
+          <a:lstStyle/>
+          <a:p>
+            <a:pPr algn="ctr" indent="0" marL="0">
+              <a:buNone/>
+            </a:pPr>
+            <a:r>
+              <a:rPr lang="en-US" sz="1500" dirty="0">
+                <a:solidFill>
+                  <a:srgbClr val="5A6478"/>
+                </a:solidFill>
+                <a:latin typeface="Calibri" pitchFamily="34" charset="0"/>
+                <a:ea typeface="Calibri" pitchFamily="34" charset="-122"/>
+                <a:cs typeface="Calibri" pitchFamily="34" charset="-120"/>
+              </a:rPr>
+              <a:t>→</a:t>
+            </a:r>
+            <a:endParaRPr lang="en-US" sz="1500" dirty="0"/>
+          </a:p>
+        </p:txBody>
+      </p:sp>
+      <p:sp>
+        <p:nvSpPr>
+          <p:cNvPr id="13" name="Shape 11"/>
+          <p:cNvSpPr/>
+          <p:nvPr/>
+        </p:nvSpPr>
+        <p:spPr>
+          <a:xfrm>
+            <a:off x="5934456" y="1920240"/>
+            <a:ext cx="2034540" cy="566928"/>
+          </a:xfrm>
+          <a:prstGeom prst="roundRect">
+            <a:avLst>
+              <a:gd name="adj" fmla="val 9677"/>
+            </a:avLst>
+          </a:prstGeom>
+          <a:solidFill>
+            <a:srgbClr val="1E2761"/>
+          </a:solidFill>
+          <a:ln/>
+        </p:spPr>
+      </p:sp>
+      <p:sp>
+        <p:nvSpPr>
+          <p:cNvPr id="14" name="Text 12"/>
+          <p:cNvSpPr/>
+          <p:nvPr/>
+        </p:nvSpPr>
+        <p:spPr>
+          <a:xfrm>
+            <a:off x="5934456" y="1920240"/>
+            <a:ext cx="2034540" cy="566928"/>
+          </a:xfrm>
+          <a:prstGeom prst="rect">
+            <a:avLst/>
+          </a:prstGeom>
+          <a:noFill/>
+          <a:ln/>
+        </p:spPr>
+        <p:txBody>
+          <a:bodyPr wrap="square" lIns="254" tIns="254" rIns="254" bIns="254" rtlCol="0" anchor="ctr"/>
+          <a:lstStyle/>
+          <a:p>
+            <a:pPr algn="ctr" indent="0" marL="0">
+              <a:buNone/>
+            </a:pPr>
+            <a:r>
+              <a:rPr lang="en-US" sz="1300" b="1" dirty="0">
+                <a:solidFill>
+                  <a:srgbClr val="FFFFFF"/>
+                </a:solidFill>
+                <a:latin typeface="Calibri" pitchFamily="34" charset="0"/>
+                <a:ea typeface="Calibri" pitchFamily="34" charset="-122"/>
+                <a:cs typeface="Calibri" pitchFamily="34" charset="-120"/>
+              </a:rPr>
+              <a:t>seL4 · Microkit</a:t>
+            </a:r>
+            <a:endParaRPr lang="en-US" sz="1300" dirty="0"/>
+          </a:p>
+        </p:txBody>
+      </p:sp>
+      <p:sp>
+        <p:nvSpPr>
+          <p:cNvPr id="15" name="Text 13"/>
+          <p:cNvSpPr/>
+          <p:nvPr/>
+        </p:nvSpPr>
+        <p:spPr>
+          <a:xfrm>
+            <a:off x="8362188" y="1920240"/>
+            <a:ext cx="2194560" cy="566928"/>
+          </a:xfrm>
+          <a:prstGeom prst="rect">
+            <a:avLst/>
+          </a:prstGeom>
+          <a:noFill/>
+          <a:ln/>
+        </p:spPr>
+        <p:txBody>
+          <a:bodyPr wrap="square" lIns="0" tIns="0" rIns="0" bIns="0" rtlCol="0" anchor="ctr"/>
+          <a:lstStyle/>
+          <a:p>
+            <a:pPr algn="l" indent="0" marL="0">
+              <a:buNone/>
+            </a:pPr>
+            <a:r>
+              <a:rPr lang="en-US" sz="1200" b="1" i="1" dirty="0">
+                <a:solidFill>
+                  <a:srgbClr val="1E2761"/>
+                </a:solidFill>
+                <a:latin typeface="Calibri" pitchFamily="34" charset="0"/>
+                <a:ea typeface="Calibri" pitchFamily="34" charset="-122"/>
+                <a:cs typeface="Calibri" pitchFamily="34" charset="-120"/>
+              </a:rPr>
+              <a:t>◀ demo</a:t>
+            </a:r>
+            <a:endParaRPr lang="en-US" sz="1200" dirty="0"/>
+          </a:p>
+        </p:txBody>
+      </p:sp>
+      <p:sp>
+        <p:nvSpPr>
+          <p:cNvPr id="16" name="Text 14"/>
+          <p:cNvSpPr/>
+          <p:nvPr/>
+        </p:nvSpPr>
+        <p:spPr>
+          <a:xfrm>
+            <a:off x="658368" y="2468880"/>
+            <a:ext cx="10515600" cy="274320"/>
+          </a:xfrm>
+          <a:prstGeom prst="rect">
+            <a:avLst/>
+          </a:prstGeom>
+          <a:noFill/>
+          <a:ln/>
+        </p:spPr>
+        <p:txBody>
+          <a:bodyPr wrap="square" lIns="0" tIns="0" rIns="0" bIns="0" rtlCol="0" anchor="ctr"/>
+          <a:lstStyle/>
+          <a:p>
+            <a:pPr algn="l" indent="0" marL="0">
+              <a:buNone/>
+            </a:pPr>
+            <a:r>
+              <a:rPr lang="en-US" sz="1100" i="1" dirty="0">
+                <a:solidFill>
+                  <a:srgbClr val="5A6478"/>
+                </a:solidFill>
+                <a:latin typeface="Calibri" pitchFamily="34" charset="0"/>
+                <a:ea typeface="Calibri" pitchFamily="34" charset="-122"/>
+                <a:cs typeface="Calibri" pitchFamily="34" charset="-120"/>
+              </a:rPr>
+              <a:t>the isolette — the demo you just saw</a:t>
+            </a:r>
+            <a:endParaRPr lang="en-US" sz="1100" dirty="0"/>
+          </a:p>
+        </p:txBody>
+      </p:sp>
+      <p:sp>
+        <p:nvSpPr>
+          <p:cNvPr id="17" name="Shape 15"/>
+          <p:cNvSpPr/>
+          <p:nvPr/>
+        </p:nvSpPr>
+        <p:spPr>
+          <a:xfrm>
+            <a:off x="640080" y="3063240"/>
+            <a:ext cx="1234440" cy="566928"/>
+          </a:xfrm>
+          <a:prstGeom prst="roundRect">
+            <a:avLst>
+              <a:gd name="adj" fmla="val 9677"/>
+            </a:avLst>
+          </a:prstGeom>
+          <a:solidFill>
+            <a:srgbClr val="3A4A8C"/>
+          </a:solidFill>
+          <a:ln/>
+        </p:spPr>
+      </p:sp>
+      <p:sp>
+        <p:nvSpPr>
+          <p:cNvPr id="18" name="Text 16"/>
+          <p:cNvSpPr/>
+          <p:nvPr/>
+        </p:nvSpPr>
+        <p:spPr>
+          <a:xfrm>
+            <a:off x="640080" y="3063240"/>
+            <a:ext cx="1234440" cy="566928"/>
+          </a:xfrm>
+          <a:prstGeom prst="rect">
+            <a:avLst/>
+          </a:prstGeom>
+          <a:noFill/>
+          <a:ln/>
+        </p:spPr>
+        <p:txBody>
+          <a:bodyPr wrap="square" lIns="254" tIns="254" rIns="254" bIns="254" rtlCol="0" anchor="ctr"/>
+          <a:lstStyle/>
+          <a:p>
+            <a:pPr algn="ctr" indent="0" marL="0">
+              <a:buNone/>
+            </a:pPr>
+            <a:r>
+              <a:rPr lang="en-US" sz="1300" b="1" dirty="0">
+                <a:solidFill>
+                  <a:srgbClr val="FFFFFF"/>
+                </a:solidFill>
+                <a:latin typeface="Calibri" pitchFamily="34" charset="0"/>
+                <a:ea typeface="Calibri" pitchFamily="34" charset="-122"/>
+                <a:cs typeface="Calibri" pitchFamily="34" charset="-120"/>
+              </a:rPr>
+              <a:t>AADL</a:t>
+            </a:r>
+            <a:endParaRPr lang="en-US" sz="1300" dirty="0"/>
+          </a:p>
+        </p:txBody>
+      </p:sp>
+      <p:sp>
+        <p:nvSpPr>
+          <p:cNvPr id="19" name="Text 17"/>
+          <p:cNvSpPr/>
+          <p:nvPr/>
+        </p:nvSpPr>
+        <p:spPr>
+          <a:xfrm>
+            <a:off x="1856232" y="3063240"/>
+            <a:ext cx="365760" cy="566928"/>
+          </a:xfrm>
+          <a:prstGeom prst="rect">
+            <a:avLst/>
+          </a:prstGeom>
+          <a:noFill/>
+          <a:ln/>
+        </p:spPr>
+        <p:txBody>
+          <a:bodyPr wrap="square" lIns="0" tIns="0" rIns="0" bIns="0" rtlCol="0" anchor="ctr"/>
+          <a:lstStyle/>
+          <a:p>
+            <a:pPr algn="ctr" indent="0" marL="0">
+              <a:buNone/>
+            </a:pPr>
+            <a:r>
+              <a:rPr lang="en-US" sz="1500" dirty="0">
+                <a:solidFill>
+                  <a:srgbClr val="5A6478"/>
+                </a:solidFill>
+                <a:latin typeface="Calibri" pitchFamily="34" charset="0"/>
+                <a:ea typeface="Calibri" pitchFamily="34" charset="-122"/>
+                <a:cs typeface="Calibri" pitchFamily="34" charset="-120"/>
+              </a:rPr>
+              <a:t>→</a:t>
+            </a:r>
+            <a:endParaRPr lang="en-US" sz="1500" dirty="0"/>
+          </a:p>
+        </p:txBody>
+      </p:sp>
+      <p:sp>
+        <p:nvSpPr>
+          <p:cNvPr id="20" name="Shape 18"/>
+          <p:cNvSpPr/>
+          <p:nvPr/>
+        </p:nvSpPr>
+        <p:spPr>
+          <a:xfrm>
+            <a:off x="2221992" y="3063240"/>
+            <a:ext cx="1234440" cy="566928"/>
+          </a:xfrm>
+          <a:prstGeom prst="roundRect">
+            <a:avLst>
+              <a:gd name="adj" fmla="val 9677"/>
+            </a:avLst>
+          </a:prstGeom>
+          <a:solidFill>
+            <a:srgbClr val="3A4A8C"/>
+          </a:solidFill>
+          <a:ln/>
+        </p:spPr>
+      </p:sp>
+      <p:sp>
+        <p:nvSpPr>
+          <p:cNvPr id="21" name="Text 19"/>
+          <p:cNvSpPr/>
+          <p:nvPr/>
+        </p:nvSpPr>
+        <p:spPr>
+          <a:xfrm>
+            <a:off x="2221992" y="3063240"/>
+            <a:ext cx="1234440" cy="566928"/>
+          </a:xfrm>
+          <a:prstGeom prst="rect">
+            <a:avLst/>
+          </a:prstGeom>
+          <a:noFill/>
+          <a:ln/>
+        </p:spPr>
+        <p:txBody>
+          <a:bodyPr wrap="square" lIns="254" tIns="254" rIns="254" bIns="254" rtlCol="0" anchor="ctr"/>
+          <a:lstStyle/>
+          <a:p>
+            <a:pPr algn="ctr" indent="0" marL="0">
+              <a:buNone/>
+            </a:pPr>
+            <a:r>
+              <a:rPr lang="en-US" sz="1300" b="1" dirty="0">
+                <a:solidFill>
+                  <a:srgbClr val="FFFFFF"/>
+                </a:solidFill>
+                <a:latin typeface="Calibri" pitchFamily="34" charset="0"/>
+                <a:ea typeface="Calibri" pitchFamily="34" charset="-122"/>
+                <a:cs typeface="Calibri" pitchFamily="34" charset="-120"/>
+              </a:rPr>
+              <a:t>HAMR</a:t>
+            </a:r>
+            <a:endParaRPr lang="en-US" sz="1300" dirty="0"/>
+          </a:p>
+        </p:txBody>
+      </p:sp>
+      <p:sp>
+        <p:nvSpPr>
+          <p:cNvPr id="22" name="Text 20"/>
+          <p:cNvSpPr/>
+          <p:nvPr/>
+        </p:nvSpPr>
+        <p:spPr>
+          <a:xfrm>
+            <a:off x="3438144" y="3063240"/>
+            <a:ext cx="365760" cy="566928"/>
+          </a:xfrm>
+          <a:prstGeom prst="rect">
+            <a:avLst/>
+          </a:prstGeom>
+          <a:noFill/>
+          <a:ln/>
+        </p:spPr>
+        <p:txBody>
+          <a:bodyPr wrap="square" lIns="0" tIns="0" rIns="0" bIns="0" rtlCol="0" anchor="ctr"/>
+          <a:lstStyle/>
+          <a:p>
+            <a:pPr algn="ctr" indent="0" marL="0">
+              <a:buNone/>
+            </a:pPr>
+            <a:r>
+              <a:rPr lang="en-US" sz="1500" dirty="0">
+                <a:solidFill>
+                  <a:srgbClr val="5A6478"/>
+                </a:solidFill>
+                <a:latin typeface="Calibri" pitchFamily="34" charset="0"/>
+                <a:ea typeface="Calibri" pitchFamily="34" charset="-122"/>
+                <a:cs typeface="Calibri" pitchFamily="34" charset="-120"/>
+              </a:rPr>
+              <a:t>→</a:t>
+            </a:r>
+            <a:endParaRPr lang="en-US" sz="1500" dirty="0"/>
+          </a:p>
+        </p:txBody>
+      </p:sp>
+      <p:sp>
+        <p:nvSpPr>
+          <p:cNvPr id="23" name="Shape 21"/>
+          <p:cNvSpPr/>
+          <p:nvPr/>
+        </p:nvSpPr>
+        <p:spPr>
+          <a:xfrm>
+            <a:off x="3803904" y="3063240"/>
+            <a:ext cx="1613916" cy="566928"/>
+          </a:xfrm>
+          <a:prstGeom prst="roundRect">
+            <a:avLst>
+              <a:gd name="adj" fmla="val 9677"/>
+            </a:avLst>
+          </a:prstGeom>
+          <a:solidFill>
+            <a:srgbClr val="3A4A8C"/>
+          </a:solidFill>
+          <a:ln/>
+        </p:spPr>
+      </p:sp>
+      <p:sp>
+        <p:nvSpPr>
+          <p:cNvPr id="24" name="Text 22"/>
+          <p:cNvSpPr/>
+          <p:nvPr/>
+        </p:nvSpPr>
+        <p:spPr>
+          <a:xfrm>
+            <a:off x="3803904" y="3063240"/>
+            <a:ext cx="1613916" cy="566928"/>
+          </a:xfrm>
+          <a:prstGeom prst="rect">
+            <a:avLst/>
+          </a:prstGeom>
+          <a:noFill/>
+          <a:ln/>
+        </p:spPr>
+        <p:txBody>
+          <a:bodyPr wrap="square" lIns="254" tIns="254" rIns="254" bIns="254" rtlCol="0" anchor="ctr"/>
+          <a:lstStyle/>
+          <a:p>
+            <a:pPr algn="ctr" indent="0" marL="0">
+              <a:buNone/>
+            </a:pPr>
+            <a:r>
+              <a:rPr lang="en-US" sz="1300" b="1" dirty="0">
+                <a:solidFill>
+                  <a:srgbClr val="FFFFFF"/>
+                </a:solidFill>
+                <a:latin typeface="Calibri" pitchFamily="34" charset="0"/>
+                <a:ea typeface="Calibri" pitchFamily="34" charset="-122"/>
+                <a:cs typeface="Calibri" pitchFamily="34" charset="-120"/>
+              </a:rPr>
+              <a:t>Slang · JVM</a:t>
+            </a:r>
+            <a:endParaRPr lang="en-US" sz="1300" dirty="0"/>
+          </a:p>
+        </p:txBody>
+      </p:sp>
+      <p:sp>
+        <p:nvSpPr>
+          <p:cNvPr id="25" name="Text 23"/>
+          <p:cNvSpPr/>
+          <p:nvPr/>
+        </p:nvSpPr>
+        <p:spPr>
+          <a:xfrm>
+            <a:off x="658368" y="3611880"/>
+            <a:ext cx="10515600" cy="274320"/>
+          </a:xfrm>
+          <a:prstGeom prst="rect">
+            <a:avLst/>
+          </a:prstGeom>
+          <a:noFill/>
+          <a:ln/>
+        </p:spPr>
+        <p:txBody>
+          <a:bodyPr wrap="square" lIns="0" tIns="0" rIns="0" bIns="0" rtlCol="0" anchor="ctr"/>
+          <a:lstStyle/>
+          <a:p>
+            <a:pPr algn="l" indent="0" marL="0">
+              <a:buNone/>
+            </a:pPr>
+            <a:r>
+              <a:rPr lang="en-US" sz="1100" i="1" dirty="0">
+                <a:solidFill>
+                  <a:srgbClr val="5A6478"/>
+                </a:solidFill>
+                <a:latin typeface="Calibri" pitchFamily="34" charset="0"/>
+                <a:ea typeface="Calibri" pitchFamily="34" charset="-122"/>
+                <a:cs typeface="Calibri" pitchFamily="34" charset="-120"/>
+              </a:rPr>
+              <a:t>a different modeling language and target runtime, same artifact classes and Copland protocols  (temp-control)</a:t>
+            </a:r>
+            <a:endParaRPr lang="en-US" sz="1100" dirty="0"/>
+          </a:p>
+        </p:txBody>
+      </p:sp>
+      <p:sp>
+        <p:nvSpPr>
+          <p:cNvPr id="26" name="Shape 24"/>
+          <p:cNvSpPr/>
+          <p:nvPr/>
+        </p:nvSpPr>
+        <p:spPr>
+          <a:xfrm>
+            <a:off x="640080" y="4206240"/>
+            <a:ext cx="1234440" cy="566928"/>
+          </a:xfrm>
+          <a:prstGeom prst="roundRect">
+            <a:avLst>
+              <a:gd name="adj" fmla="val 9677"/>
+            </a:avLst>
+          </a:prstGeom>
+          <a:solidFill>
+            <a:srgbClr val="3A4A8C"/>
+          </a:solidFill>
+          <a:ln/>
+        </p:spPr>
+      </p:sp>
+      <p:sp>
+        <p:nvSpPr>
+          <p:cNvPr id="27" name="Text 25"/>
+          <p:cNvSpPr/>
+          <p:nvPr/>
+        </p:nvSpPr>
+        <p:spPr>
+          <a:xfrm>
+            <a:off x="640080" y="4206240"/>
+            <a:ext cx="1234440" cy="566928"/>
+          </a:xfrm>
+          <a:prstGeom prst="rect">
+            <a:avLst/>
+          </a:prstGeom>
+          <a:noFill/>
+          <a:ln/>
+        </p:spPr>
+        <p:txBody>
+          <a:bodyPr wrap="square" lIns="254" tIns="254" rIns="254" bIns="254" rtlCol="0" anchor="ctr"/>
+          <a:lstStyle/>
+          <a:p>
+            <a:pPr algn="ctr" indent="0" marL="0">
+              <a:buNone/>
+            </a:pPr>
+            <a:r>
+              <a:rPr lang="en-US" sz="1300" b="1" dirty="0">
+                <a:solidFill>
+                  <a:srgbClr val="FFFFFF"/>
+                </a:solidFill>
+                <a:latin typeface="Calibri" pitchFamily="34" charset="0"/>
+                <a:ea typeface="Calibri" pitchFamily="34" charset="-122"/>
+                <a:cs typeface="Calibri" pitchFamily="34" charset="-120"/>
+              </a:rPr>
+              <a:t>Lean</a:t>
+            </a:r>
+            <a:endParaRPr lang="en-US" sz="1300" dirty="0"/>
+          </a:p>
+        </p:txBody>
+      </p:sp>
+      <p:sp>
+        <p:nvSpPr>
+          <p:cNvPr id="28" name="Text 26"/>
+          <p:cNvSpPr/>
+          <p:nvPr/>
+        </p:nvSpPr>
+        <p:spPr>
+          <a:xfrm>
+            <a:off x="1856232" y="4206240"/>
+            <a:ext cx="365760" cy="566928"/>
+          </a:xfrm>
+          <a:prstGeom prst="rect">
+            <a:avLst/>
+          </a:prstGeom>
+          <a:noFill/>
+          <a:ln/>
+        </p:spPr>
+        <p:txBody>
+          <a:bodyPr wrap="square" lIns="0" tIns="0" rIns="0" bIns="0" rtlCol="0" anchor="ctr"/>
+          <a:lstStyle/>
+          <a:p>
+            <a:pPr algn="ctr" indent="0" marL="0">
+              <a:buNone/>
+            </a:pPr>
+            <a:r>
+              <a:rPr lang="en-US" sz="1500" dirty="0">
+                <a:solidFill>
+                  <a:srgbClr val="5A6478"/>
+                </a:solidFill>
+                <a:latin typeface="Calibri" pitchFamily="34" charset="0"/>
+                <a:ea typeface="Calibri" pitchFamily="34" charset="-122"/>
+                <a:cs typeface="Calibri" pitchFamily="34" charset="-120"/>
+              </a:rPr>
+              <a:t>→</a:t>
+            </a:r>
+            <a:endParaRPr lang="en-US" sz="1500" dirty="0"/>
+          </a:p>
+        </p:txBody>
+      </p:sp>
+      <p:sp>
+        <p:nvSpPr>
+          <p:cNvPr id="29" name="Shape 27"/>
+          <p:cNvSpPr/>
+          <p:nvPr/>
+        </p:nvSpPr>
+        <p:spPr>
+          <a:xfrm>
+            <a:off x="2221992" y="4206240"/>
+            <a:ext cx="4873752" cy="566928"/>
+          </a:xfrm>
+          <a:prstGeom prst="roundRect">
+            <a:avLst>
+              <a:gd name="adj" fmla="val 9677"/>
+            </a:avLst>
+          </a:prstGeom>
+          <a:solidFill>
+            <a:srgbClr val="3A4A8C"/>
+          </a:solidFill>
+          <a:ln/>
+        </p:spPr>
+      </p:sp>
+      <p:sp>
+        <p:nvSpPr>
+          <p:cNvPr id="30" name="Text 28"/>
+          <p:cNvSpPr/>
+          <p:nvPr/>
+        </p:nvSpPr>
+        <p:spPr>
+          <a:xfrm>
+            <a:off x="2221992" y="4206240"/>
+            <a:ext cx="4873752" cy="566928"/>
+          </a:xfrm>
+          <a:prstGeom prst="rect">
+            <a:avLst/>
+          </a:prstGeom>
+          <a:noFill/>
+          <a:ln/>
+        </p:spPr>
+        <p:txBody>
+          <a:bodyPr wrap="square" lIns="254" tIns="254" rIns="254" bIns="254" rtlCol="0" anchor="ctr"/>
+          <a:lstStyle/>
+          <a:p>
+            <a:pPr algn="ctr" indent="0" marL="0">
+              <a:buNone/>
+            </a:pPr>
+            <a:r>
+              <a:rPr lang="en-US" sz="1300" b="1" dirty="0">
+                <a:solidFill>
+                  <a:srgbClr val="FFFFFF"/>
+                </a:solidFill>
+                <a:latin typeface="Calibri" pitchFamily="34" charset="0"/>
+                <a:ea typeface="Calibri" pitchFamily="34" charset="-122"/>
+                <a:cs typeface="Calibri" pitchFamily="34" charset="-120"/>
+              </a:rPr>
+              <a:t>blessed statements + workflow-owned proofs</a:t>
+            </a:r>
+            <a:endParaRPr lang="en-US" sz="1300" dirty="0"/>
+          </a:p>
+        </p:txBody>
+      </p:sp>
+      <p:sp>
+        <p:nvSpPr>
+          <p:cNvPr id="31" name="Text 29"/>
+          <p:cNvSpPr/>
+          <p:nvPr/>
+        </p:nvSpPr>
+        <p:spPr>
+          <a:xfrm>
+            <a:off x="658368" y="4754880"/>
+            <a:ext cx="10515600" cy="274320"/>
+          </a:xfrm>
+          <a:prstGeom prst="rect">
+            <a:avLst/>
+          </a:prstGeom>
+          <a:noFill/>
+          <a:ln/>
+        </p:spPr>
+        <p:txBody>
+          <a:bodyPr wrap="square" lIns="0" tIns="0" rIns="0" bIns="0" rtlCol="0" anchor="ctr"/>
+          <a:lstStyle/>
+          <a:p>
+            <a:pPr algn="l" indent="0" marL="0">
+              <a:buNone/>
+            </a:pPr>
+            <a:r>
+              <a:rPr lang="en-US" sz="1100" i="1" dirty="0">
+                <a:solidFill>
+                  <a:srgbClr val="5A6478"/>
+                </a:solidFill>
+                <a:latin typeface="Calibri" pitchFamily="34" charset="0"/>
+                <a:ea typeface="Calibri" pitchFamily="34" charset="-122"/>
+                <a:cs typeface="Calibri" pitchFamily="34" charset="-120"/>
+              </a:rPr>
+              <a:t>the goal-directed encoding: attestation enforces one invariant while synthesis iterates  (landing-gear, temp-control)</a:t>
+            </a:r>
+            <a:endParaRPr lang="en-US" sz="1100" dirty="0"/>
+          </a:p>
+        </p:txBody>
+      </p:sp>
+      <p:sp>
+        <p:nvSpPr>
+          <p:cNvPr id="32" name="Shape 30"/>
+          <p:cNvSpPr/>
+          <p:nvPr/>
+        </p:nvSpPr>
+        <p:spPr>
+          <a:xfrm>
+            <a:off x="640080" y="5349240"/>
+            <a:ext cx="1234440" cy="566928"/>
+          </a:xfrm>
+          <a:prstGeom prst="roundRect">
+            <a:avLst>
+              <a:gd name="adj" fmla="val 9677"/>
+            </a:avLst>
+          </a:prstGeom>
+          <a:solidFill>
+            <a:srgbClr val="3A4A8C"/>
+          </a:solidFill>
+          <a:ln/>
+        </p:spPr>
+      </p:sp>
+      <p:sp>
+        <p:nvSpPr>
+          <p:cNvPr id="33" name="Text 31"/>
+          <p:cNvSpPr/>
+          <p:nvPr/>
+        </p:nvSpPr>
+        <p:spPr>
+          <a:xfrm>
+            <a:off x="640080" y="5349240"/>
+            <a:ext cx="1234440" cy="566928"/>
+          </a:xfrm>
+          <a:prstGeom prst="rect">
+            <a:avLst/>
+          </a:prstGeom>
+          <a:noFill/>
+          <a:ln/>
+        </p:spPr>
+        <p:txBody>
+          <a:bodyPr wrap="square" lIns="254" tIns="254" rIns="254" bIns="254" rtlCol="0" anchor="ctr"/>
+          <a:lstStyle/>
+          <a:p>
+            <a:pPr algn="ctr" indent="0" marL="0">
+              <a:buNone/>
+            </a:pPr>
+            <a:r>
+              <a:rPr lang="en-US" sz="1300" b="1" dirty="0">
+                <a:solidFill>
+                  <a:srgbClr val="FFFFFF"/>
+                </a:solidFill>
+                <a:latin typeface="Calibri" pitchFamily="34" charset="0"/>
+                <a:ea typeface="Calibri" pitchFamily="34" charset="-122"/>
+                <a:cs typeface="Calibri" pitchFamily="34" charset="-120"/>
+              </a:rPr>
+              <a:t>Rocq</a:t>
+            </a:r>
+            <a:endParaRPr lang="en-US" sz="1300" dirty="0"/>
+          </a:p>
+        </p:txBody>
+      </p:sp>
+      <p:sp>
+        <p:nvSpPr>
+          <p:cNvPr id="34" name="Text 32"/>
+          <p:cNvSpPr/>
+          <p:nvPr/>
+        </p:nvSpPr>
+        <p:spPr>
+          <a:xfrm>
+            <a:off x="1856232" y="5349240"/>
+            <a:ext cx="365760" cy="566928"/>
+          </a:xfrm>
+          <a:prstGeom prst="rect">
+            <a:avLst/>
+          </a:prstGeom>
+          <a:noFill/>
+          <a:ln/>
+        </p:spPr>
+        <p:txBody>
+          <a:bodyPr wrap="square" lIns="0" tIns="0" rIns="0" bIns="0" rtlCol="0" anchor="ctr"/>
+          <a:lstStyle/>
+          <a:p>
+            <a:pPr algn="ctr" indent="0" marL="0">
+              <a:buNone/>
+            </a:pPr>
+            <a:r>
+              <a:rPr lang="en-US" sz="1500" dirty="0">
+                <a:solidFill>
+                  <a:srgbClr val="5A6478"/>
+                </a:solidFill>
+                <a:latin typeface="Calibri" pitchFamily="34" charset="0"/>
+                <a:ea typeface="Calibri" pitchFamily="34" charset="-122"/>
+                <a:cs typeface="Calibri" pitchFamily="34" charset="-120"/>
+              </a:rPr>
+              <a:t>→</a:t>
+            </a:r>
+            <a:endParaRPr lang="en-US" sz="1500" dirty="0"/>
+          </a:p>
+        </p:txBody>
+      </p:sp>
+      <p:sp>
+        <p:nvSpPr>
+          <p:cNvPr id="35" name="Shape 33"/>
+          <p:cNvSpPr/>
+          <p:nvPr/>
+        </p:nvSpPr>
+        <p:spPr>
+          <a:xfrm>
+            <a:off x="2221992" y="5349240"/>
+            <a:ext cx="4873752" cy="566928"/>
+          </a:xfrm>
+          <a:prstGeom prst="roundRect">
+            <a:avLst>
+              <a:gd name="adj" fmla="val 9677"/>
+            </a:avLst>
+          </a:prstGeom>
+          <a:solidFill>
+            <a:srgbClr val="3A4A8C"/>
+          </a:solidFill>
+          <a:ln/>
+        </p:spPr>
+      </p:sp>
+      <p:sp>
+        <p:nvSpPr>
+          <p:cNvPr id="36" name="Text 34"/>
+          <p:cNvSpPr/>
+          <p:nvPr/>
+        </p:nvSpPr>
+        <p:spPr>
+          <a:xfrm>
+            <a:off x="2221992" y="5349240"/>
+            <a:ext cx="4873752" cy="566928"/>
+          </a:xfrm>
+          <a:prstGeom prst="rect">
+            <a:avLst/>
+          </a:prstGeom>
+          <a:noFill/>
+          <a:ln/>
+        </p:spPr>
+        <p:txBody>
+          <a:bodyPr wrap="square" lIns="254" tIns="254" rIns="254" bIns="254" rtlCol="0" anchor="ctr"/>
+          <a:lstStyle/>
+          <a:p>
+            <a:pPr algn="ctr" indent="0" marL="0">
+              <a:buNone/>
+            </a:pPr>
+            <a:r>
+              <a:rPr lang="en-US" sz="1300" b="1" dirty="0">
+                <a:solidFill>
+                  <a:srgbClr val="FFFFFF"/>
+                </a:solidFill>
+                <a:latin typeface="Calibri" pitchFamily="34" charset="0"/>
+                <a:ea typeface="Calibri" pitchFamily="34" charset="-122"/>
+                <a:cs typeface="Calibri" pitchFamily="34" charset="-120"/>
+              </a:rPr>
+              <a:t>proofs + synthesis (tactic portfolio, LLM)</a:t>
+            </a:r>
+            <a:endParaRPr lang="en-US" sz="1300" dirty="0"/>
+          </a:p>
+        </p:txBody>
+      </p:sp>
+      <p:sp>
+        <p:nvSpPr>
+          <p:cNvPr id="37" name="Text 35"/>
+          <p:cNvSpPr/>
+          <p:nvPr/>
+        </p:nvSpPr>
+        <p:spPr>
+          <a:xfrm>
+            <a:off x="658368" y="5897880"/>
+            <a:ext cx="10515600" cy="274320"/>
+          </a:xfrm>
+          <a:prstGeom prst="rect">
+            <a:avLst/>
+          </a:prstGeom>
+          <a:noFill/>
+          <a:ln/>
+        </p:spPr>
+        <p:txBody>
+          <a:bodyPr wrap="square" lIns="0" tIns="0" rIns="0" bIns="0" rtlCol="0" anchor="ctr"/>
+          <a:lstStyle/>
+          <a:p>
+            <a:pPr algn="l" indent="0" marL="0">
+              <a:buNone/>
+            </a:pPr>
+            <a:r>
+              <a:rPr lang="en-US" sz="1100" i="1" dirty="0">
+                <a:solidFill>
+                  <a:srgbClr val="5A6478"/>
+                </a:solidFill>
+                <a:latin typeface="Calibri" pitchFamily="34" charset="0"/>
+                <a:ea typeface="Calibri" pitchFamily="34" charset="-122"/>
+                <a:cs typeface="Calibri" pitchFamily="34" charset="-120"/>
+              </a:rPr>
+              <a:t>proof synthesis as a repair strategy  (temp-control)</a:t>
+            </a:r>
+            <a:endParaRPr lang="en-US" sz="1100" dirty="0"/>
+          </a:p>
+        </p:txBody>
+      </p:sp>
+    </p:spTree>
+  </p:cSld>
+  <p:clrMapOvr>
+    <a:masterClrMapping/>
+  </p:clrMapOvr>
+</p:sld>
+</file>
+
+<file path=ppt/slides/slide17.xml><?xml version="1.0" encoding="utf-8"?>
+<p:sld xmlns:a="http://schemas.openxmlformats.org/drawingml/2006/main" xmlns:r="http://schemas.openxmlformats.org/officeDocument/2006/relationships" xmlns:p="http://schemas.openxmlformats.org/presentationml/2006/main">
+  <p:cSld name="Slide 17">
     <p:bg>
       <p:bgPr>
         <a:solidFill>

</xml_diff>

<commit_message>
ecosystems slide: 2x2 card grid (replaces chips), per user edits
Reworked from pipeline-chips to a 2x2 card grid - title = artifact
pipeline, caption = example system. Four cards: isolette
(SysML->HAMR->Rust/Verus, highlighted), AADL->HAMR->Slang/Logika,
standalone Rust/Verus (find-max-verus; AutoVerus + KU Dogtreat repair
experiments), and Interactive Theorem Provers Lean/Rocq (blessed
statements, tactic/LLM repair, ITP axiom checks). Content is the user's
hand-edited candidate, ported verbatim into the generator (regenerated
slide matches byte-for-text). Thesis line extended with "and the
attestation primitives."

Co-Authored-By: Claude Fable 5 <noreply@anthropic.com>
</commit_message>
<xml_diff>
--- a/docs/video_slides_draft.pptx
+++ b/docs/video_slides_draft.pptx
@@ -1140,9 +1140,7 @@
           <a:p>
             <a:r>
               <a:rPr lang="en-US" dirty="0"/>
-              <a:t>High-level breadth slide (section 3 opener). The point: the blackboard workflow is invariant; the pipeline swaps - two frontends (SysML, AADL), four prover/target stacks (Verus/Rust, Slang/JVM, Lean, Rocq), example systems beyond the isolette (landing-gear, temp-control), all real in the repo.
-Repair-strategy diversity deliberately CUT from this slide - it lands in the capstone section instead.
-Each row is a pipeline; varying chip counts are intentional (Lean/Rocq are prover-centric, no separate HAMR codegen chain).</a:t>
+              <a:t>High-level breadth slide (section 3 opener) - card grid, per user edits 2026-08-30. Four artifact pipelines: the isolette (SysML-&gt;HAMR-&gt;Rust/Verus, the demo, highlighted), AADL-&gt;HAMR-&gt;Slang/Logika (temp-control), standalone Rust/Verus (find-max-verus; AutoVerus + KU Dogtreat repair experiments), and the interactive theorem provers Lean &amp; Rocq (blessed statements, tactic/LLM repair). Title = the artifact pipeline; caption = example system(s). Repair-strategy breadth lands per-card where it defines the ecosystem.</a:t>
             </a:r>
             <a:endParaRPr lang="en-US" dirty="0"/>
           </a:p>
@@ -5931,7 +5929,7 @@
         </p:nvSpPr>
         <p:spPr>
           <a:xfrm>
-            <a:off x="640080" y="1051560"/>
+            <a:off x="640080" y="1024128"/>
             <a:ext cx="10972800" cy="457200"/>
           </a:xfrm>
           <a:prstGeom prst="rect">
@@ -5984,7 +5982,7 @@
                 <a:ea typeface="Calibri" pitchFamily="34" charset="-122"/>
                 <a:cs typeface="Calibri" pitchFamily="34" charset="-120"/>
               </a:rPr>
-              <a:t>: the modeling language, the prover, and the target runtime.</a:t>
+              <a:t>: the modeling language, the prover, the target runtime, and the attestation primitives.</a:t>
             </a:r>
             <a:endParaRPr lang="en-US" sz="1500" dirty="0"/>
           </a:p>
@@ -5998,12 +5996,12 @@
         </p:nvSpPr>
         <p:spPr>
           <a:xfrm>
-            <a:off x="640080" y="1920240"/>
-            <a:ext cx="1298448" cy="566928"/>
+            <a:off x="640080" y="1645920"/>
+            <a:ext cx="5349240" cy="2148840"/>
           </a:xfrm>
           <a:prstGeom prst="roundRect">
             <a:avLst>
-              <a:gd name="adj" fmla="val 9677"/>
+              <a:gd name="adj" fmla="val 2553"/>
             </a:avLst>
           </a:prstGeom>
           <a:solidFill>
@@ -6020,24 +6018,24 @@
         </p:nvSpPr>
         <p:spPr>
           <a:xfrm>
-            <a:off x="640080" y="1920240"/>
-            <a:ext cx="1298448" cy="566928"/>
-          </a:xfrm>
-          <a:prstGeom prst="rect">
-            <a:avLst/>
-          </a:prstGeom>
-          <a:noFill/>
-          <a:ln/>
-        </p:spPr>
-        <p:txBody>
-          <a:bodyPr wrap="square" lIns="254" tIns="254" rIns="254" bIns="254" rtlCol="0" anchor="ctr"/>
-          <a:lstStyle/>
-          <a:p>
-            <a:pPr algn="ctr" indent="0" marL="0">
-              <a:buNone/>
-            </a:pPr>
-            <a:r>
-              <a:rPr lang="en-US" sz="1300" b="1" dirty="0">
+            <a:off x="868680" y="1755648"/>
+            <a:ext cx="4892040" cy="329184"/>
+          </a:xfrm>
+          <a:prstGeom prst="rect">
+            <a:avLst/>
+          </a:prstGeom>
+          <a:noFill/>
+          <a:ln/>
+        </p:spPr>
+        <p:txBody>
+          <a:bodyPr wrap="square" lIns="0" tIns="0" rIns="0" bIns="0" rtlCol="0" anchor="ctr"/>
+          <a:lstStyle/>
+          <a:p>
+            <a:pPr algn="l" indent="0" marL="0">
+              <a:buNone/>
+            </a:pPr>
+            <a:r>
+              <a:rPr lang="en-US" sz="1550" b="1" dirty="0">
                 <a:solidFill>
                   <a:srgbClr val="FFFFFF"/>
                 </a:solidFill>
@@ -6045,9 +6043,9 @@
                 <a:ea typeface="Calibri" pitchFamily="34" charset="-122"/>
                 <a:cs typeface="Calibri" pitchFamily="34" charset="-120"/>
               </a:rPr>
-              <a:t>SysML v2</a:t>
-            </a:r>
-            <a:endParaRPr lang="en-US" sz="1300" dirty="0"/>
+              <a:t>SysML v2 → HAMR → Rust / Verus</a:t>
+            </a:r>
+            <a:endParaRPr lang="en-US" sz="1550" dirty="0"/>
           </a:p>
         </p:txBody>
       </p:sp>
@@ -6059,8 +6057,8 @@
         </p:nvSpPr>
         <p:spPr>
           <a:xfrm>
-            <a:off x="1920240" y="1920240"/>
-            <a:ext cx="365760" cy="566928"/>
+            <a:off x="877824" y="2103120"/>
+            <a:ext cx="4892040" cy="256032"/>
           </a:xfrm>
           <a:prstGeom prst="rect">
             <a:avLst/>
@@ -6072,84 +6070,149 @@
           <a:bodyPr wrap="square" lIns="0" tIns="0" rIns="0" bIns="0" rtlCol="0" anchor="ctr"/>
           <a:lstStyle/>
           <a:p>
-            <a:pPr algn="ctr" indent="0" marL="0">
-              <a:buNone/>
-            </a:pPr>
-            <a:r>
-              <a:rPr lang="en-US" sz="1500" dirty="0">
-                <a:solidFill>
-                  <a:srgbClr val="5A6478"/>
-                </a:solidFill>
-                <a:latin typeface="Calibri" pitchFamily="34" charset="0"/>
-                <a:ea typeface="Calibri" pitchFamily="34" charset="-122"/>
-                <a:cs typeface="Calibri" pitchFamily="34" charset="-120"/>
-              </a:rPr>
-              <a:t>→</a:t>
-            </a:r>
-            <a:endParaRPr lang="en-US" sz="1500" dirty="0"/>
-          </a:p>
-        </p:txBody>
-      </p:sp>
-      <p:sp>
-        <p:nvSpPr>
-          <p:cNvPr id="7" name="Shape 5"/>
-          <p:cNvSpPr/>
-          <p:nvPr/>
-        </p:nvSpPr>
-        <p:spPr>
-          <a:xfrm>
-            <a:off x="2286000" y="1920240"/>
-            <a:ext cx="1234440" cy="566928"/>
+            <a:pPr algn="l" indent="0" marL="0">
+              <a:buNone/>
+            </a:pPr>
+            <a:r>
+              <a:rPr lang="en-US" sz="1050" i="1" dirty="0">
+                <a:solidFill>
+                  <a:srgbClr val="CADCFC"/>
+                </a:solidFill>
+                <a:latin typeface="Calibri" pitchFamily="34" charset="0"/>
+                <a:ea typeface="Calibri" pitchFamily="34" charset="-122"/>
+                <a:cs typeface="Calibri" pitchFamily="34" charset="-120"/>
+              </a:rPr>
+              <a:t>isolette</a:t>
+            </a:r>
+            <a:pPr algn="l" indent="0" marL="0">
+              <a:buNone/>
+            </a:pPr>
+            <a:r>
+              <a:rPr lang="en-US" sz="1050" b="1" i="1" dirty="0">
+                <a:solidFill>
+                  <a:srgbClr val="CADCFC"/>
+                </a:solidFill>
+                <a:latin typeface="Calibri" pitchFamily="34" charset="0"/>
+                <a:ea typeface="Calibri" pitchFamily="34" charset="-122"/>
+                <a:cs typeface="Calibri" pitchFamily="34" charset="-120"/>
+              </a:rPr>
+              <a:t>   ◀ the demo</a:t>
+            </a:r>
+            <a:endParaRPr lang="en-US" sz="1050" dirty="0"/>
+          </a:p>
+        </p:txBody>
+      </p:sp>
+      <p:sp>
+        <p:nvSpPr>
+          <p:cNvPr id="7" name="Text 5"/>
+          <p:cNvSpPr/>
+          <p:nvPr/>
+        </p:nvSpPr>
+        <p:spPr>
+          <a:xfrm>
+            <a:off x="914400" y="2423160"/>
+            <a:ext cx="4846320" cy="1252728"/>
+          </a:xfrm>
+          <a:prstGeom prst="rect">
+            <a:avLst/>
+          </a:prstGeom>
+          <a:noFill/>
+          <a:ln/>
+        </p:spPr>
+        <p:txBody>
+          <a:bodyPr wrap="square" lIns="0" tIns="0" rIns="0" bIns="0" rtlCol="0" anchor="t"/>
+          <a:lstStyle/>
+          <a:p>
+            <a:pPr algn="l" marL="342900" indent="-342900">
+              <a:spcAft>
+                <a:spcPts val="400"/>
+              </a:spcAft>
+              <a:buSzPct val="100000"/>
+              <a:buChar char="•"/>
+            </a:pPr>
+            <a:r>
+              <a:rPr lang="en-US" sz="1200" dirty="0">
+                <a:solidFill>
+                  <a:srgbClr val="CADCFC"/>
+                </a:solidFill>
+                <a:latin typeface="Calibri" pitchFamily="34" charset="0"/>
+                <a:ea typeface="Calibri" pitchFamily="34" charset="-122"/>
+                <a:cs typeface="Calibri" pitchFamily="34" charset="-120"/>
+              </a:rPr>
+              <a:t>SysMLv2 GUMBO component contracts</a:t>
+            </a:r>
+            <a:endParaRPr lang="en-US" sz="1200" dirty="0"/>
+          </a:p>
+          <a:p>
+            <a:pPr algn="l" marL="342900" indent="-342900">
+              <a:spcAft>
+                <a:spcPts val="400"/>
+              </a:spcAft>
+              <a:buSzPct val="100000"/>
+              <a:buChar char="•"/>
+            </a:pPr>
+            <a:r>
+              <a:rPr lang="en-US" sz="1200" dirty="0">
+                <a:solidFill>
+                  <a:srgbClr val="CADCFC"/>
+                </a:solidFill>
+                <a:latin typeface="Calibri" pitchFamily="34" charset="0"/>
+                <a:ea typeface="Calibri" pitchFamily="34" charset="-122"/>
+                <a:cs typeface="Calibri" pitchFamily="34" charset="-120"/>
+              </a:rPr>
+              <a:t>seL4 / Microkit runtime target</a:t>
+            </a:r>
+            <a:endParaRPr lang="en-US" sz="1200" dirty="0"/>
+          </a:p>
+          <a:p>
+            <a:pPr algn="l" marL="342900" indent="-342900">
+              <a:spcAft>
+                <a:spcPts val="400"/>
+              </a:spcAft>
+              <a:buSzPct val="100000"/>
+              <a:buChar char="•"/>
+            </a:pPr>
+            <a:r>
+              <a:rPr lang="en-US" sz="1200" dirty="0">
+                <a:solidFill>
+                  <a:srgbClr val="CADCFC"/>
+                </a:solidFill>
+                <a:latin typeface="Calibri" pitchFamily="34" charset="0"/>
+                <a:ea typeface="Calibri" pitchFamily="34" charset="-122"/>
+                <a:cs typeface="Calibri" pitchFamily="34" charset="-120"/>
+              </a:rPr>
+              <a:t>Every artifact class measured — the full demo</a:t>
+            </a:r>
+            <a:endParaRPr lang="en-US" sz="1200" dirty="0"/>
+          </a:p>
+        </p:txBody>
+      </p:sp>
+      <p:sp>
+        <p:nvSpPr>
+          <p:cNvPr id="8" name="Shape 6"/>
+          <p:cNvSpPr/>
+          <p:nvPr/>
+        </p:nvSpPr>
+        <p:spPr>
+          <a:xfrm>
+            <a:off x="6263640" y="1645920"/>
+            <a:ext cx="5349240" cy="2148840"/>
           </a:xfrm>
           <a:prstGeom prst="roundRect">
             <a:avLst>
-              <a:gd name="adj" fmla="val 9677"/>
+              <a:gd name="adj" fmla="val 2553"/>
             </a:avLst>
           </a:prstGeom>
           <a:solidFill>
-            <a:srgbClr val="1E2761"/>
+            <a:srgbClr val="F2F4F8"/>
           </a:solidFill>
-          <a:ln/>
-        </p:spPr>
-      </p:sp>
-      <p:sp>
-        <p:nvSpPr>
-          <p:cNvPr id="8" name="Text 6"/>
-          <p:cNvSpPr/>
-          <p:nvPr/>
-        </p:nvSpPr>
-        <p:spPr>
-          <a:xfrm>
-            <a:off x="2286000" y="1920240"/>
-            <a:ext cx="1234440" cy="566928"/>
-          </a:xfrm>
-          <a:prstGeom prst="rect">
-            <a:avLst/>
-          </a:prstGeom>
-          <a:noFill/>
-          <a:ln/>
-        </p:spPr>
-        <p:txBody>
-          <a:bodyPr wrap="square" lIns="254" tIns="254" rIns="254" bIns="254" rtlCol="0" anchor="ctr"/>
-          <a:lstStyle/>
-          <a:p>
-            <a:pPr algn="ctr" indent="0" marL="0">
-              <a:buNone/>
-            </a:pPr>
-            <a:r>
-              <a:rPr lang="en-US" sz="1300" b="1" dirty="0">
-                <a:solidFill>
-                  <a:srgbClr val="FFFFFF"/>
-                </a:solidFill>
-                <a:latin typeface="Calibri" pitchFamily="34" charset="0"/>
-                <a:ea typeface="Calibri" pitchFamily="34" charset="-122"/>
-                <a:cs typeface="Calibri" pitchFamily="34" charset="-120"/>
-              </a:rPr>
-              <a:t>HAMR</a:t>
-            </a:r>
-            <a:endParaRPr lang="en-US" sz="1300" dirty="0"/>
-          </a:p>
-        </p:txBody>
+          <a:ln w="12700">
+            <a:solidFill>
+              <a:srgbClr val="CADCFC"/>
+            </a:solidFill>
+            <a:prstDash val="solid"/>
+          </a:ln>
+        </p:spPr>
       </p:sp>
       <p:sp>
         <p:nvSpPr>
@@ -6159,8 +6222,8 @@
         </p:nvSpPr>
         <p:spPr>
           <a:xfrm>
-            <a:off x="3502152" y="1920240"/>
-            <a:ext cx="365760" cy="566928"/>
+            <a:off x="6492240" y="1755648"/>
+            <a:ext cx="4892040" cy="329184"/>
           </a:xfrm>
           <a:prstGeom prst="rect">
             <a:avLst/>
@@ -6172,11 +6235,50 @@
           <a:bodyPr wrap="square" lIns="0" tIns="0" rIns="0" bIns="0" rtlCol="0" anchor="ctr"/>
           <a:lstStyle/>
           <a:p>
-            <a:pPr algn="ctr" indent="0" marL="0">
-              <a:buNone/>
-            </a:pPr>
-            <a:r>
-              <a:rPr lang="en-US" sz="1500" dirty="0">
+            <a:pPr algn="l" indent="0" marL="0">
+              <a:buNone/>
+            </a:pPr>
+            <a:r>
+              <a:rPr lang="en-US" sz="1550" b="1" dirty="0">
+                <a:solidFill>
+                  <a:srgbClr val="1E2761"/>
+                </a:solidFill>
+                <a:latin typeface="Calibri" pitchFamily="34" charset="0"/>
+                <a:ea typeface="Calibri" pitchFamily="34" charset="-122"/>
+                <a:cs typeface="Calibri" pitchFamily="34" charset="-120"/>
+              </a:rPr>
+              <a:t>AADL → HAMR → Slang / Logika</a:t>
+            </a:r>
+            <a:endParaRPr lang="en-US" sz="1550" dirty="0"/>
+          </a:p>
+        </p:txBody>
+      </p:sp>
+      <p:sp>
+        <p:nvSpPr>
+          <p:cNvPr id="10" name="Text 8"/>
+          <p:cNvSpPr/>
+          <p:nvPr/>
+        </p:nvSpPr>
+        <p:spPr>
+          <a:xfrm>
+            <a:off x="6501384" y="2103120"/>
+            <a:ext cx="4892040" cy="256032"/>
+          </a:xfrm>
+          <a:prstGeom prst="rect">
+            <a:avLst/>
+          </a:prstGeom>
+          <a:noFill/>
+          <a:ln/>
+        </p:spPr>
+        <p:txBody>
+          <a:bodyPr wrap="square" lIns="0" tIns="0" rIns="0" bIns="0" rtlCol="0" anchor="ctr"/>
+          <a:lstStyle/>
+          <a:p>
+            <a:pPr algn="l" indent="0" marL="0">
+              <a:buNone/>
+            </a:pPr>
+            <a:r>
+              <a:rPr lang="en-US" sz="1050" i="1" dirty="0">
                 <a:solidFill>
                   <a:srgbClr val="5A6478"/>
                 </a:solidFill>
@@ -6184,83 +6286,134 @@
                 <a:ea typeface="Calibri" pitchFamily="34" charset="-122"/>
                 <a:cs typeface="Calibri" pitchFamily="34" charset="-120"/>
               </a:rPr>
-              <a:t>→</a:t>
-            </a:r>
-            <a:endParaRPr lang="en-US" sz="1500" dirty="0"/>
-          </a:p>
-        </p:txBody>
-      </p:sp>
-      <p:sp>
-        <p:nvSpPr>
-          <p:cNvPr id="10" name="Shape 8"/>
-          <p:cNvSpPr/>
-          <p:nvPr/>
-        </p:nvSpPr>
-        <p:spPr>
-          <a:xfrm>
-            <a:off x="3867912" y="1920240"/>
-            <a:ext cx="1719072" cy="566928"/>
+              <a:t>temp-control</a:t>
+            </a:r>
+            <a:endParaRPr lang="en-US" sz="1050" dirty="0"/>
+          </a:p>
+        </p:txBody>
+      </p:sp>
+      <p:sp>
+        <p:nvSpPr>
+          <p:cNvPr id="11" name="Text 9"/>
+          <p:cNvSpPr/>
+          <p:nvPr/>
+        </p:nvSpPr>
+        <p:spPr>
+          <a:xfrm>
+            <a:off x="6537960" y="2423160"/>
+            <a:ext cx="4846320" cy="1252728"/>
+          </a:xfrm>
+          <a:prstGeom prst="rect">
+            <a:avLst/>
+          </a:prstGeom>
+          <a:noFill/>
+          <a:ln/>
+        </p:spPr>
+        <p:txBody>
+          <a:bodyPr wrap="square" lIns="0" tIns="0" rIns="0" bIns="0" rtlCol="0" anchor="t"/>
+          <a:lstStyle/>
+          <a:p>
+            <a:pPr algn="l" marL="342900" indent="-342900">
+              <a:spcAft>
+                <a:spcPts val="400"/>
+              </a:spcAft>
+              <a:buSzPct val="100000"/>
+              <a:buChar char="•"/>
+            </a:pPr>
+            <a:r>
+              <a:rPr lang="en-US" sz="1200" dirty="0">
+                <a:solidFill>
+                  <a:srgbClr val="212121"/>
+                </a:solidFill>
+                <a:latin typeface="Calibri" pitchFamily="34" charset="0"/>
+                <a:ea typeface="Calibri" pitchFamily="34" charset="-122"/>
+                <a:cs typeface="Calibri" pitchFamily="34" charset="-120"/>
+              </a:rPr>
+              <a:t>AADL GUMBO component contracts</a:t>
+            </a:r>
+            <a:endParaRPr lang="en-US" sz="1200" dirty="0"/>
+          </a:p>
+          <a:p>
+            <a:pPr algn="l" marL="342900" indent="-342900">
+              <a:spcAft>
+                <a:spcPts val="400"/>
+              </a:spcAft>
+              <a:buSzPct val="100000"/>
+              <a:buChar char="•"/>
+            </a:pPr>
+            <a:r>
+              <a:rPr lang="en-US" sz="1200" dirty="0">
+                <a:solidFill>
+                  <a:srgbClr val="212121"/>
+                </a:solidFill>
+                <a:latin typeface="Calibri" pitchFamily="34" charset="0"/>
+                <a:ea typeface="Calibri" pitchFamily="34" charset="-122"/>
+                <a:cs typeface="Calibri" pitchFamily="34" charset="-120"/>
+              </a:rPr>
+              <a:t>JVM runtime target</a:t>
+            </a:r>
+            <a:endParaRPr lang="en-US" sz="1200" dirty="0"/>
+          </a:p>
+          <a:p>
+            <a:pPr algn="l" marL="342900" indent="-342900">
+              <a:spcAft>
+                <a:spcPts val="400"/>
+              </a:spcAft>
+              <a:buSzPct val="100000"/>
+              <a:buChar char="•"/>
+            </a:pPr>
+            <a:r>
+              <a:rPr lang="en-US" sz="1200" dirty="0">
+                <a:solidFill>
+                  <a:srgbClr val="212121"/>
+                </a:solidFill>
+                <a:latin typeface="Calibri" pitchFamily="34" charset="0"/>
+                <a:ea typeface="Calibri" pitchFamily="34" charset="-122"/>
+                <a:cs typeface="Calibri" pitchFamily="34" charset="-120"/>
+              </a:rPr>
+              <a:t>Same blackboard, similar Copland protocols</a:t>
+            </a:r>
+            <a:endParaRPr lang="en-US" sz="1200" dirty="0"/>
+          </a:p>
+        </p:txBody>
+      </p:sp>
+      <p:sp>
+        <p:nvSpPr>
+          <p:cNvPr id="12" name="Shape 10"/>
+          <p:cNvSpPr/>
+          <p:nvPr/>
+        </p:nvSpPr>
+        <p:spPr>
+          <a:xfrm>
+            <a:off x="640080" y="4069080"/>
+            <a:ext cx="5349240" cy="2148840"/>
           </a:xfrm>
           <a:prstGeom prst="roundRect">
             <a:avLst>
-              <a:gd name="adj" fmla="val 9677"/>
+              <a:gd name="adj" fmla="val 2553"/>
             </a:avLst>
           </a:prstGeom>
           <a:solidFill>
-            <a:srgbClr val="1E2761"/>
+            <a:srgbClr val="F2F4F8"/>
           </a:solidFill>
-          <a:ln/>
-        </p:spPr>
-      </p:sp>
-      <p:sp>
-        <p:nvSpPr>
-          <p:cNvPr id="11" name="Text 9"/>
-          <p:cNvSpPr/>
-          <p:nvPr/>
-        </p:nvSpPr>
-        <p:spPr>
-          <a:xfrm>
-            <a:off x="3867912" y="1920240"/>
-            <a:ext cx="1719072" cy="566928"/>
-          </a:xfrm>
-          <a:prstGeom prst="rect">
-            <a:avLst/>
-          </a:prstGeom>
-          <a:noFill/>
-          <a:ln/>
-        </p:spPr>
-        <p:txBody>
-          <a:bodyPr wrap="square" lIns="254" tIns="254" rIns="254" bIns="254" rtlCol="0" anchor="ctr"/>
-          <a:lstStyle/>
-          <a:p>
-            <a:pPr algn="ctr" indent="0" marL="0">
-              <a:buNone/>
-            </a:pPr>
-            <a:r>
-              <a:rPr lang="en-US" sz="1300" b="1" dirty="0">
-                <a:solidFill>
-                  <a:srgbClr val="FFFFFF"/>
-                </a:solidFill>
-                <a:latin typeface="Calibri" pitchFamily="34" charset="0"/>
-                <a:ea typeface="Calibri" pitchFamily="34" charset="-122"/>
-                <a:cs typeface="Calibri" pitchFamily="34" charset="-120"/>
-              </a:rPr>
-              <a:t>Verus · Rust</a:t>
-            </a:r>
-            <a:endParaRPr lang="en-US" sz="1300" dirty="0"/>
-          </a:p>
-        </p:txBody>
-      </p:sp>
-      <p:sp>
-        <p:nvSpPr>
-          <p:cNvPr id="12" name="Text 10"/>
-          <p:cNvSpPr/>
-          <p:nvPr/>
-        </p:nvSpPr>
-        <p:spPr>
-          <a:xfrm>
-            <a:off x="5568696" y="1920240"/>
-            <a:ext cx="365760" cy="566928"/>
+          <a:ln w="12700">
+            <a:solidFill>
+              <a:srgbClr val="CADCFC"/>
+            </a:solidFill>
+            <a:prstDash val="solid"/>
+          </a:ln>
+        </p:spPr>
+      </p:sp>
+      <p:sp>
+        <p:nvSpPr>
+          <p:cNvPr id="13" name="Text 11"/>
+          <p:cNvSpPr/>
+          <p:nvPr/>
+        </p:nvSpPr>
+        <p:spPr>
+          <a:xfrm>
+            <a:off x="868680" y="4178808"/>
+            <a:ext cx="4892040" cy="329184"/>
           </a:xfrm>
           <a:prstGeom prst="rect">
             <a:avLst/>
@@ -6272,11 +6425,50 @@
           <a:bodyPr wrap="square" lIns="0" tIns="0" rIns="0" bIns="0" rtlCol="0" anchor="ctr"/>
           <a:lstStyle/>
           <a:p>
-            <a:pPr algn="ctr" indent="0" marL="0">
-              <a:buNone/>
-            </a:pPr>
-            <a:r>
-              <a:rPr lang="en-US" sz="1500" dirty="0">
+            <a:pPr algn="l" indent="0" marL="0">
+              <a:buNone/>
+            </a:pPr>
+            <a:r>
+              <a:rPr lang="en-US" sz="1550" b="1" dirty="0">
+                <a:solidFill>
+                  <a:srgbClr val="1E2761"/>
+                </a:solidFill>
+                <a:latin typeface="Calibri" pitchFamily="34" charset="0"/>
+                <a:ea typeface="Calibri" pitchFamily="34" charset="-122"/>
+                <a:cs typeface="Calibri" pitchFamily="34" charset="-120"/>
+              </a:rPr>
+              <a:t>Standalone Rust / Verus</a:t>
+            </a:r>
+            <a:endParaRPr lang="en-US" sz="1550" dirty="0"/>
+          </a:p>
+        </p:txBody>
+      </p:sp>
+      <p:sp>
+        <p:nvSpPr>
+          <p:cNvPr id="14" name="Text 12"/>
+          <p:cNvSpPr/>
+          <p:nvPr/>
+        </p:nvSpPr>
+        <p:spPr>
+          <a:xfrm>
+            <a:off x="877824" y="4526280"/>
+            <a:ext cx="4892040" cy="256032"/>
+          </a:xfrm>
+          <a:prstGeom prst="rect">
+            <a:avLst/>
+          </a:prstGeom>
+          <a:noFill/>
+          <a:ln/>
+        </p:spPr>
+        <p:txBody>
+          <a:bodyPr wrap="square" lIns="0" tIns="0" rIns="0" bIns="0" rtlCol="0" anchor="ctr"/>
+          <a:lstStyle/>
+          <a:p>
+            <a:pPr algn="l" indent="0" marL="0">
+              <a:buNone/>
+            </a:pPr>
+            <a:r>
+              <a:rPr lang="en-US" sz="1050" i="1" dirty="0">
                 <a:solidFill>
                   <a:srgbClr val="5A6478"/>
                 </a:solidFill>
@@ -6284,83 +6476,134 @@
                 <a:ea typeface="Calibri" pitchFamily="34" charset="-122"/>
                 <a:cs typeface="Calibri" pitchFamily="34" charset="-120"/>
               </a:rPr>
-              <a:t>→</a:t>
-            </a:r>
-            <a:endParaRPr lang="en-US" sz="1500" dirty="0"/>
-          </a:p>
-        </p:txBody>
-      </p:sp>
-      <p:sp>
-        <p:nvSpPr>
-          <p:cNvPr id="13" name="Shape 11"/>
-          <p:cNvSpPr/>
-          <p:nvPr/>
-        </p:nvSpPr>
-        <p:spPr>
-          <a:xfrm>
-            <a:off x="5934456" y="1920240"/>
-            <a:ext cx="2034540" cy="566928"/>
+              <a:t>find-max-verus</a:t>
+            </a:r>
+            <a:endParaRPr lang="en-US" sz="1050" dirty="0"/>
+          </a:p>
+        </p:txBody>
+      </p:sp>
+      <p:sp>
+        <p:nvSpPr>
+          <p:cNvPr id="15" name="Text 13"/>
+          <p:cNvSpPr/>
+          <p:nvPr/>
+        </p:nvSpPr>
+        <p:spPr>
+          <a:xfrm>
+            <a:off x="914400" y="4846320"/>
+            <a:ext cx="4846320" cy="1252728"/>
+          </a:xfrm>
+          <a:prstGeom prst="rect">
+            <a:avLst/>
+          </a:prstGeom>
+          <a:noFill/>
+          <a:ln/>
+        </p:spPr>
+        <p:txBody>
+          <a:bodyPr wrap="square" lIns="0" tIns="0" rIns="0" bIns="0" rtlCol="0" anchor="t"/>
+          <a:lstStyle/>
+          <a:p>
+            <a:pPr algn="l" marL="342900" indent="-342900">
+              <a:spcAft>
+                <a:spcPts val="400"/>
+              </a:spcAft>
+              <a:buSzPct val="100000"/>
+              <a:buChar char="•"/>
+            </a:pPr>
+            <a:r>
+              <a:rPr lang="en-US" sz="1200" dirty="0">
+                <a:solidFill>
+                  <a:srgbClr val="212121"/>
+                </a:solidFill>
+                <a:latin typeface="Calibri" pitchFamily="34" charset="0"/>
+                <a:ea typeface="Calibri" pitchFamily="34" charset="-122"/>
+                <a:cs typeface="Calibri" pitchFamily="34" charset="-120"/>
+              </a:rPr>
+              <a:t>Contracts + proofs written directly in Verus</a:t>
+            </a:r>
+            <a:endParaRPr lang="en-US" sz="1200" dirty="0"/>
+          </a:p>
+          <a:p>
+            <a:pPr algn="l" marL="342900" indent="-342900">
+              <a:spcAft>
+                <a:spcPts val="400"/>
+              </a:spcAft>
+              <a:buSzPct val="100000"/>
+              <a:buChar char="•"/>
+            </a:pPr>
+            <a:r>
+              <a:rPr lang="en-US" sz="1200" dirty="0">
+                <a:solidFill>
+                  <a:srgbClr val="212121"/>
+                </a:solidFill>
+                <a:latin typeface="Calibri" pitchFamily="34" charset="0"/>
+                <a:ea typeface="Calibri" pitchFamily="34" charset="-122"/>
+                <a:cs typeface="Calibri" pitchFamily="34" charset="-120"/>
+              </a:rPr>
+              <a:t>No model, no codegen — implementation + proof classes only</a:t>
+            </a:r>
+            <a:endParaRPr lang="en-US" sz="1200" dirty="0"/>
+          </a:p>
+          <a:p>
+            <a:pPr algn="l" marL="342900" indent="-342900">
+              <a:spcAft>
+                <a:spcPts val="400"/>
+              </a:spcAft>
+              <a:buSzPct val="100000"/>
+              <a:buChar char="•"/>
+            </a:pPr>
+            <a:r>
+              <a:rPr lang="en-US" sz="1200" dirty="0">
+                <a:solidFill>
+                  <a:srgbClr val="212121"/>
+                </a:solidFill>
+                <a:latin typeface="Calibri" pitchFamily="34" charset="0"/>
+                <a:ea typeface="Calibri" pitchFamily="34" charset="-122"/>
+                <a:cs typeface="Calibri" pitchFamily="34" charset="-120"/>
+              </a:rPr>
+              <a:t>Proof-repair experiments: AutoVerus, KU Dogtreat linear planner</a:t>
+            </a:r>
+            <a:endParaRPr lang="en-US" sz="1200" dirty="0"/>
+          </a:p>
+        </p:txBody>
+      </p:sp>
+      <p:sp>
+        <p:nvSpPr>
+          <p:cNvPr id="16" name="Shape 14"/>
+          <p:cNvSpPr/>
+          <p:nvPr/>
+        </p:nvSpPr>
+        <p:spPr>
+          <a:xfrm>
+            <a:off x="6263640" y="4069080"/>
+            <a:ext cx="5349240" cy="2148840"/>
           </a:xfrm>
           <a:prstGeom prst="roundRect">
             <a:avLst>
-              <a:gd name="adj" fmla="val 9677"/>
+              <a:gd name="adj" fmla="val 2553"/>
             </a:avLst>
           </a:prstGeom>
           <a:solidFill>
-            <a:srgbClr val="1E2761"/>
+            <a:srgbClr val="F2F4F8"/>
           </a:solidFill>
-          <a:ln/>
-        </p:spPr>
-      </p:sp>
-      <p:sp>
-        <p:nvSpPr>
-          <p:cNvPr id="14" name="Text 12"/>
-          <p:cNvSpPr/>
-          <p:nvPr/>
-        </p:nvSpPr>
-        <p:spPr>
-          <a:xfrm>
-            <a:off x="5934456" y="1920240"/>
-            <a:ext cx="2034540" cy="566928"/>
-          </a:xfrm>
-          <a:prstGeom prst="rect">
-            <a:avLst/>
-          </a:prstGeom>
-          <a:noFill/>
-          <a:ln/>
-        </p:spPr>
-        <p:txBody>
-          <a:bodyPr wrap="square" lIns="254" tIns="254" rIns="254" bIns="254" rtlCol="0" anchor="ctr"/>
-          <a:lstStyle/>
-          <a:p>
-            <a:pPr algn="ctr" indent="0" marL="0">
-              <a:buNone/>
-            </a:pPr>
-            <a:r>
-              <a:rPr lang="en-US" sz="1300" b="1" dirty="0">
-                <a:solidFill>
-                  <a:srgbClr val="FFFFFF"/>
-                </a:solidFill>
-                <a:latin typeface="Calibri" pitchFamily="34" charset="0"/>
-                <a:ea typeface="Calibri" pitchFamily="34" charset="-122"/>
-                <a:cs typeface="Calibri" pitchFamily="34" charset="-120"/>
-              </a:rPr>
-              <a:t>seL4 · Microkit</a:t>
-            </a:r>
-            <a:endParaRPr lang="en-US" sz="1300" dirty="0"/>
-          </a:p>
-        </p:txBody>
-      </p:sp>
-      <p:sp>
-        <p:nvSpPr>
-          <p:cNvPr id="15" name="Text 13"/>
-          <p:cNvSpPr/>
-          <p:nvPr/>
-        </p:nvSpPr>
-        <p:spPr>
-          <a:xfrm>
-            <a:off x="8362188" y="1920240"/>
-            <a:ext cx="2194560" cy="566928"/>
+          <a:ln w="12700">
+            <a:solidFill>
+              <a:srgbClr val="CADCFC"/>
+            </a:solidFill>
+            <a:prstDash val="solid"/>
+          </a:ln>
+        </p:spPr>
+      </p:sp>
+      <p:sp>
+        <p:nvSpPr>
+          <p:cNvPr id="17" name="Text 15"/>
+          <p:cNvSpPr/>
+          <p:nvPr/>
+        </p:nvSpPr>
+        <p:spPr>
+          <a:xfrm>
+            <a:off x="6492240" y="4178808"/>
+            <a:ext cx="4892040" cy="329184"/>
           </a:xfrm>
           <a:prstGeom prst="rect">
             <a:avLst/>
@@ -6376,7 +6619,7 @@
               <a:buNone/>
             </a:pPr>
             <a:r>
-              <a:rPr lang="en-US" sz="1200" b="1" i="1" dirty="0">
+              <a:rPr lang="en-US" sz="1550" b="1" dirty="0">
                 <a:solidFill>
                   <a:srgbClr val="1E2761"/>
                 </a:solidFill>
@@ -6384,748 +6627,154 @@
                 <a:ea typeface="Calibri" pitchFamily="34" charset="-122"/>
                 <a:cs typeface="Calibri" pitchFamily="34" charset="-120"/>
               </a:rPr>
-              <a:t>◀ demo</a:t>
+              <a:t>Interactive Theorem Provers:  Lean / Rocq</a:t>
+            </a:r>
+            <a:endParaRPr lang="en-US" sz="1550" dirty="0"/>
+          </a:p>
+        </p:txBody>
+      </p:sp>
+      <p:sp>
+        <p:nvSpPr>
+          <p:cNvPr id="18" name="Text 16"/>
+          <p:cNvSpPr/>
+          <p:nvPr/>
+        </p:nvSpPr>
+        <p:spPr>
+          <a:xfrm>
+            <a:off x="6501384" y="4526280"/>
+            <a:ext cx="4892040" cy="256032"/>
+          </a:xfrm>
+          <a:prstGeom prst="rect">
+            <a:avLst/>
+          </a:prstGeom>
+          <a:noFill/>
+          <a:ln/>
+        </p:spPr>
+        <p:txBody>
+          <a:bodyPr wrap="square" lIns="0" tIns="0" rIns="0" bIns="0" rtlCol="0" anchor="ctr"/>
+          <a:lstStyle/>
+          <a:p>
+            <a:pPr algn="l" indent="0" marL="0">
+              <a:buNone/>
+            </a:pPr>
+            <a:r>
+              <a:rPr lang="en-US" sz="1050" i="1" dirty="0">
+                <a:solidFill>
+                  <a:srgbClr val="5A6478"/>
+                </a:solidFill>
+                <a:latin typeface="Calibri" pitchFamily="34" charset="0"/>
+                <a:ea typeface="Calibri" pitchFamily="34" charset="-122"/>
+                <a:cs typeface="Calibri" pitchFamily="34" charset="-120"/>
+              </a:rPr>
+              <a:t>landing-gear, temp-control</a:t>
+            </a:r>
+            <a:endParaRPr lang="en-US" sz="1050" dirty="0"/>
+          </a:p>
+        </p:txBody>
+      </p:sp>
+      <p:sp>
+        <p:nvSpPr>
+          <p:cNvPr id="19" name="Text 17"/>
+          <p:cNvSpPr/>
+          <p:nvPr/>
+        </p:nvSpPr>
+        <p:spPr>
+          <a:xfrm>
+            <a:off x="6537960" y="4846320"/>
+            <a:ext cx="4846320" cy="1252728"/>
+          </a:xfrm>
+          <a:prstGeom prst="rect">
+            <a:avLst/>
+          </a:prstGeom>
+          <a:noFill/>
+          <a:ln/>
+        </p:spPr>
+        <p:txBody>
+          <a:bodyPr wrap="square" lIns="0" tIns="0" rIns="0" bIns="0" rtlCol="0" anchor="t"/>
+          <a:lstStyle/>
+          <a:p>
+            <a:pPr algn="l" marL="342900" indent="-342900">
+              <a:spcAft>
+                <a:spcPts val="400"/>
+              </a:spcAft>
+              <a:buSzPct val="100000"/>
+              <a:buChar char="•"/>
+            </a:pPr>
+            <a:r>
+              <a:rPr lang="en-US" sz="1200" dirty="0">
+                <a:solidFill>
+                  <a:srgbClr val="212121"/>
+                </a:solidFill>
+                <a:latin typeface="Calibri" pitchFamily="34" charset="0"/>
+                <a:ea typeface="Calibri" pitchFamily="34" charset="-122"/>
+                <a:cs typeface="Calibri" pitchFamily="34" charset="-120"/>
+              </a:rPr>
+              <a:t>Blessed theorem statements, workflow-owned implementations, proofs</a:t>
             </a:r>
             <a:endParaRPr lang="en-US" sz="1200" dirty="0"/>
           </a:p>
-        </p:txBody>
-      </p:sp>
-      <p:sp>
-        <p:nvSpPr>
-          <p:cNvPr id="16" name="Text 14"/>
-          <p:cNvSpPr/>
-          <p:nvPr/>
-        </p:nvSpPr>
-        <p:spPr>
-          <a:xfrm>
-            <a:off x="658368" y="2468880"/>
-            <a:ext cx="10515600" cy="274320"/>
-          </a:xfrm>
-          <a:prstGeom prst="rect">
-            <a:avLst/>
-          </a:prstGeom>
-          <a:noFill/>
-          <a:ln/>
-        </p:spPr>
-        <p:txBody>
-          <a:bodyPr wrap="square" lIns="0" tIns="0" rIns="0" bIns="0" rtlCol="0" anchor="ctr"/>
-          <a:lstStyle/>
-          <a:p>
-            <a:pPr algn="l" indent="0" marL="0">
-              <a:buNone/>
-            </a:pPr>
-            <a:r>
-              <a:rPr lang="en-US" sz="1100" i="1" dirty="0">
-                <a:solidFill>
-                  <a:srgbClr val="5A6478"/>
-                </a:solidFill>
-                <a:latin typeface="Calibri" pitchFamily="34" charset="0"/>
-                <a:ea typeface="Calibri" pitchFamily="34" charset="-122"/>
-                <a:cs typeface="Calibri" pitchFamily="34" charset="-120"/>
-              </a:rPr>
-              <a:t>the isolette — the demo you just saw</a:t>
-            </a:r>
-            <a:endParaRPr lang="en-US" sz="1100" dirty="0"/>
-          </a:p>
-        </p:txBody>
-      </p:sp>
-      <p:sp>
-        <p:nvSpPr>
-          <p:cNvPr id="17" name="Shape 15"/>
-          <p:cNvSpPr/>
-          <p:nvPr/>
-        </p:nvSpPr>
-        <p:spPr>
-          <a:xfrm>
-            <a:off x="640080" y="3063240"/>
-            <a:ext cx="1234440" cy="566928"/>
-          </a:xfrm>
-          <a:prstGeom prst="roundRect">
-            <a:avLst>
-              <a:gd name="adj" fmla="val 9677"/>
-            </a:avLst>
-          </a:prstGeom>
-          <a:solidFill>
-            <a:srgbClr val="3A4A8C"/>
-          </a:solidFill>
-          <a:ln/>
-        </p:spPr>
-      </p:sp>
-      <p:sp>
-        <p:nvSpPr>
-          <p:cNvPr id="18" name="Text 16"/>
-          <p:cNvSpPr/>
-          <p:nvPr/>
-        </p:nvSpPr>
-        <p:spPr>
-          <a:xfrm>
-            <a:off x="640080" y="3063240"/>
-            <a:ext cx="1234440" cy="566928"/>
-          </a:xfrm>
-          <a:prstGeom prst="rect">
-            <a:avLst/>
-          </a:prstGeom>
-          <a:noFill/>
-          <a:ln/>
-        </p:spPr>
-        <p:txBody>
-          <a:bodyPr wrap="square" lIns="254" tIns="254" rIns="254" bIns="254" rtlCol="0" anchor="ctr"/>
-          <a:lstStyle/>
-          <a:p>
-            <a:pPr algn="ctr" indent="0" marL="0">
-              <a:buNone/>
-            </a:pPr>
-            <a:r>
-              <a:rPr lang="en-US" sz="1300" b="1" dirty="0">
-                <a:solidFill>
-                  <a:srgbClr val="FFFFFF"/>
-                </a:solidFill>
-                <a:latin typeface="Calibri" pitchFamily="34" charset="0"/>
-                <a:ea typeface="Calibri" pitchFamily="34" charset="-122"/>
-                <a:cs typeface="Calibri" pitchFamily="34" charset="-120"/>
-              </a:rPr>
-              <a:t>AADL</a:t>
-            </a:r>
-            <a:endParaRPr lang="en-US" sz="1300" dirty="0"/>
-          </a:p>
-        </p:txBody>
-      </p:sp>
-      <p:sp>
-        <p:nvSpPr>
-          <p:cNvPr id="19" name="Text 17"/>
-          <p:cNvSpPr/>
-          <p:nvPr/>
-        </p:nvSpPr>
-        <p:spPr>
-          <a:xfrm>
-            <a:off x="1856232" y="3063240"/>
-            <a:ext cx="365760" cy="566928"/>
-          </a:xfrm>
-          <a:prstGeom prst="rect">
-            <a:avLst/>
-          </a:prstGeom>
-          <a:noFill/>
-          <a:ln/>
-        </p:spPr>
-        <p:txBody>
-          <a:bodyPr wrap="square" lIns="0" tIns="0" rIns="0" bIns="0" rtlCol="0" anchor="ctr"/>
-          <a:lstStyle/>
-          <a:p>
-            <a:pPr algn="ctr" indent="0" marL="0">
-              <a:buNone/>
-            </a:pPr>
-            <a:r>
-              <a:rPr lang="en-US" sz="1500" dirty="0">
-                <a:solidFill>
-                  <a:srgbClr val="5A6478"/>
-                </a:solidFill>
-                <a:latin typeface="Calibri" pitchFamily="34" charset="0"/>
-                <a:ea typeface="Calibri" pitchFamily="34" charset="-122"/>
-                <a:cs typeface="Calibri" pitchFamily="34" charset="-120"/>
-              </a:rPr>
-              <a:t>→</a:t>
-            </a:r>
-            <a:endParaRPr lang="en-US" sz="1500" dirty="0"/>
-          </a:p>
-        </p:txBody>
-      </p:sp>
-      <p:sp>
-        <p:nvSpPr>
-          <p:cNvPr id="20" name="Shape 18"/>
-          <p:cNvSpPr/>
-          <p:nvPr/>
-        </p:nvSpPr>
-        <p:spPr>
-          <a:xfrm>
-            <a:off x="2221992" y="3063240"/>
-            <a:ext cx="1234440" cy="566928"/>
-          </a:xfrm>
-          <a:prstGeom prst="roundRect">
-            <a:avLst>
-              <a:gd name="adj" fmla="val 9677"/>
-            </a:avLst>
-          </a:prstGeom>
-          <a:solidFill>
-            <a:srgbClr val="3A4A8C"/>
-          </a:solidFill>
-          <a:ln/>
-        </p:spPr>
-      </p:sp>
-      <p:sp>
-        <p:nvSpPr>
-          <p:cNvPr id="21" name="Text 19"/>
-          <p:cNvSpPr/>
-          <p:nvPr/>
-        </p:nvSpPr>
-        <p:spPr>
-          <a:xfrm>
-            <a:off x="2221992" y="3063240"/>
-            <a:ext cx="1234440" cy="566928"/>
-          </a:xfrm>
-          <a:prstGeom prst="rect">
-            <a:avLst/>
-          </a:prstGeom>
-          <a:noFill/>
-          <a:ln/>
-        </p:spPr>
-        <p:txBody>
-          <a:bodyPr wrap="square" lIns="254" tIns="254" rIns="254" bIns="254" rtlCol="0" anchor="ctr"/>
-          <a:lstStyle/>
-          <a:p>
-            <a:pPr algn="ctr" indent="0" marL="0">
-              <a:buNone/>
-            </a:pPr>
-            <a:r>
-              <a:rPr lang="en-US" sz="1300" b="1" dirty="0">
-                <a:solidFill>
-                  <a:srgbClr val="FFFFFF"/>
-                </a:solidFill>
-                <a:latin typeface="Calibri" pitchFamily="34" charset="0"/>
-                <a:ea typeface="Calibri" pitchFamily="34" charset="-122"/>
-                <a:cs typeface="Calibri" pitchFamily="34" charset="-120"/>
-              </a:rPr>
-              <a:t>HAMR</a:t>
-            </a:r>
-            <a:endParaRPr lang="en-US" sz="1300" dirty="0"/>
-          </a:p>
-        </p:txBody>
-      </p:sp>
-      <p:sp>
-        <p:nvSpPr>
-          <p:cNvPr id="22" name="Text 20"/>
-          <p:cNvSpPr/>
-          <p:nvPr/>
-        </p:nvSpPr>
-        <p:spPr>
-          <a:xfrm>
-            <a:off x="3438144" y="3063240"/>
-            <a:ext cx="365760" cy="566928"/>
-          </a:xfrm>
-          <a:prstGeom prst="rect">
-            <a:avLst/>
-          </a:prstGeom>
-          <a:noFill/>
-          <a:ln/>
-        </p:spPr>
-        <p:txBody>
-          <a:bodyPr wrap="square" lIns="0" tIns="0" rIns="0" bIns="0" rtlCol="0" anchor="ctr"/>
-          <a:lstStyle/>
-          <a:p>
-            <a:pPr algn="ctr" indent="0" marL="0">
-              <a:buNone/>
-            </a:pPr>
-            <a:r>
-              <a:rPr lang="en-US" sz="1500" dirty="0">
-                <a:solidFill>
-                  <a:srgbClr val="5A6478"/>
-                </a:solidFill>
-                <a:latin typeface="Calibri" pitchFamily="34" charset="0"/>
-                <a:ea typeface="Calibri" pitchFamily="34" charset="-122"/>
-                <a:cs typeface="Calibri" pitchFamily="34" charset="-120"/>
-              </a:rPr>
-              <a:t>→</a:t>
-            </a:r>
-            <a:endParaRPr lang="en-US" sz="1500" dirty="0"/>
-          </a:p>
-        </p:txBody>
-      </p:sp>
-      <p:sp>
-        <p:nvSpPr>
-          <p:cNvPr id="23" name="Shape 21"/>
-          <p:cNvSpPr/>
-          <p:nvPr/>
-        </p:nvSpPr>
-        <p:spPr>
-          <a:xfrm>
-            <a:off x="3803904" y="3063240"/>
-            <a:ext cx="1613916" cy="566928"/>
-          </a:xfrm>
-          <a:prstGeom prst="roundRect">
-            <a:avLst>
-              <a:gd name="adj" fmla="val 9677"/>
-            </a:avLst>
-          </a:prstGeom>
-          <a:solidFill>
-            <a:srgbClr val="3A4A8C"/>
-          </a:solidFill>
-          <a:ln/>
-        </p:spPr>
-      </p:sp>
-      <p:sp>
-        <p:nvSpPr>
-          <p:cNvPr id="24" name="Text 22"/>
-          <p:cNvSpPr/>
-          <p:nvPr/>
-        </p:nvSpPr>
-        <p:spPr>
-          <a:xfrm>
-            <a:off x="3803904" y="3063240"/>
-            <a:ext cx="1613916" cy="566928"/>
-          </a:xfrm>
-          <a:prstGeom prst="rect">
-            <a:avLst/>
-          </a:prstGeom>
-          <a:noFill/>
-          <a:ln/>
-        </p:spPr>
-        <p:txBody>
-          <a:bodyPr wrap="square" lIns="254" tIns="254" rIns="254" bIns="254" rtlCol="0" anchor="ctr"/>
-          <a:lstStyle/>
-          <a:p>
-            <a:pPr algn="ctr" indent="0" marL="0">
-              <a:buNone/>
-            </a:pPr>
-            <a:r>
-              <a:rPr lang="en-US" sz="1300" b="1" dirty="0">
-                <a:solidFill>
-                  <a:srgbClr val="FFFFFF"/>
-                </a:solidFill>
-                <a:latin typeface="Calibri" pitchFamily="34" charset="0"/>
-                <a:ea typeface="Calibri" pitchFamily="34" charset="-122"/>
-                <a:cs typeface="Calibri" pitchFamily="34" charset="-120"/>
-              </a:rPr>
-              <a:t>Slang · JVM</a:t>
-            </a:r>
-            <a:endParaRPr lang="en-US" sz="1300" dirty="0"/>
-          </a:p>
-        </p:txBody>
-      </p:sp>
-      <p:sp>
-        <p:nvSpPr>
-          <p:cNvPr id="25" name="Text 23"/>
-          <p:cNvSpPr/>
-          <p:nvPr/>
-        </p:nvSpPr>
-        <p:spPr>
-          <a:xfrm>
-            <a:off x="658368" y="3611880"/>
-            <a:ext cx="10515600" cy="274320"/>
-          </a:xfrm>
-          <a:prstGeom prst="rect">
-            <a:avLst/>
-          </a:prstGeom>
-          <a:noFill/>
-          <a:ln/>
-        </p:spPr>
-        <p:txBody>
-          <a:bodyPr wrap="square" lIns="0" tIns="0" rIns="0" bIns="0" rtlCol="0" anchor="ctr"/>
-          <a:lstStyle/>
-          <a:p>
-            <a:pPr algn="l" indent="0" marL="0">
-              <a:buNone/>
-            </a:pPr>
-            <a:r>
-              <a:rPr lang="en-US" sz="1100" i="1" dirty="0">
-                <a:solidFill>
-                  <a:srgbClr val="5A6478"/>
-                </a:solidFill>
-                <a:latin typeface="Calibri" pitchFamily="34" charset="0"/>
-                <a:ea typeface="Calibri" pitchFamily="34" charset="-122"/>
-                <a:cs typeface="Calibri" pitchFamily="34" charset="-120"/>
-              </a:rPr>
-              <a:t>a different modeling language and target runtime, same artifact classes and Copland protocols  (temp-control)</a:t>
-            </a:r>
-            <a:endParaRPr lang="en-US" sz="1100" dirty="0"/>
-          </a:p>
-        </p:txBody>
-      </p:sp>
-      <p:sp>
-        <p:nvSpPr>
-          <p:cNvPr id="26" name="Shape 24"/>
-          <p:cNvSpPr/>
-          <p:nvPr/>
-        </p:nvSpPr>
-        <p:spPr>
-          <a:xfrm>
-            <a:off x="640080" y="4206240"/>
-            <a:ext cx="1234440" cy="566928"/>
-          </a:xfrm>
-          <a:prstGeom prst="roundRect">
-            <a:avLst>
-              <a:gd name="adj" fmla="val 9677"/>
-            </a:avLst>
-          </a:prstGeom>
-          <a:solidFill>
-            <a:srgbClr val="3A4A8C"/>
-          </a:solidFill>
-          <a:ln/>
-        </p:spPr>
-      </p:sp>
-      <p:sp>
-        <p:nvSpPr>
-          <p:cNvPr id="27" name="Text 25"/>
-          <p:cNvSpPr/>
-          <p:nvPr/>
-        </p:nvSpPr>
-        <p:spPr>
-          <a:xfrm>
-            <a:off x="640080" y="4206240"/>
-            <a:ext cx="1234440" cy="566928"/>
-          </a:xfrm>
-          <a:prstGeom prst="rect">
-            <a:avLst/>
-          </a:prstGeom>
-          <a:noFill/>
-          <a:ln/>
-        </p:spPr>
-        <p:txBody>
-          <a:bodyPr wrap="square" lIns="254" tIns="254" rIns="254" bIns="254" rtlCol="0" anchor="ctr"/>
-          <a:lstStyle/>
-          <a:p>
-            <a:pPr algn="ctr" indent="0" marL="0">
-              <a:buNone/>
-            </a:pPr>
-            <a:r>
-              <a:rPr lang="en-US" sz="1300" b="1" dirty="0">
-                <a:solidFill>
-                  <a:srgbClr val="FFFFFF"/>
-                </a:solidFill>
-                <a:latin typeface="Calibri" pitchFamily="34" charset="0"/>
-                <a:ea typeface="Calibri" pitchFamily="34" charset="-122"/>
-                <a:cs typeface="Calibri" pitchFamily="34" charset="-120"/>
-              </a:rPr>
-              <a:t>Lean</a:t>
-            </a:r>
-            <a:endParaRPr lang="en-US" sz="1300" dirty="0"/>
-          </a:p>
-        </p:txBody>
-      </p:sp>
-      <p:sp>
-        <p:nvSpPr>
-          <p:cNvPr id="28" name="Text 26"/>
-          <p:cNvSpPr/>
-          <p:nvPr/>
-        </p:nvSpPr>
-        <p:spPr>
-          <a:xfrm>
-            <a:off x="1856232" y="4206240"/>
-            <a:ext cx="365760" cy="566928"/>
-          </a:xfrm>
-          <a:prstGeom prst="rect">
-            <a:avLst/>
-          </a:prstGeom>
-          <a:noFill/>
-          <a:ln/>
-        </p:spPr>
-        <p:txBody>
-          <a:bodyPr wrap="square" lIns="0" tIns="0" rIns="0" bIns="0" rtlCol="0" anchor="ctr"/>
-          <a:lstStyle/>
-          <a:p>
-            <a:pPr algn="ctr" indent="0" marL="0">
-              <a:buNone/>
-            </a:pPr>
-            <a:r>
-              <a:rPr lang="en-US" sz="1500" dirty="0">
-                <a:solidFill>
-                  <a:srgbClr val="5A6478"/>
-                </a:solidFill>
-                <a:latin typeface="Calibri" pitchFamily="34" charset="0"/>
-                <a:ea typeface="Calibri" pitchFamily="34" charset="-122"/>
-                <a:cs typeface="Calibri" pitchFamily="34" charset="-120"/>
-              </a:rPr>
-              <a:t>→</a:t>
-            </a:r>
-            <a:endParaRPr lang="en-US" sz="1500" dirty="0"/>
-          </a:p>
-        </p:txBody>
-      </p:sp>
-      <p:sp>
-        <p:nvSpPr>
-          <p:cNvPr id="29" name="Shape 27"/>
-          <p:cNvSpPr/>
-          <p:nvPr/>
-        </p:nvSpPr>
-        <p:spPr>
-          <a:xfrm>
-            <a:off x="2221992" y="4206240"/>
-            <a:ext cx="4873752" cy="566928"/>
-          </a:xfrm>
-          <a:prstGeom prst="roundRect">
-            <a:avLst>
-              <a:gd name="adj" fmla="val 9677"/>
-            </a:avLst>
-          </a:prstGeom>
-          <a:solidFill>
-            <a:srgbClr val="3A4A8C"/>
-          </a:solidFill>
-          <a:ln/>
-        </p:spPr>
-      </p:sp>
-      <p:sp>
-        <p:nvSpPr>
-          <p:cNvPr id="30" name="Text 28"/>
-          <p:cNvSpPr/>
-          <p:nvPr/>
-        </p:nvSpPr>
-        <p:spPr>
-          <a:xfrm>
-            <a:off x="2221992" y="4206240"/>
-            <a:ext cx="4873752" cy="566928"/>
-          </a:xfrm>
-          <a:prstGeom prst="rect">
-            <a:avLst/>
-          </a:prstGeom>
-          <a:noFill/>
-          <a:ln/>
-        </p:spPr>
-        <p:txBody>
-          <a:bodyPr wrap="square" lIns="254" tIns="254" rIns="254" bIns="254" rtlCol="0" anchor="ctr"/>
-          <a:lstStyle/>
-          <a:p>
-            <a:pPr algn="ctr" indent="0" marL="0">
-              <a:buNone/>
-            </a:pPr>
-            <a:r>
-              <a:rPr lang="en-US" sz="1300" b="1" dirty="0">
-                <a:solidFill>
-                  <a:srgbClr val="FFFFFF"/>
-                </a:solidFill>
-                <a:latin typeface="Calibri" pitchFamily="34" charset="0"/>
-                <a:ea typeface="Calibri" pitchFamily="34" charset="-122"/>
-                <a:cs typeface="Calibri" pitchFamily="34" charset="-120"/>
-              </a:rPr>
-              <a:t>blessed statements + workflow-owned proofs</a:t>
-            </a:r>
-            <a:endParaRPr lang="en-US" sz="1300" dirty="0"/>
-          </a:p>
-        </p:txBody>
-      </p:sp>
-      <p:sp>
-        <p:nvSpPr>
-          <p:cNvPr id="31" name="Text 29"/>
-          <p:cNvSpPr/>
-          <p:nvPr/>
-        </p:nvSpPr>
-        <p:spPr>
-          <a:xfrm>
-            <a:off x="658368" y="4754880"/>
-            <a:ext cx="10515600" cy="274320"/>
-          </a:xfrm>
-          <a:prstGeom prst="rect">
-            <a:avLst/>
-          </a:prstGeom>
-          <a:noFill/>
-          <a:ln/>
-        </p:spPr>
-        <p:txBody>
-          <a:bodyPr wrap="square" lIns="0" tIns="0" rIns="0" bIns="0" rtlCol="0" anchor="ctr"/>
-          <a:lstStyle/>
-          <a:p>
-            <a:pPr algn="l" indent="0" marL="0">
-              <a:buNone/>
-            </a:pPr>
-            <a:r>
-              <a:rPr lang="en-US" sz="1100" i="1" dirty="0">
-                <a:solidFill>
-                  <a:srgbClr val="5A6478"/>
-                </a:solidFill>
-                <a:latin typeface="Calibri" pitchFamily="34" charset="0"/>
-                <a:ea typeface="Calibri" pitchFamily="34" charset="-122"/>
-                <a:cs typeface="Calibri" pitchFamily="34" charset="-120"/>
-              </a:rPr>
-              <a:t>the goal-directed encoding: attestation enforces one invariant while synthesis iterates  (landing-gear, temp-control)</a:t>
-            </a:r>
-            <a:endParaRPr lang="en-US" sz="1100" dirty="0"/>
-          </a:p>
-        </p:txBody>
-      </p:sp>
-      <p:sp>
-        <p:nvSpPr>
-          <p:cNvPr id="32" name="Shape 30"/>
-          <p:cNvSpPr/>
-          <p:nvPr/>
-        </p:nvSpPr>
-        <p:spPr>
-          <a:xfrm>
-            <a:off x="640080" y="5349240"/>
-            <a:ext cx="1234440" cy="566928"/>
-          </a:xfrm>
-          <a:prstGeom prst="roundRect">
-            <a:avLst>
-              <a:gd name="adj" fmla="val 9677"/>
-            </a:avLst>
-          </a:prstGeom>
-          <a:solidFill>
-            <a:srgbClr val="3A4A8C"/>
-          </a:solidFill>
-          <a:ln/>
-        </p:spPr>
-      </p:sp>
-      <p:sp>
-        <p:nvSpPr>
-          <p:cNvPr id="33" name="Text 31"/>
-          <p:cNvSpPr/>
-          <p:nvPr/>
-        </p:nvSpPr>
-        <p:spPr>
-          <a:xfrm>
-            <a:off x="640080" y="5349240"/>
-            <a:ext cx="1234440" cy="566928"/>
-          </a:xfrm>
-          <a:prstGeom prst="rect">
-            <a:avLst/>
-          </a:prstGeom>
-          <a:noFill/>
-          <a:ln/>
-        </p:spPr>
-        <p:txBody>
-          <a:bodyPr wrap="square" lIns="254" tIns="254" rIns="254" bIns="254" rtlCol="0" anchor="ctr"/>
-          <a:lstStyle/>
-          <a:p>
-            <a:pPr algn="ctr" indent="0" marL="0">
-              <a:buNone/>
-            </a:pPr>
-            <a:r>
-              <a:rPr lang="en-US" sz="1300" b="1" dirty="0">
-                <a:solidFill>
-                  <a:srgbClr val="FFFFFF"/>
-                </a:solidFill>
-                <a:latin typeface="Calibri" pitchFamily="34" charset="0"/>
-                <a:ea typeface="Calibri" pitchFamily="34" charset="-122"/>
-                <a:cs typeface="Calibri" pitchFamily="34" charset="-120"/>
-              </a:rPr>
-              <a:t>Rocq</a:t>
-            </a:r>
-            <a:endParaRPr lang="en-US" sz="1300" dirty="0"/>
-          </a:p>
-        </p:txBody>
-      </p:sp>
-      <p:sp>
-        <p:nvSpPr>
-          <p:cNvPr id="34" name="Text 32"/>
-          <p:cNvSpPr/>
-          <p:nvPr/>
-        </p:nvSpPr>
-        <p:spPr>
-          <a:xfrm>
-            <a:off x="1856232" y="5349240"/>
-            <a:ext cx="365760" cy="566928"/>
-          </a:xfrm>
-          <a:prstGeom prst="rect">
-            <a:avLst/>
-          </a:prstGeom>
-          <a:noFill/>
-          <a:ln/>
-        </p:spPr>
-        <p:txBody>
-          <a:bodyPr wrap="square" lIns="0" tIns="0" rIns="0" bIns="0" rtlCol="0" anchor="ctr"/>
-          <a:lstStyle/>
-          <a:p>
-            <a:pPr algn="ctr" indent="0" marL="0">
-              <a:buNone/>
-            </a:pPr>
-            <a:r>
-              <a:rPr lang="en-US" sz="1500" dirty="0">
-                <a:solidFill>
-                  <a:srgbClr val="5A6478"/>
-                </a:solidFill>
-                <a:latin typeface="Calibri" pitchFamily="34" charset="0"/>
-                <a:ea typeface="Calibri" pitchFamily="34" charset="-122"/>
-                <a:cs typeface="Calibri" pitchFamily="34" charset="-120"/>
-              </a:rPr>
-              <a:t>→</a:t>
-            </a:r>
-            <a:endParaRPr lang="en-US" sz="1500" dirty="0"/>
-          </a:p>
-        </p:txBody>
-      </p:sp>
-      <p:sp>
-        <p:nvSpPr>
-          <p:cNvPr id="35" name="Shape 33"/>
-          <p:cNvSpPr/>
-          <p:nvPr/>
-        </p:nvSpPr>
-        <p:spPr>
-          <a:xfrm>
-            <a:off x="2221992" y="5349240"/>
-            <a:ext cx="4873752" cy="566928"/>
-          </a:xfrm>
-          <a:prstGeom prst="roundRect">
-            <a:avLst>
-              <a:gd name="adj" fmla="val 9677"/>
-            </a:avLst>
-          </a:prstGeom>
-          <a:solidFill>
-            <a:srgbClr val="3A4A8C"/>
-          </a:solidFill>
-          <a:ln/>
-        </p:spPr>
-      </p:sp>
-      <p:sp>
-        <p:nvSpPr>
-          <p:cNvPr id="36" name="Text 34"/>
-          <p:cNvSpPr/>
-          <p:nvPr/>
-        </p:nvSpPr>
-        <p:spPr>
-          <a:xfrm>
-            <a:off x="2221992" y="5349240"/>
-            <a:ext cx="4873752" cy="566928"/>
-          </a:xfrm>
-          <a:prstGeom prst="rect">
-            <a:avLst/>
-          </a:prstGeom>
-          <a:noFill/>
-          <a:ln/>
-        </p:spPr>
-        <p:txBody>
-          <a:bodyPr wrap="square" lIns="254" tIns="254" rIns="254" bIns="254" rtlCol="0" anchor="ctr"/>
-          <a:lstStyle/>
-          <a:p>
-            <a:pPr algn="ctr" indent="0" marL="0">
-              <a:buNone/>
-            </a:pPr>
-            <a:r>
-              <a:rPr lang="en-US" sz="1300" b="1" dirty="0">
-                <a:solidFill>
-                  <a:srgbClr val="FFFFFF"/>
-                </a:solidFill>
-                <a:latin typeface="Calibri" pitchFamily="34" charset="0"/>
-                <a:ea typeface="Calibri" pitchFamily="34" charset="-122"/>
-                <a:cs typeface="Calibri" pitchFamily="34" charset="-120"/>
-              </a:rPr>
-              <a:t>proofs + synthesis (tactic portfolio, LLM)</a:t>
-            </a:r>
-            <a:endParaRPr lang="en-US" sz="1300" dirty="0"/>
-          </a:p>
-        </p:txBody>
-      </p:sp>
-      <p:sp>
-        <p:nvSpPr>
-          <p:cNvPr id="37" name="Text 35"/>
-          <p:cNvSpPr/>
-          <p:nvPr/>
-        </p:nvSpPr>
-        <p:spPr>
-          <a:xfrm>
-            <a:off x="658368" y="5897880"/>
-            <a:ext cx="10515600" cy="274320"/>
-          </a:xfrm>
-          <a:prstGeom prst="rect">
-            <a:avLst/>
-          </a:prstGeom>
-          <a:noFill/>
-          <a:ln/>
-        </p:spPr>
-        <p:txBody>
-          <a:bodyPr wrap="square" lIns="0" tIns="0" rIns="0" bIns="0" rtlCol="0" anchor="ctr"/>
-          <a:lstStyle/>
-          <a:p>
-            <a:pPr algn="l" indent="0" marL="0">
-              <a:buNone/>
-            </a:pPr>
-            <a:r>
-              <a:rPr lang="en-US" sz="1100" i="1" dirty="0">
-                <a:solidFill>
-                  <a:srgbClr val="5A6478"/>
-                </a:solidFill>
-                <a:latin typeface="Calibri" pitchFamily="34" charset="0"/>
-                <a:ea typeface="Calibri" pitchFamily="34" charset="-122"/>
-                <a:cs typeface="Calibri" pitchFamily="34" charset="-120"/>
-              </a:rPr>
-              <a:t>proof synthesis as a repair strategy  (temp-control)</a:t>
-            </a:r>
-            <a:endParaRPr lang="en-US" sz="1100" dirty="0"/>
+          <a:p>
+            <a:pPr algn="l" marL="342900" indent="-342900">
+              <a:spcAft>
+                <a:spcPts val="400"/>
+              </a:spcAft>
+              <a:buSzPct val="100000"/>
+              <a:buChar char="•"/>
+            </a:pPr>
+            <a:r>
+              <a:rPr lang="en-US" sz="1200" dirty="0">
+                <a:solidFill>
+                  <a:srgbClr val="212121"/>
+                </a:solidFill>
+                <a:latin typeface="Calibri" pitchFamily="34" charset="0"/>
+                <a:ea typeface="Calibri" pitchFamily="34" charset="-122"/>
+                <a:cs typeface="Calibri" pitchFamily="34" charset="-120"/>
+              </a:rPr>
+              <a:t>Tactic-driven and LLM-driven proof repair</a:t>
+            </a:r>
+            <a:endParaRPr lang="en-US" sz="1200" dirty="0"/>
+          </a:p>
+          <a:p>
+            <a:pPr algn="l" marL="342900" indent="-342900">
+              <a:spcAft>
+                <a:spcPts val="400"/>
+              </a:spcAft>
+              <a:buSzPct val="100000"/>
+              <a:buChar char="•"/>
+            </a:pPr>
+            <a:r>
+              <a:rPr lang="en-US" sz="1200" dirty="0">
+                <a:solidFill>
+                  <a:srgbClr val="212121"/>
+                </a:solidFill>
+                <a:latin typeface="Calibri" pitchFamily="34" charset="0"/>
+                <a:ea typeface="Calibri" pitchFamily="34" charset="-122"/>
+                <a:cs typeface="Calibri" pitchFamily="34" charset="-120"/>
+              </a:rPr>
+              <a:t>Goal-directed: attestation enforces one invariant while synthesis iterates</a:t>
+            </a:r>
+            <a:endParaRPr lang="en-US" sz="1200" dirty="0"/>
+          </a:p>
+          <a:p>
+            <a:pPr algn="l" marL="342900" indent="-342900">
+              <a:spcAft>
+                <a:spcPts val="400"/>
+              </a:spcAft>
+              <a:buSzPct val="100000"/>
+              <a:buChar char="•"/>
+            </a:pPr>
+            <a:r>
+              <a:rPr lang="en-US" sz="1200" dirty="0">
+                <a:solidFill>
+                  <a:srgbClr val="212121"/>
+                </a:solidFill>
+                <a:latin typeface="Calibri" pitchFamily="34" charset="0"/>
+                <a:ea typeface="Calibri" pitchFamily="34" charset="-122"/>
+                <a:cs typeface="Calibri" pitchFamily="34" charset="-120"/>
+              </a:rPr>
+              <a:t>ITP-specific axiom checks</a:t>
+            </a:r>
+            <a:endParaRPr lang="en-US" sz="1200" dirty="0"/>
           </a:p>
         </p:txBody>
       </p:sp>

</xml_diff>

<commit_message>
capstone A: "AI in the loop" (untrusted synthesis, deterministic audit)
First AI-in-the-loop capstone slide: two-tier header ("AI in the loop"
big + descriptive caption, the theme B/C reuse), a stage / where-AI-
participates / the-rule table with the bottom two rows (verification &
appraisal, evidence/trust state) shaded as the AI-free band. Full
repair-engine list on the Proofs row. Content includes the user's
manual edits, ported verbatim (regenerated slide matches).

Co-Authored-By: Claude Fable 5 <noreply@anthropic.com>
</commit_message>
<xml_diff>
--- a/docs/video_slides_draft.pptx
+++ b/docs/video_slides_draft.pptx
@@ -22,9 +22,10 @@
     <p:sldId id="270" r:id="rId16"/>
     <p:sldId id="271" r:id="rId17"/>
     <p:sldId id="272" r:id="rId18"/>
+    <p:sldId id="273" r:id="rId19"/>
   </p:sldIdLst>
   <p:notesMasterIdLst>
-    <p:notesMasterId r:id="rId19"/>
+    <p:notesMasterId r:id="rId20"/>
   </p:notesMasterIdLst>
   <p:sldSz cx="12192000" cy="6858000"/>
   <p:notesSz cx="6858000" cy="12192000"/>
@@ -1228,8 +1229,10 @@
           <a:p>
             <a:r>
               <a:rPr lang="en-US" dirty="0"/>
-              <a:t>Collection point for every reference in the deck - keep this slide current as sections are added (isolette slide carries the K-State + AR-08-32 citations inline; Copland/Verus/seL4 seeded here ahead of their sections).
-DOIs on record in docs/video_slide_drafts.md.</a:t>
+              <a:t>Capstone slide 1 of 3 (theme: 'AI in the loop' as the big title, a descriptive caption beneath - B and C reuse the header).
+One idea: AI helps everywhere EXCEPT the judges. The top three stages (model, implementation, proofs) are AI-assisted; the bottom two (verification/appraisal, evidence/trust state) are AI-free by design - the shaded band.
+The Proofs row is where the repair-strategy breadth lands (deferred from the ecosystems slide): tactic portfolio, LLM (API + desktop sessions), AutoVerus, KU Dogtreat linear planner.
+Motivation flip (speaker, sets up the close): as more lifecycle artifacts ARE AI-generated, lifecycle attestation is what makes them trustworthy - provenance and evidence, not provider assurances.</a:t>
             </a:r>
             <a:endParaRPr lang="en-US" dirty="0"/>
           </a:p>
@@ -1253,6 +1256,95 @@
             <a:fld id="{F7021451-1387-4CA6-816F-3879F97B5CBC}" type="slidenum">
               <a:rPr lang="en-US"/>
               <a:t>17</a:t>
+            </a:fld>
+            <a:endParaRPr lang="en-US"/>
+          </a:p>
+        </p:txBody>
+      </p:sp>
+    </p:spTree>
+    <p:extLst>
+      <p:ext uri="{BB962C8B-B14F-4D97-AF65-F5344CB8AC3E}">
+        <p14:creationId xmlns:p14="http://schemas.microsoft.com/office/powerpoint/2010/main" val="1024086991"/>
+      </p:ext>
+    </p:extLst>
+  </p:cSld>
+  <p:clrMapOvr>
+    <a:masterClrMapping/>
+  </p:clrMapOvr>
+</p:notes>
+</file>
+
+<file path=ppt/notesSlides/notesSlide18.xml><?xml version="1.0" encoding="utf-8"?>
+<p:notes xmlns:a="http://schemas.openxmlformats.org/drawingml/2006/main" xmlns:r="http://schemas.openxmlformats.org/officeDocument/2006/relationships" xmlns:p="http://schemas.openxmlformats.org/presentationml/2006/main">
+  <p:cSld>
+    <p:spTree>
+      <p:nvGrpSpPr>
+        <p:cNvPr id="1" name=""/>
+        <p:cNvGrpSpPr/>
+        <p:nvPr/>
+      </p:nvGrpSpPr>
+      <p:grpSpPr>
+        <a:xfrm>
+          <a:off x="0" y="0"/>
+          <a:ext cx="0" cy="0"/>
+          <a:chOff x="0" y="0"/>
+          <a:chExt cx="0" cy="0"/>
+        </a:xfrm>
+      </p:grpSpPr>
+      <p:sp>
+        <p:nvSpPr>
+          <p:cNvPr id="2" name="Slide Image Placeholder 1"/>
+          <p:cNvSpPr>
+            <a:spLocks noGrp="1" noRot="1" noChangeAspect="1"/>
+          </p:cNvSpPr>
+          <p:nvPr>
+            <p:ph type="sldImg"/>
+          </p:nvPr>
+        </p:nvSpPr>
+        <p:spPr/>
+      </p:sp>
+      <p:sp>
+        <p:nvSpPr>
+          <p:cNvPr id="3" name="Notes Placeholder 2"/>
+          <p:cNvSpPr>
+            <a:spLocks noGrp="1"/>
+          </p:cNvSpPr>
+          <p:nvPr>
+            <p:ph type="body" idx="1"/>
+          </p:nvPr>
+        </p:nvSpPr>
+        <p:spPr/>
+        <p:txBody>
+          <a:bodyPr/>
+          <a:lstStyle/>
+          <a:p>
+            <a:r>
+              <a:rPr lang="en-US" dirty="0"/>
+              <a:t>Collection point for every reference in the deck - keep this slide current as sections are added (isolette slide carries the K-State + AR-08-32 citations inline; Copland/Verus/seL4 seeded here ahead of their sections).
+DOIs on record in docs/video_slide_drafts.md.</a:t>
+            </a:r>
+            <a:endParaRPr lang="en-US" dirty="0"/>
+          </a:p>
+        </p:txBody>
+      </p:sp>
+      <p:sp>
+        <p:nvSpPr>
+          <p:cNvPr id="4" name="Slide Number Placeholder 3"/>
+          <p:cNvSpPr>
+            <a:spLocks noGrp="1"/>
+          </p:cNvSpPr>
+          <p:nvPr>
+            <p:ph type="sldNum" sz="quarter" idx="10"/>
+          </p:nvPr>
+        </p:nvSpPr>
+        <p:spPr/>
+        <p:txBody>
+          <a:bodyPr/>
+          <a:lstStyle/>
+          <a:p>
+            <a:fld id="{F7021451-1387-4CA6-816F-3879F97B5CBC}" type="slidenum">
+              <a:rPr lang="en-US"/>
+              <a:t>18</a:t>
             </a:fld>
             <a:endParaRPr lang="en-US"/>
           </a:p>
@@ -6818,6 +6910,1464 @@
         </p:nvSpPr>
         <p:spPr>
           <a:xfrm>
+            <a:off x="640080" y="347472"/>
+            <a:ext cx="10972800" cy="640080"/>
+          </a:xfrm>
+          <a:prstGeom prst="rect">
+            <a:avLst/>
+          </a:prstGeom>
+          <a:noFill/>
+          <a:ln/>
+        </p:spPr>
+        <p:txBody>
+          <a:bodyPr wrap="square" lIns="0" tIns="0" rIns="0" bIns="0" rtlCol="0" anchor="ctr"/>
+          <a:lstStyle/>
+          <a:p>
+            <a:pPr indent="0" marL="0">
+              <a:buNone/>
+            </a:pPr>
+            <a:r>
+              <a:rPr lang="en-US" sz="4000" b="1" dirty="0">
+                <a:solidFill>
+                  <a:srgbClr val="1E2761"/>
+                </a:solidFill>
+                <a:latin typeface="Cambria" pitchFamily="34" charset="0"/>
+                <a:ea typeface="Cambria" pitchFamily="34" charset="-122"/>
+                <a:cs typeface="Cambria" pitchFamily="34" charset="-120"/>
+              </a:rPr>
+              <a:t>AI in the loop</a:t>
+            </a:r>
+            <a:endParaRPr lang="en-US" sz="4000" dirty="0"/>
+          </a:p>
+        </p:txBody>
+      </p:sp>
+      <p:sp>
+        <p:nvSpPr>
+          <p:cNvPr id="3" name="Text 1"/>
+          <p:cNvSpPr/>
+          <p:nvPr/>
+        </p:nvSpPr>
+        <p:spPr>
+          <a:xfrm>
+            <a:off x="658368" y="1024128"/>
+            <a:ext cx="10972800" cy="411480"/>
+          </a:xfrm>
+          <a:prstGeom prst="rect">
+            <a:avLst/>
+          </a:prstGeom>
+          <a:noFill/>
+          <a:ln/>
+        </p:spPr>
+        <p:txBody>
+          <a:bodyPr wrap="square" lIns="0" tIns="0" rIns="0" bIns="0" rtlCol="0" anchor="ctr"/>
+          <a:lstStyle/>
+          <a:p>
+            <a:pPr indent="0" marL="0">
+              <a:buNone/>
+            </a:pPr>
+            <a:r>
+              <a:rPr lang="en-US" sz="1600" i="1" dirty="0">
+                <a:solidFill>
+                  <a:srgbClr val="5A6478"/>
+                </a:solidFill>
+                <a:latin typeface="Calibri" pitchFamily="34" charset="0"/>
+                <a:ea typeface="Calibri" pitchFamily="34" charset="-122"/>
+                <a:cs typeface="Calibri" pitchFamily="34" charset="-120"/>
+              </a:rPr>
+              <a:t>untrusted artifact synthesis and repair;  verified audit and deterministic appraisal</a:t>
+            </a:r>
+            <a:endParaRPr lang="en-US" sz="1600" dirty="0"/>
+          </a:p>
+        </p:txBody>
+      </p:sp>
+      <p:graphicFrame>
+        <p:nvGraphicFramePr>
+          <p:cNvPr id="18" name="Table 0"/>
+          <p:cNvGraphicFramePr>
+            <a:graphicFrameLocks noGrp="1"/>
+          </p:cNvGraphicFramePr>
+          <p:nvPr>
+            <p:extLst>
+              <p:ext uri="{D42A27DB-BD31-4B8C-83A1-F6EECF244321}">
+                <p14:modId xmlns:p14="http://schemas.microsoft.com/office/powerpoint/2010/main" val="1579011935"/>
+              </p:ext>
+            </p:extLst>
+          </p:nvPr>
+        </p:nvGraphicFramePr>
+        <p:xfrm>
+          <a:off x="640080" y="1600200"/>
+          <a:ext cx="10881360" cy="914400"/>
+        </p:xfrm>
+        <a:graphic>
+          <a:graphicData uri="http://schemas.openxmlformats.org/drawingml/2006/table">
+            <a:tbl>
+              <a:tblPr/>
+              <a:tblGrid>
+                <a:gridCol w="2286000"/>
+                <a:gridCol w="4480560"/>
+                <a:gridCol w="4114800"/>
+              </a:tblGrid>
+              <a:tr h="365760">
+                <a:tc>
+                  <a:txBody>
+                    <a:bodyPr/>
+                    <a:lstStyle/>
+                    <a:p>
+                      <a:pPr algn="l" indent="0" marL="0">
+                        <a:buNone/>
+                      </a:pPr>
+                      <a:r>
+                        <a:rPr lang="en-US" sz="1350" b="1" dirty="0">
+                          <a:solidFill>
+                            <a:srgbClr val="FFFFFF"/>
+                          </a:solidFill>
+                          <a:latin typeface="Calibri" pitchFamily="34" charset="0"/>
+                          <a:ea typeface="Calibri" pitchFamily="34" charset="-122"/>
+                          <a:cs typeface="Calibri" pitchFamily="34" charset="-120"/>
+                        </a:rPr>
+                        <a:t>Workflow stage</a:t>
+                      </a:r>
+                      <a:endParaRPr lang="en-US" sz="1350" dirty="0">
+                        <a:latin typeface="Calibri" charset="0"/>
+                        <a:ea typeface="Calibri" charset="0"/>
+                        <a:cs typeface="Calibri" charset="0"/>
+                      </a:endParaRPr>
+                    </a:p>
+                  </a:txBody>
+                  <a:tcPr marL="82296" marR="82296" marT="82296" marB="82296" anchor="ctr">
+                    <a:lnL w="12700" cap="flat" cmpd="sng" algn="ctr">
+                      <a:solidFill>
+                        <a:srgbClr val="D8DEEA"/>
+                      </a:solidFill>
+                      <a:prstDash val="solid"/>
+                      <a:round/>
+                      <a:headEnd type="none" w="med" len="med"/>
+                      <a:tailEnd type="none" w="med" len="med"/>
+                    </a:lnL>
+                    <a:lnR w="12700" cap="flat" cmpd="sng" algn="ctr">
+                      <a:solidFill>
+                        <a:srgbClr val="D8DEEA"/>
+                      </a:solidFill>
+                      <a:prstDash val="solid"/>
+                      <a:round/>
+                      <a:headEnd type="none" w="med" len="med"/>
+                      <a:tailEnd type="none" w="med" len="med"/>
+                    </a:lnR>
+                    <a:lnT w="12700" cap="flat" cmpd="sng" algn="ctr">
+                      <a:solidFill>
+                        <a:srgbClr val="D8DEEA"/>
+                      </a:solidFill>
+                      <a:prstDash val="solid"/>
+                      <a:round/>
+                      <a:headEnd type="none" w="med" len="med"/>
+                      <a:tailEnd type="none" w="med" len="med"/>
+                    </a:lnT>
+                    <a:lnB w="12700" cap="flat" cmpd="sng" algn="ctr">
+                      <a:solidFill>
+                        <a:srgbClr val="D8DEEA"/>
+                      </a:solidFill>
+                      <a:prstDash val="solid"/>
+                      <a:round/>
+                      <a:headEnd type="none" w="med" len="med"/>
+                      <a:tailEnd type="none" w="med" len="med"/>
+                    </a:lnB>
+                    <a:solidFill>
+                      <a:srgbClr val="1E2761"/>
+                    </a:solidFill>
+                  </a:tcPr>
+                </a:tc>
+                <a:tc>
+                  <a:txBody>
+                    <a:bodyPr/>
+                    <a:lstStyle/>
+                    <a:p>
+                      <a:pPr algn="l" indent="0" marL="0">
+                        <a:buNone/>
+                      </a:pPr>
+                      <a:r>
+                        <a:rPr lang="en-US" sz="1350" b="1" dirty="0">
+                          <a:solidFill>
+                            <a:srgbClr val="FFFFFF"/>
+                          </a:solidFill>
+                          <a:latin typeface="Calibri" pitchFamily="34" charset="0"/>
+                          <a:ea typeface="Calibri" pitchFamily="34" charset="-122"/>
+                          <a:cs typeface="Calibri" pitchFamily="34" charset="-120"/>
+                        </a:rPr>
+                        <a:t>Where AI participates</a:t>
+                      </a:r>
+                      <a:endParaRPr lang="en-US" sz="1350" dirty="0">
+                        <a:latin typeface="Calibri" charset="0"/>
+                        <a:ea typeface="Calibri" charset="0"/>
+                        <a:cs typeface="Calibri" charset="0"/>
+                      </a:endParaRPr>
+                    </a:p>
+                  </a:txBody>
+                  <a:tcPr marL="82296" marR="82296" marT="82296" marB="82296" anchor="ctr">
+                    <a:lnL w="12700" cap="flat" cmpd="sng" algn="ctr">
+                      <a:solidFill>
+                        <a:srgbClr val="D8DEEA"/>
+                      </a:solidFill>
+                      <a:prstDash val="solid"/>
+                      <a:round/>
+                      <a:headEnd type="none" w="med" len="med"/>
+                      <a:tailEnd type="none" w="med" len="med"/>
+                    </a:lnL>
+                    <a:lnR w="12700" cap="flat" cmpd="sng" algn="ctr">
+                      <a:solidFill>
+                        <a:srgbClr val="D8DEEA"/>
+                      </a:solidFill>
+                      <a:prstDash val="solid"/>
+                      <a:round/>
+                      <a:headEnd type="none" w="med" len="med"/>
+                      <a:tailEnd type="none" w="med" len="med"/>
+                    </a:lnR>
+                    <a:lnT w="12700" cap="flat" cmpd="sng" algn="ctr">
+                      <a:solidFill>
+                        <a:srgbClr val="D8DEEA"/>
+                      </a:solidFill>
+                      <a:prstDash val="solid"/>
+                      <a:round/>
+                      <a:headEnd type="none" w="med" len="med"/>
+                      <a:tailEnd type="none" w="med" len="med"/>
+                    </a:lnT>
+                    <a:lnB w="12700" cap="flat" cmpd="sng" algn="ctr">
+                      <a:solidFill>
+                        <a:srgbClr val="D8DEEA"/>
+                      </a:solidFill>
+                      <a:prstDash val="solid"/>
+                      <a:round/>
+                      <a:headEnd type="none" w="med" len="med"/>
+                      <a:tailEnd type="none" w="med" len="med"/>
+                    </a:lnB>
+                    <a:solidFill>
+                      <a:srgbClr val="1E2761"/>
+                    </a:solidFill>
+                  </a:tcPr>
+                </a:tc>
+                <a:tc>
+                  <a:txBody>
+                    <a:bodyPr/>
+                    <a:lstStyle/>
+                    <a:p>
+                      <a:pPr algn="l" indent="0" marL="0">
+                        <a:buNone/>
+                      </a:pPr>
+                      <a:r>
+                        <a:rPr lang="en-US" sz="1350" b="1" dirty="0">
+                          <a:solidFill>
+                            <a:srgbClr val="FFFFFF"/>
+                          </a:solidFill>
+                          <a:latin typeface="Calibri" pitchFamily="34" charset="0"/>
+                          <a:ea typeface="Calibri" pitchFamily="34" charset="-122"/>
+                          <a:cs typeface="Calibri" pitchFamily="34" charset="-120"/>
+                        </a:rPr>
+                        <a:t>The rule</a:t>
+                      </a:r>
+                      <a:endParaRPr lang="en-US" sz="1350" dirty="0">
+                        <a:latin typeface="Calibri" charset="0"/>
+                        <a:ea typeface="Calibri" charset="0"/>
+                        <a:cs typeface="Calibri" charset="0"/>
+                      </a:endParaRPr>
+                    </a:p>
+                  </a:txBody>
+                  <a:tcPr marL="82296" marR="82296" marT="82296" marB="82296" anchor="ctr">
+                    <a:lnL w="12700" cap="flat" cmpd="sng" algn="ctr">
+                      <a:solidFill>
+                        <a:srgbClr val="D8DEEA"/>
+                      </a:solidFill>
+                      <a:prstDash val="solid"/>
+                      <a:round/>
+                      <a:headEnd type="none" w="med" len="med"/>
+                      <a:tailEnd type="none" w="med" len="med"/>
+                    </a:lnL>
+                    <a:lnR w="12700" cap="flat" cmpd="sng" algn="ctr">
+                      <a:solidFill>
+                        <a:srgbClr val="D8DEEA"/>
+                      </a:solidFill>
+                      <a:prstDash val="solid"/>
+                      <a:round/>
+                      <a:headEnd type="none" w="med" len="med"/>
+                      <a:tailEnd type="none" w="med" len="med"/>
+                    </a:lnR>
+                    <a:lnT w="12700" cap="flat" cmpd="sng" algn="ctr">
+                      <a:solidFill>
+                        <a:srgbClr val="D8DEEA"/>
+                      </a:solidFill>
+                      <a:prstDash val="solid"/>
+                      <a:round/>
+                      <a:headEnd type="none" w="med" len="med"/>
+                      <a:tailEnd type="none" w="med" len="med"/>
+                    </a:lnT>
+                    <a:lnB w="12700" cap="flat" cmpd="sng" algn="ctr">
+                      <a:solidFill>
+                        <a:srgbClr val="D8DEEA"/>
+                      </a:solidFill>
+                      <a:prstDash val="solid"/>
+                      <a:round/>
+                      <a:headEnd type="none" w="med" len="med"/>
+                      <a:tailEnd type="none" w="med" len="med"/>
+                    </a:lnB>
+                    <a:solidFill>
+                      <a:srgbClr val="1E2761"/>
+                    </a:solidFill>
+                  </a:tcPr>
+                </a:tc>
+              </a:tr>
+              <a:tr h="566928">
+                <a:tc>
+                  <a:txBody>
+                    <a:bodyPr/>
+                    <a:lstStyle/>
+                    <a:p>
+                      <a:pPr algn="l" indent="0" marL="0">
+                        <a:buNone/>
+                      </a:pPr>
+                      <a:r>
+                        <a:rPr lang="en-US" sz="1200" b="1" dirty="0">
+                          <a:solidFill>
+                            <a:srgbClr val="212121"/>
+                          </a:solidFill>
+                          <a:latin typeface="Calibri" pitchFamily="34" charset="0"/>
+                          <a:ea typeface="Calibri" pitchFamily="34" charset="-122"/>
+                          <a:cs typeface="Calibri" pitchFamily="34" charset="-120"/>
+                        </a:rPr>
+                        <a:t>Model / spec</a:t>
+                      </a:r>
+                      <a:endParaRPr lang="en-US" sz="1200" dirty="0">
+                        <a:latin typeface="Calibri" charset="0"/>
+                        <a:ea typeface="Calibri" charset="0"/>
+                        <a:cs typeface="Calibri" charset="0"/>
+                      </a:endParaRPr>
+                    </a:p>
+                  </a:txBody>
+                  <a:tcPr marL="82296" marR="82296" marT="82296" marB="82296" anchor="ctr">
+                    <a:lnL w="12700" cap="flat" cmpd="sng" algn="ctr">
+                      <a:solidFill>
+                        <a:srgbClr val="D8DEEA"/>
+                      </a:solidFill>
+                      <a:prstDash val="solid"/>
+                      <a:round/>
+                      <a:headEnd type="none" w="med" len="med"/>
+                      <a:tailEnd type="none" w="med" len="med"/>
+                    </a:lnL>
+                    <a:lnR w="12700" cap="flat" cmpd="sng" algn="ctr">
+                      <a:solidFill>
+                        <a:srgbClr val="D8DEEA"/>
+                      </a:solidFill>
+                      <a:prstDash val="solid"/>
+                      <a:round/>
+                      <a:headEnd type="none" w="med" len="med"/>
+                      <a:tailEnd type="none" w="med" len="med"/>
+                    </a:lnR>
+                    <a:lnT w="12700" cap="flat" cmpd="sng" algn="ctr">
+                      <a:solidFill>
+                        <a:srgbClr val="D8DEEA"/>
+                      </a:solidFill>
+                      <a:prstDash val="solid"/>
+                      <a:round/>
+                      <a:headEnd type="none" w="med" len="med"/>
+                      <a:tailEnd type="none" w="med" len="med"/>
+                    </a:lnT>
+                    <a:lnB w="12700" cap="flat" cmpd="sng" algn="ctr">
+                      <a:solidFill>
+                        <a:srgbClr val="D8DEEA"/>
+                      </a:solidFill>
+                      <a:prstDash val="solid"/>
+                      <a:round/>
+                      <a:headEnd type="none" w="med" len="med"/>
+                      <a:tailEnd type="none" w="med" len="med"/>
+                    </a:lnB>
+                    <a:solidFill>
+                      <a:srgbClr val="FFFFFF"/>
+                    </a:solidFill>
+                  </a:tcPr>
+                </a:tc>
+                <a:tc>
+                  <a:txBody>
+                    <a:bodyPr/>
+                    <a:lstStyle/>
+                    <a:p>
+                      <a:pPr algn="l" indent="0" marL="0">
+                        <a:buNone/>
+                      </a:pPr>
+                      <a:r>
+                        <a:rPr lang="en-US" sz="1200" dirty="0">
+                          <a:solidFill>
+                            <a:srgbClr val="212121"/>
+                          </a:solidFill>
+                          <a:latin typeface="Calibri" pitchFamily="34" charset="0"/>
+                          <a:ea typeface="Calibri" pitchFamily="34" charset="-122"/>
+                          <a:cs typeface="Calibri" pitchFamily="34" charset="-120"/>
+                        </a:rPr>
+                        <a:t>LLMs may draft or restate specs</a:t>
+                      </a:r>
+                      <a:endParaRPr lang="en-US" sz="1200" dirty="0">
+                        <a:latin typeface="Calibri" charset="0"/>
+                        <a:ea typeface="Calibri" charset="0"/>
+                        <a:cs typeface="Calibri" charset="0"/>
+                      </a:endParaRPr>
+                    </a:p>
+                  </a:txBody>
+                  <a:tcPr marL="82296" marR="82296" marT="82296" marB="82296" anchor="ctr">
+                    <a:lnL w="12700" cap="flat" cmpd="sng" algn="ctr">
+                      <a:solidFill>
+                        <a:srgbClr val="D8DEEA"/>
+                      </a:solidFill>
+                      <a:prstDash val="solid"/>
+                      <a:round/>
+                      <a:headEnd type="none" w="med" len="med"/>
+                      <a:tailEnd type="none" w="med" len="med"/>
+                    </a:lnL>
+                    <a:lnR w="12700" cap="flat" cmpd="sng" algn="ctr">
+                      <a:solidFill>
+                        <a:srgbClr val="D8DEEA"/>
+                      </a:solidFill>
+                      <a:prstDash val="solid"/>
+                      <a:round/>
+                      <a:headEnd type="none" w="med" len="med"/>
+                      <a:tailEnd type="none" w="med" len="med"/>
+                    </a:lnR>
+                    <a:lnT w="12700" cap="flat" cmpd="sng" algn="ctr">
+                      <a:solidFill>
+                        <a:srgbClr val="D8DEEA"/>
+                      </a:solidFill>
+                      <a:prstDash val="solid"/>
+                      <a:round/>
+                      <a:headEnd type="none" w="med" len="med"/>
+                      <a:tailEnd type="none" w="med" len="med"/>
+                    </a:lnT>
+                    <a:lnB w="12700" cap="flat" cmpd="sng" algn="ctr">
+                      <a:solidFill>
+                        <a:srgbClr val="D8DEEA"/>
+                      </a:solidFill>
+                      <a:prstDash val="solid"/>
+                      <a:round/>
+                      <a:headEnd type="none" w="med" len="med"/>
+                      <a:tailEnd type="none" w="med" len="med"/>
+                    </a:lnB>
+                    <a:solidFill>
+                      <a:srgbClr val="FFFFFF"/>
+                    </a:solidFill>
+                  </a:tcPr>
+                </a:tc>
+                <a:tc>
+                  <a:txBody>
+                    <a:bodyPr/>
+                    <a:lstStyle/>
+                    <a:p>
+                      <a:pPr algn="l" indent="0" marL="0">
+                        <a:buNone/>
+                      </a:pPr>
+                      <a:r>
+                        <a:rPr lang="en-US" sz="1200" dirty="0">
+                          <a:solidFill>
+                            <a:srgbClr val="212121"/>
+                          </a:solidFill>
+                          <a:latin typeface="Calibri" pitchFamily="34" charset="0"/>
+                          <a:ea typeface="Calibri" pitchFamily="34" charset="-122"/>
+                          <a:cs typeface="Calibri" pitchFamily="34" charset="-120"/>
+                        </a:rPr>
+                        <a:t>only the administrator </a:t>
+                      </a:r>
+                      <a:pPr algn="l" indent="0" marL="0">
+                        <a:buNone/>
+                      </a:pPr>
+                      <a:r>
+                        <a:rPr lang="en-US" sz="1200" b="1" dirty="0">
+                          <a:solidFill>
+                            <a:srgbClr val="212121"/>
+                          </a:solidFill>
+                          <a:latin typeface="Calibri" pitchFamily="34" charset="0"/>
+                          <a:ea typeface="Calibri" pitchFamily="34" charset="-122"/>
+                          <a:cs typeface="Calibri" pitchFamily="34" charset="-120"/>
+                        </a:rPr>
+                        <a:t>blesses</a:t>
+                      </a:r>
+                      <a:pPr algn="l" indent="0" marL="0">
+                        <a:buNone/>
+                      </a:pPr>
+                      <a:r>
+                        <a:rPr lang="en-US" sz="1200" dirty="0">
+                          <a:solidFill>
+                            <a:srgbClr val="212121"/>
+                          </a:solidFill>
+                          <a:latin typeface="Calibri" pitchFamily="34" charset="0"/>
+                          <a:ea typeface="Calibri" pitchFamily="34" charset="-122"/>
+                          <a:cs typeface="Calibri" pitchFamily="34" charset="-120"/>
+                        </a:rPr>
+                        <a:t> — authority is human</a:t>
+                      </a:r>
+                      <a:endParaRPr lang="en-US" sz="1200" dirty="0">
+                        <a:latin typeface="Calibri" charset="0"/>
+                        <a:ea typeface="Calibri" charset="0"/>
+                        <a:cs typeface="Calibri" charset="0"/>
+                      </a:endParaRPr>
+                    </a:p>
+                  </a:txBody>
+                  <a:tcPr marL="82296" marR="82296" marT="82296" marB="82296" anchor="ctr">
+                    <a:lnL w="12700" cap="flat" cmpd="sng" algn="ctr">
+                      <a:solidFill>
+                        <a:srgbClr val="D8DEEA"/>
+                      </a:solidFill>
+                      <a:prstDash val="solid"/>
+                      <a:round/>
+                      <a:headEnd type="none" w="med" len="med"/>
+                      <a:tailEnd type="none" w="med" len="med"/>
+                    </a:lnL>
+                    <a:lnR w="12700" cap="flat" cmpd="sng" algn="ctr">
+                      <a:solidFill>
+                        <a:srgbClr val="D8DEEA"/>
+                      </a:solidFill>
+                      <a:prstDash val="solid"/>
+                      <a:round/>
+                      <a:headEnd type="none" w="med" len="med"/>
+                      <a:tailEnd type="none" w="med" len="med"/>
+                    </a:lnR>
+                    <a:lnT w="12700" cap="flat" cmpd="sng" algn="ctr">
+                      <a:solidFill>
+                        <a:srgbClr val="D8DEEA"/>
+                      </a:solidFill>
+                      <a:prstDash val="solid"/>
+                      <a:round/>
+                      <a:headEnd type="none" w="med" len="med"/>
+                      <a:tailEnd type="none" w="med" len="med"/>
+                    </a:lnT>
+                    <a:lnB w="12700" cap="flat" cmpd="sng" algn="ctr">
+                      <a:solidFill>
+                        <a:srgbClr val="D8DEEA"/>
+                      </a:solidFill>
+                      <a:prstDash val="solid"/>
+                      <a:round/>
+                      <a:headEnd type="none" w="med" len="med"/>
+                      <a:tailEnd type="none" w="med" len="med"/>
+                    </a:lnB>
+                    <a:solidFill>
+                      <a:srgbClr val="FFFFFF"/>
+                    </a:solidFill>
+                  </a:tcPr>
+                </a:tc>
+              </a:tr>
+              <a:tr h="566928">
+                <a:tc>
+                  <a:txBody>
+                    <a:bodyPr/>
+                    <a:lstStyle/>
+                    <a:p>
+                      <a:pPr algn="l" indent="0" marL="0">
+                        <a:buNone/>
+                      </a:pPr>
+                      <a:r>
+                        <a:rPr lang="en-US" sz="1200" b="1" dirty="0">
+                          <a:solidFill>
+                            <a:srgbClr val="212121"/>
+                          </a:solidFill>
+                          <a:latin typeface="Calibri" pitchFamily="34" charset="0"/>
+                          <a:ea typeface="Calibri" pitchFamily="34" charset="-122"/>
+                          <a:cs typeface="Calibri" pitchFamily="34" charset="-120"/>
+                        </a:rPr>
+                        <a:t>Implementation</a:t>
+                      </a:r>
+                      <a:endParaRPr lang="en-US" sz="1200" dirty="0">
+                        <a:latin typeface="Calibri" charset="0"/>
+                        <a:ea typeface="Calibri" charset="0"/>
+                        <a:cs typeface="Calibri" charset="0"/>
+                      </a:endParaRPr>
+                    </a:p>
+                  </a:txBody>
+                  <a:tcPr marL="82296" marR="82296" marT="82296" marB="82296" anchor="ctr">
+                    <a:lnL w="12700" cap="flat" cmpd="sng" algn="ctr">
+                      <a:solidFill>
+                        <a:srgbClr val="D8DEEA"/>
+                      </a:solidFill>
+                      <a:prstDash val="solid"/>
+                      <a:round/>
+                      <a:headEnd type="none" w="med" len="med"/>
+                      <a:tailEnd type="none" w="med" len="med"/>
+                    </a:lnL>
+                    <a:lnR w="12700" cap="flat" cmpd="sng" algn="ctr">
+                      <a:solidFill>
+                        <a:srgbClr val="D8DEEA"/>
+                      </a:solidFill>
+                      <a:prstDash val="solid"/>
+                      <a:round/>
+                      <a:headEnd type="none" w="med" len="med"/>
+                      <a:tailEnd type="none" w="med" len="med"/>
+                    </a:lnR>
+                    <a:lnT w="12700" cap="flat" cmpd="sng" algn="ctr">
+                      <a:solidFill>
+                        <a:srgbClr val="D8DEEA"/>
+                      </a:solidFill>
+                      <a:prstDash val="solid"/>
+                      <a:round/>
+                      <a:headEnd type="none" w="med" len="med"/>
+                      <a:tailEnd type="none" w="med" len="med"/>
+                    </a:lnT>
+                    <a:lnB w="12700" cap="flat" cmpd="sng" algn="ctr">
+                      <a:solidFill>
+                        <a:srgbClr val="D8DEEA"/>
+                      </a:solidFill>
+                      <a:prstDash val="solid"/>
+                      <a:round/>
+                      <a:headEnd type="none" w="med" len="med"/>
+                      <a:tailEnd type="none" w="med" len="med"/>
+                    </a:lnB>
+                    <a:solidFill>
+                      <a:srgbClr val="FFFFFF"/>
+                    </a:solidFill>
+                  </a:tcPr>
+                </a:tc>
+                <a:tc>
+                  <a:txBody>
+                    <a:bodyPr/>
+                    <a:lstStyle/>
+                    <a:p>
+                      <a:pPr algn="l" indent="0" marL="0">
+                        <a:buNone/>
+                      </a:pPr>
+                      <a:r>
+                        <a:rPr lang="en-US" sz="1200" dirty="0">
+                          <a:solidFill>
+                            <a:srgbClr val="212121"/>
+                          </a:solidFill>
+                          <a:latin typeface="Calibri" pitchFamily="34" charset="0"/>
+                          <a:ea typeface="Calibri" pitchFamily="34" charset="-122"/>
+                          <a:cs typeface="Calibri" pitchFamily="34" charset="-120"/>
+                        </a:rPr>
+                        <a:t>spec-guided synthesis / re-derivation with LLM engines</a:t>
+                      </a:r>
+                      <a:endParaRPr lang="en-US" sz="1200" dirty="0">
+                        <a:latin typeface="Calibri" charset="0"/>
+                        <a:ea typeface="Calibri" charset="0"/>
+                        <a:cs typeface="Calibri" charset="0"/>
+                      </a:endParaRPr>
+                    </a:p>
+                  </a:txBody>
+                  <a:tcPr marL="82296" marR="82296" marT="82296" marB="82296" anchor="ctr">
+                    <a:lnL w="12700" cap="flat" cmpd="sng" algn="ctr">
+                      <a:solidFill>
+                        <a:srgbClr val="D8DEEA"/>
+                      </a:solidFill>
+                      <a:prstDash val="solid"/>
+                      <a:round/>
+                      <a:headEnd type="none" w="med" len="med"/>
+                      <a:tailEnd type="none" w="med" len="med"/>
+                    </a:lnL>
+                    <a:lnR w="12700" cap="flat" cmpd="sng" algn="ctr">
+                      <a:solidFill>
+                        <a:srgbClr val="D8DEEA"/>
+                      </a:solidFill>
+                      <a:prstDash val="solid"/>
+                      <a:round/>
+                      <a:headEnd type="none" w="med" len="med"/>
+                      <a:tailEnd type="none" w="med" len="med"/>
+                    </a:lnR>
+                    <a:lnT w="12700" cap="flat" cmpd="sng" algn="ctr">
+                      <a:solidFill>
+                        <a:srgbClr val="D8DEEA"/>
+                      </a:solidFill>
+                      <a:prstDash val="solid"/>
+                      <a:round/>
+                      <a:headEnd type="none" w="med" len="med"/>
+                      <a:tailEnd type="none" w="med" len="med"/>
+                    </a:lnT>
+                    <a:lnB w="12700" cap="flat" cmpd="sng" algn="ctr">
+                      <a:solidFill>
+                        <a:srgbClr val="D8DEEA"/>
+                      </a:solidFill>
+                      <a:prstDash val="solid"/>
+                      <a:round/>
+                      <a:headEnd type="none" w="med" len="med"/>
+                      <a:tailEnd type="none" w="med" len="med"/>
+                    </a:lnB>
+                    <a:solidFill>
+                      <a:srgbClr val="FFFFFF"/>
+                    </a:solidFill>
+                  </a:tcPr>
+                </a:tc>
+                <a:tc>
+                  <a:txBody>
+                    <a:bodyPr/>
+                    <a:lstStyle/>
+                    <a:p>
+                      <a:pPr algn="l" indent="0" marL="0">
+                        <a:buNone/>
+                      </a:pPr>
+                      <a:r>
+                        <a:rPr lang="en-US" sz="1200" dirty="0">
+                          <a:solidFill>
+                            <a:srgbClr val="212121"/>
+                          </a:solidFill>
+                          <a:latin typeface="Calibri" pitchFamily="34" charset="0"/>
+                          <a:ea typeface="Calibri" pitchFamily="34" charset="-122"/>
+                          <a:cs typeface="Calibri" pitchFamily="34" charset="-120"/>
+                        </a:rPr>
+                        <a:t>the seed proofs must prove again against the blessed statements</a:t>
+                      </a:r>
+                      <a:endParaRPr lang="en-US" sz="1200" dirty="0">
+                        <a:latin typeface="Calibri" charset="0"/>
+                        <a:ea typeface="Calibri" charset="0"/>
+                        <a:cs typeface="Calibri" charset="0"/>
+                      </a:endParaRPr>
+                    </a:p>
+                  </a:txBody>
+                  <a:tcPr marL="82296" marR="82296" marT="82296" marB="82296" anchor="ctr">
+                    <a:lnL w="12700" cap="flat" cmpd="sng" algn="ctr">
+                      <a:solidFill>
+                        <a:srgbClr val="D8DEEA"/>
+                      </a:solidFill>
+                      <a:prstDash val="solid"/>
+                      <a:round/>
+                      <a:headEnd type="none" w="med" len="med"/>
+                      <a:tailEnd type="none" w="med" len="med"/>
+                    </a:lnL>
+                    <a:lnR w="12700" cap="flat" cmpd="sng" algn="ctr">
+                      <a:solidFill>
+                        <a:srgbClr val="D8DEEA"/>
+                      </a:solidFill>
+                      <a:prstDash val="solid"/>
+                      <a:round/>
+                      <a:headEnd type="none" w="med" len="med"/>
+                      <a:tailEnd type="none" w="med" len="med"/>
+                    </a:lnR>
+                    <a:lnT w="12700" cap="flat" cmpd="sng" algn="ctr">
+                      <a:solidFill>
+                        <a:srgbClr val="D8DEEA"/>
+                      </a:solidFill>
+                      <a:prstDash val="solid"/>
+                      <a:round/>
+                      <a:headEnd type="none" w="med" len="med"/>
+                      <a:tailEnd type="none" w="med" len="med"/>
+                    </a:lnT>
+                    <a:lnB w="12700" cap="flat" cmpd="sng" algn="ctr">
+                      <a:solidFill>
+                        <a:srgbClr val="D8DEEA"/>
+                      </a:solidFill>
+                      <a:prstDash val="solid"/>
+                      <a:round/>
+                      <a:headEnd type="none" w="med" len="med"/>
+                      <a:tailEnd type="none" w="med" len="med"/>
+                    </a:lnB>
+                    <a:solidFill>
+                      <a:srgbClr val="FFFFFF"/>
+                    </a:solidFill>
+                  </a:tcPr>
+                </a:tc>
+              </a:tr>
+              <a:tr h="914400">
+                <a:tc>
+                  <a:txBody>
+                    <a:bodyPr/>
+                    <a:lstStyle/>
+                    <a:p>
+                      <a:pPr algn="l" indent="0" marL="0">
+                        <a:buNone/>
+                      </a:pPr>
+                      <a:r>
+                        <a:rPr lang="en-US" sz="1200" b="1" dirty="0">
+                          <a:solidFill>
+                            <a:srgbClr val="212121"/>
+                          </a:solidFill>
+                          <a:latin typeface="Calibri" pitchFamily="34" charset="0"/>
+                          <a:ea typeface="Calibri" pitchFamily="34" charset="-122"/>
+                          <a:cs typeface="Calibri" pitchFamily="34" charset="-120"/>
+                        </a:rPr>
+                        <a:t>Proofs</a:t>
+                      </a:r>
+                      <a:endParaRPr lang="en-US" sz="1200" dirty="0">
+                        <a:latin typeface="Calibri" charset="0"/>
+                        <a:ea typeface="Calibri" charset="0"/>
+                        <a:cs typeface="Calibri" charset="0"/>
+                      </a:endParaRPr>
+                    </a:p>
+                  </a:txBody>
+                  <a:tcPr marL="82296" marR="82296" marT="82296" marB="82296" anchor="ctr">
+                    <a:lnL w="12700" cap="flat" cmpd="sng" algn="ctr">
+                      <a:solidFill>
+                        <a:srgbClr val="D8DEEA"/>
+                      </a:solidFill>
+                      <a:prstDash val="solid"/>
+                      <a:round/>
+                      <a:headEnd type="none" w="med" len="med"/>
+                      <a:tailEnd type="none" w="med" len="med"/>
+                    </a:lnL>
+                    <a:lnR w="12700" cap="flat" cmpd="sng" algn="ctr">
+                      <a:solidFill>
+                        <a:srgbClr val="D8DEEA"/>
+                      </a:solidFill>
+                      <a:prstDash val="solid"/>
+                      <a:round/>
+                      <a:headEnd type="none" w="med" len="med"/>
+                      <a:tailEnd type="none" w="med" len="med"/>
+                    </a:lnR>
+                    <a:lnT w="12700" cap="flat" cmpd="sng" algn="ctr">
+                      <a:solidFill>
+                        <a:srgbClr val="D8DEEA"/>
+                      </a:solidFill>
+                      <a:prstDash val="solid"/>
+                      <a:round/>
+                      <a:headEnd type="none" w="med" len="med"/>
+                      <a:tailEnd type="none" w="med" len="med"/>
+                    </a:lnT>
+                    <a:lnB w="12700" cap="flat" cmpd="sng" algn="ctr">
+                      <a:solidFill>
+                        <a:srgbClr val="D8DEEA"/>
+                      </a:solidFill>
+                      <a:prstDash val="solid"/>
+                      <a:round/>
+                      <a:headEnd type="none" w="med" len="med"/>
+                      <a:tailEnd type="none" w="med" len="med"/>
+                    </a:lnB>
+                    <a:solidFill>
+                      <a:srgbClr val="FFFFFF"/>
+                    </a:solidFill>
+                  </a:tcPr>
+                </a:tc>
+                <a:tc>
+                  <a:txBody>
+                    <a:bodyPr/>
+                    <a:lstStyle/>
+                    <a:p>
+                      <a:pPr algn="l" indent="0" marL="0">
+                        <a:buNone/>
+                      </a:pPr>
+                      <a:r>
+                        <a:rPr lang="en-US" sz="1200" dirty="0">
+                          <a:solidFill>
+                            <a:srgbClr val="212121"/>
+                          </a:solidFill>
+                          <a:latin typeface="Calibri" pitchFamily="34" charset="0"/>
+                          <a:ea typeface="Calibri" pitchFamily="34" charset="-122"/>
+                          <a:cs typeface="Calibri" pitchFamily="34" charset="-120"/>
+                        </a:rPr>
+                        <a:t>LLM-suggested tactic portfolio (deterministic at runtime) · LLM API calls + LLM-assisted desktop sessions (loop is paused) · Custom proof repair agents (AutoVerus · KU Dogtreat linear planner)</a:t>
+                      </a:r>
+                      <a:endParaRPr lang="en-US" sz="1200" dirty="0">
+                        <a:latin typeface="Calibri" charset="0"/>
+                        <a:ea typeface="Calibri" charset="0"/>
+                        <a:cs typeface="Calibri" charset="0"/>
+                      </a:endParaRPr>
+                    </a:p>
+                  </a:txBody>
+                  <a:tcPr marL="82296" marR="82296" marT="82296" marB="82296" anchor="ctr">
+                    <a:lnL w="12700" cap="flat" cmpd="sng" algn="ctr">
+                      <a:solidFill>
+                        <a:srgbClr val="D8DEEA"/>
+                      </a:solidFill>
+                      <a:prstDash val="solid"/>
+                      <a:round/>
+                      <a:headEnd type="none" w="med" len="med"/>
+                      <a:tailEnd type="none" w="med" len="med"/>
+                    </a:lnL>
+                    <a:lnR w="12700" cap="flat" cmpd="sng" algn="ctr">
+                      <a:solidFill>
+                        <a:srgbClr val="D8DEEA"/>
+                      </a:solidFill>
+                      <a:prstDash val="solid"/>
+                      <a:round/>
+                      <a:headEnd type="none" w="med" len="med"/>
+                      <a:tailEnd type="none" w="med" len="med"/>
+                    </a:lnR>
+                    <a:lnT w="12700" cap="flat" cmpd="sng" algn="ctr">
+                      <a:solidFill>
+                        <a:srgbClr val="D8DEEA"/>
+                      </a:solidFill>
+                      <a:prstDash val="solid"/>
+                      <a:round/>
+                      <a:headEnd type="none" w="med" len="med"/>
+                      <a:tailEnd type="none" w="med" len="med"/>
+                    </a:lnT>
+                    <a:lnB w="12700" cap="flat" cmpd="sng" algn="ctr">
+                      <a:solidFill>
+                        <a:srgbClr val="D8DEEA"/>
+                      </a:solidFill>
+                      <a:prstDash val="solid"/>
+                      <a:round/>
+                      <a:headEnd type="none" w="med" len="med"/>
+                      <a:tailEnd type="none" w="med" len="med"/>
+                    </a:lnB>
+                    <a:solidFill>
+                      <a:srgbClr val="FFFFFF"/>
+                    </a:solidFill>
+                  </a:tcPr>
+                </a:tc>
+                <a:tc>
+                  <a:txBody>
+                    <a:bodyPr/>
+                    <a:lstStyle/>
+                    <a:p>
+                      <a:pPr algn="l" indent="0" marL="0">
+                        <a:buNone/>
+                      </a:pPr>
+                      <a:r>
+                        <a:rPr lang="en-US" sz="1200" dirty="0">
+                          <a:solidFill>
+                            <a:srgbClr val="212121"/>
+                          </a:solidFill>
+                          <a:latin typeface="Calibri" pitchFamily="34" charset="0"/>
+                          <a:ea typeface="Calibri" pitchFamily="34" charset="-122"/>
+                          <a:cs typeface="Calibri" pitchFamily="34" charset="-120"/>
+                        </a:rPr>
+                        <a:t>a repair claim is worthless without evidence; only fresh measurement re-establishes good standing</a:t>
+                      </a:r>
+                      <a:endParaRPr lang="en-US" sz="1200" dirty="0">
+                        <a:latin typeface="Calibri" charset="0"/>
+                        <a:ea typeface="Calibri" charset="0"/>
+                        <a:cs typeface="Calibri" charset="0"/>
+                      </a:endParaRPr>
+                    </a:p>
+                  </a:txBody>
+                  <a:tcPr marL="82296" marR="82296" marT="82296" marB="82296" anchor="ctr">
+                    <a:lnL w="12700" cap="flat" cmpd="sng" algn="ctr">
+                      <a:solidFill>
+                        <a:srgbClr val="D8DEEA"/>
+                      </a:solidFill>
+                      <a:prstDash val="solid"/>
+                      <a:round/>
+                      <a:headEnd type="none" w="med" len="med"/>
+                      <a:tailEnd type="none" w="med" len="med"/>
+                    </a:lnL>
+                    <a:lnR w="12700" cap="flat" cmpd="sng" algn="ctr">
+                      <a:solidFill>
+                        <a:srgbClr val="D8DEEA"/>
+                      </a:solidFill>
+                      <a:prstDash val="solid"/>
+                      <a:round/>
+                      <a:headEnd type="none" w="med" len="med"/>
+                      <a:tailEnd type="none" w="med" len="med"/>
+                    </a:lnR>
+                    <a:lnT w="12700" cap="flat" cmpd="sng" algn="ctr">
+                      <a:solidFill>
+                        <a:srgbClr val="D8DEEA"/>
+                      </a:solidFill>
+                      <a:prstDash val="solid"/>
+                      <a:round/>
+                      <a:headEnd type="none" w="med" len="med"/>
+                      <a:tailEnd type="none" w="med" len="med"/>
+                    </a:lnT>
+                    <a:lnB w="12700" cap="flat" cmpd="sng" algn="ctr">
+                      <a:solidFill>
+                        <a:srgbClr val="D8DEEA"/>
+                      </a:solidFill>
+                      <a:prstDash val="solid"/>
+                      <a:round/>
+                      <a:headEnd type="none" w="med" len="med"/>
+                      <a:tailEnd type="none" w="med" len="med"/>
+                    </a:lnB>
+                    <a:solidFill>
+                      <a:srgbClr val="FFFFFF"/>
+                    </a:solidFill>
+                  </a:tcPr>
+                </a:tc>
+              </a:tr>
+              <a:tr h="658368">
+                <a:tc>
+                  <a:txBody>
+                    <a:bodyPr/>
+                    <a:lstStyle/>
+                    <a:p>
+                      <a:pPr algn="l" indent="0" marL="0">
+                        <a:buNone/>
+                      </a:pPr>
+                      <a:r>
+                        <a:rPr lang="en-US" sz="1200" b="1" dirty="0">
+                          <a:solidFill>
+                            <a:srgbClr val="212121"/>
+                          </a:solidFill>
+                          <a:latin typeface="Calibri" pitchFamily="34" charset="0"/>
+                          <a:ea typeface="Calibri" pitchFamily="34" charset="-122"/>
+                          <a:cs typeface="Calibri" pitchFamily="34" charset="-120"/>
+                        </a:rPr>
+                        <a:t>Verification &amp; appraisal</a:t>
+                      </a:r>
+                      <a:endParaRPr lang="en-US" sz="1200" dirty="0">
+                        <a:latin typeface="Calibri" charset="0"/>
+                        <a:ea typeface="Calibri" charset="0"/>
+                        <a:cs typeface="Calibri" charset="0"/>
+                      </a:endParaRPr>
+                    </a:p>
+                  </a:txBody>
+                  <a:tcPr marL="82296" marR="82296" marT="82296" marB="82296" anchor="ctr">
+                    <a:lnL w="12700" cap="flat" cmpd="sng" algn="ctr">
+                      <a:solidFill>
+                        <a:srgbClr val="D8DEEA"/>
+                      </a:solidFill>
+                      <a:prstDash val="solid"/>
+                      <a:round/>
+                      <a:headEnd type="none" w="med" len="med"/>
+                      <a:tailEnd type="none" w="med" len="med"/>
+                    </a:lnL>
+                    <a:lnR w="12700" cap="flat" cmpd="sng" algn="ctr">
+                      <a:solidFill>
+                        <a:srgbClr val="D8DEEA"/>
+                      </a:solidFill>
+                      <a:prstDash val="solid"/>
+                      <a:round/>
+                      <a:headEnd type="none" w="med" len="med"/>
+                      <a:tailEnd type="none" w="med" len="med"/>
+                    </a:lnR>
+                    <a:lnT w="12700" cap="flat" cmpd="sng" algn="ctr">
+                      <a:solidFill>
+                        <a:srgbClr val="D8DEEA"/>
+                      </a:solidFill>
+                      <a:prstDash val="solid"/>
+                      <a:round/>
+                      <a:headEnd type="none" w="med" len="med"/>
+                      <a:tailEnd type="none" w="med" len="med"/>
+                    </a:lnT>
+                    <a:lnB w="12700" cap="flat" cmpd="sng" algn="ctr">
+                      <a:solidFill>
+                        <a:srgbClr val="D8DEEA"/>
+                      </a:solidFill>
+                      <a:prstDash val="solid"/>
+                      <a:round/>
+                      <a:headEnd type="none" w="med" len="med"/>
+                      <a:tailEnd type="none" w="med" len="med"/>
+                    </a:lnB>
+                    <a:solidFill>
+                      <a:srgbClr val="E4E7EF"/>
+                    </a:solidFill>
+                  </a:tcPr>
+                </a:tc>
+                <a:tc>
+                  <a:txBody>
+                    <a:bodyPr/>
+                    <a:lstStyle/>
+                    <a:p>
+                      <a:pPr algn="l" indent="0" marL="0">
+                        <a:buNone/>
+                      </a:pPr>
+                      <a:r>
+                        <a:rPr lang="en-US" sz="1200" b="1" dirty="0">
+                          <a:solidFill>
+                            <a:srgbClr val="212121"/>
+                          </a:solidFill>
+                          <a:latin typeface="Calibri" pitchFamily="34" charset="0"/>
+                          <a:ea typeface="Calibri" pitchFamily="34" charset="-122"/>
+                          <a:cs typeface="Calibri" pitchFamily="34" charset="-120"/>
+                        </a:rPr>
+                        <a:t>none — by design</a:t>
+                      </a:r>
+                      <a:endParaRPr lang="en-US" sz="1200" dirty="0">
+                        <a:latin typeface="Calibri" charset="0"/>
+                        <a:ea typeface="Calibri" charset="0"/>
+                        <a:cs typeface="Calibri" charset="0"/>
+                      </a:endParaRPr>
+                    </a:p>
+                  </a:txBody>
+                  <a:tcPr marL="82296" marR="82296" marT="82296" marB="82296" anchor="ctr">
+                    <a:lnL w="12700" cap="flat" cmpd="sng" algn="ctr">
+                      <a:solidFill>
+                        <a:srgbClr val="D8DEEA"/>
+                      </a:solidFill>
+                      <a:prstDash val="solid"/>
+                      <a:round/>
+                      <a:headEnd type="none" w="med" len="med"/>
+                      <a:tailEnd type="none" w="med" len="med"/>
+                    </a:lnL>
+                    <a:lnR w="12700" cap="flat" cmpd="sng" algn="ctr">
+                      <a:solidFill>
+                        <a:srgbClr val="D8DEEA"/>
+                      </a:solidFill>
+                      <a:prstDash val="solid"/>
+                      <a:round/>
+                      <a:headEnd type="none" w="med" len="med"/>
+                      <a:tailEnd type="none" w="med" len="med"/>
+                    </a:lnR>
+                    <a:lnT w="12700" cap="flat" cmpd="sng" algn="ctr">
+                      <a:solidFill>
+                        <a:srgbClr val="D8DEEA"/>
+                      </a:solidFill>
+                      <a:prstDash val="solid"/>
+                      <a:round/>
+                      <a:headEnd type="none" w="med" len="med"/>
+                      <a:tailEnd type="none" w="med" len="med"/>
+                    </a:lnT>
+                    <a:lnB w="12700" cap="flat" cmpd="sng" algn="ctr">
+                      <a:solidFill>
+                        <a:srgbClr val="D8DEEA"/>
+                      </a:solidFill>
+                      <a:prstDash val="solid"/>
+                      <a:round/>
+                      <a:headEnd type="none" w="med" len="med"/>
+                      <a:tailEnd type="none" w="med" len="med"/>
+                    </a:lnB>
+                    <a:solidFill>
+                      <a:srgbClr val="E4E7EF"/>
+                    </a:solidFill>
+                  </a:tcPr>
+                </a:tc>
+                <a:tc>
+                  <a:txBody>
+                    <a:bodyPr/>
+                    <a:lstStyle/>
+                    <a:p>
+                      <a:pPr algn="l" indent="0" marL="0">
+                        <a:buNone/>
+                      </a:pPr>
+                      <a:r>
+                        <a:rPr lang="en-US" sz="1200" dirty="0">
+                          <a:solidFill>
+                            <a:srgbClr val="212121"/>
+                          </a:solidFill>
+                          <a:latin typeface="Calibri" pitchFamily="34" charset="0"/>
+                          <a:ea typeface="Calibri" pitchFamily="34" charset="-122"/>
+                          <a:cs typeface="Calibri" pitchFamily="34" charset="-120"/>
+                        </a:rPr>
+                        <a:t>deterministic judges: proof kernels (Rocq, Lean, Verus), hash appraisal vs signed goldens, semantic analysis of source code</a:t>
+                      </a:r>
+                      <a:endParaRPr lang="en-US" sz="1200" dirty="0">
+                        <a:latin typeface="Calibri" charset="0"/>
+                        <a:ea typeface="Calibri" charset="0"/>
+                        <a:cs typeface="Calibri" charset="0"/>
+                      </a:endParaRPr>
+                    </a:p>
+                  </a:txBody>
+                  <a:tcPr marL="82296" marR="82296" marT="82296" marB="82296" anchor="ctr">
+                    <a:lnL w="12700" cap="flat" cmpd="sng" algn="ctr">
+                      <a:solidFill>
+                        <a:srgbClr val="D8DEEA"/>
+                      </a:solidFill>
+                      <a:prstDash val="solid"/>
+                      <a:round/>
+                      <a:headEnd type="none" w="med" len="med"/>
+                      <a:tailEnd type="none" w="med" len="med"/>
+                    </a:lnL>
+                    <a:lnR w="12700" cap="flat" cmpd="sng" algn="ctr">
+                      <a:solidFill>
+                        <a:srgbClr val="D8DEEA"/>
+                      </a:solidFill>
+                      <a:prstDash val="solid"/>
+                      <a:round/>
+                      <a:headEnd type="none" w="med" len="med"/>
+                      <a:tailEnd type="none" w="med" len="med"/>
+                    </a:lnR>
+                    <a:lnT w="12700" cap="flat" cmpd="sng" algn="ctr">
+                      <a:solidFill>
+                        <a:srgbClr val="D8DEEA"/>
+                      </a:solidFill>
+                      <a:prstDash val="solid"/>
+                      <a:round/>
+                      <a:headEnd type="none" w="med" len="med"/>
+                      <a:tailEnd type="none" w="med" len="med"/>
+                    </a:lnT>
+                    <a:lnB w="12700" cap="flat" cmpd="sng" algn="ctr">
+                      <a:solidFill>
+                        <a:srgbClr val="D8DEEA"/>
+                      </a:solidFill>
+                      <a:prstDash val="solid"/>
+                      <a:round/>
+                      <a:headEnd type="none" w="med" len="med"/>
+                      <a:tailEnd type="none" w="med" len="med"/>
+                    </a:lnB>
+                    <a:solidFill>
+                      <a:srgbClr val="E4E7EF"/>
+                    </a:solidFill>
+                  </a:tcPr>
+                </a:tc>
+              </a:tr>
+              <a:tr h="658368">
+                <a:tc>
+                  <a:txBody>
+                    <a:bodyPr/>
+                    <a:lstStyle/>
+                    <a:p>
+                      <a:pPr algn="l" indent="0" marL="0">
+                        <a:buNone/>
+                      </a:pPr>
+                      <a:r>
+                        <a:rPr lang="en-US" sz="1200" b="1" dirty="0">
+                          <a:solidFill>
+                            <a:srgbClr val="212121"/>
+                          </a:solidFill>
+                          <a:latin typeface="Calibri" pitchFamily="34" charset="0"/>
+                          <a:ea typeface="Calibri" pitchFamily="34" charset="-122"/>
+                          <a:cs typeface="Calibri" pitchFamily="34" charset="-120"/>
+                        </a:rPr>
+                        <a:t>Evidence / trust state</a:t>
+                      </a:r>
+                      <a:endParaRPr lang="en-US" sz="1200" dirty="0">
+                        <a:latin typeface="Calibri" charset="0"/>
+                        <a:ea typeface="Calibri" charset="0"/>
+                        <a:cs typeface="Calibri" charset="0"/>
+                      </a:endParaRPr>
+                    </a:p>
+                  </a:txBody>
+                  <a:tcPr marL="82296" marR="82296" marT="82296" marB="82296" anchor="ctr">
+                    <a:lnL w="12700" cap="flat" cmpd="sng" algn="ctr">
+                      <a:solidFill>
+                        <a:srgbClr val="D8DEEA"/>
+                      </a:solidFill>
+                      <a:prstDash val="solid"/>
+                      <a:round/>
+                      <a:headEnd type="none" w="med" len="med"/>
+                      <a:tailEnd type="none" w="med" len="med"/>
+                    </a:lnL>
+                    <a:lnR w="12700" cap="flat" cmpd="sng" algn="ctr">
+                      <a:solidFill>
+                        <a:srgbClr val="D8DEEA"/>
+                      </a:solidFill>
+                      <a:prstDash val="solid"/>
+                      <a:round/>
+                      <a:headEnd type="none" w="med" len="med"/>
+                      <a:tailEnd type="none" w="med" len="med"/>
+                    </a:lnR>
+                    <a:lnT w="12700" cap="flat" cmpd="sng" algn="ctr">
+                      <a:solidFill>
+                        <a:srgbClr val="D8DEEA"/>
+                      </a:solidFill>
+                      <a:prstDash val="solid"/>
+                      <a:round/>
+                      <a:headEnd type="none" w="med" len="med"/>
+                      <a:tailEnd type="none" w="med" len="med"/>
+                    </a:lnT>
+                    <a:lnB w="12700" cap="flat" cmpd="sng" algn="ctr">
+                      <a:solidFill>
+                        <a:srgbClr val="D8DEEA"/>
+                      </a:solidFill>
+                      <a:prstDash val="solid"/>
+                      <a:round/>
+                      <a:headEnd type="none" w="med" len="med"/>
+                      <a:tailEnd type="none" w="med" len="med"/>
+                    </a:lnB>
+                    <a:solidFill>
+                      <a:srgbClr val="E4E7EF"/>
+                    </a:solidFill>
+                  </a:tcPr>
+                </a:tc>
+                <a:tc>
+                  <a:txBody>
+                    <a:bodyPr/>
+                    <a:lstStyle/>
+                    <a:p>
+                      <a:pPr algn="l" indent="0" marL="0">
+                        <a:buNone/>
+                      </a:pPr>
+                      <a:r>
+                        <a:rPr lang="en-US" sz="1200" b="1" dirty="0">
+                          <a:solidFill>
+                            <a:srgbClr val="212121"/>
+                          </a:solidFill>
+                          <a:latin typeface="Calibri" pitchFamily="34" charset="0"/>
+                          <a:ea typeface="Calibri" pitchFamily="34" charset="-122"/>
+                          <a:cs typeface="Calibri" pitchFamily="34" charset="-120"/>
+                        </a:rPr>
+                        <a:t>none — by design</a:t>
+                      </a:r>
+                      <a:endParaRPr lang="en-US" sz="1200" dirty="0">
+                        <a:latin typeface="Calibri" charset="0"/>
+                        <a:ea typeface="Calibri" charset="0"/>
+                        <a:cs typeface="Calibri" charset="0"/>
+                      </a:endParaRPr>
+                    </a:p>
+                  </a:txBody>
+                  <a:tcPr marL="82296" marR="82296" marT="82296" marB="82296" anchor="ctr">
+                    <a:lnL w="12700" cap="flat" cmpd="sng" algn="ctr">
+                      <a:solidFill>
+                        <a:srgbClr val="D8DEEA"/>
+                      </a:solidFill>
+                      <a:prstDash val="solid"/>
+                      <a:round/>
+                      <a:headEnd type="none" w="med" len="med"/>
+                      <a:tailEnd type="none" w="med" len="med"/>
+                    </a:lnL>
+                    <a:lnR w="12700" cap="flat" cmpd="sng" algn="ctr">
+                      <a:solidFill>
+                        <a:srgbClr val="D8DEEA"/>
+                      </a:solidFill>
+                      <a:prstDash val="solid"/>
+                      <a:round/>
+                      <a:headEnd type="none" w="med" len="med"/>
+                      <a:tailEnd type="none" w="med" len="med"/>
+                    </a:lnR>
+                    <a:lnT w="12700" cap="flat" cmpd="sng" algn="ctr">
+                      <a:solidFill>
+                        <a:srgbClr val="D8DEEA"/>
+                      </a:solidFill>
+                      <a:prstDash val="solid"/>
+                      <a:round/>
+                      <a:headEnd type="none" w="med" len="med"/>
+                      <a:tailEnd type="none" w="med" len="med"/>
+                    </a:lnT>
+                    <a:lnB w="12700" cap="flat" cmpd="sng" algn="ctr">
+                      <a:solidFill>
+                        <a:srgbClr val="D8DEEA"/>
+                      </a:solidFill>
+                      <a:prstDash val="solid"/>
+                      <a:round/>
+                      <a:headEnd type="none" w="med" len="med"/>
+                      <a:tailEnd type="none" w="med" len="med"/>
+                    </a:lnB>
+                    <a:solidFill>
+                      <a:srgbClr val="E4E7EF"/>
+                    </a:solidFill>
+                  </a:tcPr>
+                </a:tc>
+                <a:tc>
+                  <a:txBody>
+                    <a:bodyPr/>
+                    <a:lstStyle/>
+                    <a:p>
+                      <a:pPr algn="l" indent="0" marL="0">
+                        <a:buNone/>
+                      </a:pPr>
+                      <a:r>
+                        <a:rPr lang="en-US" sz="1200" dirty="0">
+                          <a:solidFill>
+                            <a:srgbClr val="212121"/>
+                          </a:solidFill>
+                          <a:latin typeface="Calibri" pitchFamily="34" charset="0"/>
+                          <a:ea typeface="Calibri" pitchFamily="34" charset="-122"/>
+                          <a:cs typeface="Calibri" pitchFamily="34" charset="-120"/>
+                        </a:rPr>
+                        <a:t>cryptographic anchor · non-derivability; no one (human or AI) may repair a baseline without fresh administrator blessing</a:t>
+                      </a:r>
+                      <a:endParaRPr lang="en-US" sz="1200" dirty="0">
+                        <a:latin typeface="Calibri" charset="0"/>
+                        <a:ea typeface="Calibri" charset="0"/>
+                        <a:cs typeface="Calibri" charset="0"/>
+                      </a:endParaRPr>
+                    </a:p>
+                  </a:txBody>
+                  <a:tcPr marL="82296" marR="82296" marT="82296" marB="82296" anchor="ctr">
+                    <a:lnL w="12700" cap="flat" cmpd="sng" algn="ctr">
+                      <a:solidFill>
+                        <a:srgbClr val="D8DEEA"/>
+                      </a:solidFill>
+                      <a:prstDash val="solid"/>
+                      <a:round/>
+                      <a:headEnd type="none" w="med" len="med"/>
+                      <a:tailEnd type="none" w="med" len="med"/>
+                    </a:lnL>
+                    <a:lnR w="12700" cap="flat" cmpd="sng" algn="ctr">
+                      <a:solidFill>
+                        <a:srgbClr val="D8DEEA"/>
+                      </a:solidFill>
+                      <a:prstDash val="solid"/>
+                      <a:round/>
+                      <a:headEnd type="none" w="med" len="med"/>
+                      <a:tailEnd type="none" w="med" len="med"/>
+                    </a:lnR>
+                    <a:lnT w="12700" cap="flat" cmpd="sng" algn="ctr">
+                      <a:solidFill>
+                        <a:srgbClr val="D8DEEA"/>
+                      </a:solidFill>
+                      <a:prstDash val="solid"/>
+                      <a:round/>
+                      <a:headEnd type="none" w="med" len="med"/>
+                      <a:tailEnd type="none" w="med" len="med"/>
+                    </a:lnT>
+                    <a:lnB w="12700" cap="flat" cmpd="sng" algn="ctr">
+                      <a:solidFill>
+                        <a:srgbClr val="D8DEEA"/>
+                      </a:solidFill>
+                      <a:prstDash val="solid"/>
+                      <a:round/>
+                      <a:headEnd type="none" w="med" len="med"/>
+                      <a:tailEnd type="none" w="med" len="med"/>
+                    </a:lnB>
+                    <a:solidFill>
+                      <a:srgbClr val="E4E7EF"/>
+                    </a:solidFill>
+                  </a:tcPr>
+                </a:tc>
+              </a:tr>
+            </a:tbl>
+          </a:graphicData>
+        </a:graphic>
+      </p:graphicFrame>
+      <p:sp>
+        <p:nvSpPr>
+          <p:cNvPr id="5" name="Text 2"/>
+          <p:cNvSpPr/>
+          <p:nvPr/>
+        </p:nvSpPr>
+        <p:spPr>
+          <a:xfrm>
+            <a:off x="640080" y="5989320"/>
+            <a:ext cx="10881360" cy="685800"/>
+          </a:xfrm>
+          <a:prstGeom prst="rect">
+            <a:avLst/>
+          </a:prstGeom>
+          <a:noFill/>
+          <a:ln/>
+        </p:spPr>
+        <p:txBody>
+          <a:bodyPr wrap="square" lIns="0" tIns="0" rIns="0" bIns="0" rtlCol="0" anchor="t"/>
+          <a:lstStyle/>
+          <a:p>
+            <a:pPr algn="l" indent="0" marL="0">
+              <a:buNone/>
+            </a:pPr>
+            <a:r>
+              <a:rPr lang="en-US" sz="1250" b="1" i="1" dirty="0">
+                <a:solidFill>
+                  <a:srgbClr val="1E2761"/>
+                </a:solidFill>
+                <a:latin typeface="Calibri" pitchFamily="34" charset="0"/>
+                <a:ea typeface="Calibri" pitchFamily="34" charset="-122"/>
+                <a:cs typeface="Calibri" pitchFamily="34" charset="-120"/>
+              </a:rPr>
+              <a:t>🔒  the bottom two — the judges — are AI-free by design</a:t>
+            </a:r>
+            <a:pPr algn="l" indent="0" marL="0">
+              <a:buNone/>
+            </a:pPr>
+            <a:r>
+              <a:rPr lang="en-US" sz="1250" i="1" dirty="0">
+                <a:solidFill>
+                  <a:srgbClr val="212121"/>
+                </a:solidFill>
+                <a:latin typeface="Calibri" pitchFamily="34" charset="0"/>
+                <a:ea typeface="Calibri" pitchFamily="34" charset="-122"/>
+                <a:cs typeface="Calibri" pitchFamily="34" charset="-120"/>
+              </a:rPr>
+              <a:t>:  an LLM’s output is just another untrusted artifact, facing the same episode and appraisal as a human edit or a tamper. Guarantees never depend on LLM engines being good, honest, or even present.</a:t>
+            </a:r>
+            <a:endParaRPr lang="en-US" sz="1250" dirty="0"/>
+          </a:p>
+        </p:txBody>
+      </p:sp>
+    </p:spTree>
+  </p:cSld>
+  <p:clrMapOvr>
+    <a:masterClrMapping/>
+  </p:clrMapOvr>
+</p:sld>
+</file>
+
+<file path=ppt/slides/slide18.xml><?xml version="1.0" encoding="utf-8"?>
+<p:sld xmlns:a="http://schemas.openxmlformats.org/drawingml/2006/main" xmlns:r="http://schemas.openxmlformats.org/officeDocument/2006/relationships" xmlns:p="http://schemas.openxmlformats.org/presentationml/2006/main">
+  <p:cSld name="Slide 18">
+    <p:bg>
+      <p:bgPr>
+        <a:solidFill>
+          <a:srgbClr val="FFFFFF"/>
+        </a:solidFill>
+      </p:bgPr>
+    </p:bg>
+    <p:spTree>
+      <p:nvGrpSpPr>
+        <p:cNvPr id="1" name=""/>
+        <p:cNvGrpSpPr/>
+        <p:nvPr/>
+      </p:nvGrpSpPr>
+      <p:grpSpPr>
+        <a:xfrm>
+          <a:off x="0" y="0"/>
+          <a:ext cx="0" cy="0"/>
+          <a:chOff x="0" y="0"/>
+          <a:chExt cx="0" cy="0"/>
+        </a:xfrm>
+      </p:grpSpPr>
+      <p:sp>
+        <p:nvSpPr>
+          <p:cNvPr id="2" name="Text 0"/>
+          <p:cNvSpPr/>
+          <p:nvPr/>
+        </p:nvSpPr>
+        <p:spPr>
+          <a:xfrm>
             <a:off x="640080" y="411480"/>
             <a:ext cx="10972800" cy="731520"/>
           </a:xfrm>

</xml_diff>

<commit_message>
capstone B: "AI built the loop" + capstone A caption edits
Second AI capstone slide (deck 18): AI built the loop — a 5-row table
(blackboard infrastructure, CVM core & frontends, measurement
primitives, attestation protocols, attacks) with the judged-by payoff,
closing on the "virtuous cycle" footer. Includes the user's manual
edits to both A and B (ported verbatim; regenerated slides match): A's
tightened caption; B's title→"AI built the loop", the CVM row's honest
"Claude assisted an expert Rocq developer" note, measurement-primitives
rename, and the virtuous-cycle footer. Git-provenance framing dropped.

Co-Authored-By: Claude Fable 5 <noreply@anthropic.com>
</commit_message>
<xml_diff>
--- a/docs/video_slides_draft.pptx
+++ b/docs/video_slides_draft.pptx
@@ -23,9 +23,10 @@
     <p:sldId id="271" r:id="rId17"/>
     <p:sldId id="272" r:id="rId18"/>
     <p:sldId id="273" r:id="rId19"/>
+    <p:sldId id="274" r:id="rId20"/>
   </p:sldIdLst>
   <p:notesMasterIdLst>
-    <p:notesMasterId r:id="rId20"/>
+    <p:notesMasterId r:id="rId21"/>
   </p:notesMasterIdLst>
   <p:sldSz cx="12192000" cy="6858000"/>
   <p:notesSz cx="6858000" cy="12192000"/>
@@ -1320,8 +1321,10 @@
           <a:p>
             <a:r>
               <a:rPr lang="en-US" dirty="0"/>
-              <a:t>Collection point for every reference in the deck - keep this slide current as sections are added (isolette slide carries the K-State + AR-08-32 citations inline; Copland/Verus/seL4 seeded here ahead of their sections).
-DOIs on record in docs/video_slide_drafts.md.</a:t>
+              <a:t>Capstone slide 2 of 3 (theme: 'AI in the loop' big title + caption). The one idea: AI built the entire attestation stack, and that stack is held to the same measured discipline it enforces.
+Counts current 2026-08-30: 12 new + 7 upgraded asp-libs binaries (git-attested, separate repo); 42 provisioned Copland protocol dirs (the newest, the l1b marker tier, was built in this very session - a callback available if wanted); 7 red-team attack classes.
+cvm-mcp aside (15 s): an AI-built MCP interface so AI agents can drive attestation - AI both built the loop and can drive it.
+Git provenance deliberately de-emphasized per user; the point is the self-application (the reflexive footer), not the Co-Authored-By trailers.</a:t>
             </a:r>
             <a:endParaRPr lang="en-US" dirty="0"/>
           </a:p>
@@ -1345,6 +1348,95 @@
             <a:fld id="{F7021451-1387-4CA6-816F-3879F97B5CBC}" type="slidenum">
               <a:rPr lang="en-US"/>
               <a:t>18</a:t>
+            </a:fld>
+            <a:endParaRPr lang="en-US"/>
+          </a:p>
+        </p:txBody>
+      </p:sp>
+    </p:spTree>
+    <p:extLst>
+      <p:ext uri="{BB962C8B-B14F-4D97-AF65-F5344CB8AC3E}">
+        <p14:creationId xmlns:p14="http://schemas.microsoft.com/office/powerpoint/2010/main" val="1024086991"/>
+      </p:ext>
+    </p:extLst>
+  </p:cSld>
+  <p:clrMapOvr>
+    <a:masterClrMapping/>
+  </p:clrMapOvr>
+</p:notes>
+</file>
+
+<file path=ppt/notesSlides/notesSlide19.xml><?xml version="1.0" encoding="utf-8"?>
+<p:notes xmlns:a="http://schemas.openxmlformats.org/drawingml/2006/main" xmlns:r="http://schemas.openxmlformats.org/officeDocument/2006/relationships" xmlns:p="http://schemas.openxmlformats.org/presentationml/2006/main">
+  <p:cSld>
+    <p:spTree>
+      <p:nvGrpSpPr>
+        <p:cNvPr id="1" name=""/>
+        <p:cNvGrpSpPr/>
+        <p:nvPr/>
+      </p:nvGrpSpPr>
+      <p:grpSpPr>
+        <a:xfrm>
+          <a:off x="0" y="0"/>
+          <a:ext cx="0" cy="0"/>
+          <a:chOff x="0" y="0"/>
+          <a:chExt cx="0" cy="0"/>
+        </a:xfrm>
+      </p:grpSpPr>
+      <p:sp>
+        <p:nvSpPr>
+          <p:cNvPr id="2" name="Slide Image Placeholder 1"/>
+          <p:cNvSpPr>
+            <a:spLocks noGrp="1" noRot="1" noChangeAspect="1"/>
+          </p:cNvSpPr>
+          <p:nvPr>
+            <p:ph type="sldImg"/>
+          </p:nvPr>
+        </p:nvSpPr>
+        <p:spPr/>
+      </p:sp>
+      <p:sp>
+        <p:nvSpPr>
+          <p:cNvPr id="3" name="Notes Placeholder 2"/>
+          <p:cNvSpPr>
+            <a:spLocks noGrp="1"/>
+          </p:cNvSpPr>
+          <p:nvPr>
+            <p:ph type="body" idx="1"/>
+          </p:nvPr>
+        </p:nvSpPr>
+        <p:spPr/>
+        <p:txBody>
+          <a:bodyPr/>
+          <a:lstStyle/>
+          <a:p>
+            <a:r>
+              <a:rPr lang="en-US" dirty="0"/>
+              <a:t>Collection point for every reference in the deck - keep this slide current as sections are added (isolette slide carries the K-State + AR-08-32 citations inline; Copland/Verus/seL4 seeded here ahead of their sections).
+DOIs on record in docs/video_slide_drafts.md.</a:t>
+            </a:r>
+            <a:endParaRPr lang="en-US" dirty="0"/>
+          </a:p>
+        </p:txBody>
+      </p:sp>
+      <p:sp>
+        <p:nvSpPr>
+          <p:cNvPr id="4" name="Slide Number Placeholder 3"/>
+          <p:cNvSpPr>
+            <a:spLocks noGrp="1"/>
+          </p:cNvSpPr>
+          <p:nvPr>
+            <p:ph type="sldNum" sz="quarter" idx="10"/>
+          </p:nvPr>
+        </p:nvSpPr>
+        <p:spPr/>
+        <p:txBody>
+          <a:bodyPr/>
+          <a:lstStyle/>
+          <a:p>
+            <a:fld id="{F7021451-1387-4CA6-816F-3879F97B5CBC}" type="slidenum">
+              <a:rPr lang="en-US"/>
+              <a:t>19</a:t>
             </a:fld>
             <a:endParaRPr lang="en-US"/>
           </a:p>
@@ -6974,7 +7066,7 @@
                 <a:ea typeface="Calibri" pitchFamily="34" charset="-122"/>
                 <a:cs typeface="Calibri" pitchFamily="34" charset="-120"/>
               </a:rPr>
-              <a:t>untrusted artifact synthesis and repair;  verified audit and deterministic appraisal</a:t>
+              <a:t>untrusted artifact synthesis/repair;  verified, deterministic appraisal</a:t>
             </a:r>
             <a:endParaRPr lang="en-US" sz="1600" dirty="0"/>
           </a:p>
@@ -8339,6 +8431,1551 @@
 <file path=ppt/slides/slide18.xml><?xml version="1.0" encoding="utf-8"?>
 <p:sld xmlns:a="http://schemas.openxmlformats.org/drawingml/2006/main" xmlns:r="http://schemas.openxmlformats.org/officeDocument/2006/relationships" xmlns:p="http://schemas.openxmlformats.org/presentationml/2006/main">
   <p:cSld name="Slide 18">
+    <p:bg>
+      <p:bgPr>
+        <a:solidFill>
+          <a:srgbClr val="FFFFFF"/>
+        </a:solidFill>
+      </p:bgPr>
+    </p:bg>
+    <p:spTree>
+      <p:nvGrpSpPr>
+        <p:cNvPr id="1" name=""/>
+        <p:cNvGrpSpPr/>
+        <p:nvPr/>
+      </p:nvGrpSpPr>
+      <p:grpSpPr>
+        <a:xfrm>
+          <a:off x="0" y="0"/>
+          <a:ext cx="0" cy="0"/>
+          <a:chOff x="0" y="0"/>
+          <a:chExt cx="0" cy="0"/>
+        </a:xfrm>
+      </p:grpSpPr>
+      <p:sp>
+        <p:nvSpPr>
+          <p:cNvPr id="2" name="Text 0"/>
+          <p:cNvSpPr/>
+          <p:nvPr/>
+        </p:nvSpPr>
+        <p:spPr>
+          <a:xfrm>
+            <a:off x="640080" y="347472"/>
+            <a:ext cx="10972800" cy="640080"/>
+          </a:xfrm>
+          <a:prstGeom prst="rect">
+            <a:avLst/>
+          </a:prstGeom>
+          <a:noFill/>
+          <a:ln/>
+        </p:spPr>
+        <p:txBody>
+          <a:bodyPr wrap="square" lIns="0" tIns="0" rIns="0" bIns="0" rtlCol="0" anchor="ctr"/>
+          <a:lstStyle/>
+          <a:p>
+            <a:pPr indent="0" marL="0">
+              <a:buNone/>
+            </a:pPr>
+            <a:r>
+              <a:rPr lang="en-US" sz="4000" b="1" dirty="0">
+                <a:solidFill>
+                  <a:srgbClr val="1E2761"/>
+                </a:solidFill>
+                <a:latin typeface="Cambria" pitchFamily="34" charset="0"/>
+                <a:ea typeface="Cambria" pitchFamily="34" charset="-122"/>
+                <a:cs typeface="Cambria" pitchFamily="34" charset="-120"/>
+              </a:rPr>
+              <a:t>AI built the loop</a:t>
+            </a:r>
+            <a:endParaRPr lang="en-US" sz="4000" dirty="0"/>
+          </a:p>
+        </p:txBody>
+      </p:sp>
+      <p:sp>
+        <p:nvSpPr>
+          <p:cNvPr id="3" name="Text 1"/>
+          <p:cNvSpPr/>
+          <p:nvPr/>
+        </p:nvSpPr>
+        <p:spPr>
+          <a:xfrm>
+            <a:off x="658368" y="1024128"/>
+            <a:ext cx="10972800" cy="411480"/>
+          </a:xfrm>
+          <a:prstGeom prst="rect">
+            <a:avLst/>
+          </a:prstGeom>
+          <a:noFill/>
+          <a:ln/>
+        </p:spPr>
+        <p:txBody>
+          <a:bodyPr wrap="square" lIns="0" tIns="0" rIns="0" bIns="0" rtlCol="0" anchor="ctr"/>
+          <a:lstStyle/>
+          <a:p>
+            <a:pPr indent="0" marL="0">
+              <a:buNone/>
+            </a:pPr>
+            <a:r>
+              <a:rPr lang="en-US" sz="1600" i="1" dirty="0">
+                <a:solidFill>
+                  <a:srgbClr val="5A6478"/>
+                </a:solidFill>
+                <a:latin typeface="Calibri" pitchFamily="34" charset="0"/>
+                <a:ea typeface="Calibri" pitchFamily="34" charset="-122"/>
+                <a:cs typeface="Calibri" pitchFamily="34" charset="-120"/>
+              </a:rPr>
+              <a:t>blackboard and attestation infrastructure, artifact measurements, attestation protocols, attacks</a:t>
+            </a:r>
+            <a:endParaRPr lang="en-US" sz="1600" dirty="0"/>
+          </a:p>
+        </p:txBody>
+      </p:sp>
+      <p:graphicFrame>
+        <p:nvGraphicFramePr>
+          <p:cNvPr id="19" name="Table 0"/>
+          <p:cNvGraphicFramePr>
+            <a:graphicFrameLocks noGrp="1"/>
+          </p:cNvGraphicFramePr>
+          <p:nvPr>
+            <p:extLst>
+              <p:ext uri="{D42A27DB-BD31-4B8C-83A1-F6EECF244321}">
+                <p14:modId xmlns:p14="http://schemas.microsoft.com/office/powerpoint/2010/main" val="1579011935"/>
+              </p:ext>
+            </p:extLst>
+          </p:nvPr>
+        </p:nvGraphicFramePr>
+        <p:xfrm>
+          <a:off x="640080" y="1600200"/>
+          <a:ext cx="10881360" cy="914400"/>
+        </p:xfrm>
+        <a:graphic>
+          <a:graphicData uri="http://schemas.openxmlformats.org/drawingml/2006/table">
+            <a:tbl>
+              <a:tblPr/>
+              <a:tblGrid>
+                <a:gridCol w="2377440"/>
+                <a:gridCol w="5120640"/>
+                <a:gridCol w="3383280"/>
+              </a:tblGrid>
+              <a:tr h="365760">
+                <a:tc>
+                  <a:txBody>
+                    <a:bodyPr/>
+                    <a:lstStyle/>
+                    <a:p>
+                      <a:pPr algn="l" indent="0" marL="0">
+                        <a:buNone/>
+                      </a:pPr>
+                      <a:r>
+                        <a:rPr lang="en-US" sz="1350" b="1" dirty="0">
+                          <a:solidFill>
+                            <a:srgbClr val="FFFFFF"/>
+                          </a:solidFill>
+                          <a:latin typeface="Calibri" pitchFamily="34" charset="0"/>
+                          <a:ea typeface="Calibri" pitchFamily="34" charset="-122"/>
+                          <a:cs typeface="Calibri" pitchFamily="34" charset="-120"/>
+                        </a:rPr>
+                        <a:t>What AI built</a:t>
+                      </a:r>
+                      <a:endParaRPr lang="en-US" sz="1350" dirty="0">
+                        <a:latin typeface="Calibri" charset="0"/>
+                        <a:ea typeface="Calibri" charset="0"/>
+                        <a:cs typeface="Calibri" charset="0"/>
+                      </a:endParaRPr>
+                    </a:p>
+                  </a:txBody>
+                  <a:tcPr marL="82296" marR="82296" marT="82296" marB="82296" anchor="ctr">
+                    <a:lnL w="12700" cap="flat" cmpd="sng" algn="ctr">
+                      <a:solidFill>
+                        <a:srgbClr val="D8DEEA"/>
+                      </a:solidFill>
+                      <a:prstDash val="solid"/>
+                      <a:round/>
+                      <a:headEnd type="none" w="med" len="med"/>
+                      <a:tailEnd type="none" w="med" len="med"/>
+                    </a:lnL>
+                    <a:lnR w="12700" cap="flat" cmpd="sng" algn="ctr">
+                      <a:solidFill>
+                        <a:srgbClr val="D8DEEA"/>
+                      </a:solidFill>
+                      <a:prstDash val="solid"/>
+                      <a:round/>
+                      <a:headEnd type="none" w="med" len="med"/>
+                      <a:tailEnd type="none" w="med" len="med"/>
+                    </a:lnR>
+                    <a:lnT w="12700" cap="flat" cmpd="sng" algn="ctr">
+                      <a:solidFill>
+                        <a:srgbClr val="D8DEEA"/>
+                      </a:solidFill>
+                      <a:prstDash val="solid"/>
+                      <a:round/>
+                      <a:headEnd type="none" w="med" len="med"/>
+                      <a:tailEnd type="none" w="med" len="med"/>
+                    </a:lnT>
+                    <a:lnB w="12700" cap="flat" cmpd="sng" algn="ctr">
+                      <a:solidFill>
+                        <a:srgbClr val="D8DEEA"/>
+                      </a:solidFill>
+                      <a:prstDash val="solid"/>
+                      <a:round/>
+                      <a:headEnd type="none" w="med" len="med"/>
+                      <a:tailEnd type="none" w="med" len="med"/>
+                    </a:lnB>
+                    <a:solidFill>
+                      <a:srgbClr val="1E2761"/>
+                    </a:solidFill>
+                  </a:tcPr>
+                </a:tc>
+                <a:tc>
+                  <a:txBody>
+                    <a:bodyPr/>
+                    <a:lstStyle/>
+                    <a:p>
+                      <a:pPr algn="l" indent="0" marL="0">
+                        <a:buNone/>
+                      </a:pPr>
+                      <a:endParaRPr lang="en-US" sz="1350" dirty="0">
+                        <a:latin typeface="Calibri" charset="0"/>
+                        <a:ea typeface="Calibri" charset="0"/>
+                        <a:cs typeface="Calibri" charset="0"/>
+                      </a:endParaRPr>
+                    </a:p>
+                  </a:txBody>
+                  <a:tcPr marL="82296" marR="82296" marT="82296" marB="82296" anchor="ctr">
+                    <a:lnL w="12700" cap="flat" cmpd="sng" algn="ctr">
+                      <a:solidFill>
+                        <a:srgbClr val="D8DEEA"/>
+                      </a:solidFill>
+                      <a:prstDash val="solid"/>
+                      <a:round/>
+                      <a:headEnd type="none" w="med" len="med"/>
+                      <a:tailEnd type="none" w="med" len="med"/>
+                    </a:lnL>
+                    <a:lnR w="12700" cap="flat" cmpd="sng" algn="ctr">
+                      <a:solidFill>
+                        <a:srgbClr val="D8DEEA"/>
+                      </a:solidFill>
+                      <a:prstDash val="solid"/>
+                      <a:round/>
+                      <a:headEnd type="none" w="med" len="med"/>
+                      <a:tailEnd type="none" w="med" len="med"/>
+                    </a:lnR>
+                    <a:lnT w="12700" cap="flat" cmpd="sng" algn="ctr">
+                      <a:solidFill>
+                        <a:srgbClr val="D8DEEA"/>
+                      </a:solidFill>
+                      <a:prstDash val="solid"/>
+                      <a:round/>
+                      <a:headEnd type="none" w="med" len="med"/>
+                      <a:tailEnd type="none" w="med" len="med"/>
+                    </a:lnT>
+                    <a:lnB w="12700" cap="flat" cmpd="sng" algn="ctr">
+                      <a:solidFill>
+                        <a:srgbClr val="D8DEEA"/>
+                      </a:solidFill>
+                      <a:prstDash val="solid"/>
+                      <a:round/>
+                      <a:headEnd type="none" w="med" len="med"/>
+                      <a:tailEnd type="none" w="med" len="med"/>
+                    </a:lnB>
+                    <a:solidFill>
+                      <a:srgbClr val="1E2761"/>
+                    </a:solidFill>
+                  </a:tcPr>
+                </a:tc>
+                <a:tc>
+                  <a:txBody>
+                    <a:bodyPr/>
+                    <a:lstStyle/>
+                    <a:p>
+                      <a:pPr algn="l" indent="0" marL="0">
+                        <a:buNone/>
+                      </a:pPr>
+                      <a:r>
+                        <a:rPr lang="en-US" sz="1350" b="1" dirty="0">
+                          <a:solidFill>
+                            <a:srgbClr val="FFFFFF"/>
+                          </a:solidFill>
+                          <a:latin typeface="Calibri" pitchFamily="34" charset="0"/>
+                          <a:ea typeface="Calibri" pitchFamily="34" charset="-122"/>
+                          <a:cs typeface="Calibri" pitchFamily="34" charset="-120"/>
+                        </a:rPr>
+                        <a:t>Judged by</a:t>
+                      </a:r>
+                      <a:endParaRPr lang="en-US" sz="1350" dirty="0">
+                        <a:latin typeface="Calibri" charset="0"/>
+                        <a:ea typeface="Calibri" charset="0"/>
+                        <a:cs typeface="Calibri" charset="0"/>
+                      </a:endParaRPr>
+                    </a:p>
+                  </a:txBody>
+                  <a:tcPr marL="82296" marR="82296" marT="82296" marB="82296" anchor="ctr">
+                    <a:lnL w="12700" cap="flat" cmpd="sng" algn="ctr">
+                      <a:solidFill>
+                        <a:srgbClr val="D8DEEA"/>
+                      </a:solidFill>
+                      <a:prstDash val="solid"/>
+                      <a:round/>
+                      <a:headEnd type="none" w="med" len="med"/>
+                      <a:tailEnd type="none" w="med" len="med"/>
+                    </a:lnL>
+                    <a:lnR w="12700" cap="flat" cmpd="sng" algn="ctr">
+                      <a:solidFill>
+                        <a:srgbClr val="D8DEEA"/>
+                      </a:solidFill>
+                      <a:prstDash val="solid"/>
+                      <a:round/>
+                      <a:headEnd type="none" w="med" len="med"/>
+                      <a:tailEnd type="none" w="med" len="med"/>
+                    </a:lnR>
+                    <a:lnT w="12700" cap="flat" cmpd="sng" algn="ctr">
+                      <a:solidFill>
+                        <a:srgbClr val="D8DEEA"/>
+                      </a:solidFill>
+                      <a:prstDash val="solid"/>
+                      <a:round/>
+                      <a:headEnd type="none" w="med" len="med"/>
+                      <a:tailEnd type="none" w="med" len="med"/>
+                    </a:lnT>
+                    <a:lnB w="12700" cap="flat" cmpd="sng" algn="ctr">
+                      <a:solidFill>
+                        <a:srgbClr val="D8DEEA"/>
+                      </a:solidFill>
+                      <a:prstDash val="solid"/>
+                      <a:round/>
+                      <a:headEnd type="none" w="med" len="med"/>
+                      <a:tailEnd type="none" w="med" len="med"/>
+                    </a:lnB>
+                    <a:solidFill>
+                      <a:srgbClr val="1E2761"/>
+                    </a:solidFill>
+                  </a:tcPr>
+                </a:tc>
+              </a:tr>
+              <a:tr h="640080">
+                <a:tc>
+                  <a:txBody>
+                    <a:bodyPr/>
+                    <a:lstStyle/>
+                    <a:p>
+                      <a:pPr algn="l" indent="0" marL="0">
+                        <a:buNone/>
+                      </a:pPr>
+                      <a:r>
+                        <a:rPr lang="en-US" sz="1200" b="1" dirty="0">
+                          <a:solidFill>
+                            <a:srgbClr val="212121"/>
+                          </a:solidFill>
+                          <a:latin typeface="Calibri" pitchFamily="34" charset="0"/>
+                          <a:ea typeface="Calibri" pitchFamily="34" charset="-122"/>
+                          <a:cs typeface="Calibri" pitchFamily="34" charset="-120"/>
+                        </a:rPr>
+                        <a:t>Blackboard infrastructure</a:t>
+                      </a:r>
+                      <a:endParaRPr lang="en-US" sz="1200" dirty="0">
+                        <a:latin typeface="Calibri" charset="0"/>
+                        <a:ea typeface="Calibri" charset="0"/>
+                        <a:cs typeface="Calibri" charset="0"/>
+                      </a:endParaRPr>
+                    </a:p>
+                  </a:txBody>
+                  <a:tcPr marL="82296" marR="82296" marT="82296" marB="82296" anchor="ctr">
+                    <a:lnL w="12700" cap="flat" cmpd="sng" algn="ctr">
+                      <a:solidFill>
+                        <a:srgbClr val="D8DEEA"/>
+                      </a:solidFill>
+                      <a:prstDash val="solid"/>
+                      <a:round/>
+                      <a:headEnd type="none" w="med" len="med"/>
+                      <a:tailEnd type="none" w="med" len="med"/>
+                    </a:lnL>
+                    <a:lnR w="12700" cap="flat" cmpd="sng" algn="ctr">
+                      <a:solidFill>
+                        <a:srgbClr val="D8DEEA"/>
+                      </a:solidFill>
+                      <a:prstDash val="solid"/>
+                      <a:round/>
+                      <a:headEnd type="none" w="med" len="med"/>
+                      <a:tailEnd type="none" w="med" len="med"/>
+                    </a:lnR>
+                    <a:lnT w="12700" cap="flat" cmpd="sng" algn="ctr">
+                      <a:solidFill>
+                        <a:srgbClr val="D8DEEA"/>
+                      </a:solidFill>
+                      <a:prstDash val="solid"/>
+                      <a:round/>
+                      <a:headEnd type="none" w="med" len="med"/>
+                      <a:tailEnd type="none" w="med" len="med"/>
+                    </a:lnT>
+                    <a:lnB w="12700" cap="flat" cmpd="sng" algn="ctr">
+                      <a:solidFill>
+                        <a:srgbClr val="D8DEEA"/>
+                      </a:solidFill>
+                      <a:prstDash val="solid"/>
+                      <a:round/>
+                      <a:headEnd type="none" w="med" len="med"/>
+                      <a:tailEnd type="none" w="med" len="med"/>
+                    </a:lnB>
+                    <a:solidFill>
+                      <a:srgbClr val="FFFFFF"/>
+                    </a:solidFill>
+                  </a:tcPr>
+                </a:tc>
+                <a:tc>
+                  <a:txBody>
+                    <a:bodyPr/>
+                    <a:lstStyle/>
+                    <a:p>
+                      <a:pPr algn="l" indent="0" marL="0">
+                        <a:buNone/>
+                      </a:pPr>
+                      <a:r>
+                        <a:rPr lang="en-US" sz="1200" dirty="0">
+                          <a:solidFill>
+                            <a:srgbClr val="212121"/>
+                          </a:solidFill>
+                          <a:latin typeface="Calibri" pitchFamily="34" charset="0"/>
+                          <a:ea typeface="Calibri" pitchFamily="34" charset="-122"/>
+                          <a:cs typeface="Calibri" pitchFamily="34" charset="-120"/>
+                        </a:rPr>
+                        <a:t>pybb framework (blackboard / controller / knowledge sources), demo arcs, install script, CI suite, detailed documentation</a:t>
+                      </a:r>
+                      <a:endParaRPr lang="en-US" sz="1200" dirty="0">
+                        <a:latin typeface="Calibri" charset="0"/>
+                        <a:ea typeface="Calibri" charset="0"/>
+                        <a:cs typeface="Calibri" charset="0"/>
+                      </a:endParaRPr>
+                    </a:p>
+                  </a:txBody>
+                  <a:tcPr marL="82296" marR="82296" marT="82296" marB="82296" anchor="ctr">
+                    <a:lnL w="12700" cap="flat" cmpd="sng" algn="ctr">
+                      <a:solidFill>
+                        <a:srgbClr val="D8DEEA"/>
+                      </a:solidFill>
+                      <a:prstDash val="solid"/>
+                      <a:round/>
+                      <a:headEnd type="none" w="med" len="med"/>
+                      <a:tailEnd type="none" w="med" len="med"/>
+                    </a:lnL>
+                    <a:lnR w="12700" cap="flat" cmpd="sng" algn="ctr">
+                      <a:solidFill>
+                        <a:srgbClr val="D8DEEA"/>
+                      </a:solidFill>
+                      <a:prstDash val="solid"/>
+                      <a:round/>
+                      <a:headEnd type="none" w="med" len="med"/>
+                      <a:tailEnd type="none" w="med" len="med"/>
+                    </a:lnR>
+                    <a:lnT w="12700" cap="flat" cmpd="sng" algn="ctr">
+                      <a:solidFill>
+                        <a:srgbClr val="D8DEEA"/>
+                      </a:solidFill>
+                      <a:prstDash val="solid"/>
+                      <a:round/>
+                      <a:headEnd type="none" w="med" len="med"/>
+                      <a:tailEnd type="none" w="med" len="med"/>
+                    </a:lnT>
+                    <a:lnB w="12700" cap="flat" cmpd="sng" algn="ctr">
+                      <a:solidFill>
+                        <a:srgbClr val="D8DEEA"/>
+                      </a:solidFill>
+                      <a:prstDash val="solid"/>
+                      <a:round/>
+                      <a:headEnd type="none" w="med" len="med"/>
+                      <a:tailEnd type="none" w="med" len="med"/>
+                    </a:lnB>
+                    <a:solidFill>
+                      <a:srgbClr val="FFFFFF"/>
+                    </a:solidFill>
+                  </a:tcPr>
+                </a:tc>
+                <a:tc>
+                  <a:txBody>
+                    <a:bodyPr/>
+                    <a:lstStyle/>
+                    <a:p>
+                      <a:pPr algn="l" indent="0" marL="0">
+                        <a:buNone/>
+                      </a:pPr>
+                      <a:r>
+                        <a:rPr lang="en-US" sz="1200" dirty="0">
+                          <a:solidFill>
+                            <a:srgbClr val="212121"/>
+                          </a:solidFill>
+                          <a:latin typeface="Calibri" pitchFamily="34" charset="0"/>
+                          <a:ea typeface="Calibri" pitchFamily="34" charset="-122"/>
+                          <a:cs typeface="Calibri" pitchFamily="34" charset="-120"/>
+                        </a:rPr>
+                        <a:t>Untrusted orchestration (evidence bundles are independently-verifiable)</a:t>
+                      </a:r>
+                      <a:endParaRPr lang="en-US" sz="1200" dirty="0">
+                        <a:latin typeface="Calibri" charset="0"/>
+                        <a:ea typeface="Calibri" charset="0"/>
+                        <a:cs typeface="Calibri" charset="0"/>
+                      </a:endParaRPr>
+                    </a:p>
+                  </a:txBody>
+                  <a:tcPr marL="82296" marR="82296" marT="82296" marB="82296" anchor="ctr">
+                    <a:lnL w="12700" cap="flat" cmpd="sng" algn="ctr">
+                      <a:solidFill>
+                        <a:srgbClr val="D8DEEA"/>
+                      </a:solidFill>
+                      <a:prstDash val="solid"/>
+                      <a:round/>
+                      <a:headEnd type="none" w="med" len="med"/>
+                      <a:tailEnd type="none" w="med" len="med"/>
+                    </a:lnL>
+                    <a:lnR w="12700" cap="flat" cmpd="sng" algn="ctr">
+                      <a:solidFill>
+                        <a:srgbClr val="D8DEEA"/>
+                      </a:solidFill>
+                      <a:prstDash val="solid"/>
+                      <a:round/>
+                      <a:headEnd type="none" w="med" len="med"/>
+                      <a:tailEnd type="none" w="med" len="med"/>
+                    </a:lnR>
+                    <a:lnT w="12700" cap="flat" cmpd="sng" algn="ctr">
+                      <a:solidFill>
+                        <a:srgbClr val="D8DEEA"/>
+                      </a:solidFill>
+                      <a:prstDash val="solid"/>
+                      <a:round/>
+                      <a:headEnd type="none" w="med" len="med"/>
+                      <a:tailEnd type="none" w="med" len="med"/>
+                    </a:lnT>
+                    <a:lnB w="12700" cap="flat" cmpd="sng" algn="ctr">
+                      <a:solidFill>
+                        <a:srgbClr val="D8DEEA"/>
+                      </a:solidFill>
+                      <a:prstDash val="solid"/>
+                      <a:round/>
+                      <a:headEnd type="none" w="med" len="med"/>
+                      <a:tailEnd type="none" w="med" len="med"/>
+                    </a:lnB>
+                    <a:solidFill>
+                      <a:srgbClr val="FFFFFF"/>
+                    </a:solidFill>
+                  </a:tcPr>
+                </a:tc>
+              </a:tr>
+              <a:tr h="658368">
+                <a:tc>
+                  <a:txBody>
+                    <a:bodyPr/>
+                    <a:lstStyle/>
+                    <a:p>
+                      <a:pPr algn="l" indent="0" marL="0">
+                        <a:buNone/>
+                      </a:pPr>
+                      <a:r>
+                        <a:rPr lang="en-US" sz="1200" b="1" dirty="0">
+                          <a:solidFill>
+                            <a:srgbClr val="212121"/>
+                          </a:solidFill>
+                          <a:latin typeface="Calibri" pitchFamily="34" charset="0"/>
+                          <a:ea typeface="Calibri" pitchFamily="34" charset="-122"/>
+                          <a:cs typeface="Calibri" pitchFamily="34" charset="-120"/>
+                        </a:rPr>
+                        <a:t>CVM core &amp; frontends</a:t>
+                      </a:r>
+                      <a:endParaRPr lang="en-US" sz="1200" dirty="0">
+                        <a:latin typeface="Calibri" charset="0"/>
+                        <a:ea typeface="Calibri" charset="0"/>
+                        <a:cs typeface="Calibri" charset="0"/>
+                      </a:endParaRPr>
+                    </a:p>
+                  </a:txBody>
+                  <a:tcPr marL="82296" marR="82296" marT="82296" marB="82296" anchor="ctr">
+                    <a:lnL w="12700" cap="flat" cmpd="sng" algn="ctr">
+                      <a:solidFill>
+                        <a:srgbClr val="D8DEEA"/>
+                      </a:solidFill>
+                      <a:prstDash val="solid"/>
+                      <a:round/>
+                      <a:headEnd type="none" w="med" len="med"/>
+                      <a:tailEnd type="none" w="med" len="med"/>
+                    </a:lnL>
+                    <a:lnR w="12700" cap="flat" cmpd="sng" algn="ctr">
+                      <a:solidFill>
+                        <a:srgbClr val="D8DEEA"/>
+                      </a:solidFill>
+                      <a:prstDash val="solid"/>
+                      <a:round/>
+                      <a:headEnd type="none" w="med" len="med"/>
+                      <a:tailEnd type="none" w="med" len="med"/>
+                    </a:lnR>
+                    <a:lnT w="12700" cap="flat" cmpd="sng" algn="ctr">
+                      <a:solidFill>
+                        <a:srgbClr val="D8DEEA"/>
+                      </a:solidFill>
+                      <a:prstDash val="solid"/>
+                      <a:round/>
+                      <a:headEnd type="none" w="med" len="med"/>
+                      <a:tailEnd type="none" w="med" len="med"/>
+                    </a:lnT>
+                    <a:lnB w="12700" cap="flat" cmpd="sng" algn="ctr">
+                      <a:solidFill>
+                        <a:srgbClr val="D8DEEA"/>
+                      </a:solidFill>
+                      <a:prstDash val="solid"/>
+                      <a:round/>
+                      <a:headEnd type="none" w="med" len="med"/>
+                      <a:tailEnd type="none" w="med" len="med"/>
+                    </a:lnB>
+                    <a:solidFill>
+                      <a:srgbClr val="FFFFFF"/>
+                    </a:solidFill>
+                  </a:tcPr>
+                </a:tc>
+                <a:tc>
+                  <a:txBody>
+                    <a:bodyPr/>
+                    <a:lstStyle/>
+                    <a:p>
+                      <a:pPr algn="l" indent="0" marL="0">
+                        <a:buNone/>
+                      </a:pPr>
+                      <a:r>
+                        <a:rPr lang="en-US" sz="1200" dirty="0">
+                          <a:solidFill>
+                            <a:srgbClr val="212121"/>
+                          </a:solidFill>
+                          <a:latin typeface="Calibri" pitchFamily="34" charset="0"/>
+                          <a:ea typeface="Calibri" pitchFamily="34" charset="-122"/>
+                          <a:cs typeface="Calibri" pitchFamily="34" charset="-120"/>
+                        </a:rPr>
+                        <a:t>bpar (parallel Copland term) </a:t>
+                      </a:r>
+                      <a:pPr algn="l" indent="0" marL="0">
+                        <a:buNone/>
+                      </a:pPr>
+                      <a:r>
+                        <a:rPr lang="en-US" sz="1200" i="1" dirty="0">
+                          <a:solidFill>
+                            <a:srgbClr val="212121"/>
+                          </a:solidFill>
+                          <a:latin typeface="Calibri" pitchFamily="34" charset="0"/>
+                          <a:ea typeface="Calibri" pitchFamily="34" charset="-122"/>
+                          <a:cs typeface="Calibri" pitchFamily="34" charset="-120"/>
+                        </a:rPr>
+                        <a:t>in the verified CVM</a:t>
+                      </a:r>
+                      <a:pPr algn="l" indent="0" marL="0">
+                        <a:buNone/>
+                      </a:pPr>
+                      <a:r>
+                        <a:rPr lang="en-US" sz="1200" dirty="0">
+                          <a:solidFill>
+                            <a:srgbClr val="212121"/>
+                          </a:solidFill>
+                          <a:latin typeface="Calibri" pitchFamily="34" charset="0"/>
+                          <a:ea typeface="Calibri" pitchFamily="34" charset="-122"/>
+                          <a:cs typeface="Calibri" pitchFamily="34" charset="-120"/>
+                        </a:rPr>
+                        <a:t>; --stdin / --req_file frontend fixes</a:t>
+                      </a:r>
+                      <a:endParaRPr lang="en-US" sz="1200" dirty="0">
+                        <a:latin typeface="Calibri" charset="0"/>
+                        <a:ea typeface="Calibri" charset="0"/>
+                        <a:cs typeface="Calibri" charset="0"/>
+                      </a:endParaRPr>
+                    </a:p>
+                  </a:txBody>
+                  <a:tcPr marL="82296" marR="82296" marT="82296" marB="82296" anchor="ctr">
+                    <a:lnL w="12700" cap="flat" cmpd="sng" algn="ctr">
+                      <a:solidFill>
+                        <a:srgbClr val="D8DEEA"/>
+                      </a:solidFill>
+                      <a:prstDash val="solid"/>
+                      <a:round/>
+                      <a:headEnd type="none" w="med" len="med"/>
+                      <a:tailEnd type="none" w="med" len="med"/>
+                    </a:lnL>
+                    <a:lnR w="12700" cap="flat" cmpd="sng" algn="ctr">
+                      <a:solidFill>
+                        <a:srgbClr val="D8DEEA"/>
+                      </a:solidFill>
+                      <a:prstDash val="solid"/>
+                      <a:round/>
+                      <a:headEnd type="none" w="med" len="med"/>
+                      <a:tailEnd type="none" w="med" len="med"/>
+                    </a:lnR>
+                    <a:lnT w="12700" cap="flat" cmpd="sng" algn="ctr">
+                      <a:solidFill>
+                        <a:srgbClr val="D8DEEA"/>
+                      </a:solidFill>
+                      <a:prstDash val="solid"/>
+                      <a:round/>
+                      <a:headEnd type="none" w="med" len="med"/>
+                      <a:tailEnd type="none" w="med" len="med"/>
+                    </a:lnT>
+                    <a:lnB w="12700" cap="flat" cmpd="sng" algn="ctr">
+                      <a:solidFill>
+                        <a:srgbClr val="D8DEEA"/>
+                      </a:solidFill>
+                      <a:prstDash val="solid"/>
+                      <a:round/>
+                      <a:headEnd type="none" w="med" len="med"/>
+                      <a:tailEnd type="none" w="med" len="med"/>
+                    </a:lnB>
+                    <a:solidFill>
+                      <a:srgbClr val="FFFFFF"/>
+                    </a:solidFill>
+                  </a:tcPr>
+                </a:tc>
+                <a:tc>
+                  <a:txBody>
+                    <a:bodyPr/>
+                    <a:lstStyle/>
+                    <a:p>
+                      <a:pPr algn="l" indent="0" marL="0">
+                        <a:buNone/>
+                      </a:pPr>
+                      <a:r>
+                        <a:rPr lang="en-US" sz="1200" b="1" dirty="0">
+                          <a:solidFill>
+                            <a:srgbClr val="212121"/>
+                          </a:solidFill>
+                          <a:latin typeface="Calibri" pitchFamily="34" charset="0"/>
+                          <a:ea typeface="Calibri" pitchFamily="34" charset="-122"/>
+                          <a:cs typeface="Calibri" pitchFamily="34" charset="-120"/>
+                        </a:rPr>
+                        <a:t>Rocq proofs w.r.t. CVM reference semantics --</a:t>
+                      </a:r>
+                      <a:pPr algn="l" indent="0" marL="0">
+                        <a:buNone/>
+                      </a:pPr>
+                      <a:r>
+                        <a:rPr lang="en-US" sz="1200" dirty="0">
+                          <a:solidFill>
+                            <a:srgbClr val="212121"/>
+                          </a:solidFill>
+                          <a:latin typeface="Calibri" pitchFamily="34" charset="0"/>
+                          <a:ea typeface="Calibri" pitchFamily="34" charset="-122"/>
+                          <a:cs typeface="Calibri" pitchFamily="34" charset="-120"/>
+                        </a:rPr>
+                        <a:t>Claude couldn’t update existing proofs automatically, but assisted an expert Rocq developer</a:t>
+                      </a:r>
+                      <a:endParaRPr lang="en-US" sz="1200" dirty="0">
+                        <a:latin typeface="Calibri" charset="0"/>
+                        <a:ea typeface="Calibri" charset="0"/>
+                        <a:cs typeface="Calibri" charset="0"/>
+                      </a:endParaRPr>
+                    </a:p>
+                  </a:txBody>
+                  <a:tcPr marL="82296" marR="82296" marT="82296" marB="82296" anchor="ctr">
+                    <a:lnL w="12700" cap="flat" cmpd="sng" algn="ctr">
+                      <a:solidFill>
+                        <a:srgbClr val="D8DEEA"/>
+                      </a:solidFill>
+                      <a:prstDash val="solid"/>
+                      <a:round/>
+                      <a:headEnd type="none" w="med" len="med"/>
+                      <a:tailEnd type="none" w="med" len="med"/>
+                    </a:lnL>
+                    <a:lnR w="12700" cap="flat" cmpd="sng" algn="ctr">
+                      <a:solidFill>
+                        <a:srgbClr val="D8DEEA"/>
+                      </a:solidFill>
+                      <a:prstDash val="solid"/>
+                      <a:round/>
+                      <a:headEnd type="none" w="med" len="med"/>
+                      <a:tailEnd type="none" w="med" len="med"/>
+                    </a:lnR>
+                    <a:lnT w="12700" cap="flat" cmpd="sng" algn="ctr">
+                      <a:solidFill>
+                        <a:srgbClr val="D8DEEA"/>
+                      </a:solidFill>
+                      <a:prstDash val="solid"/>
+                      <a:round/>
+                      <a:headEnd type="none" w="med" len="med"/>
+                      <a:tailEnd type="none" w="med" len="med"/>
+                    </a:lnT>
+                    <a:lnB w="12700" cap="flat" cmpd="sng" algn="ctr">
+                      <a:solidFill>
+                        <a:srgbClr val="D8DEEA"/>
+                      </a:solidFill>
+                      <a:prstDash val="solid"/>
+                      <a:round/>
+                      <a:headEnd type="none" w="med" len="med"/>
+                      <a:tailEnd type="none" w="med" len="med"/>
+                    </a:lnB>
+                    <a:solidFill>
+                      <a:srgbClr val="FFFFFF"/>
+                    </a:solidFill>
+                  </a:tcPr>
+                </a:tc>
+              </a:tr>
+              <a:tr h="841248">
+                <a:tc>
+                  <a:txBody>
+                    <a:bodyPr/>
+                    <a:lstStyle/>
+                    <a:p>
+                      <a:pPr algn="l" indent="0" marL="0">
+                        <a:buNone/>
+                      </a:pPr>
+                      <a:r>
+                        <a:rPr lang="en-US" sz="1200" b="1" dirty="0">
+                          <a:solidFill>
+                            <a:srgbClr val="212121"/>
+                          </a:solidFill>
+                          <a:latin typeface="Calibri" pitchFamily="34" charset="0"/>
+                          <a:ea typeface="Calibri" pitchFamily="34" charset="-122"/>
+                          <a:cs typeface="Calibri" pitchFamily="34" charset="-120"/>
+                        </a:rPr>
+                        <a:t>Measurement primitives</a:t>
+                      </a:r>
+                      <a:endParaRPr lang="en-US" sz="1200" dirty="0">
+                        <a:latin typeface="Calibri" charset="0"/>
+                        <a:ea typeface="Calibri" charset="0"/>
+                        <a:cs typeface="Calibri" charset="0"/>
+                      </a:endParaRPr>
+                    </a:p>
+                  </a:txBody>
+                  <a:tcPr marL="82296" marR="82296" marT="82296" marB="82296" anchor="ctr">
+                    <a:lnL w="12700" cap="flat" cmpd="sng" algn="ctr">
+                      <a:solidFill>
+                        <a:srgbClr val="D8DEEA"/>
+                      </a:solidFill>
+                      <a:prstDash val="solid"/>
+                      <a:round/>
+                      <a:headEnd type="none" w="med" len="med"/>
+                      <a:tailEnd type="none" w="med" len="med"/>
+                    </a:lnL>
+                    <a:lnR w="12700" cap="flat" cmpd="sng" algn="ctr">
+                      <a:solidFill>
+                        <a:srgbClr val="D8DEEA"/>
+                      </a:solidFill>
+                      <a:prstDash val="solid"/>
+                      <a:round/>
+                      <a:headEnd type="none" w="med" len="med"/>
+                      <a:tailEnd type="none" w="med" len="med"/>
+                    </a:lnR>
+                    <a:lnT w="12700" cap="flat" cmpd="sng" algn="ctr">
+                      <a:solidFill>
+                        <a:srgbClr val="D8DEEA"/>
+                      </a:solidFill>
+                      <a:prstDash val="solid"/>
+                      <a:round/>
+                      <a:headEnd type="none" w="med" len="med"/>
+                      <a:tailEnd type="none" w="med" len="med"/>
+                    </a:lnT>
+                    <a:lnB w="12700" cap="flat" cmpd="sng" algn="ctr">
+                      <a:solidFill>
+                        <a:srgbClr val="D8DEEA"/>
+                      </a:solidFill>
+                      <a:prstDash val="solid"/>
+                      <a:round/>
+                      <a:headEnd type="none" w="med" len="med"/>
+                      <a:tailEnd type="none" w="med" len="med"/>
+                    </a:lnB>
+                    <a:solidFill>
+                      <a:srgbClr val="FFFFFF"/>
+                    </a:solidFill>
+                  </a:tcPr>
+                </a:tc>
+                <a:tc>
+                  <a:txBody>
+                    <a:bodyPr/>
+                    <a:lstStyle/>
+                    <a:p>
+                      <a:pPr algn="l" indent="0" marL="0">
+                        <a:buNone/>
+                      </a:pPr>
+                      <a:r>
+                        <a:rPr lang="en-US" sz="1200" b="1" dirty="0">
+                          <a:solidFill>
+                            <a:srgbClr val="212121"/>
+                          </a:solidFill>
+                          <a:latin typeface="Calibri" pitchFamily="34" charset="0"/>
+                          <a:ea typeface="Calibri" pitchFamily="34" charset="-122"/>
+                          <a:cs typeface="Calibri" pitchFamily="34" charset="-120"/>
+                        </a:rPr>
+                        <a:t>12 new + 7 upgraded</a:t>
+                      </a:r>
+                      <a:pPr algn="l" indent="0" marL="0">
+                        <a:buNone/>
+                      </a:pPr>
+                      <a:r>
+                        <a:rPr lang="en-US" sz="1200" dirty="0">
+                          <a:solidFill>
+                            <a:srgbClr val="212121"/>
+                          </a:solidFill>
+                          <a:latin typeface="Calibri" pitchFamily="34" charset="0"/>
+                          <a:ea typeface="Calibri" pitchFamily="34" charset="-122"/>
+                          <a:cs typeface="Calibri" pitchFamily="34" charset="-120"/>
+                        </a:rPr>
+                        <a:t> asp-libs binaries — hashing, the Lean/Rocq/HAMR runners &amp; appraisers, the cheat scan, golden-slice extraction</a:t>
+                      </a:r>
+                      <a:endParaRPr lang="en-US" sz="1200" dirty="0">
+                        <a:latin typeface="Calibri" charset="0"/>
+                        <a:ea typeface="Calibri" charset="0"/>
+                        <a:cs typeface="Calibri" charset="0"/>
+                      </a:endParaRPr>
+                    </a:p>
+                  </a:txBody>
+                  <a:tcPr marL="82296" marR="82296" marT="82296" marB="82296" anchor="ctr">
+                    <a:lnL w="12700" cap="flat" cmpd="sng" algn="ctr">
+                      <a:solidFill>
+                        <a:srgbClr val="D8DEEA"/>
+                      </a:solidFill>
+                      <a:prstDash val="solid"/>
+                      <a:round/>
+                      <a:headEnd type="none" w="med" len="med"/>
+                      <a:tailEnd type="none" w="med" len="med"/>
+                    </a:lnL>
+                    <a:lnR w="12700" cap="flat" cmpd="sng" algn="ctr">
+                      <a:solidFill>
+                        <a:srgbClr val="D8DEEA"/>
+                      </a:solidFill>
+                      <a:prstDash val="solid"/>
+                      <a:round/>
+                      <a:headEnd type="none" w="med" len="med"/>
+                      <a:tailEnd type="none" w="med" len="med"/>
+                    </a:lnR>
+                    <a:lnT w="12700" cap="flat" cmpd="sng" algn="ctr">
+                      <a:solidFill>
+                        <a:srgbClr val="D8DEEA"/>
+                      </a:solidFill>
+                      <a:prstDash val="solid"/>
+                      <a:round/>
+                      <a:headEnd type="none" w="med" len="med"/>
+                      <a:tailEnd type="none" w="med" len="med"/>
+                    </a:lnT>
+                    <a:lnB w="12700" cap="flat" cmpd="sng" algn="ctr">
+                      <a:solidFill>
+                        <a:srgbClr val="D8DEEA"/>
+                      </a:solidFill>
+                      <a:prstDash val="solid"/>
+                      <a:round/>
+                      <a:headEnd type="none" w="med" len="med"/>
+                      <a:tailEnd type="none" w="med" len="med"/>
+                    </a:lnB>
+                    <a:solidFill>
+                      <a:srgbClr val="FFFFFF"/>
+                    </a:solidFill>
+                  </a:tcPr>
+                </a:tc>
+                <a:tc>
+                  <a:txBody>
+                    <a:bodyPr/>
+                    <a:lstStyle/>
+                    <a:p>
+                      <a:pPr algn="l" indent="0" marL="0">
+                        <a:buNone/>
+                      </a:pPr>
+                      <a:r>
+                        <a:rPr lang="en-US" sz="1200" dirty="0">
+                          <a:solidFill>
+                            <a:srgbClr val="212121"/>
+                          </a:solidFill>
+                          <a:latin typeface="Calibri" pitchFamily="34" charset="0"/>
+                          <a:ea typeface="Calibri" pitchFamily="34" charset="-122"/>
+                          <a:cs typeface="Calibri" pitchFamily="34" charset="-120"/>
+                        </a:rPr>
+                        <a:t>tool hashes measure-then-use; syntax-guided analysis of source files, appraisal vs signed goldens</a:t>
+                      </a:r>
+                      <a:endParaRPr lang="en-US" sz="1200" dirty="0">
+                        <a:latin typeface="Calibri" charset="0"/>
+                        <a:ea typeface="Calibri" charset="0"/>
+                        <a:cs typeface="Calibri" charset="0"/>
+                      </a:endParaRPr>
+                    </a:p>
+                  </a:txBody>
+                  <a:tcPr marL="82296" marR="82296" marT="82296" marB="82296" anchor="ctr">
+                    <a:lnL w="12700" cap="flat" cmpd="sng" algn="ctr">
+                      <a:solidFill>
+                        <a:srgbClr val="D8DEEA"/>
+                      </a:solidFill>
+                      <a:prstDash val="solid"/>
+                      <a:round/>
+                      <a:headEnd type="none" w="med" len="med"/>
+                      <a:tailEnd type="none" w="med" len="med"/>
+                    </a:lnL>
+                    <a:lnR w="12700" cap="flat" cmpd="sng" algn="ctr">
+                      <a:solidFill>
+                        <a:srgbClr val="D8DEEA"/>
+                      </a:solidFill>
+                      <a:prstDash val="solid"/>
+                      <a:round/>
+                      <a:headEnd type="none" w="med" len="med"/>
+                      <a:tailEnd type="none" w="med" len="med"/>
+                    </a:lnR>
+                    <a:lnT w="12700" cap="flat" cmpd="sng" algn="ctr">
+                      <a:solidFill>
+                        <a:srgbClr val="D8DEEA"/>
+                      </a:solidFill>
+                      <a:prstDash val="solid"/>
+                      <a:round/>
+                      <a:headEnd type="none" w="med" len="med"/>
+                      <a:tailEnd type="none" w="med" len="med"/>
+                    </a:lnT>
+                    <a:lnB w="12700" cap="flat" cmpd="sng" algn="ctr">
+                      <a:solidFill>
+                        <a:srgbClr val="D8DEEA"/>
+                      </a:solidFill>
+                      <a:prstDash val="solid"/>
+                      <a:round/>
+                      <a:headEnd type="none" w="med" len="med"/>
+                      <a:tailEnd type="none" w="med" len="med"/>
+                    </a:lnB>
+                    <a:solidFill>
+                      <a:srgbClr val="FFFFFF"/>
+                    </a:solidFill>
+                  </a:tcPr>
+                </a:tc>
+              </a:tr>
+              <a:tr h="566928">
+                <a:tc>
+                  <a:txBody>
+                    <a:bodyPr/>
+                    <a:lstStyle/>
+                    <a:p>
+                      <a:pPr algn="l" indent="0" marL="0">
+                        <a:buNone/>
+                      </a:pPr>
+                      <a:r>
+                        <a:rPr lang="en-US" sz="1200" b="1" dirty="0">
+                          <a:solidFill>
+                            <a:srgbClr val="212121"/>
+                          </a:solidFill>
+                          <a:latin typeface="Calibri" pitchFamily="34" charset="0"/>
+                          <a:ea typeface="Calibri" pitchFamily="34" charset="-122"/>
+                          <a:cs typeface="Calibri" pitchFamily="34" charset="-120"/>
+                        </a:rPr>
+                        <a:t>Attestation protocols</a:t>
+                      </a:r>
+                      <a:endParaRPr lang="en-US" sz="1200" dirty="0">
+                        <a:latin typeface="Calibri" charset="0"/>
+                        <a:ea typeface="Calibri" charset="0"/>
+                        <a:cs typeface="Calibri" charset="0"/>
+                      </a:endParaRPr>
+                    </a:p>
+                  </a:txBody>
+                  <a:tcPr marL="82296" marR="82296" marT="82296" marB="82296" anchor="ctr">
+                    <a:lnL w="12700" cap="flat" cmpd="sng" algn="ctr">
+                      <a:solidFill>
+                        <a:srgbClr val="D8DEEA"/>
+                      </a:solidFill>
+                      <a:prstDash val="solid"/>
+                      <a:round/>
+                      <a:headEnd type="none" w="med" len="med"/>
+                      <a:tailEnd type="none" w="med" len="med"/>
+                    </a:lnL>
+                    <a:lnR w="12700" cap="flat" cmpd="sng" algn="ctr">
+                      <a:solidFill>
+                        <a:srgbClr val="D8DEEA"/>
+                      </a:solidFill>
+                      <a:prstDash val="solid"/>
+                      <a:round/>
+                      <a:headEnd type="none" w="med" len="med"/>
+                      <a:tailEnd type="none" w="med" len="med"/>
+                    </a:lnR>
+                    <a:lnT w="12700" cap="flat" cmpd="sng" algn="ctr">
+                      <a:solidFill>
+                        <a:srgbClr val="D8DEEA"/>
+                      </a:solidFill>
+                      <a:prstDash val="solid"/>
+                      <a:round/>
+                      <a:headEnd type="none" w="med" len="med"/>
+                      <a:tailEnd type="none" w="med" len="med"/>
+                    </a:lnT>
+                    <a:lnB w="12700" cap="flat" cmpd="sng" algn="ctr">
+                      <a:solidFill>
+                        <a:srgbClr val="D8DEEA"/>
+                      </a:solidFill>
+                      <a:prstDash val="solid"/>
+                      <a:round/>
+                      <a:headEnd type="none" w="med" len="med"/>
+                      <a:tailEnd type="none" w="med" len="med"/>
+                    </a:lnB>
+                    <a:solidFill>
+                      <a:srgbClr val="FFFFFF"/>
+                    </a:solidFill>
+                  </a:tcPr>
+                </a:tc>
+                <a:tc>
+                  <a:txBody>
+                    <a:bodyPr/>
+                    <a:lstStyle/>
+                    <a:p>
+                      <a:pPr algn="l" indent="0" marL="0">
+                        <a:buNone/>
+                      </a:pPr>
+                      <a:r>
+                        <a:rPr lang="en-US" sz="1200" b="1" dirty="0">
+                          <a:solidFill>
+                            <a:srgbClr val="212121"/>
+                          </a:solidFill>
+                          <a:latin typeface="Calibri" pitchFamily="34" charset="0"/>
+                          <a:ea typeface="Calibri" pitchFamily="34" charset="-122"/>
+                          <a:cs typeface="Calibri" pitchFamily="34" charset="-120"/>
+                        </a:rPr>
+                        <a:t>42 provisioned</a:t>
+                      </a:r>
+                      <a:pPr algn="l" indent="0" marL="0">
+                        <a:buNone/>
+                      </a:pPr>
+                      <a:r>
+                        <a:rPr lang="en-US" sz="1200" dirty="0">
+                          <a:solidFill>
+                            <a:srgbClr val="212121"/>
+                          </a:solidFill>
+                          <a:latin typeface="Calibri" pitchFamily="34" charset="0"/>
+                          <a:ea typeface="Calibri" pitchFamily="34" charset="-122"/>
+                          <a:cs typeface="Calibri" pitchFamily="34" charset="-120"/>
+                        </a:rPr>
+                        <a:t> Copland protocol directories across the ecosystems</a:t>
+                      </a:r>
+                      <a:endParaRPr lang="en-US" sz="1200" dirty="0">
+                        <a:latin typeface="Calibri" charset="0"/>
+                        <a:ea typeface="Calibri" charset="0"/>
+                        <a:cs typeface="Calibri" charset="0"/>
+                      </a:endParaRPr>
+                    </a:p>
+                  </a:txBody>
+                  <a:tcPr marL="82296" marR="82296" marT="82296" marB="82296" anchor="ctr">
+                    <a:lnL w="12700" cap="flat" cmpd="sng" algn="ctr">
+                      <a:solidFill>
+                        <a:srgbClr val="D8DEEA"/>
+                      </a:solidFill>
+                      <a:prstDash val="solid"/>
+                      <a:round/>
+                      <a:headEnd type="none" w="med" len="med"/>
+                      <a:tailEnd type="none" w="med" len="med"/>
+                    </a:lnL>
+                    <a:lnR w="12700" cap="flat" cmpd="sng" algn="ctr">
+                      <a:solidFill>
+                        <a:srgbClr val="D8DEEA"/>
+                      </a:solidFill>
+                      <a:prstDash val="solid"/>
+                      <a:round/>
+                      <a:headEnd type="none" w="med" len="med"/>
+                      <a:tailEnd type="none" w="med" len="med"/>
+                    </a:lnR>
+                    <a:lnT w="12700" cap="flat" cmpd="sng" algn="ctr">
+                      <a:solidFill>
+                        <a:srgbClr val="D8DEEA"/>
+                      </a:solidFill>
+                      <a:prstDash val="solid"/>
+                      <a:round/>
+                      <a:headEnd type="none" w="med" len="med"/>
+                      <a:tailEnd type="none" w="med" len="med"/>
+                    </a:lnT>
+                    <a:lnB w="12700" cap="flat" cmpd="sng" algn="ctr">
+                      <a:solidFill>
+                        <a:srgbClr val="D8DEEA"/>
+                      </a:solidFill>
+                      <a:prstDash val="solid"/>
+                      <a:round/>
+                      <a:headEnd type="none" w="med" len="med"/>
+                      <a:tailEnd type="none" w="med" len="med"/>
+                    </a:lnB>
+                    <a:solidFill>
+                      <a:srgbClr val="FFFFFF"/>
+                    </a:solidFill>
+                  </a:tcPr>
+                </a:tc>
+                <a:tc>
+                  <a:txBody>
+                    <a:bodyPr/>
+                    <a:lstStyle/>
+                    <a:p>
+                      <a:pPr algn="l" indent="0" marL="0">
+                        <a:buNone/>
+                      </a:pPr>
+                      <a:r>
+                        <a:rPr lang="en-US" sz="1200" dirty="0">
+                          <a:solidFill>
+                            <a:srgbClr val="212121"/>
+                          </a:solidFill>
+                          <a:latin typeface="Calibri" pitchFamily="34" charset="0"/>
+                          <a:ea typeface="Calibri" pitchFamily="34" charset="-122"/>
+                          <a:cs typeface="Calibri" pitchFamily="34" charset="-120"/>
+                        </a:rPr>
+                        <a:t>readiness-gate config checks; blessed baselines</a:t>
+                      </a:r>
+                      <a:endParaRPr lang="en-US" sz="1200" dirty="0">
+                        <a:latin typeface="Calibri" charset="0"/>
+                        <a:ea typeface="Calibri" charset="0"/>
+                        <a:cs typeface="Calibri" charset="0"/>
+                      </a:endParaRPr>
+                    </a:p>
+                  </a:txBody>
+                  <a:tcPr marL="82296" marR="82296" marT="82296" marB="82296" anchor="ctr">
+                    <a:lnL w="12700" cap="flat" cmpd="sng" algn="ctr">
+                      <a:solidFill>
+                        <a:srgbClr val="D8DEEA"/>
+                      </a:solidFill>
+                      <a:prstDash val="solid"/>
+                      <a:round/>
+                      <a:headEnd type="none" w="med" len="med"/>
+                      <a:tailEnd type="none" w="med" len="med"/>
+                    </a:lnL>
+                    <a:lnR w="12700" cap="flat" cmpd="sng" algn="ctr">
+                      <a:solidFill>
+                        <a:srgbClr val="D8DEEA"/>
+                      </a:solidFill>
+                      <a:prstDash val="solid"/>
+                      <a:round/>
+                      <a:headEnd type="none" w="med" len="med"/>
+                      <a:tailEnd type="none" w="med" len="med"/>
+                    </a:lnR>
+                    <a:lnT w="12700" cap="flat" cmpd="sng" algn="ctr">
+                      <a:solidFill>
+                        <a:srgbClr val="D8DEEA"/>
+                      </a:solidFill>
+                      <a:prstDash val="solid"/>
+                      <a:round/>
+                      <a:headEnd type="none" w="med" len="med"/>
+                      <a:tailEnd type="none" w="med" len="med"/>
+                    </a:lnT>
+                    <a:lnB w="12700" cap="flat" cmpd="sng" algn="ctr">
+                      <a:solidFill>
+                        <a:srgbClr val="D8DEEA"/>
+                      </a:solidFill>
+                      <a:prstDash val="solid"/>
+                      <a:round/>
+                      <a:headEnd type="none" w="med" len="med"/>
+                      <a:tailEnd type="none" w="med" len="med"/>
+                    </a:lnB>
+                    <a:solidFill>
+                      <a:srgbClr val="FFFFFF"/>
+                    </a:solidFill>
+                  </a:tcPr>
+                </a:tc>
+              </a:tr>
+              <a:tr h="749808">
+                <a:tc>
+                  <a:txBody>
+                    <a:bodyPr/>
+                    <a:lstStyle/>
+                    <a:p>
+                      <a:pPr algn="l" indent="0" marL="0">
+                        <a:buNone/>
+                      </a:pPr>
+                      <a:r>
+                        <a:rPr lang="en-US" sz="1200" b="1" dirty="0">
+                          <a:solidFill>
+                            <a:srgbClr val="212121"/>
+                          </a:solidFill>
+                          <a:latin typeface="Calibri" pitchFamily="34" charset="0"/>
+                          <a:ea typeface="Calibri" pitchFamily="34" charset="-122"/>
+                          <a:cs typeface="Calibri" pitchFamily="34" charset="-120"/>
+                        </a:rPr>
+                        <a:t>Attacks</a:t>
+                      </a:r>
+                      <a:endParaRPr lang="en-US" sz="1200" dirty="0">
+                        <a:latin typeface="Calibri" charset="0"/>
+                        <a:ea typeface="Calibri" charset="0"/>
+                        <a:cs typeface="Calibri" charset="0"/>
+                      </a:endParaRPr>
+                    </a:p>
+                  </a:txBody>
+                  <a:tcPr marL="82296" marR="82296" marT="82296" marB="82296" anchor="ctr">
+                    <a:lnL w="12700" cap="flat" cmpd="sng" algn="ctr">
+                      <a:solidFill>
+                        <a:srgbClr val="D8DEEA"/>
+                      </a:solidFill>
+                      <a:prstDash val="solid"/>
+                      <a:round/>
+                      <a:headEnd type="none" w="med" len="med"/>
+                      <a:tailEnd type="none" w="med" len="med"/>
+                    </a:lnL>
+                    <a:lnR w="12700" cap="flat" cmpd="sng" algn="ctr">
+                      <a:solidFill>
+                        <a:srgbClr val="D8DEEA"/>
+                      </a:solidFill>
+                      <a:prstDash val="solid"/>
+                      <a:round/>
+                      <a:headEnd type="none" w="med" len="med"/>
+                      <a:tailEnd type="none" w="med" len="med"/>
+                    </a:lnR>
+                    <a:lnT w="12700" cap="flat" cmpd="sng" algn="ctr">
+                      <a:solidFill>
+                        <a:srgbClr val="D8DEEA"/>
+                      </a:solidFill>
+                      <a:prstDash val="solid"/>
+                      <a:round/>
+                      <a:headEnd type="none" w="med" len="med"/>
+                      <a:tailEnd type="none" w="med" len="med"/>
+                    </a:lnT>
+                    <a:lnB w="12700" cap="flat" cmpd="sng" algn="ctr">
+                      <a:solidFill>
+                        <a:srgbClr val="D8DEEA"/>
+                      </a:solidFill>
+                      <a:prstDash val="solid"/>
+                      <a:round/>
+                      <a:headEnd type="none" w="med" len="med"/>
+                      <a:tailEnd type="none" w="med" len="med"/>
+                    </a:lnB>
+                    <a:solidFill>
+                      <a:srgbClr val="FFFFFF"/>
+                    </a:solidFill>
+                  </a:tcPr>
+                </a:tc>
+                <a:tc>
+                  <a:txBody>
+                    <a:bodyPr/>
+                    <a:lstStyle/>
+                    <a:p>
+                      <a:pPr algn="l" indent="0" marL="0">
+                        <a:buNone/>
+                      </a:pPr>
+                      <a:r>
+                        <a:rPr lang="en-US" sz="1200" dirty="0">
+                          <a:solidFill>
+                            <a:srgbClr val="212121"/>
+                          </a:solidFill>
+                          <a:latin typeface="Calibri" pitchFamily="34" charset="0"/>
+                          <a:ea typeface="Calibri" pitchFamily="34" charset="-122"/>
+                          <a:cs typeface="Calibri" pitchFamily="34" charset="-120"/>
+                        </a:rPr>
+                        <a:t>scripted demo tampers (scenes 1–8) + </a:t>
+                      </a:r>
+                      <a:pPr algn="l" indent="0" marL="0">
+                        <a:buNone/>
+                      </a:pPr>
+                      <a:r>
+                        <a:rPr lang="en-US" sz="1200" b="1" dirty="0">
+                          <a:solidFill>
+                            <a:srgbClr val="212121"/>
+                          </a:solidFill>
+                          <a:latin typeface="Calibri" pitchFamily="34" charset="0"/>
+                          <a:ea typeface="Calibri" pitchFamily="34" charset="-122"/>
+                          <a:cs typeface="Calibri" pitchFamily="34" charset="-120"/>
+                        </a:rPr>
+                        <a:t>7 red-team attack classes</a:t>
+                      </a:r>
+                      <a:pPr algn="l" indent="0" marL="0">
+                        <a:buNone/>
+                      </a:pPr>
+                      <a:r>
+                        <a:rPr lang="en-US" sz="1200" dirty="0">
+                          <a:solidFill>
+                            <a:srgbClr val="212121"/>
+                          </a:solidFill>
+                          <a:latin typeface="Calibri" pitchFamily="34" charset="0"/>
+                          <a:ea typeface="Calibri" pitchFamily="34" charset="-122"/>
+                          <a:cs typeface="Calibri" pitchFamily="34" charset="-120"/>
+                        </a:rPr>
+                        <a:t> (scenes 9–12, 14)</a:t>
+                      </a:r>
+                      <a:endParaRPr lang="en-US" sz="1200" dirty="0">
+                        <a:latin typeface="Calibri" charset="0"/>
+                        <a:ea typeface="Calibri" charset="0"/>
+                        <a:cs typeface="Calibri" charset="0"/>
+                      </a:endParaRPr>
+                    </a:p>
+                  </a:txBody>
+                  <a:tcPr marL="82296" marR="82296" marT="82296" marB="82296" anchor="ctr">
+                    <a:lnL w="12700" cap="flat" cmpd="sng" algn="ctr">
+                      <a:solidFill>
+                        <a:srgbClr val="D8DEEA"/>
+                      </a:solidFill>
+                      <a:prstDash val="solid"/>
+                      <a:round/>
+                      <a:headEnd type="none" w="med" len="med"/>
+                      <a:tailEnd type="none" w="med" len="med"/>
+                    </a:lnL>
+                    <a:lnR w="12700" cap="flat" cmpd="sng" algn="ctr">
+                      <a:solidFill>
+                        <a:srgbClr val="D8DEEA"/>
+                      </a:solidFill>
+                      <a:prstDash val="solid"/>
+                      <a:round/>
+                      <a:headEnd type="none" w="med" len="med"/>
+                      <a:tailEnd type="none" w="med" len="med"/>
+                    </a:lnR>
+                    <a:lnT w="12700" cap="flat" cmpd="sng" algn="ctr">
+                      <a:solidFill>
+                        <a:srgbClr val="D8DEEA"/>
+                      </a:solidFill>
+                      <a:prstDash val="solid"/>
+                      <a:round/>
+                      <a:headEnd type="none" w="med" len="med"/>
+                      <a:tailEnd type="none" w="med" len="med"/>
+                    </a:lnT>
+                    <a:lnB w="12700" cap="flat" cmpd="sng" algn="ctr">
+                      <a:solidFill>
+                        <a:srgbClr val="D8DEEA"/>
+                      </a:solidFill>
+                      <a:prstDash val="solid"/>
+                      <a:round/>
+                      <a:headEnd type="none" w="med" len="med"/>
+                      <a:tailEnd type="none" w="med" len="med"/>
+                    </a:lnB>
+                    <a:solidFill>
+                      <a:srgbClr val="FFFFFF"/>
+                    </a:solidFill>
+                  </a:tcPr>
+                </a:tc>
+                <a:tc>
+                  <a:txBody>
+                    <a:bodyPr/>
+                    <a:lstStyle/>
+                    <a:p>
+                      <a:pPr algn="l" indent="0" marL="0">
+                        <a:buNone/>
+                      </a:pPr>
+                      <a:r>
+                        <a:rPr lang="en-US" sz="1200" dirty="0">
+                          <a:solidFill>
+                            <a:srgbClr val="212121"/>
+                          </a:solidFill>
+                          <a:latin typeface="Calibri" pitchFamily="34" charset="0"/>
+                          <a:ea typeface="Calibri" pitchFamily="34" charset="-122"/>
+                          <a:cs typeface="Calibri" pitchFamily="34" charset="-120"/>
+                        </a:rPr>
+                        <a:t>every scene gates on detection / attribution; each forced a new tier (</a:t>
+                      </a:r>
+                      <a:pPr algn="l" indent="0" marL="0">
+                        <a:buNone/>
+                      </a:pPr>
+                      <a:r>
+                        <a:rPr lang="en-US" sz="1200" i="1" dirty="0">
+                          <a:solidFill>
+                            <a:srgbClr val="212121"/>
+                          </a:solidFill>
+                          <a:latin typeface="Calibri" pitchFamily="34" charset="0"/>
+                          <a:ea typeface="Calibri" pitchFamily="34" charset="-122"/>
+                          <a:cs typeface="Calibri" pitchFamily="34" charset="-120"/>
+                        </a:rPr>
+                        <a:t>→ next slide</a:t>
+                      </a:r>
+                      <a:pPr algn="l" indent="0" marL="0">
+                        <a:buNone/>
+                      </a:pPr>
+                      <a:r>
+                        <a:rPr lang="en-US" sz="1200" dirty="0">
+                          <a:solidFill>
+                            <a:srgbClr val="212121"/>
+                          </a:solidFill>
+                          <a:latin typeface="Calibri" pitchFamily="34" charset="0"/>
+                          <a:ea typeface="Calibri" pitchFamily="34" charset="-122"/>
+                          <a:cs typeface="Calibri" pitchFamily="34" charset="-120"/>
+                        </a:rPr>
+                        <a:t>)</a:t>
+                      </a:r>
+                      <a:endParaRPr lang="en-US" sz="1200" dirty="0">
+                        <a:latin typeface="Calibri" charset="0"/>
+                        <a:ea typeface="Calibri" charset="0"/>
+                        <a:cs typeface="Calibri" charset="0"/>
+                      </a:endParaRPr>
+                    </a:p>
+                  </a:txBody>
+                  <a:tcPr marL="82296" marR="82296" marT="82296" marB="82296" anchor="ctr">
+                    <a:lnL w="12700" cap="flat" cmpd="sng" algn="ctr">
+                      <a:solidFill>
+                        <a:srgbClr val="D8DEEA"/>
+                      </a:solidFill>
+                      <a:prstDash val="solid"/>
+                      <a:round/>
+                      <a:headEnd type="none" w="med" len="med"/>
+                      <a:tailEnd type="none" w="med" len="med"/>
+                    </a:lnL>
+                    <a:lnR w="12700" cap="flat" cmpd="sng" algn="ctr">
+                      <a:solidFill>
+                        <a:srgbClr val="D8DEEA"/>
+                      </a:solidFill>
+                      <a:prstDash val="solid"/>
+                      <a:round/>
+                      <a:headEnd type="none" w="med" len="med"/>
+                      <a:tailEnd type="none" w="med" len="med"/>
+                    </a:lnR>
+                    <a:lnT w="12700" cap="flat" cmpd="sng" algn="ctr">
+                      <a:solidFill>
+                        <a:srgbClr val="D8DEEA"/>
+                      </a:solidFill>
+                      <a:prstDash val="solid"/>
+                      <a:round/>
+                      <a:headEnd type="none" w="med" len="med"/>
+                      <a:tailEnd type="none" w="med" len="med"/>
+                    </a:lnT>
+                    <a:lnB w="12700" cap="flat" cmpd="sng" algn="ctr">
+                      <a:solidFill>
+                        <a:srgbClr val="D8DEEA"/>
+                      </a:solidFill>
+                      <a:prstDash val="solid"/>
+                      <a:round/>
+                      <a:headEnd type="none" w="med" len="med"/>
+                      <a:tailEnd type="none" w="med" len="med"/>
+                    </a:lnB>
+                    <a:solidFill>
+                      <a:srgbClr val="FFFFFF"/>
+                    </a:solidFill>
+                  </a:tcPr>
+                </a:tc>
+              </a:tr>
+            </a:tbl>
+          </a:graphicData>
+        </a:graphic>
+      </p:graphicFrame>
+      <p:sp>
+        <p:nvSpPr>
+          <p:cNvPr id="5" name="Text 2"/>
+          <p:cNvSpPr/>
+          <p:nvPr/>
+        </p:nvSpPr>
+        <p:spPr>
+          <a:xfrm>
+            <a:off x="640080" y="6126480"/>
+            <a:ext cx="10881360" cy="365760"/>
+          </a:xfrm>
+          <a:prstGeom prst="rect">
+            <a:avLst/>
+          </a:prstGeom>
+          <a:noFill/>
+          <a:ln/>
+        </p:spPr>
+        <p:txBody>
+          <a:bodyPr wrap="square" lIns="0" tIns="0" rIns="0" bIns="0" rtlCol="0" anchor="ctr"/>
+          <a:lstStyle/>
+          <a:p>
+            <a:pPr algn="l" indent="0" marL="0">
+              <a:buNone/>
+            </a:pPr>
+            <a:r>
+              <a:rPr lang="en-US" sz="1350" b="1" i="1" dirty="0">
+                <a:solidFill>
+                  <a:srgbClr val="1E2761"/>
+                </a:solidFill>
+                <a:latin typeface="Calibri" pitchFamily="34" charset="0"/>
+                <a:ea typeface="Calibri" pitchFamily="34" charset="-122"/>
+                <a:cs typeface="Calibri" pitchFamily="34" charset="-120"/>
+              </a:rPr>
+              <a:t>A virtuous cycle – </a:t>
+            </a:r>
+            <a:pPr algn="l" indent="0" marL="0">
+              <a:buNone/>
+            </a:pPr>
+            <a:r>
+              <a:rPr lang="en-US" sz="1350" i="1" dirty="0">
+                <a:solidFill>
+                  <a:srgbClr val="1E2761"/>
+                </a:solidFill>
+                <a:latin typeface="Calibri" pitchFamily="34" charset="0"/>
+                <a:ea typeface="Calibri" pitchFamily="34" charset="-122"/>
+                <a:cs typeface="Calibri" pitchFamily="34" charset="-120"/>
+              </a:rPr>
+              <a:t>AI-assisted workflow to add (deterministic) tools and domain-specific measurement capabilities.  </a:t>
+            </a:r>
+            <a:endParaRPr lang="en-US" sz="1350" dirty="0"/>
+          </a:p>
+        </p:txBody>
+      </p:sp>
+    </p:spTree>
+  </p:cSld>
+  <p:clrMapOvr>
+    <a:masterClrMapping/>
+  </p:clrMapOvr>
+</p:sld>
+</file>
+
+<file path=ppt/slides/slide19.xml><?xml version="1.0" encoding="utf-8"?>
+<p:sld xmlns:a="http://schemas.openxmlformats.org/drawingml/2006/main" xmlns:r="http://schemas.openxmlformats.org/officeDocument/2006/relationships" xmlns:p="http://schemas.openxmlformats.org/presentationml/2006/main">
+  <p:cSld name="Slide 19">
     <p:bg>
       <p:bgPr>
         <a:solidFill>

</xml_diff>

<commit_message>
capstone C: "AI attacked the loop" + verb-emphasis on all three titles
Third AI capstone (deck 19): the 7-attack table (Attack / avoided
detection by / new measurement forced), LAUNDER highlighted as the
reflexive this-session attack, adversarial-co-development footer.
Includes the user's manual edits (ported verbatim; slides match):
verb italicized in all three capstone titles (AI *in* / *built* /
*attacked* the loop), C's caption ("seven attack types, each
undetected at discovery time") and footer ("defense-in-depth, anomaly
detection, mitigation").

Co-Authored-By: Claude Fable 5 <noreply@anthropic.com>
</commit_message>
<xml_diff>
--- a/docs/video_slides_draft.pptx
+++ b/docs/video_slides_draft.pptx
@@ -24,9 +24,10 @@
     <p:sldId id="272" r:id="rId18"/>
     <p:sldId id="273" r:id="rId19"/>
     <p:sldId id="274" r:id="rId20"/>
+    <p:sldId id="275" r:id="rId21"/>
   </p:sldIdLst>
   <p:notesMasterIdLst>
-    <p:notesMasterId r:id="rId21"/>
+    <p:notesMasterId r:id="rId22"/>
   </p:notesMasterIdLst>
   <p:sldSz cx="12192000" cy="6858000"/>
   <p:notesSz cx="6858000" cy="12192000"/>
@@ -1412,8 +1413,11 @@
           <a:p>
             <a:r>
               <a:rPr lang="en-US" dirty="0"/>
-              <a:t>Collection point for every reference in the deck - keep this slide current as sections are added (isolette slide carries the K-State + AR-08-32 citations inline; Copland/Verus/seL4 seeded here ahead of their sections).
-DOIs on record in docs/video_slide_drafts.md.</a:t>
+              <a:t>Capstone slide 3 of 3 (title 'AI attacked the loop'). The same sessions red-teamed the stack they built; every attack was green across every EXISTING tier when found, and each forced a new measurement capability - defense-in-depth measured into existence.
+7 attacks -&gt; 4 measurement capabilities: cheat scan (ADMIT, SMUGGLE), sysproof file hashes (SHRINK, SWAP), gensrc measurement (STALE, INVERT), and the l1b marker tier + coverage lint (LAUNDER, highlighted - found this session).
+STALE vs INVERT are two different blind spots of 'verification succeeded': STALE = a stale cached verdict (verified over old bytes); INVERT = unverified code out of the proof's scope. Same detector (gensrc bytes), different evasion.
+LAUNDER is the reflexive one: it exposed a COVERAGE gap in the measurement itself (the report emits no compute_cases slice), so it forced a detector PLUS a provisioning invariant. Root cause is upstream (HAMR report emission) - see draft_hamr_report_contract_coverage.md.
+Speaker: the escalating lesson of 9-&gt;12 is that 'verification succeeded' and 'no cheats present' are both weaker claims than 'these are the blessed bytes.'</a:t>
             </a:r>
             <a:endParaRPr lang="en-US" dirty="0"/>
           </a:p>
@@ -1528,6 +1532,95 @@
             <a:fld id="{F7021451-1387-4CA6-816F-3879F97B5CBC}" type="slidenum">
               <a:rPr lang="en-US"/>
               <a:t>2</a:t>
+            </a:fld>
+            <a:endParaRPr lang="en-US"/>
+          </a:p>
+        </p:txBody>
+      </p:sp>
+    </p:spTree>
+    <p:extLst>
+      <p:ext uri="{BB962C8B-B14F-4D97-AF65-F5344CB8AC3E}">
+        <p14:creationId xmlns:p14="http://schemas.microsoft.com/office/powerpoint/2010/main" val="1024086991"/>
+      </p:ext>
+    </p:extLst>
+  </p:cSld>
+  <p:clrMapOvr>
+    <a:masterClrMapping/>
+  </p:clrMapOvr>
+</p:notes>
+</file>
+
+<file path=ppt/notesSlides/notesSlide20.xml><?xml version="1.0" encoding="utf-8"?>
+<p:notes xmlns:a="http://schemas.openxmlformats.org/drawingml/2006/main" xmlns:r="http://schemas.openxmlformats.org/officeDocument/2006/relationships" xmlns:p="http://schemas.openxmlformats.org/presentationml/2006/main">
+  <p:cSld>
+    <p:spTree>
+      <p:nvGrpSpPr>
+        <p:cNvPr id="1" name=""/>
+        <p:cNvGrpSpPr/>
+        <p:nvPr/>
+      </p:nvGrpSpPr>
+      <p:grpSpPr>
+        <a:xfrm>
+          <a:off x="0" y="0"/>
+          <a:ext cx="0" cy="0"/>
+          <a:chOff x="0" y="0"/>
+          <a:chExt cx="0" cy="0"/>
+        </a:xfrm>
+      </p:grpSpPr>
+      <p:sp>
+        <p:nvSpPr>
+          <p:cNvPr id="2" name="Slide Image Placeholder 1"/>
+          <p:cNvSpPr>
+            <a:spLocks noGrp="1" noRot="1" noChangeAspect="1"/>
+          </p:cNvSpPr>
+          <p:nvPr>
+            <p:ph type="sldImg"/>
+          </p:nvPr>
+        </p:nvSpPr>
+        <p:spPr/>
+      </p:sp>
+      <p:sp>
+        <p:nvSpPr>
+          <p:cNvPr id="3" name="Notes Placeholder 2"/>
+          <p:cNvSpPr>
+            <a:spLocks noGrp="1"/>
+          </p:cNvSpPr>
+          <p:nvPr>
+            <p:ph type="body" idx="1"/>
+          </p:nvPr>
+        </p:nvSpPr>
+        <p:spPr/>
+        <p:txBody>
+          <a:bodyPr/>
+          <a:lstStyle/>
+          <a:p>
+            <a:r>
+              <a:rPr lang="en-US" dirty="0"/>
+              <a:t>Collection point for every reference in the deck - keep this slide current as sections are added (isolette slide carries the K-State + AR-08-32 citations inline; Copland/Verus/seL4 seeded here ahead of their sections).
+DOIs on record in docs/video_slide_drafts.md.</a:t>
+            </a:r>
+            <a:endParaRPr lang="en-US" dirty="0"/>
+          </a:p>
+        </p:txBody>
+      </p:sp>
+      <p:sp>
+        <p:nvSpPr>
+          <p:cNvPr id="4" name="Slide Number Placeholder 3"/>
+          <p:cNvSpPr>
+            <a:spLocks noGrp="1"/>
+          </p:cNvSpPr>
+          <p:nvPr>
+            <p:ph type="sldNum" sz="quarter" idx="10"/>
+          </p:nvPr>
+        </p:nvSpPr>
+        <p:spPr/>
+        <p:txBody>
+          <a:bodyPr/>
+          <a:lstStyle/>
+          <a:p>
+            <a:fld id="{F7021451-1387-4CA6-816F-3879F97B5CBC}" type="slidenum">
+              <a:rPr lang="en-US"/>
+              <a:t>20</a:t>
             </a:fld>
             <a:endParaRPr lang="en-US"/>
           </a:p>
@@ -7027,7 +7120,35 @@
                 <a:ea typeface="Cambria" pitchFamily="34" charset="-122"/>
                 <a:cs typeface="Cambria" pitchFamily="34" charset="-120"/>
               </a:rPr>
-              <a:t>AI in the loop</a:t>
+              <a:t>AI </a:t>
+            </a:r>
+            <a:pPr indent="0" marL="0">
+              <a:buNone/>
+            </a:pPr>
+            <a:r>
+              <a:rPr lang="en-US" sz="4000" b="1" i="1" dirty="0">
+                <a:solidFill>
+                  <a:srgbClr val="1E2761"/>
+                </a:solidFill>
+                <a:latin typeface="Cambria" pitchFamily="34" charset="0"/>
+                <a:ea typeface="Cambria" pitchFamily="34" charset="-122"/>
+                <a:cs typeface="Cambria" pitchFamily="34" charset="-120"/>
+              </a:rPr>
+              <a:t>in</a:t>
+            </a:r>
+            <a:pPr indent="0" marL="0">
+              <a:buNone/>
+            </a:pPr>
+            <a:r>
+              <a:rPr lang="en-US" sz="4000" b="1" dirty="0">
+                <a:solidFill>
+                  <a:srgbClr val="1E2761"/>
+                </a:solidFill>
+                <a:latin typeface="Cambria" pitchFamily="34" charset="0"/>
+                <a:ea typeface="Cambria" pitchFamily="34" charset="-122"/>
+                <a:cs typeface="Cambria" pitchFamily="34" charset="-120"/>
+              </a:rPr>
+              <a:t> the loop</a:t>
             </a:r>
             <a:endParaRPr lang="en-US" sz="4000" dirty="0"/>
           </a:p>
@@ -8485,7 +8606,35 @@
                 <a:ea typeface="Cambria" pitchFamily="34" charset="-122"/>
                 <a:cs typeface="Cambria" pitchFamily="34" charset="-120"/>
               </a:rPr>
-              <a:t>AI built the loop</a:t>
+              <a:t>AI </a:t>
+            </a:r>
+            <a:pPr indent="0" marL="0">
+              <a:buNone/>
+            </a:pPr>
+            <a:r>
+              <a:rPr lang="en-US" sz="4000" b="1" i="1" dirty="0">
+                <a:solidFill>
+                  <a:srgbClr val="1E2761"/>
+                </a:solidFill>
+                <a:latin typeface="Cambria" pitchFamily="34" charset="0"/>
+                <a:ea typeface="Cambria" pitchFamily="34" charset="-122"/>
+                <a:cs typeface="Cambria" pitchFamily="34" charset="-120"/>
+              </a:rPr>
+              <a:t>built</a:t>
+            </a:r>
+            <a:pPr indent="0" marL="0">
+              <a:buNone/>
+            </a:pPr>
+            <a:r>
+              <a:rPr lang="en-US" sz="4000" b="1" dirty="0">
+                <a:solidFill>
+                  <a:srgbClr val="1E2761"/>
+                </a:solidFill>
+                <a:latin typeface="Cambria" pitchFamily="34" charset="0"/>
+                <a:ea typeface="Cambria" pitchFamily="34" charset="-122"/>
+                <a:cs typeface="Cambria" pitchFamily="34" charset="-120"/>
+              </a:rPr>
+              <a:t> the loop</a:t>
             </a:r>
             <a:endParaRPr lang="en-US" sz="4000" dirty="0"/>
           </a:p>
@@ -10005,8 +10154,8 @@
         </p:nvSpPr>
         <p:spPr>
           <a:xfrm>
-            <a:off x="640080" y="411480"/>
-            <a:ext cx="10972800" cy="731520"/>
+            <a:off x="640080" y="347472"/>
+            <a:ext cx="10972800" cy="640080"/>
           </a:xfrm>
           <a:prstGeom prst="rect">
             <a:avLst/>
@@ -10022,7 +10171,7 @@
               <a:buNone/>
             </a:pPr>
             <a:r>
-              <a:rPr lang="en-US" sz="3600" b="1" dirty="0">
+              <a:rPr lang="en-US" sz="4000" b="1" dirty="0">
                 <a:solidFill>
                   <a:srgbClr val="1E2761"/>
                 </a:solidFill>
@@ -10030,9 +10179,37 @@
                 <a:ea typeface="Cambria" pitchFamily="34" charset="-122"/>
                 <a:cs typeface="Cambria" pitchFamily="34" charset="-120"/>
               </a:rPr>
-              <a:t>References</a:t>
-            </a:r>
-            <a:endParaRPr lang="en-US" sz="3600" dirty="0"/>
+              <a:t>AI </a:t>
+            </a:r>
+            <a:pPr indent="0" marL="0">
+              <a:buNone/>
+            </a:pPr>
+            <a:r>
+              <a:rPr lang="en-US" sz="4000" b="1" i="1" dirty="0">
+                <a:solidFill>
+                  <a:srgbClr val="1E2761"/>
+                </a:solidFill>
+                <a:latin typeface="Cambria" pitchFamily="34" charset="0"/>
+                <a:ea typeface="Cambria" pitchFamily="34" charset="-122"/>
+                <a:cs typeface="Cambria" pitchFamily="34" charset="-120"/>
+              </a:rPr>
+              <a:t>attacked</a:t>
+            </a:r>
+            <a:pPr indent="0" marL="0">
+              <a:buNone/>
+            </a:pPr>
+            <a:r>
+              <a:rPr lang="en-US" sz="4000" b="1" dirty="0">
+                <a:solidFill>
+                  <a:srgbClr val="1E2761"/>
+                </a:solidFill>
+                <a:latin typeface="Cambria" pitchFamily="34" charset="0"/>
+                <a:ea typeface="Cambria" pitchFamily="34" charset="-122"/>
+                <a:cs typeface="Cambria" pitchFamily="34" charset="-120"/>
+              </a:rPr>
+              <a:t> the loop</a:t>
+            </a:r>
+            <a:endParaRPr lang="en-US" sz="4000" dirty="0"/>
           </a:p>
         </p:txBody>
       </p:sp>
@@ -10044,8 +10221,8 @@
         </p:nvSpPr>
         <p:spPr>
           <a:xfrm>
-            <a:off x="640080" y="1371600"/>
-            <a:ext cx="10972800" cy="5120640"/>
+            <a:off x="658368" y="1024128"/>
+            <a:ext cx="10972800" cy="411480"/>
           </a:xfrm>
           <a:prstGeom prst="rect">
             <a:avLst/>
@@ -10054,17 +10231,1830 @@
           <a:ln/>
         </p:spPr>
         <p:txBody>
-          <a:bodyPr wrap="square" lIns="0" tIns="0" rIns="0" bIns="0" rtlCol="0" anchor="t"/>
+          <a:bodyPr wrap="square" lIns="0" tIns="0" rIns="0" bIns="0" rtlCol="0" anchor="ctr"/>
+          <a:lstStyle/>
+          <a:p>
+            <a:pPr indent="0" marL="0">
+              <a:buNone/>
+            </a:pPr>
+            <a:r>
+              <a:rPr lang="en-US" sz="1600" i="1" dirty="0">
+                <a:solidFill>
+                  <a:srgbClr val="5A6478"/>
+                </a:solidFill>
+                <a:latin typeface="Calibri" pitchFamily="34" charset="0"/>
+                <a:ea typeface="Calibri" pitchFamily="34" charset="-122"/>
+                <a:cs typeface="Calibri" pitchFamily="34" charset="-120"/>
+              </a:rPr>
+              <a:t>seven attack types, each undetected at discovery time — each forced a new measurement capability</a:t>
+            </a:r>
+            <a:endParaRPr lang="en-US" sz="1600" dirty="0"/>
+          </a:p>
+        </p:txBody>
+      </p:sp>
+      <p:graphicFrame>
+        <p:nvGraphicFramePr>
+          <p:cNvPr id="20" name="Table 0"/>
+          <p:cNvGraphicFramePr>
+            <a:graphicFrameLocks noGrp="1"/>
+          </p:cNvGraphicFramePr>
+          <p:nvPr>
+            <p:extLst>
+              <p:ext uri="{D42A27DB-BD31-4B8C-83A1-F6EECF244321}">
+                <p14:modId xmlns:p14="http://schemas.microsoft.com/office/powerpoint/2010/main" val="1579011935"/>
+              </p:ext>
+            </p:extLst>
+          </p:nvPr>
+        </p:nvGraphicFramePr>
+        <p:xfrm>
+          <a:off x="640080" y="1554480"/>
+          <a:ext cx="10881360" cy="914400"/>
+        </p:xfrm>
+        <a:graphic>
+          <a:graphicData uri="http://schemas.openxmlformats.org/drawingml/2006/table">
+            <a:tbl>
+              <a:tblPr/>
+              <a:tblGrid>
+                <a:gridCol w="3611880"/>
+                <a:gridCol w="4069080"/>
+                <a:gridCol w="3200400"/>
+              </a:tblGrid>
+              <a:tr h="329184">
+                <a:tc>
+                  <a:txBody>
+                    <a:bodyPr/>
+                    <a:lstStyle/>
+                    <a:p>
+                      <a:pPr algn="l" indent="0" marL="0">
+                        <a:buNone/>
+                      </a:pPr>
+                      <a:r>
+                        <a:rPr lang="en-US" sz="1250" b="1" dirty="0">
+                          <a:solidFill>
+                            <a:srgbClr val="FFFFFF"/>
+                          </a:solidFill>
+                          <a:latin typeface="Calibri" pitchFamily="34" charset="0"/>
+                          <a:ea typeface="Calibri" pitchFamily="34" charset="-122"/>
+                          <a:cs typeface="Calibri" pitchFamily="34" charset="-120"/>
+                        </a:rPr>
+                        <a:t>Attack</a:t>
+                      </a:r>
+                      <a:endParaRPr lang="en-US" sz="1250" dirty="0">
+                        <a:latin typeface="Calibri" charset="0"/>
+                        <a:ea typeface="Calibri" charset="0"/>
+                        <a:cs typeface="Calibri" charset="0"/>
+                      </a:endParaRPr>
+                    </a:p>
+                  </a:txBody>
+                  <a:tcPr marL="73152" marR="73152" marT="73152" marB="73152" anchor="ctr">
+                    <a:lnL w="12700" cap="flat" cmpd="sng" algn="ctr">
+                      <a:solidFill>
+                        <a:srgbClr val="D8DEEA"/>
+                      </a:solidFill>
+                      <a:prstDash val="solid"/>
+                      <a:round/>
+                      <a:headEnd type="none" w="med" len="med"/>
+                      <a:tailEnd type="none" w="med" len="med"/>
+                    </a:lnL>
+                    <a:lnR w="12700" cap="flat" cmpd="sng" algn="ctr">
+                      <a:solidFill>
+                        <a:srgbClr val="D8DEEA"/>
+                      </a:solidFill>
+                      <a:prstDash val="solid"/>
+                      <a:round/>
+                      <a:headEnd type="none" w="med" len="med"/>
+                      <a:tailEnd type="none" w="med" len="med"/>
+                    </a:lnR>
+                    <a:lnT w="12700" cap="flat" cmpd="sng" algn="ctr">
+                      <a:solidFill>
+                        <a:srgbClr val="D8DEEA"/>
+                      </a:solidFill>
+                      <a:prstDash val="solid"/>
+                      <a:round/>
+                      <a:headEnd type="none" w="med" len="med"/>
+                      <a:tailEnd type="none" w="med" len="med"/>
+                    </a:lnT>
+                    <a:lnB w="12700" cap="flat" cmpd="sng" algn="ctr">
+                      <a:solidFill>
+                        <a:srgbClr val="D8DEEA"/>
+                      </a:solidFill>
+                      <a:prstDash val="solid"/>
+                      <a:round/>
+                      <a:headEnd type="none" w="med" len="med"/>
+                      <a:tailEnd type="none" w="med" len="med"/>
+                    </a:lnB>
+                    <a:solidFill>
+                      <a:srgbClr val="1E2761"/>
+                    </a:solidFill>
+                  </a:tcPr>
+                </a:tc>
+                <a:tc>
+                  <a:txBody>
+                    <a:bodyPr/>
+                    <a:lstStyle/>
+                    <a:p>
+                      <a:pPr algn="l" indent="0" marL="0">
+                        <a:buNone/>
+                      </a:pPr>
+                      <a:r>
+                        <a:rPr lang="en-US" sz="1250" b="1" dirty="0">
+                          <a:solidFill>
+                            <a:srgbClr val="FFFFFF"/>
+                          </a:solidFill>
+                          <a:latin typeface="Calibri" pitchFamily="34" charset="0"/>
+                          <a:ea typeface="Calibri" pitchFamily="34" charset="-122"/>
+                          <a:cs typeface="Calibri" pitchFamily="34" charset="-120"/>
+                        </a:rPr>
+                        <a:t>Avoided detection by…</a:t>
+                      </a:r>
+                      <a:endParaRPr lang="en-US" sz="1250" dirty="0">
+                        <a:latin typeface="Calibri" charset="0"/>
+                        <a:ea typeface="Calibri" charset="0"/>
+                        <a:cs typeface="Calibri" charset="0"/>
+                      </a:endParaRPr>
+                    </a:p>
+                  </a:txBody>
+                  <a:tcPr marL="73152" marR="73152" marT="73152" marB="73152" anchor="ctr">
+                    <a:lnL w="12700" cap="flat" cmpd="sng" algn="ctr">
+                      <a:solidFill>
+                        <a:srgbClr val="D8DEEA"/>
+                      </a:solidFill>
+                      <a:prstDash val="solid"/>
+                      <a:round/>
+                      <a:headEnd type="none" w="med" len="med"/>
+                      <a:tailEnd type="none" w="med" len="med"/>
+                    </a:lnL>
+                    <a:lnR w="12700" cap="flat" cmpd="sng" algn="ctr">
+                      <a:solidFill>
+                        <a:srgbClr val="D8DEEA"/>
+                      </a:solidFill>
+                      <a:prstDash val="solid"/>
+                      <a:round/>
+                      <a:headEnd type="none" w="med" len="med"/>
+                      <a:tailEnd type="none" w="med" len="med"/>
+                    </a:lnR>
+                    <a:lnT w="12700" cap="flat" cmpd="sng" algn="ctr">
+                      <a:solidFill>
+                        <a:srgbClr val="D8DEEA"/>
+                      </a:solidFill>
+                      <a:prstDash val="solid"/>
+                      <a:round/>
+                      <a:headEnd type="none" w="med" len="med"/>
+                      <a:tailEnd type="none" w="med" len="med"/>
+                    </a:lnT>
+                    <a:lnB w="12700" cap="flat" cmpd="sng" algn="ctr">
+                      <a:solidFill>
+                        <a:srgbClr val="D8DEEA"/>
+                      </a:solidFill>
+                      <a:prstDash val="solid"/>
+                      <a:round/>
+                      <a:headEnd type="none" w="med" len="med"/>
+                      <a:tailEnd type="none" w="med" len="med"/>
+                    </a:lnB>
+                    <a:solidFill>
+                      <a:srgbClr val="1E2761"/>
+                    </a:solidFill>
+                  </a:tcPr>
+                </a:tc>
+                <a:tc>
+                  <a:txBody>
+                    <a:bodyPr/>
+                    <a:lstStyle/>
+                    <a:p>
+                      <a:pPr algn="l" indent="0" marL="0">
+                        <a:buNone/>
+                      </a:pPr>
+                      <a:r>
+                        <a:rPr lang="en-US" sz="1250" b="1" dirty="0">
+                          <a:solidFill>
+                            <a:srgbClr val="FFFFFF"/>
+                          </a:solidFill>
+                          <a:latin typeface="Calibri" pitchFamily="34" charset="0"/>
+                          <a:ea typeface="Calibri" pitchFamily="34" charset="-122"/>
+                          <a:cs typeface="Calibri" pitchFamily="34" charset="-120"/>
+                        </a:rPr>
+                        <a:t>New measurement forced</a:t>
+                      </a:r>
+                      <a:endParaRPr lang="en-US" sz="1250" dirty="0">
+                        <a:latin typeface="Calibri" charset="0"/>
+                        <a:ea typeface="Calibri" charset="0"/>
+                        <a:cs typeface="Calibri" charset="0"/>
+                      </a:endParaRPr>
+                    </a:p>
+                  </a:txBody>
+                  <a:tcPr marL="73152" marR="73152" marT="73152" marB="73152" anchor="ctr">
+                    <a:lnL w="12700" cap="flat" cmpd="sng" algn="ctr">
+                      <a:solidFill>
+                        <a:srgbClr val="D8DEEA"/>
+                      </a:solidFill>
+                      <a:prstDash val="solid"/>
+                      <a:round/>
+                      <a:headEnd type="none" w="med" len="med"/>
+                      <a:tailEnd type="none" w="med" len="med"/>
+                    </a:lnL>
+                    <a:lnR w="12700" cap="flat" cmpd="sng" algn="ctr">
+                      <a:solidFill>
+                        <a:srgbClr val="D8DEEA"/>
+                      </a:solidFill>
+                      <a:prstDash val="solid"/>
+                      <a:round/>
+                      <a:headEnd type="none" w="med" len="med"/>
+                      <a:tailEnd type="none" w="med" len="med"/>
+                    </a:lnR>
+                    <a:lnT w="12700" cap="flat" cmpd="sng" algn="ctr">
+                      <a:solidFill>
+                        <a:srgbClr val="D8DEEA"/>
+                      </a:solidFill>
+                      <a:prstDash val="solid"/>
+                      <a:round/>
+                      <a:headEnd type="none" w="med" len="med"/>
+                      <a:tailEnd type="none" w="med" len="med"/>
+                    </a:lnT>
+                    <a:lnB w="12700" cap="flat" cmpd="sng" algn="ctr">
+                      <a:solidFill>
+                        <a:srgbClr val="D8DEEA"/>
+                      </a:solidFill>
+                      <a:prstDash val="solid"/>
+                      <a:round/>
+                      <a:headEnd type="none" w="med" len="med"/>
+                      <a:tailEnd type="none" w="med" len="med"/>
+                    </a:lnB>
+                    <a:solidFill>
+                      <a:srgbClr val="1E2761"/>
+                    </a:solidFill>
+                  </a:tcPr>
+                </a:tc>
+              </a:tr>
+              <a:tr h="502920">
+                <a:tc>
+                  <a:txBody>
+                    <a:bodyPr/>
+                    <a:lstStyle/>
+                    <a:p>
+                      <a:pPr algn="l" indent="0" marL="0">
+                        <a:buNone/>
+                      </a:pPr>
+                      <a:r>
+                        <a:rPr lang="en-US" sz="1100" b="1" dirty="0">
+                          <a:solidFill>
+                            <a:srgbClr val="212121"/>
+                          </a:solidFill>
+                          <a:latin typeface="Calibri" pitchFamily="34" charset="0"/>
+                          <a:ea typeface="Calibri" pitchFamily="34" charset="-122"/>
+                          <a:cs typeface="Calibri" pitchFamily="34" charset="-120"/>
+                        </a:rPr>
+                        <a:t>ADMIT</a:t>
+                      </a:r>
+                      <a:pPr algn="l" indent="0" marL="0">
+                        <a:buNone/>
+                      </a:pPr>
+                      <a:r>
+                        <a:rPr lang="en-US" sz="1100" dirty="0">
+                          <a:solidFill>
+                            <a:srgbClr val="212121"/>
+                          </a:solidFill>
+                          <a:latin typeface="Calibri" pitchFamily="34" charset="0"/>
+                          <a:ea typeface="Calibri" pitchFamily="34" charset="-122"/>
+                          <a:cs typeface="Calibri" pitchFamily="34" charset="-120"/>
+                        </a:rPr>
+                        <a:t> — assume(false) in an unmeasured bridge file</a:t>
+                      </a:r>
+                      <a:endParaRPr lang="en-US" sz="1100" dirty="0">
+                        <a:latin typeface="Calibri" charset="0"/>
+                        <a:ea typeface="Calibri" charset="0"/>
+                        <a:cs typeface="Calibri" charset="0"/>
+                      </a:endParaRPr>
+                    </a:p>
+                  </a:txBody>
+                  <a:tcPr marL="73152" marR="73152" marT="73152" marB="73152" anchor="ctr">
+                    <a:lnL w="12700" cap="flat" cmpd="sng" algn="ctr">
+                      <a:solidFill>
+                        <a:srgbClr val="D8DEEA"/>
+                      </a:solidFill>
+                      <a:prstDash val="solid"/>
+                      <a:round/>
+                      <a:headEnd type="none" w="med" len="med"/>
+                      <a:tailEnd type="none" w="med" len="med"/>
+                    </a:lnL>
+                    <a:lnR w="12700" cap="flat" cmpd="sng" algn="ctr">
+                      <a:solidFill>
+                        <a:srgbClr val="D8DEEA"/>
+                      </a:solidFill>
+                      <a:prstDash val="solid"/>
+                      <a:round/>
+                      <a:headEnd type="none" w="med" len="med"/>
+                      <a:tailEnd type="none" w="med" len="med"/>
+                    </a:lnR>
+                    <a:lnT w="12700" cap="flat" cmpd="sng" algn="ctr">
+                      <a:solidFill>
+                        <a:srgbClr val="D8DEEA"/>
+                      </a:solidFill>
+                      <a:prstDash val="solid"/>
+                      <a:round/>
+                      <a:headEnd type="none" w="med" len="med"/>
+                      <a:tailEnd type="none" w="med" len="med"/>
+                    </a:lnT>
+                    <a:lnB w="12700" cap="flat" cmpd="sng" algn="ctr">
+                      <a:solidFill>
+                        <a:srgbClr val="D8DEEA"/>
+                      </a:solidFill>
+                      <a:prstDash val="solid"/>
+                      <a:round/>
+                      <a:headEnd type="none" w="med" len="med"/>
+                      <a:tailEnd type="none" w="med" len="med"/>
+                    </a:lnB>
+                    <a:solidFill>
+                      <a:srgbClr val="FFFFFF"/>
+                    </a:solidFill>
+                  </a:tcPr>
+                </a:tc>
+                <a:tc>
+                  <a:txBody>
+                    <a:bodyPr/>
+                    <a:lstStyle/>
+                    <a:p>
+                      <a:pPr algn="l" indent="0" marL="0">
+                        <a:buNone/>
+                      </a:pPr>
+                      <a:r>
+                        <a:rPr lang="en-US" sz="1100" dirty="0">
+                          <a:solidFill>
+                            <a:srgbClr val="212121"/>
+                          </a:solidFill>
+                          <a:latin typeface="Calibri" pitchFamily="34" charset="0"/>
+                          <a:ea typeface="Calibri" pitchFamily="34" charset="-122"/>
+                          <a:cs typeface="Calibri" pitchFamily="34" charset="-120"/>
+                        </a:rPr>
+                        <a:t>cargo-verus reports the same success over the hollow proof</a:t>
+                      </a:r>
+                      <a:endParaRPr lang="en-US" sz="1100" dirty="0">
+                        <a:latin typeface="Calibri" charset="0"/>
+                        <a:ea typeface="Calibri" charset="0"/>
+                        <a:cs typeface="Calibri" charset="0"/>
+                      </a:endParaRPr>
+                    </a:p>
+                  </a:txBody>
+                  <a:tcPr marL="73152" marR="73152" marT="73152" marB="73152" anchor="ctr">
+                    <a:lnL w="12700" cap="flat" cmpd="sng" algn="ctr">
+                      <a:solidFill>
+                        <a:srgbClr val="D8DEEA"/>
+                      </a:solidFill>
+                      <a:prstDash val="solid"/>
+                      <a:round/>
+                      <a:headEnd type="none" w="med" len="med"/>
+                      <a:tailEnd type="none" w="med" len="med"/>
+                    </a:lnL>
+                    <a:lnR w="12700" cap="flat" cmpd="sng" algn="ctr">
+                      <a:solidFill>
+                        <a:srgbClr val="D8DEEA"/>
+                      </a:solidFill>
+                      <a:prstDash val="solid"/>
+                      <a:round/>
+                      <a:headEnd type="none" w="med" len="med"/>
+                      <a:tailEnd type="none" w="med" len="med"/>
+                    </a:lnR>
+                    <a:lnT w="12700" cap="flat" cmpd="sng" algn="ctr">
+                      <a:solidFill>
+                        <a:srgbClr val="D8DEEA"/>
+                      </a:solidFill>
+                      <a:prstDash val="solid"/>
+                      <a:round/>
+                      <a:headEnd type="none" w="med" len="med"/>
+                      <a:tailEnd type="none" w="med" len="med"/>
+                    </a:lnT>
+                    <a:lnB w="12700" cap="flat" cmpd="sng" algn="ctr">
+                      <a:solidFill>
+                        <a:srgbClr val="D8DEEA"/>
+                      </a:solidFill>
+                      <a:prstDash val="solid"/>
+                      <a:round/>
+                      <a:headEnd type="none" w="med" len="med"/>
+                      <a:tailEnd type="none" w="med" len="med"/>
+                    </a:lnB>
+                    <a:solidFill>
+                      <a:srgbClr val="FFFFFF"/>
+                    </a:solidFill>
+                  </a:tcPr>
+                </a:tc>
+                <a:tc>
+                  <a:txBody>
+                    <a:bodyPr/>
+                    <a:lstStyle/>
+                    <a:p>
+                      <a:pPr algn="l" indent="0" marL="0">
+                        <a:buNone/>
+                      </a:pPr>
+                      <a:r>
+                        <a:rPr lang="en-US" sz="1100" dirty="0">
+                          <a:solidFill>
+                            <a:srgbClr val="212121"/>
+                          </a:solidFill>
+                          <a:latin typeface="Calibri" pitchFamily="34" charset="0"/>
+                          <a:ea typeface="Calibri" pitchFamily="34" charset="-122"/>
+                          <a:cs typeface="Calibri" pitchFamily="34" charset="-120"/>
+                        </a:rPr>
+                        <a:t>cheat scan (cheat_scan_verus)</a:t>
+                      </a:r>
+                      <a:endParaRPr lang="en-US" sz="1100" dirty="0">
+                        <a:latin typeface="Calibri" charset="0"/>
+                        <a:ea typeface="Calibri" charset="0"/>
+                        <a:cs typeface="Calibri" charset="0"/>
+                      </a:endParaRPr>
+                    </a:p>
+                  </a:txBody>
+                  <a:tcPr marL="73152" marR="73152" marT="73152" marB="73152" anchor="ctr">
+                    <a:lnL w="12700" cap="flat" cmpd="sng" algn="ctr">
+                      <a:solidFill>
+                        <a:srgbClr val="D8DEEA"/>
+                      </a:solidFill>
+                      <a:prstDash val="solid"/>
+                      <a:round/>
+                      <a:headEnd type="none" w="med" len="med"/>
+                      <a:tailEnd type="none" w="med" len="med"/>
+                    </a:lnL>
+                    <a:lnR w="12700" cap="flat" cmpd="sng" algn="ctr">
+                      <a:solidFill>
+                        <a:srgbClr val="D8DEEA"/>
+                      </a:solidFill>
+                      <a:prstDash val="solid"/>
+                      <a:round/>
+                      <a:headEnd type="none" w="med" len="med"/>
+                      <a:tailEnd type="none" w="med" len="med"/>
+                    </a:lnR>
+                    <a:lnT w="12700" cap="flat" cmpd="sng" algn="ctr">
+                      <a:solidFill>
+                        <a:srgbClr val="D8DEEA"/>
+                      </a:solidFill>
+                      <a:prstDash val="solid"/>
+                      <a:round/>
+                      <a:headEnd type="none" w="med" len="med"/>
+                      <a:tailEnd type="none" w="med" len="med"/>
+                    </a:lnT>
+                    <a:lnB w="12700" cap="flat" cmpd="sng" algn="ctr">
+                      <a:solidFill>
+                        <a:srgbClr val="D8DEEA"/>
+                      </a:solidFill>
+                      <a:prstDash val="solid"/>
+                      <a:round/>
+                      <a:headEnd type="none" w="med" len="med"/>
+                      <a:tailEnd type="none" w="med" len="med"/>
+                    </a:lnB>
+                    <a:solidFill>
+                      <a:srgbClr val="FFFFFF"/>
+                    </a:solidFill>
+                  </a:tcPr>
+                </a:tc>
+              </a:tr>
+              <a:tr h="502920">
+                <a:tc>
+                  <a:txBody>
+                    <a:bodyPr/>
+                    <a:lstStyle/>
+                    <a:p>
+                      <a:pPr algn="l" indent="0" marL="0">
+                        <a:buNone/>
+                      </a:pPr>
+                      <a:r>
+                        <a:rPr lang="en-US" sz="1100" b="1" dirty="0">
+                          <a:solidFill>
+                            <a:srgbClr val="212121"/>
+                          </a:solidFill>
+                          <a:latin typeface="Calibri" pitchFamily="34" charset="0"/>
+                          <a:ea typeface="Calibri" pitchFamily="34" charset="-122"/>
+                          <a:cs typeface="Calibri" pitchFamily="34" charset="-120"/>
+                        </a:rPr>
+                        <a:t>SMUGGLE</a:t>
+                      </a:r>
+                      <a:pPr algn="l" indent="0" marL="0">
+                        <a:buNone/>
+                      </a:pPr>
+                      <a:r>
+                        <a:rPr lang="en-US" sz="1100" dirty="0">
+                          <a:solidFill>
+                            <a:srgbClr val="212121"/>
+                          </a:solidFill>
+                          <a:latin typeface="Calibri" pitchFamily="34" charset="0"/>
+                          <a:ea typeface="Calibri" pitchFamily="34" charset="-122"/>
+                          <a:cs typeface="Calibri" pitchFamily="34" charset="-120"/>
+                        </a:rPr>
+                        <a:t> — external_body broadcast axiom, ensures false</a:t>
+                      </a:r>
+                      <a:endParaRPr lang="en-US" sz="1100" dirty="0">
+                        <a:latin typeface="Calibri" charset="0"/>
+                        <a:ea typeface="Calibri" charset="0"/>
+                        <a:cs typeface="Calibri" charset="0"/>
+                      </a:endParaRPr>
+                    </a:p>
+                  </a:txBody>
+                  <a:tcPr marL="73152" marR="73152" marT="73152" marB="73152" anchor="ctr">
+                    <a:lnL w="12700" cap="flat" cmpd="sng" algn="ctr">
+                      <a:solidFill>
+                        <a:srgbClr val="D8DEEA"/>
+                      </a:solidFill>
+                      <a:prstDash val="solid"/>
+                      <a:round/>
+                      <a:headEnd type="none" w="med" len="med"/>
+                      <a:tailEnd type="none" w="med" len="med"/>
+                    </a:lnL>
+                    <a:lnR w="12700" cap="flat" cmpd="sng" algn="ctr">
+                      <a:solidFill>
+                        <a:srgbClr val="D8DEEA"/>
+                      </a:solidFill>
+                      <a:prstDash val="solid"/>
+                      <a:round/>
+                      <a:headEnd type="none" w="med" len="med"/>
+                      <a:tailEnd type="none" w="med" len="med"/>
+                    </a:lnR>
+                    <a:lnT w="12700" cap="flat" cmpd="sng" algn="ctr">
+                      <a:solidFill>
+                        <a:srgbClr val="D8DEEA"/>
+                      </a:solidFill>
+                      <a:prstDash val="solid"/>
+                      <a:round/>
+                      <a:headEnd type="none" w="med" len="med"/>
+                      <a:tailEnd type="none" w="med" len="med"/>
+                    </a:lnT>
+                    <a:lnB w="12700" cap="flat" cmpd="sng" algn="ctr">
+                      <a:solidFill>
+                        <a:srgbClr val="D8DEEA"/>
+                      </a:solidFill>
+                      <a:prstDash val="solid"/>
+                      <a:round/>
+                      <a:headEnd type="none" w="med" len="med"/>
+                      <a:tailEnd type="none" w="med" len="med"/>
+                    </a:lnB>
+                    <a:solidFill>
+                      <a:srgbClr val="FFFFFF"/>
+                    </a:solidFill>
+                  </a:tcPr>
+                </a:tc>
+                <a:tc>
+                  <a:txBody>
+                    <a:bodyPr/>
+                    <a:lstStyle/>
+                    <a:p>
+                      <a:pPr algn="l" indent="0" marL="0">
+                        <a:buNone/>
+                      </a:pPr>
+                      <a:r>
+                        <a:rPr lang="en-US" sz="1100" dirty="0">
+                          <a:solidFill>
+                            <a:srgbClr val="212121"/>
+                          </a:solidFill>
+                          <a:latin typeface="Calibri" pitchFamily="34" charset="0"/>
+                          <a:ea typeface="Calibri" pitchFamily="34" charset="-122"/>
+                          <a:cs typeface="Calibri" pitchFamily="34" charset="-120"/>
+                        </a:rPr>
+                        <a:t>cargo-verus reports the same success over the hollow proof</a:t>
+                      </a:r>
+                      <a:endParaRPr lang="en-US" sz="1100" dirty="0">
+                        <a:latin typeface="Calibri" charset="0"/>
+                        <a:ea typeface="Calibri" charset="0"/>
+                        <a:cs typeface="Calibri" charset="0"/>
+                      </a:endParaRPr>
+                    </a:p>
+                  </a:txBody>
+                  <a:tcPr marL="73152" marR="73152" marT="73152" marB="73152" anchor="ctr">
+                    <a:lnL w="12700" cap="flat" cmpd="sng" algn="ctr">
+                      <a:solidFill>
+                        <a:srgbClr val="D8DEEA"/>
+                      </a:solidFill>
+                      <a:prstDash val="solid"/>
+                      <a:round/>
+                      <a:headEnd type="none" w="med" len="med"/>
+                      <a:tailEnd type="none" w="med" len="med"/>
+                    </a:lnL>
+                    <a:lnR w="12700" cap="flat" cmpd="sng" algn="ctr">
+                      <a:solidFill>
+                        <a:srgbClr val="D8DEEA"/>
+                      </a:solidFill>
+                      <a:prstDash val="solid"/>
+                      <a:round/>
+                      <a:headEnd type="none" w="med" len="med"/>
+                      <a:tailEnd type="none" w="med" len="med"/>
+                    </a:lnR>
+                    <a:lnT w="12700" cap="flat" cmpd="sng" algn="ctr">
+                      <a:solidFill>
+                        <a:srgbClr val="D8DEEA"/>
+                      </a:solidFill>
+                      <a:prstDash val="solid"/>
+                      <a:round/>
+                      <a:headEnd type="none" w="med" len="med"/>
+                      <a:tailEnd type="none" w="med" len="med"/>
+                    </a:lnT>
+                    <a:lnB w="12700" cap="flat" cmpd="sng" algn="ctr">
+                      <a:solidFill>
+                        <a:srgbClr val="D8DEEA"/>
+                      </a:solidFill>
+                      <a:prstDash val="solid"/>
+                      <a:round/>
+                      <a:headEnd type="none" w="med" len="med"/>
+                      <a:tailEnd type="none" w="med" len="med"/>
+                    </a:lnB>
+                    <a:solidFill>
+                      <a:srgbClr val="FFFFFF"/>
+                    </a:solidFill>
+                  </a:tcPr>
+                </a:tc>
+                <a:tc>
+                  <a:txBody>
+                    <a:bodyPr/>
+                    <a:lstStyle/>
+                    <a:p>
+                      <a:pPr algn="l" indent="0" marL="0">
+                        <a:buNone/>
+                      </a:pPr>
+                      <a:r>
+                        <a:rPr lang="en-US" sz="1100" dirty="0">
+                          <a:solidFill>
+                            <a:srgbClr val="212121"/>
+                          </a:solidFill>
+                          <a:latin typeface="Calibri" pitchFamily="34" charset="0"/>
+                          <a:ea typeface="Calibri" pitchFamily="34" charset="-122"/>
+                          <a:cs typeface="Calibri" pitchFamily="34" charset="-120"/>
+                        </a:rPr>
+                        <a:t>cheat scan (cheat_scan_verus)</a:t>
+                      </a:r>
+                      <a:endParaRPr lang="en-US" sz="1100" dirty="0">
+                        <a:latin typeface="Calibri" charset="0"/>
+                        <a:ea typeface="Calibri" charset="0"/>
+                        <a:cs typeface="Calibri" charset="0"/>
+                      </a:endParaRPr>
+                    </a:p>
+                  </a:txBody>
+                  <a:tcPr marL="73152" marR="73152" marT="73152" marB="73152" anchor="ctr">
+                    <a:lnL w="12700" cap="flat" cmpd="sng" algn="ctr">
+                      <a:solidFill>
+                        <a:srgbClr val="D8DEEA"/>
+                      </a:solidFill>
+                      <a:prstDash val="solid"/>
+                      <a:round/>
+                      <a:headEnd type="none" w="med" len="med"/>
+                      <a:tailEnd type="none" w="med" len="med"/>
+                    </a:lnL>
+                    <a:lnR w="12700" cap="flat" cmpd="sng" algn="ctr">
+                      <a:solidFill>
+                        <a:srgbClr val="D8DEEA"/>
+                      </a:solidFill>
+                      <a:prstDash val="solid"/>
+                      <a:round/>
+                      <a:headEnd type="none" w="med" len="med"/>
+                      <a:tailEnd type="none" w="med" len="med"/>
+                    </a:lnR>
+                    <a:lnT w="12700" cap="flat" cmpd="sng" algn="ctr">
+                      <a:solidFill>
+                        <a:srgbClr val="D8DEEA"/>
+                      </a:solidFill>
+                      <a:prstDash val="solid"/>
+                      <a:round/>
+                      <a:headEnd type="none" w="med" len="med"/>
+                      <a:tailEnd type="none" w="med" len="med"/>
+                    </a:lnT>
+                    <a:lnB w="12700" cap="flat" cmpd="sng" algn="ctr">
+                      <a:solidFill>
+                        <a:srgbClr val="D8DEEA"/>
+                      </a:solidFill>
+                      <a:prstDash val="solid"/>
+                      <a:round/>
+                      <a:headEnd type="none" w="med" len="med"/>
+                      <a:tailEnd type="none" w="med" len="med"/>
+                    </a:lnB>
+                    <a:solidFill>
+                      <a:srgbClr val="FFFFFF"/>
+                    </a:solidFill>
+                  </a:tcPr>
+                </a:tc>
+              </a:tr>
+              <a:tr h="457200">
+                <a:tc>
+                  <a:txBody>
+                    <a:bodyPr/>
+                    <a:lstStyle/>
+                    <a:p>
+                      <a:pPr algn="l" indent="0" marL="0">
+                        <a:buNone/>
+                      </a:pPr>
+                      <a:r>
+                        <a:rPr lang="en-US" sz="1100" b="1" dirty="0">
+                          <a:solidFill>
+                            <a:srgbClr val="212121"/>
+                          </a:solidFill>
+                          <a:latin typeface="Calibri" pitchFamily="34" charset="0"/>
+                          <a:ea typeface="Calibri" pitchFamily="34" charset="-122"/>
+                          <a:cs typeface="Calibri" pitchFamily="34" charset="-120"/>
+                        </a:rPr>
+                        <a:t>SHRINK</a:t>
+                      </a:r>
+                      <a:pPr algn="l" indent="0" marL="0">
+                        <a:buNone/>
+                      </a:pPr>
+                      <a:r>
+                        <a:rPr lang="en-US" sz="1100" dirty="0">
+                          <a:solidFill>
+                            <a:srgbClr val="212121"/>
+                          </a:solidFill>
+                          <a:latin typeface="Calibri" pitchFamily="34" charset="0"/>
+                          <a:ea typeface="Calibri" pitchFamily="34" charset="-122"/>
+                          <a:cs typeface="Calibri" pitchFamily="34" charset="-120"/>
+                        </a:rPr>
+                        <a:t> — a system-proof module commented out</a:t>
+                      </a:r>
+                      <a:endParaRPr lang="en-US" sz="1100" dirty="0">
+                        <a:latin typeface="Calibri" charset="0"/>
+                        <a:ea typeface="Calibri" charset="0"/>
+                        <a:cs typeface="Calibri" charset="0"/>
+                      </a:endParaRPr>
+                    </a:p>
+                  </a:txBody>
+                  <a:tcPr marL="73152" marR="73152" marT="73152" marB="73152" anchor="ctr">
+                    <a:lnL w="12700" cap="flat" cmpd="sng" algn="ctr">
+                      <a:solidFill>
+                        <a:srgbClr val="D8DEEA"/>
+                      </a:solidFill>
+                      <a:prstDash val="solid"/>
+                      <a:round/>
+                      <a:headEnd type="none" w="med" len="med"/>
+                      <a:tailEnd type="none" w="med" len="med"/>
+                    </a:lnL>
+                    <a:lnR w="12700" cap="flat" cmpd="sng" algn="ctr">
+                      <a:solidFill>
+                        <a:srgbClr val="D8DEEA"/>
+                      </a:solidFill>
+                      <a:prstDash val="solid"/>
+                      <a:round/>
+                      <a:headEnd type="none" w="med" len="med"/>
+                      <a:tailEnd type="none" w="med" len="med"/>
+                    </a:lnR>
+                    <a:lnT w="12700" cap="flat" cmpd="sng" algn="ctr">
+                      <a:solidFill>
+                        <a:srgbClr val="D8DEEA"/>
+                      </a:solidFill>
+                      <a:prstDash val="solid"/>
+                      <a:round/>
+                      <a:headEnd type="none" w="med" len="med"/>
+                      <a:tailEnd type="none" w="med" len="med"/>
+                    </a:lnT>
+                    <a:lnB w="12700" cap="flat" cmpd="sng" algn="ctr">
+                      <a:solidFill>
+                        <a:srgbClr val="D8DEEA"/>
+                      </a:solidFill>
+                      <a:prstDash val="solid"/>
+                      <a:round/>
+                      <a:headEnd type="none" w="med" len="med"/>
+                      <a:tailEnd type="none" w="med" len="med"/>
+                    </a:lnB>
+                    <a:solidFill>
+                      <a:srgbClr val="FFFFFF"/>
+                    </a:solidFill>
+                  </a:tcPr>
+                </a:tc>
+                <a:tc>
+                  <a:txBody>
+                    <a:bodyPr/>
+                    <a:lstStyle/>
+                    <a:p>
+                      <a:pPr algn="l" indent="0" marL="0">
+                        <a:buNone/>
+                      </a:pPr>
+                      <a:r>
+                        <a:rPr lang="en-US" sz="1100" dirty="0">
+                          <a:solidFill>
+                            <a:srgbClr val="212121"/>
+                          </a:solidFill>
+                          <a:latin typeface="Calibri" pitchFamily="34" charset="0"/>
+                          <a:ea typeface="Calibri" pitchFamily="34" charset="-122"/>
+                          <a:cs typeface="Calibri" pitchFamily="34" charset="-120"/>
+                        </a:rPr>
+                        <a:t>smaller crate still verifies, 0 errors</a:t>
+                      </a:r>
+                      <a:endParaRPr lang="en-US" sz="1100" dirty="0">
+                        <a:latin typeface="Calibri" charset="0"/>
+                        <a:ea typeface="Calibri" charset="0"/>
+                        <a:cs typeface="Calibri" charset="0"/>
+                      </a:endParaRPr>
+                    </a:p>
+                  </a:txBody>
+                  <a:tcPr marL="73152" marR="73152" marT="73152" marB="73152" anchor="ctr">
+                    <a:lnL w="12700" cap="flat" cmpd="sng" algn="ctr">
+                      <a:solidFill>
+                        <a:srgbClr val="D8DEEA"/>
+                      </a:solidFill>
+                      <a:prstDash val="solid"/>
+                      <a:round/>
+                      <a:headEnd type="none" w="med" len="med"/>
+                      <a:tailEnd type="none" w="med" len="med"/>
+                    </a:lnL>
+                    <a:lnR w="12700" cap="flat" cmpd="sng" algn="ctr">
+                      <a:solidFill>
+                        <a:srgbClr val="D8DEEA"/>
+                      </a:solidFill>
+                      <a:prstDash val="solid"/>
+                      <a:round/>
+                      <a:headEnd type="none" w="med" len="med"/>
+                      <a:tailEnd type="none" w="med" len="med"/>
+                    </a:lnR>
+                    <a:lnT w="12700" cap="flat" cmpd="sng" algn="ctr">
+                      <a:solidFill>
+                        <a:srgbClr val="D8DEEA"/>
+                      </a:solidFill>
+                      <a:prstDash val="solid"/>
+                      <a:round/>
+                      <a:headEnd type="none" w="med" len="med"/>
+                      <a:tailEnd type="none" w="med" len="med"/>
+                    </a:lnT>
+                    <a:lnB w="12700" cap="flat" cmpd="sng" algn="ctr">
+                      <a:solidFill>
+                        <a:srgbClr val="D8DEEA"/>
+                      </a:solidFill>
+                      <a:prstDash val="solid"/>
+                      <a:round/>
+                      <a:headEnd type="none" w="med" len="med"/>
+                      <a:tailEnd type="none" w="med" len="med"/>
+                    </a:lnB>
+                    <a:solidFill>
+                      <a:srgbClr val="FFFFFF"/>
+                    </a:solidFill>
+                  </a:tcPr>
+                </a:tc>
+                <a:tc>
+                  <a:txBody>
+                    <a:bodyPr/>
+                    <a:lstStyle/>
+                    <a:p>
+                      <a:pPr algn="l" indent="0" marL="0">
+                        <a:buNone/>
+                      </a:pPr>
+                      <a:r>
+                        <a:rPr lang="en-US" sz="1100" dirty="0">
+                          <a:solidFill>
+                            <a:srgbClr val="212121"/>
+                          </a:solidFill>
+                          <a:latin typeface="Calibri" pitchFamily="34" charset="0"/>
+                          <a:ea typeface="Calibri" pitchFamily="34" charset="-122"/>
+                          <a:cs typeface="Calibri" pitchFamily="34" charset="-120"/>
+                        </a:rPr>
+                        <a:t>sysproof file hashes</a:t>
+                      </a:r>
+                      <a:endParaRPr lang="en-US" sz="1100" dirty="0">
+                        <a:latin typeface="Calibri" charset="0"/>
+                        <a:ea typeface="Calibri" charset="0"/>
+                        <a:cs typeface="Calibri" charset="0"/>
+                      </a:endParaRPr>
+                    </a:p>
+                  </a:txBody>
+                  <a:tcPr marL="73152" marR="73152" marT="73152" marB="73152" anchor="ctr">
+                    <a:lnL w="12700" cap="flat" cmpd="sng" algn="ctr">
+                      <a:solidFill>
+                        <a:srgbClr val="D8DEEA"/>
+                      </a:solidFill>
+                      <a:prstDash val="solid"/>
+                      <a:round/>
+                      <a:headEnd type="none" w="med" len="med"/>
+                      <a:tailEnd type="none" w="med" len="med"/>
+                    </a:lnL>
+                    <a:lnR w="12700" cap="flat" cmpd="sng" algn="ctr">
+                      <a:solidFill>
+                        <a:srgbClr val="D8DEEA"/>
+                      </a:solidFill>
+                      <a:prstDash val="solid"/>
+                      <a:round/>
+                      <a:headEnd type="none" w="med" len="med"/>
+                      <a:tailEnd type="none" w="med" len="med"/>
+                    </a:lnR>
+                    <a:lnT w="12700" cap="flat" cmpd="sng" algn="ctr">
+                      <a:solidFill>
+                        <a:srgbClr val="D8DEEA"/>
+                      </a:solidFill>
+                      <a:prstDash val="solid"/>
+                      <a:round/>
+                      <a:headEnd type="none" w="med" len="med"/>
+                      <a:tailEnd type="none" w="med" len="med"/>
+                    </a:lnT>
+                    <a:lnB w="12700" cap="flat" cmpd="sng" algn="ctr">
+                      <a:solidFill>
+                        <a:srgbClr val="D8DEEA"/>
+                      </a:solidFill>
+                      <a:prstDash val="solid"/>
+                      <a:round/>
+                      <a:headEnd type="none" w="med" len="med"/>
+                      <a:tailEnd type="none" w="med" len="med"/>
+                    </a:lnB>
+                    <a:solidFill>
+                      <a:srgbClr val="FFFFFF"/>
+                    </a:solidFill>
+                  </a:tcPr>
+                </a:tc>
+              </a:tr>
+              <a:tr h="548640">
+                <a:tc>
+                  <a:txBody>
+                    <a:bodyPr/>
+                    <a:lstStyle/>
+                    <a:p>
+                      <a:pPr algn="l" indent="0" marL="0">
+                        <a:buNone/>
+                      </a:pPr>
+                      <a:r>
+                        <a:rPr lang="en-US" sz="1100" b="1" dirty="0">
+                          <a:solidFill>
+                            <a:srgbClr val="212121"/>
+                          </a:solidFill>
+                          <a:latin typeface="Calibri" pitchFamily="34" charset="0"/>
+                          <a:ea typeface="Calibri" pitchFamily="34" charset="-122"/>
+                          <a:cs typeface="Calibri" pitchFamily="34" charset="-120"/>
+                        </a:rPr>
+                        <a:t>SWAP</a:t>
+                      </a:r>
+                      <a:pPr algn="l" indent="0" marL="0">
+                        <a:buNone/>
+                      </a:pPr>
+                      <a:r>
+                        <a:rPr lang="en-US" sz="1100" dirty="0">
+                          <a:solidFill>
+                            <a:srgbClr val="212121"/>
+                          </a:solidFill>
+                          <a:latin typeface="Calibri" pitchFamily="34" charset="0"/>
+                          <a:ea typeface="Calibri" pitchFamily="34" charset="-122"/>
+                          <a:cs typeface="Calibri" pitchFamily="34" charset="-120"/>
+                        </a:rPr>
+                        <a:t> — real VC dropped, trivial one added, constant count</a:t>
+                      </a:r>
+                      <a:endParaRPr lang="en-US" sz="1100" dirty="0">
+                        <a:latin typeface="Calibri" charset="0"/>
+                        <a:ea typeface="Calibri" charset="0"/>
+                        <a:cs typeface="Calibri" charset="0"/>
+                      </a:endParaRPr>
+                    </a:p>
+                  </a:txBody>
+                  <a:tcPr marL="73152" marR="73152" marT="73152" marB="73152" anchor="ctr">
+                    <a:lnL w="12700" cap="flat" cmpd="sng" algn="ctr">
+                      <a:solidFill>
+                        <a:srgbClr val="D8DEEA"/>
+                      </a:solidFill>
+                      <a:prstDash val="solid"/>
+                      <a:round/>
+                      <a:headEnd type="none" w="med" len="med"/>
+                      <a:tailEnd type="none" w="med" len="med"/>
+                    </a:lnL>
+                    <a:lnR w="12700" cap="flat" cmpd="sng" algn="ctr">
+                      <a:solidFill>
+                        <a:srgbClr val="D8DEEA"/>
+                      </a:solidFill>
+                      <a:prstDash val="solid"/>
+                      <a:round/>
+                      <a:headEnd type="none" w="med" len="med"/>
+                      <a:tailEnd type="none" w="med" len="med"/>
+                    </a:lnR>
+                    <a:lnT w="12700" cap="flat" cmpd="sng" algn="ctr">
+                      <a:solidFill>
+                        <a:srgbClr val="D8DEEA"/>
+                      </a:solidFill>
+                      <a:prstDash val="solid"/>
+                      <a:round/>
+                      <a:headEnd type="none" w="med" len="med"/>
+                      <a:tailEnd type="none" w="med" len="med"/>
+                    </a:lnT>
+                    <a:lnB w="12700" cap="flat" cmpd="sng" algn="ctr">
+                      <a:solidFill>
+                        <a:srgbClr val="D8DEEA"/>
+                      </a:solidFill>
+                      <a:prstDash val="solid"/>
+                      <a:round/>
+                      <a:headEnd type="none" w="med" len="med"/>
+                      <a:tailEnd type="none" w="med" len="med"/>
+                    </a:lnB>
+                    <a:solidFill>
+                      <a:srgbClr val="FFFFFF"/>
+                    </a:solidFill>
+                  </a:tcPr>
+                </a:tc>
+                <a:tc>
+                  <a:txBody>
+                    <a:bodyPr/>
+                    <a:lstStyle/>
+                    <a:p>
+                      <a:pPr algn="l" indent="0" marL="0">
+                        <a:buNone/>
+                      </a:pPr>
+                      <a:r>
+                        <a:rPr lang="en-US" sz="1100" dirty="0">
+                          <a:solidFill>
+                            <a:srgbClr val="212121"/>
+                          </a:solidFill>
+                          <a:latin typeface="Calibri" pitchFamily="34" charset="0"/>
+                          <a:ea typeface="Calibri" pitchFamily="34" charset="-122"/>
+                          <a:cs typeface="Calibri" pitchFamily="34" charset="-120"/>
+                        </a:rPr>
+                        <a:t>outcome, count, escape surface all unchanged</a:t>
+                      </a:r>
+                      <a:endParaRPr lang="en-US" sz="1100" dirty="0">
+                        <a:latin typeface="Calibri" charset="0"/>
+                        <a:ea typeface="Calibri" charset="0"/>
+                        <a:cs typeface="Calibri" charset="0"/>
+                      </a:endParaRPr>
+                    </a:p>
+                  </a:txBody>
+                  <a:tcPr marL="73152" marR="73152" marT="73152" marB="73152" anchor="ctr">
+                    <a:lnL w="12700" cap="flat" cmpd="sng" algn="ctr">
+                      <a:solidFill>
+                        <a:srgbClr val="D8DEEA"/>
+                      </a:solidFill>
+                      <a:prstDash val="solid"/>
+                      <a:round/>
+                      <a:headEnd type="none" w="med" len="med"/>
+                      <a:tailEnd type="none" w="med" len="med"/>
+                    </a:lnL>
+                    <a:lnR w="12700" cap="flat" cmpd="sng" algn="ctr">
+                      <a:solidFill>
+                        <a:srgbClr val="D8DEEA"/>
+                      </a:solidFill>
+                      <a:prstDash val="solid"/>
+                      <a:round/>
+                      <a:headEnd type="none" w="med" len="med"/>
+                      <a:tailEnd type="none" w="med" len="med"/>
+                    </a:lnR>
+                    <a:lnT w="12700" cap="flat" cmpd="sng" algn="ctr">
+                      <a:solidFill>
+                        <a:srgbClr val="D8DEEA"/>
+                      </a:solidFill>
+                      <a:prstDash val="solid"/>
+                      <a:round/>
+                      <a:headEnd type="none" w="med" len="med"/>
+                      <a:tailEnd type="none" w="med" len="med"/>
+                    </a:lnT>
+                    <a:lnB w="12700" cap="flat" cmpd="sng" algn="ctr">
+                      <a:solidFill>
+                        <a:srgbClr val="D8DEEA"/>
+                      </a:solidFill>
+                      <a:prstDash val="solid"/>
+                      <a:round/>
+                      <a:headEnd type="none" w="med" len="med"/>
+                      <a:tailEnd type="none" w="med" len="med"/>
+                    </a:lnB>
+                    <a:solidFill>
+                      <a:srgbClr val="FFFFFF"/>
+                    </a:solidFill>
+                  </a:tcPr>
+                </a:tc>
+                <a:tc>
+                  <a:txBody>
+                    <a:bodyPr/>
+                    <a:lstStyle/>
+                    <a:p>
+                      <a:pPr algn="l" indent="0" marL="0">
+                        <a:buNone/>
+                      </a:pPr>
+                      <a:r>
+                        <a:rPr lang="en-US" sz="1100" dirty="0">
+                          <a:solidFill>
+                            <a:srgbClr val="212121"/>
+                          </a:solidFill>
+                          <a:latin typeface="Calibri" pitchFamily="34" charset="0"/>
+                          <a:ea typeface="Calibri" pitchFamily="34" charset="-122"/>
+                          <a:cs typeface="Calibri" pitchFamily="34" charset="-120"/>
+                        </a:rPr>
+                        <a:t>sysproof file hashes</a:t>
+                      </a:r>
+                      <a:endParaRPr lang="en-US" sz="1100" dirty="0">
+                        <a:latin typeface="Calibri" charset="0"/>
+                        <a:ea typeface="Calibri" charset="0"/>
+                        <a:cs typeface="Calibri" charset="0"/>
+                      </a:endParaRPr>
+                    </a:p>
+                  </a:txBody>
+                  <a:tcPr marL="73152" marR="73152" marT="73152" marB="73152" anchor="ctr">
+                    <a:lnL w="12700" cap="flat" cmpd="sng" algn="ctr">
+                      <a:solidFill>
+                        <a:srgbClr val="D8DEEA"/>
+                      </a:solidFill>
+                      <a:prstDash val="solid"/>
+                      <a:round/>
+                      <a:headEnd type="none" w="med" len="med"/>
+                      <a:tailEnd type="none" w="med" len="med"/>
+                    </a:lnL>
+                    <a:lnR w="12700" cap="flat" cmpd="sng" algn="ctr">
+                      <a:solidFill>
+                        <a:srgbClr val="D8DEEA"/>
+                      </a:solidFill>
+                      <a:prstDash val="solid"/>
+                      <a:round/>
+                      <a:headEnd type="none" w="med" len="med"/>
+                      <a:tailEnd type="none" w="med" len="med"/>
+                    </a:lnR>
+                    <a:lnT w="12700" cap="flat" cmpd="sng" algn="ctr">
+                      <a:solidFill>
+                        <a:srgbClr val="D8DEEA"/>
+                      </a:solidFill>
+                      <a:prstDash val="solid"/>
+                      <a:round/>
+                      <a:headEnd type="none" w="med" len="med"/>
+                      <a:tailEnd type="none" w="med" len="med"/>
+                    </a:lnT>
+                    <a:lnB w="12700" cap="flat" cmpd="sng" algn="ctr">
+                      <a:solidFill>
+                        <a:srgbClr val="D8DEEA"/>
+                      </a:solidFill>
+                      <a:prstDash val="solid"/>
+                      <a:round/>
+                      <a:headEnd type="none" w="med" len="med"/>
+                      <a:tailEnd type="none" w="med" len="med"/>
+                    </a:lnB>
+                    <a:solidFill>
+                      <a:srgbClr val="FFFFFF"/>
+                    </a:solidFill>
+                  </a:tcPr>
+                </a:tc>
+              </a:tr>
+              <a:tr h="566928">
+                <a:tc>
+                  <a:txBody>
+                    <a:bodyPr/>
+                    <a:lstStyle/>
+                    <a:p>
+                      <a:pPr algn="l" indent="0" marL="0">
+                        <a:buNone/>
+                      </a:pPr>
+                      <a:r>
+                        <a:rPr lang="en-US" sz="1100" b="1" dirty="0">
+                          <a:solidFill>
+                            <a:srgbClr val="212121"/>
+                          </a:solidFill>
+                          <a:latin typeface="Calibri" pitchFamily="34" charset="0"/>
+                          <a:ea typeface="Calibri" pitchFamily="34" charset="-122"/>
+                          <a:cs typeface="Calibri" pitchFamily="34" charset="-120"/>
+                        </a:rPr>
+                        <a:t>STALE</a:t>
+                      </a:r>
+                      <a:pPr algn="l" indent="0" marL="0">
+                        <a:buNone/>
+                      </a:pPr>
+                      <a:r>
+                        <a:rPr lang="en-US" sz="1100" dirty="0">
+                          <a:solidFill>
+                            <a:srgbClr val="212121"/>
+                          </a:solidFill>
+                          <a:latin typeface="Calibri" pitchFamily="34" charset="0"/>
+                          <a:ea typeface="Calibri" pitchFamily="34" charset="-122"/>
+                          <a:cs typeface="Calibri" pitchFamily="34" charset="-120"/>
+                        </a:rPr>
+                        <a:t> — semantic flip in a cached dep, mtime preserved</a:t>
+                      </a:r>
+                      <a:endParaRPr lang="en-US" sz="1100" dirty="0">
+                        <a:latin typeface="Calibri" charset="0"/>
+                        <a:ea typeface="Calibri" charset="0"/>
+                        <a:cs typeface="Calibri" charset="0"/>
+                      </a:endParaRPr>
+                    </a:p>
+                  </a:txBody>
+                  <a:tcPr marL="73152" marR="73152" marT="73152" marB="73152" anchor="ctr">
+                    <a:lnL w="12700" cap="flat" cmpd="sng" algn="ctr">
+                      <a:solidFill>
+                        <a:srgbClr val="D8DEEA"/>
+                      </a:solidFill>
+                      <a:prstDash val="solid"/>
+                      <a:round/>
+                      <a:headEnd type="none" w="med" len="med"/>
+                      <a:tailEnd type="none" w="med" len="med"/>
+                    </a:lnL>
+                    <a:lnR w="12700" cap="flat" cmpd="sng" algn="ctr">
+                      <a:solidFill>
+                        <a:srgbClr val="D8DEEA"/>
+                      </a:solidFill>
+                      <a:prstDash val="solid"/>
+                      <a:round/>
+                      <a:headEnd type="none" w="med" len="med"/>
+                      <a:tailEnd type="none" w="med" len="med"/>
+                    </a:lnR>
+                    <a:lnT w="12700" cap="flat" cmpd="sng" algn="ctr">
+                      <a:solidFill>
+                        <a:srgbClr val="D8DEEA"/>
+                      </a:solidFill>
+                      <a:prstDash val="solid"/>
+                      <a:round/>
+                      <a:headEnd type="none" w="med" len="med"/>
+                      <a:tailEnd type="none" w="med" len="med"/>
+                    </a:lnT>
+                    <a:lnB w="12700" cap="flat" cmpd="sng" algn="ctr">
+                      <a:solidFill>
+                        <a:srgbClr val="D8DEEA"/>
+                      </a:solidFill>
+                      <a:prstDash val="solid"/>
+                      <a:round/>
+                      <a:headEnd type="none" w="med" len="med"/>
+                      <a:tailEnd type="none" w="med" len="med"/>
+                    </a:lnB>
+                    <a:solidFill>
+                      <a:srgbClr val="FFFFFF"/>
+                    </a:solidFill>
+                  </a:tcPr>
+                </a:tc>
+                <a:tc>
+                  <a:txBody>
+                    <a:bodyPr/>
+                    <a:lstStyle/>
+                    <a:p>
+                      <a:pPr algn="l" indent="0" marL="0">
+                        <a:buNone/>
+                      </a:pPr>
+                      <a:r>
+                        <a:rPr lang="en-US" sz="1100" dirty="0">
+                          <a:solidFill>
+                            <a:srgbClr val="212121"/>
+                          </a:solidFill>
+                          <a:latin typeface="Calibri" pitchFamily="34" charset="0"/>
+                          <a:ea typeface="Calibri" pitchFamily="34" charset="-122"/>
+                          <a:cs typeface="Calibri" pitchFamily="34" charset="-120"/>
+                        </a:rPr>
+                        <a:t>mtime-gated cache serves the stale verdict; green over false bytes</a:t>
+                      </a:r>
+                      <a:endParaRPr lang="en-US" sz="1100" dirty="0">
+                        <a:latin typeface="Calibri" charset="0"/>
+                        <a:ea typeface="Calibri" charset="0"/>
+                        <a:cs typeface="Calibri" charset="0"/>
+                      </a:endParaRPr>
+                    </a:p>
+                  </a:txBody>
+                  <a:tcPr marL="73152" marR="73152" marT="73152" marB="73152" anchor="ctr">
+                    <a:lnL w="12700" cap="flat" cmpd="sng" algn="ctr">
+                      <a:solidFill>
+                        <a:srgbClr val="D8DEEA"/>
+                      </a:solidFill>
+                      <a:prstDash val="solid"/>
+                      <a:round/>
+                      <a:headEnd type="none" w="med" len="med"/>
+                      <a:tailEnd type="none" w="med" len="med"/>
+                    </a:lnL>
+                    <a:lnR w="12700" cap="flat" cmpd="sng" algn="ctr">
+                      <a:solidFill>
+                        <a:srgbClr val="D8DEEA"/>
+                      </a:solidFill>
+                      <a:prstDash val="solid"/>
+                      <a:round/>
+                      <a:headEnd type="none" w="med" len="med"/>
+                      <a:tailEnd type="none" w="med" len="med"/>
+                    </a:lnR>
+                    <a:lnT w="12700" cap="flat" cmpd="sng" algn="ctr">
+                      <a:solidFill>
+                        <a:srgbClr val="D8DEEA"/>
+                      </a:solidFill>
+                      <a:prstDash val="solid"/>
+                      <a:round/>
+                      <a:headEnd type="none" w="med" len="med"/>
+                      <a:tailEnd type="none" w="med" len="med"/>
+                    </a:lnT>
+                    <a:lnB w="12700" cap="flat" cmpd="sng" algn="ctr">
+                      <a:solidFill>
+                        <a:srgbClr val="D8DEEA"/>
+                      </a:solidFill>
+                      <a:prstDash val="solid"/>
+                      <a:round/>
+                      <a:headEnd type="none" w="med" len="med"/>
+                      <a:tailEnd type="none" w="med" len="med"/>
+                    </a:lnB>
+                    <a:solidFill>
+                      <a:srgbClr val="FFFFFF"/>
+                    </a:solidFill>
+                  </a:tcPr>
+                </a:tc>
+                <a:tc>
+                  <a:txBody>
+                    <a:bodyPr/>
+                    <a:lstStyle/>
+                    <a:p>
+                      <a:pPr algn="l" indent="0" marL="0">
+                        <a:buNone/>
+                      </a:pPr>
+                      <a:r>
+                        <a:rPr lang="en-US" sz="1100" dirty="0">
+                          <a:solidFill>
+                            <a:srgbClr val="212121"/>
+                          </a:solidFill>
+                          <a:latin typeface="Calibri" pitchFamily="34" charset="0"/>
+                          <a:ea typeface="Calibri" pitchFamily="34" charset="-122"/>
+                          <a:cs typeface="Calibri" pitchFamily="34" charset="-120"/>
+                        </a:rPr>
+                        <a:t>gensrc measurement</a:t>
+                      </a:r>
+                      <a:endParaRPr lang="en-US" sz="1100" dirty="0">
+                        <a:latin typeface="Calibri" charset="0"/>
+                        <a:ea typeface="Calibri" charset="0"/>
+                        <a:cs typeface="Calibri" charset="0"/>
+                      </a:endParaRPr>
+                    </a:p>
+                  </a:txBody>
+                  <a:tcPr marL="73152" marR="73152" marT="73152" marB="73152" anchor="ctr">
+                    <a:lnL w="12700" cap="flat" cmpd="sng" algn="ctr">
+                      <a:solidFill>
+                        <a:srgbClr val="D8DEEA"/>
+                      </a:solidFill>
+                      <a:prstDash val="solid"/>
+                      <a:round/>
+                      <a:headEnd type="none" w="med" len="med"/>
+                      <a:tailEnd type="none" w="med" len="med"/>
+                    </a:lnL>
+                    <a:lnR w="12700" cap="flat" cmpd="sng" algn="ctr">
+                      <a:solidFill>
+                        <a:srgbClr val="D8DEEA"/>
+                      </a:solidFill>
+                      <a:prstDash val="solid"/>
+                      <a:round/>
+                      <a:headEnd type="none" w="med" len="med"/>
+                      <a:tailEnd type="none" w="med" len="med"/>
+                    </a:lnR>
+                    <a:lnT w="12700" cap="flat" cmpd="sng" algn="ctr">
+                      <a:solidFill>
+                        <a:srgbClr val="D8DEEA"/>
+                      </a:solidFill>
+                      <a:prstDash val="solid"/>
+                      <a:round/>
+                      <a:headEnd type="none" w="med" len="med"/>
+                      <a:tailEnd type="none" w="med" len="med"/>
+                    </a:lnT>
+                    <a:lnB w="12700" cap="flat" cmpd="sng" algn="ctr">
+                      <a:solidFill>
+                        <a:srgbClr val="D8DEEA"/>
+                      </a:solidFill>
+                      <a:prstDash val="solid"/>
+                      <a:round/>
+                      <a:headEnd type="none" w="med" len="med"/>
+                      <a:tailEnd type="none" w="med" len="med"/>
+                    </a:lnB>
+                    <a:solidFill>
+                      <a:srgbClr val="FFFFFF"/>
+                    </a:solidFill>
+                  </a:tcPr>
+                </a:tc>
+              </a:tr>
+              <a:tr h="566928">
+                <a:tc>
+                  <a:txBody>
+                    <a:bodyPr/>
+                    <a:lstStyle/>
+                    <a:p>
+                      <a:pPr algn="l" indent="0" marL="0">
+                        <a:buNone/>
+                      </a:pPr>
+                      <a:r>
+                        <a:rPr lang="en-US" sz="1100" b="1" dirty="0">
+                          <a:solidFill>
+                            <a:srgbClr val="212121"/>
+                          </a:solidFill>
+                          <a:latin typeface="Calibri" pitchFamily="34" charset="0"/>
+                          <a:ea typeface="Calibri" pitchFamily="34" charset="-122"/>
+                          <a:cs typeface="Calibri" pitchFamily="34" charset="-120"/>
+                        </a:rPr>
+                        <a:t>INVERT</a:t>
+                      </a:r>
+                      <a:pPr algn="l" indent="0" marL="0">
+                        <a:buNone/>
+                      </a:pPr>
+                      <a:r>
+                        <a:rPr lang="en-US" sz="1100" dirty="0">
+                          <a:solidFill>
+                            <a:srgbClr val="212121"/>
+                          </a:solidFill>
+                          <a:latin typeface="Calibri" pitchFamily="34" charset="0"/>
+                          <a:ea typeface="Calibri" pitchFamily="34" charset="-122"/>
+                          <a:cs typeface="Calibri" pitchFamily="34" charset="-120"/>
+                        </a:rPr>
+                        <a:t> — heat command flipped in unverified FFI glue</a:t>
+                      </a:r>
+                      <a:endParaRPr lang="en-US" sz="1100" dirty="0">
+                        <a:latin typeface="Calibri" charset="0"/>
+                        <a:ea typeface="Calibri" charset="0"/>
+                        <a:cs typeface="Calibri" charset="0"/>
+                      </a:endParaRPr>
+                    </a:p>
+                  </a:txBody>
+                  <a:tcPr marL="73152" marR="73152" marT="73152" marB="73152" anchor="ctr">
+                    <a:lnL w="12700" cap="flat" cmpd="sng" algn="ctr">
+                      <a:solidFill>
+                        <a:srgbClr val="D8DEEA"/>
+                      </a:solidFill>
+                      <a:prstDash val="solid"/>
+                      <a:round/>
+                      <a:headEnd type="none" w="med" len="med"/>
+                      <a:tailEnd type="none" w="med" len="med"/>
+                    </a:lnL>
+                    <a:lnR w="12700" cap="flat" cmpd="sng" algn="ctr">
+                      <a:solidFill>
+                        <a:srgbClr val="D8DEEA"/>
+                      </a:solidFill>
+                      <a:prstDash val="solid"/>
+                      <a:round/>
+                      <a:headEnd type="none" w="med" len="med"/>
+                      <a:tailEnd type="none" w="med" len="med"/>
+                    </a:lnR>
+                    <a:lnT w="12700" cap="flat" cmpd="sng" algn="ctr">
+                      <a:solidFill>
+                        <a:srgbClr val="D8DEEA"/>
+                      </a:solidFill>
+                      <a:prstDash val="solid"/>
+                      <a:round/>
+                      <a:headEnd type="none" w="med" len="med"/>
+                      <a:tailEnd type="none" w="med" len="med"/>
+                    </a:lnT>
+                    <a:lnB w="12700" cap="flat" cmpd="sng" algn="ctr">
+                      <a:solidFill>
+                        <a:srgbClr val="D8DEEA"/>
+                      </a:solidFill>
+                      <a:prstDash val="solid"/>
+                      <a:round/>
+                      <a:headEnd type="none" w="med" len="med"/>
+                      <a:tailEnd type="none" w="med" len="med"/>
+                    </a:lnB>
+                    <a:solidFill>
+                      <a:srgbClr val="FFFFFF"/>
+                    </a:solidFill>
+                  </a:tcPr>
+                </a:tc>
+                <a:tc>
+                  <a:txBody>
+                    <a:bodyPr/>
+                    <a:lstStyle/>
+                    <a:p>
+                      <a:pPr algn="l" indent="0" marL="0">
+                        <a:buNone/>
+                      </a:pPr>
+                      <a:r>
+                        <a:rPr lang="en-US" sz="1100" dirty="0">
+                          <a:solidFill>
+                            <a:srgbClr val="212121"/>
+                          </a:solidFill>
+                          <a:latin typeface="Calibri" pitchFamily="34" charset="0"/>
+                          <a:ea typeface="Calibri" pitchFamily="34" charset="-122"/>
+                          <a:cs typeface="Calibri" pitchFamily="34" charset="-120"/>
+                        </a:rPr>
+                        <a:t>Verus never reads the body — unverified code, out of scope</a:t>
+                      </a:r>
+                      <a:endParaRPr lang="en-US" sz="1100" dirty="0">
+                        <a:latin typeface="Calibri" charset="0"/>
+                        <a:ea typeface="Calibri" charset="0"/>
+                        <a:cs typeface="Calibri" charset="0"/>
+                      </a:endParaRPr>
+                    </a:p>
+                  </a:txBody>
+                  <a:tcPr marL="73152" marR="73152" marT="73152" marB="73152" anchor="ctr">
+                    <a:lnL w="12700" cap="flat" cmpd="sng" algn="ctr">
+                      <a:solidFill>
+                        <a:srgbClr val="D8DEEA"/>
+                      </a:solidFill>
+                      <a:prstDash val="solid"/>
+                      <a:round/>
+                      <a:headEnd type="none" w="med" len="med"/>
+                      <a:tailEnd type="none" w="med" len="med"/>
+                    </a:lnL>
+                    <a:lnR w="12700" cap="flat" cmpd="sng" algn="ctr">
+                      <a:solidFill>
+                        <a:srgbClr val="D8DEEA"/>
+                      </a:solidFill>
+                      <a:prstDash val="solid"/>
+                      <a:round/>
+                      <a:headEnd type="none" w="med" len="med"/>
+                      <a:tailEnd type="none" w="med" len="med"/>
+                    </a:lnR>
+                    <a:lnT w="12700" cap="flat" cmpd="sng" algn="ctr">
+                      <a:solidFill>
+                        <a:srgbClr val="D8DEEA"/>
+                      </a:solidFill>
+                      <a:prstDash val="solid"/>
+                      <a:round/>
+                      <a:headEnd type="none" w="med" len="med"/>
+                      <a:tailEnd type="none" w="med" len="med"/>
+                    </a:lnT>
+                    <a:lnB w="12700" cap="flat" cmpd="sng" algn="ctr">
+                      <a:solidFill>
+                        <a:srgbClr val="D8DEEA"/>
+                      </a:solidFill>
+                      <a:prstDash val="solid"/>
+                      <a:round/>
+                      <a:headEnd type="none" w="med" len="med"/>
+                      <a:tailEnd type="none" w="med" len="med"/>
+                    </a:lnB>
+                    <a:solidFill>
+                      <a:srgbClr val="FFFFFF"/>
+                    </a:solidFill>
+                  </a:tcPr>
+                </a:tc>
+                <a:tc>
+                  <a:txBody>
+                    <a:bodyPr/>
+                    <a:lstStyle/>
+                    <a:p>
+                      <a:pPr algn="l" indent="0" marL="0">
+                        <a:buNone/>
+                      </a:pPr>
+                      <a:r>
+                        <a:rPr lang="en-US" sz="1100" dirty="0">
+                          <a:solidFill>
+                            <a:srgbClr val="212121"/>
+                          </a:solidFill>
+                          <a:latin typeface="Calibri" pitchFamily="34" charset="0"/>
+                          <a:ea typeface="Calibri" pitchFamily="34" charset="-122"/>
+                          <a:cs typeface="Calibri" pitchFamily="34" charset="-120"/>
+                        </a:rPr>
+                        <a:t>gensrc measurement</a:t>
+                      </a:r>
+                      <a:endParaRPr lang="en-US" sz="1100" dirty="0">
+                        <a:latin typeface="Calibri" charset="0"/>
+                        <a:ea typeface="Calibri" charset="0"/>
+                        <a:cs typeface="Calibri" charset="0"/>
+                      </a:endParaRPr>
+                    </a:p>
+                  </a:txBody>
+                  <a:tcPr marL="73152" marR="73152" marT="73152" marB="73152" anchor="ctr">
+                    <a:lnL w="12700" cap="flat" cmpd="sng" algn="ctr">
+                      <a:solidFill>
+                        <a:srgbClr val="D8DEEA"/>
+                      </a:solidFill>
+                      <a:prstDash val="solid"/>
+                      <a:round/>
+                      <a:headEnd type="none" w="med" len="med"/>
+                      <a:tailEnd type="none" w="med" len="med"/>
+                    </a:lnL>
+                    <a:lnR w="12700" cap="flat" cmpd="sng" algn="ctr">
+                      <a:solidFill>
+                        <a:srgbClr val="D8DEEA"/>
+                      </a:solidFill>
+                      <a:prstDash val="solid"/>
+                      <a:round/>
+                      <a:headEnd type="none" w="med" len="med"/>
+                      <a:tailEnd type="none" w="med" len="med"/>
+                    </a:lnR>
+                    <a:lnT w="12700" cap="flat" cmpd="sng" algn="ctr">
+                      <a:solidFill>
+                        <a:srgbClr val="D8DEEA"/>
+                      </a:solidFill>
+                      <a:prstDash val="solid"/>
+                      <a:round/>
+                      <a:headEnd type="none" w="med" len="med"/>
+                      <a:tailEnd type="none" w="med" len="med"/>
+                    </a:lnT>
+                    <a:lnB w="12700" cap="flat" cmpd="sng" algn="ctr">
+                      <a:solidFill>
+                        <a:srgbClr val="D8DEEA"/>
+                      </a:solidFill>
+                      <a:prstDash val="solid"/>
+                      <a:round/>
+                      <a:headEnd type="none" w="med" len="med"/>
+                      <a:tailEnd type="none" w="med" len="med"/>
+                    </a:lnB>
+                    <a:solidFill>
+                      <a:srgbClr val="FFFFFF"/>
+                    </a:solidFill>
+                  </a:tcPr>
+                </a:tc>
+              </a:tr>
+              <a:tr h="786384">
+                <a:tc>
+                  <a:txBody>
+                    <a:bodyPr/>
+                    <a:lstStyle/>
+                    <a:p>
+                      <a:pPr algn="l" indent="0" marL="0">
+                        <a:buNone/>
+                      </a:pPr>
+                      <a:r>
+                        <a:rPr lang="en-US" sz="1100" b="1" dirty="0">
+                          <a:solidFill>
+                            <a:srgbClr val="212121"/>
+                          </a:solidFill>
+                          <a:latin typeface="Calibri" pitchFamily="34" charset="0"/>
+                          <a:ea typeface="Calibri" pitchFamily="34" charset="-122"/>
+                          <a:cs typeface="Calibri" pitchFamily="34" charset="-120"/>
+                        </a:rPr>
+                        <a:t>LAUNDER</a:t>
+                      </a:r>
+                      <a:pPr algn="l" indent="0" marL="0">
+                        <a:buNone/>
+                      </a:pPr>
+                      <a:r>
+                        <a:rPr lang="en-US" sz="1100" dirty="0">
+                          <a:solidFill>
+                            <a:srgbClr val="212121"/>
+                          </a:solidFill>
+                          <a:latin typeface="Calibri" pitchFamily="34" charset="0"/>
+                          <a:ea typeface="Calibri" pitchFamily="34" charset="-122"/>
+                          <a:cs typeface="Calibri" pitchFamily="34" charset="-120"/>
+                        </a:rPr>
+                        <a:t> — contract weakened + impl inverted to match</a:t>
+                      </a:r>
+                      <a:endParaRPr lang="en-US" sz="1100" dirty="0">
+                        <a:latin typeface="Calibri" charset="0"/>
+                        <a:ea typeface="Calibri" charset="0"/>
+                        <a:cs typeface="Calibri" charset="0"/>
+                      </a:endParaRPr>
+                    </a:p>
+                  </a:txBody>
+                  <a:tcPr marL="73152" marR="73152" marT="73152" marB="73152" anchor="ctr">
+                    <a:lnL w="12700" cap="flat" cmpd="sng" algn="ctr">
+                      <a:solidFill>
+                        <a:srgbClr val="D8DEEA"/>
+                      </a:solidFill>
+                      <a:prstDash val="solid"/>
+                      <a:round/>
+                      <a:headEnd type="none" w="med" len="med"/>
+                      <a:tailEnd type="none" w="med" len="med"/>
+                    </a:lnL>
+                    <a:lnR w="12700" cap="flat" cmpd="sng" algn="ctr">
+                      <a:solidFill>
+                        <a:srgbClr val="D8DEEA"/>
+                      </a:solidFill>
+                      <a:prstDash val="solid"/>
+                      <a:round/>
+                      <a:headEnd type="none" w="med" len="med"/>
+                      <a:tailEnd type="none" w="med" len="med"/>
+                    </a:lnR>
+                    <a:lnT w="12700" cap="flat" cmpd="sng" algn="ctr">
+                      <a:solidFill>
+                        <a:srgbClr val="D8DEEA"/>
+                      </a:solidFill>
+                      <a:prstDash val="solid"/>
+                      <a:round/>
+                      <a:headEnd type="none" w="med" len="med"/>
+                      <a:tailEnd type="none" w="med" len="med"/>
+                    </a:lnT>
+                    <a:lnB w="12700" cap="flat" cmpd="sng" algn="ctr">
+                      <a:solidFill>
+                        <a:srgbClr val="D8DEEA"/>
+                      </a:solidFill>
+                      <a:prstDash val="solid"/>
+                      <a:round/>
+                      <a:headEnd type="none" w="med" len="med"/>
+                      <a:tailEnd type="none" w="med" len="med"/>
+                    </a:lnB>
+                    <a:solidFill>
+                      <a:srgbClr val="EDEFF4"/>
+                    </a:solidFill>
+                  </a:tcPr>
+                </a:tc>
+                <a:tc>
+                  <a:txBody>
+                    <a:bodyPr/>
+                    <a:lstStyle/>
+                    <a:p>
+                      <a:pPr algn="l" indent="0" marL="0">
+                        <a:buNone/>
+                      </a:pPr>
+                      <a:r>
+                        <a:rPr lang="en-US" sz="1100" dirty="0">
+                          <a:solidFill>
+                            <a:srgbClr val="212121"/>
+                          </a:solidFill>
+                          <a:latin typeface="Calibri" pitchFamily="34" charset="0"/>
+                          <a:ea typeface="Calibri" pitchFamily="34" charset="-122"/>
+                          <a:cs typeface="Calibri" pitchFamily="34" charset="-120"/>
+                        </a:rPr>
+                        <a:t>self-consistent; gap in contract coverage for attestation report’s compute_cases construct</a:t>
+                      </a:r>
+                      <a:endParaRPr lang="en-US" sz="1100" dirty="0">
+                        <a:latin typeface="Calibri" charset="0"/>
+                        <a:ea typeface="Calibri" charset="0"/>
+                        <a:cs typeface="Calibri" charset="0"/>
+                      </a:endParaRPr>
+                    </a:p>
+                  </a:txBody>
+                  <a:tcPr marL="73152" marR="73152" marT="73152" marB="73152" anchor="ctr">
+                    <a:lnL w="12700" cap="flat" cmpd="sng" algn="ctr">
+                      <a:solidFill>
+                        <a:srgbClr val="D8DEEA"/>
+                      </a:solidFill>
+                      <a:prstDash val="solid"/>
+                      <a:round/>
+                      <a:headEnd type="none" w="med" len="med"/>
+                      <a:tailEnd type="none" w="med" len="med"/>
+                    </a:lnL>
+                    <a:lnR w="12700" cap="flat" cmpd="sng" algn="ctr">
+                      <a:solidFill>
+                        <a:srgbClr val="D8DEEA"/>
+                      </a:solidFill>
+                      <a:prstDash val="solid"/>
+                      <a:round/>
+                      <a:headEnd type="none" w="med" len="med"/>
+                      <a:tailEnd type="none" w="med" len="med"/>
+                    </a:lnR>
+                    <a:lnT w="12700" cap="flat" cmpd="sng" algn="ctr">
+                      <a:solidFill>
+                        <a:srgbClr val="D8DEEA"/>
+                      </a:solidFill>
+                      <a:prstDash val="solid"/>
+                      <a:round/>
+                      <a:headEnd type="none" w="med" len="med"/>
+                      <a:tailEnd type="none" w="med" len="med"/>
+                    </a:lnT>
+                    <a:lnB w="12700" cap="flat" cmpd="sng" algn="ctr">
+                      <a:solidFill>
+                        <a:srgbClr val="D8DEEA"/>
+                      </a:solidFill>
+                      <a:prstDash val="solid"/>
+                      <a:round/>
+                      <a:headEnd type="none" w="med" len="med"/>
+                      <a:tailEnd type="none" w="med" len="med"/>
+                    </a:lnB>
+                    <a:solidFill>
+                      <a:srgbClr val="EDEFF4"/>
+                    </a:solidFill>
+                  </a:tcPr>
+                </a:tc>
+                <a:tc>
+                  <a:txBody>
+                    <a:bodyPr/>
+                    <a:lstStyle/>
+                    <a:p>
+                      <a:pPr algn="l" indent="0" marL="0">
+                        <a:buNone/>
+                      </a:pPr>
+                      <a:r>
+                        <a:rPr lang="en-US" sz="1100" dirty="0">
+                          <a:solidFill>
+                            <a:srgbClr val="212121"/>
+                          </a:solidFill>
+                          <a:latin typeface="Calibri" pitchFamily="34" charset="0"/>
+                          <a:ea typeface="Calibri" pitchFamily="34" charset="-122"/>
+                          <a:cs typeface="Calibri" pitchFamily="34" charset="-120"/>
+                        </a:rPr>
+                        <a:t>stopgap contract measurement, contract coverage check at provisioning</a:t>
+                      </a:r>
+                      <a:endParaRPr lang="en-US" sz="1100" dirty="0">
+                        <a:latin typeface="Calibri" charset="0"/>
+                        <a:ea typeface="Calibri" charset="0"/>
+                        <a:cs typeface="Calibri" charset="0"/>
+                      </a:endParaRPr>
+                    </a:p>
+                  </a:txBody>
+                  <a:tcPr marL="73152" marR="73152" marT="73152" marB="73152" anchor="ctr">
+                    <a:lnL w="12700" cap="flat" cmpd="sng" algn="ctr">
+                      <a:solidFill>
+                        <a:srgbClr val="D8DEEA"/>
+                      </a:solidFill>
+                      <a:prstDash val="solid"/>
+                      <a:round/>
+                      <a:headEnd type="none" w="med" len="med"/>
+                      <a:tailEnd type="none" w="med" len="med"/>
+                    </a:lnL>
+                    <a:lnR w="12700" cap="flat" cmpd="sng" algn="ctr">
+                      <a:solidFill>
+                        <a:srgbClr val="D8DEEA"/>
+                      </a:solidFill>
+                      <a:prstDash val="solid"/>
+                      <a:round/>
+                      <a:headEnd type="none" w="med" len="med"/>
+                      <a:tailEnd type="none" w="med" len="med"/>
+                    </a:lnR>
+                    <a:lnT w="12700" cap="flat" cmpd="sng" algn="ctr">
+                      <a:solidFill>
+                        <a:srgbClr val="D8DEEA"/>
+                      </a:solidFill>
+                      <a:prstDash val="solid"/>
+                      <a:round/>
+                      <a:headEnd type="none" w="med" len="med"/>
+                      <a:tailEnd type="none" w="med" len="med"/>
+                    </a:lnT>
+                    <a:lnB w="12700" cap="flat" cmpd="sng" algn="ctr">
+                      <a:solidFill>
+                        <a:srgbClr val="D8DEEA"/>
+                      </a:solidFill>
+                      <a:prstDash val="solid"/>
+                      <a:round/>
+                      <a:headEnd type="none" w="med" len="med"/>
+                      <a:tailEnd type="none" w="med" len="med"/>
+                    </a:lnB>
+                    <a:solidFill>
+                      <a:srgbClr val="EDEFF4"/>
+                    </a:solidFill>
+                  </a:tcPr>
+                </a:tc>
+              </a:tr>
+            </a:tbl>
+          </a:graphicData>
+        </a:graphic>
+      </p:graphicFrame>
+      <p:sp>
+        <p:nvSpPr>
+          <p:cNvPr id="5" name="Text 2"/>
+          <p:cNvSpPr/>
+          <p:nvPr/>
+        </p:nvSpPr>
+        <p:spPr>
+          <a:xfrm>
+            <a:off x="640080" y="6144768"/>
+            <a:ext cx="10881360" cy="365760"/>
+          </a:xfrm>
+          <a:prstGeom prst="rect">
+            <a:avLst/>
+          </a:prstGeom>
+          <a:noFill/>
+          <a:ln/>
+        </p:spPr>
+        <p:txBody>
+          <a:bodyPr wrap="square" lIns="0" tIns="0" rIns="0" bIns="0" rtlCol="0" anchor="ctr"/>
           <a:lstStyle/>
           <a:p>
             <a:pPr algn="l" indent="0" marL="0">
-              <a:spcAft>
-                <a:spcPts val="400"/>
-              </a:spcAft>
-              <a:buNone/>
-            </a:pPr>
-            <a:r>
-              <a:rPr lang="en-US" sz="1400" b="1" dirty="0">
+              <a:buNone/>
+            </a:pPr>
+            <a:r>
+              <a:rPr lang="en-US" sz="1350" b="1" i="1" dirty="0">
                 <a:solidFill>
                   <a:srgbClr val="1E2761"/>
                 </a:solidFill>
@@ -10072,263 +12062,13 @@
                 <a:ea typeface="Calibri" pitchFamily="34" charset="-122"/>
                 <a:cs typeface="Calibri" pitchFamily="34" charset="-120"/>
               </a:rPr>
-              <a:t>The isolette &amp; HAMR (Kansas State)</a:t>
-            </a:r>
-            <a:endParaRPr lang="en-US" sz="1400" dirty="0"/>
-          </a:p>
-          <a:p>
-            <a:pPr algn="l" marL="342900" indent="-342900">
-              <a:spcAft>
-                <a:spcPts val="300"/>
-              </a:spcAft>
-              <a:buSzPct val="100000"/>
-              <a:buChar char="•"/>
-            </a:pPr>
-            <a:r>
-              <a:rPr lang="en-US" sz="1150" dirty="0">
-                <a:solidFill>
-                  <a:srgbClr val="212121"/>
-                </a:solidFill>
-                <a:latin typeface="Calibri" pitchFamily="34" charset="0"/>
-                <a:ea typeface="Calibri" pitchFamily="34" charset="-122"/>
-                <a:cs typeface="Calibri" pitchFamily="34" charset="-120"/>
-              </a:rPr>
-              <a:t>Hatcliff &amp; Belt, </a:t>
+              <a:t>Adversarial co-development</a:t>
             </a:r>
             <a:pPr algn="l" indent="0" marL="0">
-              <a:spcAft>
-                <a:spcPts val="300"/>
-              </a:spcAft>
-              <a:buNone/>
-            </a:pPr>
-            <a:r>
-              <a:rPr lang="en-US" sz="1150" i="1" dirty="0">
-                <a:solidFill>
-                  <a:srgbClr val="212121"/>
-                </a:solidFill>
-                <a:latin typeface="Calibri" pitchFamily="34" charset="0"/>
-                <a:ea typeface="Calibri" pitchFamily="34" charset="-122"/>
-                <a:cs typeface="Calibri" pitchFamily="34" charset="-120"/>
-              </a:rPr>
-              <a:t>The Isolette System: Illustrating End-to-End Artifacts for Rigorous Model-Based Engineering</a:t>
-            </a:r>
-            <a:pPr algn="l" indent="0" marL="0">
-              <a:spcAft>
-                <a:spcPts val="300"/>
-              </a:spcAft>
-              <a:buNone/>
-            </a:pPr>
-            <a:r>
-              <a:rPr lang="en-US" sz="1150" dirty="0">
-                <a:solidFill>
-                  <a:srgbClr val="212121"/>
-                </a:solidFill>
-                <a:latin typeface="Calibri" pitchFamily="34" charset="0"/>
-                <a:ea typeface="Calibri" pitchFamily="34" charset="-122"/>
-                <a:cs typeface="Calibri" pitchFamily="34" charset="-120"/>
-              </a:rPr>
-              <a:t>, Springer LNCS 15240, 2025</a:t>
-            </a:r>
-            <a:endParaRPr lang="en-US" sz="1400" dirty="0"/>
-          </a:p>
-          <a:p>
-            <a:pPr algn="l" marL="342900" indent="-342900">
-              <a:spcAft>
-                <a:spcPts val="300"/>
-              </a:spcAft>
-              <a:buSzPct val="100000"/>
-              <a:buChar char="•"/>
-            </a:pPr>
-            <a:r>
-              <a:rPr lang="en-US" sz="1150" dirty="0">
-                <a:solidFill>
-                  <a:srgbClr val="212121"/>
-                </a:solidFill>
-                <a:latin typeface="Calibri" pitchFamily="34" charset="0"/>
-                <a:ea typeface="Calibri" pitchFamily="34" charset="-122"/>
-                <a:cs typeface="Calibri" pitchFamily="34" charset="-120"/>
-              </a:rPr>
-              <a:t>Hatcliff, Belt, Robby, McKenzie, Liang, </a:t>
-            </a:r>
-            <a:pPr algn="l" indent="0" marL="0">
-              <a:spcAft>
-                <a:spcPts val="300"/>
-              </a:spcAft>
-              <a:buNone/>
-            </a:pPr>
-            <a:r>
-              <a:rPr lang="en-US" sz="1150" i="1" dirty="0">
-                <a:solidFill>
-                  <a:srgbClr val="212121"/>
-                </a:solidFill>
-                <a:latin typeface="Calibri" pitchFamily="34" charset="0"/>
-                <a:ea typeface="Calibri" pitchFamily="34" charset="-122"/>
-                <a:cs typeface="Calibri" pitchFamily="34" charset="-120"/>
-              </a:rPr>
-              <a:t>End-to-End Formal Methods Integrated Development with SysMLv2 Using HAMR</a:t>
-            </a:r>
-            <a:pPr algn="l" indent="0" marL="0">
-              <a:spcAft>
-                <a:spcPts val="300"/>
-              </a:spcAft>
-              <a:buNone/>
-            </a:pPr>
-            <a:r>
-              <a:rPr lang="en-US" sz="1150" dirty="0">
-                <a:solidFill>
-                  <a:srgbClr val="212121"/>
-                </a:solidFill>
-                <a:latin typeface="Calibri" pitchFamily="34" charset="0"/>
-                <a:ea typeface="Calibri" pitchFamily="34" charset="-122"/>
-                <a:cs typeface="Calibri" pitchFamily="34" charset="-120"/>
-              </a:rPr>
-              <a:t>, Springer, 2025</a:t>
-            </a:r>
-            <a:endParaRPr lang="en-US" sz="1400" dirty="0"/>
-          </a:p>
-          <a:p>
-            <a:pPr algn="l" marL="342900" indent="-342900">
-              <a:spcAft>
-                <a:spcPts val="300"/>
-              </a:spcAft>
-              <a:buSzPct val="100000"/>
-              <a:buChar char="•"/>
-            </a:pPr>
-            <a:r>
-              <a:rPr lang="en-US" sz="1150" dirty="0">
-                <a:solidFill>
-                  <a:srgbClr val="212121"/>
-                </a:solidFill>
-                <a:latin typeface="Calibri" pitchFamily="34" charset="0"/>
-                <a:ea typeface="Calibri" pitchFamily="34" charset="-122"/>
-                <a:cs typeface="Calibri" pitchFamily="34" charset="-120"/>
-              </a:rPr>
-              <a:t>Hatcliff, Belt, Robby, Carpenter, </a:t>
-            </a:r>
-            <a:pPr algn="l" indent="0" marL="0">
-              <a:spcAft>
-                <a:spcPts val="300"/>
-              </a:spcAft>
-              <a:buNone/>
-            </a:pPr>
-            <a:r>
-              <a:rPr lang="en-US" sz="1150" i="1" dirty="0">
-                <a:solidFill>
-                  <a:srgbClr val="212121"/>
-                </a:solidFill>
-                <a:latin typeface="Calibri" pitchFamily="34" charset="0"/>
-                <a:ea typeface="Calibri" pitchFamily="34" charset="-122"/>
-                <a:cs typeface="Calibri" pitchFamily="34" charset="-120"/>
-              </a:rPr>
-              <a:t>HAMR: An AADL Multi-platform Code Generation Toolset</a:t>
-            </a:r>
-            <a:pPr algn="l" indent="0" marL="0">
-              <a:spcAft>
-                <a:spcPts val="300"/>
-              </a:spcAft>
-              <a:buNone/>
-            </a:pPr>
-            <a:r>
-              <a:rPr lang="en-US" sz="1150" dirty="0">
-                <a:solidFill>
-                  <a:srgbClr val="212121"/>
-                </a:solidFill>
-                <a:latin typeface="Calibri" pitchFamily="34" charset="0"/>
-                <a:ea typeface="Calibri" pitchFamily="34" charset="-122"/>
-                <a:cs typeface="Calibri" pitchFamily="34" charset="-120"/>
-              </a:rPr>
-              <a:t>, ISoLA 2021, LNCS 13036, pp. 274–295</a:t>
-            </a:r>
-            <a:endParaRPr lang="en-US" sz="1400" dirty="0"/>
-          </a:p>
-          <a:p>
-            <a:pPr algn="l" marL="342900" indent="-342900">
-              <a:spcAft>
-                <a:spcPts val="300"/>
-              </a:spcAft>
-              <a:buSzPct val="100000"/>
-              <a:buChar char="•"/>
-            </a:pPr>
-            <a:r>
-              <a:rPr lang="en-US" sz="1150" dirty="0">
-                <a:solidFill>
-                  <a:srgbClr val="212121"/>
-                </a:solidFill>
-                <a:latin typeface="Calibri" pitchFamily="34" charset="0"/>
-                <a:ea typeface="Calibri" pitchFamily="34" charset="-122"/>
-                <a:cs typeface="Calibri" pitchFamily="34" charset="-120"/>
-              </a:rPr>
-              <a:t>Lempia &amp; Miller, </a:t>
-            </a:r>
-            <a:pPr algn="l" indent="0" marL="0">
-              <a:spcAft>
-                <a:spcPts val="300"/>
-              </a:spcAft>
-              <a:buNone/>
-            </a:pPr>
-            <a:r>
-              <a:rPr lang="en-US" sz="1150" i="1" dirty="0">
-                <a:solidFill>
-                  <a:srgbClr val="212121"/>
-                </a:solidFill>
-                <a:latin typeface="Calibri" pitchFamily="34" charset="0"/>
-                <a:ea typeface="Calibri" pitchFamily="34" charset="-122"/>
-                <a:cs typeface="Calibri" pitchFamily="34" charset="-120"/>
-              </a:rPr>
-              <a:t>Requirements Engineering Management Handbook</a:t>
-            </a:r>
-            <a:pPr algn="l" indent="0" marL="0">
-              <a:spcAft>
-                <a:spcPts val="300"/>
-              </a:spcAft>
-              <a:buNone/>
-            </a:pPr>
-            <a:r>
-              <a:rPr lang="en-US" sz="1150" dirty="0">
-                <a:solidFill>
-                  <a:srgbClr val="212121"/>
-                </a:solidFill>
-                <a:latin typeface="Calibri" pitchFamily="34" charset="0"/>
-                <a:ea typeface="Calibri" pitchFamily="34" charset="-122"/>
-                <a:cs typeface="Calibri" pitchFamily="34" charset="-120"/>
-              </a:rPr>
-              <a:t>, DOT/FAA/AR-08/32, 2009</a:t>
-            </a:r>
-            <a:endParaRPr lang="en-US" sz="1400" dirty="0"/>
-          </a:p>
-          <a:p>
-            <a:pPr algn="l" marL="342900" indent="-342900">
-              <a:spcAft>
-                <a:spcPts val="300"/>
-              </a:spcAft>
-              <a:buSzPct val="100000"/>
-              <a:buChar char="•"/>
-            </a:pPr>
-            <a:r>
-              <a:rPr lang="en-US" sz="1150" dirty="0">
-                <a:solidFill>
-                  <a:srgbClr val="212121"/>
-                </a:solidFill>
-                <a:latin typeface="Calibri" pitchFamily="34" charset="0"/>
-                <a:ea typeface="Calibri" pitchFamily="34" charset="-122"/>
-                <a:cs typeface="Calibri" pitchFamily="34" charset="-120"/>
-              </a:rPr>
-              <a:t>INSPECTA models: github.com/loonwerks/INSPECTA-models</a:t>
-            </a:r>
-            <a:endParaRPr lang="en-US" sz="1400" dirty="0"/>
-          </a:p>
-          <a:p>
-            <a:pPr algn="l" indent="0" marL="0">
-              <a:spcBef>
-                <a:spcPts val="1200"/>
-              </a:spcBef>
-              <a:spcAft>
-                <a:spcPts val="400"/>
-              </a:spcAft>
-              <a:buNone/>
-            </a:pPr>
-            <a:r>
-              <a:rPr lang="en-US" sz="1400" b="1" dirty="0">
+              <a:buNone/>
+            </a:pPr>
+            <a:r>
+              <a:rPr lang="en-US" sz="1350" i="1" dirty="0">
                 <a:solidFill>
                   <a:srgbClr val="1E2761"/>
                 </a:solidFill>
@@ -10336,197 +12076,9 @@
                 <a:ea typeface="Calibri" pitchFamily="34" charset="-122"/>
                 <a:cs typeface="Calibri" pitchFamily="34" charset="-120"/>
               </a:rPr>
-              <a:t>Attestation foundations</a:t>
-            </a:r>
-            <a:endParaRPr lang="en-US" sz="1400" dirty="0"/>
-          </a:p>
-          <a:p>
-            <a:pPr algn="l" marL="342900" indent="-342900">
-              <a:spcAft>
-                <a:spcPts val="300"/>
-              </a:spcAft>
-              <a:buSzPct val="100000"/>
-              <a:buChar char="•"/>
-            </a:pPr>
-            <a:r>
-              <a:rPr lang="en-US" sz="1150" dirty="0">
-                <a:solidFill>
-                  <a:srgbClr val="212121"/>
-                </a:solidFill>
-                <a:latin typeface="Calibri" pitchFamily="34" charset="0"/>
-                <a:ea typeface="Calibri" pitchFamily="34" charset="-122"/>
-                <a:cs typeface="Calibri" pitchFamily="34" charset="-120"/>
-              </a:rPr>
-              <a:t>Ramsdell, Rowe, Alexander, Helble, Loscocco, Pendergrass, Petz, </a:t>
-            </a:r>
-            <a:pPr algn="l" indent="0" marL="0">
-              <a:spcAft>
-                <a:spcPts val="300"/>
-              </a:spcAft>
-              <a:buNone/>
-            </a:pPr>
-            <a:r>
-              <a:rPr lang="en-US" sz="1150" i="1" dirty="0">
-                <a:solidFill>
-                  <a:srgbClr val="212121"/>
-                </a:solidFill>
-                <a:latin typeface="Calibri" pitchFamily="34" charset="0"/>
-                <a:ea typeface="Calibri" pitchFamily="34" charset="-122"/>
-                <a:cs typeface="Calibri" pitchFamily="34" charset="-120"/>
-              </a:rPr>
-              <a:t>Orchestrating Layered Attestations</a:t>
-            </a:r>
-            <a:pPr algn="l" indent="0" marL="0">
-              <a:spcAft>
-                <a:spcPts val="300"/>
-              </a:spcAft>
-              <a:buNone/>
-            </a:pPr>
-            <a:r>
-              <a:rPr lang="en-US" sz="1150" dirty="0">
-                <a:solidFill>
-                  <a:srgbClr val="212121"/>
-                </a:solidFill>
-                <a:latin typeface="Calibri" pitchFamily="34" charset="0"/>
-                <a:ea typeface="Calibri" pitchFamily="34" charset="-122"/>
-                <a:cs typeface="Calibri" pitchFamily="34" charset="-120"/>
-              </a:rPr>
-              <a:t>, POST 2019, LNCS 11426</a:t>
-            </a:r>
-            <a:endParaRPr lang="en-US" sz="1400" dirty="0"/>
-          </a:p>
-          <a:p>
-            <a:pPr algn="l" indent="0" marL="0">
-              <a:spcBef>
-                <a:spcPts val="1200"/>
-              </a:spcBef>
-              <a:spcAft>
-                <a:spcPts val="400"/>
-              </a:spcAft>
-              <a:buNone/>
-            </a:pPr>
-            <a:r>
-              <a:rPr lang="en-US" sz="1400" b="1" dirty="0">
-                <a:solidFill>
-                  <a:srgbClr val="1E2761"/>
-                </a:solidFill>
-                <a:latin typeface="Calibri" pitchFamily="34" charset="0"/>
-                <a:ea typeface="Calibri" pitchFamily="34" charset="-122"/>
-                <a:cs typeface="Calibri" pitchFamily="34" charset="-120"/>
-              </a:rPr>
-              <a:t>Verification &amp; platform</a:t>
-            </a:r>
-            <a:endParaRPr lang="en-US" sz="1400" dirty="0"/>
-          </a:p>
-          <a:p>
-            <a:pPr algn="l" marL="342900" indent="-342900">
-              <a:spcAft>
-                <a:spcPts val="300"/>
-              </a:spcAft>
-              <a:buSzPct val="100000"/>
-              <a:buChar char="•"/>
-            </a:pPr>
-            <a:r>
-              <a:rPr lang="en-US" sz="1150" dirty="0">
-                <a:solidFill>
-                  <a:srgbClr val="212121"/>
-                </a:solidFill>
-                <a:latin typeface="Calibri" pitchFamily="34" charset="0"/>
-                <a:ea typeface="Calibri" pitchFamily="34" charset="-122"/>
-                <a:cs typeface="Calibri" pitchFamily="34" charset="-120"/>
-              </a:rPr>
-              <a:t>Lattuada, Hance, Cho, Brun, Subasinghe, Zhou, Howell, Parno, Hawblitzel, </a:t>
-            </a:r>
-            <a:pPr algn="l" indent="0" marL="0">
-              <a:spcAft>
-                <a:spcPts val="300"/>
-              </a:spcAft>
-              <a:buNone/>
-            </a:pPr>
-            <a:r>
-              <a:rPr lang="en-US" sz="1150" i="1" dirty="0">
-                <a:solidFill>
-                  <a:srgbClr val="212121"/>
-                </a:solidFill>
-                <a:latin typeface="Calibri" pitchFamily="34" charset="0"/>
-                <a:ea typeface="Calibri" pitchFamily="34" charset="-122"/>
-                <a:cs typeface="Calibri" pitchFamily="34" charset="-120"/>
-              </a:rPr>
-              <a:t>Verus: Verifying Rust Programs using Linear Ghost Types</a:t>
-            </a:r>
-            <a:pPr algn="l" indent="0" marL="0">
-              <a:spcAft>
-                <a:spcPts val="300"/>
-              </a:spcAft>
-              <a:buNone/>
-            </a:pPr>
-            <a:r>
-              <a:rPr lang="en-US" sz="1150" dirty="0">
-                <a:solidFill>
-                  <a:srgbClr val="212121"/>
-                </a:solidFill>
-                <a:latin typeface="Calibri" pitchFamily="34" charset="0"/>
-                <a:ea typeface="Calibri" pitchFamily="34" charset="-122"/>
-                <a:cs typeface="Calibri" pitchFamily="34" charset="-120"/>
-              </a:rPr>
-              <a:t>, PACMPL 7 (OOPSLA1), 2023</a:t>
-            </a:r>
-            <a:endParaRPr lang="en-US" sz="1400" dirty="0"/>
-          </a:p>
-          <a:p>
-            <a:pPr algn="l" marL="342900" indent="-342900">
-              <a:spcAft>
-                <a:spcPts val="300"/>
-              </a:spcAft>
-              <a:buSzPct val="100000"/>
-              <a:buChar char="•"/>
-            </a:pPr>
-            <a:r>
-              <a:rPr lang="en-US" sz="1150" dirty="0">
-                <a:solidFill>
-                  <a:srgbClr val="212121"/>
-                </a:solidFill>
-                <a:latin typeface="Calibri" pitchFamily="34" charset="0"/>
-                <a:ea typeface="Calibri" pitchFamily="34" charset="-122"/>
-                <a:cs typeface="Calibri" pitchFamily="34" charset="-120"/>
-              </a:rPr>
-              <a:t>Klein et al., </a:t>
-            </a:r>
-            <a:pPr algn="l" indent="0" marL="0">
-              <a:spcAft>
-                <a:spcPts val="300"/>
-              </a:spcAft>
-              <a:buNone/>
-            </a:pPr>
-            <a:r>
-              <a:rPr lang="en-US" sz="1150" i="1" dirty="0">
-                <a:solidFill>
-                  <a:srgbClr val="212121"/>
-                </a:solidFill>
-                <a:latin typeface="Calibri" pitchFamily="34" charset="0"/>
-                <a:ea typeface="Calibri" pitchFamily="34" charset="-122"/>
-                <a:cs typeface="Calibri" pitchFamily="34" charset="-120"/>
-              </a:rPr>
-              <a:t>seL4: Formal Verification of an OS Kernel</a:t>
-            </a:r>
-            <a:pPr algn="l" indent="0" marL="0">
-              <a:spcAft>
-                <a:spcPts val="300"/>
-              </a:spcAft>
-              <a:buNone/>
-            </a:pPr>
-            <a:r>
-              <a:rPr lang="en-US" sz="1150" dirty="0">
-                <a:solidFill>
-                  <a:srgbClr val="212121"/>
-                </a:solidFill>
-                <a:latin typeface="Calibri" pitchFamily="34" charset="0"/>
-                <a:ea typeface="Calibri" pitchFamily="34" charset="-122"/>
-                <a:cs typeface="Calibri" pitchFamily="34" charset="-120"/>
-              </a:rPr>
-              <a:t>, SOSP 2009</a:t>
-            </a:r>
-            <a:endParaRPr lang="en-US" sz="1400" dirty="0"/>
+              <a:t> — defense-in-depth, anomaly detection, mitigation.</a:t>
+            </a:r>
+            <a:endParaRPr lang="en-US" sz="1350" dirty="0"/>
           </a:p>
         </p:txBody>
       </p:sp>
@@ -11079,6 +12631,571 @@
               <a:t>trust is NOT anchored in the following:  developer claims, untrusted tools, LLM outputs, cached verdicts</a:t>
             </a:r>
             <a:endParaRPr lang="en-US" sz="2000" dirty="0"/>
+          </a:p>
+        </p:txBody>
+      </p:sp>
+    </p:spTree>
+  </p:cSld>
+  <p:clrMapOvr>
+    <a:masterClrMapping/>
+  </p:clrMapOvr>
+</p:sld>
+</file>
+
+<file path=ppt/slides/slide20.xml><?xml version="1.0" encoding="utf-8"?>
+<p:sld xmlns:a="http://schemas.openxmlformats.org/drawingml/2006/main" xmlns:r="http://schemas.openxmlformats.org/officeDocument/2006/relationships" xmlns:p="http://schemas.openxmlformats.org/presentationml/2006/main">
+  <p:cSld name="Slide 20">
+    <p:bg>
+      <p:bgPr>
+        <a:solidFill>
+          <a:srgbClr val="FFFFFF"/>
+        </a:solidFill>
+      </p:bgPr>
+    </p:bg>
+    <p:spTree>
+      <p:nvGrpSpPr>
+        <p:cNvPr id="1" name=""/>
+        <p:cNvGrpSpPr/>
+        <p:nvPr/>
+      </p:nvGrpSpPr>
+      <p:grpSpPr>
+        <a:xfrm>
+          <a:off x="0" y="0"/>
+          <a:ext cx="0" cy="0"/>
+          <a:chOff x="0" y="0"/>
+          <a:chExt cx="0" cy="0"/>
+        </a:xfrm>
+      </p:grpSpPr>
+      <p:sp>
+        <p:nvSpPr>
+          <p:cNvPr id="2" name="Text 0"/>
+          <p:cNvSpPr/>
+          <p:nvPr/>
+        </p:nvSpPr>
+        <p:spPr>
+          <a:xfrm>
+            <a:off x="640080" y="411480"/>
+            <a:ext cx="10972800" cy="731520"/>
+          </a:xfrm>
+          <a:prstGeom prst="rect">
+            <a:avLst/>
+          </a:prstGeom>
+          <a:noFill/>
+          <a:ln/>
+        </p:spPr>
+        <p:txBody>
+          <a:bodyPr wrap="square" lIns="0" tIns="0" rIns="0" bIns="0" rtlCol="0" anchor="ctr"/>
+          <a:lstStyle/>
+          <a:p>
+            <a:pPr indent="0" marL="0">
+              <a:buNone/>
+            </a:pPr>
+            <a:r>
+              <a:rPr lang="en-US" sz="3600" b="1" dirty="0">
+                <a:solidFill>
+                  <a:srgbClr val="1E2761"/>
+                </a:solidFill>
+                <a:latin typeface="Cambria" pitchFamily="34" charset="0"/>
+                <a:ea typeface="Cambria" pitchFamily="34" charset="-122"/>
+                <a:cs typeface="Cambria" pitchFamily="34" charset="-120"/>
+              </a:rPr>
+              <a:t>References</a:t>
+            </a:r>
+            <a:endParaRPr lang="en-US" sz="3600" dirty="0"/>
+          </a:p>
+        </p:txBody>
+      </p:sp>
+      <p:sp>
+        <p:nvSpPr>
+          <p:cNvPr id="3" name="Text 1"/>
+          <p:cNvSpPr/>
+          <p:nvPr/>
+        </p:nvSpPr>
+        <p:spPr>
+          <a:xfrm>
+            <a:off x="640080" y="1371600"/>
+            <a:ext cx="10972800" cy="5120640"/>
+          </a:xfrm>
+          <a:prstGeom prst="rect">
+            <a:avLst/>
+          </a:prstGeom>
+          <a:noFill/>
+          <a:ln/>
+        </p:spPr>
+        <p:txBody>
+          <a:bodyPr wrap="square" lIns="0" tIns="0" rIns="0" bIns="0" rtlCol="0" anchor="t"/>
+          <a:lstStyle/>
+          <a:p>
+            <a:pPr algn="l" indent="0" marL="0">
+              <a:spcAft>
+                <a:spcPts val="400"/>
+              </a:spcAft>
+              <a:buNone/>
+            </a:pPr>
+            <a:r>
+              <a:rPr lang="en-US" sz="1400" b="1" dirty="0">
+                <a:solidFill>
+                  <a:srgbClr val="1E2761"/>
+                </a:solidFill>
+                <a:latin typeface="Calibri" pitchFamily="34" charset="0"/>
+                <a:ea typeface="Calibri" pitchFamily="34" charset="-122"/>
+                <a:cs typeface="Calibri" pitchFamily="34" charset="-120"/>
+              </a:rPr>
+              <a:t>The isolette &amp; HAMR (Kansas State)</a:t>
+            </a:r>
+            <a:endParaRPr lang="en-US" sz="1400" dirty="0"/>
+          </a:p>
+          <a:p>
+            <a:pPr algn="l" marL="342900" indent="-342900">
+              <a:spcAft>
+                <a:spcPts val="300"/>
+              </a:spcAft>
+              <a:buSzPct val="100000"/>
+              <a:buChar char="•"/>
+            </a:pPr>
+            <a:r>
+              <a:rPr lang="en-US" sz="1150" dirty="0">
+                <a:solidFill>
+                  <a:srgbClr val="212121"/>
+                </a:solidFill>
+                <a:latin typeface="Calibri" pitchFamily="34" charset="0"/>
+                <a:ea typeface="Calibri" pitchFamily="34" charset="-122"/>
+                <a:cs typeface="Calibri" pitchFamily="34" charset="-120"/>
+              </a:rPr>
+              <a:t>Hatcliff &amp; Belt, </a:t>
+            </a:r>
+            <a:pPr algn="l" indent="0" marL="0">
+              <a:spcAft>
+                <a:spcPts val="300"/>
+              </a:spcAft>
+              <a:buNone/>
+            </a:pPr>
+            <a:r>
+              <a:rPr lang="en-US" sz="1150" i="1" dirty="0">
+                <a:solidFill>
+                  <a:srgbClr val="212121"/>
+                </a:solidFill>
+                <a:latin typeface="Calibri" pitchFamily="34" charset="0"/>
+                <a:ea typeface="Calibri" pitchFamily="34" charset="-122"/>
+                <a:cs typeface="Calibri" pitchFamily="34" charset="-120"/>
+              </a:rPr>
+              <a:t>The Isolette System: Illustrating End-to-End Artifacts for Rigorous Model-Based Engineering</a:t>
+            </a:r>
+            <a:pPr algn="l" indent="0" marL="0">
+              <a:spcAft>
+                <a:spcPts val="300"/>
+              </a:spcAft>
+              <a:buNone/>
+            </a:pPr>
+            <a:r>
+              <a:rPr lang="en-US" sz="1150" dirty="0">
+                <a:solidFill>
+                  <a:srgbClr val="212121"/>
+                </a:solidFill>
+                <a:latin typeface="Calibri" pitchFamily="34" charset="0"/>
+                <a:ea typeface="Calibri" pitchFamily="34" charset="-122"/>
+                <a:cs typeface="Calibri" pitchFamily="34" charset="-120"/>
+              </a:rPr>
+              <a:t>, Springer LNCS 15240, 2025</a:t>
+            </a:r>
+            <a:endParaRPr lang="en-US" sz="1400" dirty="0"/>
+          </a:p>
+          <a:p>
+            <a:pPr algn="l" marL="342900" indent="-342900">
+              <a:spcAft>
+                <a:spcPts val="300"/>
+              </a:spcAft>
+              <a:buSzPct val="100000"/>
+              <a:buChar char="•"/>
+            </a:pPr>
+            <a:r>
+              <a:rPr lang="en-US" sz="1150" dirty="0">
+                <a:solidFill>
+                  <a:srgbClr val="212121"/>
+                </a:solidFill>
+                <a:latin typeface="Calibri" pitchFamily="34" charset="0"/>
+                <a:ea typeface="Calibri" pitchFamily="34" charset="-122"/>
+                <a:cs typeface="Calibri" pitchFamily="34" charset="-120"/>
+              </a:rPr>
+              <a:t>Hatcliff, Belt, Robby, McKenzie, Liang, </a:t>
+            </a:r>
+            <a:pPr algn="l" indent="0" marL="0">
+              <a:spcAft>
+                <a:spcPts val="300"/>
+              </a:spcAft>
+              <a:buNone/>
+            </a:pPr>
+            <a:r>
+              <a:rPr lang="en-US" sz="1150" i="1" dirty="0">
+                <a:solidFill>
+                  <a:srgbClr val="212121"/>
+                </a:solidFill>
+                <a:latin typeface="Calibri" pitchFamily="34" charset="0"/>
+                <a:ea typeface="Calibri" pitchFamily="34" charset="-122"/>
+                <a:cs typeface="Calibri" pitchFamily="34" charset="-120"/>
+              </a:rPr>
+              <a:t>End-to-End Formal Methods Integrated Development with SysMLv2 Using HAMR</a:t>
+            </a:r>
+            <a:pPr algn="l" indent="0" marL="0">
+              <a:spcAft>
+                <a:spcPts val="300"/>
+              </a:spcAft>
+              <a:buNone/>
+            </a:pPr>
+            <a:r>
+              <a:rPr lang="en-US" sz="1150" dirty="0">
+                <a:solidFill>
+                  <a:srgbClr val="212121"/>
+                </a:solidFill>
+                <a:latin typeface="Calibri" pitchFamily="34" charset="0"/>
+                <a:ea typeface="Calibri" pitchFamily="34" charset="-122"/>
+                <a:cs typeface="Calibri" pitchFamily="34" charset="-120"/>
+              </a:rPr>
+              <a:t>, Springer, 2025</a:t>
+            </a:r>
+            <a:endParaRPr lang="en-US" sz="1400" dirty="0"/>
+          </a:p>
+          <a:p>
+            <a:pPr algn="l" marL="342900" indent="-342900">
+              <a:spcAft>
+                <a:spcPts val="300"/>
+              </a:spcAft>
+              <a:buSzPct val="100000"/>
+              <a:buChar char="•"/>
+            </a:pPr>
+            <a:r>
+              <a:rPr lang="en-US" sz="1150" dirty="0">
+                <a:solidFill>
+                  <a:srgbClr val="212121"/>
+                </a:solidFill>
+                <a:latin typeface="Calibri" pitchFamily="34" charset="0"/>
+                <a:ea typeface="Calibri" pitchFamily="34" charset="-122"/>
+                <a:cs typeface="Calibri" pitchFamily="34" charset="-120"/>
+              </a:rPr>
+              <a:t>Hatcliff, Belt, Robby, Carpenter, </a:t>
+            </a:r>
+            <a:pPr algn="l" indent="0" marL="0">
+              <a:spcAft>
+                <a:spcPts val="300"/>
+              </a:spcAft>
+              <a:buNone/>
+            </a:pPr>
+            <a:r>
+              <a:rPr lang="en-US" sz="1150" i="1" dirty="0">
+                <a:solidFill>
+                  <a:srgbClr val="212121"/>
+                </a:solidFill>
+                <a:latin typeface="Calibri" pitchFamily="34" charset="0"/>
+                <a:ea typeface="Calibri" pitchFamily="34" charset="-122"/>
+                <a:cs typeface="Calibri" pitchFamily="34" charset="-120"/>
+              </a:rPr>
+              <a:t>HAMR: An AADL Multi-platform Code Generation Toolset</a:t>
+            </a:r>
+            <a:pPr algn="l" indent="0" marL="0">
+              <a:spcAft>
+                <a:spcPts val="300"/>
+              </a:spcAft>
+              <a:buNone/>
+            </a:pPr>
+            <a:r>
+              <a:rPr lang="en-US" sz="1150" dirty="0">
+                <a:solidFill>
+                  <a:srgbClr val="212121"/>
+                </a:solidFill>
+                <a:latin typeface="Calibri" pitchFamily="34" charset="0"/>
+                <a:ea typeface="Calibri" pitchFamily="34" charset="-122"/>
+                <a:cs typeface="Calibri" pitchFamily="34" charset="-120"/>
+              </a:rPr>
+              <a:t>, ISoLA 2021, LNCS 13036, pp. 274–295</a:t>
+            </a:r>
+            <a:endParaRPr lang="en-US" sz="1400" dirty="0"/>
+          </a:p>
+          <a:p>
+            <a:pPr algn="l" marL="342900" indent="-342900">
+              <a:spcAft>
+                <a:spcPts val="300"/>
+              </a:spcAft>
+              <a:buSzPct val="100000"/>
+              <a:buChar char="•"/>
+            </a:pPr>
+            <a:r>
+              <a:rPr lang="en-US" sz="1150" dirty="0">
+                <a:solidFill>
+                  <a:srgbClr val="212121"/>
+                </a:solidFill>
+                <a:latin typeface="Calibri" pitchFamily="34" charset="0"/>
+                <a:ea typeface="Calibri" pitchFamily="34" charset="-122"/>
+                <a:cs typeface="Calibri" pitchFamily="34" charset="-120"/>
+              </a:rPr>
+              <a:t>Lempia &amp; Miller, </a:t>
+            </a:r>
+            <a:pPr algn="l" indent="0" marL="0">
+              <a:spcAft>
+                <a:spcPts val="300"/>
+              </a:spcAft>
+              <a:buNone/>
+            </a:pPr>
+            <a:r>
+              <a:rPr lang="en-US" sz="1150" i="1" dirty="0">
+                <a:solidFill>
+                  <a:srgbClr val="212121"/>
+                </a:solidFill>
+                <a:latin typeface="Calibri" pitchFamily="34" charset="0"/>
+                <a:ea typeface="Calibri" pitchFamily="34" charset="-122"/>
+                <a:cs typeface="Calibri" pitchFamily="34" charset="-120"/>
+              </a:rPr>
+              <a:t>Requirements Engineering Management Handbook</a:t>
+            </a:r>
+            <a:pPr algn="l" indent="0" marL="0">
+              <a:spcAft>
+                <a:spcPts val="300"/>
+              </a:spcAft>
+              <a:buNone/>
+            </a:pPr>
+            <a:r>
+              <a:rPr lang="en-US" sz="1150" dirty="0">
+                <a:solidFill>
+                  <a:srgbClr val="212121"/>
+                </a:solidFill>
+                <a:latin typeface="Calibri" pitchFamily="34" charset="0"/>
+                <a:ea typeface="Calibri" pitchFamily="34" charset="-122"/>
+                <a:cs typeface="Calibri" pitchFamily="34" charset="-120"/>
+              </a:rPr>
+              <a:t>, DOT/FAA/AR-08/32, 2009</a:t>
+            </a:r>
+            <a:endParaRPr lang="en-US" sz="1400" dirty="0"/>
+          </a:p>
+          <a:p>
+            <a:pPr algn="l" marL="342900" indent="-342900">
+              <a:spcAft>
+                <a:spcPts val="300"/>
+              </a:spcAft>
+              <a:buSzPct val="100000"/>
+              <a:buChar char="•"/>
+            </a:pPr>
+            <a:r>
+              <a:rPr lang="en-US" sz="1150" dirty="0">
+                <a:solidFill>
+                  <a:srgbClr val="212121"/>
+                </a:solidFill>
+                <a:latin typeface="Calibri" pitchFamily="34" charset="0"/>
+                <a:ea typeface="Calibri" pitchFamily="34" charset="-122"/>
+                <a:cs typeface="Calibri" pitchFamily="34" charset="-120"/>
+              </a:rPr>
+              <a:t>INSPECTA models: github.com/loonwerks/INSPECTA-models</a:t>
+            </a:r>
+            <a:endParaRPr lang="en-US" sz="1400" dirty="0"/>
+          </a:p>
+          <a:p>
+            <a:pPr algn="l" indent="0" marL="0">
+              <a:spcBef>
+                <a:spcPts val="1200"/>
+              </a:spcBef>
+              <a:spcAft>
+                <a:spcPts val="400"/>
+              </a:spcAft>
+              <a:buNone/>
+            </a:pPr>
+            <a:r>
+              <a:rPr lang="en-US" sz="1400" b="1" dirty="0">
+                <a:solidFill>
+                  <a:srgbClr val="1E2761"/>
+                </a:solidFill>
+                <a:latin typeface="Calibri" pitchFamily="34" charset="0"/>
+                <a:ea typeface="Calibri" pitchFamily="34" charset="-122"/>
+                <a:cs typeface="Calibri" pitchFamily="34" charset="-120"/>
+              </a:rPr>
+              <a:t>Attestation foundations</a:t>
+            </a:r>
+            <a:endParaRPr lang="en-US" sz="1400" dirty="0"/>
+          </a:p>
+          <a:p>
+            <a:pPr algn="l" marL="342900" indent="-342900">
+              <a:spcAft>
+                <a:spcPts val="300"/>
+              </a:spcAft>
+              <a:buSzPct val="100000"/>
+              <a:buChar char="•"/>
+            </a:pPr>
+            <a:r>
+              <a:rPr lang="en-US" sz="1150" dirty="0">
+                <a:solidFill>
+                  <a:srgbClr val="212121"/>
+                </a:solidFill>
+                <a:latin typeface="Calibri" pitchFamily="34" charset="0"/>
+                <a:ea typeface="Calibri" pitchFamily="34" charset="-122"/>
+                <a:cs typeface="Calibri" pitchFamily="34" charset="-120"/>
+              </a:rPr>
+              <a:t>Ramsdell, Rowe, Alexander, Helble, Loscocco, Pendergrass, Petz, </a:t>
+            </a:r>
+            <a:pPr algn="l" indent="0" marL="0">
+              <a:spcAft>
+                <a:spcPts val="300"/>
+              </a:spcAft>
+              <a:buNone/>
+            </a:pPr>
+            <a:r>
+              <a:rPr lang="en-US" sz="1150" i="1" dirty="0">
+                <a:solidFill>
+                  <a:srgbClr val="212121"/>
+                </a:solidFill>
+                <a:latin typeface="Calibri" pitchFamily="34" charset="0"/>
+                <a:ea typeface="Calibri" pitchFamily="34" charset="-122"/>
+                <a:cs typeface="Calibri" pitchFamily="34" charset="-120"/>
+              </a:rPr>
+              <a:t>Orchestrating Layered Attestations</a:t>
+            </a:r>
+            <a:pPr algn="l" indent="0" marL="0">
+              <a:spcAft>
+                <a:spcPts val="300"/>
+              </a:spcAft>
+              <a:buNone/>
+            </a:pPr>
+            <a:r>
+              <a:rPr lang="en-US" sz="1150" dirty="0">
+                <a:solidFill>
+                  <a:srgbClr val="212121"/>
+                </a:solidFill>
+                <a:latin typeface="Calibri" pitchFamily="34" charset="0"/>
+                <a:ea typeface="Calibri" pitchFamily="34" charset="-122"/>
+                <a:cs typeface="Calibri" pitchFamily="34" charset="-120"/>
+              </a:rPr>
+              <a:t>, POST 2019, LNCS 11426</a:t>
+            </a:r>
+            <a:endParaRPr lang="en-US" sz="1400" dirty="0"/>
+          </a:p>
+          <a:p>
+            <a:pPr algn="l" indent="0" marL="0">
+              <a:spcBef>
+                <a:spcPts val="1200"/>
+              </a:spcBef>
+              <a:spcAft>
+                <a:spcPts val="400"/>
+              </a:spcAft>
+              <a:buNone/>
+            </a:pPr>
+            <a:r>
+              <a:rPr lang="en-US" sz="1400" b="1" dirty="0">
+                <a:solidFill>
+                  <a:srgbClr val="1E2761"/>
+                </a:solidFill>
+                <a:latin typeface="Calibri" pitchFamily="34" charset="0"/>
+                <a:ea typeface="Calibri" pitchFamily="34" charset="-122"/>
+                <a:cs typeface="Calibri" pitchFamily="34" charset="-120"/>
+              </a:rPr>
+              <a:t>Verification &amp; platform</a:t>
+            </a:r>
+            <a:endParaRPr lang="en-US" sz="1400" dirty="0"/>
+          </a:p>
+          <a:p>
+            <a:pPr algn="l" marL="342900" indent="-342900">
+              <a:spcAft>
+                <a:spcPts val="300"/>
+              </a:spcAft>
+              <a:buSzPct val="100000"/>
+              <a:buChar char="•"/>
+            </a:pPr>
+            <a:r>
+              <a:rPr lang="en-US" sz="1150" dirty="0">
+                <a:solidFill>
+                  <a:srgbClr val="212121"/>
+                </a:solidFill>
+                <a:latin typeface="Calibri" pitchFamily="34" charset="0"/>
+                <a:ea typeface="Calibri" pitchFamily="34" charset="-122"/>
+                <a:cs typeface="Calibri" pitchFamily="34" charset="-120"/>
+              </a:rPr>
+              <a:t>Lattuada, Hance, Cho, Brun, Subasinghe, Zhou, Howell, Parno, Hawblitzel, </a:t>
+            </a:r>
+            <a:pPr algn="l" indent="0" marL="0">
+              <a:spcAft>
+                <a:spcPts val="300"/>
+              </a:spcAft>
+              <a:buNone/>
+            </a:pPr>
+            <a:r>
+              <a:rPr lang="en-US" sz="1150" i="1" dirty="0">
+                <a:solidFill>
+                  <a:srgbClr val="212121"/>
+                </a:solidFill>
+                <a:latin typeface="Calibri" pitchFamily="34" charset="0"/>
+                <a:ea typeface="Calibri" pitchFamily="34" charset="-122"/>
+                <a:cs typeface="Calibri" pitchFamily="34" charset="-120"/>
+              </a:rPr>
+              <a:t>Verus: Verifying Rust Programs using Linear Ghost Types</a:t>
+            </a:r>
+            <a:pPr algn="l" indent="0" marL="0">
+              <a:spcAft>
+                <a:spcPts val="300"/>
+              </a:spcAft>
+              <a:buNone/>
+            </a:pPr>
+            <a:r>
+              <a:rPr lang="en-US" sz="1150" dirty="0">
+                <a:solidFill>
+                  <a:srgbClr val="212121"/>
+                </a:solidFill>
+                <a:latin typeface="Calibri" pitchFamily="34" charset="0"/>
+                <a:ea typeface="Calibri" pitchFamily="34" charset="-122"/>
+                <a:cs typeface="Calibri" pitchFamily="34" charset="-120"/>
+              </a:rPr>
+              <a:t>, PACMPL 7 (OOPSLA1), 2023</a:t>
+            </a:r>
+            <a:endParaRPr lang="en-US" sz="1400" dirty="0"/>
+          </a:p>
+          <a:p>
+            <a:pPr algn="l" marL="342900" indent="-342900">
+              <a:spcAft>
+                <a:spcPts val="300"/>
+              </a:spcAft>
+              <a:buSzPct val="100000"/>
+              <a:buChar char="•"/>
+            </a:pPr>
+            <a:r>
+              <a:rPr lang="en-US" sz="1150" dirty="0">
+                <a:solidFill>
+                  <a:srgbClr val="212121"/>
+                </a:solidFill>
+                <a:latin typeface="Calibri" pitchFamily="34" charset="0"/>
+                <a:ea typeface="Calibri" pitchFamily="34" charset="-122"/>
+                <a:cs typeface="Calibri" pitchFamily="34" charset="-120"/>
+              </a:rPr>
+              <a:t>Klein et al., </a:t>
+            </a:r>
+            <a:pPr algn="l" indent="0" marL="0">
+              <a:spcAft>
+                <a:spcPts val="300"/>
+              </a:spcAft>
+              <a:buNone/>
+            </a:pPr>
+            <a:r>
+              <a:rPr lang="en-US" sz="1150" i="1" dirty="0">
+                <a:solidFill>
+                  <a:srgbClr val="212121"/>
+                </a:solidFill>
+                <a:latin typeface="Calibri" pitchFamily="34" charset="0"/>
+                <a:ea typeface="Calibri" pitchFamily="34" charset="-122"/>
+                <a:cs typeface="Calibri" pitchFamily="34" charset="-120"/>
+              </a:rPr>
+              <a:t>seL4: Formal Verification of an OS Kernel</a:t>
+            </a:r>
+            <a:pPr algn="l" indent="0" marL="0">
+              <a:spcAft>
+                <a:spcPts val="300"/>
+              </a:spcAft>
+              <a:buNone/>
+            </a:pPr>
+            <a:r>
+              <a:rPr lang="en-US" sz="1150" dirty="0">
+                <a:solidFill>
+                  <a:srgbClr val="212121"/>
+                </a:solidFill>
+                <a:latin typeface="Calibri" pitchFamily="34" charset="0"/>
+                <a:ea typeface="Calibri" pitchFamily="34" charset="-122"/>
+                <a:cs typeface="Calibri" pitchFamily="34" charset="-120"/>
+              </a:rPr>
+              <a:t>, SOSP 2009</a:t>
+            </a:r>
+            <a:endParaRPr lang="en-US" sz="1400" dirty="0"/>
           </a:p>
         </p:txBody>
       </p:sp>

</xml_diff>

<commit_message>
title slide: author block, DARPA PROVERS sponsor line, pybb gloss, reworded subtitle
- Authors from the HCSS 2026 paper with numbered-superscript affiliations
  (KU, Collins Aerospace, K-State), as a data-driven AUTHORS/AFFILS list
- Sponsor footer: "Supported by the DARPA PROVERS effort (contract FA8750-24-9-1000)"
- Title gloss "(python blackboard)" inline after pybb, py/b/b letters enlarged
- Subtitle reworded and centered on two lines (ported from PowerPoint edits)
- Slide log updated; date is still a placeholder

Co-Authored-By: Claude Fable 5.1 <noreply@anthropic.com>
</commit_message>
<xml_diff>
--- a/docs/video_slides_draft.pptx
+++ b/docs/video_slides_draft.pptx
@@ -521,7 +521,7 @@
           <a:p>
             <a:r>
               <a:rPr lang="en-US" dirty="0"/>
-              <a:t>Title card. Subtitle deliberately names the four core artifact classes - the deck's first echo of the artifact-class table (slide 6). Optional footer: INSPECTA program context.</a:t>
+              <a:t>Title card. Subtitle deliberately names the four core artifact classes - the deck's first echo of the artifact-class table (slide 6). Footer: DARPA PROVERS sponsor acknowledgment with contract number (INSPECTA is the team's project under PROVERS).</a:t>
             </a:r>
             <a:endParaRPr lang="en-US" dirty="0"/>
           </a:p>
@@ -2613,7 +2613,7 @@
         <p:spPr>
           <a:xfrm>
             <a:off x="822960" y="2194560"/>
-            <a:ext cx="10515600" cy="1097280"/>
+            <a:ext cx="10972800" cy="1097280"/>
           </a:xfrm>
           <a:prstGeom prst="rect">
             <a:avLst/>
@@ -2639,6 +2639,104 @@
               </a:rPr>
               <a:t>Lifecycle Attestation with pybb</a:t>
             </a:r>
+            <a:pPr algn="l" indent="0" marL="0">
+              <a:buNone/>
+            </a:pPr>
+            <a:r>
+              <a:rPr lang="en-US" sz="2200" i="1" dirty="0">
+                <a:solidFill>
+                  <a:srgbClr val="CADCFC"/>
+                </a:solidFill>
+                <a:latin typeface="Calibri" pitchFamily="34" charset="0"/>
+                <a:ea typeface="Calibri" pitchFamily="34" charset="-122"/>
+                <a:cs typeface="Calibri" pitchFamily="34" charset="-120"/>
+              </a:rPr>
+              <a:t> (</a:t>
+            </a:r>
+            <a:pPr algn="l" indent="0" marL="0">
+              <a:buNone/>
+            </a:pPr>
+            <a:r>
+              <a:rPr lang="en-US" sz="3600" b="1" i="1" dirty="0">
+                <a:solidFill>
+                  <a:srgbClr val="CADCFC"/>
+                </a:solidFill>
+                <a:latin typeface="Calibri" pitchFamily="34" charset="0"/>
+                <a:ea typeface="Calibri" pitchFamily="34" charset="-122"/>
+                <a:cs typeface="Calibri" pitchFamily="34" charset="-120"/>
+              </a:rPr>
+              <a:t>py</a:t>
+            </a:r>
+            <a:pPr algn="l" indent="0" marL="0">
+              <a:buNone/>
+            </a:pPr>
+            <a:r>
+              <a:rPr lang="en-US" sz="2200" i="1" dirty="0">
+                <a:solidFill>
+                  <a:srgbClr val="CADCFC"/>
+                </a:solidFill>
+                <a:latin typeface="Calibri" pitchFamily="34" charset="0"/>
+                <a:ea typeface="Calibri" pitchFamily="34" charset="-122"/>
+                <a:cs typeface="Calibri" pitchFamily="34" charset="-120"/>
+              </a:rPr>
+              <a:t>thon </a:t>
+            </a:r>
+            <a:pPr algn="l" indent="0" marL="0">
+              <a:buNone/>
+            </a:pPr>
+            <a:r>
+              <a:rPr lang="en-US" sz="3600" b="1" i="1" dirty="0">
+                <a:solidFill>
+                  <a:srgbClr val="CADCFC"/>
+                </a:solidFill>
+                <a:latin typeface="Calibri" pitchFamily="34" charset="0"/>
+                <a:ea typeface="Calibri" pitchFamily="34" charset="-122"/>
+                <a:cs typeface="Calibri" pitchFamily="34" charset="-120"/>
+              </a:rPr>
+              <a:t>b</a:t>
+            </a:r>
+            <a:pPr algn="l" indent="0" marL="0">
+              <a:buNone/>
+            </a:pPr>
+            <a:r>
+              <a:rPr lang="en-US" sz="2200" i="1" dirty="0">
+                <a:solidFill>
+                  <a:srgbClr val="CADCFC"/>
+                </a:solidFill>
+                <a:latin typeface="Calibri" pitchFamily="34" charset="0"/>
+                <a:ea typeface="Calibri" pitchFamily="34" charset="-122"/>
+                <a:cs typeface="Calibri" pitchFamily="34" charset="-120"/>
+              </a:rPr>
+              <a:t>lack</a:t>
+            </a:r>
+            <a:pPr algn="l" indent="0" marL="0">
+              <a:buNone/>
+            </a:pPr>
+            <a:r>
+              <a:rPr lang="en-US" sz="3600" b="1" i="1" dirty="0">
+                <a:solidFill>
+                  <a:srgbClr val="CADCFC"/>
+                </a:solidFill>
+                <a:latin typeface="Calibri" pitchFamily="34" charset="0"/>
+                <a:ea typeface="Calibri" pitchFamily="34" charset="-122"/>
+                <a:cs typeface="Calibri" pitchFamily="34" charset="-120"/>
+              </a:rPr>
+              <a:t>b</a:t>
+            </a:r>
+            <a:pPr algn="l" indent="0" marL="0">
+              <a:buNone/>
+            </a:pPr>
+            <a:r>
+              <a:rPr lang="en-US" sz="2200" i="1" dirty="0">
+                <a:solidFill>
+                  <a:srgbClr val="CADCFC"/>
+                </a:solidFill>
+                <a:latin typeface="Calibri" pitchFamily="34" charset="0"/>
+                <a:ea typeface="Calibri" pitchFamily="34" charset="-122"/>
+                <a:cs typeface="Calibri" pitchFamily="34" charset="-120"/>
+              </a:rPr>
+              <a:t>oard)</a:t>
+            </a:r>
             <a:endParaRPr lang="en-US" sz="4400" dirty="0"/>
           </a:p>
         </p:txBody>
@@ -2664,7 +2762,7 @@
           <a:bodyPr wrap="square" lIns="0" tIns="0" rIns="0" bIns="0" rtlCol="0" anchor="ctr"/>
           <a:lstStyle/>
           <a:p>
-            <a:pPr algn="l" indent="0" marL="0">
+            <a:pPr algn="ctr" indent="0" marL="0">
               <a:buNone/>
             </a:pPr>
             <a:r>
@@ -2676,10 +2774,27 @@
                 <a:ea typeface="Calibri" pitchFamily="34" charset="-122"/>
                 <a:cs typeface="Calibri" pitchFamily="34" charset="-120"/>
               </a:rPr>
-              <a:t>Measured trust across models, contracts, implementations, and proofs</a:t>
+              <a:t>Measured trust across models, contracts, code, and proofs in </a:t>
             </a:r>
             <a:endParaRPr lang="en-US" sz="2000" dirty="0"/>
           </a:p>
+          <a:p>
+            <a:pPr algn="ctr" indent="0" marL="0">
+              <a:buNone/>
+            </a:pPr>
+            <a:r>
+              <a:rPr lang="en-US" sz="2000" i="1" dirty="0">
+                <a:solidFill>
+                  <a:srgbClr val="CADCFC"/>
+                </a:solidFill>
+                <a:latin typeface="Calibri" pitchFamily="34" charset="0"/>
+                <a:ea typeface="Calibri" pitchFamily="34" charset="-122"/>
+                <a:cs typeface="Calibri" pitchFamily="34" charset="-120"/>
+              </a:rPr>
+              <a:t>high assurance, LLM-assisted development pipelines</a:t>
+            </a:r>
+            <a:endParaRPr lang="en-US" sz="2000" dirty="0"/>
+          </a:p>
         </p:txBody>
       </p:sp>
       <p:sp>
@@ -2690,8 +2805,8 @@
         </p:nvSpPr>
         <p:spPr>
           <a:xfrm>
-            <a:off x="822960" y="5760720"/>
-            <a:ext cx="10515600" cy="365760"/>
+            <a:off x="822960" y="4754880"/>
+            <a:ext cx="10515600" cy="868680"/>
           </a:xfrm>
           <a:prstGeom prst="rect">
             <a:avLst/>
@@ -2700,6 +2815,300 @@
           <a:ln/>
         </p:spPr>
         <p:txBody>
+          <a:bodyPr wrap="square" lIns="0" tIns="0" rIns="0" bIns="0" rtlCol="0" anchor="b"/>
+          <a:lstStyle/>
+          <a:p>
+            <a:pPr algn="l" indent="0" marL="0">
+              <a:buNone/>
+            </a:pPr>
+            <a:r>
+              <a:rPr lang="en-US" sz="1600" dirty="0">
+                <a:solidFill>
+                  <a:srgbClr val="CADCFC"/>
+                </a:solidFill>
+                <a:latin typeface="Calibri" pitchFamily="34" charset="0"/>
+                <a:ea typeface="Calibri" pitchFamily="34" charset="-122"/>
+                <a:cs typeface="Calibri" pitchFamily="34" charset="-120"/>
+              </a:rPr>
+              <a:t>Adam Petz</a:t>
+            </a:r>
+            <a:pPr algn="l" indent="0" marL="0">
+              <a:buNone/>
+            </a:pPr>
+            <a:r>
+              <a:rPr lang="en-US" sz="1600" baseline="30000" dirty="0">
+                <a:solidFill>
+                  <a:srgbClr val="CADCFC"/>
+                </a:solidFill>
+                <a:latin typeface="Calibri" pitchFamily="34" charset="0"/>
+                <a:ea typeface="Calibri" pitchFamily="34" charset="-122"/>
+                <a:cs typeface="Calibri" pitchFamily="34" charset="-120"/>
+              </a:rPr>
+              <a:t>1</a:t>
+            </a:r>
+            <a:pPr algn="l" indent="0" marL="0">
+              <a:buNone/>
+            </a:pPr>
+            <a:r>
+              <a:rPr lang="en-US" sz="1600" dirty="0">
+                <a:solidFill>
+                  <a:srgbClr val="CADCFC"/>
+                </a:solidFill>
+                <a:latin typeface="Calibri" pitchFamily="34" charset="0"/>
+                <a:ea typeface="Calibri" pitchFamily="34" charset="-122"/>
+                <a:cs typeface="Calibri" pitchFamily="34" charset="-120"/>
+              </a:rPr>
+              <a:t>, Isaac Amundson</a:t>
+            </a:r>
+            <a:pPr algn="l" indent="0" marL="0">
+              <a:buNone/>
+            </a:pPr>
+            <a:r>
+              <a:rPr lang="en-US" sz="1600" baseline="30000" dirty="0">
+                <a:solidFill>
+                  <a:srgbClr val="CADCFC"/>
+                </a:solidFill>
+                <a:latin typeface="Calibri" pitchFamily="34" charset="0"/>
+                <a:ea typeface="Calibri" pitchFamily="34" charset="-122"/>
+                <a:cs typeface="Calibri" pitchFamily="34" charset="-120"/>
+              </a:rPr>
+              <a:t>2</a:t>
+            </a:r>
+            <a:pPr algn="l" indent="0" marL="0">
+              <a:buNone/>
+            </a:pPr>
+            <a:r>
+              <a:rPr lang="en-US" sz="1600" dirty="0">
+                <a:solidFill>
+                  <a:srgbClr val="CADCFC"/>
+                </a:solidFill>
+                <a:latin typeface="Calibri" pitchFamily="34" charset="0"/>
+                <a:ea typeface="Calibri" pitchFamily="34" charset="-122"/>
+                <a:cs typeface="Calibri" pitchFamily="34" charset="-120"/>
+              </a:rPr>
+              <a:t>, Timothy Barclay</a:t>
+            </a:r>
+            <a:pPr algn="l" indent="0" marL="0">
+              <a:buNone/>
+            </a:pPr>
+            <a:r>
+              <a:rPr lang="en-US" sz="1600" baseline="30000" dirty="0">
+                <a:solidFill>
+                  <a:srgbClr val="CADCFC"/>
+                </a:solidFill>
+                <a:latin typeface="Calibri" pitchFamily="34" charset="0"/>
+                <a:ea typeface="Calibri" pitchFamily="34" charset="-122"/>
+                <a:cs typeface="Calibri" pitchFamily="34" charset="-120"/>
+              </a:rPr>
+              <a:t>2</a:t>
+            </a:r>
+            <a:pPr algn="l" indent="0" marL="0">
+              <a:buNone/>
+            </a:pPr>
+            <a:r>
+              <a:rPr lang="en-US" sz="1600" dirty="0">
+                <a:solidFill>
+                  <a:srgbClr val="CADCFC"/>
+                </a:solidFill>
+                <a:latin typeface="Calibri" pitchFamily="34" charset="0"/>
+                <a:ea typeface="Calibri" pitchFamily="34" charset="-122"/>
+                <a:cs typeface="Calibri" pitchFamily="34" charset="-120"/>
+              </a:rPr>
+              <a:t>, David Hardin</a:t>
+            </a:r>
+            <a:pPr algn="l" indent="0" marL="0">
+              <a:buNone/>
+            </a:pPr>
+            <a:r>
+              <a:rPr lang="en-US" sz="1600" baseline="30000" dirty="0">
+                <a:solidFill>
+                  <a:srgbClr val="CADCFC"/>
+                </a:solidFill>
+                <a:latin typeface="Calibri" pitchFamily="34" charset="0"/>
+                <a:ea typeface="Calibri" pitchFamily="34" charset="-122"/>
+                <a:cs typeface="Calibri" pitchFamily="34" charset="-120"/>
+              </a:rPr>
+              <a:t>2</a:t>
+            </a:r>
+            <a:pPr algn="l" indent="0" marL="0">
+              <a:buNone/>
+            </a:pPr>
+            <a:r>
+              <a:rPr lang="en-US" sz="1600" dirty="0">
+                <a:solidFill>
+                  <a:srgbClr val="CADCFC"/>
+                </a:solidFill>
+                <a:latin typeface="Calibri" pitchFamily="34" charset="0"/>
+                <a:ea typeface="Calibri" pitchFamily="34" charset="-122"/>
+                <a:cs typeface="Calibri" pitchFamily="34" charset="-120"/>
+              </a:rPr>
+              <a:t>, Jason Belt</a:t>
+            </a:r>
+            <a:pPr algn="l" indent="0" marL="0">
+              <a:buNone/>
+            </a:pPr>
+            <a:r>
+              <a:rPr lang="en-US" sz="1600" baseline="30000" dirty="0">
+                <a:solidFill>
+                  <a:srgbClr val="CADCFC"/>
+                </a:solidFill>
+                <a:latin typeface="Calibri" pitchFamily="34" charset="0"/>
+                <a:ea typeface="Calibri" pitchFamily="34" charset="-122"/>
+                <a:cs typeface="Calibri" pitchFamily="34" charset="-120"/>
+              </a:rPr>
+              <a:t>3</a:t>
+            </a:r>
+            <a:pPr algn="l" indent="0" marL="0">
+              <a:buNone/>
+            </a:pPr>
+            <a:r>
+              <a:rPr lang="en-US" sz="1600" dirty="0">
+                <a:solidFill>
+                  <a:srgbClr val="CADCFC"/>
+                </a:solidFill>
+                <a:latin typeface="Calibri" pitchFamily="34" charset="0"/>
+                <a:ea typeface="Calibri" pitchFamily="34" charset="-122"/>
+                <a:cs typeface="Calibri" pitchFamily="34" charset="-120"/>
+              </a:rPr>
+              <a:t>, John Hatcliff</a:t>
+            </a:r>
+            <a:pPr algn="l" indent="0" marL="0">
+              <a:buNone/>
+            </a:pPr>
+            <a:r>
+              <a:rPr lang="en-US" sz="1600" baseline="30000" dirty="0">
+                <a:solidFill>
+                  <a:srgbClr val="CADCFC"/>
+                </a:solidFill>
+                <a:latin typeface="Calibri" pitchFamily="34" charset="0"/>
+                <a:ea typeface="Calibri" pitchFamily="34" charset="-122"/>
+                <a:cs typeface="Calibri" pitchFamily="34" charset="-120"/>
+              </a:rPr>
+              <a:t>3</a:t>
+            </a:r>
+            <a:pPr algn="l" indent="0" marL="0">
+              <a:buNone/>
+            </a:pPr>
+            <a:r>
+              <a:rPr lang="en-US" sz="1600" dirty="0">
+                <a:solidFill>
+                  <a:srgbClr val="CADCFC"/>
+                </a:solidFill>
+                <a:latin typeface="Calibri" pitchFamily="34" charset="0"/>
+                <a:ea typeface="Calibri" pitchFamily="34" charset="-122"/>
+                <a:cs typeface="Calibri" pitchFamily="34" charset="-120"/>
+              </a:rPr>
+              <a:t>,</a:t>
+            </a:r>
+            <a:endParaRPr lang="en-US" sz="1600" dirty="0"/>
+          </a:p>
+          <a:p>
+            <a:pPr algn="l" indent="0" marL="0">
+              <a:buNone/>
+            </a:pPr>
+            <a:r>
+              <a:rPr lang="en-US" sz="1600" dirty="0">
+                <a:solidFill>
+                  <a:srgbClr val="CADCFC"/>
+                </a:solidFill>
+                <a:latin typeface="Calibri" pitchFamily="34" charset="0"/>
+                <a:ea typeface="Calibri" pitchFamily="34" charset="-122"/>
+                <a:cs typeface="Calibri" pitchFamily="34" charset="-120"/>
+              </a:rPr>
+              <a:t>Anakha Krishna</a:t>
+            </a:r>
+            <a:pPr algn="l" indent="0" marL="0">
+              <a:buNone/>
+            </a:pPr>
+            <a:r>
+              <a:rPr lang="en-US" sz="1600" baseline="30000" dirty="0">
+                <a:solidFill>
+                  <a:srgbClr val="CADCFC"/>
+                </a:solidFill>
+                <a:latin typeface="Calibri" pitchFamily="34" charset="0"/>
+                <a:ea typeface="Calibri" pitchFamily="34" charset="-122"/>
+                <a:cs typeface="Calibri" pitchFamily="34" charset="-120"/>
+              </a:rPr>
+              <a:t>1</a:t>
+            </a:r>
+            <a:pPr algn="l" indent="0" marL="0">
+              <a:buNone/>
+            </a:pPr>
+            <a:r>
+              <a:rPr lang="en-US" sz="1600" dirty="0">
+                <a:solidFill>
+                  <a:srgbClr val="CADCFC"/>
+                </a:solidFill>
+                <a:latin typeface="Calibri" pitchFamily="34" charset="0"/>
+                <a:ea typeface="Calibri" pitchFamily="34" charset="-122"/>
+                <a:cs typeface="Calibri" pitchFamily="34" charset="-120"/>
+              </a:rPr>
+              <a:t>, Ina Harris</a:t>
+            </a:r>
+            <a:pPr algn="l" indent="0" marL="0">
+              <a:buNone/>
+            </a:pPr>
+            <a:r>
+              <a:rPr lang="en-US" sz="1600" baseline="30000" dirty="0">
+                <a:solidFill>
+                  <a:srgbClr val="CADCFC"/>
+                </a:solidFill>
+                <a:latin typeface="Calibri" pitchFamily="34" charset="0"/>
+                <a:ea typeface="Calibri" pitchFamily="34" charset="-122"/>
+                <a:cs typeface="Calibri" pitchFamily="34" charset="-120"/>
+              </a:rPr>
+              <a:t>1</a:t>
+            </a:r>
+            <a:pPr algn="l" indent="0" marL="0">
+              <a:buNone/>
+            </a:pPr>
+            <a:r>
+              <a:rPr lang="en-US" sz="1600" dirty="0">
+                <a:solidFill>
+                  <a:srgbClr val="CADCFC"/>
+                </a:solidFill>
+                <a:latin typeface="Calibri" pitchFamily="34" charset="0"/>
+                <a:ea typeface="Calibri" pitchFamily="34" charset="-122"/>
+                <a:cs typeface="Calibri" pitchFamily="34" charset="-120"/>
+              </a:rPr>
+              <a:t>, Perry Alexander</a:t>
+            </a:r>
+            <a:pPr algn="l" indent="0" marL="0">
+              <a:buNone/>
+            </a:pPr>
+            <a:r>
+              <a:rPr lang="en-US" sz="1600" baseline="30000" dirty="0">
+                <a:solidFill>
+                  <a:srgbClr val="CADCFC"/>
+                </a:solidFill>
+                <a:latin typeface="Calibri" pitchFamily="34" charset="0"/>
+                <a:ea typeface="Calibri" pitchFamily="34" charset="-122"/>
+                <a:cs typeface="Calibri" pitchFamily="34" charset="-120"/>
+              </a:rPr>
+              <a:t>1</a:t>
+            </a:r>
+            <a:endParaRPr lang="en-US" sz="1600" dirty="0"/>
+          </a:p>
+        </p:txBody>
+      </p:sp>
+      <p:sp>
+        <p:nvSpPr>
+          <p:cNvPr id="5" name="Text 3"/>
+          <p:cNvSpPr/>
+          <p:nvPr/>
+        </p:nvSpPr>
+        <p:spPr>
+          <a:xfrm>
+            <a:off x="822960" y="5669280"/>
+            <a:ext cx="10515600" cy="320040"/>
+          </a:xfrm>
+          <a:prstGeom prst="rect">
+            <a:avLst/>
+          </a:prstGeom>
+          <a:noFill/>
+          <a:ln/>
+        </p:spPr>
+        <p:txBody>
           <a:bodyPr wrap="square" lIns="0" tIns="0" rIns="0" bIns="0" rtlCol="0" anchor="ctr"/>
           <a:lstStyle/>
           <a:p>
@@ -2707,7 +3116,7 @@
               <a:buNone/>
             </a:pPr>
             <a:r>
-              <a:rPr lang="en-US" sz="1400" dirty="0">
+              <a:rPr lang="en-US" sz="1300" baseline="30000" dirty="0">
                 <a:solidFill>
                   <a:srgbClr val="CADCFC"/>
                 </a:solidFill>
@@ -2715,9 +3124,157 @@
                 <a:ea typeface="Calibri" pitchFamily="34" charset="-122"/>
                 <a:cs typeface="Calibri" pitchFamily="34" charset="-120"/>
               </a:rPr>
-              <a:t>Presenter name  ·  affiliation  ·  date</a:t>
-            </a:r>
-            <a:endParaRPr lang="en-US" sz="1400" dirty="0"/>
+              <a:t>1</a:t>
+            </a:r>
+            <a:pPr algn="l" indent="0" marL="0">
+              <a:buNone/>
+            </a:pPr>
+            <a:r>
+              <a:rPr lang="en-US" sz="1300" dirty="0">
+                <a:solidFill>
+                  <a:srgbClr val="CADCFC"/>
+                </a:solidFill>
+                <a:latin typeface="Calibri" pitchFamily="34" charset="0"/>
+                <a:ea typeface="Calibri" pitchFamily="34" charset="-122"/>
+                <a:cs typeface="Calibri" pitchFamily="34" charset="-120"/>
+              </a:rPr>
+              <a:t>University of Kansas</a:t>
+            </a:r>
+            <a:pPr algn="l" indent="0" marL="0">
+              <a:buNone/>
+            </a:pPr>
+            <a:r>
+              <a:rPr lang="en-US" sz="1300" baseline="30000" dirty="0">
+                <a:solidFill>
+                  <a:srgbClr val="CADCFC"/>
+                </a:solidFill>
+                <a:latin typeface="Calibri" pitchFamily="34" charset="0"/>
+                <a:ea typeface="Calibri" pitchFamily="34" charset="-122"/>
+                <a:cs typeface="Calibri" pitchFamily="34" charset="-120"/>
+              </a:rPr>
+              <a:t>    2</a:t>
+            </a:r>
+            <a:pPr algn="l" indent="0" marL="0">
+              <a:buNone/>
+            </a:pPr>
+            <a:r>
+              <a:rPr lang="en-US" sz="1300" dirty="0">
+                <a:solidFill>
+                  <a:srgbClr val="CADCFC"/>
+                </a:solidFill>
+                <a:latin typeface="Calibri" pitchFamily="34" charset="0"/>
+                <a:ea typeface="Calibri" pitchFamily="34" charset="-122"/>
+                <a:cs typeface="Calibri" pitchFamily="34" charset="-120"/>
+              </a:rPr>
+              <a:t>Collins Aerospace</a:t>
+            </a:r>
+            <a:pPr algn="l" indent="0" marL="0">
+              <a:buNone/>
+            </a:pPr>
+            <a:r>
+              <a:rPr lang="en-US" sz="1300" baseline="30000" dirty="0">
+                <a:solidFill>
+                  <a:srgbClr val="CADCFC"/>
+                </a:solidFill>
+                <a:latin typeface="Calibri" pitchFamily="34" charset="0"/>
+                <a:ea typeface="Calibri" pitchFamily="34" charset="-122"/>
+                <a:cs typeface="Calibri" pitchFamily="34" charset="-120"/>
+              </a:rPr>
+              <a:t>    3</a:t>
+            </a:r>
+            <a:pPr algn="l" indent="0" marL="0">
+              <a:buNone/>
+            </a:pPr>
+            <a:r>
+              <a:rPr lang="en-US" sz="1300" dirty="0">
+                <a:solidFill>
+                  <a:srgbClr val="CADCFC"/>
+                </a:solidFill>
+                <a:latin typeface="Calibri" pitchFamily="34" charset="0"/>
+                <a:ea typeface="Calibri" pitchFamily="34" charset="-122"/>
+                <a:cs typeface="Calibri" pitchFamily="34" charset="-120"/>
+              </a:rPr>
+              <a:t>Kansas State University</a:t>
+            </a:r>
+            <a:endParaRPr lang="en-US" sz="1300" dirty="0"/>
+          </a:p>
+        </p:txBody>
+      </p:sp>
+      <p:sp>
+        <p:nvSpPr>
+          <p:cNvPr id="6" name="Text 4"/>
+          <p:cNvSpPr/>
+          <p:nvPr/>
+        </p:nvSpPr>
+        <p:spPr>
+          <a:xfrm>
+            <a:off x="822960" y="6035040"/>
+            <a:ext cx="4572000" cy="320040"/>
+          </a:xfrm>
+          <a:prstGeom prst="rect">
+            <a:avLst/>
+          </a:prstGeom>
+          <a:noFill/>
+          <a:ln/>
+        </p:spPr>
+        <p:txBody>
+          <a:bodyPr wrap="square" lIns="0" tIns="0" rIns="0" bIns="0" rtlCol="0" anchor="ctr"/>
+          <a:lstStyle/>
+          <a:p>
+            <a:pPr algn="l" indent="0" marL="0">
+              <a:buNone/>
+            </a:pPr>
+            <a:r>
+              <a:rPr lang="en-US" sz="1300" dirty="0">
+                <a:solidFill>
+                  <a:srgbClr val="CADCFC"/>
+                </a:solidFill>
+                <a:latin typeface="Calibri" pitchFamily="34" charset="0"/>
+                <a:ea typeface="Calibri" pitchFamily="34" charset="-122"/>
+                <a:cs typeface="Calibri" pitchFamily="34" charset="-120"/>
+              </a:rPr>
+              <a:t>September 2026</a:t>
+            </a:r>
+            <a:endParaRPr lang="en-US" sz="1300" dirty="0"/>
+          </a:p>
+        </p:txBody>
+      </p:sp>
+      <p:sp>
+        <p:nvSpPr>
+          <p:cNvPr id="7" name="Text 5"/>
+          <p:cNvSpPr/>
+          <p:nvPr/>
+        </p:nvSpPr>
+        <p:spPr>
+          <a:xfrm>
+            <a:off x="5394960" y="6035040"/>
+            <a:ext cx="5943600" cy="320040"/>
+          </a:xfrm>
+          <a:prstGeom prst="rect">
+            <a:avLst/>
+          </a:prstGeom>
+          <a:noFill/>
+          <a:ln/>
+        </p:spPr>
+        <p:txBody>
+          <a:bodyPr wrap="square" lIns="0" tIns="0" rIns="0" bIns="0" rtlCol="0" anchor="ctr"/>
+          <a:lstStyle/>
+          <a:p>
+            <a:pPr algn="r" indent="0" marL="0">
+              <a:buNone/>
+            </a:pPr>
+            <a:r>
+              <a:rPr lang="en-US" sz="1200" dirty="0">
+                <a:solidFill>
+                  <a:srgbClr val="CADCFC"/>
+                </a:solidFill>
+                <a:latin typeface="Calibri" pitchFamily="34" charset="0"/>
+                <a:ea typeface="Calibri" pitchFamily="34" charset="-122"/>
+                <a:cs typeface="Calibri" pitchFamily="34" charset="-120"/>
+              </a:rPr>
+              <a:t>Supported by the DARPA PROVERS effort (contract FA8750-24-9-1000)</a:t>
+            </a:r>
+            <a:endParaRPr lang="en-US" sz="1200" dirty="0"/>
           </a:p>
         </p:txBody>
       </p:sp>

</xml_diff>

<commit_message>
slides 2-4: roadmap first, lifecycle-event wording, tighter Copland labels (ported PowerPoint edits)
- Swap deck positions 2 and 3: Roadmap strip now precedes the lifecycle
  attestation slide; on-slide "Section headers provisional" caption removed
- Lifecycle slide: title capitalized, events reworded to natural lifecycle
  events (specification drift / toolchain updates / artifact updates,
  synthesis, repair), banner nudged up, subline capitalized
- Core stack: Copland description trimmed, "Copland Virtual Machine (CVM)",
  snippet caption and summary reworded
- Slide log updated to match

Co-Authored-By: Claude Fable 5.1 <noreply@anthropic.com>
</commit_message>
<xml_diff>
--- a/docs/video_slides_draft.pptx
+++ b/docs/video_slides_draft.pptx
@@ -1505,10 +1505,8 @@
           <a:p>
             <a:r>
               <a:rPr lang="en-US" dirty="0"/>
-              <a:t>Promise the audience every demo scene echoes the banner.
-The administrator's bless survives 'every': authority enters the system only AS signed evidence (the blessed baseline), never by assertion - scene 6's laundering beat proves exactly that.
-Subline payoffs: developer claims -&gt; scenes 5/7; untrusted tools -&gt; scene 7; LLM outputs -&gt; capstone slides A/B; cached verdicts -&gt; scene 11.
-Visual TODO: three-stage widening-scope progression (boot-time -&gt; layered runtime -&gt; lifecycle loop) to replace/join the bullets.</a:t>
+              <a:t>~15 seconds on first appearance; afterwards it rides on transition slides for free.
+Design decision: one master/layout holds the strip text so a section rename is a single edit. Header titles are provisional.</a:t>
             </a:r>
             <a:endParaRPr lang="en-US" dirty="0"/>
           </a:p>
@@ -1685,8 +1683,10 @@
           <a:p>
             <a:r>
               <a:rPr lang="en-US" dirty="0"/>
-              <a:t>~15 seconds on first appearance; afterwards it rides on transition slides for free.
-Design decision: one master/layout holds the strip text so a section rename is a single edit. Header titles are provisional.</a:t>
+              <a:t>Promise the audience every demo scene echoes the banner.
+The administrator's bless survives 'every': authority enters the system only AS signed evidence (the blessed baseline), never by assertion - scene 6's laundering beat proves exactly that.
+Subline payoffs: developer claims -&gt; scenes 5/7; untrusted tools -&gt; scene 7; LLM outputs -&gt; capstone slides A/B; cached verdicts -&gt; scene 11.
+Visual TODO: three-stage widening-scope progression (boot-time -&gt; layered runtime -&gt; lifecycle loop) to replace/join the bullets.</a:t>
             </a:r>
             <a:endParaRPr lang="en-US" dirty="0"/>
           </a:p>
@@ -12704,7 +12704,7 @@
                 <a:ea typeface="Cambria" pitchFamily="34" charset="-122"/>
                 <a:cs typeface="Cambria" pitchFamily="34" charset="-120"/>
               </a:rPr>
-              <a:t>What is lifecycle attestation?</a:t>
+              <a:t>Roadmap</a:t>
             </a:r>
             <a:endParaRPr lang="en-US" sz="3600" dirty="0"/>
           </a:p>
@@ -12712,418 +12712,18 @@
       </p:sp>
       <p:sp>
         <p:nvSpPr>
-          <p:cNvPr id="3" name="Text 1"/>
-          <p:cNvSpPr/>
-          <p:nvPr/>
-        </p:nvSpPr>
-        <p:spPr>
-          <a:xfrm>
-            <a:off x="640080" y="1325880"/>
-            <a:ext cx="10972800" cy="3566160"/>
-          </a:xfrm>
-          <a:prstGeom prst="rect">
-            <a:avLst/>
-          </a:prstGeom>
-          <a:noFill/>
-          <a:ln/>
-        </p:spPr>
-        <p:txBody>
-          <a:bodyPr wrap="square" lIns="0" tIns="0" rIns="0" bIns="0" rtlCol="0" anchor="t"/>
-          <a:lstStyle/>
-          <a:p>
-            <a:pPr algn="l" marL="342900" indent="-342900">
-              <a:buSzPct val="100000"/>
-              <a:buChar char="•"/>
-            </a:pPr>
-            <a:r>
-              <a:rPr lang="en-US" sz="1700" b="1" dirty="0">
-                <a:solidFill>
-                  <a:srgbClr val="212121"/>
-                </a:solidFill>
-                <a:latin typeface="Calibri" pitchFamily="34" charset="0"/>
-                <a:ea typeface="Calibri" pitchFamily="34" charset="-122"/>
-                <a:cs typeface="Calibri" pitchFamily="34" charset="-120"/>
-              </a:rPr>
-              <a:t>Traditional remote attestation: </a:t>
-            </a:r>
-            <a:pPr algn="l" indent="0" marL="0">
-              <a:buNone/>
-            </a:pPr>
-            <a:r>
-              <a:rPr lang="en-US" sz="1700" b="1" dirty="0">
-                <a:solidFill>
-                  <a:srgbClr val="212121"/>
-                </a:solidFill>
-                <a:latin typeface="Calibri" pitchFamily="34" charset="0"/>
-                <a:ea typeface="Calibri" pitchFamily="34" charset="-122"/>
-                <a:cs typeface="Calibri" pitchFamily="34" charset="-120"/>
-              </a:rPr>
-              <a:t>did system components boot into a predictable state?</a:t>
-            </a:r>
-            <a:pPr algn="l" indent="0" marL="0">
-              <a:spcAft>
-                <a:spcPts val="1000"/>
-              </a:spcAft>
-              <a:buNone/>
-            </a:pPr>
-            <a:r>
-              <a:rPr lang="en-US" sz="1700" dirty="0">
-                <a:solidFill>
-                  <a:srgbClr val="212121"/>
-                </a:solidFill>
-                <a:latin typeface="Calibri" pitchFamily="34" charset="0"/>
-                <a:ea typeface="Calibri" pitchFamily="34" charset="-122"/>
-                <a:cs typeface="Calibri" pitchFamily="34" charset="-120"/>
-              </a:rPr>
-              <a:t> (boot-time, static runtime)</a:t>
-            </a:r>
-            <a:endParaRPr lang="en-US" sz="1700" dirty="0"/>
-          </a:p>
-          <a:p>
-            <a:pPr algn="l" marL="342900" indent="-342900">
-              <a:buSzPct val="100000"/>
-              <a:buChar char="•"/>
-            </a:pPr>
-            <a:r>
-              <a:rPr lang="en-US" sz="1700" b="1" dirty="0">
-                <a:solidFill>
-                  <a:srgbClr val="212121"/>
-                </a:solidFill>
-                <a:latin typeface="Calibri" pitchFamily="34" charset="0"/>
-                <a:ea typeface="Calibri" pitchFamily="34" charset="-122"/>
-                <a:cs typeface="Calibri" pitchFamily="34" charset="-120"/>
-              </a:rPr>
-              <a:t>Layered, runtime attestation: </a:t>
-            </a:r>
-            <a:pPr algn="l" indent="0" marL="0">
-              <a:buNone/>
-            </a:pPr>
-            <a:r>
-              <a:rPr lang="en-US" sz="1700" dirty="0">
-                <a:solidFill>
-                  <a:srgbClr val="212121"/>
-                </a:solidFill>
-                <a:latin typeface="Calibri" pitchFamily="34" charset="0"/>
-                <a:ea typeface="Calibri" pitchFamily="34" charset="-122"/>
-                <a:cs typeface="Calibri" pitchFamily="34" charset="-120"/>
-              </a:rPr>
-              <a:t>extend boot-time trust via dynamic measurement of system components </a:t>
-            </a:r>
-            <a:pPr algn="l" indent="0" marL="0">
-              <a:spcAft>
-                <a:spcPts val="1000"/>
-              </a:spcAft>
-              <a:buNone/>
-            </a:pPr>
-            <a:r>
-              <a:rPr lang="en-US" sz="1700" b="1" dirty="0">
-                <a:solidFill>
-                  <a:srgbClr val="212121"/>
-                </a:solidFill>
-                <a:latin typeface="Calibri" pitchFamily="34" charset="0"/>
-                <a:ea typeface="Calibri" pitchFamily="34" charset="-122"/>
-                <a:cs typeface="Calibri" pitchFamily="34" charset="-120"/>
-              </a:rPr>
-              <a:t>and their context/dependencies</a:t>
-            </a:r>
-            <a:endParaRPr lang="en-US" sz="1700" dirty="0"/>
-          </a:p>
-          <a:p>
-            <a:pPr algn="l" marL="342900" indent="-342900">
-              <a:buSzPct val="100000"/>
-              <a:buChar char="•"/>
-            </a:pPr>
-            <a:r>
-              <a:rPr lang="en-US" sz="1700" b="1" dirty="0">
-                <a:solidFill>
-                  <a:srgbClr val="212121"/>
-                </a:solidFill>
-                <a:latin typeface="Calibri" pitchFamily="34" charset="0"/>
-                <a:ea typeface="Calibri" pitchFamily="34" charset="-122"/>
-                <a:cs typeface="Calibri" pitchFamily="34" charset="-120"/>
-              </a:rPr>
-              <a:t>Lifecycle attestation: </a:t>
-            </a:r>
-            <a:pPr algn="l" indent="0" marL="0">
-              <a:buNone/>
-            </a:pPr>
-            <a:r>
-              <a:rPr lang="en-US" sz="1700" dirty="0">
-                <a:solidFill>
-                  <a:srgbClr val="212121"/>
-                </a:solidFill>
-                <a:latin typeface="Calibri" pitchFamily="34" charset="0"/>
-                <a:ea typeface="Calibri" pitchFamily="34" charset="-122"/>
-                <a:cs typeface="Calibri" pitchFamily="34" charset="-120"/>
-              </a:rPr>
-              <a:t>extends this notion to </a:t>
-            </a:r>
-            <a:pPr algn="l" indent="0" marL="0">
-              <a:buNone/>
-            </a:pPr>
-            <a:r>
-              <a:rPr lang="en-US" sz="1700" b="1" dirty="0">
-                <a:solidFill>
-                  <a:srgbClr val="212121"/>
-                </a:solidFill>
-                <a:latin typeface="Calibri" pitchFamily="34" charset="0"/>
-                <a:ea typeface="Calibri" pitchFamily="34" charset="-122"/>
-                <a:cs typeface="Calibri" pitchFamily="34" charset="-120"/>
-              </a:rPr>
-              <a:t>artifacts of the development lifecycle</a:t>
-            </a:r>
-            <a:pPr algn="l" indent="0" marL="0">
-              <a:spcAft>
-                <a:spcPts val="1000"/>
-              </a:spcAft>
-              <a:buNone/>
-            </a:pPr>
-            <a:r>
-              <a:rPr lang="en-US" sz="1700" dirty="0">
-                <a:solidFill>
-                  <a:srgbClr val="212121"/>
-                </a:solidFill>
-                <a:latin typeface="Calibri" pitchFamily="34" charset="0"/>
-                <a:ea typeface="Calibri" pitchFamily="34" charset="-122"/>
-                <a:cs typeface="Calibri" pitchFamily="34" charset="-120"/>
-              </a:rPr>
-              <a:t>: models, contracts, implementations, proofs, toolchains</a:t>
-            </a:r>
-            <a:endParaRPr lang="en-US" sz="1700" dirty="0"/>
-          </a:p>
-          <a:p>
-            <a:pPr algn="l" lvl="1" marL="685800" indent="-342900">
-              <a:spcAft>
-                <a:spcPts val="1000"/>
-              </a:spcAft>
-              <a:buSzPct val="100000"/>
-              <a:buChar char="–"/>
-            </a:pPr>
-            <a:r>
-              <a:rPr lang="en-US" sz="1700" dirty="0">
-                <a:solidFill>
-                  <a:srgbClr val="212121"/>
-                </a:solidFill>
-                <a:latin typeface="Calibri" pitchFamily="34" charset="0"/>
-                <a:ea typeface="Calibri" pitchFamily="34" charset="-122"/>
-                <a:cs typeface="Calibri" pitchFamily="34" charset="-120"/>
-              </a:rPr>
-              <a:t>…including the attestation infrastructure and evidence itself</a:t>
-            </a:r>
-            <a:endParaRPr lang="en-US" sz="1700" dirty="0"/>
-          </a:p>
-          <a:p>
-            <a:pPr algn="l" lvl="1" marL="685800" indent="-342900">
-              <a:buSzPct val="100000"/>
-              <a:buChar char="–"/>
-            </a:pPr>
-            <a:r>
-              <a:rPr lang="en-US" sz="1700" dirty="0">
-                <a:solidFill>
-                  <a:srgbClr val="212121"/>
-                </a:solidFill>
-                <a:latin typeface="Calibri" pitchFamily="34" charset="0"/>
-                <a:ea typeface="Calibri" pitchFamily="34" charset="-122"/>
-                <a:cs typeface="Calibri" pitchFamily="34" charset="-120"/>
-              </a:rPr>
-              <a:t>…and to lifecycle </a:t>
-            </a:r>
-            <a:pPr algn="l" indent="0" marL="0">
-              <a:buNone/>
-            </a:pPr>
-            <a:r>
-              <a:rPr lang="en-US" sz="1700" b="1" dirty="0">
-                <a:solidFill>
-                  <a:srgbClr val="212121"/>
-                </a:solidFill>
-                <a:latin typeface="Calibri" pitchFamily="34" charset="0"/>
-                <a:ea typeface="Calibri" pitchFamily="34" charset="-122"/>
-                <a:cs typeface="Calibri" pitchFamily="34" charset="-120"/>
-              </a:rPr>
-              <a:t>events</a:t>
-            </a:r>
-            <a:pPr algn="l" indent="0" marL="0">
-              <a:spcAft>
-                <a:spcPts val="1000"/>
-              </a:spcAft>
-              <a:buNone/>
-            </a:pPr>
-            <a:r>
-              <a:rPr lang="en-US" sz="1700" dirty="0">
-                <a:solidFill>
-                  <a:srgbClr val="212121"/>
-                </a:solidFill>
-                <a:latin typeface="Calibri" pitchFamily="34" charset="0"/>
-                <a:ea typeface="Calibri" pitchFamily="34" charset="-122"/>
-                <a:cs typeface="Calibri" pitchFamily="34" charset="-120"/>
-              </a:rPr>
-              <a:t>:</a:t>
-            </a:r>
-            <a:endParaRPr lang="en-US" sz="1700" dirty="0"/>
-          </a:p>
-          <a:p>
-            <a:pPr algn="l" lvl="2" marL="1028700" indent="-342900">
-              <a:spcAft>
-                <a:spcPts val="200"/>
-              </a:spcAft>
-              <a:buSzPct val="100000"/>
-              <a:buChar char="▪"/>
-            </a:pPr>
-            <a:r>
-              <a:rPr lang="en-US" sz="1700" dirty="0">
-                <a:solidFill>
-                  <a:srgbClr val="212121"/>
-                </a:solidFill>
-                <a:latin typeface="Calibri" pitchFamily="34" charset="0"/>
-                <a:ea typeface="Calibri" pitchFamily="34" charset="-122"/>
-                <a:cs typeface="Calibri" pitchFamily="34" charset="-120"/>
-              </a:rPr>
-              <a:t>specification drift (sanctioned or not)</a:t>
-            </a:r>
-            <a:endParaRPr lang="en-US" sz="1700" dirty="0"/>
-          </a:p>
-          <a:p>
-            <a:pPr algn="l" lvl="2" marL="1028700" indent="-342900">
-              <a:spcAft>
-                <a:spcPts val="200"/>
-              </a:spcAft>
-              <a:buSzPct val="100000"/>
-              <a:buChar char="▪"/>
-            </a:pPr>
-            <a:r>
-              <a:rPr lang="en-US" sz="1700" dirty="0">
-                <a:solidFill>
-                  <a:srgbClr val="212121"/>
-                </a:solidFill>
-                <a:latin typeface="Calibri" pitchFamily="34" charset="0"/>
-                <a:ea typeface="Calibri" pitchFamily="34" charset="-122"/>
-                <a:cs typeface="Calibri" pitchFamily="34" charset="-120"/>
-              </a:rPr>
-              <a:t>artifact tampering</a:t>
-            </a:r>
-            <a:endParaRPr lang="en-US" sz="1700" dirty="0"/>
-          </a:p>
-          <a:p>
-            <a:pPr algn="l" lvl="2" marL="1028700" indent="-342900">
-              <a:spcAft>
-                <a:spcPts val="200"/>
-              </a:spcAft>
-              <a:buSzPct val="100000"/>
-              <a:buChar char="▪"/>
-            </a:pPr>
-            <a:r>
-              <a:rPr lang="en-US" sz="1700" dirty="0">
-                <a:solidFill>
-                  <a:srgbClr val="212121"/>
-                </a:solidFill>
-                <a:latin typeface="Calibri" pitchFamily="34" charset="0"/>
-                <a:ea typeface="Calibri" pitchFamily="34" charset="-122"/>
-                <a:cs typeface="Calibri" pitchFamily="34" charset="-120"/>
-              </a:rPr>
-              <a:t>artifact synthesis</a:t>
-            </a:r>
-            <a:endParaRPr lang="en-US" sz="1700" dirty="0"/>
-          </a:p>
-          <a:p>
-            <a:pPr algn="l" lvl="2" marL="1028700" indent="-342900">
-              <a:spcAft>
-                <a:spcPts val="200"/>
-              </a:spcAft>
-              <a:buSzPct val="100000"/>
-              <a:buChar char="▪"/>
-            </a:pPr>
-            <a:r>
-              <a:rPr lang="en-US" sz="1700" dirty="0">
-                <a:solidFill>
-                  <a:srgbClr val="212121"/>
-                </a:solidFill>
-                <a:latin typeface="Calibri" pitchFamily="34" charset="0"/>
-                <a:ea typeface="Calibri" pitchFamily="34" charset="-122"/>
-                <a:cs typeface="Calibri" pitchFamily="34" charset="-120"/>
-              </a:rPr>
-              <a:t>artifact repair</a:t>
-            </a:r>
-            <a:endParaRPr lang="en-US" sz="1700" dirty="0"/>
-          </a:p>
-          <a:p>
-            <a:pPr algn="l" marL="342900" indent="-342900">
-              <a:buSzPct val="100000"/>
-              <a:buChar char="•"/>
-            </a:pPr>
-            <a:r>
-              <a:rPr lang="en-US" sz="1700" b="1" dirty="0">
-                <a:solidFill>
-                  <a:srgbClr val="212121"/>
-                </a:solidFill>
-                <a:latin typeface="Calibri" pitchFamily="34" charset="0"/>
-                <a:ea typeface="Calibri" pitchFamily="34" charset="-122"/>
-                <a:cs typeface="Calibri" pitchFamily="34" charset="-120"/>
-              </a:rPr>
-              <a:t>Motivation: </a:t>
-            </a:r>
-            <a:pPr algn="l" indent="0" marL="0">
-              <a:buNone/>
-            </a:pPr>
-            <a:r>
-              <a:rPr lang="en-US" sz="1700" dirty="0">
-                <a:solidFill>
-                  <a:srgbClr val="212121"/>
-                </a:solidFill>
-                <a:latin typeface="Calibri" pitchFamily="34" charset="0"/>
-                <a:ea typeface="Calibri" pitchFamily="34" charset="-122"/>
-                <a:cs typeface="Calibri" pitchFamily="34" charset="-120"/>
-              </a:rPr>
-              <a:t>the </a:t>
-            </a:r>
-            <a:pPr algn="l" indent="0" marL="0">
-              <a:buNone/>
-            </a:pPr>
-            <a:r>
-              <a:rPr lang="en-US" sz="1700" b="1" dirty="0">
-                <a:solidFill>
-                  <a:srgbClr val="212121"/>
-                </a:solidFill>
-                <a:latin typeface="Calibri" pitchFamily="34" charset="0"/>
-                <a:ea typeface="Calibri" pitchFamily="34" charset="-122"/>
-                <a:cs typeface="Calibri" pitchFamily="34" charset="-120"/>
-              </a:rPr>
-              <a:t>proliferation of AI-generated software artifacts</a:t>
-            </a:r>
-            <a:pPr algn="l" indent="0" marL="0">
-              <a:spcAft>
-                <a:spcPts val="1000"/>
-              </a:spcAft>
-              <a:buNone/>
-            </a:pPr>
-            <a:r>
-              <a:rPr lang="en-US" sz="1700" dirty="0">
-                <a:solidFill>
-                  <a:srgbClr val="212121"/>
-                </a:solidFill>
-                <a:latin typeface="Calibri" pitchFamily="34" charset="0"/>
-                <a:ea typeface="Calibri" pitchFamily="34" charset="-122"/>
-                <a:cs typeface="Calibri" pitchFamily="34" charset="-120"/>
-              </a:rPr>
-              <a:t>, amid the need for rapid re-certification of systems</a:t>
-            </a:r>
-            <a:endParaRPr lang="en-US" sz="1700" dirty="0"/>
-          </a:p>
-        </p:txBody>
-      </p:sp>
-      <p:sp>
-        <p:nvSpPr>
-          <p:cNvPr id="4" name="Shape 2"/>
-          <p:cNvSpPr/>
-          <p:nvPr/>
-        </p:nvSpPr>
-        <p:spPr>
-          <a:xfrm>
-            <a:off x="640080" y="5074920"/>
-            <a:ext cx="10881360" cy="1234440"/>
+          <p:cNvPr id="3" name="Shape 1"/>
+          <p:cNvSpPr/>
+          <p:nvPr/>
+        </p:nvSpPr>
+        <p:spPr>
+          <a:xfrm>
+            <a:off x="640080" y="2834640"/>
+            <a:ext cx="2044598" cy="777240"/>
           </a:xfrm>
           <a:prstGeom prst="roundRect">
             <a:avLst>
-              <a:gd name="adj" fmla="val 5926"/>
+              <a:gd name="adj" fmla="val 8235"/>
             </a:avLst>
           </a:prstGeom>
           <a:solidFill>
@@ -13134,14 +12734,14 @@
       </p:sp>
       <p:sp>
         <p:nvSpPr>
-          <p:cNvPr id="5" name="Text 3"/>
-          <p:cNvSpPr/>
-          <p:nvPr/>
-        </p:nvSpPr>
-        <p:spPr>
-          <a:xfrm>
-            <a:off x="914400" y="5074920"/>
-            <a:ext cx="10332720" cy="1234440"/>
+          <p:cNvPr id="4" name="Text 2"/>
+          <p:cNvSpPr/>
+          <p:nvPr/>
+        </p:nvSpPr>
+        <p:spPr>
+          <a:xfrm>
+            <a:off x="640080" y="2834640"/>
+            <a:ext cx="2044598" cy="777240"/>
           </a:xfrm>
           <a:prstGeom prst="rect">
             <a:avLst/>
@@ -13150,44 +12750,441 @@
           <a:ln/>
         </p:spPr>
         <p:txBody>
+          <a:bodyPr wrap="square" lIns="254" tIns="254" rIns="254" bIns="254" rtlCol="0" anchor="ctr"/>
+          <a:lstStyle/>
+          <a:p>
+            <a:pPr algn="ctr" indent="0" marL="0">
+              <a:buNone/>
+            </a:pPr>
+            <a:r>
+              <a:rPr lang="en-US" sz="1350" b="1" dirty="0">
+                <a:solidFill>
+                  <a:srgbClr val="FFFFFF"/>
+                </a:solidFill>
+                <a:latin typeface="Calibri" pitchFamily="34" charset="0"/>
+                <a:ea typeface="Calibri" pitchFamily="34" charset="-122"/>
+                <a:cs typeface="Calibri" pitchFamily="34" charset="-120"/>
+              </a:rPr>
+              <a:t>Preliminaries</a:t>
+            </a:r>
+            <a:endParaRPr lang="en-US" sz="1350" dirty="0"/>
+          </a:p>
+        </p:txBody>
+      </p:sp>
+      <p:sp>
+        <p:nvSpPr>
+          <p:cNvPr id="5" name="Text 3"/>
+          <p:cNvSpPr/>
+          <p:nvPr/>
+        </p:nvSpPr>
+        <p:spPr>
+          <a:xfrm>
+            <a:off x="2629814" y="2834640"/>
+            <a:ext cx="274320" cy="777240"/>
+          </a:xfrm>
+          <a:prstGeom prst="rect">
+            <a:avLst/>
+          </a:prstGeom>
+          <a:noFill/>
+          <a:ln/>
+        </p:spPr>
+        <p:txBody>
           <a:bodyPr wrap="square" lIns="0" tIns="0" rIns="0" bIns="0" rtlCol="0" anchor="ctr"/>
           <a:lstStyle/>
           <a:p>
             <a:pPr algn="ctr" indent="0" marL="0">
-              <a:spcAft>
-                <a:spcPts val="400"/>
-              </a:spcAft>
-              <a:buNone/>
-            </a:pPr>
-            <a:r>
-              <a:rPr lang="en-US" sz="2000" b="1" dirty="0">
-                <a:solidFill>
-                  <a:srgbClr val="FFFFFF"/>
-                </a:solidFill>
-                <a:latin typeface="Calibri" pitchFamily="34" charset="0"/>
-                <a:ea typeface="Calibri" pitchFamily="34" charset="-122"/>
-                <a:cs typeface="Calibri" pitchFamily="34" charset="-120"/>
-              </a:rPr>
-              <a:t>Every trust decision is grounded in cryptographic attestation evidence.</a:t>
-            </a:r>
-            <a:endParaRPr lang="en-US" sz="2000" dirty="0"/>
-          </a:p>
+              <a:buNone/>
+            </a:pPr>
+            <a:r>
+              <a:rPr lang="en-US" sz="1400" dirty="0">
+                <a:solidFill>
+                  <a:srgbClr val="5A6478"/>
+                </a:solidFill>
+                <a:latin typeface="Calibri" pitchFamily="34" charset="0"/>
+                <a:ea typeface="Calibri" pitchFamily="34" charset="-122"/>
+                <a:cs typeface="Calibri" pitchFamily="34" charset="-120"/>
+              </a:rPr>
+              <a:t>→</a:t>
+            </a:r>
+            <a:endParaRPr lang="en-US" sz="1400" dirty="0"/>
+          </a:p>
+        </p:txBody>
+      </p:sp>
+      <p:sp>
+        <p:nvSpPr>
+          <p:cNvPr id="6" name="Shape 4"/>
+          <p:cNvSpPr/>
+          <p:nvPr/>
+        </p:nvSpPr>
+        <p:spPr>
+          <a:xfrm>
+            <a:off x="2849270" y="2834640"/>
+            <a:ext cx="2044598" cy="777240"/>
+          </a:xfrm>
+          <a:prstGeom prst="roundRect">
+            <a:avLst>
+              <a:gd name="adj" fmla="val 8235"/>
+            </a:avLst>
+          </a:prstGeom>
+          <a:solidFill>
+            <a:srgbClr val="CADCFC"/>
+          </a:solidFill>
+          <a:ln/>
+        </p:spPr>
+      </p:sp>
+      <p:sp>
+        <p:nvSpPr>
+          <p:cNvPr id="7" name="Text 5"/>
+          <p:cNvSpPr/>
+          <p:nvPr/>
+        </p:nvSpPr>
+        <p:spPr>
+          <a:xfrm>
+            <a:off x="2849270" y="2834640"/>
+            <a:ext cx="2044598" cy="777240"/>
+          </a:xfrm>
+          <a:prstGeom prst="rect">
+            <a:avLst/>
+          </a:prstGeom>
+          <a:noFill/>
+          <a:ln/>
+        </p:spPr>
+        <p:txBody>
+          <a:bodyPr wrap="square" lIns="254" tIns="254" rIns="254" bIns="254" rtlCol="0" anchor="ctr"/>
+          <a:lstStyle/>
           <a:p>
             <a:pPr algn="ctr" indent="0" marL="0">
               <a:buNone/>
             </a:pPr>
             <a:r>
-              <a:rPr lang="en-US" sz="1400" i="1" dirty="0">
-                <a:solidFill>
-                  <a:srgbClr val="CADCFC"/>
-                </a:solidFill>
-                <a:latin typeface="Calibri" pitchFamily="34" charset="0"/>
-                <a:ea typeface="Calibri" pitchFamily="34" charset="-122"/>
-                <a:cs typeface="Calibri" pitchFamily="34" charset="-120"/>
-              </a:rPr>
-              <a:t>trust is NOT anchored in the following:  developer claims, untrusted tools, LLM outputs, cached verdicts</a:t>
-            </a:r>
-            <a:endParaRPr lang="en-US" sz="2000" dirty="0"/>
+              <a:rPr lang="en-US" sz="1350" dirty="0">
+                <a:solidFill>
+                  <a:srgbClr val="1E2761"/>
+                </a:solidFill>
+                <a:latin typeface="Calibri" pitchFamily="34" charset="0"/>
+                <a:ea typeface="Calibri" pitchFamily="34" charset="-122"/>
+                <a:cs typeface="Calibri" pitchFamily="34" charset="-120"/>
+              </a:rPr>
+              <a:t>Demo:</a:t>
+            </a:r>
+            <a:endParaRPr lang="en-US" sz="1350" dirty="0"/>
+          </a:p>
+          <a:p>
+            <a:pPr algn="ctr" indent="0" marL="0">
+              <a:buNone/>
+            </a:pPr>
+            <a:r>
+              <a:rPr lang="en-US" sz="1350" dirty="0">
+                <a:solidFill>
+                  <a:srgbClr val="1E2761"/>
+                </a:solidFill>
+                <a:latin typeface="Calibri" pitchFamily="34" charset="0"/>
+                <a:ea typeface="Calibri" pitchFamily="34" charset="-122"/>
+                <a:cs typeface="Calibri" pitchFamily="34" charset="-120"/>
+              </a:rPr>
+              <a:t>Isolette (SysMLv2 → Rust)</a:t>
+            </a:r>
+            <a:endParaRPr lang="en-US" sz="1350" dirty="0"/>
+          </a:p>
+        </p:txBody>
+      </p:sp>
+      <p:sp>
+        <p:nvSpPr>
+          <p:cNvPr id="8" name="Text 6"/>
+          <p:cNvSpPr/>
+          <p:nvPr/>
+        </p:nvSpPr>
+        <p:spPr>
+          <a:xfrm>
+            <a:off x="4839005" y="2834640"/>
+            <a:ext cx="274320" cy="777240"/>
+          </a:xfrm>
+          <a:prstGeom prst="rect">
+            <a:avLst/>
+          </a:prstGeom>
+          <a:noFill/>
+          <a:ln/>
+        </p:spPr>
+        <p:txBody>
+          <a:bodyPr wrap="square" lIns="0" tIns="0" rIns="0" bIns="0" rtlCol="0" anchor="ctr"/>
+          <a:lstStyle/>
+          <a:p>
+            <a:pPr algn="ctr" indent="0" marL="0">
+              <a:buNone/>
+            </a:pPr>
+            <a:r>
+              <a:rPr lang="en-US" sz="1400" dirty="0">
+                <a:solidFill>
+                  <a:srgbClr val="5A6478"/>
+                </a:solidFill>
+                <a:latin typeface="Calibri" pitchFamily="34" charset="0"/>
+                <a:ea typeface="Calibri" pitchFamily="34" charset="-122"/>
+                <a:cs typeface="Calibri" pitchFamily="34" charset="-120"/>
+              </a:rPr>
+              <a:t>→</a:t>
+            </a:r>
+            <a:endParaRPr lang="en-US" sz="1400" dirty="0"/>
+          </a:p>
+        </p:txBody>
+      </p:sp>
+      <p:sp>
+        <p:nvSpPr>
+          <p:cNvPr id="9" name="Shape 7"/>
+          <p:cNvSpPr/>
+          <p:nvPr/>
+        </p:nvSpPr>
+        <p:spPr>
+          <a:xfrm>
+            <a:off x="5058461" y="2834640"/>
+            <a:ext cx="2044598" cy="777240"/>
+          </a:xfrm>
+          <a:prstGeom prst="roundRect">
+            <a:avLst>
+              <a:gd name="adj" fmla="val 8235"/>
+            </a:avLst>
+          </a:prstGeom>
+          <a:solidFill>
+            <a:srgbClr val="CADCFC"/>
+          </a:solidFill>
+          <a:ln/>
+        </p:spPr>
+      </p:sp>
+      <p:sp>
+        <p:nvSpPr>
+          <p:cNvPr id="10" name="Text 8"/>
+          <p:cNvSpPr/>
+          <p:nvPr/>
+        </p:nvSpPr>
+        <p:spPr>
+          <a:xfrm>
+            <a:off x="5058461" y="2834640"/>
+            <a:ext cx="2044598" cy="777240"/>
+          </a:xfrm>
+          <a:prstGeom prst="rect">
+            <a:avLst/>
+          </a:prstGeom>
+          <a:noFill/>
+          <a:ln/>
+        </p:spPr>
+        <p:txBody>
+          <a:bodyPr wrap="square" lIns="254" tIns="254" rIns="254" bIns="254" rtlCol="0" anchor="ctr"/>
+          <a:lstStyle/>
+          <a:p>
+            <a:pPr algn="ctr" indent="0" marL="0">
+              <a:buNone/>
+            </a:pPr>
+            <a:r>
+              <a:rPr lang="en-US" sz="1350" dirty="0">
+                <a:solidFill>
+                  <a:srgbClr val="1E2761"/>
+                </a:solidFill>
+                <a:latin typeface="Calibri" pitchFamily="34" charset="0"/>
+                <a:ea typeface="Calibri" pitchFamily="34" charset="-122"/>
+                <a:cs typeface="Calibri" pitchFamily="34" charset="-120"/>
+              </a:rPr>
+              <a:t>Other Ecosystems</a:t>
+            </a:r>
+            <a:endParaRPr lang="en-US" sz="1350" dirty="0"/>
+          </a:p>
+        </p:txBody>
+      </p:sp>
+      <p:sp>
+        <p:nvSpPr>
+          <p:cNvPr id="11" name="Text 9"/>
+          <p:cNvSpPr/>
+          <p:nvPr/>
+        </p:nvSpPr>
+        <p:spPr>
+          <a:xfrm>
+            <a:off x="7048195" y="2834640"/>
+            <a:ext cx="274320" cy="777240"/>
+          </a:xfrm>
+          <a:prstGeom prst="rect">
+            <a:avLst/>
+          </a:prstGeom>
+          <a:noFill/>
+          <a:ln/>
+        </p:spPr>
+        <p:txBody>
+          <a:bodyPr wrap="square" lIns="0" tIns="0" rIns="0" bIns="0" rtlCol="0" anchor="ctr"/>
+          <a:lstStyle/>
+          <a:p>
+            <a:pPr algn="ctr" indent="0" marL="0">
+              <a:buNone/>
+            </a:pPr>
+            <a:r>
+              <a:rPr lang="en-US" sz="1400" dirty="0">
+                <a:solidFill>
+                  <a:srgbClr val="5A6478"/>
+                </a:solidFill>
+                <a:latin typeface="Calibri" pitchFamily="34" charset="0"/>
+                <a:ea typeface="Calibri" pitchFamily="34" charset="-122"/>
+                <a:cs typeface="Calibri" pitchFamily="34" charset="-120"/>
+              </a:rPr>
+              <a:t>→</a:t>
+            </a:r>
+            <a:endParaRPr lang="en-US" sz="1400" dirty="0"/>
+          </a:p>
+        </p:txBody>
+      </p:sp>
+      <p:sp>
+        <p:nvSpPr>
+          <p:cNvPr id="12" name="Shape 10"/>
+          <p:cNvSpPr/>
+          <p:nvPr/>
+        </p:nvSpPr>
+        <p:spPr>
+          <a:xfrm>
+            <a:off x="7267651" y="2834640"/>
+            <a:ext cx="2044598" cy="777240"/>
+          </a:xfrm>
+          <a:prstGeom prst="roundRect">
+            <a:avLst>
+              <a:gd name="adj" fmla="val 8235"/>
+            </a:avLst>
+          </a:prstGeom>
+          <a:solidFill>
+            <a:srgbClr val="CADCFC"/>
+          </a:solidFill>
+          <a:ln/>
+        </p:spPr>
+      </p:sp>
+      <p:sp>
+        <p:nvSpPr>
+          <p:cNvPr id="13" name="Text 11"/>
+          <p:cNvSpPr/>
+          <p:nvPr/>
+        </p:nvSpPr>
+        <p:spPr>
+          <a:xfrm>
+            <a:off x="7267651" y="2834640"/>
+            <a:ext cx="2044598" cy="777240"/>
+          </a:xfrm>
+          <a:prstGeom prst="rect">
+            <a:avLst/>
+          </a:prstGeom>
+          <a:noFill/>
+          <a:ln/>
+        </p:spPr>
+        <p:txBody>
+          <a:bodyPr wrap="square" lIns="254" tIns="254" rIns="254" bIns="254" rtlCol="0" anchor="ctr"/>
+          <a:lstStyle/>
+          <a:p>
+            <a:pPr algn="ctr" indent="0" marL="0">
+              <a:buNone/>
+            </a:pPr>
+            <a:r>
+              <a:rPr lang="en-US" sz="1350" dirty="0">
+                <a:solidFill>
+                  <a:srgbClr val="1E2761"/>
+                </a:solidFill>
+                <a:latin typeface="Calibri" pitchFamily="34" charset="0"/>
+                <a:ea typeface="Calibri" pitchFamily="34" charset="-122"/>
+                <a:cs typeface="Calibri" pitchFamily="34" charset="-120"/>
+              </a:rPr>
+              <a:t>AI in the Loop</a:t>
+            </a:r>
+            <a:endParaRPr lang="en-US" sz="1350" dirty="0"/>
+          </a:p>
+        </p:txBody>
+      </p:sp>
+      <p:sp>
+        <p:nvSpPr>
+          <p:cNvPr id="14" name="Text 12"/>
+          <p:cNvSpPr/>
+          <p:nvPr/>
+        </p:nvSpPr>
+        <p:spPr>
+          <a:xfrm>
+            <a:off x="9257386" y="2834640"/>
+            <a:ext cx="274320" cy="777240"/>
+          </a:xfrm>
+          <a:prstGeom prst="rect">
+            <a:avLst/>
+          </a:prstGeom>
+          <a:noFill/>
+          <a:ln/>
+        </p:spPr>
+        <p:txBody>
+          <a:bodyPr wrap="square" lIns="0" tIns="0" rIns="0" bIns="0" rtlCol="0" anchor="ctr"/>
+          <a:lstStyle/>
+          <a:p>
+            <a:pPr algn="ctr" indent="0" marL="0">
+              <a:buNone/>
+            </a:pPr>
+            <a:r>
+              <a:rPr lang="en-US" sz="1400" dirty="0">
+                <a:solidFill>
+                  <a:srgbClr val="5A6478"/>
+                </a:solidFill>
+                <a:latin typeface="Calibri" pitchFamily="34" charset="0"/>
+                <a:ea typeface="Calibri" pitchFamily="34" charset="-122"/>
+                <a:cs typeface="Calibri" pitchFamily="34" charset="-120"/>
+              </a:rPr>
+              <a:t>→</a:t>
+            </a:r>
+            <a:endParaRPr lang="en-US" sz="1400" dirty="0"/>
+          </a:p>
+        </p:txBody>
+      </p:sp>
+      <p:sp>
+        <p:nvSpPr>
+          <p:cNvPr id="15" name="Shape 13"/>
+          <p:cNvSpPr/>
+          <p:nvPr/>
+        </p:nvSpPr>
+        <p:spPr>
+          <a:xfrm>
+            <a:off x="9476842" y="2834640"/>
+            <a:ext cx="2044598" cy="777240"/>
+          </a:xfrm>
+          <a:prstGeom prst="roundRect">
+            <a:avLst>
+              <a:gd name="adj" fmla="val 8235"/>
+            </a:avLst>
+          </a:prstGeom>
+          <a:solidFill>
+            <a:srgbClr val="CADCFC"/>
+          </a:solidFill>
+          <a:ln/>
+        </p:spPr>
+      </p:sp>
+      <p:sp>
+        <p:nvSpPr>
+          <p:cNvPr id="16" name="Text 14"/>
+          <p:cNvSpPr/>
+          <p:nvPr/>
+        </p:nvSpPr>
+        <p:spPr>
+          <a:xfrm>
+            <a:off x="9476842" y="2834640"/>
+            <a:ext cx="2044598" cy="777240"/>
+          </a:xfrm>
+          <a:prstGeom prst="rect">
+            <a:avLst/>
+          </a:prstGeom>
+          <a:noFill/>
+          <a:ln/>
+        </p:spPr>
+        <p:txBody>
+          <a:bodyPr wrap="square" lIns="254" tIns="254" rIns="254" bIns="254" rtlCol="0" anchor="ctr"/>
+          <a:lstStyle/>
+          <a:p>
+            <a:pPr algn="ctr" indent="0" marL="0">
+              <a:buNone/>
+            </a:pPr>
+            <a:r>
+              <a:rPr lang="en-US" sz="1350" dirty="0">
+                <a:solidFill>
+                  <a:srgbClr val="1E2761"/>
+                </a:solidFill>
+                <a:latin typeface="Calibri" pitchFamily="34" charset="0"/>
+                <a:ea typeface="Calibri" pitchFamily="34" charset="-122"/>
+                <a:cs typeface="Calibri" pitchFamily="34" charset="-120"/>
+              </a:rPr>
+              <a:t>Close</a:t>
+            </a:r>
+            <a:endParaRPr lang="en-US" sz="1350" dirty="0"/>
           </a:p>
         </p:txBody>
       </p:sp>
@@ -13821,7 +13818,7 @@
                 <a:ea typeface="Cambria" pitchFamily="34" charset="-122"/>
                 <a:cs typeface="Cambria" pitchFamily="34" charset="-120"/>
               </a:rPr>
-              <a:t>Roadmap</a:t>
+              <a:t>What is Lifecycle Attestation?</a:t>
             </a:r>
             <a:endParaRPr lang="en-US" sz="3600" dirty="0"/>
           </a:p>
@@ -13829,18 +13826,369 @@
       </p:sp>
       <p:sp>
         <p:nvSpPr>
-          <p:cNvPr id="3" name="Shape 1"/>
-          <p:cNvSpPr/>
-          <p:nvPr/>
-        </p:nvSpPr>
-        <p:spPr>
-          <a:xfrm>
-            <a:off x="640080" y="2834640"/>
-            <a:ext cx="2044598" cy="777240"/>
+          <p:cNvPr id="3" name="Text 1"/>
+          <p:cNvSpPr/>
+          <p:nvPr/>
+        </p:nvSpPr>
+        <p:spPr>
+          <a:xfrm>
+            <a:off x="640080" y="1325880"/>
+            <a:ext cx="10972800" cy="3566160"/>
+          </a:xfrm>
+          <a:prstGeom prst="rect">
+            <a:avLst/>
+          </a:prstGeom>
+          <a:noFill/>
+          <a:ln/>
+        </p:spPr>
+        <p:txBody>
+          <a:bodyPr wrap="square" lIns="0" tIns="0" rIns="0" bIns="0" rtlCol="0" anchor="t"/>
+          <a:lstStyle/>
+          <a:p>
+            <a:pPr algn="l" marL="342900" indent="-342900">
+              <a:buSzPct val="100000"/>
+              <a:buChar char="•"/>
+            </a:pPr>
+            <a:r>
+              <a:rPr lang="en-US" sz="1700" b="1" dirty="0">
+                <a:solidFill>
+                  <a:srgbClr val="212121"/>
+                </a:solidFill>
+                <a:latin typeface="Calibri" pitchFamily="34" charset="0"/>
+                <a:ea typeface="Calibri" pitchFamily="34" charset="-122"/>
+                <a:cs typeface="Calibri" pitchFamily="34" charset="-120"/>
+              </a:rPr>
+              <a:t>Traditional remote attestation: </a:t>
+            </a:r>
+            <a:pPr algn="l" indent="0" marL="0">
+              <a:buNone/>
+            </a:pPr>
+            <a:r>
+              <a:rPr lang="en-US" sz="1700" b="1" dirty="0">
+                <a:solidFill>
+                  <a:srgbClr val="212121"/>
+                </a:solidFill>
+                <a:latin typeface="Calibri" pitchFamily="34" charset="0"/>
+                <a:ea typeface="Calibri" pitchFamily="34" charset="-122"/>
+                <a:cs typeface="Calibri" pitchFamily="34" charset="-120"/>
+              </a:rPr>
+              <a:t>did system components boot into a predictable state?</a:t>
+            </a:r>
+            <a:pPr algn="l" indent="0" marL="0">
+              <a:spcAft>
+                <a:spcPts val="1000"/>
+              </a:spcAft>
+              <a:buNone/>
+            </a:pPr>
+            <a:r>
+              <a:rPr lang="en-US" sz="1700" dirty="0">
+                <a:solidFill>
+                  <a:srgbClr val="212121"/>
+                </a:solidFill>
+                <a:latin typeface="Calibri" pitchFamily="34" charset="0"/>
+                <a:ea typeface="Calibri" pitchFamily="34" charset="-122"/>
+                <a:cs typeface="Calibri" pitchFamily="34" charset="-120"/>
+              </a:rPr>
+              <a:t> (boot-time, static runtime)</a:t>
+            </a:r>
+            <a:endParaRPr lang="en-US" sz="1700" dirty="0"/>
+          </a:p>
+          <a:p>
+            <a:pPr algn="l" marL="342900" indent="-342900">
+              <a:buSzPct val="100000"/>
+              <a:buChar char="•"/>
+            </a:pPr>
+            <a:r>
+              <a:rPr lang="en-US" sz="1700" b="1" dirty="0">
+                <a:solidFill>
+                  <a:srgbClr val="212121"/>
+                </a:solidFill>
+                <a:latin typeface="Calibri" pitchFamily="34" charset="0"/>
+                <a:ea typeface="Calibri" pitchFamily="34" charset="-122"/>
+                <a:cs typeface="Calibri" pitchFamily="34" charset="-120"/>
+              </a:rPr>
+              <a:t>Layered, runtime attestation: </a:t>
+            </a:r>
+            <a:pPr algn="l" indent="0" marL="0">
+              <a:buNone/>
+            </a:pPr>
+            <a:r>
+              <a:rPr lang="en-US" sz="1700" dirty="0">
+                <a:solidFill>
+                  <a:srgbClr val="212121"/>
+                </a:solidFill>
+                <a:latin typeface="Calibri" pitchFamily="34" charset="0"/>
+                <a:ea typeface="Calibri" pitchFamily="34" charset="-122"/>
+                <a:cs typeface="Calibri" pitchFamily="34" charset="-120"/>
+              </a:rPr>
+              <a:t>extend boot-time trust via dynamic measurement of system components </a:t>
+            </a:r>
+            <a:pPr algn="l" indent="0" marL="0">
+              <a:spcAft>
+                <a:spcPts val="1000"/>
+              </a:spcAft>
+              <a:buNone/>
+            </a:pPr>
+            <a:r>
+              <a:rPr lang="en-US" sz="1700" b="1" dirty="0">
+                <a:solidFill>
+                  <a:srgbClr val="212121"/>
+                </a:solidFill>
+                <a:latin typeface="Calibri" pitchFamily="34" charset="0"/>
+                <a:ea typeface="Calibri" pitchFamily="34" charset="-122"/>
+                <a:cs typeface="Calibri" pitchFamily="34" charset="-120"/>
+              </a:rPr>
+              <a:t>and their context/dependencies</a:t>
+            </a:r>
+            <a:endParaRPr lang="en-US" sz="1700" dirty="0"/>
+          </a:p>
+          <a:p>
+            <a:pPr algn="l" marL="342900" indent="-342900">
+              <a:buSzPct val="100000"/>
+              <a:buChar char="•"/>
+            </a:pPr>
+            <a:r>
+              <a:rPr lang="en-US" sz="1700" b="1" dirty="0">
+                <a:solidFill>
+                  <a:srgbClr val="212121"/>
+                </a:solidFill>
+                <a:latin typeface="Calibri" pitchFamily="34" charset="0"/>
+                <a:ea typeface="Calibri" pitchFamily="34" charset="-122"/>
+                <a:cs typeface="Calibri" pitchFamily="34" charset="-120"/>
+              </a:rPr>
+              <a:t>Lifecycle attestation: </a:t>
+            </a:r>
+            <a:pPr algn="l" indent="0" marL="0">
+              <a:buNone/>
+            </a:pPr>
+            <a:r>
+              <a:rPr lang="en-US" sz="1700" dirty="0">
+                <a:solidFill>
+                  <a:srgbClr val="212121"/>
+                </a:solidFill>
+                <a:latin typeface="Calibri" pitchFamily="34" charset="0"/>
+                <a:ea typeface="Calibri" pitchFamily="34" charset="-122"/>
+                <a:cs typeface="Calibri" pitchFamily="34" charset="-120"/>
+              </a:rPr>
+              <a:t>extends this notion to </a:t>
+            </a:r>
+            <a:pPr algn="l" indent="0" marL="0">
+              <a:buNone/>
+            </a:pPr>
+            <a:r>
+              <a:rPr lang="en-US" sz="1700" b="1" dirty="0">
+                <a:solidFill>
+                  <a:srgbClr val="212121"/>
+                </a:solidFill>
+                <a:latin typeface="Calibri" pitchFamily="34" charset="0"/>
+                <a:ea typeface="Calibri" pitchFamily="34" charset="-122"/>
+                <a:cs typeface="Calibri" pitchFamily="34" charset="-120"/>
+              </a:rPr>
+              <a:t>artifacts of the development lifecycle</a:t>
+            </a:r>
+            <a:pPr algn="l" indent="0" marL="0">
+              <a:spcAft>
+                <a:spcPts val="1000"/>
+              </a:spcAft>
+              <a:buNone/>
+            </a:pPr>
+            <a:r>
+              <a:rPr lang="en-US" sz="1700" dirty="0">
+                <a:solidFill>
+                  <a:srgbClr val="212121"/>
+                </a:solidFill>
+                <a:latin typeface="Calibri" pitchFamily="34" charset="0"/>
+                <a:ea typeface="Calibri" pitchFamily="34" charset="-122"/>
+                <a:cs typeface="Calibri" pitchFamily="34" charset="-120"/>
+              </a:rPr>
+              <a:t>: models, contracts, implementations, proofs, toolchains</a:t>
+            </a:r>
+            <a:endParaRPr lang="en-US" sz="1700" dirty="0"/>
+          </a:p>
+          <a:p>
+            <a:pPr algn="l" lvl="1" marL="685800" indent="-342900">
+              <a:spcAft>
+                <a:spcPts val="1000"/>
+              </a:spcAft>
+              <a:buSzPct val="100000"/>
+              <a:buChar char="–"/>
+            </a:pPr>
+            <a:r>
+              <a:rPr lang="en-US" sz="1700" dirty="0">
+                <a:solidFill>
+                  <a:srgbClr val="212121"/>
+                </a:solidFill>
+                <a:latin typeface="Calibri" pitchFamily="34" charset="0"/>
+                <a:ea typeface="Calibri" pitchFamily="34" charset="-122"/>
+                <a:cs typeface="Calibri" pitchFamily="34" charset="-120"/>
+              </a:rPr>
+              <a:t>…including the attestation infrastructure and evidence itself</a:t>
+            </a:r>
+            <a:endParaRPr lang="en-US" sz="1700" dirty="0"/>
+          </a:p>
+          <a:p>
+            <a:pPr algn="l" lvl="1" marL="685800" indent="-342900">
+              <a:spcAft>
+                <a:spcPts val="1000"/>
+              </a:spcAft>
+              <a:buSzPct val="100000"/>
+              <a:buChar char="–"/>
+            </a:pPr>
+            <a:r>
+              <a:rPr lang="en-US" sz="1700" dirty="0">
+                <a:solidFill>
+                  <a:srgbClr val="212121"/>
+                </a:solidFill>
+                <a:latin typeface="Calibri" pitchFamily="34" charset="0"/>
+                <a:ea typeface="Calibri" pitchFamily="34" charset="-122"/>
+                <a:cs typeface="Calibri" pitchFamily="34" charset="-120"/>
+              </a:rPr>
+              <a:t>…and to natural lifecycle events:</a:t>
+            </a:r>
+            <a:endParaRPr lang="en-US" sz="1700" dirty="0"/>
+          </a:p>
+          <a:p>
+            <a:pPr algn="l" lvl="2" marL="1028700" indent="-342900">
+              <a:spcAft>
+                <a:spcPts val="200"/>
+              </a:spcAft>
+              <a:buSzPct val="100000"/>
+              <a:buChar char="▪"/>
+            </a:pPr>
+            <a:r>
+              <a:rPr lang="en-US" sz="1700" dirty="0">
+                <a:solidFill>
+                  <a:srgbClr val="212121"/>
+                </a:solidFill>
+                <a:latin typeface="Calibri" pitchFamily="34" charset="0"/>
+                <a:ea typeface="Calibri" pitchFamily="34" charset="-122"/>
+                <a:cs typeface="Calibri" pitchFamily="34" charset="-120"/>
+              </a:rPr>
+              <a:t>specification drift </a:t>
+            </a:r>
+            <a:endParaRPr lang="en-US" sz="1700" dirty="0"/>
+          </a:p>
+          <a:p>
+            <a:pPr algn="l" lvl="2" marL="1028700" indent="-342900">
+              <a:spcAft>
+                <a:spcPts val="200"/>
+              </a:spcAft>
+              <a:buSzPct val="100000"/>
+              <a:buChar char="▪"/>
+            </a:pPr>
+            <a:r>
+              <a:rPr lang="en-US" sz="1700" dirty="0">
+                <a:solidFill>
+                  <a:srgbClr val="212121"/>
+                </a:solidFill>
+                <a:latin typeface="Calibri" pitchFamily="34" charset="0"/>
+                <a:ea typeface="Calibri" pitchFamily="34" charset="-122"/>
+                <a:cs typeface="Calibri" pitchFamily="34" charset="-120"/>
+              </a:rPr>
+              <a:t>toolchain updates</a:t>
+            </a:r>
+            <a:endParaRPr lang="en-US" sz="1700" dirty="0"/>
+          </a:p>
+          <a:p>
+            <a:pPr algn="l" lvl="2" marL="1028700" indent="-342900">
+              <a:spcAft>
+                <a:spcPts val="200"/>
+              </a:spcAft>
+              <a:buSzPct val="100000"/>
+              <a:buChar char="▪"/>
+            </a:pPr>
+            <a:r>
+              <a:rPr lang="en-US" sz="1700" dirty="0">
+                <a:solidFill>
+                  <a:srgbClr val="212121"/>
+                </a:solidFill>
+                <a:latin typeface="Calibri" pitchFamily="34" charset="0"/>
+                <a:ea typeface="Calibri" pitchFamily="34" charset="-122"/>
+                <a:cs typeface="Calibri" pitchFamily="34" charset="-120"/>
+              </a:rPr>
+              <a:t>artifact updates, synthesis, repair</a:t>
+            </a:r>
+            <a:endParaRPr lang="en-US" sz="1700" dirty="0"/>
+          </a:p>
+          <a:p>
+            <a:pPr algn="l" marL="342900" indent="-342900">
+              <a:buSzPct val="100000"/>
+              <a:buChar char="•"/>
+            </a:pPr>
+            <a:r>
+              <a:rPr lang="en-US" sz="1700" b="1" dirty="0">
+                <a:solidFill>
+                  <a:srgbClr val="212121"/>
+                </a:solidFill>
+                <a:latin typeface="Calibri" pitchFamily="34" charset="0"/>
+                <a:ea typeface="Calibri" pitchFamily="34" charset="-122"/>
+                <a:cs typeface="Calibri" pitchFamily="34" charset="-120"/>
+              </a:rPr>
+              <a:t>Motivation: </a:t>
+            </a:r>
+            <a:pPr algn="l" indent="0" marL="0">
+              <a:buNone/>
+            </a:pPr>
+            <a:r>
+              <a:rPr lang="en-US" sz="1700" dirty="0">
+                <a:solidFill>
+                  <a:srgbClr val="212121"/>
+                </a:solidFill>
+                <a:latin typeface="Calibri" pitchFamily="34" charset="0"/>
+                <a:ea typeface="Calibri" pitchFamily="34" charset="-122"/>
+                <a:cs typeface="Calibri" pitchFamily="34" charset="-120"/>
+              </a:rPr>
+              <a:t>the </a:t>
+            </a:r>
+            <a:pPr algn="l" indent="0" marL="0">
+              <a:buNone/>
+            </a:pPr>
+            <a:r>
+              <a:rPr lang="en-US" sz="1700" b="1" dirty="0">
+                <a:solidFill>
+                  <a:srgbClr val="212121"/>
+                </a:solidFill>
+                <a:latin typeface="Calibri" pitchFamily="34" charset="0"/>
+                <a:ea typeface="Calibri" pitchFamily="34" charset="-122"/>
+                <a:cs typeface="Calibri" pitchFamily="34" charset="-120"/>
+              </a:rPr>
+              <a:t>proliferation of AI-generated software artifacts</a:t>
+            </a:r>
+            <a:pPr algn="l" indent="0" marL="0">
+              <a:spcAft>
+                <a:spcPts val="1000"/>
+              </a:spcAft>
+              <a:buNone/>
+            </a:pPr>
+            <a:r>
+              <a:rPr lang="en-US" sz="1700" dirty="0">
+                <a:solidFill>
+                  <a:srgbClr val="212121"/>
+                </a:solidFill>
+                <a:latin typeface="Calibri" pitchFamily="34" charset="0"/>
+                <a:ea typeface="Calibri" pitchFamily="34" charset="-122"/>
+                <a:cs typeface="Calibri" pitchFamily="34" charset="-120"/>
+              </a:rPr>
+              <a:t>, amid the need for rapid re-certification of systems</a:t>
+            </a:r>
+            <a:endParaRPr lang="en-US" sz="1700" dirty="0"/>
+          </a:p>
+        </p:txBody>
+      </p:sp>
+      <p:sp>
+        <p:nvSpPr>
+          <p:cNvPr id="4" name="Shape 2"/>
+          <p:cNvSpPr/>
+          <p:nvPr/>
+        </p:nvSpPr>
+        <p:spPr>
+          <a:xfrm>
+            <a:off x="640080" y="4901184"/>
+            <a:ext cx="10881360" cy="1234440"/>
           </a:xfrm>
           <a:prstGeom prst="roundRect">
             <a:avLst>
-              <a:gd name="adj" fmla="val 8235"/>
+              <a:gd name="adj" fmla="val 5926"/>
             </a:avLst>
           </a:prstGeom>
           <a:solidFill>
@@ -13851,14 +14199,14 @@
       </p:sp>
       <p:sp>
         <p:nvSpPr>
-          <p:cNvPr id="4" name="Text 2"/>
-          <p:cNvSpPr/>
-          <p:nvPr/>
-        </p:nvSpPr>
-        <p:spPr>
-          <a:xfrm>
-            <a:off x="640080" y="2834640"/>
-            <a:ext cx="2044598" cy="777240"/>
+          <p:cNvPr id="5" name="Text 3"/>
+          <p:cNvSpPr/>
+          <p:nvPr/>
+        </p:nvSpPr>
+        <p:spPr>
+          <a:xfrm>
+            <a:off x="914400" y="4901184"/>
+            <a:ext cx="10332720" cy="1234440"/>
           </a:xfrm>
           <a:prstGeom prst="rect">
             <a:avLst/>
@@ -13867,480 +14215,44 @@
           <a:ln/>
         </p:spPr>
         <p:txBody>
-          <a:bodyPr wrap="square" lIns="254" tIns="254" rIns="254" bIns="254" rtlCol="0" anchor="ctr"/>
-          <a:lstStyle/>
-          <a:p>
-            <a:pPr algn="ctr" indent="0" marL="0">
-              <a:buNone/>
-            </a:pPr>
-            <a:r>
-              <a:rPr lang="en-US" sz="1350" b="1" dirty="0">
-                <a:solidFill>
-                  <a:srgbClr val="FFFFFF"/>
-                </a:solidFill>
-                <a:latin typeface="Calibri" pitchFamily="34" charset="0"/>
-                <a:ea typeface="Calibri" pitchFamily="34" charset="-122"/>
-                <a:cs typeface="Calibri" pitchFamily="34" charset="-120"/>
-              </a:rPr>
-              <a:t>Preliminaries</a:t>
-            </a:r>
-            <a:endParaRPr lang="en-US" sz="1350" dirty="0"/>
-          </a:p>
-        </p:txBody>
-      </p:sp>
-      <p:sp>
-        <p:nvSpPr>
-          <p:cNvPr id="5" name="Text 3"/>
-          <p:cNvSpPr/>
-          <p:nvPr/>
-        </p:nvSpPr>
-        <p:spPr>
-          <a:xfrm>
-            <a:off x="2629814" y="2834640"/>
-            <a:ext cx="274320" cy="777240"/>
-          </a:xfrm>
-          <a:prstGeom prst="rect">
-            <a:avLst/>
-          </a:prstGeom>
-          <a:noFill/>
-          <a:ln/>
-        </p:spPr>
-        <p:txBody>
           <a:bodyPr wrap="square" lIns="0" tIns="0" rIns="0" bIns="0" rtlCol="0" anchor="ctr"/>
           <a:lstStyle/>
           <a:p>
             <a:pPr algn="ctr" indent="0" marL="0">
-              <a:buNone/>
-            </a:pPr>
-            <a:r>
-              <a:rPr lang="en-US" sz="1400" dirty="0">
-                <a:solidFill>
-                  <a:srgbClr val="5A6478"/>
-                </a:solidFill>
-                <a:latin typeface="Calibri" pitchFamily="34" charset="0"/>
-                <a:ea typeface="Calibri" pitchFamily="34" charset="-122"/>
-                <a:cs typeface="Calibri" pitchFamily="34" charset="-120"/>
-              </a:rPr>
-              <a:t>→</a:t>
-            </a:r>
-            <a:endParaRPr lang="en-US" sz="1400" dirty="0"/>
-          </a:p>
-        </p:txBody>
-      </p:sp>
-      <p:sp>
-        <p:nvSpPr>
-          <p:cNvPr id="6" name="Shape 4"/>
-          <p:cNvSpPr/>
-          <p:nvPr/>
-        </p:nvSpPr>
-        <p:spPr>
-          <a:xfrm>
-            <a:off x="2849270" y="2834640"/>
-            <a:ext cx="2044598" cy="777240"/>
-          </a:xfrm>
-          <a:prstGeom prst="roundRect">
-            <a:avLst>
-              <a:gd name="adj" fmla="val 8235"/>
-            </a:avLst>
-          </a:prstGeom>
-          <a:solidFill>
-            <a:srgbClr val="CADCFC"/>
-          </a:solidFill>
-          <a:ln/>
-        </p:spPr>
-      </p:sp>
-      <p:sp>
-        <p:nvSpPr>
-          <p:cNvPr id="7" name="Text 5"/>
-          <p:cNvSpPr/>
-          <p:nvPr/>
-        </p:nvSpPr>
-        <p:spPr>
-          <a:xfrm>
-            <a:off x="2849270" y="2834640"/>
-            <a:ext cx="2044598" cy="777240"/>
-          </a:xfrm>
-          <a:prstGeom prst="rect">
-            <a:avLst/>
-          </a:prstGeom>
-          <a:noFill/>
-          <a:ln/>
-        </p:spPr>
-        <p:txBody>
-          <a:bodyPr wrap="square" lIns="254" tIns="254" rIns="254" bIns="254" rtlCol="0" anchor="ctr"/>
-          <a:lstStyle/>
+              <a:spcAft>
+                <a:spcPts val="400"/>
+              </a:spcAft>
+              <a:buNone/>
+            </a:pPr>
+            <a:r>
+              <a:rPr lang="en-US" sz="2000" b="1" dirty="0">
+                <a:solidFill>
+                  <a:srgbClr val="FFFFFF"/>
+                </a:solidFill>
+                <a:latin typeface="Calibri" pitchFamily="34" charset="0"/>
+                <a:ea typeface="Calibri" pitchFamily="34" charset="-122"/>
+                <a:cs typeface="Calibri" pitchFamily="34" charset="-120"/>
+              </a:rPr>
+              <a:t>Every trust decision is grounded in cryptographic attestation evidence.</a:t>
+            </a:r>
+            <a:endParaRPr lang="en-US" sz="2000" dirty="0"/>
+          </a:p>
           <a:p>
             <a:pPr algn="ctr" indent="0" marL="0">
               <a:buNone/>
             </a:pPr>
             <a:r>
-              <a:rPr lang="en-US" sz="1350" dirty="0">
-                <a:solidFill>
-                  <a:srgbClr val="1E2761"/>
-                </a:solidFill>
-                <a:latin typeface="Calibri" pitchFamily="34" charset="0"/>
-                <a:ea typeface="Calibri" pitchFamily="34" charset="-122"/>
-                <a:cs typeface="Calibri" pitchFamily="34" charset="-120"/>
-              </a:rPr>
-              <a:t>Demo:</a:t>
-            </a:r>
-            <a:endParaRPr lang="en-US" sz="1350" dirty="0"/>
-          </a:p>
-          <a:p>
-            <a:pPr algn="ctr" indent="0" marL="0">
-              <a:buNone/>
-            </a:pPr>
-            <a:r>
-              <a:rPr lang="en-US" sz="1350" dirty="0">
-                <a:solidFill>
-                  <a:srgbClr val="1E2761"/>
-                </a:solidFill>
-                <a:latin typeface="Calibri" pitchFamily="34" charset="0"/>
-                <a:ea typeface="Calibri" pitchFamily="34" charset="-122"/>
-                <a:cs typeface="Calibri" pitchFamily="34" charset="-120"/>
-              </a:rPr>
-              <a:t>Isolette (SysMLv2 → Rust)</a:t>
-            </a:r>
-            <a:endParaRPr lang="en-US" sz="1350" dirty="0"/>
-          </a:p>
-        </p:txBody>
-      </p:sp>
-      <p:sp>
-        <p:nvSpPr>
-          <p:cNvPr id="8" name="Text 6"/>
-          <p:cNvSpPr/>
-          <p:nvPr/>
-        </p:nvSpPr>
-        <p:spPr>
-          <a:xfrm>
-            <a:off x="4839005" y="2834640"/>
-            <a:ext cx="274320" cy="777240"/>
-          </a:xfrm>
-          <a:prstGeom prst="rect">
-            <a:avLst/>
-          </a:prstGeom>
-          <a:noFill/>
-          <a:ln/>
-        </p:spPr>
-        <p:txBody>
-          <a:bodyPr wrap="square" lIns="0" tIns="0" rIns="0" bIns="0" rtlCol="0" anchor="ctr"/>
-          <a:lstStyle/>
-          <a:p>
-            <a:pPr algn="ctr" indent="0" marL="0">
-              <a:buNone/>
-            </a:pPr>
-            <a:r>
-              <a:rPr lang="en-US" sz="1400" dirty="0">
-                <a:solidFill>
-                  <a:srgbClr val="5A6478"/>
-                </a:solidFill>
-                <a:latin typeface="Calibri" pitchFamily="34" charset="0"/>
-                <a:ea typeface="Calibri" pitchFamily="34" charset="-122"/>
-                <a:cs typeface="Calibri" pitchFamily="34" charset="-120"/>
-              </a:rPr>
-              <a:t>→</a:t>
-            </a:r>
-            <a:endParaRPr lang="en-US" sz="1400" dirty="0"/>
-          </a:p>
-        </p:txBody>
-      </p:sp>
-      <p:sp>
-        <p:nvSpPr>
-          <p:cNvPr id="9" name="Shape 7"/>
-          <p:cNvSpPr/>
-          <p:nvPr/>
-        </p:nvSpPr>
-        <p:spPr>
-          <a:xfrm>
-            <a:off x="5058461" y="2834640"/>
-            <a:ext cx="2044598" cy="777240"/>
-          </a:xfrm>
-          <a:prstGeom prst="roundRect">
-            <a:avLst>
-              <a:gd name="adj" fmla="val 8235"/>
-            </a:avLst>
-          </a:prstGeom>
-          <a:solidFill>
-            <a:srgbClr val="CADCFC"/>
-          </a:solidFill>
-          <a:ln/>
-        </p:spPr>
-      </p:sp>
-      <p:sp>
-        <p:nvSpPr>
-          <p:cNvPr id="10" name="Text 8"/>
-          <p:cNvSpPr/>
-          <p:nvPr/>
-        </p:nvSpPr>
-        <p:spPr>
-          <a:xfrm>
-            <a:off x="5058461" y="2834640"/>
-            <a:ext cx="2044598" cy="777240"/>
-          </a:xfrm>
-          <a:prstGeom prst="rect">
-            <a:avLst/>
-          </a:prstGeom>
-          <a:noFill/>
-          <a:ln/>
-        </p:spPr>
-        <p:txBody>
-          <a:bodyPr wrap="square" lIns="254" tIns="254" rIns="254" bIns="254" rtlCol="0" anchor="ctr"/>
-          <a:lstStyle/>
-          <a:p>
-            <a:pPr algn="ctr" indent="0" marL="0">
-              <a:buNone/>
-            </a:pPr>
-            <a:r>
-              <a:rPr lang="en-US" sz="1350" dirty="0">
-                <a:solidFill>
-                  <a:srgbClr val="1E2761"/>
-                </a:solidFill>
-                <a:latin typeface="Calibri" pitchFamily="34" charset="0"/>
-                <a:ea typeface="Calibri" pitchFamily="34" charset="-122"/>
-                <a:cs typeface="Calibri" pitchFamily="34" charset="-120"/>
-              </a:rPr>
-              <a:t>Other Ecosystems</a:t>
-            </a:r>
-            <a:endParaRPr lang="en-US" sz="1350" dirty="0"/>
-          </a:p>
-        </p:txBody>
-      </p:sp>
-      <p:sp>
-        <p:nvSpPr>
-          <p:cNvPr id="11" name="Text 9"/>
-          <p:cNvSpPr/>
-          <p:nvPr/>
-        </p:nvSpPr>
-        <p:spPr>
-          <a:xfrm>
-            <a:off x="7048195" y="2834640"/>
-            <a:ext cx="274320" cy="777240"/>
-          </a:xfrm>
-          <a:prstGeom prst="rect">
-            <a:avLst/>
-          </a:prstGeom>
-          <a:noFill/>
-          <a:ln/>
-        </p:spPr>
-        <p:txBody>
-          <a:bodyPr wrap="square" lIns="0" tIns="0" rIns="0" bIns="0" rtlCol="0" anchor="ctr"/>
-          <a:lstStyle/>
-          <a:p>
-            <a:pPr algn="ctr" indent="0" marL="0">
-              <a:buNone/>
-            </a:pPr>
-            <a:r>
-              <a:rPr lang="en-US" sz="1400" dirty="0">
-                <a:solidFill>
-                  <a:srgbClr val="5A6478"/>
-                </a:solidFill>
-                <a:latin typeface="Calibri" pitchFamily="34" charset="0"/>
-                <a:ea typeface="Calibri" pitchFamily="34" charset="-122"/>
-                <a:cs typeface="Calibri" pitchFamily="34" charset="-120"/>
-              </a:rPr>
-              <a:t>→</a:t>
-            </a:r>
-            <a:endParaRPr lang="en-US" sz="1400" dirty="0"/>
-          </a:p>
-        </p:txBody>
-      </p:sp>
-      <p:sp>
-        <p:nvSpPr>
-          <p:cNvPr id="12" name="Shape 10"/>
-          <p:cNvSpPr/>
-          <p:nvPr/>
-        </p:nvSpPr>
-        <p:spPr>
-          <a:xfrm>
-            <a:off x="7267651" y="2834640"/>
-            <a:ext cx="2044598" cy="777240"/>
-          </a:xfrm>
-          <a:prstGeom prst="roundRect">
-            <a:avLst>
-              <a:gd name="adj" fmla="val 8235"/>
-            </a:avLst>
-          </a:prstGeom>
-          <a:solidFill>
-            <a:srgbClr val="CADCFC"/>
-          </a:solidFill>
-          <a:ln/>
-        </p:spPr>
-      </p:sp>
-      <p:sp>
-        <p:nvSpPr>
-          <p:cNvPr id="13" name="Text 11"/>
-          <p:cNvSpPr/>
-          <p:nvPr/>
-        </p:nvSpPr>
-        <p:spPr>
-          <a:xfrm>
-            <a:off x="7267651" y="2834640"/>
-            <a:ext cx="2044598" cy="777240"/>
-          </a:xfrm>
-          <a:prstGeom prst="rect">
-            <a:avLst/>
-          </a:prstGeom>
-          <a:noFill/>
-          <a:ln/>
-        </p:spPr>
-        <p:txBody>
-          <a:bodyPr wrap="square" lIns="254" tIns="254" rIns="254" bIns="254" rtlCol="0" anchor="ctr"/>
-          <a:lstStyle/>
-          <a:p>
-            <a:pPr algn="ctr" indent="0" marL="0">
-              <a:buNone/>
-            </a:pPr>
-            <a:r>
-              <a:rPr lang="en-US" sz="1350" dirty="0">
-                <a:solidFill>
-                  <a:srgbClr val="1E2761"/>
-                </a:solidFill>
-                <a:latin typeface="Calibri" pitchFamily="34" charset="0"/>
-                <a:ea typeface="Calibri" pitchFamily="34" charset="-122"/>
-                <a:cs typeface="Calibri" pitchFamily="34" charset="-120"/>
-              </a:rPr>
-              <a:t>AI in the Loop</a:t>
-            </a:r>
-            <a:endParaRPr lang="en-US" sz="1350" dirty="0"/>
-          </a:p>
-        </p:txBody>
-      </p:sp>
-      <p:sp>
-        <p:nvSpPr>
-          <p:cNvPr id="14" name="Text 12"/>
-          <p:cNvSpPr/>
-          <p:nvPr/>
-        </p:nvSpPr>
-        <p:spPr>
-          <a:xfrm>
-            <a:off x="9257386" y="2834640"/>
-            <a:ext cx="274320" cy="777240"/>
-          </a:xfrm>
-          <a:prstGeom prst="rect">
-            <a:avLst/>
-          </a:prstGeom>
-          <a:noFill/>
-          <a:ln/>
-        </p:spPr>
-        <p:txBody>
-          <a:bodyPr wrap="square" lIns="0" tIns="0" rIns="0" bIns="0" rtlCol="0" anchor="ctr"/>
-          <a:lstStyle/>
-          <a:p>
-            <a:pPr algn="ctr" indent="0" marL="0">
-              <a:buNone/>
-            </a:pPr>
-            <a:r>
-              <a:rPr lang="en-US" sz="1400" dirty="0">
-                <a:solidFill>
-                  <a:srgbClr val="5A6478"/>
-                </a:solidFill>
-                <a:latin typeface="Calibri" pitchFamily="34" charset="0"/>
-                <a:ea typeface="Calibri" pitchFamily="34" charset="-122"/>
-                <a:cs typeface="Calibri" pitchFamily="34" charset="-120"/>
-              </a:rPr>
-              <a:t>→</a:t>
-            </a:r>
-            <a:endParaRPr lang="en-US" sz="1400" dirty="0"/>
-          </a:p>
-        </p:txBody>
-      </p:sp>
-      <p:sp>
-        <p:nvSpPr>
-          <p:cNvPr id="15" name="Shape 13"/>
-          <p:cNvSpPr/>
-          <p:nvPr/>
-        </p:nvSpPr>
-        <p:spPr>
-          <a:xfrm>
-            <a:off x="9476842" y="2834640"/>
-            <a:ext cx="2044598" cy="777240"/>
-          </a:xfrm>
-          <a:prstGeom prst="roundRect">
-            <a:avLst>
-              <a:gd name="adj" fmla="val 8235"/>
-            </a:avLst>
-          </a:prstGeom>
-          <a:solidFill>
-            <a:srgbClr val="CADCFC"/>
-          </a:solidFill>
-          <a:ln/>
-        </p:spPr>
-      </p:sp>
-      <p:sp>
-        <p:nvSpPr>
-          <p:cNvPr id="16" name="Text 14"/>
-          <p:cNvSpPr/>
-          <p:nvPr/>
-        </p:nvSpPr>
-        <p:spPr>
-          <a:xfrm>
-            <a:off x="9476842" y="2834640"/>
-            <a:ext cx="2044598" cy="777240"/>
-          </a:xfrm>
-          <a:prstGeom prst="rect">
-            <a:avLst/>
-          </a:prstGeom>
-          <a:noFill/>
-          <a:ln/>
-        </p:spPr>
-        <p:txBody>
-          <a:bodyPr wrap="square" lIns="254" tIns="254" rIns="254" bIns="254" rtlCol="0" anchor="ctr"/>
-          <a:lstStyle/>
-          <a:p>
-            <a:pPr algn="ctr" indent="0" marL="0">
-              <a:buNone/>
-            </a:pPr>
-            <a:r>
-              <a:rPr lang="en-US" sz="1350" dirty="0">
-                <a:solidFill>
-                  <a:srgbClr val="1E2761"/>
-                </a:solidFill>
-                <a:latin typeface="Calibri" pitchFamily="34" charset="0"/>
-                <a:ea typeface="Calibri" pitchFamily="34" charset="-122"/>
-                <a:cs typeface="Calibri" pitchFamily="34" charset="-120"/>
-              </a:rPr>
-              <a:t>Close</a:t>
-            </a:r>
-            <a:endParaRPr lang="en-US" sz="1350" dirty="0"/>
-          </a:p>
-        </p:txBody>
-      </p:sp>
-      <p:sp>
-        <p:nvSpPr>
-          <p:cNvPr id="17" name="Text 15"/>
-          <p:cNvSpPr/>
-          <p:nvPr/>
-        </p:nvSpPr>
-        <p:spPr>
-          <a:xfrm>
-            <a:off x="640080" y="3977640"/>
-            <a:ext cx="10881360" cy="365760"/>
-          </a:xfrm>
-          <a:prstGeom prst="rect">
-            <a:avLst/>
-          </a:prstGeom>
-          <a:noFill/>
-          <a:ln/>
-        </p:spPr>
-        <p:txBody>
-          <a:bodyPr wrap="square" lIns="0" tIns="0" rIns="0" bIns="0" rtlCol="0" anchor="ctr"/>
-          <a:lstStyle/>
-          <a:p>
-            <a:pPr indent="0" marL="0">
-              <a:buNone/>
-            </a:pPr>
-            <a:r>
-              <a:rPr lang="en-US" sz="1300" i="1" dirty="0">
-                <a:solidFill>
-                  <a:srgbClr val="5A6478"/>
-                </a:solidFill>
-                <a:latin typeface="Calibri" pitchFamily="34" charset="0"/>
-                <a:ea typeface="Calibri" pitchFamily="34" charset="-122"/>
-                <a:cs typeface="Calibri" pitchFamily="34" charset="-120"/>
-              </a:rPr>
-              <a:t>Section headers provisional — the strip returns at every act transition with the current section highlighted.</a:t>
-            </a:r>
-            <a:endParaRPr lang="en-US" sz="1300" dirty="0"/>
+              <a:rPr lang="en-US" sz="1400" i="1" dirty="0">
+                <a:solidFill>
+                  <a:srgbClr val="CADCFC"/>
+                </a:solidFill>
+                <a:latin typeface="Calibri" pitchFamily="34" charset="0"/>
+                <a:ea typeface="Calibri" pitchFamily="34" charset="-122"/>
+                <a:cs typeface="Calibri" pitchFamily="34" charset="-120"/>
+              </a:rPr>
+              <a:t>Trust is NOT anchored in the following:  developer claims, untrusted tools, LLM outputs, cached verdicts</a:t>
+            </a:r>
+            <a:endParaRPr lang="en-US" sz="2000" dirty="0"/>
           </a:p>
         </p:txBody>
       </p:sp>
@@ -14490,7 +14402,7 @@
                 <a:ea typeface="Calibri" pitchFamily="34" charset="-122"/>
                 <a:cs typeface="Calibri" pitchFamily="34" charset="-120"/>
               </a:rPr>
-              <a:t>attestation protocols as formal terms with an evidence semantics: what was measured, in what order, signed by whom</a:t>
+              <a:t>attestation protocols as formal terms with an evidence semantics</a:t>
             </a:r>
             <a:endParaRPr lang="en-US" sz="1700" dirty="0"/>
           </a:p>
@@ -14590,7 +14502,7 @@
                 <a:ea typeface="Calibri" pitchFamily="34" charset="-122"/>
                 <a:cs typeface="Calibri" pitchFamily="34" charset="-120"/>
               </a:rPr>
-              <a:t>CVM — Copland Virtual Machine</a:t>
+              <a:t>Copland Virtual Machine (CVM)</a:t>
             </a:r>
             <a:endParaRPr lang="en-US" sz="1700" dirty="0"/>
           </a:p>
@@ -14888,7 +14800,7 @@
                 <a:ea typeface="Calibri" pitchFamily="34" charset="-122"/>
                 <a:cs typeface="Calibri" pitchFamily="34" charset="-120"/>
               </a:rPr>
-              <a:t>A real protocol from the demo — the isolette model class:</a:t>
+              <a:t>Copland protocol from the demo — the Isolette model class:</a:t>
             </a:r>
             <a:endParaRPr lang="en-US" sz="1300" dirty="0"/>
           </a:p>
@@ -15078,7 +14990,7 @@
                 <a:ea typeface="Calibri" pitchFamily="34" charset="-122"/>
                 <a:cs typeface="Calibri" pitchFamily="34" charset="-120"/>
               </a:rPr>
-              <a:t>measure the five blessed model files → </a:t>
+              <a:t>measure five blessed model files → </a:t>
             </a:r>
             <a:endParaRPr lang="en-US" sz="2000" dirty="0"/>
           </a:p>

</xml_diff>

<commit_message>
slide 3: restore user's reduced bolding (lead-in labels plain, emphasis on key phrases)
The previous port re-added the old bold lead-ins on the lifecycle
attestation slide because the comparison ignored run formatting. Now
matches the PowerPoint-saved deck exactly: labels un-bolded, "and their
context/dependencies" un-bolded, "rapid re-certification of systems" bolded.

Co-Authored-By: Claude Fable 5.1 <noreply@anthropic.com>
</commit_message>
<xml_diff>
--- a/docs/video_slides_draft.pptx
+++ b/docs/video_slides_draft.pptx
@@ -13846,10 +13846,45 @@
           <a:lstStyle/>
           <a:p>
             <a:pPr algn="l" marL="342900" indent="-342900">
+              <a:spcAft>
+                <a:spcPts val="1000"/>
+              </a:spcAft>
               <a:buSzPct val="100000"/>
               <a:buChar char="•"/>
             </a:pPr>
             <a:r>
+              <a:rPr lang="en-US" sz="1700" dirty="0">
+                <a:solidFill>
+                  <a:srgbClr val="212121"/>
+                </a:solidFill>
+                <a:latin typeface="Calibri" pitchFamily="34" charset="0"/>
+                <a:ea typeface="Calibri" pitchFamily="34" charset="-122"/>
+                <a:cs typeface="Calibri" pitchFamily="34" charset="-120"/>
+              </a:rPr>
+              <a:t>Traditional remote attestation: did system components boot into a predictable state? (boot-time, static runtime)</a:t>
+            </a:r>
+            <a:endParaRPr lang="en-US" sz="1700" dirty="0"/>
+          </a:p>
+          <a:p>
+            <a:pPr algn="l" marL="342900" indent="-342900">
+              <a:buSzPct val="100000"/>
+              <a:buChar char="•"/>
+            </a:pPr>
+            <a:r>
+              <a:rPr lang="en-US" sz="1700" dirty="0">
+                <a:solidFill>
+                  <a:srgbClr val="212121"/>
+                </a:solidFill>
+                <a:latin typeface="Calibri" pitchFamily="34" charset="0"/>
+                <a:ea typeface="Calibri" pitchFamily="34" charset="-122"/>
+                <a:cs typeface="Calibri" pitchFamily="34" charset="-120"/>
+              </a:rPr>
+              <a:t>Layered, runtime attestation</a:t>
+            </a:r>
+            <a:pPr algn="l" indent="0" marL="0">
+              <a:buNone/>
+            </a:pPr>
+            <a:r>
               <a:rPr lang="en-US" sz="1700" b="1" dirty="0">
                 <a:solidFill>
                   <a:srgbClr val="212121"/>
@@ -13858,21 +13893,7 @@
                 <a:ea typeface="Calibri" pitchFamily="34" charset="-122"/>
                 <a:cs typeface="Calibri" pitchFamily="34" charset="-120"/>
               </a:rPr>
-              <a:t>Traditional remote attestation: </a:t>
-            </a:r>
-            <a:pPr algn="l" indent="0" marL="0">
-              <a:buNone/>
-            </a:pPr>
-            <a:r>
-              <a:rPr lang="en-US" sz="1700" b="1" dirty="0">
-                <a:solidFill>
-                  <a:srgbClr val="212121"/>
-                </a:solidFill>
-                <a:latin typeface="Calibri" pitchFamily="34" charset="0"/>
-                <a:ea typeface="Calibri" pitchFamily="34" charset="-122"/>
-                <a:cs typeface="Calibri" pitchFamily="34" charset="-120"/>
-              </a:rPr>
-              <a:t>did system components boot into a predictable state?</a:t>
+              <a:t>: </a:t>
             </a:r>
             <a:pPr algn="l" indent="0" marL="0">
               <a:spcAft>
@@ -13889,7 +13910,7 @@
                 <a:ea typeface="Calibri" pitchFamily="34" charset="-122"/>
                 <a:cs typeface="Calibri" pitchFamily="34" charset="-120"/>
               </a:rPr>
-              <a:t> (boot-time, static runtime)</a:t>
+              <a:t>extend boot-time trust via dynamic measurement of system components and their context/dependencies</a:t>
             </a:r>
             <a:endParaRPr lang="en-US" sz="1700" dirty="0"/>
           </a:p>
@@ -13899,6 +13920,20 @@
               <a:buChar char="•"/>
             </a:pPr>
             <a:r>
+              <a:rPr lang="en-US" sz="1700" dirty="0">
+                <a:solidFill>
+                  <a:srgbClr val="212121"/>
+                </a:solidFill>
+                <a:latin typeface="Calibri" pitchFamily="34" charset="0"/>
+                <a:ea typeface="Calibri" pitchFamily="34" charset="-122"/>
+                <a:cs typeface="Calibri" pitchFamily="34" charset="-120"/>
+              </a:rPr>
+              <a:t>Lifecycle attestation</a:t>
+            </a:r>
+            <a:pPr algn="l" indent="0" marL="0">
+              <a:buNone/>
+            </a:pPr>
+            <a:r>
               <a:rPr lang="en-US" sz="1700" b="1" dirty="0">
                 <a:solidFill>
                   <a:srgbClr val="212121"/>
@@ -13907,56 +13942,7 @@
                 <a:ea typeface="Calibri" pitchFamily="34" charset="-122"/>
                 <a:cs typeface="Calibri" pitchFamily="34" charset="-120"/>
               </a:rPr>
-              <a:t>Layered, runtime attestation: </a:t>
-            </a:r>
-            <a:pPr algn="l" indent="0" marL="0">
-              <a:buNone/>
-            </a:pPr>
-            <a:r>
-              <a:rPr lang="en-US" sz="1700" dirty="0">
-                <a:solidFill>
-                  <a:srgbClr val="212121"/>
-                </a:solidFill>
-                <a:latin typeface="Calibri" pitchFamily="34" charset="0"/>
-                <a:ea typeface="Calibri" pitchFamily="34" charset="-122"/>
-                <a:cs typeface="Calibri" pitchFamily="34" charset="-120"/>
-              </a:rPr>
-              <a:t>extend boot-time trust via dynamic measurement of system components </a:t>
-            </a:r>
-            <a:pPr algn="l" indent="0" marL="0">
-              <a:spcAft>
-                <a:spcPts val="1000"/>
-              </a:spcAft>
-              <a:buNone/>
-            </a:pPr>
-            <a:r>
-              <a:rPr lang="en-US" sz="1700" b="1" dirty="0">
-                <a:solidFill>
-                  <a:srgbClr val="212121"/>
-                </a:solidFill>
-                <a:latin typeface="Calibri" pitchFamily="34" charset="0"/>
-                <a:ea typeface="Calibri" pitchFamily="34" charset="-122"/>
-                <a:cs typeface="Calibri" pitchFamily="34" charset="-120"/>
-              </a:rPr>
-              <a:t>and their context/dependencies</a:t>
-            </a:r>
-            <a:endParaRPr lang="en-US" sz="1700" dirty="0"/>
-          </a:p>
-          <a:p>
-            <a:pPr algn="l" marL="342900" indent="-342900">
-              <a:buSzPct val="100000"/>
-              <a:buChar char="•"/>
-            </a:pPr>
-            <a:r>
-              <a:rPr lang="en-US" sz="1700" b="1" dirty="0">
-                <a:solidFill>
-                  <a:srgbClr val="212121"/>
-                </a:solidFill>
-                <a:latin typeface="Calibri" pitchFamily="34" charset="0"/>
-                <a:ea typeface="Calibri" pitchFamily="34" charset="-122"/>
-                <a:cs typeface="Calibri" pitchFamily="34" charset="-120"/>
-              </a:rPr>
-              <a:t>Lifecycle attestation: </a:t>
+              <a:t>: </a:t>
             </a:r>
             <a:pPr algn="l" indent="0" marL="0">
               <a:buNone/>
@@ -14116,6 +14102,20 @@
               <a:buChar char="•"/>
             </a:pPr>
             <a:r>
+              <a:rPr lang="en-US" sz="1700" dirty="0">
+                <a:solidFill>
+                  <a:srgbClr val="212121"/>
+                </a:solidFill>
+                <a:latin typeface="Calibri" pitchFamily="34" charset="0"/>
+                <a:ea typeface="Calibri" pitchFamily="34" charset="-122"/>
+                <a:cs typeface="Calibri" pitchFamily="34" charset="-120"/>
+              </a:rPr>
+              <a:t>Motivation</a:t>
+            </a:r>
+            <a:pPr algn="l" indent="0" marL="0">
+              <a:buNone/>
+            </a:pPr>
+            <a:r>
               <a:rPr lang="en-US" sz="1700" b="1" dirty="0">
                 <a:solidFill>
                   <a:srgbClr val="212121"/>
@@ -14124,7 +14124,7 @@
                 <a:ea typeface="Calibri" pitchFamily="34" charset="-122"/>
                 <a:cs typeface="Calibri" pitchFamily="34" charset="-120"/>
               </a:rPr>
-              <a:t>Motivation: </a:t>
+              <a:t>: </a:t>
             </a:r>
             <a:pPr algn="l" indent="0" marL="0">
               <a:buNone/>
@@ -14153,6 +14153,20 @@
                 <a:cs typeface="Calibri" pitchFamily="34" charset="-120"/>
               </a:rPr>
               <a:t>proliferation of AI-generated software artifacts</a:t>
+            </a:r>
+            <a:pPr algn="l" indent="0" marL="0">
+              <a:buNone/>
+            </a:pPr>
+            <a:r>
+              <a:rPr lang="en-US" sz="1700" dirty="0">
+                <a:solidFill>
+                  <a:srgbClr val="212121"/>
+                </a:solidFill>
+                <a:latin typeface="Calibri" pitchFamily="34" charset="0"/>
+                <a:ea typeface="Calibri" pitchFamily="34" charset="-122"/>
+                <a:cs typeface="Calibri" pitchFamily="34" charset="-120"/>
+              </a:rPr>
+              <a:t>, amid the need for </a:t>
             </a:r>
             <a:pPr algn="l" indent="0" marL="0">
               <a:spcAft>
@@ -14161,7 +14175,7 @@
               <a:buNone/>
             </a:pPr>
             <a:r>
-              <a:rPr lang="en-US" sz="1700" dirty="0">
+              <a:rPr lang="en-US" sz="1700" b="1" dirty="0">
                 <a:solidFill>
                   <a:srgbClr val="212121"/>
                 </a:solidFill>
@@ -14169,7 +14183,7 @@
                 <a:ea typeface="Calibri" pitchFamily="34" charset="-122"/>
                 <a:cs typeface="Calibri" pitchFamily="34" charset="-120"/>
               </a:rPr>
-              <a:t>, amid the need for rapid re-certification of systems</a:t>
+              <a:t>rapid re-certification of systems</a:t>
             </a:r>
             <a:endParaRPr lang="en-US" sz="1700" dirty="0"/>
           </a:p>

</xml_diff>

<commit_message>
slide 5 + Act I: plain arrow labels, reworded on-fail/on-pass keys, legend moved to Act I (ported PowerPoint edits)
Blackboard architecture slide (5):
- arrow labels set in plain type; "on-pass: restart-episode ⇒ fresh measurement",
  "on-fail: handoff to next repair KS / (attempts spent, changes restored)",
  "on fail: no repair chain => escalate" (moved beside the escalate lane)
- "bless ⇒ provision" label deleted (arrow kept); "all rungs exhausted" nudged
- checklist-glyph legend removed from this slide

Act I transition slide (9):
- legend added bottom-right, three lines: ✓ attested / ✗ refuted /
  ? poisoned (untrustworthy)

Verified shape-for-shape (geometry, fills, lines, run formatting, notes)
against the PowerPoint-saved deck; slide log updated.

Co-Authored-By: Claude Fable 5.1 <noreply@anthropic.com>
</commit_message>
<xml_diff>
--- a/docs/video_slides_draft.pptx
+++ b/docs/video_slides_draft.pptx
@@ -15224,46 +15224,7 @@
       </p:sp>
       <p:sp>
         <p:nvSpPr>
-          <p:cNvPr id="6" name="Text 4"/>
-          <p:cNvSpPr/>
-          <p:nvPr/>
-        </p:nvSpPr>
-        <p:spPr>
-          <a:xfrm>
-            <a:off x="4041648" y="1609344"/>
-            <a:ext cx="1737360" cy="256032"/>
-          </a:xfrm>
-          <a:prstGeom prst="rect">
-            <a:avLst/>
-          </a:prstGeom>
-          <a:noFill/>
-          <a:ln/>
-        </p:spPr>
-        <p:txBody>
-          <a:bodyPr wrap="square" lIns="0" tIns="0" rIns="0" bIns="0" rtlCol="0" anchor="ctr"/>
-          <a:lstStyle/>
-          <a:p>
-            <a:pPr algn="l" indent="0" marL="0">
-              <a:buNone/>
-            </a:pPr>
-            <a:r>
-              <a:rPr lang="en-US" sz="1000" i="1" dirty="0">
-                <a:solidFill>
-                  <a:srgbClr val="1E2761"/>
-                </a:solidFill>
-                <a:latin typeface="Calibri" pitchFamily="34" charset="0"/>
-                <a:ea typeface="Calibri" pitchFamily="34" charset="-122"/>
-                <a:cs typeface="Calibri" pitchFamily="34" charset="-120"/>
-              </a:rPr>
-              <a:t>bless ⇒ provision</a:t>
-            </a:r>
-            <a:endParaRPr lang="en-US" sz="1000" dirty="0"/>
-          </a:p>
-        </p:txBody>
-      </p:sp>
-      <p:sp>
-        <p:nvSpPr>
-          <p:cNvPr id="7" name="Shape 5"/>
+          <p:cNvPr id="6" name="Shape 4"/>
           <p:cNvSpPr/>
           <p:nvPr/>
         </p:nvSpPr>
@@ -15285,7 +15246,7 @@
       </p:sp>
       <p:sp>
         <p:nvSpPr>
-          <p:cNvPr id="8" name="Text 6"/>
+          <p:cNvPr id="7" name="Text 5"/>
           <p:cNvSpPr/>
           <p:nvPr/>
         </p:nvSpPr>
@@ -15324,7 +15285,7 @@
       </p:sp>
       <p:sp>
         <p:nvSpPr>
-          <p:cNvPr id="9" name="Shape 7"/>
+          <p:cNvPr id="8" name="Shape 6"/>
           <p:cNvSpPr/>
           <p:nvPr/>
         </p:nvSpPr>
@@ -15348,7 +15309,7 @@
       </p:sp>
       <p:sp>
         <p:nvSpPr>
-          <p:cNvPr id="10" name="Text 8"/>
+          <p:cNvPr id="9" name="Text 7"/>
           <p:cNvSpPr/>
           <p:nvPr/>
         </p:nvSpPr>
@@ -15387,7 +15348,7 @@
       </p:sp>
       <p:sp>
         <p:nvSpPr>
-          <p:cNvPr id="11" name="Shape 9"/>
+          <p:cNvPr id="10" name="Shape 8"/>
           <p:cNvSpPr/>
           <p:nvPr/>
         </p:nvSpPr>
@@ -15409,7 +15370,7 @@
       </p:sp>
       <p:sp>
         <p:nvSpPr>
-          <p:cNvPr id="12" name="Text 10"/>
+          <p:cNvPr id="11" name="Text 9"/>
           <p:cNvSpPr/>
           <p:nvPr/>
         </p:nvSpPr>
@@ -15448,7 +15409,7 @@
       </p:sp>
       <p:sp>
         <p:nvSpPr>
-          <p:cNvPr id="13" name="Shape 11"/>
+          <p:cNvPr id="12" name="Shape 10"/>
           <p:cNvSpPr/>
           <p:nvPr/>
         </p:nvSpPr>
@@ -15470,7 +15431,7 @@
       </p:sp>
       <p:sp>
         <p:nvSpPr>
-          <p:cNvPr id="14" name="Text 12"/>
+          <p:cNvPr id="13" name="Text 11"/>
           <p:cNvSpPr/>
           <p:nvPr/>
         </p:nvSpPr>
@@ -15509,7 +15470,7 @@
       </p:sp>
       <p:sp>
         <p:nvSpPr>
-          <p:cNvPr id="15" name="Shape 13"/>
+          <p:cNvPr id="14" name="Shape 12"/>
           <p:cNvSpPr/>
           <p:nvPr/>
         </p:nvSpPr>
@@ -15531,7 +15492,7 @@
       </p:sp>
       <p:sp>
         <p:nvSpPr>
-          <p:cNvPr id="16" name="Text 14"/>
+          <p:cNvPr id="15" name="Text 13"/>
           <p:cNvSpPr/>
           <p:nvPr/>
         </p:nvSpPr>
@@ -15570,7 +15531,7 @@
       </p:sp>
       <p:sp>
         <p:nvSpPr>
-          <p:cNvPr id="17" name="Shape 15"/>
+          <p:cNvPr id="16" name="Shape 14"/>
           <p:cNvSpPr/>
           <p:nvPr/>
         </p:nvSpPr>
@@ -15594,7 +15555,7 @@
       </p:sp>
       <p:sp>
         <p:nvSpPr>
-          <p:cNvPr id="18" name="Shape 16"/>
+          <p:cNvPr id="17" name="Shape 15"/>
           <p:cNvSpPr/>
           <p:nvPr/>
         </p:nvSpPr>
@@ -15617,7 +15578,7 @@
       </p:sp>
       <p:sp>
         <p:nvSpPr>
-          <p:cNvPr id="19" name="Shape 17"/>
+          <p:cNvPr id="18" name="Shape 16"/>
           <p:cNvSpPr/>
           <p:nvPr/>
         </p:nvSpPr>
@@ -15640,7 +15601,7 @@
       </p:sp>
       <p:sp>
         <p:nvSpPr>
-          <p:cNvPr id="20" name="Shape 18"/>
+          <p:cNvPr id="19" name="Shape 17"/>
           <p:cNvSpPr/>
           <p:nvPr/>
         </p:nvSpPr>
@@ -15664,14 +15625,14 @@
       </p:sp>
       <p:sp>
         <p:nvSpPr>
-          <p:cNvPr id="21" name="Text 19"/>
-          <p:cNvSpPr/>
-          <p:nvPr/>
-        </p:nvSpPr>
-        <p:spPr>
-          <a:xfrm>
-            <a:off x="228600" y="3977640"/>
-            <a:ext cx="1097280" cy="822960"/>
+          <p:cNvPr id="20" name="Text 18"/>
+          <p:cNvSpPr/>
+          <p:nvPr/>
+        </p:nvSpPr>
+        <p:spPr>
+          <a:xfrm>
+            <a:off x="1389888" y="3931920"/>
+            <a:ext cx="1088136" cy="822960"/>
           </a:xfrm>
           <a:prstGeom prst="rect">
             <a:avLst/>
@@ -15687,7 +15648,7 @@
               <a:buNone/>
             </a:pPr>
             <a:r>
-              <a:rPr lang="en-US" sz="1000" i="1" dirty="0">
+              <a:rPr lang="en-US" sz="1000" dirty="0">
                 <a:solidFill>
                   <a:srgbClr val="A33327"/>
                 </a:solidFill>
@@ -15695,32 +15656,15 @@
                 <a:ea typeface="Calibri" pitchFamily="34" charset="-122"/>
                 <a:cs typeface="Calibri" pitchFamily="34" charset="-120"/>
               </a:rPr>
-              <a:t>no repair chain:</a:t>
+              <a:t>on fail:  no repair chain =&gt; escalate</a:t>
             </a:r>
             <a:endParaRPr lang="en-US" sz="1000" dirty="0"/>
           </a:p>
-          <a:p>
-            <a:pPr algn="r" indent="0" marL="0">
-              <a:buNone/>
-            </a:pPr>
-            <a:r>
-              <a:rPr lang="en-US" sz="1000" i="1" dirty="0">
-                <a:solidFill>
-                  <a:srgbClr val="A33327"/>
-                </a:solidFill>
-                <a:latin typeface="Calibri" pitchFamily="34" charset="0"/>
-                <a:ea typeface="Calibri" pitchFamily="34" charset="-122"/>
-                <a:cs typeface="Calibri" pitchFamily="34" charset="-120"/>
-              </a:rPr>
-              <a:t>fail ⇒ escalate</a:t>
-            </a:r>
-            <a:endParaRPr lang="en-US" sz="1000" dirty="0"/>
-          </a:p>
-        </p:txBody>
-      </p:sp>
-      <p:sp>
-        <p:nvSpPr>
-          <p:cNvPr id="22" name="Shape 20"/>
+        </p:txBody>
+      </p:sp>
+      <p:sp>
+        <p:nvSpPr>
+          <p:cNvPr id="21" name="Shape 19"/>
           <p:cNvSpPr/>
           <p:nvPr/>
         </p:nvSpPr>
@@ -15743,7 +15687,7 @@
       </p:sp>
       <p:sp>
         <p:nvSpPr>
-          <p:cNvPr id="23" name="Shape 21"/>
+          <p:cNvPr id="22" name="Shape 20"/>
           <p:cNvSpPr/>
           <p:nvPr/>
         </p:nvSpPr>
@@ -15767,7 +15711,7 @@
       </p:sp>
       <p:sp>
         <p:nvSpPr>
-          <p:cNvPr id="24" name="Text 22"/>
+          <p:cNvPr id="23" name="Text 21"/>
           <p:cNvSpPr/>
           <p:nvPr/>
         </p:nvSpPr>
@@ -15790,7 +15734,7 @@
               <a:buNone/>
             </a:pPr>
             <a:r>
-              <a:rPr lang="en-US" sz="1050" i="1" dirty="0">
+              <a:rPr lang="en-US" sz="1050" dirty="0">
                 <a:solidFill>
                   <a:srgbClr val="2C7A3F"/>
                 </a:solidFill>
@@ -15806,7 +15750,7 @@
       </p:sp>
       <p:sp>
         <p:nvSpPr>
-          <p:cNvPr id="25" name="Shape 23"/>
+          <p:cNvPr id="24" name="Shape 22"/>
           <p:cNvSpPr/>
           <p:nvPr/>
         </p:nvSpPr>
@@ -15828,7 +15772,7 @@
       </p:sp>
       <p:sp>
         <p:nvSpPr>
-          <p:cNvPr id="26" name="Text 24"/>
+          <p:cNvPr id="25" name="Text 23"/>
           <p:cNvSpPr/>
           <p:nvPr/>
         </p:nvSpPr>
@@ -15884,7 +15828,7 @@
       </p:sp>
       <p:sp>
         <p:nvSpPr>
-          <p:cNvPr id="27" name="Shape 25"/>
+          <p:cNvPr id="26" name="Shape 24"/>
           <p:cNvSpPr/>
           <p:nvPr/>
         </p:nvSpPr>
@@ -15908,7 +15852,7 @@
       </p:sp>
       <p:sp>
         <p:nvSpPr>
-          <p:cNvPr id="28" name="Text 26"/>
+          <p:cNvPr id="27" name="Text 25"/>
           <p:cNvSpPr/>
           <p:nvPr/>
         </p:nvSpPr>
@@ -15947,7 +15891,7 @@
       </p:sp>
       <p:sp>
         <p:nvSpPr>
-          <p:cNvPr id="29" name="Shape 27"/>
+          <p:cNvPr id="28" name="Shape 26"/>
           <p:cNvSpPr/>
           <p:nvPr/>
         </p:nvSpPr>
@@ -15969,7 +15913,7 @@
       </p:sp>
       <p:sp>
         <p:nvSpPr>
-          <p:cNvPr id="30" name="Text 28"/>
+          <p:cNvPr id="29" name="Text 27"/>
           <p:cNvSpPr/>
           <p:nvPr/>
         </p:nvSpPr>
@@ -16008,7 +15952,7 @@
       </p:sp>
       <p:sp>
         <p:nvSpPr>
-          <p:cNvPr id="31" name="Shape 29"/>
+          <p:cNvPr id="30" name="Shape 28"/>
           <p:cNvSpPr/>
           <p:nvPr/>
         </p:nvSpPr>
@@ -16032,7 +15976,7 @@
       </p:sp>
       <p:sp>
         <p:nvSpPr>
-          <p:cNvPr id="32" name="Shape 30"/>
+          <p:cNvPr id="31" name="Shape 29"/>
           <p:cNvSpPr/>
           <p:nvPr/>
         </p:nvSpPr>
@@ -16054,7 +15998,7 @@
       </p:sp>
       <p:sp>
         <p:nvSpPr>
-          <p:cNvPr id="33" name="Text 31"/>
+          <p:cNvPr id="32" name="Text 30"/>
           <p:cNvSpPr/>
           <p:nvPr/>
         </p:nvSpPr>
@@ -16093,7 +16037,7 @@
       </p:sp>
       <p:sp>
         <p:nvSpPr>
-          <p:cNvPr id="34" name="Shape 32"/>
+          <p:cNvPr id="33" name="Shape 31"/>
           <p:cNvSpPr/>
           <p:nvPr/>
         </p:nvSpPr>
@@ -16117,7 +16061,7 @@
       </p:sp>
       <p:sp>
         <p:nvSpPr>
-          <p:cNvPr id="35" name="Shape 33"/>
+          <p:cNvPr id="34" name="Shape 32"/>
           <p:cNvSpPr/>
           <p:nvPr/>
         </p:nvSpPr>
@@ -16139,7 +16083,7 @@
       </p:sp>
       <p:sp>
         <p:nvSpPr>
-          <p:cNvPr id="36" name="Text 34"/>
+          <p:cNvPr id="35" name="Text 33"/>
           <p:cNvSpPr/>
           <p:nvPr/>
         </p:nvSpPr>
@@ -16178,13 +16122,13 @@
       </p:sp>
       <p:sp>
         <p:nvSpPr>
-          <p:cNvPr id="37" name="Text 35"/>
-          <p:cNvSpPr/>
-          <p:nvPr/>
-        </p:nvSpPr>
-        <p:spPr>
-          <a:xfrm>
-            <a:off x="8046720" y="3767328"/>
+          <p:cNvPr id="36" name="Text 34"/>
+          <p:cNvSpPr/>
+          <p:nvPr/>
+        </p:nvSpPr>
+        <p:spPr>
+          <a:xfrm>
+            <a:off x="7763256" y="3767328"/>
             <a:ext cx="4023360" cy="274320"/>
           </a:xfrm>
           <a:prstGeom prst="rect">
@@ -16201,7 +16145,7 @@
               <a:buNone/>
             </a:pPr>
             <a:r>
-              <a:rPr lang="en-US" sz="1050" i="1" dirty="0">
+              <a:rPr lang="en-US" sz="1050" dirty="0">
                 <a:solidFill>
                   <a:srgbClr val="A33327"/>
                 </a:solidFill>
@@ -16209,15 +16153,32 @@
                 <a:ea typeface="Calibri" pitchFamily="34" charset="-122"/>
                 <a:cs typeface="Calibri" pitchFamily="34" charset="-120"/>
               </a:rPr>
-              <a:t>red → = on-fail handoff (attempts spent, changes restored)</a:t>
+              <a:t>on-fail: handoff to next repair KS </a:t>
             </a:r>
             <a:endParaRPr lang="en-US" sz="1050" dirty="0"/>
           </a:p>
-        </p:txBody>
-      </p:sp>
-      <p:sp>
-        <p:nvSpPr>
-          <p:cNvPr id="38" name="Shape 36"/>
+          <a:p>
+            <a:pPr algn="ctr" indent="0" marL="0">
+              <a:buNone/>
+            </a:pPr>
+            <a:r>
+              <a:rPr lang="en-US" sz="1050" dirty="0">
+                <a:solidFill>
+                  <a:srgbClr val="A33327"/>
+                </a:solidFill>
+                <a:latin typeface="Calibri" pitchFamily="34" charset="0"/>
+                <a:ea typeface="Calibri" pitchFamily="34" charset="-122"/>
+                <a:cs typeface="Calibri" pitchFamily="34" charset="-120"/>
+              </a:rPr>
+              <a:t>(attempts spent, changes restored)</a:t>
+            </a:r>
+            <a:endParaRPr lang="en-US" sz="1050" dirty="0"/>
+          </a:p>
+        </p:txBody>
+      </p:sp>
+      <p:sp>
+        <p:nvSpPr>
+          <p:cNvPr id="37" name="Shape 35"/>
           <p:cNvSpPr/>
           <p:nvPr/>
         </p:nvSpPr>
@@ -16240,7 +16201,7 @@
       </p:sp>
       <p:sp>
         <p:nvSpPr>
-          <p:cNvPr id="39" name="Shape 37"/>
+          <p:cNvPr id="38" name="Shape 36"/>
           <p:cNvSpPr/>
           <p:nvPr/>
         </p:nvSpPr>
@@ -16263,7 +16224,7 @@
       </p:sp>
       <p:sp>
         <p:nvSpPr>
-          <p:cNvPr id="40" name="Shape 38"/>
+          <p:cNvPr id="39" name="Shape 37"/>
           <p:cNvSpPr/>
           <p:nvPr/>
         </p:nvSpPr>
@@ -16286,7 +16247,7 @@
       </p:sp>
       <p:sp>
         <p:nvSpPr>
-          <p:cNvPr id="41" name="Shape 39"/>
+          <p:cNvPr id="40" name="Shape 38"/>
           <p:cNvSpPr/>
           <p:nvPr/>
         </p:nvSpPr>
@@ -16309,7 +16270,7 @@
       </p:sp>
       <p:sp>
         <p:nvSpPr>
-          <p:cNvPr id="42" name="Shape 40"/>
+          <p:cNvPr id="41" name="Shape 39"/>
           <p:cNvSpPr/>
           <p:nvPr/>
         </p:nvSpPr>
@@ -16333,13 +16294,13 @@
       </p:sp>
       <p:sp>
         <p:nvSpPr>
-          <p:cNvPr id="43" name="Text 41"/>
-          <p:cNvSpPr/>
-          <p:nvPr/>
-        </p:nvSpPr>
-        <p:spPr>
-          <a:xfrm>
-            <a:off x="5852160" y="1755648"/>
+          <p:cNvPr id="42" name="Text 40"/>
+          <p:cNvSpPr/>
+          <p:nvPr/>
+        </p:nvSpPr>
+        <p:spPr>
+          <a:xfrm>
+            <a:off x="6025896" y="1755648"/>
             <a:ext cx="4937760" cy="274320"/>
           </a:xfrm>
           <a:prstGeom prst="rect">
@@ -16364,7 +16325,7 @@
                 <a:ea typeface="Calibri" pitchFamily="34" charset="-122"/>
                 <a:cs typeface="Calibri" pitchFamily="34" charset="-120"/>
               </a:rPr>
-              <a:t>on-pass: re-verify · restart-episode ⇒ fresh measurement</a:t>
+              <a:t>on-pass: restart-episode ⇒ fresh measurement</a:t>
             </a:r>
             <a:endParaRPr lang="en-US" sz="1100" dirty="0"/>
           </a:p>
@@ -16372,7 +16333,7 @@
       </p:sp>
       <p:sp>
         <p:nvSpPr>
-          <p:cNvPr id="44" name="Shape 42"/>
+          <p:cNvPr id="43" name="Shape 41"/>
           <p:cNvSpPr/>
           <p:nvPr/>
         </p:nvSpPr>
@@ -16395,7 +16356,7 @@
       </p:sp>
       <p:sp>
         <p:nvSpPr>
-          <p:cNvPr id="45" name="Shape 43"/>
+          <p:cNvPr id="44" name="Shape 42"/>
           <p:cNvSpPr/>
           <p:nvPr/>
         </p:nvSpPr>
@@ -16418,7 +16379,7 @@
       </p:sp>
       <p:sp>
         <p:nvSpPr>
-          <p:cNvPr id="46" name="Shape 44"/>
+          <p:cNvPr id="45" name="Shape 43"/>
           <p:cNvSpPr/>
           <p:nvPr/>
         </p:nvSpPr>
@@ -16442,13 +16403,13 @@
       </p:sp>
       <p:sp>
         <p:nvSpPr>
-          <p:cNvPr id="47" name="Text 45"/>
-          <p:cNvSpPr/>
-          <p:nvPr/>
-        </p:nvSpPr>
-        <p:spPr>
-          <a:xfrm>
-            <a:off x="6583680" y="4773168"/>
+          <p:cNvPr id="46" name="Text 44"/>
+          <p:cNvSpPr/>
+          <p:nvPr/>
+        </p:nvSpPr>
+        <p:spPr>
+          <a:xfrm>
+            <a:off x="6766560" y="4773168"/>
             <a:ext cx="3291840" cy="274320"/>
           </a:xfrm>
           <a:prstGeom prst="rect">
@@ -16481,7 +16442,7 @@
       </p:sp>
       <p:sp>
         <p:nvSpPr>
-          <p:cNvPr id="48" name="Shape 46"/>
+          <p:cNvPr id="47" name="Shape 45"/>
           <p:cNvSpPr/>
           <p:nvPr/>
         </p:nvSpPr>
@@ -16504,7 +16465,7 @@
       </p:sp>
       <p:sp>
         <p:nvSpPr>
-          <p:cNvPr id="49" name="Shape 47"/>
+          <p:cNvPr id="48" name="Shape 46"/>
           <p:cNvSpPr/>
           <p:nvPr/>
         </p:nvSpPr>
@@ -16527,7 +16488,7 @@
       </p:sp>
       <p:sp>
         <p:nvSpPr>
-          <p:cNvPr id="50" name="Shape 48"/>
+          <p:cNvPr id="49" name="Shape 47"/>
           <p:cNvSpPr/>
           <p:nvPr/>
         </p:nvSpPr>
@@ -16551,7 +16512,7 @@
       </p:sp>
       <p:sp>
         <p:nvSpPr>
-          <p:cNvPr id="51" name="Text 49"/>
+          <p:cNvPr id="50" name="Text 48"/>
           <p:cNvSpPr/>
           <p:nvPr/>
         </p:nvSpPr>
@@ -16590,7 +16551,7 @@
       </p:sp>
       <p:sp>
         <p:nvSpPr>
-          <p:cNvPr id="52" name="Shape 50"/>
+          <p:cNvPr id="51" name="Shape 49"/>
           <p:cNvSpPr/>
           <p:nvPr/>
         </p:nvSpPr>
@@ -16612,7 +16573,7 @@
       </p:sp>
       <p:sp>
         <p:nvSpPr>
-          <p:cNvPr id="53" name="Text 51"/>
+          <p:cNvPr id="52" name="Text 50"/>
           <p:cNvSpPr/>
           <p:nvPr/>
         </p:nvSpPr>
@@ -16733,89 +16694,6 @@
               <a:t>.</a:t>
             </a:r>
             <a:endParaRPr lang="en-US" sz="1300" dirty="0"/>
-          </a:p>
-        </p:txBody>
-      </p:sp>
-      <p:sp>
-        <p:nvSpPr>
-          <p:cNvPr id="54" name="Shape 52"/>
-          <p:cNvSpPr/>
-          <p:nvPr/>
-        </p:nvSpPr>
-        <p:spPr>
-          <a:xfrm>
-            <a:off x="8961120" y="5989320"/>
-            <a:ext cx="2560320" cy="731520"/>
-          </a:xfrm>
-          <a:prstGeom prst="roundRect">
-            <a:avLst>
-              <a:gd name="adj" fmla="val 8750"/>
-            </a:avLst>
-          </a:prstGeom>
-          <a:solidFill>
-            <a:srgbClr val="F2F4F8"/>
-          </a:solidFill>
-          <a:ln w="12700">
-            <a:solidFill>
-              <a:srgbClr val="CADCFC"/>
-            </a:solidFill>
-            <a:prstDash val="solid"/>
-          </a:ln>
-        </p:spPr>
-      </p:sp>
-      <p:sp>
-        <p:nvSpPr>
-          <p:cNvPr id="55" name="Text 53"/>
-          <p:cNvSpPr/>
-          <p:nvPr/>
-        </p:nvSpPr>
-        <p:spPr>
-          <a:xfrm>
-            <a:off x="9098280" y="5989320"/>
-            <a:ext cx="2331720" cy="731520"/>
-          </a:xfrm>
-          <a:prstGeom prst="rect">
-            <a:avLst/>
-          </a:prstGeom>
-          <a:noFill/>
-          <a:ln/>
-        </p:spPr>
-        <p:txBody>
-          <a:bodyPr wrap="square" lIns="0" tIns="0" rIns="0" bIns="0" rtlCol="0" anchor="ctr"/>
-          <a:lstStyle/>
-          <a:p>
-            <a:pPr algn="l" indent="0" marL="0">
-              <a:buNone/>
-            </a:pPr>
-            <a:r>
-              <a:rPr lang="en-US" sz="1100" dirty="0">
-                <a:solidFill>
-                  <a:srgbClr val="212121"/>
-                </a:solidFill>
-                <a:latin typeface="Courier New" pitchFamily="34" charset="0"/>
-                <a:ea typeface="Courier New" pitchFamily="34" charset="-122"/>
-                <a:cs typeface="Courier New" pitchFamily="34" charset="-120"/>
-              </a:rPr>
-              <a:t>✓ attested   ✗ refuted</a:t>
-            </a:r>
-            <a:endParaRPr lang="en-US" sz="1100" dirty="0"/>
-          </a:p>
-          <a:p>
-            <a:pPr algn="l" indent="0" marL="0">
-              <a:buNone/>
-            </a:pPr>
-            <a:r>
-              <a:rPr lang="en-US" sz="1100" dirty="0">
-                <a:solidFill>
-                  <a:srgbClr val="212121"/>
-                </a:solidFill>
-                <a:latin typeface="Courier New" pitchFamily="34" charset="0"/>
-                <a:ea typeface="Courier New" pitchFamily="34" charset="-122"/>
-                <a:cs typeface="Courier New" pitchFamily="34" charset="-120"/>
-              </a:rPr>
-              <a:t>?  poisoned (fail-closed)</a:t>
-            </a:r>
-            <a:endParaRPr lang="en-US" sz="1100" dirty="0"/>
           </a:p>
         </p:txBody>
       </p:sp>
@@ -21669,6 +21547,106 @@
                 <a:cs typeface="Courier New" pitchFamily="34" charset="-120"/>
               </a:rPr>
               <a:t>./examples/demo_isolette.sh --scenes 1</a:t>
+            </a:r>
+            <a:endParaRPr lang="en-US" sz="1100" dirty="0"/>
+          </a:p>
+        </p:txBody>
+      </p:sp>
+      <p:sp>
+        <p:nvSpPr>
+          <p:cNvPr id="17" name="Shape 15"/>
+          <p:cNvSpPr/>
+          <p:nvPr/>
+        </p:nvSpPr>
+        <p:spPr>
+          <a:xfrm>
+            <a:off x="6172200" y="5660136"/>
+            <a:ext cx="2734056" cy="731520"/>
+          </a:xfrm>
+          <a:prstGeom prst="roundRect">
+            <a:avLst>
+              <a:gd name="adj" fmla="val 8750"/>
+            </a:avLst>
+          </a:prstGeom>
+          <a:solidFill>
+            <a:srgbClr val="F2F4F8"/>
+          </a:solidFill>
+          <a:ln w="12700">
+            <a:solidFill>
+              <a:srgbClr val="CADCFC"/>
+            </a:solidFill>
+            <a:prstDash val="solid"/>
+          </a:ln>
+        </p:spPr>
+      </p:sp>
+      <p:sp>
+        <p:nvSpPr>
+          <p:cNvPr id="18" name="Text 16"/>
+          <p:cNvSpPr/>
+          <p:nvPr/>
+        </p:nvSpPr>
+        <p:spPr>
+          <a:xfrm>
+            <a:off x="6309360" y="5660136"/>
+            <a:ext cx="2587752" cy="731520"/>
+          </a:xfrm>
+          <a:prstGeom prst="rect">
+            <a:avLst/>
+          </a:prstGeom>
+          <a:noFill/>
+          <a:ln/>
+        </p:spPr>
+        <p:txBody>
+          <a:bodyPr wrap="square" lIns="0" tIns="0" rIns="0" bIns="0" rtlCol="0" anchor="ctr"/>
+          <a:lstStyle/>
+          <a:p>
+            <a:pPr algn="l" indent="0" marL="0">
+              <a:buNone/>
+            </a:pPr>
+            <a:r>
+              <a:rPr lang="en-US" sz="1100" dirty="0">
+                <a:solidFill>
+                  <a:srgbClr val="212121"/>
+                </a:solidFill>
+                <a:latin typeface="Courier New" pitchFamily="34" charset="0"/>
+                <a:ea typeface="Courier New" pitchFamily="34" charset="-122"/>
+                <a:cs typeface="Courier New" pitchFamily="34" charset="-120"/>
+              </a:rPr>
+              <a:t>✓ attested   </a:t>
+            </a:r>
+            <a:endParaRPr lang="en-US" sz="1100" dirty="0"/>
+          </a:p>
+          <a:p>
+            <a:pPr algn="l" indent="0" marL="0">
+              <a:buNone/>
+            </a:pPr>
+            <a:r>
+              <a:rPr lang="en-US" sz="1100" dirty="0">
+                <a:solidFill>
+                  <a:srgbClr val="212121"/>
+                </a:solidFill>
+                <a:latin typeface="Courier New" pitchFamily="34" charset="0"/>
+                <a:ea typeface="Courier New" pitchFamily="34" charset="-122"/>
+                <a:cs typeface="Courier New" pitchFamily="34" charset="-120"/>
+              </a:rPr>
+              <a:t>✗ refuted</a:t>
+            </a:r>
+            <a:endParaRPr lang="en-US" sz="1100" dirty="0"/>
+          </a:p>
+          <a:p>
+            <a:pPr algn="l" indent="0" marL="0">
+              <a:buNone/>
+            </a:pPr>
+            <a:r>
+              <a:rPr lang="en-US" sz="1100" dirty="0">
+                <a:solidFill>
+                  <a:srgbClr val="212121"/>
+                </a:solidFill>
+                <a:latin typeface="Courier New" pitchFamily="34" charset="0"/>
+                <a:ea typeface="Courier New" pitchFamily="34" charset="-122"/>
+                <a:cs typeface="Courier New" pitchFamily="34" charset="-120"/>
+              </a:rPr>
+              <a:t>? poisoned (untrustworthy)</a:t>
             </a:r>
             <a:endParaRPr lang="en-US" sz="1100" dirty="0"/>
           </a:p>

</xml_diff>

<commit_message>
glossary + isolette slides: reworded definitions, restructured isolette beats (ported PowerPoint edits)
pybb key components (slide 6): all eight definitions tightened; Route sets
on_fail / on_pass in Courier New.

Isolette slide (8): title "The Isolette Example"; system and relevance
beats reworded, each with an "o" sub-bullet; pipeline graphic moved up
(y 4.35 -> 3.97), "seL4 + Microkit"; "the measured surface" heading
removed; three stat captions reworded (SysMLv2 packages / Verus-contract-
bearing Rust, system-level proof, blackboard's entry keys).

Generator: descriptions may now be run lists; adds a post-build pPr patch
(jszip) so the isolette sub-bullets keep PowerPoint's exact bullet font
and indents on regeneration. Verified shape-for-shape (incl. bullet font
and indents) against the PowerPoint-saved deck; slide log updated.

Co-Authored-By: Claude Fable 5.1 <noreply@anthropic.com>
</commit_message>
<xml_diff>
--- a/docs/video_slides_draft.pptx
+++ b/docs/video_slides_draft.pptx
@@ -16819,7 +16819,7 @@
                 <a:ea typeface="Calibri" pitchFamily="34" charset="-122"/>
                 <a:cs typeface="Calibri" pitchFamily="34" charset="-120"/>
               </a:rPr>
-              <a:t> — the shared store: every measurement lands as an entry with its condition and standing; three segments (provision · certify · escalate) plus a full history of every change</a:t>
+              <a:t> — a collection of entries:  the shared measurement store updated cooperatively by blackboard components</a:t>
             </a:r>
             <a:endParaRPr lang="en-US" sz="1600" dirty="0"/>
           </a:p>
@@ -16854,7 +16854,7 @@
                 <a:ea typeface="Calibri" pitchFamily="34" charset="-122"/>
                 <a:cs typeface="Calibri" pitchFamily="34" charset="-120"/>
               </a:rPr>
-              <a:t> — one measurement under judgment, identified by its key: the measurement, its condition, its standing, its repair history</a:t>
+              <a:t> — a measurement under judgment:  its measurement content, current standing, repair history</a:t>
             </a:r>
             <a:endParaRPr lang="en-US" sz="1600" dirty="0"/>
           </a:p>
@@ -16889,7 +16889,7 @@
                 <a:ea typeface="Calibri" pitchFamily="34" charset="-122"/>
                 <a:cs typeface="Calibri" pitchFamily="34" charset="-120"/>
               </a:rPr>
-              <a:t> — one full judgment of an entry: the attestation runs once and its verdicts are memoized until the episode ends — or is restarted for genuinely fresh measurement</a:t>
+              <a:t> — one full judgment of an entry: attestation records verdicts, must be restarted for fresh measurement</a:t>
             </a:r>
             <a:endParaRPr lang="en-US" sz="1600" dirty="0"/>
           </a:p>
@@ -16924,7 +16924,7 @@
                 <a:ea typeface="Calibri" pitchFamily="34" charset="-122"/>
                 <a:cs typeface="Calibri" pitchFamily="34" charset="-120"/>
               </a:rPr>
-              <a:t> — the division of blackboard entries among different workflow stages: each knowledge source watches its own collection of keys, and an entry sits in the partition of whichever rung currently owns it</a:t>
+              <a:t> — the division of blackboard entries among different workflow stages (i.e. provision, certify, escalate) </a:t>
             </a:r>
             <a:endParaRPr lang="en-US" sz="1600" dirty="0"/>
           </a:p>
@@ -16959,7 +16959,7 @@
                 <a:ea typeface="Calibri" pitchFamily="34" charset="-122"/>
                 <a:cs typeface="Calibri" pitchFamily="34" charset="-120"/>
               </a:rPr>
-              <a:t> — the cycle: evaluates every entry (provision first), dispatches keys onto outcome-routed chains, advances or hands off, escalates; halts only when everything is in good standing</a:t>
+              <a:t> — evaluates every entry (once provisioned), dispatches keys onto outcome-routed chains, advances or hands off, escalates, halts only when entries are in good standing</a:t>
             </a:r>
             <a:endParaRPr lang="en-US" sz="1600" dirty="0"/>
           </a:p>
@@ -16994,7 +16994,7 @@
                 <a:ea typeface="Calibri" pitchFamily="34" charset="-122"/>
                 <a:cs typeface="Calibri" pitchFamily="34" charset="-120"/>
               </a:rPr>
-              <a:t> — a repair rung: operates only on entries in its partition (optionally a single component), bounded by max_attempts; its work is always re-judged, never trusted</a:t>
+              <a:t> — operates only on entries in its partition (optionally a single component), bounded by max attempts; its work is always re-judged, never trusted</a:t>
             </a:r>
             <a:endParaRPr lang="en-US" sz="1600" dirty="0"/>
           </a:p>
@@ -17013,6 +17013,62 @@
                 <a:cs typeface="Calibri" pitchFamily="34" charset="-120"/>
               </a:rPr>
               <a:t>Route</a:t>
+            </a:r>
+            <a:pPr algn="l" indent="0" marL="0">
+              <a:buNone/>
+            </a:pPr>
+            <a:r>
+              <a:rPr lang="en-US" sz="1600" dirty="0">
+                <a:solidFill>
+                  <a:srgbClr val="212121"/>
+                </a:solidFill>
+                <a:latin typeface="Calibri" pitchFamily="34" charset="0"/>
+                <a:ea typeface="Calibri" pitchFamily="34" charset="-122"/>
+                <a:cs typeface="Calibri" pitchFamily="34" charset="-120"/>
+              </a:rPr>
+              <a:t> — the per-key control flow chains: </a:t>
+            </a:r>
+            <a:pPr algn="l" indent="0" marL="0">
+              <a:buNone/>
+            </a:pPr>
+            <a:r>
+              <a:rPr lang="en-US" sz="1600" dirty="0">
+                <a:solidFill>
+                  <a:srgbClr val="212121"/>
+                </a:solidFill>
+                <a:latin typeface="Courier New" pitchFamily="34" charset="0"/>
+                <a:ea typeface="Courier New" pitchFamily="34" charset="-122"/>
+                <a:cs typeface="Courier New" pitchFamily="34" charset="-120"/>
+              </a:rPr>
+              <a:t>on_fail </a:t>
+            </a:r>
+            <a:pPr algn="l" indent="0" marL="0">
+              <a:buNone/>
+            </a:pPr>
+            <a:r>
+              <a:rPr lang="en-US" sz="1600" dirty="0">
+                <a:solidFill>
+                  <a:srgbClr val="212121"/>
+                </a:solidFill>
+                <a:latin typeface="Calibri" pitchFamily="34" charset="0"/>
+                <a:ea typeface="Calibri" pitchFamily="34" charset="-122"/>
+                <a:cs typeface="Calibri" pitchFamily="34" charset="-120"/>
+              </a:rPr>
+              <a:t>= the repair ladder, </a:t>
+            </a:r>
+            <a:pPr algn="l" indent="0" marL="0">
+              <a:buNone/>
+            </a:pPr>
+            <a:r>
+              <a:rPr lang="en-US" sz="1600" dirty="0">
+                <a:solidFill>
+                  <a:srgbClr val="212121"/>
+                </a:solidFill>
+                <a:latin typeface="Courier New" pitchFamily="34" charset="0"/>
+                <a:ea typeface="Courier New" pitchFamily="34" charset="-122"/>
+                <a:cs typeface="Courier New" pitchFamily="34" charset="-120"/>
+              </a:rPr>
+              <a:t>on_pass </a:t>
             </a:r>
             <a:pPr algn="l" indent="0" marL="0">
               <a:spcAft>
@@ -17029,7 +17085,7 @@
                 <a:ea typeface="Calibri" pitchFamily="34" charset="-122"/>
                 <a:cs typeface="Calibri" pitchFamily="34" charset="-120"/>
               </a:rPr>
-              <a:t> — the per-key chains: on_fail = the repair ladder, on_pass = a confirmation chain before an entry may rest in good standing</a:t>
+              <a:t>= a confirmation chain before good standing</a:t>
             </a:r>
             <a:endParaRPr lang="en-US" sz="1600" dirty="0"/>
           </a:p>
@@ -17064,7 +17120,7 @@
                 <a:ea typeface="Calibri" pitchFamily="34" charset="-122"/>
                 <a:cs typeface="Calibri" pitchFamily="34" charset="-120"/>
               </a:rPr>
-              <a:t> — the blackboard's running record of every change across all segments — measurements, repairs, verdicts — the audit trail of the repair lifecycle</a:t>
+              <a:t> — the blackboard's running record of every change across all partitions (measurements, repairs, verdicts), documenting the audit trail of the repair lifecycle</a:t>
             </a:r>
             <a:endParaRPr lang="en-US" sz="1600" dirty="0"/>
           </a:p>
@@ -19562,7 +19618,7 @@
                 <a:ea typeface="Cambria" pitchFamily="34" charset="-122"/>
                 <a:cs typeface="Cambria" pitchFamily="34" charset="-120"/>
               </a:rPr>
-              <a:t>The isolette</a:t>
+              <a:t>The Isolette Example</a:t>
             </a:r>
             <a:endParaRPr lang="en-US" sz="3400" dirty="0"/>
           </a:p>
@@ -19619,16 +19675,17 @@
                 <a:ea typeface="Calibri" pitchFamily="34" charset="-122"/>
                 <a:cs typeface="Calibri" pitchFamily="34" charset="-120"/>
               </a:rPr>
-              <a:t>an infant-incubator thermostat — regulate and monitor functions keep a newborn's environment in a safe temperature range; heat control on/off</a:t>
+              <a:t>infant-incubator thermostat that regulates and monitors a newborn's environment to maintain a safe temperature range (heat control on/off)</a:t>
             </a:r>
             <a:endParaRPr lang="en-US" sz="1350" dirty="0"/>
           </a:p>
           <a:p>
-            <a:pPr algn="l" indent="0" marL="0">
+            <a:pPr marL="628650" lvl="1" indent="-171450">
               <a:spcAft>
                 <a:spcPts val="1000"/>
               </a:spcAft>
-              <a:buNone/>
+              <a:buFont typeface="Courier New" panose="02070309020205020404" pitchFamily="49" charset="0"/>
+              <a:buChar char="o"/>
             </a:pPr>
             <a:r>
               <a:rPr lang="en-US" sz="1100" i="1" dirty="0">
@@ -19660,6 +19717,9 @@
               <a:t>The relevance: </a:t>
             </a:r>
             <a:pPr algn="l" indent="0" marL="0">
+              <a:spcAft>
+                <a:spcPts val="200"/>
+              </a:spcAft>
               <a:buNone/>
             </a:pPr>
             <a:r>
@@ -19671,10 +19731,29 @@
                 <a:ea typeface="Calibri" pitchFamily="34" charset="-122"/>
                 <a:cs typeface="Calibri" pitchFamily="34" charset="-120"/>
               </a:rPr>
-              <a:t>the INSPECTA program's seL4/Microkit exemplar — a real, current, safety-critical development artifact, not a toy built for this talk</a:t>
+              <a:t>the INSPECTA program's seL4/Microkit HAMR-based pipeline</a:t>
             </a:r>
             <a:endParaRPr lang="en-US" sz="1350" dirty="0"/>
           </a:p>
+          <a:p>
+            <a:pPr marL="800100" lvl="1" indent="-342900">
+              <a:buSzPct val="100000"/>
+              <a:buFont typeface="Courier New" panose="02070309020205020404" pitchFamily="49" charset="0"/>
+              <a:buChar char="o"/>
+            </a:pPr>
+            <a:r>
+              <a:rPr lang="en-US" sz="1350" dirty="0">
+                <a:solidFill>
+                  <a:srgbClr val="212121"/>
+                </a:solidFill>
+                <a:latin typeface="Calibri" pitchFamily="34" charset="0"/>
+                <a:ea typeface="Calibri" pitchFamily="34" charset="-122"/>
+                <a:cs typeface="Calibri" pitchFamily="34" charset="-120"/>
+              </a:rPr>
+              <a:t>current, safety-critical development artifact, not a toy example</a:t>
+            </a:r>
+            <a:endParaRPr lang="en-US" sz="1350" dirty="0"/>
+          </a:p>
         </p:txBody>
       </p:sp>
       <p:sp>
@@ -19685,7 +19764,7 @@
         </p:nvSpPr>
         <p:spPr>
           <a:xfrm>
-            <a:off x="640080" y="3977640"/>
+            <a:off x="640080" y="3630168"/>
             <a:ext cx="1275588" cy="777240"/>
           </a:xfrm>
           <a:prstGeom prst="roundRect">
@@ -19707,7 +19786,7 @@
         </p:nvSpPr>
         <p:spPr>
           <a:xfrm>
-            <a:off x="640080" y="3977640"/>
+            <a:off x="640080" y="3630168"/>
             <a:ext cx="1275588" cy="777240"/>
           </a:xfrm>
           <a:prstGeom prst="rect">
@@ -19763,7 +19842,7 @@
         </p:nvSpPr>
         <p:spPr>
           <a:xfrm>
-            <a:off x="1879092" y="3977640"/>
+            <a:off x="1879092" y="3630168"/>
             <a:ext cx="384048" cy="777240"/>
           </a:xfrm>
           <a:prstGeom prst="rect">
@@ -19802,7 +19881,7 @@
         </p:nvSpPr>
         <p:spPr>
           <a:xfrm>
-            <a:off x="2226564" y="3977640"/>
+            <a:off x="2226564" y="3630168"/>
             <a:ext cx="1275588" cy="777240"/>
           </a:xfrm>
           <a:prstGeom prst="roundRect">
@@ -19824,7 +19903,7 @@
         </p:nvSpPr>
         <p:spPr>
           <a:xfrm>
-            <a:off x="2226564" y="3977640"/>
+            <a:off x="2226564" y="3630168"/>
             <a:ext cx="1275588" cy="777240"/>
           </a:xfrm>
           <a:prstGeom prst="rect">
@@ -19880,7 +19959,7 @@
         </p:nvSpPr>
         <p:spPr>
           <a:xfrm>
-            <a:off x="3465576" y="3977640"/>
+            <a:off x="3465576" y="3630168"/>
             <a:ext cx="384048" cy="777240"/>
           </a:xfrm>
           <a:prstGeom prst="rect">
@@ -19919,7 +19998,7 @@
         </p:nvSpPr>
         <p:spPr>
           <a:xfrm>
-            <a:off x="3813048" y="3977640"/>
+            <a:off x="3813048" y="3630168"/>
             <a:ext cx="1275588" cy="777240"/>
           </a:xfrm>
           <a:prstGeom prst="roundRect">
@@ -19941,7 +20020,7 @@
         </p:nvSpPr>
         <p:spPr>
           <a:xfrm>
-            <a:off x="3813048" y="3977640"/>
+            <a:off x="3813048" y="3630168"/>
             <a:ext cx="1275588" cy="777240"/>
           </a:xfrm>
           <a:prstGeom prst="rect">
@@ -19997,7 +20076,7 @@
         </p:nvSpPr>
         <p:spPr>
           <a:xfrm>
-            <a:off x="5052060" y="3977640"/>
+            <a:off x="5052060" y="3630168"/>
             <a:ext cx="384048" cy="777240"/>
           </a:xfrm>
           <a:prstGeom prst="rect">
@@ -20036,7 +20115,7 @@
         </p:nvSpPr>
         <p:spPr>
           <a:xfrm>
-            <a:off x="5399532" y="3977640"/>
+            <a:off x="5399532" y="3630168"/>
             <a:ext cx="1275588" cy="777240"/>
           </a:xfrm>
           <a:prstGeom prst="roundRect">
@@ -20058,7 +20137,7 @@
         </p:nvSpPr>
         <p:spPr>
           <a:xfrm>
-            <a:off x="5399532" y="3977640"/>
+            <a:off x="5399532" y="3630168"/>
             <a:ext cx="1275588" cy="777240"/>
           </a:xfrm>
           <a:prstGeom prst="rect">
@@ -20083,7 +20162,7 @@
                 <a:ea typeface="Calibri" pitchFamily="34" charset="-122"/>
                 <a:cs typeface="Calibri" pitchFamily="34" charset="-120"/>
               </a:rPr>
-              <a:t>seL4 / Microkit</a:t>
+              <a:t>seL4 + Microkit</a:t>
             </a:r>
             <a:endParaRPr lang="en-US" sz="1050" dirty="0"/>
           </a:p>
@@ -20319,46 +20398,7 @@
       </p:sp>
       <p:sp>
         <p:nvSpPr>
-          <p:cNvPr id="27" name="Text 25"/>
-          <p:cNvSpPr/>
-          <p:nvPr/>
-        </p:nvSpPr>
-        <p:spPr>
-          <a:xfrm>
-            <a:off x="7040880" y="1325880"/>
-            <a:ext cx="4480560" cy="320040"/>
-          </a:xfrm>
-          <a:prstGeom prst="rect">
-            <a:avLst/>
-          </a:prstGeom>
-          <a:noFill/>
-          <a:ln/>
-        </p:spPr>
-        <p:txBody>
-          <a:bodyPr wrap="square" lIns="0" tIns="0" rIns="0" bIns="0" rtlCol="0" anchor="ctr"/>
-          <a:lstStyle/>
-          <a:p>
-            <a:pPr algn="l" indent="0" marL="0">
-              <a:buNone/>
-            </a:pPr>
-            <a:r>
-              <a:rPr lang="en-US" sz="1300" i="1" dirty="0">
-                <a:solidFill>
-                  <a:srgbClr val="5A6478"/>
-                </a:solidFill>
-                <a:latin typeface="Calibri" pitchFamily="34" charset="0"/>
-                <a:ea typeface="Calibri" pitchFamily="34" charset="-122"/>
-                <a:cs typeface="Calibri" pitchFamily="34" charset="-120"/>
-              </a:rPr>
-              <a:t>the measured surface</a:t>
-            </a:r>
-            <a:endParaRPr lang="en-US" sz="1300" dirty="0"/>
-          </a:p>
-        </p:txBody>
-      </p:sp>
-      <p:sp>
-        <p:nvSpPr>
-          <p:cNvPr id="28" name="Shape 26"/>
+          <p:cNvPr id="27" name="Shape 25"/>
           <p:cNvSpPr/>
           <p:nvPr/>
         </p:nvSpPr>
@@ -20385,7 +20425,7 @@
       </p:sp>
       <p:sp>
         <p:nvSpPr>
-          <p:cNvPr id="29" name="Text 27"/>
+          <p:cNvPr id="28" name="Text 26"/>
           <p:cNvSpPr/>
           <p:nvPr/>
         </p:nvSpPr>
@@ -20424,14 +20464,14 @@
       </p:sp>
       <p:sp>
         <p:nvSpPr>
-          <p:cNvPr id="30" name="Text 28"/>
-          <p:cNvSpPr/>
-          <p:nvPr/>
-        </p:nvSpPr>
-        <p:spPr>
-          <a:xfrm>
-            <a:off x="8202168" y="1627632"/>
-            <a:ext cx="3273552" cy="676656"/>
+          <p:cNvPr id="29" name="Text 27"/>
+          <p:cNvSpPr/>
+          <p:nvPr/>
+        </p:nvSpPr>
+        <p:spPr>
+          <a:xfrm>
+            <a:off x="8119872" y="1627632"/>
+            <a:ext cx="3355848" cy="676656"/>
           </a:xfrm>
           <a:prstGeom prst="rect">
             <a:avLst/>
@@ -20455,7 +20495,7 @@
                 <a:ea typeface="Calibri" pitchFamily="34" charset="-122"/>
                 <a:cs typeface="Calibri" pitchFamily="34" charset="-120"/>
               </a:rPr>
-              <a:t>measured files (SysML packages + contract-bearing Rust)</a:t>
+              <a:t>measured files (SysMLv2 packages, Verus-contract-bearing Rust)</a:t>
             </a:r>
             <a:endParaRPr lang="en-US" sz="1000" dirty="0"/>
           </a:p>
@@ -20463,7 +20503,7 @@
       </p:sp>
       <p:sp>
         <p:nvSpPr>
-          <p:cNvPr id="31" name="Shape 29"/>
+          <p:cNvPr id="30" name="Shape 28"/>
           <p:cNvSpPr/>
           <p:nvPr/>
         </p:nvSpPr>
@@ -20490,7 +20530,7 @@
       </p:sp>
       <p:sp>
         <p:nvSpPr>
-          <p:cNvPr id="32" name="Text 30"/>
+          <p:cNvPr id="31" name="Text 29"/>
           <p:cNvSpPr/>
           <p:nvPr/>
         </p:nvSpPr>
@@ -20529,7 +20569,7 @@
       </p:sp>
       <p:sp>
         <p:nvSpPr>
-          <p:cNvPr id="33" name="Text 31"/>
+          <p:cNvPr id="32" name="Text 30"/>
           <p:cNvSpPr/>
           <p:nvPr/>
         </p:nvSpPr>
@@ -20568,7 +20608,7 @@
       </p:sp>
       <p:sp>
         <p:nvSpPr>
-          <p:cNvPr id="34" name="Shape 32"/>
+          <p:cNvPr id="33" name="Shape 31"/>
           <p:cNvSpPr/>
           <p:nvPr/>
         </p:nvSpPr>
@@ -20595,7 +20635,7 @@
       </p:sp>
       <p:sp>
         <p:nvSpPr>
-          <p:cNvPr id="35" name="Text 33"/>
+          <p:cNvPr id="34" name="Text 32"/>
           <p:cNvSpPr/>
           <p:nvPr/>
         </p:nvSpPr>
@@ -20634,7 +20674,7 @@
       </p:sp>
       <p:sp>
         <p:nvSpPr>
-          <p:cNvPr id="36" name="Text 34"/>
+          <p:cNvPr id="35" name="Text 33"/>
           <p:cNvSpPr/>
           <p:nvPr/>
         </p:nvSpPr>
@@ -20665,7 +20705,7 @@
                 <a:ea typeface="Calibri" pitchFamily="34" charset="-122"/>
                 <a:cs typeface="Calibri" pitchFamily="34" charset="-120"/>
               </a:rPr>
-              <a:t>crates re-verified every episode (7 components + the system proof)</a:t>
+              <a:t>crates re-verified every episode (7 components and the system-level proof)</a:t>
             </a:r>
             <a:endParaRPr lang="en-US" sz="1000" dirty="0"/>
           </a:p>
@@ -20673,7 +20713,7 @@
       </p:sp>
       <p:sp>
         <p:nvSpPr>
-          <p:cNvPr id="37" name="Shape 35"/>
+          <p:cNvPr id="36" name="Shape 34"/>
           <p:cNvSpPr/>
           <p:nvPr/>
         </p:nvSpPr>
@@ -20700,7 +20740,7 @@
       </p:sp>
       <p:sp>
         <p:nvSpPr>
-          <p:cNvPr id="38" name="Text 36"/>
+          <p:cNvPr id="37" name="Text 35"/>
           <p:cNvSpPr/>
           <p:nvPr/>
         </p:nvSpPr>
@@ -20739,7 +20779,7 @@
       </p:sp>
       <p:sp>
         <p:nvSpPr>
-          <p:cNvPr id="39" name="Text 37"/>
+          <p:cNvPr id="38" name="Text 36"/>
           <p:cNvSpPr/>
           <p:nvPr/>
         </p:nvSpPr>
@@ -20778,7 +20818,7 @@
       </p:sp>
       <p:sp>
         <p:nvSpPr>
-          <p:cNvPr id="40" name="Shape 38"/>
+          <p:cNvPr id="39" name="Shape 37"/>
           <p:cNvSpPr/>
           <p:nvPr/>
         </p:nvSpPr>
@@ -20805,7 +20845,7 @@
       </p:sp>
       <p:sp>
         <p:nvSpPr>
-          <p:cNvPr id="41" name="Text 39"/>
+          <p:cNvPr id="40" name="Text 38"/>
           <p:cNvSpPr/>
           <p:nvPr/>
         </p:nvSpPr>
@@ -20844,7 +20884,7 @@
       </p:sp>
       <p:sp>
         <p:nvSpPr>
-          <p:cNvPr id="42" name="Text 40"/>
+          <p:cNvPr id="41" name="Text 39"/>
           <p:cNvSpPr/>
           <p:nvPr/>
         </p:nvSpPr>
@@ -20883,7 +20923,7 @@
       </p:sp>
       <p:sp>
         <p:nvSpPr>
-          <p:cNvPr id="43" name="Shape 41"/>
+          <p:cNvPr id="42" name="Shape 40"/>
           <p:cNvSpPr/>
           <p:nvPr/>
         </p:nvSpPr>
@@ -20910,7 +20950,7 @@
       </p:sp>
       <p:sp>
         <p:nvSpPr>
-          <p:cNvPr id="44" name="Text 42"/>
+          <p:cNvPr id="43" name="Text 41"/>
           <p:cNvSpPr/>
           <p:nvPr/>
         </p:nvSpPr>
@@ -20949,7 +20989,7 @@
       </p:sp>
       <p:sp>
         <p:nvSpPr>
-          <p:cNvPr id="45" name="Text 43"/>
+          <p:cNvPr id="44" name="Text 42"/>
           <p:cNvSpPr/>
           <p:nvPr/>
         </p:nvSpPr>
@@ -20980,7 +21020,7 @@
                 <a:ea typeface="Calibri" pitchFamily="34" charset="-122"/>
                 <a:cs typeface="Calibri" pitchFamily="34" charset="-120"/>
               </a:rPr>
-              <a:t>attestation tiers — the glossary's entry keys:</a:t>
+              <a:t>attestation tiers — the blackboard's entry keys:</a:t>
             </a:r>
             <a:endParaRPr lang="en-US" sz="1000" dirty="0"/>
           </a:p>

</xml_diff>

<commit_message>
act transitions, ecosystems, capstones: reworded watch-for lines and labels (ported PowerPoint edits)
Act transition slides (9-15): scene tags read "Demo scene N" (Act II's
range note dropped), tag nudged down on Acts IV-VII; watch-for lines
reworded (I, III, VII split across two paragraphs; V drops "simulated for
demo"; VI names the appraisal protocol / verification tool and bolds
"each refused by cryptographic checks").

Ecosystems (16): two-line thesis reworded; isolette and AADL card bullets
reworded; Verus card gains "o" sub-bullets AutoVerus / KU Dogtreat.

Capstones: A's "judges are AI-free" footer removed; B's kicker nudged up;
C's kicker says "proposed mitigation".

Generator: per-act scenesY, run-list watch lines, sub-bullet support on
ecosystem cards, pPr overrides for the new sub-bullets. Verified
shape-for-shape against the PowerPoint-saved deck; slide log updated.

Co-Authored-By: Claude Fable 5.1 <noreply@anthropic.com>
</commit_message>
<xml_diff>
--- a/docs/video_slides_draft.pptx
+++ b/docs/video_slides_draft.pptx
@@ -3743,7 +3743,7 @@
                 <a:ea typeface="Calibri" pitchFamily="34" charset="-122"/>
                 <a:cs typeface="Calibri" pitchFamily="34" charset="-120"/>
               </a:rPr>
-              <a:t>scene 3 (expand allowed temperature range)</a:t>
+              <a:t>Demo scene 3</a:t>
             </a:r>
             <a:endParaRPr lang="en-US" sz="1500" dirty="0"/>
           </a:p>
@@ -4292,7 +4292,7 @@
                 <a:ea typeface="Calibri" pitchFamily="34" charset="-122"/>
                 <a:cs typeface="Calibri" pitchFamily="34" charset="-120"/>
               </a:rPr>
-              <a:t>scene 13</a:t>
+              <a:t>Demo scene 13</a:t>
             </a:r>
             <a:endParaRPr lang="en-US" sz="1500" dirty="0"/>
           </a:p>
@@ -4331,8 +4331,11 @@
                 <a:ea typeface="Calibri" pitchFamily="34" charset="-122"/>
                 <a:cs typeface="Calibri" pitchFamily="34" charset="-120"/>
               </a:rPr>
-              <a:t>A developer rewrites implementation logic — semantically equivalent. The hash moves, but </a:t>
-            </a:r>
+              <a:t>A developer rewrites semantically equivalent implementation logic.  The hash moves, but </a:t>
+            </a:r>
+            <a:endParaRPr lang="en-US" sz="2000" dirty="0"/>
+          </a:p>
+          <a:p>
             <a:pPr indent="0" marL="0">
               <a:buNone/>
             </a:pPr>
@@ -4844,7 +4847,7 @@
         </p:nvSpPr>
         <p:spPr>
           <a:xfrm>
-            <a:off x="822960" y="3154680"/>
+            <a:off x="822960" y="3236976"/>
             <a:ext cx="10515600" cy="411480"/>
           </a:xfrm>
           <a:prstGeom prst="rect">
@@ -4869,7 +4872,7 @@
                 <a:ea typeface="Calibri" pitchFamily="34" charset="-122"/>
                 <a:cs typeface="Calibri" pitchFamily="34" charset="-120"/>
               </a:rPr>
-              <a:t>scene 14</a:t>
+              <a:t>Demo scene 14</a:t>
             </a:r>
             <a:endParaRPr lang="en-US" sz="1500" dirty="0"/>
           </a:p>
@@ -4908,7 +4911,7 @@
                 <a:ea typeface="Calibri" pitchFamily="34" charset="-122"/>
                 <a:cs typeface="Calibri" pitchFamily="34" charset="-120"/>
               </a:rPr>
-              <a:t>The model is untouched, but a Verus contract is weakened (</a:t>
+              <a:t>The model is untouched, but a live Verus contract is weakened (</a:t>
             </a:r>
             <a:pPr indent="0" marL="0">
               <a:buNone/>
@@ -5421,7 +5424,7 @@
         </p:nvSpPr>
         <p:spPr>
           <a:xfrm>
-            <a:off x="822960" y="3154680"/>
+            <a:off x="822960" y="3236976"/>
             <a:ext cx="10515600" cy="411480"/>
           </a:xfrm>
           <a:prstGeom prst="rect">
@@ -5446,7 +5449,7 @@
                 <a:ea typeface="Calibri" pitchFamily="34" charset="-122"/>
                 <a:cs typeface="Calibri" pitchFamily="34" charset="-120"/>
               </a:rPr>
-              <a:t>scene 2</a:t>
+              <a:t>Demo scene 2</a:t>
             </a:r>
             <a:endParaRPr lang="en-US" sz="1500" dirty="0"/>
           </a:p>
@@ -5485,7 +5488,7 @@
                 <a:ea typeface="Calibri" pitchFamily="34" charset="-122"/>
                 <a:cs typeface="Calibri" pitchFamily="34" charset="-120"/>
               </a:rPr>
-              <a:t>Implementation code (developer-owned) changes, breaking a Verus contract.  Blackboard loop diagnoses, repairs (simulated for demo), then </a:t>
+              <a:t>Implementation code (developer-owned) changes, breaking a Verus contract.  Blackboard loop diagnoses, repairs, then </a:t>
             </a:r>
             <a:pPr indent="0" marL="0">
               <a:buNone/>
@@ -5998,7 +6001,7 @@
         </p:nvSpPr>
         <p:spPr>
           <a:xfrm>
-            <a:off x="822960" y="3154680"/>
+            <a:off x="822960" y="3236976"/>
             <a:ext cx="10515600" cy="411480"/>
           </a:xfrm>
           <a:prstGeom prst="rect">
@@ -6023,7 +6026,7 @@
                 <a:ea typeface="Calibri" pitchFamily="34" charset="-122"/>
                 <a:cs typeface="Calibri" pitchFamily="34" charset="-120"/>
               </a:rPr>
-              <a:t>scenes 6 + 7</a:t>
+              <a:t>Demo scenes 6 + 7</a:t>
             </a:r>
             <a:endParaRPr lang="en-US" sz="1500" dirty="0"/>
           </a:p>
@@ -6062,7 +6065,35 @@
                 <a:ea typeface="Calibri" pitchFamily="34" charset="-122"/>
                 <a:cs typeface="Calibri" pitchFamily="34" charset="-120"/>
               </a:rPr>
-              <a:t>The signed golden evidence bundle, an installed golden value in the protocol ASP ARGS, then the verifier itself — each tamper attributed, each refused by cryptographic checks.</a:t>
+              <a:t>The signed golden evidence bundle, an installed (live) golden value in the appraisal protocol, then the verification tool itself — each tamper attributed, </a:t>
+            </a:r>
+            <a:pPr indent="0" marL="0">
+              <a:buNone/>
+            </a:pPr>
+            <a:r>
+              <a:rPr lang="en-US" sz="2000" b="1" i="1" dirty="0">
+                <a:solidFill>
+                  <a:srgbClr val="212121"/>
+                </a:solidFill>
+                <a:latin typeface="Calibri" pitchFamily="34" charset="0"/>
+                <a:ea typeface="Calibri" pitchFamily="34" charset="-122"/>
+                <a:cs typeface="Calibri" pitchFamily="34" charset="-120"/>
+              </a:rPr>
+              <a:t>each refused by cryptographic checks</a:t>
+            </a:r>
+            <a:pPr indent="0" marL="0">
+              <a:buNone/>
+            </a:pPr>
+            <a:r>
+              <a:rPr lang="en-US" sz="2000" i="1" dirty="0">
+                <a:solidFill>
+                  <a:srgbClr val="212121"/>
+                </a:solidFill>
+                <a:latin typeface="Calibri" pitchFamily="34" charset="0"/>
+                <a:ea typeface="Calibri" pitchFamily="34" charset="-122"/>
+                <a:cs typeface="Calibri" pitchFamily="34" charset="-120"/>
+              </a:rPr>
+              <a:t>.</a:t>
             </a:r>
             <a:endParaRPr lang="en-US" sz="2000" dirty="0"/>
           </a:p>
@@ -6547,7 +6578,7 @@
         </p:nvSpPr>
         <p:spPr>
           <a:xfrm>
-            <a:off x="822960" y="3154680"/>
+            <a:off x="822960" y="3236976"/>
             <a:ext cx="10515600" cy="411480"/>
           </a:xfrm>
           <a:prstGeom prst="rect">
@@ -6572,7 +6603,7 @@
                 <a:ea typeface="Calibri" pitchFamily="34" charset="-122"/>
                 <a:cs typeface="Calibri" pitchFamily="34" charset="-120"/>
               </a:rPr>
-              <a:t>scenes 9 + 12</a:t>
+              <a:t>Demo scenes 9 + 12</a:t>
             </a:r>
             <a:endParaRPr lang="en-US" sz="1500" dirty="0"/>
           </a:p>
@@ -6625,8 +6656,11 @@
                 <a:ea typeface="Calibri" pitchFamily="34" charset="-122"/>
                 <a:cs typeface="Calibri" pitchFamily="34" charset="-120"/>
               </a:rPr>
-              <a:t>subtle ways that proof attempts cheat </a:t>
-            </a:r>
+              <a:t>subtle cheating in proof attempts, </a:t>
+            </a:r>
+            <a:endParaRPr lang="en-US" sz="2000" dirty="0"/>
+          </a:p>
+          <a:p>
             <a:pPr indent="0" marL="0">
               <a:buNone/>
             </a:pPr>
@@ -6639,7 +6673,7 @@
                 <a:ea typeface="Calibri" pitchFamily="34" charset="-122"/>
                 <a:cs typeface="Calibri" pitchFamily="34" charset="-120"/>
               </a:rPr>
-              <a:t>to undermine verification soundness.</a:t>
+              <a:t>that would otherwise undermine verification soundness.</a:t>
             </a:r>
             <a:endParaRPr lang="en-US" sz="2000" dirty="0"/>
           </a:p>
@@ -6788,7 +6822,7 @@
                 <a:ea typeface="Calibri" pitchFamily="34" charset="-122"/>
                 <a:cs typeface="Calibri" pitchFamily="34" charset="-120"/>
               </a:rPr>
-              <a:t>The blackboard, controller, repair ladder, and artifact classes don’t change — only the </a:t>
+              <a:t>The blackboard infrastructure and artifact classes don’t change — only the </a:t>
             </a:r>
             <a:pPr indent="0" marL="0">
               <a:buNone/>
@@ -6816,7 +6850,24 @@
                 <a:ea typeface="Calibri" pitchFamily="34" charset="-122"/>
                 <a:cs typeface="Calibri" pitchFamily="34" charset="-120"/>
               </a:rPr>
-              <a:t>: the modeling language, the prover, the target runtime, and the attestation primitives.</a:t>
+              <a:t>: modeling language, prover, </a:t>
+            </a:r>
+            <a:endParaRPr lang="en-US" sz="1500" dirty="0"/>
+          </a:p>
+          <a:p>
+            <a:pPr indent="0" marL="0">
+              <a:buNone/>
+            </a:pPr>
+            <a:r>
+              <a:rPr lang="en-US" sz="1500" i="1" dirty="0">
+                <a:solidFill>
+                  <a:srgbClr val="212121"/>
+                </a:solidFill>
+                <a:latin typeface="Calibri" pitchFamily="34" charset="0"/>
+                <a:ea typeface="Calibri" pitchFamily="34" charset="-122"/>
+                <a:cs typeface="Calibri" pitchFamily="34" charset="-120"/>
+              </a:rPr>
+              <a:t>target runtime, and attestation primitives.</a:t>
             </a:r>
             <a:endParaRPr lang="en-US" sz="1500" dirty="0"/>
           </a:p>
@@ -7015,7 +7066,7 @@
                 <a:ea typeface="Calibri" pitchFamily="34" charset="-122"/>
                 <a:cs typeface="Calibri" pitchFamily="34" charset="-120"/>
               </a:rPr>
-              <a:t>Every artifact class measured — the full demo</a:t>
+              <a:t>Every artifact class measured</a:t>
             </a:r>
             <a:endParaRPr lang="en-US" sz="1200" dirty="0"/>
           </a:p>
@@ -7205,7 +7256,7 @@
                 <a:ea typeface="Calibri" pitchFamily="34" charset="-122"/>
                 <a:cs typeface="Calibri" pitchFamily="34" charset="-120"/>
               </a:rPr>
-              <a:t>Same blackboard, similar Copland protocols</a:t>
+              <a:t>Same blackboard, similar Copland protocols to SysMLv2 pipeline</a:t>
             </a:r>
             <a:endParaRPr lang="en-US" sz="1200" dirty="0"/>
           </a:p>
@@ -7395,7 +7446,51 @@
                 <a:ea typeface="Calibri" pitchFamily="34" charset="-122"/>
                 <a:cs typeface="Calibri" pitchFamily="34" charset="-120"/>
               </a:rPr>
-              <a:t>Proof-repair experiments: AutoVerus, KU Dogtreat linear planner</a:t>
+              <a:t>Proof-repair experiments</a:t>
+            </a:r>
+            <a:endParaRPr lang="en-US" sz="1200" dirty="0"/>
+          </a:p>
+          <a:p>
+            <a:pPr marL="800100" lvl="1" indent="-342900">
+              <a:spcAft>
+                <a:spcPts val="400"/>
+              </a:spcAft>
+              <a:buSzPct val="100000"/>
+              <a:buFont typeface="Courier New" panose="02070309020205020404" pitchFamily="49" charset="0"/>
+              <a:buChar char="o"/>
+            </a:pPr>
+            <a:r>
+              <a:rPr lang="en-US" sz="1200" dirty="0">
+                <a:solidFill>
+                  <a:srgbClr val="212121"/>
+                </a:solidFill>
+                <a:latin typeface="Calibri" pitchFamily="34" charset="0"/>
+                <a:ea typeface="Calibri" pitchFamily="34" charset="-122"/>
+                <a:cs typeface="Calibri" pitchFamily="34" charset="-120"/>
+              </a:rPr>
+              <a:t>AutoVerus</a:t>
+            </a:r>
+            <a:endParaRPr lang="en-US" sz="1200" dirty="0"/>
+          </a:p>
+          <a:p>
+            <a:pPr marL="800100" lvl="1" indent="-342900">
+              <a:spcAft>
+                <a:spcPts val="400"/>
+              </a:spcAft>
+              <a:buSzPct val="100000"/>
+              <a:buFont typeface="Courier New" panose="02070309020205020404" pitchFamily="49" charset="0"/>
+              <a:buChar char="o"/>
+            </a:pPr>
+            <a:r>
+              <a:rPr lang="en-US" sz="1200" dirty="0">
+                <a:solidFill>
+                  <a:srgbClr val="212121"/>
+                </a:solidFill>
+                <a:latin typeface="Calibri" pitchFamily="34" charset="0"/>
+                <a:ea typeface="Calibri" pitchFamily="34" charset="-122"/>
+                <a:cs typeface="Calibri" pitchFamily="34" charset="-120"/>
+              </a:rPr>
+              <a:t>KU Dogtreat linear planner</a:t>
             </a:r>
             <a:endParaRPr lang="en-US" sz="1200" dirty="0"/>
           </a:p>
@@ -9045,59 +9140,6 @@
           </a:graphicData>
         </a:graphic>
       </p:graphicFrame>
-      <p:sp>
-        <p:nvSpPr>
-          <p:cNvPr id="5" name="Text 2"/>
-          <p:cNvSpPr/>
-          <p:nvPr/>
-        </p:nvSpPr>
-        <p:spPr>
-          <a:xfrm>
-            <a:off x="640080" y="5989320"/>
-            <a:ext cx="10881360" cy="685800"/>
-          </a:xfrm>
-          <a:prstGeom prst="rect">
-            <a:avLst/>
-          </a:prstGeom>
-          <a:noFill/>
-          <a:ln/>
-        </p:spPr>
-        <p:txBody>
-          <a:bodyPr wrap="square" lIns="0" tIns="0" rIns="0" bIns="0" rtlCol="0" anchor="t"/>
-          <a:lstStyle/>
-          <a:p>
-            <a:pPr algn="l" indent="0" marL="0">
-              <a:buNone/>
-            </a:pPr>
-            <a:r>
-              <a:rPr lang="en-US" sz="1250" b="1" i="1" dirty="0">
-                <a:solidFill>
-                  <a:srgbClr val="1E2761"/>
-                </a:solidFill>
-                <a:latin typeface="Calibri" pitchFamily="34" charset="0"/>
-                <a:ea typeface="Calibri" pitchFamily="34" charset="-122"/>
-                <a:cs typeface="Calibri" pitchFamily="34" charset="-120"/>
-              </a:rPr>
-              <a:t>🔒  the bottom two — the judges — are AI-free by design</a:t>
-            </a:r>
-            <a:pPr algn="l" indent="0" marL="0">
-              <a:buNone/>
-            </a:pPr>
-            <a:r>
-              <a:rPr lang="en-US" sz="1250" i="1" dirty="0">
-                <a:solidFill>
-                  <a:srgbClr val="212121"/>
-                </a:solidFill>
-                <a:latin typeface="Calibri" pitchFamily="34" charset="0"/>
-                <a:ea typeface="Calibri" pitchFamily="34" charset="-122"/>
-                <a:cs typeface="Calibri" pitchFamily="34" charset="-120"/>
-              </a:rPr>
-              <a:t>:  an LLM’s output is just another untrusted artifact, facing the same episode and appraisal as a human edit or a tamper. Guarantees never depend on LLM engines being good, honest, or even present.</a:t>
-            </a:r>
-            <a:endParaRPr lang="en-US" sz="1250" dirty="0"/>
-          </a:p>
-        </p:txBody>
-      </p:sp>
     </p:spTree>
   </p:cSld>
   <p:clrMapOvr>
@@ -10626,7 +10668,7 @@
         </p:nvSpPr>
         <p:spPr>
           <a:xfrm>
-            <a:off x="640080" y="6126480"/>
+            <a:off x="640080" y="6044184"/>
             <a:ext cx="10881360" cy="365760"/>
           </a:xfrm>
           <a:prstGeom prst="rect">
@@ -12633,7 +12675,7 @@
                 <a:ea typeface="Calibri" pitchFamily="34" charset="-122"/>
                 <a:cs typeface="Calibri" pitchFamily="34" charset="-120"/>
               </a:rPr>
-              <a:t> — defense-in-depth, anomaly detection, mitigation.</a:t>
+              <a:t> — defense-in-depth, anomaly detection, proposed mitigation.</a:t>
             </a:r>
             <a:endParaRPr lang="en-US" sz="1350" dirty="0"/>
           </a:p>
@@ -21508,7 +21550,7 @@
                 <a:ea typeface="Calibri" pitchFamily="34" charset="-122"/>
                 <a:cs typeface="Calibri" pitchFamily="34" charset="-120"/>
               </a:rPr>
-              <a:t>scene 1</a:t>
+              <a:t>Demo scene 1</a:t>
             </a:r>
             <a:endParaRPr lang="en-US" sz="1500" dirty="0"/>
           </a:p>
@@ -21547,7 +21589,24 @@
                 <a:ea typeface="Calibri" pitchFamily="34" charset="-122"/>
                 <a:cs typeface="Calibri" pitchFamily="34" charset="-120"/>
               </a:rPr>
-              <a:t>All artifacts start in a “pass” state:  all artifacts have integrity against golden values and implementations meet their contracts.</a:t>
+              <a:t>All artifacts start in a “pass” state with integrity against golden values and </a:t>
+            </a:r>
+            <a:endParaRPr lang="en-US" sz="2000" dirty="0"/>
+          </a:p>
+          <a:p>
+            <a:pPr indent="0" marL="0">
+              <a:buNone/>
+            </a:pPr>
+            <a:r>
+              <a:rPr lang="en-US" sz="2000" i="1" dirty="0">
+                <a:solidFill>
+                  <a:srgbClr val="212121"/>
+                </a:solidFill>
+                <a:latin typeface="Calibri" pitchFamily="34" charset="0"/>
+                <a:ea typeface="Calibri" pitchFamily="34" charset="-122"/>
+                <a:cs typeface="Calibri" pitchFamily="34" charset="-120"/>
+              </a:rPr>
+              <a:t>implementations meet their contracts.</a:t>
             </a:r>
             <a:endParaRPr lang="en-US" sz="2000" dirty="0"/>
           </a:p>

</xml_diff>

<commit_message>
capstone tables A/B/C: port cell edits missed by the previous pass
The earlier port compared only plain shapes and skipped table frames, so
the user's edits inside the three capstone tables were regenerated away.
Now ported cell-for-cell:

- A: headers "Where LLMs participate" / "The Guardrail"; LLM column
  trimmed; guardrail column rewritten; table nudged down (y 1.84)
- B: column retitled "How we trust it (or not)" and rewritten; CVM row
  split across two lines with bpar / --stdin, --req_file in Courier New;
  Attacks row reworded
- C: header "Avoided detection by"; identifiers in Courier New; several
  cells trimmed

Verification now covers tables (row heights, column widths, cell runs)
as well as shapes and notes; slide log records the table wording.

Co-Authored-By: Claude Fable 5.1 <noreply@anthropic.com>
</commit_message>
<xml_diff>
--- a/docs/video_slides_draft.pptx
+++ b/docs/video_slides_draft.pptx
@@ -7860,7 +7860,7 @@
           </p:nvPr>
         </p:nvGraphicFramePr>
         <p:xfrm>
-          <a:off x="640080" y="1600200"/>
+          <a:off x="640080" y="1682496"/>
           <a:ext cx="10881360" cy="914400"/>
         </p:xfrm>
         <a:graphic>
@@ -7958,7 +7958,7 @@
                           <a:ea typeface="Calibri" pitchFamily="34" charset="-122"/>
                           <a:cs typeface="Calibri" pitchFamily="34" charset="-120"/>
                         </a:rPr>
-                        <a:t>Where AI participates</a:t>
+                        <a:t>Where LLMs participate</a:t>
                       </a:r>
                       <a:endParaRPr lang="en-US" sz="1350" dirty="0">
                         <a:latin typeface="Calibri" charset="0"/>
@@ -8026,7 +8026,7 @@
                           <a:ea typeface="Calibri" pitchFamily="34" charset="-122"/>
                           <a:cs typeface="Calibri" pitchFamily="34" charset="-120"/>
                         </a:rPr>
-                        <a:t>The rule</a:t>
+                        <a:t>The Guardrail</a:t>
                       </a:r>
                       <a:endParaRPr lang="en-US" sz="1350" dirty="0">
                         <a:latin typeface="Calibri" charset="0"/>
@@ -8164,7 +8164,7 @@
                           <a:ea typeface="Calibri" pitchFamily="34" charset="-122"/>
                           <a:cs typeface="Calibri" pitchFamily="34" charset="-120"/>
                         </a:rPr>
-                        <a:t>LLMs may draft or restate specs</a:t>
+                        <a:t>May draft or restate specs</a:t>
                       </a:r>
                       <a:endParaRPr lang="en-US" sz="1200" dirty="0">
                         <a:latin typeface="Calibri" charset="0"/>
@@ -8232,35 +8232,7 @@
                           <a:ea typeface="Calibri" pitchFamily="34" charset="-122"/>
                           <a:cs typeface="Calibri" pitchFamily="34" charset="-120"/>
                         </a:rPr>
-                        <a:t>only the administrator </a:t>
-                      </a:r>
-                      <a:pPr algn="l" indent="0" marL="0">
-                        <a:buNone/>
-                      </a:pPr>
-                      <a:r>
-                        <a:rPr lang="en-US" sz="1200" b="1" dirty="0">
-                          <a:solidFill>
-                            <a:srgbClr val="212121"/>
-                          </a:solidFill>
-                          <a:latin typeface="Calibri" pitchFamily="34" charset="0"/>
-                          <a:ea typeface="Calibri" pitchFamily="34" charset="-122"/>
-                          <a:cs typeface="Calibri" pitchFamily="34" charset="-120"/>
-                        </a:rPr>
-                        <a:t>blesses</a:t>
-                      </a:r>
-                      <a:pPr algn="l" indent="0" marL="0">
-                        <a:buNone/>
-                      </a:pPr>
-                      <a:r>
-                        <a:rPr lang="en-US" sz="1200" dirty="0">
-                          <a:solidFill>
-                            <a:srgbClr val="212121"/>
-                          </a:solidFill>
-                          <a:latin typeface="Calibri" pitchFamily="34" charset="0"/>
-                          <a:ea typeface="Calibri" pitchFamily="34" charset="-122"/>
-                          <a:cs typeface="Calibri" pitchFamily="34" charset="-120"/>
-                        </a:rPr>
-                        <a:t> — authority is human</a:t>
+                        <a:t>Only a human administrator may authenticate a new spec</a:t>
                       </a:r>
                       <a:endParaRPr lang="en-US" sz="1200" dirty="0">
                         <a:latin typeface="Calibri" charset="0"/>
@@ -8398,7 +8370,7 @@
                           <a:ea typeface="Calibri" pitchFamily="34" charset="-122"/>
                           <a:cs typeface="Calibri" pitchFamily="34" charset="-120"/>
                         </a:rPr>
-                        <a:t>spec-guided synthesis / re-derivation with LLM engines</a:t>
+                        <a:t>spec-guided synthesis / re-derivation</a:t>
                       </a:r>
                       <a:endParaRPr lang="en-US" sz="1200" dirty="0">
                         <a:latin typeface="Calibri" charset="0"/>
@@ -8466,7 +8438,7 @@
                           <a:ea typeface="Calibri" pitchFamily="34" charset="-122"/>
                           <a:cs typeface="Calibri" pitchFamily="34" charset="-120"/>
                         </a:rPr>
-                        <a:t>the seed proofs must prove again against the blessed statements</a:t>
+                        <a:t>Code must meet its formal contracts, checked by legitimate toolchain, derived from human-blessed spec</a:t>
                       </a:r>
                       <a:endParaRPr lang="en-US" sz="1200" dirty="0">
                         <a:latin typeface="Calibri" charset="0"/>
@@ -8604,7 +8576,7 @@
                           <a:ea typeface="Calibri" pitchFamily="34" charset="-122"/>
                           <a:cs typeface="Calibri" pitchFamily="34" charset="-120"/>
                         </a:rPr>
-                        <a:t>LLM-suggested tactic portfolio (deterministic at runtime) · LLM API calls + LLM-assisted desktop sessions (loop is paused) · Custom proof repair agents (AutoVerus · KU Dogtreat linear planner)</a:t>
+                        <a:t>Suggests tactic portfolio (deterministic at runtime) · API calls + LLM-assisted desktop sessions (loop is paused) · Proof repair agents (AutoVerus · KU Dogtreat linear planner)</a:t>
                       </a:r>
                       <a:endParaRPr lang="en-US" sz="1200" dirty="0">
                         <a:latin typeface="Calibri" charset="0"/>
@@ -8672,7 +8644,7 @@
                           <a:ea typeface="Calibri" pitchFamily="34" charset="-122"/>
                           <a:cs typeface="Calibri" pitchFamily="34" charset="-120"/>
                         </a:rPr>
-                        <a:t>a repair claim is worthless without evidence; only fresh measurement re-establishes good standing</a:t>
+                        <a:t>Only fresh measurement re-establishes good standing</a:t>
                       </a:r>
                       <a:endParaRPr lang="en-US" sz="1200" dirty="0">
                         <a:latin typeface="Calibri" charset="0"/>
@@ -8878,7 +8850,7 @@
                           <a:ea typeface="Calibri" pitchFamily="34" charset="-122"/>
                           <a:cs typeface="Calibri" pitchFamily="34" charset="-120"/>
                         </a:rPr>
-                        <a:t>deterministic judges: proof kernels (Rocq, Lean, Verus), hash appraisal vs signed goldens, semantic analysis of source code</a:t>
+                        <a:t>Verification kernels (Rocq, Lean, Verus), formally-verified attestation managers (evidence unbundling), trusted attestation primitives (hash checks, semantic analysis of source code, etc.)</a:t>
                       </a:r>
                       <a:endParaRPr lang="en-US" sz="1200" dirty="0">
                         <a:latin typeface="Calibri" charset="0"/>
@@ -9084,7 +9056,7 @@
                           <a:ea typeface="Calibri" pitchFamily="34" charset="-122"/>
                           <a:cs typeface="Calibri" pitchFamily="34" charset="-120"/>
                         </a:rPr>
-                        <a:t>cryptographic anchor · non-derivability; no one (human or AI) may repair a baseline without fresh administrator blessing</a:t>
+                        <a:t>Cryptographic immutability</a:t>
                       </a:r>
                       <a:endParaRPr lang="en-US" sz="1200" dirty="0">
                         <a:latin typeface="Calibri" charset="0"/>
@@ -9448,7 +9420,7 @@
                           <a:ea typeface="Calibri" pitchFamily="34" charset="-122"/>
                           <a:cs typeface="Calibri" pitchFamily="34" charset="-120"/>
                         </a:rPr>
-                        <a:t>Judged by</a:t>
+                        <a:t>How we trust it (or not)</a:t>
                       </a:r>
                       <a:endParaRPr lang="en-US" sz="1350" dirty="0">
                         <a:latin typeface="Calibri" charset="0"/>
@@ -9586,7 +9558,7 @@
                           <a:ea typeface="Calibri" pitchFamily="34" charset="-122"/>
                           <a:cs typeface="Calibri" pitchFamily="34" charset="-120"/>
                         </a:rPr>
-                        <a:t>pybb framework (blackboard / controller / knowledge sources), demo arcs, install script, CI suite, detailed documentation</a:t>
+                        <a:t>pybb framework (blackboard, controller, knowledge sources), demo arcs, install script, CI suite, detailed documentation</a:t>
                       </a:r>
                       <a:endParaRPr lang="en-US" sz="1200" dirty="0">
                         <a:latin typeface="Calibri" charset="0"/>
@@ -9654,7 +9626,21 @@
                           <a:ea typeface="Calibri" pitchFamily="34" charset="-122"/>
                           <a:cs typeface="Calibri" pitchFamily="34" charset="-120"/>
                         </a:rPr>
-                        <a:t>Untrusted orchestration (evidence bundles are independently-verifiable)</a:t>
+                        <a:t>Orchestration in python is untrusted,</a:t>
+                      </a:r>
+                      <a:pPr algn="l" indent="0" marL="0">
+                        <a:buNone/>
+                      </a:pPr>
+                      <a:r>
+                        <a:rPr lang="en-US" sz="1200" b="1" dirty="0">
+                          <a:solidFill>
+                            <a:srgbClr val="212121"/>
+                          </a:solidFill>
+                          <a:latin typeface="Calibri" pitchFamily="34" charset="0"/>
+                          <a:ea typeface="Calibri" pitchFamily="34" charset="-122"/>
+                          <a:cs typeface="Calibri" pitchFamily="34" charset="-120"/>
+                        </a:rPr>
+                        <a:t> but evidence bundles are independently-verifiable</a:t>
                       </a:r>
                       <a:endParaRPr lang="en-US" sz="1200" dirty="0">
                         <a:latin typeface="Calibri" charset="0"/>
@@ -9788,11 +9774,25 @@
                           <a:solidFill>
                             <a:srgbClr val="212121"/>
                           </a:solidFill>
+                          <a:latin typeface="Courier New" pitchFamily="34" charset="0"/>
+                          <a:ea typeface="Courier New" pitchFamily="34" charset="-122"/>
+                          <a:cs typeface="Courier New" pitchFamily="34" charset="-120"/>
+                        </a:rPr>
+                        <a:t>bpar</a:t>
+                      </a:r>
+                      <a:pPr algn="l" indent="0" marL="0">
+                        <a:buNone/>
+                      </a:pPr>
+                      <a:r>
+                        <a:rPr lang="en-US" sz="1200" dirty="0">
+                          <a:solidFill>
+                            <a:srgbClr val="212121"/>
+                          </a:solidFill>
                           <a:latin typeface="Calibri" pitchFamily="34" charset="0"/>
                           <a:ea typeface="Calibri" pitchFamily="34" charset="-122"/>
                           <a:cs typeface="Calibri" pitchFamily="34" charset="-120"/>
                         </a:rPr>
-                        <a:t>bpar (parallel Copland term) </a:t>
+                        <a:t> (parallel Copland term) </a:t>
                       </a:r>
                       <a:pPr algn="l" indent="0" marL="0">
                         <a:buNone/>
@@ -9806,7 +9806,42 @@
                           <a:ea typeface="Calibri" pitchFamily="34" charset="-122"/>
                           <a:cs typeface="Calibri" pitchFamily="34" charset="-120"/>
                         </a:rPr>
-                        <a:t>in the verified CVM</a:t>
+                        <a:t>in the verified CVM core,</a:t>
+                      </a:r>
+                      <a:endParaRPr lang="en-US" sz="1200" dirty="0">
+                        <a:latin typeface="Calibri" charset="0"/>
+                        <a:ea typeface="Calibri" charset="0"/>
+                        <a:cs typeface="Calibri" charset="0"/>
+                      </a:endParaRPr>
+                    </a:p>
+                    <a:p>
+                      <a:pPr algn="l" indent="0" marL="0">
+                        <a:buNone/>
+                      </a:pPr>
+                      <a:r>
+                        <a:rPr lang="en-US" sz="1200" dirty="0">
+                          <a:solidFill>
+                            <a:srgbClr val="212121"/>
+                          </a:solidFill>
+                          <a:latin typeface="Calibri" pitchFamily="34" charset="0"/>
+                          <a:ea typeface="Calibri" pitchFamily="34" charset="-122"/>
+                          <a:cs typeface="Calibri" pitchFamily="34" charset="-120"/>
+                        </a:rPr>
+                        <a:t>CVM frontend fixes (</a:t>
+                      </a:r>
+                      <a:pPr algn="l" indent="0" marL="0">
+                        <a:buNone/>
+                      </a:pPr>
+                      <a:r>
+                        <a:rPr lang="en-US" sz="1200" dirty="0">
+                          <a:solidFill>
+                            <a:srgbClr val="212121"/>
+                          </a:solidFill>
+                          <a:latin typeface="Courier New" pitchFamily="34" charset="0"/>
+                          <a:ea typeface="Courier New" pitchFamily="34" charset="-122"/>
+                          <a:cs typeface="Courier New" pitchFamily="34" charset="-120"/>
+                        </a:rPr>
+                        <a:t>--stdin, --req_file </a:t>
                       </a:r>
                       <a:pPr algn="l" indent="0" marL="0">
                         <a:buNone/>
@@ -9820,7 +9855,7 @@
                           <a:ea typeface="Calibri" pitchFamily="34" charset="-122"/>
                           <a:cs typeface="Calibri" pitchFamily="34" charset="-120"/>
                         </a:rPr>
-                        <a:t>; --stdin / --req_file frontend fixes</a:t>
+                        <a:t>interfaces)</a:t>
                       </a:r>
                       <a:endParaRPr lang="en-US" sz="1200" dirty="0">
                         <a:latin typeface="Calibri" charset="0"/>
@@ -10054,7 +10089,7 @@
                           <a:ea typeface="Calibri" pitchFamily="34" charset="-122"/>
                           <a:cs typeface="Calibri" pitchFamily="34" charset="-120"/>
                         </a:rPr>
-                        <a:t> asp-libs binaries — hashing, the Lean/Rocq/HAMR runners &amp; appraisers, the cheat scan, golden-slice extraction</a:t>
+                        <a:t> asp-libs binaries (hashing, the Lean/Rocq/HAMR runners &amp; appraisers, cheat scan, golden-slice extraction)</a:t>
                       </a:r>
                       <a:endParaRPr lang="en-US" sz="1200" dirty="0">
                         <a:latin typeface="Calibri" charset="0"/>
@@ -10122,7 +10157,7 @@
                           <a:ea typeface="Calibri" pitchFamily="34" charset="-122"/>
                           <a:cs typeface="Calibri" pitchFamily="34" charset="-120"/>
                         </a:rPr>
-                        <a:t>tool hashes measure-then-use; syntax-guided analysis of source files, appraisal vs signed goldens</a:t>
+                        <a:t>New attestation primitives are untrusted, require manual inspection (or formal analysis)</a:t>
                       </a:r>
                       <a:endParaRPr lang="en-US" sz="1200" dirty="0">
                         <a:latin typeface="Calibri" charset="0"/>
@@ -10342,7 +10377,7 @@
                           <a:ea typeface="Calibri" pitchFamily="34" charset="-122"/>
                           <a:cs typeface="Calibri" pitchFamily="34" charset="-120"/>
                         </a:rPr>
-                        <a:t>readiness-gate config checks; blessed baselines</a:t>
+                        <a:t>Copland protocol analysis bolsters trust</a:t>
                       </a:r>
                       <a:endParaRPr lang="en-US" sz="1200" dirty="0">
                         <a:latin typeface="Calibri" charset="0"/>
@@ -10480,7 +10515,7 @@
                           <a:ea typeface="Calibri" pitchFamily="34" charset="-122"/>
                           <a:cs typeface="Calibri" pitchFamily="34" charset="-120"/>
                         </a:rPr>
-                        <a:t>scripted demo tampers (scenes 1–8) + </a:t>
+                        <a:t>demo tampers + </a:t>
                       </a:r>
                       <a:pPr algn="l" indent="0" marL="0">
                         <a:buNone/>
@@ -10494,7 +10529,7 @@
                           <a:ea typeface="Calibri" pitchFamily="34" charset="-122"/>
                           <a:cs typeface="Calibri" pitchFamily="34" charset="-120"/>
                         </a:rPr>
-                        <a:t>7 red-team attack classes</a:t>
+                        <a:t>7 red-team attack classes </a:t>
                       </a:r>
                       <a:pPr algn="l" indent="0" marL="0">
                         <a:buNone/>
@@ -10508,7 +10543,7 @@
                           <a:ea typeface="Calibri" pitchFamily="34" charset="-122"/>
                           <a:cs typeface="Calibri" pitchFamily="34" charset="-120"/>
                         </a:rPr>
-                        <a:t> (scenes 9–12, 14)</a:t>
+                        <a:t>(see next slide)</a:t>
                       </a:r>
                       <a:endParaRPr lang="en-US" sz="1200" dirty="0">
                         <a:latin typeface="Calibri" charset="0"/>
@@ -10576,13 +10611,13 @@
                           <a:ea typeface="Calibri" pitchFamily="34" charset="-122"/>
                           <a:cs typeface="Calibri" pitchFamily="34" charset="-120"/>
                         </a:rPr>
-                        <a:t>every scene gates on detection / attribution; each forced a new tier (</a:t>
+                        <a:t>Concrete “counter-examples” show attacks succeeding, </a:t>
                       </a:r>
                       <a:pPr algn="l" indent="0" marL="0">
                         <a:buNone/>
                       </a:pPr>
                       <a:r>
-                        <a:rPr lang="en-US" sz="1200" i="1" dirty="0">
+                        <a:rPr lang="en-US" sz="1200" b="1" dirty="0">
                           <a:solidFill>
                             <a:srgbClr val="212121"/>
                           </a:solidFill>
@@ -10590,21 +10625,7 @@
                           <a:ea typeface="Calibri" pitchFamily="34" charset="-122"/>
                           <a:cs typeface="Calibri" pitchFamily="34" charset="-120"/>
                         </a:rPr>
-                        <a:t>→ next slide</a:t>
-                      </a:r>
-                      <a:pPr algn="l" indent="0" marL="0">
-                        <a:buNone/>
-                      </a:pPr>
-                      <a:r>
-                        <a:rPr lang="en-US" sz="1200" dirty="0">
-                          <a:solidFill>
-                            <a:srgbClr val="212121"/>
-                          </a:solidFill>
-                          <a:latin typeface="Calibri" pitchFamily="34" charset="0"/>
-                          <a:ea typeface="Calibri" pitchFamily="34" charset="-122"/>
-                          <a:cs typeface="Calibri" pitchFamily="34" charset="-120"/>
-                        </a:rPr>
-                        <a:t>)</a:t>
+                        <a:t>undetected by existing measurement</a:t>
                       </a:r>
                       <a:endParaRPr lang="en-US" sz="1200" dirty="0">
                         <a:latin typeface="Calibri" charset="0"/>
@@ -10964,7 +10985,7 @@
                           <a:ea typeface="Calibri" pitchFamily="34" charset="-122"/>
                           <a:cs typeface="Calibri" pitchFamily="34" charset="-120"/>
                         </a:rPr>
-                        <a:t>Avoided detection by…</a:t>
+                        <a:t>Avoided detection by</a:t>
                       </a:r>
                       <a:endParaRPr lang="en-US" sz="1250" dirty="0">
                         <a:latin typeface="Calibri" charset="0"/>
@@ -11116,7 +11137,35 @@
                           <a:ea typeface="Calibri" pitchFamily="34" charset="-122"/>
                           <a:cs typeface="Calibri" pitchFamily="34" charset="-120"/>
                         </a:rPr>
-                        <a:t> — assume(false) in an unmeasured bridge file</a:t>
+                        <a:t> — </a:t>
+                      </a:r>
+                      <a:pPr algn="l" indent="0" marL="0">
+                        <a:buNone/>
+                      </a:pPr>
+                      <a:r>
+                        <a:rPr lang="en-US" sz="1100" dirty="0">
+                          <a:solidFill>
+                            <a:srgbClr val="212121"/>
+                          </a:solidFill>
+                          <a:latin typeface="Courier New" pitchFamily="34" charset="0"/>
+                          <a:ea typeface="Courier New" pitchFamily="34" charset="-122"/>
+                          <a:cs typeface="Courier New" pitchFamily="34" charset="-120"/>
+                        </a:rPr>
+                        <a:t>assume(false) </a:t>
+                      </a:r>
+                      <a:pPr algn="l" indent="0" marL="0">
+                        <a:buNone/>
+                      </a:pPr>
+                      <a:r>
+                        <a:rPr lang="en-US" sz="1100" dirty="0">
+                          <a:solidFill>
+                            <a:srgbClr val="212121"/>
+                          </a:solidFill>
+                          <a:latin typeface="Calibri" pitchFamily="34" charset="0"/>
+                          <a:ea typeface="Calibri" pitchFamily="34" charset="-122"/>
+                          <a:cs typeface="Calibri" pitchFamily="34" charset="-120"/>
+                        </a:rPr>
+                        <a:t>in an unmeasured bridge file</a:t>
                       </a:r>
                       <a:endParaRPr lang="en-US" sz="1100" dirty="0">
                         <a:latin typeface="Calibri" charset="0"/>
@@ -11252,7 +11301,35 @@
                           <a:ea typeface="Calibri" pitchFamily="34" charset="-122"/>
                           <a:cs typeface="Calibri" pitchFamily="34" charset="-120"/>
                         </a:rPr>
-                        <a:t>cheat scan (cheat_scan_verus)</a:t>
+                        <a:t>cheat scan (</a:t>
+                      </a:r>
+                      <a:pPr algn="l" indent="0" marL="0">
+                        <a:buNone/>
+                      </a:pPr>
+                      <a:r>
+                        <a:rPr lang="en-US" sz="1100" dirty="0">
+                          <a:solidFill>
+                            <a:srgbClr val="212121"/>
+                          </a:solidFill>
+                          <a:latin typeface="Courier New" pitchFamily="34" charset="0"/>
+                          <a:ea typeface="Courier New" pitchFamily="34" charset="-122"/>
+                          <a:cs typeface="Courier New" pitchFamily="34" charset="-120"/>
+                        </a:rPr>
+                        <a:t>cheat_scan_verus</a:t>
+                      </a:r>
+                      <a:pPr algn="l" indent="0" marL="0">
+                        <a:buNone/>
+                      </a:pPr>
+                      <a:r>
+                        <a:rPr lang="en-US" sz="1100" dirty="0">
+                          <a:solidFill>
+                            <a:srgbClr val="212121"/>
+                          </a:solidFill>
+                          <a:latin typeface="Calibri" pitchFamily="34" charset="0"/>
+                          <a:ea typeface="Calibri" pitchFamily="34" charset="-122"/>
+                          <a:cs typeface="Calibri" pitchFamily="34" charset="-120"/>
+                        </a:rPr>
+                        <a:t>)</a:t>
                       </a:r>
                       <a:endParaRPr lang="en-US" sz="1100" dirty="0">
                         <a:latin typeface="Calibri" charset="0"/>
@@ -11336,7 +11413,35 @@
                           <a:ea typeface="Calibri" pitchFamily="34" charset="-122"/>
                           <a:cs typeface="Calibri" pitchFamily="34" charset="-120"/>
                         </a:rPr>
-                        <a:t> — external_body broadcast axiom, ensures false</a:t>
+                        <a:t> — </a:t>
+                      </a:r>
+                      <a:pPr algn="l" indent="0" marL="0">
+                        <a:buNone/>
+                      </a:pPr>
+                      <a:r>
+                        <a:rPr lang="en-US" sz="1100" dirty="0">
+                          <a:solidFill>
+                            <a:srgbClr val="212121"/>
+                          </a:solidFill>
+                          <a:latin typeface="Courier New" pitchFamily="34" charset="0"/>
+                          <a:ea typeface="Courier New" pitchFamily="34" charset="-122"/>
+                          <a:cs typeface="Courier New" pitchFamily="34" charset="-120"/>
+                        </a:rPr>
+                        <a:t>external_body </a:t>
+                      </a:r>
+                      <a:pPr algn="l" indent="0" marL="0">
+                        <a:buNone/>
+                      </a:pPr>
+                      <a:r>
+                        <a:rPr lang="en-US" sz="1100" dirty="0">
+                          <a:solidFill>
+                            <a:srgbClr val="212121"/>
+                          </a:solidFill>
+                          <a:latin typeface="Calibri" pitchFamily="34" charset="0"/>
+                          <a:ea typeface="Calibri" pitchFamily="34" charset="-122"/>
+                          <a:cs typeface="Calibri" pitchFamily="34" charset="-120"/>
+                        </a:rPr>
+                        <a:t>broadcast axiom, ensures false</a:t>
                       </a:r>
                       <a:endParaRPr lang="en-US" sz="1100" dirty="0">
                         <a:latin typeface="Calibri" charset="0"/>
@@ -11472,7 +11577,35 @@
                           <a:ea typeface="Calibri" pitchFamily="34" charset="-122"/>
                           <a:cs typeface="Calibri" pitchFamily="34" charset="-120"/>
                         </a:rPr>
-                        <a:t>cheat scan (cheat_scan_verus)</a:t>
+                        <a:t>cheat scan (</a:t>
+                      </a:r>
+                      <a:pPr algn="l" indent="0" marL="0">
+                        <a:buNone/>
+                      </a:pPr>
+                      <a:r>
+                        <a:rPr lang="en-US" sz="1100" dirty="0">
+                          <a:solidFill>
+                            <a:srgbClr val="212121"/>
+                          </a:solidFill>
+                          <a:latin typeface="Courier New" pitchFamily="34" charset="0"/>
+                          <a:ea typeface="Courier New" pitchFamily="34" charset="-122"/>
+                          <a:cs typeface="Courier New" pitchFamily="34" charset="-120"/>
+                        </a:rPr>
+                        <a:t>cheat_scan_verus</a:t>
+                      </a:r>
+                      <a:pPr algn="l" indent="0" marL="0">
+                        <a:buNone/>
+                      </a:pPr>
+                      <a:r>
+                        <a:rPr lang="en-US" sz="1100" dirty="0">
+                          <a:solidFill>
+                            <a:srgbClr val="212121"/>
+                          </a:solidFill>
+                          <a:latin typeface="Calibri" pitchFamily="34" charset="0"/>
+                          <a:ea typeface="Calibri" pitchFamily="34" charset="-122"/>
+                          <a:cs typeface="Calibri" pitchFamily="34" charset="-120"/>
+                        </a:rPr>
+                        <a:t>)</a:t>
                       </a:r>
                       <a:endParaRPr lang="en-US" sz="1100" dirty="0">
                         <a:latin typeface="Calibri" charset="0"/>
@@ -11556,7 +11689,7 @@
                           <a:ea typeface="Calibri" pitchFamily="34" charset="-122"/>
                           <a:cs typeface="Calibri" pitchFamily="34" charset="-120"/>
                         </a:rPr>
-                        <a:t> — a system-proof module commented out</a:t>
+                        <a:t> — system-proof module commented out</a:t>
                       </a:r>
                       <a:endParaRPr lang="en-US" sz="1100" dirty="0">
                         <a:latin typeface="Calibri" charset="0"/>
@@ -11776,7 +11909,7 @@
                           <a:ea typeface="Calibri" pitchFamily="34" charset="-122"/>
                           <a:cs typeface="Calibri" pitchFamily="34" charset="-120"/>
                         </a:rPr>
-                        <a:t> — real VC dropped, trivial one added, constant count</a:t>
+                        <a:t> — contract dropped, trivial one added, same count</a:t>
                       </a:r>
                       <a:endParaRPr lang="en-US" sz="1100" dirty="0">
                         <a:latin typeface="Calibri" charset="0"/>
@@ -11996,7 +12129,35 @@
                           <a:ea typeface="Calibri" pitchFamily="34" charset="-122"/>
                           <a:cs typeface="Calibri" pitchFamily="34" charset="-120"/>
                         </a:rPr>
-                        <a:t> — semantic flip in a cached dep, mtime preserved</a:t>
+                        <a:t> — semantic flip in a cached dep, </a:t>
+                      </a:r>
+                      <a:pPr algn="l" indent="0" marL="0">
+                        <a:buNone/>
+                      </a:pPr>
+                      <a:r>
+                        <a:rPr lang="en-US" sz="1100" dirty="0">
+                          <a:solidFill>
+                            <a:srgbClr val="212121"/>
+                          </a:solidFill>
+                          <a:latin typeface="Courier New" pitchFamily="34" charset="0"/>
+                          <a:ea typeface="Courier New" pitchFamily="34" charset="-122"/>
+                          <a:cs typeface="Courier New" pitchFamily="34" charset="-120"/>
+                        </a:rPr>
+                        <a:t>mtime</a:t>
+                      </a:r>
+                      <a:pPr algn="l" indent="0" marL="0">
+                        <a:buNone/>
+                      </a:pPr>
+                      <a:r>
+                        <a:rPr lang="en-US" sz="1100" dirty="0">
+                          <a:solidFill>
+                            <a:srgbClr val="212121"/>
+                          </a:solidFill>
+                          <a:latin typeface="Calibri" pitchFamily="34" charset="0"/>
+                          <a:ea typeface="Calibri" pitchFamily="34" charset="-122"/>
+                          <a:cs typeface="Calibri" pitchFamily="34" charset="-120"/>
+                        </a:rPr>
+                        <a:t> preserved</a:t>
                       </a:r>
                       <a:endParaRPr lang="en-US" sz="1100" dirty="0">
                         <a:latin typeface="Calibri" charset="0"/>
@@ -12064,7 +12225,7 @@
                           <a:ea typeface="Calibri" pitchFamily="34" charset="-122"/>
                           <a:cs typeface="Calibri" pitchFamily="34" charset="-120"/>
                         </a:rPr>
-                        <a:t>mtime-gated cache serves the stale verdict; green over false bytes</a:t>
+                        <a:t>mtime-gated cache serves the stale verdict</a:t>
                       </a:r>
                       <a:endParaRPr lang="en-US" sz="1100" dirty="0">
                         <a:latin typeface="Calibri" charset="0"/>
@@ -12128,11 +12289,25 @@
                           <a:solidFill>
                             <a:srgbClr val="212121"/>
                           </a:solidFill>
+                          <a:latin typeface="Courier New" pitchFamily="34" charset="0"/>
+                          <a:ea typeface="Courier New" pitchFamily="34" charset="-122"/>
+                          <a:cs typeface="Courier New" pitchFamily="34" charset="-120"/>
+                        </a:rPr>
+                        <a:t>gensrc</a:t>
+                      </a:r>
+                      <a:pPr algn="l" indent="0" marL="0">
+                        <a:buNone/>
+                      </a:pPr>
+                      <a:r>
+                        <a:rPr lang="en-US" sz="1100" dirty="0">
+                          <a:solidFill>
+                            <a:srgbClr val="212121"/>
+                          </a:solidFill>
                           <a:latin typeface="Calibri" pitchFamily="34" charset="0"/>
                           <a:ea typeface="Calibri" pitchFamily="34" charset="-122"/>
                           <a:cs typeface="Calibri" pitchFamily="34" charset="-120"/>
                         </a:rPr>
-                        <a:t>gensrc measurement</a:t>
+                        <a:t> measurement</a:t>
                       </a:r>
                       <a:endParaRPr lang="en-US" sz="1100" dirty="0">
                         <a:latin typeface="Calibri" charset="0"/>
@@ -12284,7 +12459,7 @@
                           <a:ea typeface="Calibri" pitchFamily="34" charset="-122"/>
                           <a:cs typeface="Calibri" pitchFamily="34" charset="-120"/>
                         </a:rPr>
-                        <a:t>Verus never reads the body — unverified code, out of scope</a:t>
+                        <a:t>Verus never reads the body (unverified code, out of scope)</a:t>
                       </a:r>
                       <a:endParaRPr lang="en-US" sz="1100" dirty="0">
                         <a:latin typeface="Calibri" charset="0"/>
@@ -12348,11 +12523,25 @@
                           <a:solidFill>
                             <a:srgbClr val="212121"/>
                           </a:solidFill>
+                          <a:latin typeface="Courier New" pitchFamily="34" charset="0"/>
+                          <a:ea typeface="Courier New" pitchFamily="34" charset="-122"/>
+                          <a:cs typeface="Courier New" pitchFamily="34" charset="-120"/>
+                        </a:rPr>
+                        <a:t>gensrc</a:t>
+                      </a:r>
+                      <a:pPr algn="l" indent="0" marL="0">
+                        <a:buNone/>
+                      </a:pPr>
+                      <a:r>
+                        <a:rPr lang="en-US" sz="1100" dirty="0">
+                          <a:solidFill>
+                            <a:srgbClr val="212121"/>
+                          </a:solidFill>
                           <a:latin typeface="Calibri" pitchFamily="34" charset="0"/>
                           <a:ea typeface="Calibri" pitchFamily="34" charset="-122"/>
                           <a:cs typeface="Calibri" pitchFamily="34" charset="-120"/>
                         </a:rPr>
-                        <a:t>gensrc measurement</a:t>
+                        <a:t> measurement</a:t>
                       </a:r>
                       <a:endParaRPr lang="en-US" sz="1100" dirty="0">
                         <a:latin typeface="Calibri" charset="0"/>
@@ -12504,7 +12693,7 @@
                           <a:ea typeface="Calibri" pitchFamily="34" charset="-122"/>
                           <a:cs typeface="Calibri" pitchFamily="34" charset="-120"/>
                         </a:rPr>
-                        <a:t>self-consistent; gap in contract coverage for attestation report’s compute_cases construct</a:t>
+                        <a:t>gap in contract coverage for attestation report’s compute_cases construct</a:t>
                       </a:r>
                       <a:endParaRPr lang="en-US" sz="1100" dirty="0">
                         <a:latin typeface="Calibri" charset="0"/>

</xml_diff>